<commit_message>
20260914 commit : Notion rest
</commit_message>
<xml_diff>
--- a/notion/create_notion_img.pptx
+++ b/notion/create_notion_img.pptx
@@ -245,7 +245,7 @@
           <a:p>
             <a:fld id="{7237CE1A-8831-48B5-BA93-72483C6E34E8}" type="datetimeFigureOut">
               <a:rPr lang="ko-KR" altLang="en-US" smtClean="0"/>
-              <a:t>2026-09-09</a:t>
+              <a:t>2026-09-14</a:t>
             </a:fld>
             <a:endParaRPr lang="ko-KR" altLang="en-US"/>
           </a:p>
@@ -415,7 +415,7 @@
           <a:p>
             <a:fld id="{7237CE1A-8831-48B5-BA93-72483C6E34E8}" type="datetimeFigureOut">
               <a:rPr lang="ko-KR" altLang="en-US" smtClean="0"/>
-              <a:t>2026-09-09</a:t>
+              <a:t>2026-09-14</a:t>
             </a:fld>
             <a:endParaRPr lang="ko-KR" altLang="en-US"/>
           </a:p>
@@ -595,7 +595,7 @@
           <a:p>
             <a:fld id="{7237CE1A-8831-48B5-BA93-72483C6E34E8}" type="datetimeFigureOut">
               <a:rPr lang="ko-KR" altLang="en-US" smtClean="0"/>
-              <a:t>2026-09-09</a:t>
+              <a:t>2026-09-14</a:t>
             </a:fld>
             <a:endParaRPr lang="ko-KR" altLang="en-US"/>
           </a:p>
@@ -765,7 +765,7 @@
           <a:p>
             <a:fld id="{7237CE1A-8831-48B5-BA93-72483C6E34E8}" type="datetimeFigureOut">
               <a:rPr lang="ko-KR" altLang="en-US" smtClean="0"/>
-              <a:t>2026-09-09</a:t>
+              <a:t>2026-09-14</a:t>
             </a:fld>
             <a:endParaRPr lang="ko-KR" altLang="en-US"/>
           </a:p>
@@ -1011,7 +1011,7 @@
           <a:p>
             <a:fld id="{7237CE1A-8831-48B5-BA93-72483C6E34E8}" type="datetimeFigureOut">
               <a:rPr lang="ko-KR" altLang="en-US" smtClean="0"/>
-              <a:t>2026-09-09</a:t>
+              <a:t>2026-09-14</a:t>
             </a:fld>
             <a:endParaRPr lang="ko-KR" altLang="en-US"/>
           </a:p>
@@ -1243,7 +1243,7 @@
           <a:p>
             <a:fld id="{7237CE1A-8831-48B5-BA93-72483C6E34E8}" type="datetimeFigureOut">
               <a:rPr lang="ko-KR" altLang="en-US" smtClean="0"/>
-              <a:t>2026-09-09</a:t>
+              <a:t>2026-09-14</a:t>
             </a:fld>
             <a:endParaRPr lang="ko-KR" altLang="en-US"/>
           </a:p>
@@ -1610,7 +1610,7 @@
           <a:p>
             <a:fld id="{7237CE1A-8831-48B5-BA93-72483C6E34E8}" type="datetimeFigureOut">
               <a:rPr lang="ko-KR" altLang="en-US" smtClean="0"/>
-              <a:t>2026-09-09</a:t>
+              <a:t>2026-09-14</a:t>
             </a:fld>
             <a:endParaRPr lang="ko-KR" altLang="en-US"/>
           </a:p>
@@ -1728,7 +1728,7 @@
           <a:p>
             <a:fld id="{7237CE1A-8831-48B5-BA93-72483C6E34E8}" type="datetimeFigureOut">
               <a:rPr lang="ko-KR" altLang="en-US" smtClean="0"/>
-              <a:t>2026-09-09</a:t>
+              <a:t>2026-09-14</a:t>
             </a:fld>
             <a:endParaRPr lang="ko-KR" altLang="en-US"/>
           </a:p>
@@ -1823,7 +1823,7 @@
           <a:p>
             <a:fld id="{7237CE1A-8831-48B5-BA93-72483C6E34E8}" type="datetimeFigureOut">
               <a:rPr lang="ko-KR" altLang="en-US" smtClean="0"/>
-              <a:t>2026-09-09</a:t>
+              <a:t>2026-09-14</a:t>
             </a:fld>
             <a:endParaRPr lang="ko-KR" altLang="en-US"/>
           </a:p>
@@ -2100,7 +2100,7 @@
           <a:p>
             <a:fld id="{7237CE1A-8831-48B5-BA93-72483C6E34E8}" type="datetimeFigureOut">
               <a:rPr lang="ko-KR" altLang="en-US" smtClean="0"/>
-              <a:t>2026-09-09</a:t>
+              <a:t>2026-09-14</a:t>
             </a:fld>
             <a:endParaRPr lang="ko-KR" altLang="en-US"/>
           </a:p>
@@ -2353,7 +2353,7 @@
           <a:p>
             <a:fld id="{7237CE1A-8831-48B5-BA93-72483C6E34E8}" type="datetimeFigureOut">
               <a:rPr lang="ko-KR" altLang="en-US" smtClean="0"/>
-              <a:t>2026-09-09</a:t>
+              <a:t>2026-09-14</a:t>
             </a:fld>
             <a:endParaRPr lang="ko-KR" altLang="en-US"/>
           </a:p>
@@ -2566,7 +2566,7 @@
           <a:p>
             <a:fld id="{7237CE1A-8831-48B5-BA93-72483C6E34E8}" type="datetimeFigureOut">
               <a:rPr lang="ko-KR" altLang="en-US" smtClean="0"/>
-              <a:t>2026-09-09</a:t>
+              <a:t>2026-09-14</a:t>
             </a:fld>
             <a:endParaRPr lang="ko-KR" altLang="en-US"/>
           </a:p>
@@ -2973,14 +2973,14 @@
       </p:grpSpPr>
       <p:sp>
         <p:nvSpPr>
-          <p:cNvPr id="2" name="직사각형 1"/>
+          <p:cNvPr id="4" name="직사각형 3"/>
           <p:cNvSpPr/>
           <p:nvPr/>
         </p:nvSpPr>
         <p:spPr>
           <a:xfrm>
-            <a:off x="-1657350" y="1462200"/>
-            <a:ext cx="4320000" cy="2880000"/>
+            <a:off x="4877175" y="2362200"/>
+            <a:ext cx="2700000" cy="1080000"/>
           </a:xfrm>
           <a:prstGeom prst="rect">
             <a:avLst/>
@@ -3013,7 +3013,41 @@
           <a:lstStyle/>
           <a:p>
             <a:pPr algn="ctr"/>
-            <a:endParaRPr lang="ko-KR" altLang="en-US" sz="3200">
+            <a:r>
+              <a:rPr lang="en-US" altLang="ko-KR" sz="2800" dirty="0" smtClean="0">
+                <a:latin typeface="나눔스퀘어 Bold" panose="020B0600000101010101" pitchFamily="50" charset="-127"/>
+                <a:ea typeface="나눔스퀘어 Bold" panose="020B0600000101010101" pitchFamily="50" charset="-127"/>
+              </a:rPr>
+              <a:t>WSL 2</a:t>
+            </a:r>
+            <a:br>
+              <a:rPr lang="en-US" altLang="ko-KR" sz="2800" dirty="0" smtClean="0">
+                <a:latin typeface="나눔스퀘어 Bold" panose="020B0600000101010101" pitchFamily="50" charset="-127"/>
+                <a:ea typeface="나눔스퀘어 Bold" panose="020B0600000101010101" pitchFamily="50" charset="-127"/>
+              </a:rPr>
+            </a:br>
+            <a:r>
+              <a:rPr lang="en-US" altLang="ko-KR" sz="2000" dirty="0" smtClean="0">
+                <a:latin typeface="나눔스퀘어 Bold" panose="020B0600000101010101" pitchFamily="50" charset="-127"/>
+                <a:ea typeface="나눔스퀘어 Bold" panose="020B0600000101010101" pitchFamily="50" charset="-127"/>
+              </a:rPr>
+              <a:t>(</a:t>
+            </a:r>
+            <a:r>
+              <a:rPr lang="ko-KR" altLang="en-US" sz="2000" dirty="0" smtClean="0">
+                <a:latin typeface="나눔스퀘어 Bold" panose="020B0600000101010101" pitchFamily="50" charset="-127"/>
+                <a:ea typeface="나눔스퀘어 Bold" panose="020B0600000101010101" pitchFamily="50" charset="-127"/>
+              </a:rPr>
+              <a:t>윈도우의 리눅스 자리</a:t>
+            </a:r>
+            <a:r>
+              <a:rPr lang="en-US" altLang="ko-KR" sz="2000" dirty="0" smtClean="0">
+                <a:latin typeface="나눔스퀘어 Bold" panose="020B0600000101010101" pitchFamily="50" charset="-127"/>
+                <a:ea typeface="나눔스퀘어 Bold" panose="020B0600000101010101" pitchFamily="50" charset="-127"/>
+              </a:rPr>
+              <a:t>)</a:t>
+            </a:r>
+            <a:endParaRPr lang="ko-KR" altLang="en-US" sz="2800" dirty="0">
               <a:latin typeface="나눔스퀘어 Bold" panose="020B0600000101010101" pitchFamily="50" charset="-127"/>
               <a:ea typeface="나눔스퀘어 Bold" panose="020B0600000101010101" pitchFamily="50" charset="-127"/>
             </a:endParaRPr>
@@ -3022,13 +3056,13 @@
       </p:sp>
       <p:sp>
         <p:nvSpPr>
-          <p:cNvPr id="4" name="직사각형 3"/>
+          <p:cNvPr id="20" name="직사각형 19"/>
           <p:cNvSpPr/>
           <p:nvPr/>
         </p:nvSpPr>
         <p:spPr>
           <a:xfrm>
-            <a:off x="4877175" y="2362200"/>
+            <a:off x="8684437" y="2362200"/>
             <a:ext cx="2700000" cy="1080000"/>
           </a:xfrm>
           <a:prstGeom prst="rect">
@@ -3063,24 +3097,56 @@
           <a:p>
             <a:pPr algn="ctr"/>
             <a:r>
-              <a:rPr lang="ko-KR" altLang="en-US" sz="3200" dirty="0">
-                <a:latin typeface="나눔스퀘어 Bold" panose="020B0600000101010101" pitchFamily="50" charset="-127"/>
-                <a:ea typeface="나눔스퀘어 Bold" panose="020B0600000101010101" pitchFamily="50" charset="-127"/>
-              </a:rPr>
-              <a:t>애플리케이션</a:t>
-            </a:r>
-          </a:p>
-        </p:txBody>
-      </p:sp>
-      <p:sp>
-        <p:nvSpPr>
-          <p:cNvPr id="20" name="직사각형 19"/>
+              <a:rPr lang="en-US" altLang="ko-KR" sz="2800" dirty="0" err="1" smtClean="0">
+                <a:latin typeface="나눔스퀘어 Bold" panose="020B0600000101010101" pitchFamily="50" charset="-127"/>
+                <a:ea typeface="나눔스퀘어 Bold" panose="020B0600000101010101" pitchFamily="50" charset="-127"/>
+              </a:rPr>
+              <a:t>Ububtu</a:t>
+            </a:r>
+            <a:endParaRPr lang="en-US" altLang="ko-KR" sz="2800" dirty="0" smtClean="0">
+              <a:latin typeface="나눔스퀘어 Bold" panose="020B0600000101010101" pitchFamily="50" charset="-127"/>
+              <a:ea typeface="나눔스퀘어 Bold" panose="020B0600000101010101" pitchFamily="50" charset="-127"/>
+            </a:endParaRPr>
+          </a:p>
+          <a:p>
+            <a:pPr algn="ctr"/>
+            <a:r>
+              <a:rPr lang="en-US" altLang="ko-KR" sz="2400" dirty="0" smtClean="0">
+                <a:latin typeface="나눔스퀘어 Bold" panose="020B0600000101010101" pitchFamily="50" charset="-127"/>
+                <a:ea typeface="나눔스퀘어 Bold" panose="020B0600000101010101" pitchFamily="50" charset="-127"/>
+              </a:rPr>
+              <a:t>(</a:t>
+            </a:r>
+            <a:r>
+              <a:rPr lang="ko-KR" altLang="en-US" sz="2400" dirty="0" smtClean="0">
+                <a:latin typeface="나눔스퀘어 Bold" panose="020B0600000101010101" pitchFamily="50" charset="-127"/>
+                <a:ea typeface="나눔스퀘어 Bold" panose="020B0600000101010101" pitchFamily="50" charset="-127"/>
+              </a:rPr>
+              <a:t>실제 리눅스</a:t>
+            </a:r>
+            <a:r>
+              <a:rPr lang="en-US" altLang="ko-KR" sz="2400" dirty="0" smtClean="0">
+                <a:latin typeface="나눔스퀘어 Bold" panose="020B0600000101010101" pitchFamily="50" charset="-127"/>
+                <a:ea typeface="나눔스퀘어 Bold" panose="020B0600000101010101" pitchFamily="50" charset="-127"/>
+              </a:rPr>
+              <a:t>)</a:t>
+            </a:r>
+            <a:endParaRPr lang="ko-KR" altLang="en-US" sz="2400" dirty="0">
+              <a:latin typeface="나눔스퀘어 Bold" panose="020B0600000101010101" pitchFamily="50" charset="-127"/>
+              <a:ea typeface="나눔스퀘어 Bold" panose="020B0600000101010101" pitchFamily="50" charset="-127"/>
+            </a:endParaRPr>
+          </a:p>
+        </p:txBody>
+      </p:sp>
+      <p:sp>
+        <p:nvSpPr>
+          <p:cNvPr id="13" name="직사각형 12"/>
           <p:cNvSpPr/>
           <p:nvPr/>
         </p:nvSpPr>
         <p:spPr>
           <a:xfrm>
-            <a:off x="9791700" y="2362200"/>
+            <a:off x="-2737349" y="2362200"/>
             <a:ext cx="2700000" cy="1080000"/>
           </a:xfrm>
           <a:prstGeom prst="rect">
@@ -3115,76 +3181,41 @@
           <a:p>
             <a:pPr algn="ctr"/>
             <a:r>
-              <a:rPr lang="en-US" altLang="ko-KR" sz="3200" dirty="0" smtClean="0">
-                <a:latin typeface="나눔스퀘어 Bold" panose="020B0600000101010101" pitchFamily="50" charset="-127"/>
-                <a:ea typeface="나눔스퀘어 Bold" panose="020B0600000101010101" pitchFamily="50" charset="-127"/>
-              </a:rPr>
-              <a:t>Connection</a:t>
-            </a:r>
-          </a:p>
-          <a:p>
-            <a:pPr algn="ctr"/>
-            <a:r>
-              <a:rPr lang="ko-KR" altLang="en-US" sz="3200" dirty="0" smtClean="0">
-                <a:latin typeface="나눔스퀘어 Bold" panose="020B0600000101010101" pitchFamily="50" charset="-127"/>
-                <a:ea typeface="나눔스퀘어 Bold" panose="020B0600000101010101" pitchFamily="50" charset="-127"/>
-              </a:rPr>
-              <a:t>반납</a:t>
-            </a:r>
-            <a:endParaRPr lang="ko-KR" altLang="en-US" sz="3200" dirty="0">
+              <a:rPr lang="ko-KR" altLang="en-US" sz="2800" dirty="0" smtClean="0">
+                <a:latin typeface="나눔스퀘어 Bold" panose="020B0600000101010101" pitchFamily="50" charset="-127"/>
+                <a:ea typeface="나눔스퀘어 Bold" panose="020B0600000101010101" pitchFamily="50" charset="-127"/>
+              </a:rPr>
+              <a:t>내 컴퓨터</a:t>
+            </a:r>
+            <a:endParaRPr lang="en-US" altLang="ko-KR" sz="2800" dirty="0" smtClean="0">
               <a:latin typeface="나눔스퀘어 Bold" panose="020B0600000101010101" pitchFamily="50" charset="-127"/>
               <a:ea typeface="나눔스퀘어 Bold" panose="020B0600000101010101" pitchFamily="50" charset="-127"/>
             </a:endParaRPr>
           </a:p>
-        </p:txBody>
-      </p:sp>
-      <p:sp>
-        <p:nvSpPr>
-          <p:cNvPr id="6" name="직사각형 5"/>
-          <p:cNvSpPr/>
-          <p:nvPr/>
-        </p:nvSpPr>
-        <p:spPr>
-          <a:xfrm>
-            <a:off x="-1154566" y="883318"/>
-            <a:ext cx="3314433" cy="584775"/>
-          </a:xfrm>
-          <a:prstGeom prst="rect">
-            <a:avLst/>
-          </a:prstGeom>
-          <a:ln>
-            <a:noFill/>
-          </a:ln>
-        </p:spPr>
-        <p:txBody>
-          <a:bodyPr wrap="none">
-            <a:spAutoFit/>
-          </a:bodyPr>
-          <a:lstStyle/>
-          <a:p>
-            <a:pPr algn="ctr"/>
-            <a:r>
-              <a:rPr lang="ko-KR" altLang="en-US" sz="3200" dirty="0" err="1">
-                <a:latin typeface="나눔스퀘어 Bold" panose="020B0600000101010101" pitchFamily="50" charset="-127"/>
-                <a:ea typeface="나눔스퀘어 Bold" panose="020B0600000101010101" pitchFamily="50" charset="-127"/>
-              </a:rPr>
-              <a:t>Connection</a:t>
-            </a:r>
-            <a:r>
-              <a:rPr lang="ko-KR" altLang="en-US" sz="3200" dirty="0">
-                <a:latin typeface="나눔스퀘어 Bold" panose="020B0600000101010101" pitchFamily="50" charset="-127"/>
-                <a:ea typeface="나눔스퀘어 Bold" panose="020B0600000101010101" pitchFamily="50" charset="-127"/>
-              </a:rPr>
-              <a:t> </a:t>
-            </a:r>
-            <a:r>
-              <a:rPr lang="ko-KR" altLang="en-US" sz="3200" dirty="0" err="1">
-                <a:latin typeface="나눔스퀘어 Bold" panose="020B0600000101010101" pitchFamily="50" charset="-127"/>
-                <a:ea typeface="나눔스퀘어 Bold" panose="020B0600000101010101" pitchFamily="50" charset="-127"/>
-              </a:rPr>
-              <a:t>Pool</a:t>
-            </a:r>
-            <a:endParaRPr lang="ko-KR" altLang="en-US" sz="3200" dirty="0">
+          <a:p>
+            <a:pPr algn="ctr"/>
+            <a:r>
+              <a:rPr lang="en-US" altLang="ko-KR" sz="2400" dirty="0" smtClean="0">
+                <a:latin typeface="나눔스퀘어 Bold" panose="020B0600000101010101" pitchFamily="50" charset="-127"/>
+                <a:ea typeface="나눔스퀘어 Bold" panose="020B0600000101010101" pitchFamily="50" charset="-127"/>
+              </a:rPr>
+              <a:t>(</a:t>
+            </a:r>
+            <a:r>
+              <a:rPr lang="ko-KR" altLang="en-US" sz="2400" dirty="0" smtClean="0">
+                <a:latin typeface="나눔스퀘어 Bold" panose="020B0600000101010101" pitchFamily="50" charset="-127"/>
+                <a:ea typeface="나눔스퀘어 Bold" panose="020B0600000101010101" pitchFamily="50" charset="-127"/>
+              </a:rPr>
+              <a:t>하드웨어</a:t>
+            </a:r>
+            <a:r>
+              <a:rPr lang="en-US" altLang="ko-KR" sz="2400" dirty="0" smtClean="0">
+                <a:latin typeface="나눔스퀘어 Bold" panose="020B0600000101010101" pitchFamily="50" charset="-127"/>
+                <a:ea typeface="나눔스퀘어 Bold" panose="020B0600000101010101" pitchFamily="50" charset="-127"/>
+              </a:rPr>
+              <a:t>)</a:t>
+            </a:r>
+            <a:endParaRPr lang="ko-KR" altLang="en-US" sz="2400" dirty="0">
               <a:latin typeface="나눔스퀘어 Bold" panose="020B0600000101010101" pitchFamily="50" charset="-127"/>
               <a:ea typeface="나눔스퀘어 Bold" panose="020B0600000101010101" pitchFamily="50" charset="-127"/>
             </a:endParaRPr>
@@ -3193,22 +3224,20 @@
       </p:sp>
       <p:sp>
         <p:nvSpPr>
-          <p:cNvPr id="7" name="직사각형 6"/>
+          <p:cNvPr id="14" name="직사각형 13"/>
           <p:cNvSpPr/>
           <p:nvPr/>
         </p:nvSpPr>
         <p:spPr>
           <a:xfrm>
-            <a:off x="-1297350" y="1714200"/>
-            <a:ext cx="3600000" cy="648000"/>
+            <a:off x="1069913" y="2362200"/>
+            <a:ext cx="2700000" cy="1080000"/>
           </a:xfrm>
           <a:prstGeom prst="rect">
             <a:avLst/>
           </a:prstGeom>
           <a:solidFill>
-            <a:schemeClr val="bg1">
-              <a:lumMod val="95000"/>
-            </a:schemeClr>
+            <a:schemeClr val="accent5"/>
           </a:solidFill>
           <a:ln>
             <a:noFill/>
@@ -3236,218 +3265,66 @@
           <a:p>
             <a:pPr algn="ctr"/>
             <a:r>
-              <a:rPr lang="en-US" altLang="ko-KR" sz="3200" dirty="0">
-                <a:solidFill>
-                  <a:schemeClr val="tx1"/>
-                </a:solidFill>
-                <a:latin typeface="나눔스퀘어 Bold" panose="020B0600000101010101" pitchFamily="50" charset="-127"/>
-                <a:ea typeface="나눔스퀘어 Bold" panose="020B0600000101010101" pitchFamily="50" charset="-127"/>
-              </a:rPr>
-              <a:t>Connection 1</a:t>
-            </a:r>
-            <a:endParaRPr lang="ko-KR" altLang="en-US" sz="3200" dirty="0">
-              <a:solidFill>
-                <a:schemeClr val="tx1"/>
-              </a:solidFill>
+              <a:rPr lang="ko-KR" altLang="en-US" sz="2800" dirty="0" smtClean="0">
+                <a:latin typeface="나눔스퀘어 Bold" panose="020B0600000101010101" pitchFamily="50" charset="-127"/>
+                <a:ea typeface="나눔스퀘어 Bold" panose="020B0600000101010101" pitchFamily="50" charset="-127"/>
+              </a:rPr>
+              <a:t>윈도우</a:t>
+            </a:r>
+            <a:r>
+              <a:rPr lang="en-US" altLang="ko-KR" sz="2800" dirty="0" smtClean="0">
+                <a:latin typeface="나눔스퀘어 Bold" panose="020B0600000101010101" pitchFamily="50" charset="-127"/>
+                <a:ea typeface="나눔스퀘어 Bold" panose="020B0600000101010101" pitchFamily="50" charset="-127"/>
+              </a:rPr>
+              <a:t/>
+            </a:r>
+            <a:br>
+              <a:rPr lang="en-US" altLang="ko-KR" sz="2800" dirty="0" smtClean="0">
+                <a:latin typeface="나눔스퀘어 Bold" panose="020B0600000101010101" pitchFamily="50" charset="-127"/>
+                <a:ea typeface="나눔스퀘어 Bold" panose="020B0600000101010101" pitchFamily="50" charset="-127"/>
+              </a:rPr>
+            </a:br>
+            <a:r>
+              <a:rPr lang="en-US" altLang="ko-KR" sz="2400" dirty="0" smtClean="0">
+                <a:latin typeface="나눔스퀘어 Bold" panose="020B0600000101010101" pitchFamily="50" charset="-127"/>
+                <a:ea typeface="나눔스퀘어 Bold" panose="020B0600000101010101" pitchFamily="50" charset="-127"/>
+              </a:rPr>
+              <a:t>(</a:t>
+            </a:r>
+            <a:r>
+              <a:rPr lang="ko-KR" altLang="en-US" sz="2400" dirty="0" smtClean="0">
+                <a:latin typeface="나눔스퀘어 Bold" panose="020B0600000101010101" pitchFamily="50" charset="-127"/>
+                <a:ea typeface="나눔스퀘어 Bold" panose="020B0600000101010101" pitchFamily="50" charset="-127"/>
+              </a:rPr>
+              <a:t>그대로</a:t>
+            </a:r>
+            <a:r>
+              <a:rPr lang="en-US" altLang="ko-KR" sz="2400" dirty="0" smtClean="0">
+                <a:latin typeface="나눔스퀘어 Bold" panose="020B0600000101010101" pitchFamily="50" charset="-127"/>
+                <a:ea typeface="나눔스퀘어 Bold" panose="020B0600000101010101" pitchFamily="50" charset="-127"/>
+              </a:rPr>
+              <a:t>)</a:t>
+            </a:r>
+            <a:endParaRPr lang="ko-KR" altLang="en-US" sz="2800" dirty="0">
               <a:latin typeface="나눔스퀘어 Bold" panose="020B0600000101010101" pitchFamily="50" charset="-127"/>
               <a:ea typeface="나눔스퀘어 Bold" panose="020B0600000101010101" pitchFamily="50" charset="-127"/>
             </a:endParaRPr>
           </a:p>
         </p:txBody>
       </p:sp>
-      <p:sp>
-        <p:nvSpPr>
-          <p:cNvPr id="23" name="직사각형 22"/>
-          <p:cNvSpPr/>
-          <p:nvPr/>
-        </p:nvSpPr>
-        <p:spPr>
-          <a:xfrm>
-            <a:off x="-1297350" y="2609534"/>
-            <a:ext cx="3600000" cy="648000"/>
-          </a:xfrm>
-          <a:prstGeom prst="rect">
-            <a:avLst/>
-          </a:prstGeom>
-          <a:solidFill>
-            <a:schemeClr val="bg1">
-              <a:lumMod val="95000"/>
-            </a:schemeClr>
-          </a:solidFill>
-          <a:ln>
-            <a:noFill/>
-          </a:ln>
-        </p:spPr>
-        <p:style>
-          <a:lnRef idx="2">
-            <a:schemeClr val="accent1">
-              <a:shade val="50000"/>
-            </a:schemeClr>
-          </a:lnRef>
-          <a:fillRef idx="1">
-            <a:schemeClr val="accent1"/>
-          </a:fillRef>
-          <a:effectRef idx="0">
-            <a:schemeClr val="accent1"/>
-          </a:effectRef>
-          <a:fontRef idx="minor">
-            <a:schemeClr val="lt1"/>
-          </a:fontRef>
-        </p:style>
-        <p:txBody>
-          <a:bodyPr rtlCol="0" anchor="ctr"/>
-          <a:lstStyle/>
-          <a:p>
-            <a:pPr algn="ctr"/>
-            <a:r>
-              <a:rPr lang="en-US" altLang="ko-KR" sz="3200" dirty="0">
-                <a:solidFill>
-                  <a:schemeClr val="tx1"/>
-                </a:solidFill>
-                <a:latin typeface="나눔스퀘어 Bold" panose="020B0600000101010101" pitchFamily="50" charset="-127"/>
-                <a:ea typeface="나눔스퀘어 Bold" panose="020B0600000101010101" pitchFamily="50" charset="-127"/>
-              </a:rPr>
-              <a:t>Connection </a:t>
-            </a:r>
-            <a:r>
-              <a:rPr lang="en-US" altLang="ko-KR" sz="3200" dirty="0" smtClean="0">
-                <a:solidFill>
-                  <a:schemeClr val="tx1"/>
-                </a:solidFill>
-                <a:latin typeface="나눔스퀘어 Bold" panose="020B0600000101010101" pitchFamily="50" charset="-127"/>
-                <a:ea typeface="나눔스퀘어 Bold" panose="020B0600000101010101" pitchFamily="50" charset="-127"/>
-              </a:rPr>
-              <a:t>2</a:t>
-            </a:r>
-            <a:endParaRPr lang="ko-KR" altLang="en-US" sz="3200" dirty="0">
-              <a:solidFill>
-                <a:schemeClr val="tx1"/>
-              </a:solidFill>
-              <a:latin typeface="나눔스퀘어 Bold" panose="020B0600000101010101" pitchFamily="50" charset="-127"/>
-              <a:ea typeface="나눔스퀘어 Bold" panose="020B0600000101010101" pitchFamily="50" charset="-127"/>
-            </a:endParaRPr>
-          </a:p>
-        </p:txBody>
-      </p:sp>
-      <p:sp>
-        <p:nvSpPr>
-          <p:cNvPr id="24" name="직사각형 23"/>
-          <p:cNvSpPr/>
-          <p:nvPr/>
-        </p:nvSpPr>
-        <p:spPr>
-          <a:xfrm>
-            <a:off x="-1297350" y="3442200"/>
-            <a:ext cx="3600000" cy="648000"/>
-          </a:xfrm>
-          <a:prstGeom prst="rect">
-            <a:avLst/>
-          </a:prstGeom>
-          <a:solidFill>
-            <a:schemeClr val="bg1">
-              <a:lumMod val="95000"/>
-            </a:schemeClr>
-          </a:solidFill>
-          <a:ln>
-            <a:noFill/>
-          </a:ln>
-        </p:spPr>
-        <p:style>
-          <a:lnRef idx="2">
-            <a:schemeClr val="accent1">
-              <a:shade val="50000"/>
-            </a:schemeClr>
-          </a:lnRef>
-          <a:fillRef idx="1">
-            <a:schemeClr val="accent1"/>
-          </a:fillRef>
-          <a:effectRef idx="0">
-            <a:schemeClr val="accent1"/>
-          </a:effectRef>
-          <a:fontRef idx="minor">
-            <a:schemeClr val="lt1"/>
-          </a:fontRef>
-        </p:style>
-        <p:txBody>
-          <a:bodyPr rtlCol="0" anchor="ctr"/>
-          <a:lstStyle/>
-          <a:p>
-            <a:pPr algn="ctr"/>
-            <a:r>
-              <a:rPr lang="en-US" altLang="ko-KR" sz="3200" dirty="0">
-                <a:solidFill>
-                  <a:schemeClr val="tx1"/>
-                </a:solidFill>
-                <a:latin typeface="나눔스퀘어 Bold" panose="020B0600000101010101" pitchFamily="50" charset="-127"/>
-                <a:ea typeface="나눔스퀘어 Bold" panose="020B0600000101010101" pitchFamily="50" charset="-127"/>
-              </a:rPr>
-              <a:t>Connection </a:t>
-            </a:r>
-            <a:r>
-              <a:rPr lang="en-US" altLang="ko-KR" sz="3200" dirty="0" smtClean="0">
-                <a:solidFill>
-                  <a:schemeClr val="tx1"/>
-                </a:solidFill>
-                <a:latin typeface="나눔스퀘어 Bold" panose="020B0600000101010101" pitchFamily="50" charset="-127"/>
-                <a:ea typeface="나눔스퀘어 Bold" panose="020B0600000101010101" pitchFamily="50" charset="-127"/>
-              </a:rPr>
-              <a:t>3</a:t>
-            </a:r>
-            <a:endParaRPr lang="ko-KR" altLang="en-US" sz="3200" dirty="0">
-              <a:solidFill>
-                <a:schemeClr val="tx1"/>
-              </a:solidFill>
-              <a:latin typeface="나눔스퀘어 Bold" panose="020B0600000101010101" pitchFamily="50" charset="-127"/>
-              <a:ea typeface="나눔스퀘어 Bold" panose="020B0600000101010101" pitchFamily="50" charset="-127"/>
-            </a:endParaRPr>
-          </a:p>
-        </p:txBody>
-      </p:sp>
-      <p:sp>
-        <p:nvSpPr>
-          <p:cNvPr id="8" name="직사각형 7"/>
-          <p:cNvSpPr/>
-          <p:nvPr/>
-        </p:nvSpPr>
-        <p:spPr>
-          <a:xfrm>
-            <a:off x="7784994" y="2304268"/>
-            <a:ext cx="1798890" cy="584775"/>
-          </a:xfrm>
-          <a:prstGeom prst="rect">
-            <a:avLst/>
-          </a:prstGeom>
-        </p:spPr>
-        <p:txBody>
-          <a:bodyPr wrap="none">
-            <a:spAutoFit/>
-          </a:bodyPr>
-          <a:lstStyle/>
-          <a:p>
-            <a:pPr algn="ctr"/>
-            <a:r>
-              <a:rPr lang="ko-KR" altLang="en-US" sz="3200" dirty="0">
-                <a:latin typeface="나눔스퀘어 Bold" panose="020B0600000101010101" pitchFamily="50" charset="-127"/>
-                <a:ea typeface="나눔스퀘어 Bold" panose="020B0600000101010101" pitchFamily="50" charset="-127"/>
-              </a:rPr>
-              <a:t>SQL 실행</a:t>
-            </a:r>
-          </a:p>
-        </p:txBody>
-      </p:sp>
       <p:cxnSp>
         <p:nvCxnSpPr>
-          <p:cNvPr id="10" name="직선 화살표 연결선 9"/>
+          <p:cNvPr id="9" name="직선 화살표 연결선 8"/>
           <p:cNvCxnSpPr>
-            <a:stCxn id="2" idx="3"/>
-            <a:endCxn id="4" idx="1"/>
+            <a:stCxn id="13" idx="3"/>
+            <a:endCxn id="14" idx="1"/>
           </p:cNvCxnSpPr>
           <p:nvPr/>
         </p:nvCxnSpPr>
         <p:spPr>
           <a:xfrm>
-            <a:off x="2662650" y="2902200"/>
-            <a:ext cx="2214525" cy="0"/>
+            <a:off x="-37349" y="2902200"/>
+            <a:ext cx="1107262" cy="0"/>
           </a:xfrm>
           <a:prstGeom prst="straightConnector1">
             <a:avLst/>
@@ -3456,7 +3333,6 @@
             <a:solidFill>
               <a:schemeClr val="accent2"/>
             </a:solidFill>
-            <a:headEnd type="triangle"/>
             <a:tailEnd type="triangle"/>
           </a:ln>
         </p:spPr>
@@ -3477,17 +3353,17 @@
       </p:cxnSp>
       <p:cxnSp>
         <p:nvCxnSpPr>
-          <p:cNvPr id="28" name="직선 화살표 연결선 27"/>
+          <p:cNvPr id="21" name="직선 화살표 연결선 20"/>
           <p:cNvCxnSpPr>
-            <a:stCxn id="4" idx="3"/>
-            <a:endCxn id="20" idx="1"/>
+            <a:stCxn id="14" idx="3"/>
+            <a:endCxn id="4" idx="1"/>
           </p:cNvCxnSpPr>
           <p:nvPr/>
         </p:nvCxnSpPr>
         <p:spPr>
           <a:xfrm>
-            <a:off x="7577175" y="2902200"/>
-            <a:ext cx="2214525" cy="0"/>
+            <a:off x="3769913" y="2902200"/>
+            <a:ext cx="1107262" cy="0"/>
           </a:xfrm>
           <a:prstGeom prst="straightConnector1">
             <a:avLst/>
@@ -3496,7 +3372,6 @@
             <a:solidFill>
               <a:schemeClr val="accent2"/>
             </a:solidFill>
-            <a:headEnd type="triangle"/>
             <a:tailEnd type="triangle"/>
           </a:ln>
         </p:spPr>
@@ -3515,42 +3390,45 @@
           </a:fontRef>
         </p:style>
       </p:cxnSp>
-      <p:sp>
-        <p:nvSpPr>
-          <p:cNvPr id="33" name="직사각형 32"/>
-          <p:cNvSpPr/>
-          <p:nvPr/>
-        </p:nvSpPr>
-        <p:spPr>
-          <a:xfrm>
-            <a:off x="3117330" y="2304268"/>
-            <a:ext cx="1305165" cy="584775"/>
-          </a:xfrm>
-          <a:prstGeom prst="rect">
-            <a:avLst/>
-          </a:prstGeom>
-        </p:spPr>
-        <p:txBody>
-          <a:bodyPr wrap="none">
-            <a:spAutoFit/>
-          </a:bodyPr>
-          <a:lstStyle/>
-          <a:p>
-            <a:pPr algn="ctr"/>
-            <a:r>
-              <a:rPr lang="ko-KR" altLang="en-US" sz="3200" dirty="0" smtClean="0">
-                <a:latin typeface="나눔스퀘어 Bold" panose="020B0600000101010101" pitchFamily="50" charset="-127"/>
-                <a:ea typeface="나눔스퀘어 Bold" panose="020B0600000101010101" pitchFamily="50" charset="-127"/>
-              </a:rPr>
-              <a:t>빌려줌</a:t>
-            </a:r>
-            <a:endParaRPr lang="ko-KR" altLang="en-US" sz="3200" dirty="0">
-              <a:latin typeface="나눔스퀘어 Bold" panose="020B0600000101010101" pitchFamily="50" charset="-127"/>
-              <a:ea typeface="나눔스퀘어 Bold" panose="020B0600000101010101" pitchFamily="50" charset="-127"/>
-            </a:endParaRPr>
-          </a:p>
-        </p:txBody>
-      </p:sp>
+      <p:cxnSp>
+        <p:nvCxnSpPr>
+          <p:cNvPr id="25" name="직선 화살표 연결선 24"/>
+          <p:cNvCxnSpPr>
+            <a:stCxn id="4" idx="3"/>
+            <a:endCxn id="20" idx="1"/>
+          </p:cNvCxnSpPr>
+          <p:nvPr/>
+        </p:nvCxnSpPr>
+        <p:spPr>
+          <a:xfrm>
+            <a:off x="7577175" y="2902200"/>
+            <a:ext cx="1107262" cy="0"/>
+          </a:xfrm>
+          <a:prstGeom prst="straightConnector1">
+            <a:avLst/>
+          </a:prstGeom>
+          <a:ln w="76200">
+            <a:solidFill>
+              <a:schemeClr val="accent2"/>
+            </a:solidFill>
+            <a:tailEnd type="triangle"/>
+          </a:ln>
+        </p:spPr>
+        <p:style>
+          <a:lnRef idx="1">
+            <a:schemeClr val="accent1"/>
+          </a:lnRef>
+          <a:fillRef idx="0">
+            <a:schemeClr val="accent1"/>
+          </a:fillRef>
+          <a:effectRef idx="0">
+            <a:schemeClr val="accent1"/>
+          </a:effectRef>
+          <a:fontRef idx="minor">
+            <a:schemeClr val="tx1"/>
+          </a:fontRef>
+        </p:style>
+      </p:cxnSp>
     </p:spTree>
     <p:extLst>
       <p:ext uri="{BB962C8B-B14F-4D97-AF65-F5344CB8AC3E}">

</xml_diff>

<commit_message>
20260916 commit : first
</commit_message>
<xml_diff>
--- a/notion/create_notion_img.pptx
+++ b/notion/create_notion_img.pptx
@@ -245,7 +245,7 @@
           <a:p>
             <a:fld id="{7237CE1A-8831-48B5-BA93-72483C6E34E8}" type="datetimeFigureOut">
               <a:rPr lang="ko-KR" altLang="en-US" smtClean="0"/>
-              <a:t>2026-09-14</a:t>
+              <a:t>2026-09-16</a:t>
             </a:fld>
             <a:endParaRPr lang="ko-KR" altLang="en-US"/>
           </a:p>
@@ -415,7 +415,7 @@
           <a:p>
             <a:fld id="{7237CE1A-8831-48B5-BA93-72483C6E34E8}" type="datetimeFigureOut">
               <a:rPr lang="ko-KR" altLang="en-US" smtClean="0"/>
-              <a:t>2026-09-14</a:t>
+              <a:t>2026-09-16</a:t>
             </a:fld>
             <a:endParaRPr lang="ko-KR" altLang="en-US"/>
           </a:p>
@@ -595,7 +595,7 @@
           <a:p>
             <a:fld id="{7237CE1A-8831-48B5-BA93-72483C6E34E8}" type="datetimeFigureOut">
               <a:rPr lang="ko-KR" altLang="en-US" smtClean="0"/>
-              <a:t>2026-09-14</a:t>
+              <a:t>2026-09-16</a:t>
             </a:fld>
             <a:endParaRPr lang="ko-KR" altLang="en-US"/>
           </a:p>
@@ -765,7 +765,7 @@
           <a:p>
             <a:fld id="{7237CE1A-8831-48B5-BA93-72483C6E34E8}" type="datetimeFigureOut">
               <a:rPr lang="ko-KR" altLang="en-US" smtClean="0"/>
-              <a:t>2026-09-14</a:t>
+              <a:t>2026-09-16</a:t>
             </a:fld>
             <a:endParaRPr lang="ko-KR" altLang="en-US"/>
           </a:p>
@@ -1011,7 +1011,7 @@
           <a:p>
             <a:fld id="{7237CE1A-8831-48B5-BA93-72483C6E34E8}" type="datetimeFigureOut">
               <a:rPr lang="ko-KR" altLang="en-US" smtClean="0"/>
-              <a:t>2026-09-14</a:t>
+              <a:t>2026-09-16</a:t>
             </a:fld>
             <a:endParaRPr lang="ko-KR" altLang="en-US"/>
           </a:p>
@@ -1243,7 +1243,7 @@
           <a:p>
             <a:fld id="{7237CE1A-8831-48B5-BA93-72483C6E34E8}" type="datetimeFigureOut">
               <a:rPr lang="ko-KR" altLang="en-US" smtClean="0"/>
-              <a:t>2026-09-14</a:t>
+              <a:t>2026-09-16</a:t>
             </a:fld>
             <a:endParaRPr lang="ko-KR" altLang="en-US"/>
           </a:p>
@@ -1610,7 +1610,7 @@
           <a:p>
             <a:fld id="{7237CE1A-8831-48B5-BA93-72483C6E34E8}" type="datetimeFigureOut">
               <a:rPr lang="ko-KR" altLang="en-US" smtClean="0"/>
-              <a:t>2026-09-14</a:t>
+              <a:t>2026-09-16</a:t>
             </a:fld>
             <a:endParaRPr lang="ko-KR" altLang="en-US"/>
           </a:p>
@@ -1728,7 +1728,7 @@
           <a:p>
             <a:fld id="{7237CE1A-8831-48B5-BA93-72483C6E34E8}" type="datetimeFigureOut">
               <a:rPr lang="ko-KR" altLang="en-US" smtClean="0"/>
-              <a:t>2026-09-14</a:t>
+              <a:t>2026-09-16</a:t>
             </a:fld>
             <a:endParaRPr lang="ko-KR" altLang="en-US"/>
           </a:p>
@@ -1823,7 +1823,7 @@
           <a:p>
             <a:fld id="{7237CE1A-8831-48B5-BA93-72483C6E34E8}" type="datetimeFigureOut">
               <a:rPr lang="ko-KR" altLang="en-US" smtClean="0"/>
-              <a:t>2026-09-14</a:t>
+              <a:t>2026-09-16</a:t>
             </a:fld>
             <a:endParaRPr lang="ko-KR" altLang="en-US"/>
           </a:p>
@@ -2100,7 +2100,7 @@
           <a:p>
             <a:fld id="{7237CE1A-8831-48B5-BA93-72483C6E34E8}" type="datetimeFigureOut">
               <a:rPr lang="ko-KR" altLang="en-US" smtClean="0"/>
-              <a:t>2026-09-14</a:t>
+              <a:t>2026-09-16</a:t>
             </a:fld>
             <a:endParaRPr lang="ko-KR" altLang="en-US"/>
           </a:p>
@@ -2353,7 +2353,7 @@
           <a:p>
             <a:fld id="{7237CE1A-8831-48B5-BA93-72483C6E34E8}" type="datetimeFigureOut">
               <a:rPr lang="ko-KR" altLang="en-US" smtClean="0"/>
-              <a:t>2026-09-14</a:t>
+              <a:t>2026-09-16</a:t>
             </a:fld>
             <a:endParaRPr lang="ko-KR" altLang="en-US"/>
           </a:p>
@@ -2566,7 +2566,7 @@
           <a:p>
             <a:fld id="{7237CE1A-8831-48B5-BA93-72483C6E34E8}" type="datetimeFigureOut">
               <a:rPr lang="ko-KR" altLang="en-US" smtClean="0"/>
-              <a:t>2026-09-14</a:t>
+              <a:t>2026-09-16</a:t>
             </a:fld>
             <a:endParaRPr lang="ko-KR" altLang="en-US"/>
           </a:p>
@@ -2979,7 +2979,7 @@
         </p:nvSpPr>
         <p:spPr>
           <a:xfrm>
-            <a:off x="4877175" y="2362200"/>
+            <a:off x="9873983" y="1259114"/>
             <a:ext cx="2700000" cy="1080000"/>
           </a:xfrm>
           <a:prstGeom prst="rect">
@@ -3014,38 +3014,11 @@
           <a:p>
             <a:pPr algn="ctr"/>
             <a:r>
-              <a:rPr lang="en-US" altLang="ko-KR" sz="2800" dirty="0" smtClean="0">
-                <a:latin typeface="나눔스퀘어 Bold" panose="020B0600000101010101" pitchFamily="50" charset="-127"/>
-                <a:ea typeface="나눔스퀘어 Bold" panose="020B0600000101010101" pitchFamily="50" charset="-127"/>
-              </a:rPr>
-              <a:t>WSL 2</a:t>
-            </a:r>
-            <a:br>
-              <a:rPr lang="en-US" altLang="ko-KR" sz="2800" dirty="0" smtClean="0">
-                <a:latin typeface="나눔스퀘어 Bold" panose="020B0600000101010101" pitchFamily="50" charset="-127"/>
-                <a:ea typeface="나눔스퀘어 Bold" panose="020B0600000101010101" pitchFamily="50" charset="-127"/>
-              </a:rPr>
-            </a:br>
-            <a:r>
-              <a:rPr lang="en-US" altLang="ko-KR" sz="2000" dirty="0" smtClean="0">
-                <a:latin typeface="나눔스퀘어 Bold" panose="020B0600000101010101" pitchFamily="50" charset="-127"/>
-                <a:ea typeface="나눔스퀘어 Bold" panose="020B0600000101010101" pitchFamily="50" charset="-127"/>
-              </a:rPr>
-              <a:t>(</a:t>
-            </a:r>
-            <a:r>
-              <a:rPr lang="ko-KR" altLang="en-US" sz="2000" dirty="0" smtClean="0">
-                <a:latin typeface="나눔스퀘어 Bold" panose="020B0600000101010101" pitchFamily="50" charset="-127"/>
-                <a:ea typeface="나눔스퀘어 Bold" panose="020B0600000101010101" pitchFamily="50" charset="-127"/>
-              </a:rPr>
-              <a:t>윈도우의 리눅스 자리</a:t>
-            </a:r>
-            <a:r>
-              <a:rPr lang="en-US" altLang="ko-KR" sz="2000" dirty="0" smtClean="0">
-                <a:latin typeface="나눔스퀘어 Bold" panose="020B0600000101010101" pitchFamily="50" charset="-127"/>
-                <a:ea typeface="나눔스퀘어 Bold" panose="020B0600000101010101" pitchFamily="50" charset="-127"/>
-              </a:rPr>
-              <a:t>)</a:t>
+              <a:rPr lang="en-US" altLang="ko-KR" sz="3200" dirty="0">
+                <a:latin typeface="나눔스퀘어 Bold" panose="020B0600000101010101" pitchFamily="50" charset="-127"/>
+                <a:ea typeface="나눔스퀘어 Bold" panose="020B0600000101010101" pitchFamily="50" charset="-127"/>
+              </a:rPr>
+              <a:t>Database</a:t>
             </a:r>
             <a:endParaRPr lang="ko-KR" altLang="en-US" sz="2800" dirty="0">
               <a:latin typeface="나눔스퀘어 Bold" panose="020B0600000101010101" pitchFamily="50" charset="-127"/>
@@ -3056,13 +3029,13 @@
       </p:sp>
       <p:sp>
         <p:nvSpPr>
-          <p:cNvPr id="20" name="직사각형 19"/>
+          <p:cNvPr id="13" name="직사각형 12"/>
           <p:cNvSpPr/>
           <p:nvPr/>
         </p:nvSpPr>
         <p:spPr>
           <a:xfrm>
-            <a:off x="8684437" y="2362200"/>
+            <a:off x="-506043" y="1259114"/>
             <a:ext cx="2700000" cy="1080000"/>
           </a:xfrm>
           <a:prstGeom prst="rect">
@@ -3097,39 +3070,11 @@
           <a:p>
             <a:pPr algn="ctr"/>
             <a:r>
-              <a:rPr lang="en-US" altLang="ko-KR" sz="2800" dirty="0" err="1" smtClean="0">
-                <a:latin typeface="나눔스퀘어 Bold" panose="020B0600000101010101" pitchFamily="50" charset="-127"/>
-                <a:ea typeface="나눔스퀘어 Bold" panose="020B0600000101010101" pitchFamily="50" charset="-127"/>
-              </a:rPr>
-              <a:t>Ububtu</a:t>
-            </a:r>
-            <a:endParaRPr lang="en-US" altLang="ko-KR" sz="2800" dirty="0" smtClean="0">
-              <a:latin typeface="나눔스퀘어 Bold" panose="020B0600000101010101" pitchFamily="50" charset="-127"/>
-              <a:ea typeface="나눔스퀘어 Bold" panose="020B0600000101010101" pitchFamily="50" charset="-127"/>
-            </a:endParaRPr>
-          </a:p>
-          <a:p>
-            <a:pPr algn="ctr"/>
-            <a:r>
-              <a:rPr lang="en-US" altLang="ko-KR" sz="2400" dirty="0" smtClean="0">
-                <a:latin typeface="나눔스퀘어 Bold" panose="020B0600000101010101" pitchFamily="50" charset="-127"/>
-                <a:ea typeface="나눔스퀘어 Bold" panose="020B0600000101010101" pitchFamily="50" charset="-127"/>
-              </a:rPr>
-              <a:t>(</a:t>
-            </a:r>
-            <a:r>
-              <a:rPr lang="ko-KR" altLang="en-US" sz="2400" dirty="0" smtClean="0">
-                <a:latin typeface="나눔스퀘어 Bold" panose="020B0600000101010101" pitchFamily="50" charset="-127"/>
-                <a:ea typeface="나눔스퀘어 Bold" panose="020B0600000101010101" pitchFamily="50" charset="-127"/>
-              </a:rPr>
-              <a:t>실제 리눅스</a:t>
-            </a:r>
-            <a:r>
-              <a:rPr lang="en-US" altLang="ko-KR" sz="2400" dirty="0" smtClean="0">
-                <a:latin typeface="나눔스퀘어 Bold" panose="020B0600000101010101" pitchFamily="50" charset="-127"/>
-                <a:ea typeface="나눔스퀘어 Bold" panose="020B0600000101010101" pitchFamily="50" charset="-127"/>
-              </a:rPr>
-              <a:t>)</a:t>
+              <a:rPr lang="en-US" altLang="ko-KR" sz="3200" dirty="0" smtClean="0">
+                <a:latin typeface="나눔스퀘어 Bold" panose="020B0600000101010101" pitchFamily="50" charset="-127"/>
+                <a:ea typeface="나눔스퀘어 Bold" panose="020B0600000101010101" pitchFamily="50" charset="-127"/>
+              </a:rPr>
+              <a:t>Application</a:t>
             </a:r>
             <a:endParaRPr lang="ko-KR" altLang="en-US" sz="2400" dirty="0">
               <a:latin typeface="나눔스퀘어 Bold" panose="020B0600000101010101" pitchFamily="50" charset="-127"/>
@@ -3140,14 +3085,14 @@
       </p:sp>
       <p:sp>
         <p:nvSpPr>
-          <p:cNvPr id="13" name="직사각형 12"/>
+          <p:cNvPr id="14" name="직사각형 13"/>
           <p:cNvSpPr/>
           <p:nvPr/>
         </p:nvSpPr>
         <p:spPr>
           <a:xfrm>
-            <a:off x="-2737349" y="2362200"/>
-            <a:ext cx="2700000" cy="1080000"/>
+            <a:off x="3873970" y="719114"/>
+            <a:ext cx="4320000" cy="2160000"/>
           </a:xfrm>
           <a:prstGeom prst="rect">
             <a:avLst/>
@@ -3181,140 +3126,77 @@
           <a:p>
             <a:pPr algn="ctr"/>
             <a:r>
-              <a:rPr lang="ko-KR" altLang="en-US" sz="2800" dirty="0" smtClean="0">
-                <a:latin typeface="나눔스퀘어 Bold" panose="020B0600000101010101" pitchFamily="50" charset="-127"/>
-                <a:ea typeface="나눔스퀘어 Bold" panose="020B0600000101010101" pitchFamily="50" charset="-127"/>
-              </a:rPr>
-              <a:t>내 컴퓨터</a:t>
-            </a:r>
-            <a:endParaRPr lang="en-US" altLang="ko-KR" sz="2800" dirty="0" smtClean="0">
+              <a:rPr lang="en-US" altLang="ko-KR" sz="2000" dirty="0">
+                <a:latin typeface="나눔스퀘어 Bold" panose="020B0600000101010101" pitchFamily="50" charset="-127"/>
+                <a:ea typeface="나눔스퀘어 Bold" panose="020B0600000101010101" pitchFamily="50" charset="-127"/>
+              </a:rPr>
+              <a:t>Persistence </a:t>
+            </a:r>
+            <a:r>
+              <a:rPr lang="en-US" altLang="ko-KR" sz="2000" dirty="0" smtClean="0">
+                <a:latin typeface="나눔스퀘어 Bold" panose="020B0600000101010101" pitchFamily="50" charset="-127"/>
+                <a:ea typeface="나눔스퀘어 Bold" panose="020B0600000101010101" pitchFamily="50" charset="-127"/>
+              </a:rPr>
+              <a:t>Context</a:t>
+            </a:r>
+          </a:p>
+          <a:p>
+            <a:pPr algn="ctr"/>
+            <a:r>
+              <a:rPr lang="en-US" altLang="ko-KR" sz="2000" dirty="0" smtClean="0">
+                <a:latin typeface="나눔스퀘어 Bold" panose="020B0600000101010101" pitchFamily="50" charset="-127"/>
+                <a:ea typeface="나눔스퀘어 Bold" panose="020B0600000101010101" pitchFamily="50" charset="-127"/>
+              </a:rPr>
+              <a:t>(</a:t>
+            </a:r>
+            <a:r>
+              <a:rPr lang="ko-KR" altLang="en-US" sz="2000" dirty="0" smtClean="0">
+                <a:latin typeface="나눔스퀘어 Bold" panose="020B0600000101010101" pitchFamily="50" charset="-127"/>
+                <a:ea typeface="나눔스퀘어 Bold" panose="020B0600000101010101" pitchFamily="50" charset="-127"/>
+              </a:rPr>
+              <a:t>영속성 컨텍스트</a:t>
+            </a:r>
+            <a:r>
+              <a:rPr lang="en-US" altLang="ko-KR" sz="2000" dirty="0" smtClean="0">
+                <a:latin typeface="나눔스퀘어 Bold" panose="020B0600000101010101" pitchFamily="50" charset="-127"/>
+                <a:ea typeface="나눔스퀘어 Bold" panose="020B0600000101010101" pitchFamily="50" charset="-127"/>
+              </a:rPr>
+              <a:t>)</a:t>
+            </a:r>
+          </a:p>
+          <a:p>
+            <a:pPr algn="ctr"/>
+            <a:endParaRPr lang="en-US" altLang="ko-KR" sz="2000" dirty="0" smtClean="0">
               <a:latin typeface="나눔스퀘어 Bold" panose="020B0600000101010101" pitchFamily="50" charset="-127"/>
               <a:ea typeface="나눔스퀘어 Bold" panose="020B0600000101010101" pitchFamily="50" charset="-127"/>
             </a:endParaRPr>
           </a:p>
           <a:p>
             <a:pPr algn="ctr"/>
-            <a:r>
-              <a:rPr lang="en-US" altLang="ko-KR" sz="2400" dirty="0" smtClean="0">
-                <a:latin typeface="나눔스퀘어 Bold" panose="020B0600000101010101" pitchFamily="50" charset="-127"/>
-                <a:ea typeface="나눔스퀘어 Bold" panose="020B0600000101010101" pitchFamily="50" charset="-127"/>
-              </a:rPr>
-              <a:t>(</a:t>
-            </a:r>
-            <a:r>
-              <a:rPr lang="ko-KR" altLang="en-US" sz="2400" dirty="0" smtClean="0">
-                <a:latin typeface="나눔스퀘어 Bold" panose="020B0600000101010101" pitchFamily="50" charset="-127"/>
-                <a:ea typeface="나눔스퀘어 Bold" panose="020B0600000101010101" pitchFamily="50" charset="-127"/>
-              </a:rPr>
-              <a:t>하드웨어</a:t>
-            </a:r>
-            <a:r>
-              <a:rPr lang="en-US" altLang="ko-KR" sz="2400" dirty="0" smtClean="0">
-                <a:latin typeface="나눔스퀘어 Bold" panose="020B0600000101010101" pitchFamily="50" charset="-127"/>
-                <a:ea typeface="나눔스퀘어 Bold" panose="020B0600000101010101" pitchFamily="50" charset="-127"/>
-              </a:rPr>
-              <a:t>)</a:t>
-            </a:r>
-            <a:endParaRPr lang="ko-KR" altLang="en-US" sz="2400" dirty="0">
+            <a:endParaRPr lang="en-US" altLang="ko-KR" sz="2000" dirty="0">
               <a:latin typeface="나눔스퀘어 Bold" panose="020B0600000101010101" pitchFamily="50" charset="-127"/>
               <a:ea typeface="나눔스퀘어 Bold" panose="020B0600000101010101" pitchFamily="50" charset="-127"/>
             </a:endParaRPr>
           </a:p>
-        </p:txBody>
-      </p:sp>
-      <p:sp>
-        <p:nvSpPr>
-          <p:cNvPr id="14" name="직사각형 13"/>
-          <p:cNvSpPr/>
-          <p:nvPr/>
-        </p:nvSpPr>
-        <p:spPr>
-          <a:xfrm>
-            <a:off x="1069913" y="2362200"/>
-            <a:ext cx="2700000" cy="1080000"/>
-          </a:xfrm>
-          <a:prstGeom prst="rect">
-            <a:avLst/>
-          </a:prstGeom>
-          <a:solidFill>
-            <a:schemeClr val="accent5"/>
-          </a:solidFill>
-          <a:ln>
-            <a:noFill/>
-          </a:ln>
-        </p:spPr>
-        <p:style>
-          <a:lnRef idx="2">
-            <a:schemeClr val="accent1">
-              <a:shade val="50000"/>
-            </a:schemeClr>
-          </a:lnRef>
-          <a:fillRef idx="1">
-            <a:schemeClr val="accent1"/>
-          </a:fillRef>
-          <a:effectRef idx="0">
-            <a:schemeClr val="accent1"/>
-          </a:effectRef>
-          <a:fontRef idx="minor">
-            <a:schemeClr val="lt1"/>
-          </a:fontRef>
-        </p:style>
-        <p:txBody>
-          <a:bodyPr rtlCol="0" anchor="ctr"/>
-          <a:lstStyle/>
-          <a:p>
-            <a:pPr algn="ctr"/>
-            <a:r>
-              <a:rPr lang="ko-KR" altLang="en-US" sz="2800" dirty="0" smtClean="0">
-                <a:latin typeface="나눔스퀘어 Bold" panose="020B0600000101010101" pitchFamily="50" charset="-127"/>
-                <a:ea typeface="나눔스퀘어 Bold" panose="020B0600000101010101" pitchFamily="50" charset="-127"/>
-              </a:rPr>
-              <a:t>윈도우</a:t>
-            </a:r>
-            <a:r>
-              <a:rPr lang="en-US" altLang="ko-KR" sz="2800" dirty="0" smtClean="0">
-                <a:latin typeface="나눔스퀘어 Bold" panose="020B0600000101010101" pitchFamily="50" charset="-127"/>
-                <a:ea typeface="나눔스퀘어 Bold" panose="020B0600000101010101" pitchFamily="50" charset="-127"/>
-              </a:rPr>
-              <a:t/>
-            </a:r>
-            <a:br>
-              <a:rPr lang="en-US" altLang="ko-KR" sz="2800" dirty="0" smtClean="0">
-                <a:latin typeface="나눔스퀘어 Bold" panose="020B0600000101010101" pitchFamily="50" charset="-127"/>
-                <a:ea typeface="나눔스퀘어 Bold" panose="020B0600000101010101" pitchFamily="50" charset="-127"/>
-              </a:rPr>
-            </a:br>
-            <a:r>
-              <a:rPr lang="en-US" altLang="ko-KR" sz="2400" dirty="0" smtClean="0">
-                <a:latin typeface="나눔스퀘어 Bold" panose="020B0600000101010101" pitchFamily="50" charset="-127"/>
-                <a:ea typeface="나눔스퀘어 Bold" panose="020B0600000101010101" pitchFamily="50" charset="-127"/>
-              </a:rPr>
-              <a:t>(</a:t>
-            </a:r>
-            <a:r>
-              <a:rPr lang="ko-KR" altLang="en-US" sz="2400" dirty="0" smtClean="0">
-                <a:latin typeface="나눔스퀘어 Bold" panose="020B0600000101010101" pitchFamily="50" charset="-127"/>
-                <a:ea typeface="나눔스퀘어 Bold" panose="020B0600000101010101" pitchFamily="50" charset="-127"/>
-              </a:rPr>
-              <a:t>그대로</a:t>
-            </a:r>
-            <a:r>
-              <a:rPr lang="en-US" altLang="ko-KR" sz="2400" dirty="0" smtClean="0">
-                <a:latin typeface="나눔스퀘어 Bold" panose="020B0600000101010101" pitchFamily="50" charset="-127"/>
-                <a:ea typeface="나눔스퀘어 Bold" panose="020B0600000101010101" pitchFamily="50" charset="-127"/>
-              </a:rPr>
-              <a:t>)</a:t>
-            </a:r>
-            <a:endParaRPr lang="ko-KR" altLang="en-US" sz="2800" dirty="0">
+          <a:p>
+            <a:pPr algn="ctr"/>
+            <a:endParaRPr lang="en-US" altLang="ko-KR" sz="2000" dirty="0" smtClean="0">
               <a:latin typeface="나눔스퀘어 Bold" panose="020B0600000101010101" pitchFamily="50" charset="-127"/>
               <a:ea typeface="나눔스퀘어 Bold" panose="020B0600000101010101" pitchFamily="50" charset="-127"/>
             </a:endParaRPr>
           </a:p>
+          <a:p>
+            <a:pPr algn="ctr"/>
+            <a:endParaRPr lang="en-US" altLang="ko-KR" sz="2000" dirty="0">
+              <a:latin typeface="나눔스퀘어 Bold" panose="020B0600000101010101" pitchFamily="50" charset="-127"/>
+              <a:ea typeface="나눔스퀘어 Bold" panose="020B0600000101010101" pitchFamily="50" charset="-127"/>
+            </a:endParaRPr>
+          </a:p>
         </p:txBody>
       </p:sp>
       <p:cxnSp>
         <p:nvCxnSpPr>
-          <p:cNvPr id="9" name="직선 화살표 연결선 8"/>
+          <p:cNvPr id="8" name="직선 화살표 연결선 7"/>
           <p:cNvCxnSpPr>
             <a:stCxn id="13" idx="3"/>
             <a:endCxn id="14" idx="1"/>
@@ -3323,8 +3205,8 @@
         </p:nvCxnSpPr>
         <p:spPr>
           <a:xfrm>
-            <a:off x="-37349" y="2902200"/>
-            <a:ext cx="1107262" cy="0"/>
+            <a:off x="2193957" y="1799114"/>
+            <a:ext cx="1680013" cy="0"/>
           </a:xfrm>
           <a:prstGeom prst="straightConnector1">
             <a:avLst/>
@@ -3333,6 +3215,7 @@
             <a:solidFill>
               <a:schemeClr val="accent2"/>
             </a:solidFill>
+            <a:headEnd type="triangle"/>
             <a:tailEnd type="triangle"/>
           </a:ln>
         </p:spPr>
@@ -3353,7 +3236,7 @@
       </p:cxnSp>
       <p:cxnSp>
         <p:nvCxnSpPr>
-          <p:cNvPr id="21" name="직선 화살표 연결선 20"/>
+          <p:cNvPr id="18" name="직선 화살표 연결선 17"/>
           <p:cNvCxnSpPr>
             <a:stCxn id="14" idx="3"/>
             <a:endCxn id="4" idx="1"/>
@@ -3362,8 +3245,8 @@
         </p:nvCxnSpPr>
         <p:spPr>
           <a:xfrm>
-            <a:off x="3769913" y="2902200"/>
-            <a:ext cx="1107262" cy="0"/>
+            <a:off x="8193970" y="1799114"/>
+            <a:ext cx="1680013" cy="0"/>
           </a:xfrm>
           <a:prstGeom prst="straightConnector1">
             <a:avLst/>
@@ -3372,6 +3255,7 @@
             <a:solidFill>
               <a:schemeClr val="accent2"/>
             </a:solidFill>
+            <a:headEnd type="triangle"/>
             <a:tailEnd type="triangle"/>
           </a:ln>
         </p:spPr>
@@ -3390,45 +3274,308 @@
           </a:fontRef>
         </p:style>
       </p:cxnSp>
-      <p:cxnSp>
-        <p:nvCxnSpPr>
-          <p:cNvPr id="25" name="직선 화살표 연결선 24"/>
-          <p:cNvCxnSpPr>
-            <a:stCxn id="4" idx="3"/>
-            <a:endCxn id="20" idx="1"/>
-          </p:cNvCxnSpPr>
-          <p:nvPr/>
-        </p:nvCxnSpPr>
-        <p:spPr>
-          <a:xfrm>
-            <a:off x="7577175" y="2902200"/>
-            <a:ext cx="1107262" cy="0"/>
-          </a:xfrm>
-          <a:prstGeom prst="straightConnector1">
-            <a:avLst/>
-          </a:prstGeom>
-          <a:ln w="76200">
-            <a:solidFill>
-              <a:schemeClr val="accent2"/>
-            </a:solidFill>
-            <a:tailEnd type="triangle"/>
+      <p:sp>
+        <p:nvSpPr>
+          <p:cNvPr id="22" name="모서리가 둥근 직사각형 21"/>
+          <p:cNvSpPr/>
+          <p:nvPr/>
+        </p:nvSpPr>
+        <p:spPr>
+          <a:xfrm>
+            <a:off x="4143970" y="1610436"/>
+            <a:ext cx="3780000" cy="1080000"/>
+          </a:xfrm>
+          <a:prstGeom prst="roundRect">
+            <a:avLst/>
+          </a:prstGeom>
+          <a:solidFill>
+            <a:schemeClr val="bg1"/>
+          </a:solidFill>
+          <a:ln>
+            <a:noFill/>
           </a:ln>
         </p:spPr>
         <p:style>
-          <a:lnRef idx="1">
-            <a:schemeClr val="accent1"/>
+          <a:lnRef idx="2">
+            <a:schemeClr val="accent1">
+              <a:shade val="50000"/>
+            </a:schemeClr>
           </a:lnRef>
-          <a:fillRef idx="0">
+          <a:fillRef idx="1">
             <a:schemeClr val="accent1"/>
           </a:fillRef>
           <a:effectRef idx="0">
             <a:schemeClr val="accent1"/>
           </a:effectRef>
           <a:fontRef idx="minor">
-            <a:schemeClr val="tx1"/>
+            <a:schemeClr val="lt1"/>
           </a:fontRef>
         </p:style>
-      </p:cxnSp>
+        <p:txBody>
+          <a:bodyPr rtlCol="0" anchor="ctr"/>
+          <a:lstStyle/>
+          <a:p>
+            <a:pPr algn="ctr"/>
+            <a:r>
+              <a:rPr lang="en-US" altLang="ko-KR" dirty="0" smtClean="0">
+                <a:solidFill>
+                  <a:schemeClr val="tx1"/>
+                </a:solidFill>
+                <a:latin typeface="나눔스퀘어 Bold" panose="020B0600000101010101" pitchFamily="50" charset="-127"/>
+                <a:ea typeface="나눔스퀘어 Bold" panose="020B0600000101010101" pitchFamily="50" charset="-127"/>
+              </a:rPr>
+              <a:t>1</a:t>
+            </a:r>
+            <a:r>
+              <a:rPr lang="ko-KR" altLang="en-US" dirty="0" smtClean="0">
+                <a:solidFill>
+                  <a:schemeClr val="tx1"/>
+                </a:solidFill>
+                <a:latin typeface="나눔스퀘어 Bold" panose="020B0600000101010101" pitchFamily="50" charset="-127"/>
+                <a:ea typeface="나눔스퀘어 Bold" panose="020B0600000101010101" pitchFamily="50" charset="-127"/>
+              </a:rPr>
+              <a:t>차 캐시</a:t>
+            </a:r>
+            <a:endParaRPr lang="en-US" altLang="ko-KR" dirty="0" smtClean="0">
+              <a:solidFill>
+                <a:schemeClr val="tx1"/>
+              </a:solidFill>
+              <a:latin typeface="나눔스퀘어 Bold" panose="020B0600000101010101" pitchFamily="50" charset="-127"/>
+              <a:ea typeface="나눔스퀘어 Bold" panose="020B0600000101010101" pitchFamily="50" charset="-127"/>
+            </a:endParaRPr>
+          </a:p>
+          <a:p>
+            <a:pPr algn="ctr"/>
+            <a:endParaRPr lang="en-US" altLang="ko-KR" dirty="0">
+              <a:solidFill>
+                <a:schemeClr val="tx1"/>
+              </a:solidFill>
+              <a:latin typeface="나눔스퀘어 Bold" panose="020B0600000101010101" pitchFamily="50" charset="-127"/>
+              <a:ea typeface="나눔스퀘어 Bold" panose="020B0600000101010101" pitchFamily="50" charset="-127"/>
+            </a:endParaRPr>
+          </a:p>
+          <a:p>
+            <a:pPr algn="ctr"/>
+            <a:endParaRPr lang="ko-KR" altLang="en-US" dirty="0">
+              <a:solidFill>
+                <a:schemeClr val="tx1"/>
+              </a:solidFill>
+              <a:latin typeface="나눔스퀘어 Bold" panose="020B0600000101010101" pitchFamily="50" charset="-127"/>
+              <a:ea typeface="나눔스퀘어 Bold" panose="020B0600000101010101" pitchFamily="50" charset="-127"/>
+            </a:endParaRPr>
+          </a:p>
+        </p:txBody>
+      </p:sp>
+      <p:sp>
+        <p:nvSpPr>
+          <p:cNvPr id="24" name="모서리가 둥근 직사각형 23"/>
+          <p:cNvSpPr/>
+          <p:nvPr/>
+        </p:nvSpPr>
+        <p:spPr>
+          <a:xfrm>
+            <a:off x="4278970" y="2062639"/>
+            <a:ext cx="1080000" cy="540000"/>
+          </a:xfrm>
+          <a:prstGeom prst="roundRect">
+            <a:avLst/>
+          </a:prstGeom>
+          <a:solidFill>
+            <a:schemeClr val="accent5"/>
+          </a:solidFill>
+          <a:ln>
+            <a:noFill/>
+          </a:ln>
+        </p:spPr>
+        <p:style>
+          <a:lnRef idx="2">
+            <a:schemeClr val="accent1">
+              <a:shade val="50000"/>
+            </a:schemeClr>
+          </a:lnRef>
+          <a:fillRef idx="1">
+            <a:schemeClr val="accent1"/>
+          </a:fillRef>
+          <a:effectRef idx="0">
+            <a:schemeClr val="accent1"/>
+          </a:effectRef>
+          <a:fontRef idx="minor">
+            <a:schemeClr val="lt1"/>
+          </a:fontRef>
+        </p:style>
+        <p:txBody>
+          <a:bodyPr rtlCol="0" anchor="ctr"/>
+          <a:lstStyle/>
+          <a:p>
+            <a:pPr algn="ctr"/>
+            <a:r>
+              <a:rPr lang="en-US" altLang="ko-KR">
+                <a:latin typeface="나눔스퀘어 Bold" panose="020B0600000101010101" pitchFamily="50" charset="-127"/>
+                <a:ea typeface="나눔스퀘어 Bold" panose="020B0600000101010101" pitchFamily="50" charset="-127"/>
+              </a:rPr>
+              <a:t>Entity </a:t>
+            </a:r>
+            <a:r>
+              <a:rPr lang="ko-KR" altLang="en-US">
+                <a:latin typeface="나눔스퀘어 Bold" panose="020B0600000101010101" pitchFamily="50" charset="-127"/>
+                <a:ea typeface="나눔스퀘어 Bold" panose="020B0600000101010101" pitchFamily="50" charset="-127"/>
+              </a:rPr>
+              <a:t>객체</a:t>
+            </a:r>
+            <a:r>
+              <a:rPr lang="en-US" altLang="ko-KR">
+                <a:latin typeface="나눔스퀘어 Bold" panose="020B0600000101010101" pitchFamily="50" charset="-127"/>
+                <a:ea typeface="나눔스퀘어 Bold" panose="020B0600000101010101" pitchFamily="50" charset="-127"/>
+              </a:rPr>
+              <a:t>1</a:t>
+            </a:r>
+            <a:endParaRPr lang="ko-KR" altLang="en-US">
+              <a:latin typeface="나눔스퀘어 Bold" panose="020B0600000101010101" pitchFamily="50" charset="-127"/>
+              <a:ea typeface="나눔스퀘어 Bold" panose="020B0600000101010101" pitchFamily="50" charset="-127"/>
+            </a:endParaRPr>
+          </a:p>
+        </p:txBody>
+      </p:sp>
+      <p:sp>
+        <p:nvSpPr>
+          <p:cNvPr id="25" name="모서리가 둥근 직사각형 24"/>
+          <p:cNvSpPr/>
+          <p:nvPr/>
+        </p:nvSpPr>
+        <p:spPr>
+          <a:xfrm>
+            <a:off x="5493970" y="2069114"/>
+            <a:ext cx="1080000" cy="540000"/>
+          </a:xfrm>
+          <a:prstGeom prst="roundRect">
+            <a:avLst/>
+          </a:prstGeom>
+          <a:solidFill>
+            <a:schemeClr val="accent5"/>
+          </a:solidFill>
+          <a:ln>
+            <a:noFill/>
+          </a:ln>
+        </p:spPr>
+        <p:style>
+          <a:lnRef idx="2">
+            <a:schemeClr val="accent1">
+              <a:shade val="50000"/>
+            </a:schemeClr>
+          </a:lnRef>
+          <a:fillRef idx="1">
+            <a:schemeClr val="accent1"/>
+          </a:fillRef>
+          <a:effectRef idx="0">
+            <a:schemeClr val="accent1"/>
+          </a:effectRef>
+          <a:fontRef idx="minor">
+            <a:schemeClr val="lt1"/>
+          </a:fontRef>
+        </p:style>
+        <p:txBody>
+          <a:bodyPr rtlCol="0" anchor="ctr"/>
+          <a:lstStyle/>
+          <a:p>
+            <a:pPr algn="ctr"/>
+            <a:r>
+              <a:rPr lang="en-US" altLang="ko-KR" dirty="0">
+                <a:latin typeface="나눔스퀘어 Bold" panose="020B0600000101010101" pitchFamily="50" charset="-127"/>
+                <a:ea typeface="나눔스퀘어 Bold" panose="020B0600000101010101" pitchFamily="50" charset="-127"/>
+              </a:rPr>
+              <a:t>Entity </a:t>
+            </a:r>
+            <a:r>
+              <a:rPr lang="ko-KR" altLang="en-US" dirty="0" smtClean="0">
+                <a:latin typeface="나눔스퀘어 Bold" panose="020B0600000101010101" pitchFamily="50" charset="-127"/>
+                <a:ea typeface="나눔스퀘어 Bold" panose="020B0600000101010101" pitchFamily="50" charset="-127"/>
+              </a:rPr>
+              <a:t>객체</a:t>
+            </a:r>
+            <a:r>
+              <a:rPr lang="en-US" altLang="ko-KR" dirty="0" smtClean="0">
+                <a:latin typeface="나눔스퀘어 Bold" panose="020B0600000101010101" pitchFamily="50" charset="-127"/>
+                <a:ea typeface="나눔스퀘어 Bold" panose="020B0600000101010101" pitchFamily="50" charset="-127"/>
+              </a:rPr>
+              <a:t>2</a:t>
+            </a:r>
+            <a:endParaRPr lang="ko-KR" altLang="en-US" dirty="0">
+              <a:latin typeface="나눔스퀘어 Bold" panose="020B0600000101010101" pitchFamily="50" charset="-127"/>
+              <a:ea typeface="나눔스퀘어 Bold" panose="020B0600000101010101" pitchFamily="50" charset="-127"/>
+            </a:endParaRPr>
+          </a:p>
+        </p:txBody>
+      </p:sp>
+      <p:sp>
+        <p:nvSpPr>
+          <p:cNvPr id="26" name="모서리가 둥근 직사각형 25"/>
+          <p:cNvSpPr/>
+          <p:nvPr/>
+        </p:nvSpPr>
+        <p:spPr>
+          <a:xfrm>
+            <a:off x="6710448" y="2062639"/>
+            <a:ext cx="1080000" cy="540000"/>
+          </a:xfrm>
+          <a:prstGeom prst="roundRect">
+            <a:avLst/>
+          </a:prstGeom>
+          <a:solidFill>
+            <a:schemeClr val="accent5"/>
+          </a:solidFill>
+          <a:ln>
+            <a:noFill/>
+          </a:ln>
+        </p:spPr>
+        <p:style>
+          <a:lnRef idx="2">
+            <a:schemeClr val="accent1">
+              <a:shade val="50000"/>
+            </a:schemeClr>
+          </a:lnRef>
+          <a:fillRef idx="1">
+            <a:schemeClr val="accent1"/>
+          </a:fillRef>
+          <a:effectRef idx="0">
+            <a:schemeClr val="accent1"/>
+          </a:effectRef>
+          <a:fontRef idx="minor">
+            <a:schemeClr val="lt1"/>
+          </a:fontRef>
+        </p:style>
+        <p:txBody>
+          <a:bodyPr rtlCol="0" anchor="ctr"/>
+          <a:lstStyle/>
+          <a:p>
+            <a:pPr algn="ctr"/>
+            <a:r>
+              <a:rPr lang="en-US" altLang="ko-KR" dirty="0">
+                <a:latin typeface="나눔스퀘어 Bold" panose="020B0600000101010101" pitchFamily="50" charset="-127"/>
+                <a:ea typeface="나눔스퀘어 Bold" panose="020B0600000101010101" pitchFamily="50" charset="-127"/>
+              </a:rPr>
+              <a:t>Entity </a:t>
+            </a:r>
+            <a:r>
+              <a:rPr lang="ko-KR" altLang="en-US" dirty="0" smtClean="0">
+                <a:latin typeface="나눔스퀘어 Bold" panose="020B0600000101010101" pitchFamily="50" charset="-127"/>
+                <a:ea typeface="나눔스퀘어 Bold" panose="020B0600000101010101" pitchFamily="50" charset="-127"/>
+              </a:rPr>
+              <a:t>객체</a:t>
+            </a:r>
+            <a:r>
+              <a:rPr lang="en-US" altLang="ko-KR" dirty="0" smtClean="0">
+                <a:latin typeface="나눔스퀘어 Bold" panose="020B0600000101010101" pitchFamily="50" charset="-127"/>
+                <a:ea typeface="나눔스퀘어 Bold" panose="020B0600000101010101" pitchFamily="50" charset="-127"/>
+              </a:rPr>
+              <a:t>3</a:t>
+            </a:r>
+            <a:endParaRPr lang="ko-KR" altLang="en-US" dirty="0">
+              <a:latin typeface="나눔스퀘어 Bold" panose="020B0600000101010101" pitchFamily="50" charset="-127"/>
+              <a:ea typeface="나눔스퀘어 Bold" panose="020B0600000101010101" pitchFamily="50" charset="-127"/>
+            </a:endParaRPr>
+          </a:p>
+        </p:txBody>
+      </p:sp>
     </p:spTree>
     <p:extLst>
       <p:ext uri="{BB962C8B-B14F-4D97-AF65-F5344CB8AC3E}">

</xml_diff>

<commit_message>
20260917 commit : 5, 6_class
</commit_message>
<xml_diff>
--- a/notion/create_notion_img.pptx
+++ b/notion/create_notion_img.pptx
@@ -245,7 +245,7 @@
           <a:p>
             <a:fld id="{7237CE1A-8831-48B5-BA93-72483C6E34E8}" type="datetimeFigureOut">
               <a:rPr lang="ko-KR" altLang="en-US" smtClean="0"/>
-              <a:t>2026-09-16</a:t>
+              <a:t>2026-09-17</a:t>
             </a:fld>
             <a:endParaRPr lang="ko-KR" altLang="en-US"/>
           </a:p>
@@ -415,7 +415,7 @@
           <a:p>
             <a:fld id="{7237CE1A-8831-48B5-BA93-72483C6E34E8}" type="datetimeFigureOut">
               <a:rPr lang="ko-KR" altLang="en-US" smtClean="0"/>
-              <a:t>2026-09-16</a:t>
+              <a:t>2026-09-17</a:t>
             </a:fld>
             <a:endParaRPr lang="ko-KR" altLang="en-US"/>
           </a:p>
@@ -595,7 +595,7 @@
           <a:p>
             <a:fld id="{7237CE1A-8831-48B5-BA93-72483C6E34E8}" type="datetimeFigureOut">
               <a:rPr lang="ko-KR" altLang="en-US" smtClean="0"/>
-              <a:t>2026-09-16</a:t>
+              <a:t>2026-09-17</a:t>
             </a:fld>
             <a:endParaRPr lang="ko-KR" altLang="en-US"/>
           </a:p>
@@ -765,7 +765,7 @@
           <a:p>
             <a:fld id="{7237CE1A-8831-48B5-BA93-72483C6E34E8}" type="datetimeFigureOut">
               <a:rPr lang="ko-KR" altLang="en-US" smtClean="0"/>
-              <a:t>2026-09-16</a:t>
+              <a:t>2026-09-17</a:t>
             </a:fld>
             <a:endParaRPr lang="ko-KR" altLang="en-US"/>
           </a:p>
@@ -1011,7 +1011,7 @@
           <a:p>
             <a:fld id="{7237CE1A-8831-48B5-BA93-72483C6E34E8}" type="datetimeFigureOut">
               <a:rPr lang="ko-KR" altLang="en-US" smtClean="0"/>
-              <a:t>2026-09-16</a:t>
+              <a:t>2026-09-17</a:t>
             </a:fld>
             <a:endParaRPr lang="ko-KR" altLang="en-US"/>
           </a:p>
@@ -1243,7 +1243,7 @@
           <a:p>
             <a:fld id="{7237CE1A-8831-48B5-BA93-72483C6E34E8}" type="datetimeFigureOut">
               <a:rPr lang="ko-KR" altLang="en-US" smtClean="0"/>
-              <a:t>2026-09-16</a:t>
+              <a:t>2026-09-17</a:t>
             </a:fld>
             <a:endParaRPr lang="ko-KR" altLang="en-US"/>
           </a:p>
@@ -1610,7 +1610,7 @@
           <a:p>
             <a:fld id="{7237CE1A-8831-48B5-BA93-72483C6E34E8}" type="datetimeFigureOut">
               <a:rPr lang="ko-KR" altLang="en-US" smtClean="0"/>
-              <a:t>2026-09-16</a:t>
+              <a:t>2026-09-17</a:t>
             </a:fld>
             <a:endParaRPr lang="ko-KR" altLang="en-US"/>
           </a:p>
@@ -1728,7 +1728,7 @@
           <a:p>
             <a:fld id="{7237CE1A-8831-48B5-BA93-72483C6E34E8}" type="datetimeFigureOut">
               <a:rPr lang="ko-KR" altLang="en-US" smtClean="0"/>
-              <a:t>2026-09-16</a:t>
+              <a:t>2026-09-17</a:t>
             </a:fld>
             <a:endParaRPr lang="ko-KR" altLang="en-US"/>
           </a:p>
@@ -1823,7 +1823,7 @@
           <a:p>
             <a:fld id="{7237CE1A-8831-48B5-BA93-72483C6E34E8}" type="datetimeFigureOut">
               <a:rPr lang="ko-KR" altLang="en-US" smtClean="0"/>
-              <a:t>2026-09-16</a:t>
+              <a:t>2026-09-17</a:t>
             </a:fld>
             <a:endParaRPr lang="ko-KR" altLang="en-US"/>
           </a:p>
@@ -2100,7 +2100,7 @@
           <a:p>
             <a:fld id="{7237CE1A-8831-48B5-BA93-72483C6E34E8}" type="datetimeFigureOut">
               <a:rPr lang="ko-KR" altLang="en-US" smtClean="0"/>
-              <a:t>2026-09-16</a:t>
+              <a:t>2026-09-17</a:t>
             </a:fld>
             <a:endParaRPr lang="ko-KR" altLang="en-US"/>
           </a:p>
@@ -2353,7 +2353,7 @@
           <a:p>
             <a:fld id="{7237CE1A-8831-48B5-BA93-72483C6E34E8}" type="datetimeFigureOut">
               <a:rPr lang="ko-KR" altLang="en-US" smtClean="0"/>
-              <a:t>2026-09-16</a:t>
+              <a:t>2026-09-17</a:t>
             </a:fld>
             <a:endParaRPr lang="ko-KR" altLang="en-US"/>
           </a:p>
@@ -2566,7 +2566,7 @@
           <a:p>
             <a:fld id="{7237CE1A-8831-48B5-BA93-72483C6E34E8}" type="datetimeFigureOut">
               <a:rPr lang="ko-KR" altLang="en-US" smtClean="0"/>
-              <a:t>2026-09-16</a:t>
+              <a:t>2026-09-17</a:t>
             </a:fld>
             <a:endParaRPr lang="ko-KR" altLang="en-US"/>
           </a:p>
@@ -2971,611 +2971,6 @@
           <a:chExt cx="0" cy="0"/>
         </a:xfrm>
       </p:grpSpPr>
-      <p:sp>
-        <p:nvSpPr>
-          <p:cNvPr id="4" name="직사각형 3"/>
-          <p:cNvSpPr/>
-          <p:nvPr/>
-        </p:nvSpPr>
-        <p:spPr>
-          <a:xfrm>
-            <a:off x="9873983" y="1259114"/>
-            <a:ext cx="2700000" cy="1080000"/>
-          </a:xfrm>
-          <a:prstGeom prst="rect">
-            <a:avLst/>
-          </a:prstGeom>
-          <a:solidFill>
-            <a:schemeClr val="accent5"/>
-          </a:solidFill>
-          <a:ln>
-            <a:noFill/>
-          </a:ln>
-        </p:spPr>
-        <p:style>
-          <a:lnRef idx="2">
-            <a:schemeClr val="accent1">
-              <a:shade val="50000"/>
-            </a:schemeClr>
-          </a:lnRef>
-          <a:fillRef idx="1">
-            <a:schemeClr val="accent1"/>
-          </a:fillRef>
-          <a:effectRef idx="0">
-            <a:schemeClr val="accent1"/>
-          </a:effectRef>
-          <a:fontRef idx="minor">
-            <a:schemeClr val="lt1"/>
-          </a:fontRef>
-        </p:style>
-        <p:txBody>
-          <a:bodyPr rtlCol="0" anchor="ctr"/>
-          <a:lstStyle/>
-          <a:p>
-            <a:pPr algn="ctr"/>
-            <a:r>
-              <a:rPr lang="en-US" altLang="ko-KR" sz="3200" dirty="0">
-                <a:latin typeface="나눔스퀘어 Bold" panose="020B0600000101010101" pitchFamily="50" charset="-127"/>
-                <a:ea typeface="나눔스퀘어 Bold" panose="020B0600000101010101" pitchFamily="50" charset="-127"/>
-              </a:rPr>
-              <a:t>Database</a:t>
-            </a:r>
-            <a:endParaRPr lang="ko-KR" altLang="en-US" sz="2800" dirty="0">
-              <a:latin typeface="나눔스퀘어 Bold" panose="020B0600000101010101" pitchFamily="50" charset="-127"/>
-              <a:ea typeface="나눔스퀘어 Bold" panose="020B0600000101010101" pitchFamily="50" charset="-127"/>
-            </a:endParaRPr>
-          </a:p>
-        </p:txBody>
-      </p:sp>
-      <p:sp>
-        <p:nvSpPr>
-          <p:cNvPr id="13" name="직사각형 12"/>
-          <p:cNvSpPr/>
-          <p:nvPr/>
-        </p:nvSpPr>
-        <p:spPr>
-          <a:xfrm>
-            <a:off x="-506043" y="1259114"/>
-            <a:ext cx="2700000" cy="1080000"/>
-          </a:xfrm>
-          <a:prstGeom prst="rect">
-            <a:avLst/>
-          </a:prstGeom>
-          <a:solidFill>
-            <a:schemeClr val="accent5"/>
-          </a:solidFill>
-          <a:ln>
-            <a:noFill/>
-          </a:ln>
-        </p:spPr>
-        <p:style>
-          <a:lnRef idx="2">
-            <a:schemeClr val="accent1">
-              <a:shade val="50000"/>
-            </a:schemeClr>
-          </a:lnRef>
-          <a:fillRef idx="1">
-            <a:schemeClr val="accent1"/>
-          </a:fillRef>
-          <a:effectRef idx="0">
-            <a:schemeClr val="accent1"/>
-          </a:effectRef>
-          <a:fontRef idx="minor">
-            <a:schemeClr val="lt1"/>
-          </a:fontRef>
-        </p:style>
-        <p:txBody>
-          <a:bodyPr rtlCol="0" anchor="ctr"/>
-          <a:lstStyle/>
-          <a:p>
-            <a:pPr algn="ctr"/>
-            <a:r>
-              <a:rPr lang="en-US" altLang="ko-KR" sz="3200" dirty="0" smtClean="0">
-                <a:latin typeface="나눔스퀘어 Bold" panose="020B0600000101010101" pitchFamily="50" charset="-127"/>
-                <a:ea typeface="나눔스퀘어 Bold" panose="020B0600000101010101" pitchFamily="50" charset="-127"/>
-              </a:rPr>
-              <a:t>Application</a:t>
-            </a:r>
-            <a:endParaRPr lang="ko-KR" altLang="en-US" sz="2400" dirty="0">
-              <a:latin typeface="나눔스퀘어 Bold" panose="020B0600000101010101" pitchFamily="50" charset="-127"/>
-              <a:ea typeface="나눔스퀘어 Bold" panose="020B0600000101010101" pitchFamily="50" charset="-127"/>
-            </a:endParaRPr>
-          </a:p>
-        </p:txBody>
-      </p:sp>
-      <p:sp>
-        <p:nvSpPr>
-          <p:cNvPr id="14" name="직사각형 13"/>
-          <p:cNvSpPr/>
-          <p:nvPr/>
-        </p:nvSpPr>
-        <p:spPr>
-          <a:xfrm>
-            <a:off x="3873970" y="719114"/>
-            <a:ext cx="4320000" cy="2160000"/>
-          </a:xfrm>
-          <a:prstGeom prst="rect">
-            <a:avLst/>
-          </a:prstGeom>
-          <a:solidFill>
-            <a:schemeClr val="accent5"/>
-          </a:solidFill>
-          <a:ln>
-            <a:noFill/>
-          </a:ln>
-        </p:spPr>
-        <p:style>
-          <a:lnRef idx="2">
-            <a:schemeClr val="accent1">
-              <a:shade val="50000"/>
-            </a:schemeClr>
-          </a:lnRef>
-          <a:fillRef idx="1">
-            <a:schemeClr val="accent1"/>
-          </a:fillRef>
-          <a:effectRef idx="0">
-            <a:schemeClr val="accent1"/>
-          </a:effectRef>
-          <a:fontRef idx="minor">
-            <a:schemeClr val="lt1"/>
-          </a:fontRef>
-        </p:style>
-        <p:txBody>
-          <a:bodyPr rtlCol="0" anchor="ctr"/>
-          <a:lstStyle/>
-          <a:p>
-            <a:pPr algn="ctr"/>
-            <a:r>
-              <a:rPr lang="en-US" altLang="ko-KR" sz="2000" dirty="0">
-                <a:latin typeface="나눔스퀘어 Bold" panose="020B0600000101010101" pitchFamily="50" charset="-127"/>
-                <a:ea typeface="나눔스퀘어 Bold" panose="020B0600000101010101" pitchFamily="50" charset="-127"/>
-              </a:rPr>
-              <a:t>Persistence </a:t>
-            </a:r>
-            <a:r>
-              <a:rPr lang="en-US" altLang="ko-KR" sz="2000" dirty="0" smtClean="0">
-                <a:latin typeface="나눔스퀘어 Bold" panose="020B0600000101010101" pitchFamily="50" charset="-127"/>
-                <a:ea typeface="나눔스퀘어 Bold" panose="020B0600000101010101" pitchFamily="50" charset="-127"/>
-              </a:rPr>
-              <a:t>Context</a:t>
-            </a:r>
-          </a:p>
-          <a:p>
-            <a:pPr algn="ctr"/>
-            <a:r>
-              <a:rPr lang="en-US" altLang="ko-KR" sz="2000" dirty="0" smtClean="0">
-                <a:latin typeface="나눔스퀘어 Bold" panose="020B0600000101010101" pitchFamily="50" charset="-127"/>
-                <a:ea typeface="나눔스퀘어 Bold" panose="020B0600000101010101" pitchFamily="50" charset="-127"/>
-              </a:rPr>
-              <a:t>(</a:t>
-            </a:r>
-            <a:r>
-              <a:rPr lang="ko-KR" altLang="en-US" sz="2000" dirty="0" smtClean="0">
-                <a:latin typeface="나눔스퀘어 Bold" panose="020B0600000101010101" pitchFamily="50" charset="-127"/>
-                <a:ea typeface="나눔스퀘어 Bold" panose="020B0600000101010101" pitchFamily="50" charset="-127"/>
-              </a:rPr>
-              <a:t>영속성 컨텍스트</a:t>
-            </a:r>
-            <a:r>
-              <a:rPr lang="en-US" altLang="ko-KR" sz="2000" dirty="0" smtClean="0">
-                <a:latin typeface="나눔스퀘어 Bold" panose="020B0600000101010101" pitchFamily="50" charset="-127"/>
-                <a:ea typeface="나눔스퀘어 Bold" panose="020B0600000101010101" pitchFamily="50" charset="-127"/>
-              </a:rPr>
-              <a:t>)</a:t>
-            </a:r>
-          </a:p>
-          <a:p>
-            <a:pPr algn="ctr"/>
-            <a:endParaRPr lang="en-US" altLang="ko-KR" sz="2000" dirty="0" smtClean="0">
-              <a:latin typeface="나눔스퀘어 Bold" panose="020B0600000101010101" pitchFamily="50" charset="-127"/>
-              <a:ea typeface="나눔스퀘어 Bold" panose="020B0600000101010101" pitchFamily="50" charset="-127"/>
-            </a:endParaRPr>
-          </a:p>
-          <a:p>
-            <a:pPr algn="ctr"/>
-            <a:endParaRPr lang="en-US" altLang="ko-KR" sz="2000" dirty="0">
-              <a:latin typeface="나눔스퀘어 Bold" panose="020B0600000101010101" pitchFamily="50" charset="-127"/>
-              <a:ea typeface="나눔스퀘어 Bold" panose="020B0600000101010101" pitchFamily="50" charset="-127"/>
-            </a:endParaRPr>
-          </a:p>
-          <a:p>
-            <a:pPr algn="ctr"/>
-            <a:endParaRPr lang="en-US" altLang="ko-KR" sz="2000" dirty="0" smtClean="0">
-              <a:latin typeface="나눔스퀘어 Bold" panose="020B0600000101010101" pitchFamily="50" charset="-127"/>
-              <a:ea typeface="나눔스퀘어 Bold" panose="020B0600000101010101" pitchFamily="50" charset="-127"/>
-            </a:endParaRPr>
-          </a:p>
-          <a:p>
-            <a:pPr algn="ctr"/>
-            <a:endParaRPr lang="en-US" altLang="ko-KR" sz="2000" dirty="0">
-              <a:latin typeface="나눔스퀘어 Bold" panose="020B0600000101010101" pitchFamily="50" charset="-127"/>
-              <a:ea typeface="나눔스퀘어 Bold" panose="020B0600000101010101" pitchFamily="50" charset="-127"/>
-            </a:endParaRPr>
-          </a:p>
-        </p:txBody>
-      </p:sp>
-      <p:cxnSp>
-        <p:nvCxnSpPr>
-          <p:cNvPr id="8" name="직선 화살표 연결선 7"/>
-          <p:cNvCxnSpPr>
-            <a:stCxn id="13" idx="3"/>
-            <a:endCxn id="14" idx="1"/>
-          </p:cNvCxnSpPr>
-          <p:nvPr/>
-        </p:nvCxnSpPr>
-        <p:spPr>
-          <a:xfrm>
-            <a:off x="2193957" y="1799114"/>
-            <a:ext cx="1680013" cy="0"/>
-          </a:xfrm>
-          <a:prstGeom prst="straightConnector1">
-            <a:avLst/>
-          </a:prstGeom>
-          <a:ln w="76200">
-            <a:solidFill>
-              <a:schemeClr val="accent2"/>
-            </a:solidFill>
-            <a:headEnd type="triangle"/>
-            <a:tailEnd type="triangle"/>
-          </a:ln>
-        </p:spPr>
-        <p:style>
-          <a:lnRef idx="1">
-            <a:schemeClr val="accent1"/>
-          </a:lnRef>
-          <a:fillRef idx="0">
-            <a:schemeClr val="accent1"/>
-          </a:fillRef>
-          <a:effectRef idx="0">
-            <a:schemeClr val="accent1"/>
-          </a:effectRef>
-          <a:fontRef idx="minor">
-            <a:schemeClr val="tx1"/>
-          </a:fontRef>
-        </p:style>
-      </p:cxnSp>
-      <p:cxnSp>
-        <p:nvCxnSpPr>
-          <p:cNvPr id="18" name="직선 화살표 연결선 17"/>
-          <p:cNvCxnSpPr>
-            <a:stCxn id="14" idx="3"/>
-            <a:endCxn id="4" idx="1"/>
-          </p:cNvCxnSpPr>
-          <p:nvPr/>
-        </p:nvCxnSpPr>
-        <p:spPr>
-          <a:xfrm>
-            <a:off x="8193970" y="1799114"/>
-            <a:ext cx="1680013" cy="0"/>
-          </a:xfrm>
-          <a:prstGeom prst="straightConnector1">
-            <a:avLst/>
-          </a:prstGeom>
-          <a:ln w="76200">
-            <a:solidFill>
-              <a:schemeClr val="accent2"/>
-            </a:solidFill>
-            <a:headEnd type="triangle"/>
-            <a:tailEnd type="triangle"/>
-          </a:ln>
-        </p:spPr>
-        <p:style>
-          <a:lnRef idx="1">
-            <a:schemeClr val="accent1"/>
-          </a:lnRef>
-          <a:fillRef idx="0">
-            <a:schemeClr val="accent1"/>
-          </a:fillRef>
-          <a:effectRef idx="0">
-            <a:schemeClr val="accent1"/>
-          </a:effectRef>
-          <a:fontRef idx="minor">
-            <a:schemeClr val="tx1"/>
-          </a:fontRef>
-        </p:style>
-      </p:cxnSp>
-      <p:sp>
-        <p:nvSpPr>
-          <p:cNvPr id="22" name="모서리가 둥근 직사각형 21"/>
-          <p:cNvSpPr/>
-          <p:nvPr/>
-        </p:nvSpPr>
-        <p:spPr>
-          <a:xfrm>
-            <a:off x="4143970" y="1610436"/>
-            <a:ext cx="3780000" cy="1080000"/>
-          </a:xfrm>
-          <a:prstGeom prst="roundRect">
-            <a:avLst/>
-          </a:prstGeom>
-          <a:solidFill>
-            <a:schemeClr val="bg1"/>
-          </a:solidFill>
-          <a:ln>
-            <a:noFill/>
-          </a:ln>
-        </p:spPr>
-        <p:style>
-          <a:lnRef idx="2">
-            <a:schemeClr val="accent1">
-              <a:shade val="50000"/>
-            </a:schemeClr>
-          </a:lnRef>
-          <a:fillRef idx="1">
-            <a:schemeClr val="accent1"/>
-          </a:fillRef>
-          <a:effectRef idx="0">
-            <a:schemeClr val="accent1"/>
-          </a:effectRef>
-          <a:fontRef idx="minor">
-            <a:schemeClr val="lt1"/>
-          </a:fontRef>
-        </p:style>
-        <p:txBody>
-          <a:bodyPr rtlCol="0" anchor="ctr"/>
-          <a:lstStyle/>
-          <a:p>
-            <a:pPr algn="ctr"/>
-            <a:r>
-              <a:rPr lang="en-US" altLang="ko-KR" dirty="0" smtClean="0">
-                <a:solidFill>
-                  <a:schemeClr val="tx1"/>
-                </a:solidFill>
-                <a:latin typeface="나눔스퀘어 Bold" panose="020B0600000101010101" pitchFamily="50" charset="-127"/>
-                <a:ea typeface="나눔스퀘어 Bold" panose="020B0600000101010101" pitchFamily="50" charset="-127"/>
-              </a:rPr>
-              <a:t>1</a:t>
-            </a:r>
-            <a:r>
-              <a:rPr lang="ko-KR" altLang="en-US" dirty="0" smtClean="0">
-                <a:solidFill>
-                  <a:schemeClr val="tx1"/>
-                </a:solidFill>
-                <a:latin typeface="나눔스퀘어 Bold" panose="020B0600000101010101" pitchFamily="50" charset="-127"/>
-                <a:ea typeface="나눔스퀘어 Bold" panose="020B0600000101010101" pitchFamily="50" charset="-127"/>
-              </a:rPr>
-              <a:t>차 캐시</a:t>
-            </a:r>
-            <a:endParaRPr lang="en-US" altLang="ko-KR" dirty="0" smtClean="0">
-              <a:solidFill>
-                <a:schemeClr val="tx1"/>
-              </a:solidFill>
-              <a:latin typeface="나눔스퀘어 Bold" panose="020B0600000101010101" pitchFamily="50" charset="-127"/>
-              <a:ea typeface="나눔스퀘어 Bold" panose="020B0600000101010101" pitchFamily="50" charset="-127"/>
-            </a:endParaRPr>
-          </a:p>
-          <a:p>
-            <a:pPr algn="ctr"/>
-            <a:endParaRPr lang="en-US" altLang="ko-KR" dirty="0">
-              <a:solidFill>
-                <a:schemeClr val="tx1"/>
-              </a:solidFill>
-              <a:latin typeface="나눔스퀘어 Bold" panose="020B0600000101010101" pitchFamily="50" charset="-127"/>
-              <a:ea typeface="나눔스퀘어 Bold" panose="020B0600000101010101" pitchFamily="50" charset="-127"/>
-            </a:endParaRPr>
-          </a:p>
-          <a:p>
-            <a:pPr algn="ctr"/>
-            <a:endParaRPr lang="ko-KR" altLang="en-US" dirty="0">
-              <a:solidFill>
-                <a:schemeClr val="tx1"/>
-              </a:solidFill>
-              <a:latin typeface="나눔스퀘어 Bold" panose="020B0600000101010101" pitchFamily="50" charset="-127"/>
-              <a:ea typeface="나눔스퀘어 Bold" panose="020B0600000101010101" pitchFamily="50" charset="-127"/>
-            </a:endParaRPr>
-          </a:p>
-        </p:txBody>
-      </p:sp>
-      <p:sp>
-        <p:nvSpPr>
-          <p:cNvPr id="24" name="모서리가 둥근 직사각형 23"/>
-          <p:cNvSpPr/>
-          <p:nvPr/>
-        </p:nvSpPr>
-        <p:spPr>
-          <a:xfrm>
-            <a:off x="4278970" y="2062639"/>
-            <a:ext cx="1080000" cy="540000"/>
-          </a:xfrm>
-          <a:prstGeom prst="roundRect">
-            <a:avLst/>
-          </a:prstGeom>
-          <a:solidFill>
-            <a:schemeClr val="accent5"/>
-          </a:solidFill>
-          <a:ln>
-            <a:noFill/>
-          </a:ln>
-        </p:spPr>
-        <p:style>
-          <a:lnRef idx="2">
-            <a:schemeClr val="accent1">
-              <a:shade val="50000"/>
-            </a:schemeClr>
-          </a:lnRef>
-          <a:fillRef idx="1">
-            <a:schemeClr val="accent1"/>
-          </a:fillRef>
-          <a:effectRef idx="0">
-            <a:schemeClr val="accent1"/>
-          </a:effectRef>
-          <a:fontRef idx="minor">
-            <a:schemeClr val="lt1"/>
-          </a:fontRef>
-        </p:style>
-        <p:txBody>
-          <a:bodyPr rtlCol="0" anchor="ctr"/>
-          <a:lstStyle/>
-          <a:p>
-            <a:pPr algn="ctr"/>
-            <a:r>
-              <a:rPr lang="en-US" altLang="ko-KR">
-                <a:latin typeface="나눔스퀘어 Bold" panose="020B0600000101010101" pitchFamily="50" charset="-127"/>
-                <a:ea typeface="나눔스퀘어 Bold" panose="020B0600000101010101" pitchFamily="50" charset="-127"/>
-              </a:rPr>
-              <a:t>Entity </a:t>
-            </a:r>
-            <a:r>
-              <a:rPr lang="ko-KR" altLang="en-US">
-                <a:latin typeface="나눔스퀘어 Bold" panose="020B0600000101010101" pitchFamily="50" charset="-127"/>
-                <a:ea typeface="나눔스퀘어 Bold" panose="020B0600000101010101" pitchFamily="50" charset="-127"/>
-              </a:rPr>
-              <a:t>객체</a:t>
-            </a:r>
-            <a:r>
-              <a:rPr lang="en-US" altLang="ko-KR">
-                <a:latin typeface="나눔스퀘어 Bold" panose="020B0600000101010101" pitchFamily="50" charset="-127"/>
-                <a:ea typeface="나눔스퀘어 Bold" panose="020B0600000101010101" pitchFamily="50" charset="-127"/>
-              </a:rPr>
-              <a:t>1</a:t>
-            </a:r>
-            <a:endParaRPr lang="ko-KR" altLang="en-US">
-              <a:latin typeface="나눔스퀘어 Bold" panose="020B0600000101010101" pitchFamily="50" charset="-127"/>
-              <a:ea typeface="나눔스퀘어 Bold" panose="020B0600000101010101" pitchFamily="50" charset="-127"/>
-            </a:endParaRPr>
-          </a:p>
-        </p:txBody>
-      </p:sp>
-      <p:sp>
-        <p:nvSpPr>
-          <p:cNvPr id="25" name="모서리가 둥근 직사각형 24"/>
-          <p:cNvSpPr/>
-          <p:nvPr/>
-        </p:nvSpPr>
-        <p:spPr>
-          <a:xfrm>
-            <a:off x="5493970" y="2069114"/>
-            <a:ext cx="1080000" cy="540000"/>
-          </a:xfrm>
-          <a:prstGeom prst="roundRect">
-            <a:avLst/>
-          </a:prstGeom>
-          <a:solidFill>
-            <a:schemeClr val="accent5"/>
-          </a:solidFill>
-          <a:ln>
-            <a:noFill/>
-          </a:ln>
-        </p:spPr>
-        <p:style>
-          <a:lnRef idx="2">
-            <a:schemeClr val="accent1">
-              <a:shade val="50000"/>
-            </a:schemeClr>
-          </a:lnRef>
-          <a:fillRef idx="1">
-            <a:schemeClr val="accent1"/>
-          </a:fillRef>
-          <a:effectRef idx="0">
-            <a:schemeClr val="accent1"/>
-          </a:effectRef>
-          <a:fontRef idx="minor">
-            <a:schemeClr val="lt1"/>
-          </a:fontRef>
-        </p:style>
-        <p:txBody>
-          <a:bodyPr rtlCol="0" anchor="ctr"/>
-          <a:lstStyle/>
-          <a:p>
-            <a:pPr algn="ctr"/>
-            <a:r>
-              <a:rPr lang="en-US" altLang="ko-KR" dirty="0">
-                <a:latin typeface="나눔스퀘어 Bold" panose="020B0600000101010101" pitchFamily="50" charset="-127"/>
-                <a:ea typeface="나눔스퀘어 Bold" panose="020B0600000101010101" pitchFamily="50" charset="-127"/>
-              </a:rPr>
-              <a:t>Entity </a:t>
-            </a:r>
-            <a:r>
-              <a:rPr lang="ko-KR" altLang="en-US" dirty="0" smtClean="0">
-                <a:latin typeface="나눔스퀘어 Bold" panose="020B0600000101010101" pitchFamily="50" charset="-127"/>
-                <a:ea typeface="나눔스퀘어 Bold" panose="020B0600000101010101" pitchFamily="50" charset="-127"/>
-              </a:rPr>
-              <a:t>객체</a:t>
-            </a:r>
-            <a:r>
-              <a:rPr lang="en-US" altLang="ko-KR" dirty="0" smtClean="0">
-                <a:latin typeface="나눔스퀘어 Bold" panose="020B0600000101010101" pitchFamily="50" charset="-127"/>
-                <a:ea typeface="나눔스퀘어 Bold" panose="020B0600000101010101" pitchFamily="50" charset="-127"/>
-              </a:rPr>
-              <a:t>2</a:t>
-            </a:r>
-            <a:endParaRPr lang="ko-KR" altLang="en-US" dirty="0">
-              <a:latin typeface="나눔스퀘어 Bold" panose="020B0600000101010101" pitchFamily="50" charset="-127"/>
-              <a:ea typeface="나눔스퀘어 Bold" panose="020B0600000101010101" pitchFamily="50" charset="-127"/>
-            </a:endParaRPr>
-          </a:p>
-        </p:txBody>
-      </p:sp>
-      <p:sp>
-        <p:nvSpPr>
-          <p:cNvPr id="26" name="모서리가 둥근 직사각형 25"/>
-          <p:cNvSpPr/>
-          <p:nvPr/>
-        </p:nvSpPr>
-        <p:spPr>
-          <a:xfrm>
-            <a:off x="6710448" y="2062639"/>
-            <a:ext cx="1080000" cy="540000"/>
-          </a:xfrm>
-          <a:prstGeom prst="roundRect">
-            <a:avLst/>
-          </a:prstGeom>
-          <a:solidFill>
-            <a:schemeClr val="accent5"/>
-          </a:solidFill>
-          <a:ln>
-            <a:noFill/>
-          </a:ln>
-        </p:spPr>
-        <p:style>
-          <a:lnRef idx="2">
-            <a:schemeClr val="accent1">
-              <a:shade val="50000"/>
-            </a:schemeClr>
-          </a:lnRef>
-          <a:fillRef idx="1">
-            <a:schemeClr val="accent1"/>
-          </a:fillRef>
-          <a:effectRef idx="0">
-            <a:schemeClr val="accent1"/>
-          </a:effectRef>
-          <a:fontRef idx="minor">
-            <a:schemeClr val="lt1"/>
-          </a:fontRef>
-        </p:style>
-        <p:txBody>
-          <a:bodyPr rtlCol="0" anchor="ctr"/>
-          <a:lstStyle/>
-          <a:p>
-            <a:pPr algn="ctr"/>
-            <a:r>
-              <a:rPr lang="en-US" altLang="ko-KR" dirty="0">
-                <a:latin typeface="나눔스퀘어 Bold" panose="020B0600000101010101" pitchFamily="50" charset="-127"/>
-                <a:ea typeface="나눔스퀘어 Bold" panose="020B0600000101010101" pitchFamily="50" charset="-127"/>
-              </a:rPr>
-              <a:t>Entity </a:t>
-            </a:r>
-            <a:r>
-              <a:rPr lang="ko-KR" altLang="en-US" dirty="0" smtClean="0">
-                <a:latin typeface="나눔스퀘어 Bold" panose="020B0600000101010101" pitchFamily="50" charset="-127"/>
-                <a:ea typeface="나눔스퀘어 Bold" panose="020B0600000101010101" pitchFamily="50" charset="-127"/>
-              </a:rPr>
-              <a:t>객체</a:t>
-            </a:r>
-            <a:r>
-              <a:rPr lang="en-US" altLang="ko-KR" dirty="0" smtClean="0">
-                <a:latin typeface="나눔스퀘어 Bold" panose="020B0600000101010101" pitchFamily="50" charset="-127"/>
-                <a:ea typeface="나눔스퀘어 Bold" panose="020B0600000101010101" pitchFamily="50" charset="-127"/>
-              </a:rPr>
-              <a:t>3</a:t>
-            </a:r>
-            <a:endParaRPr lang="ko-KR" altLang="en-US" dirty="0">
-              <a:latin typeface="나눔스퀘어 Bold" panose="020B0600000101010101" pitchFamily="50" charset="-127"/>
-              <a:ea typeface="나눔스퀘어 Bold" panose="020B0600000101010101" pitchFamily="50" charset="-127"/>
-            </a:endParaRPr>
-          </a:p>
-        </p:txBody>
-      </p:sp>
     </p:spTree>
     <p:extLst>
       <p:ext uri="{BB962C8B-B14F-4D97-AF65-F5344CB8AC3E}">

</xml_diff>

<commit_message>
20260917 commit : 7_class
</commit_message>
<xml_diff>
--- a/notion/create_notion_img.pptx
+++ b/notion/create_notion_img.pptx
@@ -6,8 +6,10 @@
   </p:sldMasterIdLst>
   <p:sldIdLst>
     <p:sldId id="256" r:id="rId2"/>
-    <p:sldId id="259" r:id="rId3"/>
-    <p:sldId id="257" r:id="rId4"/>
+    <p:sldId id="261" r:id="rId3"/>
+    <p:sldId id="262" r:id="rId4"/>
+    <p:sldId id="259" r:id="rId5"/>
+    <p:sldId id="257" r:id="rId6"/>
   </p:sldIdLst>
   <p:sldSz cx="12192000" cy="6858000"/>
   <p:notesSz cx="6858000" cy="9144000"/>
@@ -2971,6 +2973,875 @@
           <a:chExt cx="0" cy="0"/>
         </a:xfrm>
       </p:grpSpPr>
+      <p:sp>
+        <p:nvSpPr>
+          <p:cNvPr id="76" name="직사각형 75"/>
+          <p:cNvSpPr/>
+          <p:nvPr/>
+        </p:nvSpPr>
+        <p:spPr>
+          <a:xfrm>
+            <a:off x="6500" y="2422853"/>
+            <a:ext cx="6480000" cy="720000"/>
+          </a:xfrm>
+          <a:prstGeom prst="rect">
+            <a:avLst/>
+          </a:prstGeom>
+          <a:solidFill>
+            <a:schemeClr val="accent5"/>
+          </a:solidFill>
+          <a:ln>
+            <a:noFill/>
+          </a:ln>
+        </p:spPr>
+        <p:style>
+          <a:lnRef idx="2">
+            <a:schemeClr val="accent1">
+              <a:shade val="50000"/>
+            </a:schemeClr>
+          </a:lnRef>
+          <a:fillRef idx="1">
+            <a:schemeClr val="accent1"/>
+          </a:fillRef>
+          <a:effectRef idx="0">
+            <a:schemeClr val="accent1"/>
+          </a:effectRef>
+          <a:fontRef idx="minor">
+            <a:schemeClr val="lt1"/>
+          </a:fontRef>
+        </p:style>
+        <p:txBody>
+          <a:bodyPr rtlCol="0" anchor="ctr"/>
+          <a:lstStyle/>
+          <a:p>
+            <a:pPr algn="ctr"/>
+            <a:r>
+              <a:rPr lang="en-US" altLang="ko-KR" sz="2400" dirty="0" err="1" smtClean="0">
+                <a:latin typeface="나눔스퀘어 Bold" panose="020B0600000101010101" pitchFamily="50" charset="-127"/>
+                <a:ea typeface="나눔스퀘어 Bold" panose="020B0600000101010101" pitchFamily="50" charset="-127"/>
+              </a:rPr>
+              <a:t>UsernamePasswordAuththenticationFilter</a:t>
+            </a:r>
+            <a:endParaRPr lang="ko-KR" altLang="en-US" sz="2800" dirty="0">
+              <a:latin typeface="나눔스퀘어 Bold" panose="020B0600000101010101" pitchFamily="50" charset="-127"/>
+              <a:ea typeface="나눔스퀘어 Bold" panose="020B0600000101010101" pitchFamily="50" charset="-127"/>
+            </a:endParaRPr>
+          </a:p>
+        </p:txBody>
+      </p:sp>
+      <p:sp>
+        <p:nvSpPr>
+          <p:cNvPr id="77" name="직사각형 76"/>
+          <p:cNvSpPr/>
+          <p:nvPr/>
+        </p:nvSpPr>
+        <p:spPr>
+          <a:xfrm>
+            <a:off x="6500" y="3800456"/>
+            <a:ext cx="6480000" cy="720000"/>
+          </a:xfrm>
+          <a:prstGeom prst="rect">
+            <a:avLst/>
+          </a:prstGeom>
+          <a:solidFill>
+            <a:schemeClr val="accent5"/>
+          </a:solidFill>
+          <a:ln>
+            <a:noFill/>
+          </a:ln>
+        </p:spPr>
+        <p:style>
+          <a:lnRef idx="2">
+            <a:schemeClr val="accent1">
+              <a:shade val="50000"/>
+            </a:schemeClr>
+          </a:lnRef>
+          <a:fillRef idx="1">
+            <a:schemeClr val="accent1"/>
+          </a:fillRef>
+          <a:effectRef idx="0">
+            <a:schemeClr val="accent1"/>
+          </a:effectRef>
+          <a:fontRef idx="minor">
+            <a:schemeClr val="lt1"/>
+          </a:fontRef>
+        </p:style>
+        <p:txBody>
+          <a:bodyPr rtlCol="0" anchor="ctr"/>
+          <a:lstStyle/>
+          <a:p>
+            <a:pPr algn="ctr"/>
+            <a:r>
+              <a:rPr lang="en-US" altLang="ko-KR" sz="3200" dirty="0" err="1" smtClean="0">
+                <a:latin typeface="나눔스퀘어 Bold" panose="020B0600000101010101" pitchFamily="50" charset="-127"/>
+                <a:ea typeface="나눔스퀘어 Bold" panose="020B0600000101010101" pitchFamily="50" charset="-127"/>
+              </a:rPr>
+              <a:t>AuthenticationManager</a:t>
+            </a:r>
+            <a:endParaRPr lang="ko-KR" altLang="en-US" sz="3200" dirty="0">
+              <a:latin typeface="나눔스퀘어 Bold" panose="020B0600000101010101" pitchFamily="50" charset="-127"/>
+              <a:ea typeface="나눔스퀘어 Bold" panose="020B0600000101010101" pitchFamily="50" charset="-127"/>
+            </a:endParaRPr>
+          </a:p>
+        </p:txBody>
+      </p:sp>
+      <p:sp>
+        <p:nvSpPr>
+          <p:cNvPr id="78" name="직사각형 77"/>
+          <p:cNvSpPr/>
+          <p:nvPr/>
+        </p:nvSpPr>
+        <p:spPr>
+          <a:xfrm>
+            <a:off x="6500" y="5178059"/>
+            <a:ext cx="6480000" cy="720000"/>
+          </a:xfrm>
+          <a:prstGeom prst="rect">
+            <a:avLst/>
+          </a:prstGeom>
+          <a:solidFill>
+            <a:schemeClr val="accent5"/>
+          </a:solidFill>
+          <a:ln>
+            <a:noFill/>
+          </a:ln>
+        </p:spPr>
+        <p:style>
+          <a:lnRef idx="2">
+            <a:schemeClr val="accent1">
+              <a:shade val="50000"/>
+            </a:schemeClr>
+          </a:lnRef>
+          <a:fillRef idx="1">
+            <a:schemeClr val="accent1"/>
+          </a:fillRef>
+          <a:effectRef idx="0">
+            <a:schemeClr val="accent1"/>
+          </a:effectRef>
+          <a:fontRef idx="minor">
+            <a:schemeClr val="lt1"/>
+          </a:fontRef>
+        </p:style>
+        <p:txBody>
+          <a:bodyPr rtlCol="0" anchor="ctr"/>
+          <a:lstStyle/>
+          <a:p>
+            <a:pPr algn="ctr"/>
+            <a:r>
+              <a:rPr lang="en-US" altLang="ko-KR" sz="3200" dirty="0" err="1" smtClean="0">
+                <a:latin typeface="나눔스퀘어 Bold" panose="020B0600000101010101" pitchFamily="50" charset="-127"/>
+                <a:ea typeface="나눔스퀘어 Bold" panose="020B0600000101010101" pitchFamily="50" charset="-127"/>
+              </a:rPr>
+              <a:t>AuthenticationProvider</a:t>
+            </a:r>
+            <a:endParaRPr lang="ko-KR" altLang="en-US" sz="3200" dirty="0">
+              <a:latin typeface="나눔스퀘어 Bold" panose="020B0600000101010101" pitchFamily="50" charset="-127"/>
+              <a:ea typeface="나눔스퀘어 Bold" panose="020B0600000101010101" pitchFamily="50" charset="-127"/>
+            </a:endParaRPr>
+          </a:p>
+        </p:txBody>
+      </p:sp>
+      <p:sp>
+        <p:nvSpPr>
+          <p:cNvPr id="80" name="직사각형 79"/>
+          <p:cNvSpPr/>
+          <p:nvPr/>
+        </p:nvSpPr>
+        <p:spPr>
+          <a:xfrm>
+            <a:off x="6500" y="6555662"/>
+            <a:ext cx="6480000" cy="720000"/>
+          </a:xfrm>
+          <a:prstGeom prst="rect">
+            <a:avLst/>
+          </a:prstGeom>
+          <a:solidFill>
+            <a:schemeClr val="accent5"/>
+          </a:solidFill>
+          <a:ln>
+            <a:noFill/>
+          </a:ln>
+        </p:spPr>
+        <p:style>
+          <a:lnRef idx="2">
+            <a:schemeClr val="accent1">
+              <a:shade val="50000"/>
+            </a:schemeClr>
+          </a:lnRef>
+          <a:fillRef idx="1">
+            <a:schemeClr val="accent1"/>
+          </a:fillRef>
+          <a:effectRef idx="0">
+            <a:schemeClr val="accent1"/>
+          </a:effectRef>
+          <a:fontRef idx="minor">
+            <a:schemeClr val="lt1"/>
+          </a:fontRef>
+        </p:style>
+        <p:txBody>
+          <a:bodyPr rtlCol="0" anchor="ctr"/>
+          <a:lstStyle/>
+          <a:p>
+            <a:pPr algn="ctr"/>
+            <a:r>
+              <a:rPr lang="en-US" altLang="ko-KR" sz="3200" dirty="0" err="1" smtClean="0">
+                <a:latin typeface="나눔스퀘어 Bold" panose="020B0600000101010101" pitchFamily="50" charset="-127"/>
+                <a:ea typeface="나눔스퀘어 Bold" panose="020B0600000101010101" pitchFamily="50" charset="-127"/>
+              </a:rPr>
+              <a:t>UserDetailService</a:t>
+            </a:r>
+            <a:endParaRPr lang="ko-KR" altLang="en-US" sz="3200" dirty="0">
+              <a:latin typeface="나눔스퀘어 Bold" panose="020B0600000101010101" pitchFamily="50" charset="-127"/>
+              <a:ea typeface="나눔스퀘어 Bold" panose="020B0600000101010101" pitchFamily="50" charset="-127"/>
+            </a:endParaRPr>
+          </a:p>
+        </p:txBody>
+      </p:sp>
+      <p:cxnSp>
+        <p:nvCxnSpPr>
+          <p:cNvPr id="86" name="직선 화살표 연결선 85"/>
+          <p:cNvCxnSpPr>
+            <a:stCxn id="76" idx="2"/>
+            <a:endCxn id="77" idx="0"/>
+          </p:cNvCxnSpPr>
+          <p:nvPr/>
+        </p:nvCxnSpPr>
+        <p:spPr>
+          <a:xfrm>
+            <a:off x="3246500" y="3142853"/>
+            <a:ext cx="0" cy="657603"/>
+          </a:xfrm>
+          <a:prstGeom prst="straightConnector1">
+            <a:avLst/>
+          </a:prstGeom>
+          <a:ln w="76200">
+            <a:solidFill>
+              <a:schemeClr val="accent2"/>
+            </a:solidFill>
+            <a:tailEnd type="triangle"/>
+          </a:ln>
+        </p:spPr>
+        <p:style>
+          <a:lnRef idx="1">
+            <a:schemeClr val="accent1"/>
+          </a:lnRef>
+          <a:fillRef idx="0">
+            <a:schemeClr val="accent1"/>
+          </a:fillRef>
+          <a:effectRef idx="0">
+            <a:schemeClr val="accent1"/>
+          </a:effectRef>
+          <a:fontRef idx="minor">
+            <a:schemeClr val="tx1"/>
+          </a:fontRef>
+        </p:style>
+      </p:cxnSp>
+      <p:cxnSp>
+        <p:nvCxnSpPr>
+          <p:cNvPr id="87" name="직선 화살표 연결선 86"/>
+          <p:cNvCxnSpPr>
+            <a:stCxn id="77" idx="2"/>
+            <a:endCxn id="78" idx="0"/>
+          </p:cNvCxnSpPr>
+          <p:nvPr/>
+        </p:nvCxnSpPr>
+        <p:spPr>
+          <a:xfrm>
+            <a:off x="3246500" y="4520456"/>
+            <a:ext cx="0" cy="657603"/>
+          </a:xfrm>
+          <a:prstGeom prst="straightConnector1">
+            <a:avLst/>
+          </a:prstGeom>
+          <a:ln w="76200">
+            <a:solidFill>
+              <a:schemeClr val="accent2"/>
+            </a:solidFill>
+            <a:tailEnd type="triangle"/>
+          </a:ln>
+        </p:spPr>
+        <p:style>
+          <a:lnRef idx="1">
+            <a:schemeClr val="accent1"/>
+          </a:lnRef>
+          <a:fillRef idx="0">
+            <a:schemeClr val="accent1"/>
+          </a:fillRef>
+          <a:effectRef idx="0">
+            <a:schemeClr val="accent1"/>
+          </a:effectRef>
+          <a:fontRef idx="minor">
+            <a:schemeClr val="tx1"/>
+          </a:fontRef>
+        </p:style>
+      </p:cxnSp>
+      <p:cxnSp>
+        <p:nvCxnSpPr>
+          <p:cNvPr id="88" name="직선 화살표 연결선 87"/>
+          <p:cNvCxnSpPr>
+            <a:stCxn id="78" idx="2"/>
+            <a:endCxn id="80" idx="0"/>
+          </p:cNvCxnSpPr>
+          <p:nvPr/>
+        </p:nvCxnSpPr>
+        <p:spPr>
+          <a:xfrm>
+            <a:off x="3246500" y="5898059"/>
+            <a:ext cx="0" cy="657603"/>
+          </a:xfrm>
+          <a:prstGeom prst="straightConnector1">
+            <a:avLst/>
+          </a:prstGeom>
+          <a:ln w="76200">
+            <a:solidFill>
+              <a:schemeClr val="accent2"/>
+            </a:solidFill>
+            <a:tailEnd type="triangle"/>
+          </a:ln>
+        </p:spPr>
+        <p:style>
+          <a:lnRef idx="1">
+            <a:schemeClr val="accent1"/>
+          </a:lnRef>
+          <a:fillRef idx="0">
+            <a:schemeClr val="accent1"/>
+          </a:fillRef>
+          <a:effectRef idx="0">
+            <a:schemeClr val="accent1"/>
+          </a:effectRef>
+          <a:fontRef idx="minor">
+            <a:schemeClr val="tx1"/>
+          </a:fontRef>
+        </p:style>
+      </p:cxnSp>
+      <p:sp>
+        <p:nvSpPr>
+          <p:cNvPr id="89" name="직사각형 88"/>
+          <p:cNvSpPr/>
+          <p:nvPr/>
+        </p:nvSpPr>
+        <p:spPr>
+          <a:xfrm>
+            <a:off x="3606500" y="7933265"/>
+            <a:ext cx="2880000" cy="720000"/>
+          </a:xfrm>
+          <a:prstGeom prst="rect">
+            <a:avLst/>
+          </a:prstGeom>
+          <a:solidFill>
+            <a:schemeClr val="accent5"/>
+          </a:solidFill>
+          <a:ln>
+            <a:noFill/>
+          </a:ln>
+        </p:spPr>
+        <p:style>
+          <a:lnRef idx="2">
+            <a:schemeClr val="accent1">
+              <a:shade val="50000"/>
+            </a:schemeClr>
+          </a:lnRef>
+          <a:fillRef idx="1">
+            <a:schemeClr val="accent1"/>
+          </a:fillRef>
+          <a:effectRef idx="0">
+            <a:schemeClr val="accent1"/>
+          </a:effectRef>
+          <a:fontRef idx="minor">
+            <a:schemeClr val="lt1"/>
+          </a:fontRef>
+        </p:style>
+        <p:txBody>
+          <a:bodyPr rtlCol="0" anchor="ctr"/>
+          <a:lstStyle/>
+          <a:p>
+            <a:pPr algn="ctr"/>
+            <a:r>
+              <a:rPr lang="en-US" altLang="ko-KR" sz="2400" dirty="0" err="1" smtClean="0">
+                <a:latin typeface="나눔스퀘어 Bold" panose="020B0600000101010101" pitchFamily="50" charset="-127"/>
+                <a:ea typeface="나눔스퀘어 Bold" panose="020B0600000101010101" pitchFamily="50" charset="-127"/>
+              </a:rPr>
+              <a:t>DispatcherSevlet</a:t>
+            </a:r>
+            <a:endParaRPr lang="ko-KR" altLang="en-US" sz="2400" dirty="0">
+              <a:latin typeface="나눔스퀘어 Bold" panose="020B0600000101010101" pitchFamily="50" charset="-127"/>
+              <a:ea typeface="나눔스퀘어 Bold" panose="020B0600000101010101" pitchFamily="50" charset="-127"/>
+            </a:endParaRPr>
+          </a:p>
+        </p:txBody>
+      </p:sp>
+      <p:sp>
+        <p:nvSpPr>
+          <p:cNvPr id="110" name="TextBox 109"/>
+          <p:cNvSpPr txBox="1"/>
+          <p:nvPr/>
+        </p:nvSpPr>
+        <p:spPr>
+          <a:xfrm>
+            <a:off x="3468627" y="3286269"/>
+            <a:ext cx="2255746" cy="369332"/>
+          </a:xfrm>
+          <a:prstGeom prst="rect">
+            <a:avLst/>
+          </a:prstGeom>
+          <a:noFill/>
+        </p:spPr>
+        <p:txBody>
+          <a:bodyPr wrap="none" rtlCol="0">
+            <a:spAutoFit/>
+          </a:bodyPr>
+          <a:lstStyle/>
+          <a:p>
+            <a:r>
+              <a:rPr lang="en-US" altLang="ko-KR" dirty="0" smtClean="0">
+                <a:latin typeface="나눔스퀘어 Bold" panose="020B0600000101010101" pitchFamily="50" charset="-127"/>
+                <a:ea typeface="나눔스퀘어 Bold" panose="020B0600000101010101" pitchFamily="50" charset="-127"/>
+              </a:rPr>
+              <a:t>Authentication </a:t>
+            </a:r>
+            <a:r>
+              <a:rPr lang="ko-KR" altLang="en-US" dirty="0" smtClean="0">
+                <a:latin typeface="나눔스퀘어 Bold" panose="020B0600000101010101" pitchFamily="50" charset="-127"/>
+                <a:ea typeface="나눔스퀘어 Bold" panose="020B0600000101010101" pitchFamily="50" charset="-127"/>
+              </a:rPr>
+              <a:t>전달</a:t>
+            </a:r>
+            <a:endParaRPr lang="ko-KR" altLang="en-US" dirty="0">
+              <a:latin typeface="나눔스퀘어 Bold" panose="020B0600000101010101" pitchFamily="50" charset="-127"/>
+              <a:ea typeface="나눔스퀘어 Bold" panose="020B0600000101010101" pitchFamily="50" charset="-127"/>
+            </a:endParaRPr>
+          </a:p>
+        </p:txBody>
+      </p:sp>
+      <p:sp>
+        <p:nvSpPr>
+          <p:cNvPr id="112" name="TextBox 111"/>
+          <p:cNvSpPr txBox="1"/>
+          <p:nvPr/>
+        </p:nvSpPr>
+        <p:spPr>
+          <a:xfrm>
+            <a:off x="3468627" y="4663872"/>
+            <a:ext cx="1588833" cy="369332"/>
+          </a:xfrm>
+          <a:prstGeom prst="rect">
+            <a:avLst/>
+          </a:prstGeom>
+          <a:noFill/>
+        </p:spPr>
+        <p:txBody>
+          <a:bodyPr wrap="none" rtlCol="0">
+            <a:spAutoFit/>
+          </a:bodyPr>
+          <a:lstStyle/>
+          <a:p>
+            <a:r>
+              <a:rPr lang="en-US" altLang="ko-KR" dirty="0" smtClean="0">
+                <a:latin typeface="나눔스퀘어 Bold" panose="020B0600000101010101" pitchFamily="50" charset="-127"/>
+                <a:ea typeface="나눔스퀘어 Bold" panose="020B0600000101010101" pitchFamily="50" charset="-127"/>
+              </a:rPr>
+              <a:t>Provider </a:t>
+            </a:r>
+            <a:r>
+              <a:rPr lang="ko-KR" altLang="en-US" dirty="0" smtClean="0">
+                <a:latin typeface="나눔스퀘어 Bold" panose="020B0600000101010101" pitchFamily="50" charset="-127"/>
+                <a:ea typeface="나눔스퀘어 Bold" panose="020B0600000101010101" pitchFamily="50" charset="-127"/>
+              </a:rPr>
+              <a:t>선택</a:t>
+            </a:r>
+            <a:endParaRPr lang="ko-KR" altLang="en-US" dirty="0">
+              <a:latin typeface="나눔스퀘어 Bold" panose="020B0600000101010101" pitchFamily="50" charset="-127"/>
+              <a:ea typeface="나눔스퀘어 Bold" panose="020B0600000101010101" pitchFamily="50" charset="-127"/>
+            </a:endParaRPr>
+          </a:p>
+        </p:txBody>
+      </p:sp>
+      <p:sp>
+        <p:nvSpPr>
+          <p:cNvPr id="113" name="TextBox 112"/>
+          <p:cNvSpPr txBox="1"/>
+          <p:nvPr/>
+        </p:nvSpPr>
+        <p:spPr>
+          <a:xfrm>
+            <a:off x="3468627" y="6042194"/>
+            <a:ext cx="1864613" cy="369332"/>
+          </a:xfrm>
+          <a:prstGeom prst="rect">
+            <a:avLst/>
+          </a:prstGeom>
+          <a:noFill/>
+        </p:spPr>
+        <p:txBody>
+          <a:bodyPr wrap="none" rtlCol="0">
+            <a:spAutoFit/>
+          </a:bodyPr>
+          <a:lstStyle/>
+          <a:p>
+            <a:r>
+              <a:rPr lang="en-US" altLang="ko-KR" dirty="0" smtClean="0">
+                <a:latin typeface="나눔스퀘어 Bold" panose="020B0600000101010101" pitchFamily="50" charset="-127"/>
+                <a:ea typeface="나눔스퀘어 Bold" panose="020B0600000101010101" pitchFamily="50" charset="-127"/>
+              </a:rPr>
+              <a:t>DB</a:t>
+            </a:r>
+            <a:r>
+              <a:rPr lang="ko-KR" altLang="en-US" dirty="0" smtClean="0">
+                <a:latin typeface="나눔스퀘어 Bold" panose="020B0600000101010101" pitchFamily="50" charset="-127"/>
+                <a:ea typeface="나눔스퀘어 Bold" panose="020B0600000101010101" pitchFamily="50" charset="-127"/>
+              </a:rPr>
+              <a:t>정보 조회 지시</a:t>
+            </a:r>
+            <a:endParaRPr lang="ko-KR" altLang="en-US" dirty="0">
+              <a:latin typeface="나눔스퀘어 Bold" panose="020B0600000101010101" pitchFamily="50" charset="-127"/>
+              <a:ea typeface="나눔스퀘어 Bold" panose="020B0600000101010101" pitchFamily="50" charset="-127"/>
+            </a:endParaRPr>
+          </a:p>
+        </p:txBody>
+      </p:sp>
+      <p:sp>
+        <p:nvSpPr>
+          <p:cNvPr id="114" name="TextBox 113"/>
+          <p:cNvSpPr txBox="1"/>
+          <p:nvPr/>
+        </p:nvSpPr>
+        <p:spPr>
+          <a:xfrm>
+            <a:off x="506712" y="7419797"/>
+            <a:ext cx="1386918" cy="369332"/>
+          </a:xfrm>
+          <a:prstGeom prst="rect">
+            <a:avLst/>
+          </a:prstGeom>
+          <a:noFill/>
+        </p:spPr>
+        <p:txBody>
+          <a:bodyPr wrap="none" rtlCol="0">
+            <a:spAutoFit/>
+          </a:bodyPr>
+          <a:lstStyle/>
+          <a:p>
+            <a:r>
+              <a:rPr lang="en-US" altLang="ko-KR" dirty="0" smtClean="0">
+                <a:latin typeface="나눔스퀘어 Bold" panose="020B0600000101010101" pitchFamily="50" charset="-127"/>
+                <a:ea typeface="나눔스퀘어 Bold" panose="020B0600000101010101" pitchFamily="50" charset="-127"/>
+              </a:rPr>
+              <a:t>DB</a:t>
+            </a:r>
+            <a:r>
+              <a:rPr lang="ko-KR" altLang="en-US" dirty="0" smtClean="0">
+                <a:latin typeface="나눔스퀘어 Bold" panose="020B0600000101010101" pitchFamily="50" charset="-127"/>
+                <a:ea typeface="나눔스퀘어 Bold" panose="020B0600000101010101" pitchFamily="50" charset="-127"/>
+              </a:rPr>
+              <a:t>정보 조회</a:t>
+            </a:r>
+            <a:endParaRPr lang="ko-KR" altLang="en-US" dirty="0">
+              <a:latin typeface="나눔스퀘어 Bold" panose="020B0600000101010101" pitchFamily="50" charset="-127"/>
+              <a:ea typeface="나눔스퀘어 Bold" panose="020B0600000101010101" pitchFamily="50" charset="-127"/>
+            </a:endParaRPr>
+          </a:p>
+        </p:txBody>
+      </p:sp>
+      <p:sp>
+        <p:nvSpPr>
+          <p:cNvPr id="115" name="TextBox 114"/>
+          <p:cNvSpPr txBox="1"/>
+          <p:nvPr/>
+        </p:nvSpPr>
+        <p:spPr>
+          <a:xfrm>
+            <a:off x="4641265" y="7419797"/>
+            <a:ext cx="1082348" cy="369332"/>
+          </a:xfrm>
+          <a:prstGeom prst="rect">
+            <a:avLst/>
+          </a:prstGeom>
+          <a:noFill/>
+        </p:spPr>
+        <p:txBody>
+          <a:bodyPr wrap="none" rtlCol="0">
+            <a:spAutoFit/>
+          </a:bodyPr>
+          <a:lstStyle/>
+          <a:p>
+            <a:r>
+              <a:rPr lang="ko-KR" altLang="en-US" dirty="0" smtClean="0">
+                <a:latin typeface="나눔스퀘어 Bold" panose="020B0600000101010101" pitchFamily="50" charset="-127"/>
+                <a:ea typeface="나눔스퀘어 Bold" panose="020B0600000101010101" pitchFamily="50" charset="-127"/>
+              </a:rPr>
+              <a:t>요청 전달</a:t>
+            </a:r>
+            <a:endParaRPr lang="ko-KR" altLang="en-US" dirty="0">
+              <a:latin typeface="나눔스퀘어 Bold" panose="020B0600000101010101" pitchFamily="50" charset="-127"/>
+              <a:ea typeface="나눔스퀘어 Bold" panose="020B0600000101010101" pitchFamily="50" charset="-127"/>
+            </a:endParaRPr>
+          </a:p>
+        </p:txBody>
+      </p:sp>
+      <p:sp>
+        <p:nvSpPr>
+          <p:cNvPr id="116" name="직사각형 115"/>
+          <p:cNvSpPr/>
+          <p:nvPr/>
+        </p:nvSpPr>
+        <p:spPr>
+          <a:xfrm>
+            <a:off x="6500" y="7933265"/>
+            <a:ext cx="2880000" cy="720000"/>
+          </a:xfrm>
+          <a:prstGeom prst="rect">
+            <a:avLst/>
+          </a:prstGeom>
+          <a:solidFill>
+            <a:schemeClr val="accent5"/>
+          </a:solidFill>
+          <a:ln>
+            <a:noFill/>
+          </a:ln>
+        </p:spPr>
+        <p:style>
+          <a:lnRef idx="2">
+            <a:schemeClr val="accent1">
+              <a:shade val="50000"/>
+            </a:schemeClr>
+          </a:lnRef>
+          <a:fillRef idx="1">
+            <a:schemeClr val="accent1"/>
+          </a:fillRef>
+          <a:effectRef idx="0">
+            <a:schemeClr val="accent1"/>
+          </a:effectRef>
+          <a:fontRef idx="minor">
+            <a:schemeClr val="lt1"/>
+          </a:fontRef>
+        </p:style>
+        <p:txBody>
+          <a:bodyPr rtlCol="0" anchor="ctr"/>
+          <a:lstStyle/>
+          <a:p>
+            <a:pPr algn="ctr"/>
+            <a:r>
+              <a:rPr lang="en-US" altLang="ko-KR" sz="3200" dirty="0" smtClean="0">
+                <a:latin typeface="나눔스퀘어 Bold" panose="020B0600000101010101" pitchFamily="50" charset="-127"/>
+                <a:ea typeface="나눔스퀘어 Bold" panose="020B0600000101010101" pitchFamily="50" charset="-127"/>
+              </a:rPr>
+              <a:t>DB</a:t>
+            </a:r>
+            <a:endParaRPr lang="ko-KR" altLang="en-US" sz="3200" dirty="0">
+              <a:latin typeface="나눔스퀘어 Bold" panose="020B0600000101010101" pitchFamily="50" charset="-127"/>
+              <a:ea typeface="나눔스퀘어 Bold" panose="020B0600000101010101" pitchFamily="50" charset="-127"/>
+            </a:endParaRPr>
+          </a:p>
+        </p:txBody>
+      </p:sp>
+      <p:sp>
+        <p:nvSpPr>
+          <p:cNvPr id="118" name="직사각형 117"/>
+          <p:cNvSpPr/>
+          <p:nvPr/>
+        </p:nvSpPr>
+        <p:spPr>
+          <a:xfrm>
+            <a:off x="-353500" y="1761402"/>
+            <a:ext cx="7200000" cy="7200000"/>
+          </a:xfrm>
+          <a:prstGeom prst="rect">
+            <a:avLst/>
+          </a:prstGeom>
+          <a:noFill/>
+          <a:ln w="19050">
+            <a:solidFill>
+              <a:schemeClr val="tx1"/>
+            </a:solidFill>
+          </a:ln>
+        </p:spPr>
+        <p:style>
+          <a:lnRef idx="2">
+            <a:schemeClr val="accent1">
+              <a:shade val="50000"/>
+            </a:schemeClr>
+          </a:lnRef>
+          <a:fillRef idx="1">
+            <a:schemeClr val="accent1"/>
+          </a:fillRef>
+          <a:effectRef idx="0">
+            <a:schemeClr val="accent1"/>
+          </a:effectRef>
+          <a:fontRef idx="minor">
+            <a:schemeClr val="lt1"/>
+          </a:fontRef>
+        </p:style>
+        <p:txBody>
+          <a:bodyPr rtlCol="0" anchor="ctr"/>
+          <a:lstStyle/>
+          <a:p>
+            <a:pPr algn="ctr"/>
+            <a:endParaRPr lang="ko-KR" altLang="en-US"/>
+          </a:p>
+        </p:txBody>
+      </p:sp>
+      <p:cxnSp>
+        <p:nvCxnSpPr>
+          <p:cNvPr id="119" name="직선 화살표 연결선 118"/>
+          <p:cNvCxnSpPr>
+            <a:stCxn id="80" idx="2"/>
+            <a:endCxn id="116" idx="0"/>
+          </p:cNvCxnSpPr>
+          <p:nvPr/>
+        </p:nvCxnSpPr>
+        <p:spPr>
+          <a:xfrm flipH="1">
+            <a:off x="1446500" y="7275662"/>
+            <a:ext cx="1800000" cy="657603"/>
+          </a:xfrm>
+          <a:prstGeom prst="straightConnector1">
+            <a:avLst/>
+          </a:prstGeom>
+          <a:ln w="76200">
+            <a:solidFill>
+              <a:schemeClr val="accent2"/>
+            </a:solidFill>
+            <a:tailEnd type="triangle"/>
+          </a:ln>
+        </p:spPr>
+        <p:style>
+          <a:lnRef idx="1">
+            <a:schemeClr val="accent1"/>
+          </a:lnRef>
+          <a:fillRef idx="0">
+            <a:schemeClr val="accent1"/>
+          </a:fillRef>
+          <a:effectRef idx="0">
+            <a:schemeClr val="accent1"/>
+          </a:effectRef>
+          <a:fontRef idx="minor">
+            <a:schemeClr val="tx1"/>
+          </a:fontRef>
+        </p:style>
+      </p:cxnSp>
+      <p:cxnSp>
+        <p:nvCxnSpPr>
+          <p:cNvPr id="122" name="직선 화살표 연결선 121"/>
+          <p:cNvCxnSpPr>
+            <a:stCxn id="80" idx="2"/>
+            <a:endCxn id="89" idx="0"/>
+          </p:cNvCxnSpPr>
+          <p:nvPr/>
+        </p:nvCxnSpPr>
+        <p:spPr>
+          <a:xfrm>
+            <a:off x="3246500" y="7275662"/>
+            <a:ext cx="1800000" cy="657603"/>
+          </a:xfrm>
+          <a:prstGeom prst="straightConnector1">
+            <a:avLst/>
+          </a:prstGeom>
+          <a:ln w="76200">
+            <a:solidFill>
+              <a:schemeClr val="accent2"/>
+            </a:solidFill>
+            <a:tailEnd type="triangle"/>
+          </a:ln>
+        </p:spPr>
+        <p:style>
+          <a:lnRef idx="1">
+            <a:schemeClr val="accent1"/>
+          </a:lnRef>
+          <a:fillRef idx="0">
+            <a:schemeClr val="accent1"/>
+          </a:fillRef>
+          <a:effectRef idx="0">
+            <a:schemeClr val="accent1"/>
+          </a:effectRef>
+          <a:fontRef idx="minor">
+            <a:schemeClr val="tx1"/>
+          </a:fontRef>
+        </p:style>
+      </p:cxnSp>
+      <p:sp>
+        <p:nvSpPr>
+          <p:cNvPr id="79" name="모서리가 둥근 직사각형 78"/>
+          <p:cNvSpPr/>
+          <p:nvPr/>
+        </p:nvSpPr>
+        <p:spPr>
+          <a:xfrm>
+            <a:off x="1896500" y="1401403"/>
+            <a:ext cx="2700000" cy="540000"/>
+          </a:xfrm>
+          <a:prstGeom prst="roundRect">
+            <a:avLst/>
+          </a:prstGeom>
+          <a:solidFill>
+            <a:schemeClr val="bg1"/>
+          </a:solidFill>
+          <a:ln w="19050">
+            <a:solidFill>
+              <a:schemeClr val="tx1"/>
+            </a:solidFill>
+          </a:ln>
+        </p:spPr>
+        <p:style>
+          <a:lnRef idx="2">
+            <a:schemeClr val="accent1">
+              <a:shade val="50000"/>
+            </a:schemeClr>
+          </a:lnRef>
+          <a:fillRef idx="1">
+            <a:schemeClr val="accent1"/>
+          </a:fillRef>
+          <a:effectRef idx="0">
+            <a:schemeClr val="accent1"/>
+          </a:effectRef>
+          <a:fontRef idx="minor">
+            <a:schemeClr val="lt1"/>
+          </a:fontRef>
+        </p:style>
+        <p:txBody>
+          <a:bodyPr rtlCol="0" anchor="ctr"/>
+          <a:lstStyle/>
+          <a:p>
+            <a:pPr algn="ctr"/>
+            <a:r>
+              <a:rPr lang="en-US" altLang="ko-KR" sz="2000" dirty="0" smtClean="0">
+                <a:solidFill>
+                  <a:schemeClr val="tx1"/>
+                </a:solidFill>
+                <a:latin typeface="나눔스퀘어 Bold" panose="020B0600000101010101" pitchFamily="50" charset="-127"/>
+                <a:ea typeface="나눔스퀘어 Bold" panose="020B0600000101010101" pitchFamily="50" charset="-127"/>
+              </a:rPr>
+              <a:t>Spring </a:t>
+            </a:r>
+            <a:r>
+              <a:rPr lang="en-US" altLang="ko-KR" sz="2000" dirty="0" err="1" smtClean="0">
+                <a:solidFill>
+                  <a:schemeClr val="tx1"/>
+                </a:solidFill>
+                <a:latin typeface="나눔스퀘어 Bold" panose="020B0600000101010101" pitchFamily="50" charset="-127"/>
+                <a:ea typeface="나눔스퀘어 Bold" panose="020B0600000101010101" pitchFamily="50" charset="-127"/>
+              </a:rPr>
+              <a:t>IoC</a:t>
+            </a:r>
+            <a:r>
+              <a:rPr lang="en-US" altLang="ko-KR" sz="2000" dirty="0" smtClean="0">
+                <a:solidFill>
+                  <a:schemeClr val="tx1"/>
+                </a:solidFill>
+                <a:latin typeface="나눔스퀘어 Bold" panose="020B0600000101010101" pitchFamily="50" charset="-127"/>
+                <a:ea typeface="나눔스퀘어 Bold" panose="020B0600000101010101" pitchFamily="50" charset="-127"/>
+              </a:rPr>
+              <a:t> Container</a:t>
+            </a:r>
+            <a:endParaRPr lang="ko-KR" altLang="en-US" sz="2000" dirty="0">
+              <a:solidFill>
+                <a:schemeClr val="tx1"/>
+              </a:solidFill>
+              <a:latin typeface="나눔스퀘어 Bold" panose="020B0600000101010101" pitchFamily="50" charset="-127"/>
+              <a:ea typeface="나눔스퀘어 Bold" panose="020B0600000101010101" pitchFamily="50" charset="-127"/>
+            </a:endParaRPr>
+          </a:p>
+        </p:txBody>
+      </p:sp>
     </p:spTree>
     <p:extLst>
       <p:ext uri="{BB962C8B-B14F-4D97-AF65-F5344CB8AC3E}">
@@ -3010,6 +3881,2680 @@
       </p:grpSpPr>
       <p:sp>
         <p:nvSpPr>
+          <p:cNvPr id="40" name="직사각형 39"/>
+          <p:cNvSpPr/>
+          <p:nvPr/>
+        </p:nvSpPr>
+        <p:spPr>
+          <a:xfrm>
+            <a:off x="1873050" y="5601724"/>
+            <a:ext cx="6480000" cy="720000"/>
+          </a:xfrm>
+          <a:prstGeom prst="rect">
+            <a:avLst/>
+          </a:prstGeom>
+          <a:solidFill>
+            <a:schemeClr val="accent5"/>
+          </a:solidFill>
+          <a:ln>
+            <a:noFill/>
+          </a:ln>
+        </p:spPr>
+        <p:style>
+          <a:lnRef idx="2">
+            <a:schemeClr val="accent1">
+              <a:shade val="50000"/>
+            </a:schemeClr>
+          </a:lnRef>
+          <a:fillRef idx="1">
+            <a:schemeClr val="accent1"/>
+          </a:fillRef>
+          <a:effectRef idx="0">
+            <a:schemeClr val="accent1"/>
+          </a:effectRef>
+          <a:fontRef idx="minor">
+            <a:schemeClr val="lt1"/>
+          </a:fontRef>
+        </p:style>
+        <p:txBody>
+          <a:bodyPr rtlCol="0" anchor="ctr"/>
+          <a:lstStyle/>
+          <a:p>
+            <a:pPr algn="ctr"/>
+            <a:r>
+              <a:rPr lang="en-US" altLang="ko-KR" sz="2400" dirty="0" err="1" smtClean="0">
+                <a:latin typeface="나눔스퀘어 Bold" panose="020B0600000101010101" pitchFamily="50" charset="-127"/>
+                <a:ea typeface="나눔스퀘어 Bold" panose="020B0600000101010101" pitchFamily="50" charset="-127"/>
+              </a:rPr>
+              <a:t>UsernamePasswordAuththenticationFilter</a:t>
+            </a:r>
+            <a:endParaRPr lang="ko-KR" altLang="en-US" sz="2800" dirty="0">
+              <a:latin typeface="나눔스퀘어 Bold" panose="020B0600000101010101" pitchFamily="50" charset="-127"/>
+              <a:ea typeface="나눔스퀘어 Bold" panose="020B0600000101010101" pitchFamily="50" charset="-127"/>
+            </a:endParaRPr>
+          </a:p>
+        </p:txBody>
+      </p:sp>
+      <p:sp>
+        <p:nvSpPr>
+          <p:cNvPr id="41" name="직사각형 40"/>
+          <p:cNvSpPr/>
+          <p:nvPr/>
+        </p:nvSpPr>
+        <p:spPr>
+          <a:xfrm>
+            <a:off x="1873050" y="4225559"/>
+            <a:ext cx="6480000" cy="720000"/>
+          </a:xfrm>
+          <a:prstGeom prst="rect">
+            <a:avLst/>
+          </a:prstGeom>
+          <a:solidFill>
+            <a:schemeClr val="accent5"/>
+          </a:solidFill>
+          <a:ln>
+            <a:noFill/>
+          </a:ln>
+        </p:spPr>
+        <p:style>
+          <a:lnRef idx="2">
+            <a:schemeClr val="accent1">
+              <a:shade val="50000"/>
+            </a:schemeClr>
+          </a:lnRef>
+          <a:fillRef idx="1">
+            <a:schemeClr val="accent1"/>
+          </a:fillRef>
+          <a:effectRef idx="0">
+            <a:schemeClr val="accent1"/>
+          </a:effectRef>
+          <a:fontRef idx="minor">
+            <a:schemeClr val="lt1"/>
+          </a:fontRef>
+        </p:style>
+        <p:txBody>
+          <a:bodyPr rtlCol="0" anchor="ctr"/>
+          <a:lstStyle/>
+          <a:p>
+            <a:pPr algn="ctr"/>
+            <a:r>
+              <a:rPr lang="en-US" altLang="ko-KR" sz="3200" dirty="0" err="1" smtClean="0">
+                <a:latin typeface="나눔스퀘어 Bold" panose="020B0600000101010101" pitchFamily="50" charset="-127"/>
+                <a:ea typeface="나눔스퀘어 Bold" panose="020B0600000101010101" pitchFamily="50" charset="-127"/>
+              </a:rPr>
+              <a:t>AuthenticationManager</a:t>
+            </a:r>
+            <a:endParaRPr lang="ko-KR" altLang="en-US" sz="3200" dirty="0">
+              <a:latin typeface="나눔스퀘어 Bold" panose="020B0600000101010101" pitchFamily="50" charset="-127"/>
+              <a:ea typeface="나눔스퀘어 Bold" panose="020B0600000101010101" pitchFamily="50" charset="-127"/>
+            </a:endParaRPr>
+          </a:p>
+        </p:txBody>
+      </p:sp>
+      <p:sp>
+        <p:nvSpPr>
+          <p:cNvPr id="42" name="직사각형 41"/>
+          <p:cNvSpPr/>
+          <p:nvPr/>
+        </p:nvSpPr>
+        <p:spPr>
+          <a:xfrm>
+            <a:off x="1873050" y="2847956"/>
+            <a:ext cx="6480000" cy="720000"/>
+          </a:xfrm>
+          <a:prstGeom prst="rect">
+            <a:avLst/>
+          </a:prstGeom>
+          <a:solidFill>
+            <a:schemeClr val="accent5"/>
+          </a:solidFill>
+          <a:ln>
+            <a:noFill/>
+          </a:ln>
+        </p:spPr>
+        <p:style>
+          <a:lnRef idx="2">
+            <a:schemeClr val="accent1">
+              <a:shade val="50000"/>
+            </a:schemeClr>
+          </a:lnRef>
+          <a:fillRef idx="1">
+            <a:schemeClr val="accent1"/>
+          </a:fillRef>
+          <a:effectRef idx="0">
+            <a:schemeClr val="accent1"/>
+          </a:effectRef>
+          <a:fontRef idx="minor">
+            <a:schemeClr val="lt1"/>
+          </a:fontRef>
+        </p:style>
+        <p:txBody>
+          <a:bodyPr rtlCol="0" anchor="ctr"/>
+          <a:lstStyle/>
+          <a:p>
+            <a:pPr algn="ctr"/>
+            <a:r>
+              <a:rPr lang="en-US" altLang="ko-KR" sz="3200" dirty="0" err="1" smtClean="0">
+                <a:latin typeface="나눔스퀘어 Bold" panose="020B0600000101010101" pitchFamily="50" charset="-127"/>
+                <a:ea typeface="나눔스퀘어 Bold" panose="020B0600000101010101" pitchFamily="50" charset="-127"/>
+              </a:rPr>
+              <a:t>AuthenticationProvider</a:t>
+            </a:r>
+            <a:endParaRPr lang="ko-KR" altLang="en-US" sz="3200" dirty="0">
+              <a:latin typeface="나눔스퀘어 Bold" panose="020B0600000101010101" pitchFamily="50" charset="-127"/>
+              <a:ea typeface="나눔스퀘어 Bold" panose="020B0600000101010101" pitchFamily="50" charset="-127"/>
+            </a:endParaRPr>
+          </a:p>
+        </p:txBody>
+      </p:sp>
+      <p:sp>
+        <p:nvSpPr>
+          <p:cNvPr id="44" name="직사각형 43"/>
+          <p:cNvSpPr/>
+          <p:nvPr/>
+        </p:nvSpPr>
+        <p:spPr>
+          <a:xfrm>
+            <a:off x="1873050" y="1470353"/>
+            <a:ext cx="6480000" cy="720000"/>
+          </a:xfrm>
+          <a:prstGeom prst="rect">
+            <a:avLst/>
+          </a:prstGeom>
+          <a:solidFill>
+            <a:schemeClr val="accent5"/>
+          </a:solidFill>
+          <a:ln>
+            <a:noFill/>
+          </a:ln>
+        </p:spPr>
+        <p:style>
+          <a:lnRef idx="2">
+            <a:schemeClr val="accent1">
+              <a:shade val="50000"/>
+            </a:schemeClr>
+          </a:lnRef>
+          <a:fillRef idx="1">
+            <a:schemeClr val="accent1"/>
+          </a:fillRef>
+          <a:effectRef idx="0">
+            <a:schemeClr val="accent1"/>
+          </a:effectRef>
+          <a:fontRef idx="minor">
+            <a:schemeClr val="lt1"/>
+          </a:fontRef>
+        </p:style>
+        <p:txBody>
+          <a:bodyPr rtlCol="0" anchor="ctr"/>
+          <a:lstStyle/>
+          <a:p>
+            <a:pPr algn="ctr"/>
+            <a:r>
+              <a:rPr lang="en-US" altLang="ko-KR" sz="3200" dirty="0" err="1" smtClean="0">
+                <a:latin typeface="나눔스퀘어 Bold" panose="020B0600000101010101" pitchFamily="50" charset="-127"/>
+                <a:ea typeface="나눔스퀘어 Bold" panose="020B0600000101010101" pitchFamily="50" charset="-127"/>
+              </a:rPr>
+              <a:t>UserDetailService</a:t>
+            </a:r>
+            <a:endParaRPr lang="ko-KR" altLang="en-US" sz="3200" dirty="0">
+              <a:latin typeface="나눔스퀘어 Bold" panose="020B0600000101010101" pitchFamily="50" charset="-127"/>
+              <a:ea typeface="나눔스퀘어 Bold" panose="020B0600000101010101" pitchFamily="50" charset="-127"/>
+            </a:endParaRPr>
+          </a:p>
+        </p:txBody>
+      </p:sp>
+      <p:sp>
+        <p:nvSpPr>
+          <p:cNvPr id="91" name="직사각형 90"/>
+          <p:cNvSpPr/>
+          <p:nvPr/>
+        </p:nvSpPr>
+        <p:spPr>
+          <a:xfrm>
+            <a:off x="1875150" y="6977889"/>
+            <a:ext cx="6480000" cy="1800000"/>
+          </a:xfrm>
+          <a:prstGeom prst="rect">
+            <a:avLst/>
+          </a:prstGeom>
+          <a:solidFill>
+            <a:schemeClr val="accent5"/>
+          </a:solidFill>
+          <a:ln>
+            <a:noFill/>
+          </a:ln>
+        </p:spPr>
+        <p:style>
+          <a:lnRef idx="2">
+            <a:schemeClr val="accent1">
+              <a:shade val="50000"/>
+            </a:schemeClr>
+          </a:lnRef>
+          <a:fillRef idx="1">
+            <a:schemeClr val="accent1"/>
+          </a:fillRef>
+          <a:effectRef idx="0">
+            <a:schemeClr val="accent1"/>
+          </a:effectRef>
+          <a:fontRef idx="minor">
+            <a:schemeClr val="lt1"/>
+          </a:fontRef>
+        </p:style>
+        <p:txBody>
+          <a:bodyPr rtlCol="0" anchor="ctr"/>
+          <a:lstStyle/>
+          <a:p>
+            <a:pPr algn="ctr"/>
+            <a:r>
+              <a:rPr lang="en-US" altLang="ko-KR" sz="2800" dirty="0" err="1" smtClean="0">
+                <a:latin typeface="나눔스퀘어 Bold" panose="020B0600000101010101" pitchFamily="50" charset="-127"/>
+                <a:ea typeface="나눔스퀘어 Bold" panose="020B0600000101010101" pitchFamily="50" charset="-127"/>
+              </a:rPr>
+              <a:t>SecurityContextHolder</a:t>
+            </a:r>
+            <a:endParaRPr lang="en-US" altLang="ko-KR" sz="2800" dirty="0" smtClean="0">
+              <a:latin typeface="나눔스퀘어 Bold" panose="020B0600000101010101" pitchFamily="50" charset="-127"/>
+              <a:ea typeface="나눔스퀘어 Bold" panose="020B0600000101010101" pitchFamily="50" charset="-127"/>
+            </a:endParaRPr>
+          </a:p>
+          <a:p>
+            <a:pPr algn="ctr"/>
+            <a:endParaRPr lang="en-US" altLang="ko-KR" sz="2800" dirty="0">
+              <a:latin typeface="나눔스퀘어 Bold" panose="020B0600000101010101" pitchFamily="50" charset="-127"/>
+              <a:ea typeface="나눔스퀘어 Bold" panose="020B0600000101010101" pitchFamily="50" charset="-127"/>
+            </a:endParaRPr>
+          </a:p>
+          <a:p>
+            <a:pPr algn="ctr"/>
+            <a:endParaRPr lang="en-US" altLang="ko-KR" sz="2400" dirty="0" smtClean="0">
+              <a:latin typeface="나눔스퀘어 Bold" panose="020B0600000101010101" pitchFamily="50" charset="-127"/>
+              <a:ea typeface="나눔스퀘어 Bold" panose="020B0600000101010101" pitchFamily="50" charset="-127"/>
+            </a:endParaRPr>
+          </a:p>
+          <a:p>
+            <a:pPr algn="ctr"/>
+            <a:endParaRPr lang="en-US" altLang="ko-KR" sz="2000" dirty="0" smtClean="0">
+              <a:latin typeface="나눔스퀘어 Bold" panose="020B0600000101010101" pitchFamily="50" charset="-127"/>
+              <a:ea typeface="나눔스퀘어 Bold" panose="020B0600000101010101" pitchFamily="50" charset="-127"/>
+            </a:endParaRPr>
+          </a:p>
+        </p:txBody>
+      </p:sp>
+      <p:sp>
+        <p:nvSpPr>
+          <p:cNvPr id="93" name="직사각형 92"/>
+          <p:cNvSpPr/>
+          <p:nvPr/>
+        </p:nvSpPr>
+        <p:spPr>
+          <a:xfrm>
+            <a:off x="2568900" y="7697889"/>
+            <a:ext cx="5040000" cy="720000"/>
+          </a:xfrm>
+          <a:prstGeom prst="rect">
+            <a:avLst/>
+          </a:prstGeom>
+          <a:solidFill>
+            <a:schemeClr val="accent1"/>
+          </a:solidFill>
+          <a:ln>
+            <a:noFill/>
+          </a:ln>
+        </p:spPr>
+        <p:style>
+          <a:lnRef idx="2">
+            <a:schemeClr val="accent1">
+              <a:shade val="50000"/>
+            </a:schemeClr>
+          </a:lnRef>
+          <a:fillRef idx="1">
+            <a:schemeClr val="accent1"/>
+          </a:fillRef>
+          <a:effectRef idx="0">
+            <a:schemeClr val="accent1"/>
+          </a:effectRef>
+          <a:fontRef idx="minor">
+            <a:schemeClr val="lt1"/>
+          </a:fontRef>
+        </p:style>
+        <p:txBody>
+          <a:bodyPr rtlCol="0" anchor="ctr"/>
+          <a:lstStyle/>
+          <a:p>
+            <a:pPr algn="ctr"/>
+            <a:r>
+              <a:rPr lang="en-US" altLang="ko-KR" sz="3600" dirty="0">
+                <a:latin typeface="나눔스퀘어 Bold" panose="020B0600000101010101" pitchFamily="50" charset="-127"/>
+                <a:ea typeface="나눔스퀘어 Bold" panose="020B0600000101010101" pitchFamily="50" charset="-127"/>
+              </a:rPr>
+              <a:t>Principal</a:t>
+            </a:r>
+            <a:endParaRPr lang="ko-KR" altLang="en-US" sz="3600" dirty="0">
+              <a:latin typeface="나눔스퀘어 Bold" panose="020B0600000101010101" pitchFamily="50" charset="-127"/>
+              <a:ea typeface="나눔스퀘어 Bold" panose="020B0600000101010101" pitchFamily="50" charset="-127"/>
+            </a:endParaRPr>
+          </a:p>
+        </p:txBody>
+      </p:sp>
+      <p:cxnSp>
+        <p:nvCxnSpPr>
+          <p:cNvPr id="94" name="직선 화살표 연결선 93"/>
+          <p:cNvCxnSpPr>
+            <a:endCxn id="42" idx="0"/>
+          </p:cNvCxnSpPr>
+          <p:nvPr/>
+        </p:nvCxnSpPr>
+        <p:spPr>
+          <a:xfrm>
+            <a:off x="5113050" y="2190353"/>
+            <a:ext cx="0" cy="657603"/>
+          </a:xfrm>
+          <a:prstGeom prst="straightConnector1">
+            <a:avLst/>
+          </a:prstGeom>
+          <a:ln w="76200">
+            <a:solidFill>
+              <a:schemeClr val="accent2"/>
+            </a:solidFill>
+            <a:tailEnd type="triangle"/>
+          </a:ln>
+        </p:spPr>
+        <p:style>
+          <a:lnRef idx="1">
+            <a:schemeClr val="accent1"/>
+          </a:lnRef>
+          <a:fillRef idx="0">
+            <a:schemeClr val="accent1"/>
+          </a:fillRef>
+          <a:effectRef idx="0">
+            <a:schemeClr val="accent1"/>
+          </a:effectRef>
+          <a:fontRef idx="minor">
+            <a:schemeClr val="tx1"/>
+          </a:fontRef>
+        </p:style>
+      </p:cxnSp>
+      <p:cxnSp>
+        <p:nvCxnSpPr>
+          <p:cNvPr id="97" name="직선 화살표 연결선 96"/>
+          <p:cNvCxnSpPr>
+            <a:stCxn id="42" idx="2"/>
+            <a:endCxn id="41" idx="0"/>
+          </p:cNvCxnSpPr>
+          <p:nvPr/>
+        </p:nvCxnSpPr>
+        <p:spPr>
+          <a:xfrm>
+            <a:off x="5113050" y="3567956"/>
+            <a:ext cx="0" cy="657603"/>
+          </a:xfrm>
+          <a:prstGeom prst="straightConnector1">
+            <a:avLst/>
+          </a:prstGeom>
+          <a:ln w="76200">
+            <a:solidFill>
+              <a:schemeClr val="accent2"/>
+            </a:solidFill>
+            <a:tailEnd type="triangle"/>
+          </a:ln>
+        </p:spPr>
+        <p:style>
+          <a:lnRef idx="1">
+            <a:schemeClr val="accent1"/>
+          </a:lnRef>
+          <a:fillRef idx="0">
+            <a:schemeClr val="accent1"/>
+          </a:fillRef>
+          <a:effectRef idx="0">
+            <a:schemeClr val="accent1"/>
+          </a:effectRef>
+          <a:fontRef idx="minor">
+            <a:schemeClr val="tx1"/>
+          </a:fontRef>
+        </p:style>
+      </p:cxnSp>
+      <p:cxnSp>
+        <p:nvCxnSpPr>
+          <p:cNvPr id="100" name="직선 화살표 연결선 99"/>
+          <p:cNvCxnSpPr>
+            <a:stCxn id="41" idx="2"/>
+            <a:endCxn id="40" idx="0"/>
+          </p:cNvCxnSpPr>
+          <p:nvPr/>
+        </p:nvCxnSpPr>
+        <p:spPr>
+          <a:xfrm>
+            <a:off x="5113050" y="4945559"/>
+            <a:ext cx="0" cy="656165"/>
+          </a:xfrm>
+          <a:prstGeom prst="straightConnector1">
+            <a:avLst/>
+          </a:prstGeom>
+          <a:ln w="76200">
+            <a:solidFill>
+              <a:schemeClr val="accent2"/>
+            </a:solidFill>
+            <a:tailEnd type="triangle"/>
+          </a:ln>
+        </p:spPr>
+        <p:style>
+          <a:lnRef idx="1">
+            <a:schemeClr val="accent1"/>
+          </a:lnRef>
+          <a:fillRef idx="0">
+            <a:schemeClr val="accent1"/>
+          </a:fillRef>
+          <a:effectRef idx="0">
+            <a:schemeClr val="accent1"/>
+          </a:effectRef>
+          <a:fontRef idx="minor">
+            <a:schemeClr val="tx1"/>
+          </a:fontRef>
+        </p:style>
+      </p:cxnSp>
+      <p:cxnSp>
+        <p:nvCxnSpPr>
+          <p:cNvPr id="104" name="직선 화살표 연결선 103"/>
+          <p:cNvCxnSpPr>
+            <a:stCxn id="40" idx="2"/>
+            <a:endCxn id="91" idx="0"/>
+          </p:cNvCxnSpPr>
+          <p:nvPr/>
+        </p:nvCxnSpPr>
+        <p:spPr>
+          <a:xfrm>
+            <a:off x="5113050" y="6321724"/>
+            <a:ext cx="2100" cy="656165"/>
+          </a:xfrm>
+          <a:prstGeom prst="straightConnector1">
+            <a:avLst/>
+          </a:prstGeom>
+          <a:ln w="76200">
+            <a:solidFill>
+              <a:schemeClr val="accent2"/>
+            </a:solidFill>
+            <a:tailEnd type="triangle"/>
+          </a:ln>
+        </p:spPr>
+        <p:style>
+          <a:lnRef idx="1">
+            <a:schemeClr val="accent1"/>
+          </a:lnRef>
+          <a:fillRef idx="0">
+            <a:schemeClr val="accent1"/>
+          </a:fillRef>
+          <a:effectRef idx="0">
+            <a:schemeClr val="accent1"/>
+          </a:effectRef>
+          <a:fontRef idx="minor">
+            <a:schemeClr val="tx1"/>
+          </a:fontRef>
+        </p:style>
+      </p:cxnSp>
+      <p:sp>
+        <p:nvSpPr>
+          <p:cNvPr id="109" name="직사각형 108"/>
+          <p:cNvSpPr/>
+          <p:nvPr/>
+        </p:nvSpPr>
+        <p:spPr>
+          <a:xfrm>
+            <a:off x="1513050" y="808902"/>
+            <a:ext cx="7200000" cy="8280000"/>
+          </a:xfrm>
+          <a:prstGeom prst="rect">
+            <a:avLst/>
+          </a:prstGeom>
+          <a:noFill/>
+          <a:ln w="19050">
+            <a:solidFill>
+              <a:schemeClr val="tx1"/>
+            </a:solidFill>
+          </a:ln>
+        </p:spPr>
+        <p:style>
+          <a:lnRef idx="2">
+            <a:schemeClr val="accent1">
+              <a:shade val="50000"/>
+            </a:schemeClr>
+          </a:lnRef>
+          <a:fillRef idx="1">
+            <a:schemeClr val="accent1"/>
+          </a:fillRef>
+          <a:effectRef idx="0">
+            <a:schemeClr val="accent1"/>
+          </a:effectRef>
+          <a:fontRef idx="minor">
+            <a:schemeClr val="lt1"/>
+          </a:fontRef>
+        </p:style>
+        <p:txBody>
+          <a:bodyPr rtlCol="0" anchor="ctr"/>
+          <a:lstStyle/>
+          <a:p>
+            <a:pPr algn="ctr"/>
+            <a:endParaRPr lang="ko-KR" altLang="en-US"/>
+          </a:p>
+        </p:txBody>
+      </p:sp>
+      <p:sp>
+        <p:nvSpPr>
+          <p:cNvPr id="43" name="모서리가 둥근 직사각형 42"/>
+          <p:cNvSpPr/>
+          <p:nvPr/>
+        </p:nvSpPr>
+        <p:spPr>
+          <a:xfrm>
+            <a:off x="3738900" y="448903"/>
+            <a:ext cx="2700000" cy="540000"/>
+          </a:xfrm>
+          <a:prstGeom prst="roundRect">
+            <a:avLst/>
+          </a:prstGeom>
+          <a:solidFill>
+            <a:schemeClr val="bg1"/>
+          </a:solidFill>
+          <a:ln w="19050">
+            <a:solidFill>
+              <a:schemeClr val="tx1"/>
+            </a:solidFill>
+          </a:ln>
+        </p:spPr>
+        <p:style>
+          <a:lnRef idx="2">
+            <a:schemeClr val="accent1">
+              <a:shade val="50000"/>
+            </a:schemeClr>
+          </a:lnRef>
+          <a:fillRef idx="1">
+            <a:schemeClr val="accent1"/>
+          </a:fillRef>
+          <a:effectRef idx="0">
+            <a:schemeClr val="accent1"/>
+          </a:effectRef>
+          <a:fontRef idx="minor">
+            <a:schemeClr val="lt1"/>
+          </a:fontRef>
+        </p:style>
+        <p:txBody>
+          <a:bodyPr rtlCol="0" anchor="ctr"/>
+          <a:lstStyle/>
+          <a:p>
+            <a:pPr algn="ctr"/>
+            <a:r>
+              <a:rPr lang="en-US" altLang="ko-KR" sz="2000" dirty="0" smtClean="0">
+                <a:solidFill>
+                  <a:schemeClr val="tx1"/>
+                </a:solidFill>
+                <a:latin typeface="나눔스퀘어 Bold" panose="020B0600000101010101" pitchFamily="50" charset="-127"/>
+                <a:ea typeface="나눔스퀘어 Bold" panose="020B0600000101010101" pitchFamily="50" charset="-127"/>
+              </a:rPr>
+              <a:t>Spring </a:t>
+            </a:r>
+            <a:r>
+              <a:rPr lang="en-US" altLang="ko-KR" sz="2000" dirty="0" err="1" smtClean="0">
+                <a:solidFill>
+                  <a:schemeClr val="tx1"/>
+                </a:solidFill>
+                <a:latin typeface="나눔스퀘어 Bold" panose="020B0600000101010101" pitchFamily="50" charset="-127"/>
+                <a:ea typeface="나눔스퀘어 Bold" panose="020B0600000101010101" pitchFamily="50" charset="-127"/>
+              </a:rPr>
+              <a:t>IoC</a:t>
+            </a:r>
+            <a:r>
+              <a:rPr lang="en-US" altLang="ko-KR" sz="2000" dirty="0" smtClean="0">
+                <a:solidFill>
+                  <a:schemeClr val="tx1"/>
+                </a:solidFill>
+                <a:latin typeface="나눔스퀘어 Bold" panose="020B0600000101010101" pitchFamily="50" charset="-127"/>
+                <a:ea typeface="나눔스퀘어 Bold" panose="020B0600000101010101" pitchFamily="50" charset="-127"/>
+              </a:rPr>
+              <a:t> Container</a:t>
+            </a:r>
+            <a:endParaRPr lang="ko-KR" altLang="en-US" sz="2000" dirty="0">
+              <a:solidFill>
+                <a:schemeClr val="tx1"/>
+              </a:solidFill>
+              <a:latin typeface="나눔스퀘어 Bold" panose="020B0600000101010101" pitchFamily="50" charset="-127"/>
+              <a:ea typeface="나눔스퀘어 Bold" panose="020B0600000101010101" pitchFamily="50" charset="-127"/>
+            </a:endParaRPr>
+          </a:p>
+        </p:txBody>
+      </p:sp>
+      <p:sp>
+        <p:nvSpPr>
+          <p:cNvPr id="3" name="TextBox 2"/>
+          <p:cNvSpPr txBox="1"/>
+          <p:nvPr/>
+        </p:nvSpPr>
+        <p:spPr>
+          <a:xfrm>
+            <a:off x="5324032" y="6465140"/>
+            <a:ext cx="1560042" cy="369332"/>
+          </a:xfrm>
+          <a:prstGeom prst="rect">
+            <a:avLst/>
+          </a:prstGeom>
+          <a:noFill/>
+        </p:spPr>
+        <p:txBody>
+          <a:bodyPr wrap="none" rtlCol="0">
+            <a:spAutoFit/>
+          </a:bodyPr>
+          <a:lstStyle/>
+          <a:p>
+            <a:r>
+              <a:rPr lang="ko-KR" altLang="en-US" smtClean="0">
+                <a:latin typeface="나눔스퀘어 Bold" panose="020B0600000101010101" pitchFamily="50" charset="-127"/>
+                <a:ea typeface="나눔스퀘어 Bold" panose="020B0600000101010101" pitchFamily="50" charset="-127"/>
+              </a:rPr>
+              <a:t>인증 결과 보관</a:t>
+            </a:r>
+            <a:endParaRPr lang="ko-KR" altLang="en-US">
+              <a:latin typeface="나눔스퀘어 Bold" panose="020B0600000101010101" pitchFamily="50" charset="-127"/>
+              <a:ea typeface="나눔스퀘어 Bold" panose="020B0600000101010101" pitchFamily="50" charset="-127"/>
+            </a:endParaRPr>
+          </a:p>
+        </p:txBody>
+      </p:sp>
+      <p:sp>
+        <p:nvSpPr>
+          <p:cNvPr id="33" name="TextBox 32"/>
+          <p:cNvSpPr txBox="1"/>
+          <p:nvPr/>
+        </p:nvSpPr>
+        <p:spPr>
+          <a:xfrm>
+            <a:off x="5324032" y="5085935"/>
+            <a:ext cx="1560042" cy="369332"/>
+          </a:xfrm>
+          <a:prstGeom prst="rect">
+            <a:avLst/>
+          </a:prstGeom>
+          <a:noFill/>
+        </p:spPr>
+        <p:txBody>
+          <a:bodyPr wrap="none" rtlCol="0">
+            <a:spAutoFit/>
+          </a:bodyPr>
+          <a:lstStyle/>
+          <a:p>
+            <a:r>
+              <a:rPr lang="ko-KR" altLang="en-US" dirty="0" smtClean="0">
+                <a:latin typeface="나눔스퀘어 Bold" panose="020B0600000101010101" pitchFamily="50" charset="-127"/>
+                <a:ea typeface="나눔스퀘어 Bold" panose="020B0600000101010101" pitchFamily="50" charset="-127"/>
+              </a:rPr>
+              <a:t>인증 결과 반환</a:t>
+            </a:r>
+            <a:endParaRPr lang="ko-KR" altLang="en-US" dirty="0">
+              <a:latin typeface="나눔스퀘어 Bold" panose="020B0600000101010101" pitchFamily="50" charset="-127"/>
+              <a:ea typeface="나눔스퀘어 Bold" panose="020B0600000101010101" pitchFamily="50" charset="-127"/>
+            </a:endParaRPr>
+          </a:p>
+        </p:txBody>
+      </p:sp>
+      <p:sp>
+        <p:nvSpPr>
+          <p:cNvPr id="34" name="TextBox 33"/>
+          <p:cNvSpPr txBox="1"/>
+          <p:nvPr/>
+        </p:nvSpPr>
+        <p:spPr>
+          <a:xfrm>
+            <a:off x="5324032" y="3708730"/>
+            <a:ext cx="1560042" cy="369332"/>
+          </a:xfrm>
+          <a:prstGeom prst="rect">
+            <a:avLst/>
+          </a:prstGeom>
+          <a:noFill/>
+        </p:spPr>
+        <p:txBody>
+          <a:bodyPr wrap="none" rtlCol="0">
+            <a:spAutoFit/>
+          </a:bodyPr>
+          <a:lstStyle/>
+          <a:p>
+            <a:r>
+              <a:rPr lang="ko-KR" altLang="en-US" dirty="0" smtClean="0">
+                <a:latin typeface="나눔스퀘어 Bold" panose="020B0600000101010101" pitchFamily="50" charset="-127"/>
+                <a:ea typeface="나눔스퀘어 Bold" panose="020B0600000101010101" pitchFamily="50" charset="-127"/>
+              </a:rPr>
+              <a:t>인증 결과 반환</a:t>
+            </a:r>
+            <a:endParaRPr lang="ko-KR" altLang="en-US" dirty="0">
+              <a:latin typeface="나눔스퀘어 Bold" panose="020B0600000101010101" pitchFamily="50" charset="-127"/>
+              <a:ea typeface="나눔스퀘어 Bold" panose="020B0600000101010101" pitchFamily="50" charset="-127"/>
+            </a:endParaRPr>
+          </a:p>
+        </p:txBody>
+      </p:sp>
+      <p:sp>
+        <p:nvSpPr>
+          <p:cNvPr id="35" name="TextBox 34"/>
+          <p:cNvSpPr txBox="1"/>
+          <p:nvPr/>
+        </p:nvSpPr>
+        <p:spPr>
+          <a:xfrm>
+            <a:off x="5324032" y="2332565"/>
+            <a:ext cx="1895071" cy="369332"/>
+          </a:xfrm>
+          <a:prstGeom prst="rect">
+            <a:avLst/>
+          </a:prstGeom>
+          <a:noFill/>
+        </p:spPr>
+        <p:txBody>
+          <a:bodyPr wrap="none" rtlCol="0">
+            <a:spAutoFit/>
+          </a:bodyPr>
+          <a:lstStyle/>
+          <a:p>
+            <a:r>
+              <a:rPr lang="en-US" altLang="ko-KR" dirty="0" err="1" smtClean="0">
+                <a:latin typeface="나눔스퀘어 Bold" panose="020B0600000101010101" pitchFamily="50" charset="-127"/>
+                <a:ea typeface="나눔스퀘어 Bold" panose="020B0600000101010101" pitchFamily="50" charset="-127"/>
+              </a:rPr>
+              <a:t>UserDetails</a:t>
+            </a:r>
+            <a:r>
+              <a:rPr lang="en-US" altLang="ko-KR" dirty="0" smtClean="0">
+                <a:latin typeface="나눔스퀘어 Bold" panose="020B0600000101010101" pitchFamily="50" charset="-127"/>
+                <a:ea typeface="나눔스퀘어 Bold" panose="020B0600000101010101" pitchFamily="50" charset="-127"/>
+              </a:rPr>
+              <a:t> </a:t>
+            </a:r>
+            <a:r>
+              <a:rPr lang="ko-KR" altLang="en-US" dirty="0" smtClean="0">
+                <a:latin typeface="나눔스퀘어 Bold" panose="020B0600000101010101" pitchFamily="50" charset="-127"/>
+                <a:ea typeface="나눔스퀘어 Bold" panose="020B0600000101010101" pitchFamily="50" charset="-127"/>
+              </a:rPr>
+              <a:t>반환</a:t>
+            </a:r>
+            <a:endParaRPr lang="ko-KR" altLang="en-US" dirty="0">
+              <a:latin typeface="나눔스퀘어 Bold" panose="020B0600000101010101" pitchFamily="50" charset="-127"/>
+              <a:ea typeface="나눔스퀘어 Bold" panose="020B0600000101010101" pitchFamily="50" charset="-127"/>
+            </a:endParaRPr>
+          </a:p>
+        </p:txBody>
+      </p:sp>
+    </p:spTree>
+    <p:extLst>
+      <p:ext uri="{BB962C8B-B14F-4D97-AF65-F5344CB8AC3E}">
+        <p14:creationId xmlns:p14="http://schemas.microsoft.com/office/powerpoint/2010/main" val="1159339994"/>
+      </p:ext>
+    </p:extLst>
+  </p:cSld>
+  <p:clrMapOvr>
+    <a:masterClrMapping/>
+  </p:clrMapOvr>
+  <p:timing>
+    <p:tnLst>
+      <p:par>
+        <p:cTn id="1" dur="indefinite" restart="never" nodeType="tmRoot"/>
+      </p:par>
+    </p:tnLst>
+  </p:timing>
+</p:sld>
+</file>
+
+<file path=ppt/slides/slide3.xml><?xml version="1.0" encoding="utf-8"?>
+<p:sld xmlns:a="http://schemas.openxmlformats.org/drawingml/2006/main" xmlns:r="http://schemas.openxmlformats.org/officeDocument/2006/relationships" xmlns:p="http://schemas.openxmlformats.org/presentationml/2006/main">
+  <p:cSld>
+    <p:spTree>
+      <p:nvGrpSpPr>
+        <p:cNvPr id="1" name=""/>
+        <p:cNvGrpSpPr/>
+        <p:nvPr/>
+      </p:nvGrpSpPr>
+      <p:grpSpPr>
+        <a:xfrm>
+          <a:off x="0" y="0"/>
+          <a:ext cx="0" cy="0"/>
+          <a:chOff x="0" y="0"/>
+          <a:chExt cx="0" cy="0"/>
+        </a:xfrm>
+      </p:grpSpPr>
+      <p:sp>
+        <p:nvSpPr>
+          <p:cNvPr id="7" name="직사각형 6"/>
+          <p:cNvSpPr/>
+          <p:nvPr/>
+        </p:nvSpPr>
+        <p:spPr>
+          <a:xfrm>
+            <a:off x="3923899" y="-762144"/>
+            <a:ext cx="9000000" cy="1800000"/>
+          </a:xfrm>
+          <a:prstGeom prst="rect">
+            <a:avLst/>
+          </a:prstGeom>
+          <a:noFill/>
+          <a:ln w="19050">
+            <a:solidFill>
+              <a:schemeClr val="tx1"/>
+            </a:solidFill>
+          </a:ln>
+        </p:spPr>
+        <p:style>
+          <a:lnRef idx="2">
+            <a:schemeClr val="accent1">
+              <a:shade val="50000"/>
+            </a:schemeClr>
+          </a:lnRef>
+          <a:fillRef idx="1">
+            <a:schemeClr val="accent1"/>
+          </a:fillRef>
+          <a:effectRef idx="0">
+            <a:schemeClr val="accent1"/>
+          </a:effectRef>
+          <a:fontRef idx="minor">
+            <a:schemeClr val="lt1"/>
+          </a:fontRef>
+        </p:style>
+        <p:txBody>
+          <a:bodyPr rtlCol="0" anchor="ctr"/>
+          <a:lstStyle/>
+          <a:p>
+            <a:pPr algn="ctr"/>
+            <a:endParaRPr lang="ko-KR" altLang="en-US"/>
+          </a:p>
+        </p:txBody>
+      </p:sp>
+      <p:sp>
+        <p:nvSpPr>
+          <p:cNvPr id="108" name="직사각형 107"/>
+          <p:cNvSpPr/>
+          <p:nvPr/>
+        </p:nvSpPr>
+        <p:spPr>
+          <a:xfrm>
+            <a:off x="-353500" y="1761402"/>
+            <a:ext cx="7200000" cy="7200000"/>
+          </a:xfrm>
+          <a:prstGeom prst="rect">
+            <a:avLst/>
+          </a:prstGeom>
+          <a:noFill/>
+          <a:ln w="19050">
+            <a:solidFill>
+              <a:schemeClr val="tx1"/>
+            </a:solidFill>
+          </a:ln>
+        </p:spPr>
+        <p:style>
+          <a:lnRef idx="2">
+            <a:schemeClr val="accent1">
+              <a:shade val="50000"/>
+            </a:schemeClr>
+          </a:lnRef>
+          <a:fillRef idx="1">
+            <a:schemeClr val="accent1"/>
+          </a:fillRef>
+          <a:effectRef idx="0">
+            <a:schemeClr val="accent1"/>
+          </a:effectRef>
+          <a:fontRef idx="minor">
+            <a:schemeClr val="lt1"/>
+          </a:fontRef>
+        </p:style>
+        <p:txBody>
+          <a:bodyPr rtlCol="0" anchor="ctr"/>
+          <a:lstStyle/>
+          <a:p>
+            <a:pPr algn="ctr"/>
+            <a:endParaRPr lang="ko-KR" altLang="en-US"/>
+          </a:p>
+        </p:txBody>
+      </p:sp>
+      <p:sp>
+        <p:nvSpPr>
+          <p:cNvPr id="40" name="직사각형 39"/>
+          <p:cNvSpPr/>
+          <p:nvPr/>
+        </p:nvSpPr>
+        <p:spPr>
+          <a:xfrm>
+            <a:off x="7626150" y="6554224"/>
+            <a:ext cx="6480000" cy="720000"/>
+          </a:xfrm>
+          <a:prstGeom prst="rect">
+            <a:avLst/>
+          </a:prstGeom>
+          <a:solidFill>
+            <a:schemeClr val="accent5"/>
+          </a:solidFill>
+          <a:ln>
+            <a:noFill/>
+          </a:ln>
+        </p:spPr>
+        <p:style>
+          <a:lnRef idx="2">
+            <a:schemeClr val="accent1">
+              <a:shade val="50000"/>
+            </a:schemeClr>
+          </a:lnRef>
+          <a:fillRef idx="1">
+            <a:schemeClr val="accent1"/>
+          </a:fillRef>
+          <a:effectRef idx="0">
+            <a:schemeClr val="accent1"/>
+          </a:effectRef>
+          <a:fontRef idx="minor">
+            <a:schemeClr val="lt1"/>
+          </a:fontRef>
+        </p:style>
+        <p:txBody>
+          <a:bodyPr rtlCol="0" anchor="ctr"/>
+          <a:lstStyle/>
+          <a:p>
+            <a:pPr algn="ctr"/>
+            <a:r>
+              <a:rPr lang="en-US" altLang="ko-KR" sz="2400" dirty="0" err="1" smtClean="0">
+                <a:latin typeface="나눔스퀘어 Bold" panose="020B0600000101010101" pitchFamily="50" charset="-127"/>
+                <a:ea typeface="나눔스퀘어 Bold" panose="020B0600000101010101" pitchFamily="50" charset="-127"/>
+              </a:rPr>
+              <a:t>UsernamePasswordAuththenticationFilter</a:t>
+            </a:r>
+            <a:endParaRPr lang="ko-KR" altLang="en-US" sz="2800" dirty="0">
+              <a:latin typeface="나눔스퀘어 Bold" panose="020B0600000101010101" pitchFamily="50" charset="-127"/>
+              <a:ea typeface="나눔스퀘어 Bold" panose="020B0600000101010101" pitchFamily="50" charset="-127"/>
+            </a:endParaRPr>
+          </a:p>
+        </p:txBody>
+      </p:sp>
+      <p:sp>
+        <p:nvSpPr>
+          <p:cNvPr id="41" name="직사각형 40"/>
+          <p:cNvSpPr/>
+          <p:nvPr/>
+        </p:nvSpPr>
+        <p:spPr>
+          <a:xfrm>
+            <a:off x="7626150" y="5178059"/>
+            <a:ext cx="6480000" cy="720000"/>
+          </a:xfrm>
+          <a:prstGeom prst="rect">
+            <a:avLst/>
+          </a:prstGeom>
+          <a:solidFill>
+            <a:schemeClr val="accent5"/>
+          </a:solidFill>
+          <a:ln>
+            <a:noFill/>
+          </a:ln>
+        </p:spPr>
+        <p:style>
+          <a:lnRef idx="2">
+            <a:schemeClr val="accent1">
+              <a:shade val="50000"/>
+            </a:schemeClr>
+          </a:lnRef>
+          <a:fillRef idx="1">
+            <a:schemeClr val="accent1"/>
+          </a:fillRef>
+          <a:effectRef idx="0">
+            <a:schemeClr val="accent1"/>
+          </a:effectRef>
+          <a:fontRef idx="minor">
+            <a:schemeClr val="lt1"/>
+          </a:fontRef>
+        </p:style>
+        <p:txBody>
+          <a:bodyPr rtlCol="0" anchor="ctr"/>
+          <a:lstStyle/>
+          <a:p>
+            <a:pPr algn="ctr"/>
+            <a:r>
+              <a:rPr lang="en-US" altLang="ko-KR" sz="3200" dirty="0" err="1" smtClean="0">
+                <a:latin typeface="나눔스퀘어 Bold" panose="020B0600000101010101" pitchFamily="50" charset="-127"/>
+                <a:ea typeface="나눔스퀘어 Bold" panose="020B0600000101010101" pitchFamily="50" charset="-127"/>
+              </a:rPr>
+              <a:t>AuthenticationManager</a:t>
+            </a:r>
+            <a:endParaRPr lang="ko-KR" altLang="en-US" sz="3200" dirty="0">
+              <a:latin typeface="나눔스퀘어 Bold" panose="020B0600000101010101" pitchFamily="50" charset="-127"/>
+              <a:ea typeface="나눔스퀘어 Bold" panose="020B0600000101010101" pitchFamily="50" charset="-127"/>
+            </a:endParaRPr>
+          </a:p>
+        </p:txBody>
+      </p:sp>
+      <p:sp>
+        <p:nvSpPr>
+          <p:cNvPr id="42" name="직사각형 41"/>
+          <p:cNvSpPr/>
+          <p:nvPr/>
+        </p:nvSpPr>
+        <p:spPr>
+          <a:xfrm>
+            <a:off x="7626150" y="3800456"/>
+            <a:ext cx="6480000" cy="720000"/>
+          </a:xfrm>
+          <a:prstGeom prst="rect">
+            <a:avLst/>
+          </a:prstGeom>
+          <a:solidFill>
+            <a:schemeClr val="accent5"/>
+          </a:solidFill>
+          <a:ln>
+            <a:noFill/>
+          </a:ln>
+        </p:spPr>
+        <p:style>
+          <a:lnRef idx="2">
+            <a:schemeClr val="accent1">
+              <a:shade val="50000"/>
+            </a:schemeClr>
+          </a:lnRef>
+          <a:fillRef idx="1">
+            <a:schemeClr val="accent1"/>
+          </a:fillRef>
+          <a:effectRef idx="0">
+            <a:schemeClr val="accent1"/>
+          </a:effectRef>
+          <a:fontRef idx="minor">
+            <a:schemeClr val="lt1"/>
+          </a:fontRef>
+        </p:style>
+        <p:txBody>
+          <a:bodyPr rtlCol="0" anchor="ctr"/>
+          <a:lstStyle/>
+          <a:p>
+            <a:pPr algn="ctr"/>
+            <a:r>
+              <a:rPr lang="en-US" altLang="ko-KR" sz="3200" dirty="0" err="1" smtClean="0">
+                <a:latin typeface="나눔스퀘어 Bold" panose="020B0600000101010101" pitchFamily="50" charset="-127"/>
+                <a:ea typeface="나눔스퀘어 Bold" panose="020B0600000101010101" pitchFamily="50" charset="-127"/>
+              </a:rPr>
+              <a:t>AuthenticationProvider</a:t>
+            </a:r>
+            <a:endParaRPr lang="ko-KR" altLang="en-US" sz="3200" dirty="0">
+              <a:latin typeface="나눔스퀘어 Bold" panose="020B0600000101010101" pitchFamily="50" charset="-127"/>
+              <a:ea typeface="나눔스퀘어 Bold" panose="020B0600000101010101" pitchFamily="50" charset="-127"/>
+            </a:endParaRPr>
+          </a:p>
+        </p:txBody>
+      </p:sp>
+      <p:sp>
+        <p:nvSpPr>
+          <p:cNvPr id="43" name="모서리가 둥근 직사각형 42"/>
+          <p:cNvSpPr/>
+          <p:nvPr/>
+        </p:nvSpPr>
+        <p:spPr>
+          <a:xfrm>
+            <a:off x="9492000" y="1401403"/>
+            <a:ext cx="2700000" cy="540000"/>
+          </a:xfrm>
+          <a:prstGeom prst="roundRect">
+            <a:avLst/>
+          </a:prstGeom>
+          <a:solidFill>
+            <a:schemeClr val="bg1"/>
+          </a:solidFill>
+          <a:ln w="19050">
+            <a:solidFill>
+              <a:schemeClr val="tx1"/>
+            </a:solidFill>
+          </a:ln>
+        </p:spPr>
+        <p:style>
+          <a:lnRef idx="2">
+            <a:schemeClr val="accent1">
+              <a:shade val="50000"/>
+            </a:schemeClr>
+          </a:lnRef>
+          <a:fillRef idx="1">
+            <a:schemeClr val="accent1"/>
+          </a:fillRef>
+          <a:effectRef idx="0">
+            <a:schemeClr val="accent1"/>
+          </a:effectRef>
+          <a:fontRef idx="minor">
+            <a:schemeClr val="lt1"/>
+          </a:fontRef>
+        </p:style>
+        <p:txBody>
+          <a:bodyPr rtlCol="0" anchor="ctr"/>
+          <a:lstStyle/>
+          <a:p>
+            <a:pPr algn="ctr"/>
+            <a:r>
+              <a:rPr lang="en-US" altLang="ko-KR" sz="2000" dirty="0" smtClean="0">
+                <a:solidFill>
+                  <a:schemeClr val="tx1"/>
+                </a:solidFill>
+                <a:latin typeface="나눔스퀘어 Bold" panose="020B0600000101010101" pitchFamily="50" charset="-127"/>
+                <a:ea typeface="나눔스퀘어 Bold" panose="020B0600000101010101" pitchFamily="50" charset="-127"/>
+              </a:rPr>
+              <a:t>Spring </a:t>
+            </a:r>
+            <a:r>
+              <a:rPr lang="en-US" altLang="ko-KR" sz="2000" dirty="0" err="1" smtClean="0">
+                <a:solidFill>
+                  <a:schemeClr val="tx1"/>
+                </a:solidFill>
+                <a:latin typeface="나눔스퀘어 Bold" panose="020B0600000101010101" pitchFamily="50" charset="-127"/>
+                <a:ea typeface="나눔스퀘어 Bold" panose="020B0600000101010101" pitchFamily="50" charset="-127"/>
+              </a:rPr>
+              <a:t>IoC</a:t>
+            </a:r>
+            <a:r>
+              <a:rPr lang="en-US" altLang="ko-KR" sz="2000" dirty="0" smtClean="0">
+                <a:solidFill>
+                  <a:schemeClr val="tx1"/>
+                </a:solidFill>
+                <a:latin typeface="나눔스퀘어 Bold" panose="020B0600000101010101" pitchFamily="50" charset="-127"/>
+                <a:ea typeface="나눔스퀘어 Bold" panose="020B0600000101010101" pitchFamily="50" charset="-127"/>
+              </a:rPr>
+              <a:t> Container</a:t>
+            </a:r>
+            <a:endParaRPr lang="ko-KR" altLang="en-US" sz="2000" dirty="0">
+              <a:solidFill>
+                <a:schemeClr val="tx1"/>
+              </a:solidFill>
+              <a:latin typeface="나눔스퀘어 Bold" panose="020B0600000101010101" pitchFamily="50" charset="-127"/>
+              <a:ea typeface="나눔스퀘어 Bold" panose="020B0600000101010101" pitchFamily="50" charset="-127"/>
+            </a:endParaRPr>
+          </a:p>
+        </p:txBody>
+      </p:sp>
+      <p:sp>
+        <p:nvSpPr>
+          <p:cNvPr id="44" name="직사각형 43"/>
+          <p:cNvSpPr/>
+          <p:nvPr/>
+        </p:nvSpPr>
+        <p:spPr>
+          <a:xfrm>
+            <a:off x="7626150" y="2422853"/>
+            <a:ext cx="6480000" cy="720000"/>
+          </a:xfrm>
+          <a:prstGeom prst="rect">
+            <a:avLst/>
+          </a:prstGeom>
+          <a:solidFill>
+            <a:schemeClr val="accent5"/>
+          </a:solidFill>
+          <a:ln>
+            <a:noFill/>
+          </a:ln>
+        </p:spPr>
+        <p:style>
+          <a:lnRef idx="2">
+            <a:schemeClr val="accent1">
+              <a:shade val="50000"/>
+            </a:schemeClr>
+          </a:lnRef>
+          <a:fillRef idx="1">
+            <a:schemeClr val="accent1"/>
+          </a:fillRef>
+          <a:effectRef idx="0">
+            <a:schemeClr val="accent1"/>
+          </a:effectRef>
+          <a:fontRef idx="minor">
+            <a:schemeClr val="lt1"/>
+          </a:fontRef>
+        </p:style>
+        <p:txBody>
+          <a:bodyPr rtlCol="0" anchor="ctr"/>
+          <a:lstStyle/>
+          <a:p>
+            <a:pPr algn="ctr"/>
+            <a:r>
+              <a:rPr lang="en-US" altLang="ko-KR" sz="3200" dirty="0" err="1" smtClean="0">
+                <a:latin typeface="나눔스퀘어 Bold" panose="020B0600000101010101" pitchFamily="50" charset="-127"/>
+                <a:ea typeface="나눔스퀘어 Bold" panose="020B0600000101010101" pitchFamily="50" charset="-127"/>
+              </a:rPr>
+              <a:t>UserDetailService</a:t>
+            </a:r>
+            <a:endParaRPr lang="ko-KR" altLang="en-US" sz="3200" dirty="0">
+              <a:latin typeface="나눔스퀘어 Bold" panose="020B0600000101010101" pitchFamily="50" charset="-127"/>
+              <a:ea typeface="나눔스퀘어 Bold" panose="020B0600000101010101" pitchFamily="50" charset="-127"/>
+            </a:endParaRPr>
+          </a:p>
+        </p:txBody>
+      </p:sp>
+      <p:sp>
+        <p:nvSpPr>
+          <p:cNvPr id="76" name="직사각형 75"/>
+          <p:cNvSpPr/>
+          <p:nvPr/>
+        </p:nvSpPr>
+        <p:spPr>
+          <a:xfrm>
+            <a:off x="6500" y="2422853"/>
+            <a:ext cx="6480000" cy="720000"/>
+          </a:xfrm>
+          <a:prstGeom prst="rect">
+            <a:avLst/>
+          </a:prstGeom>
+          <a:solidFill>
+            <a:schemeClr val="accent5"/>
+          </a:solidFill>
+          <a:ln>
+            <a:noFill/>
+          </a:ln>
+        </p:spPr>
+        <p:style>
+          <a:lnRef idx="2">
+            <a:schemeClr val="accent1">
+              <a:shade val="50000"/>
+            </a:schemeClr>
+          </a:lnRef>
+          <a:fillRef idx="1">
+            <a:schemeClr val="accent1"/>
+          </a:fillRef>
+          <a:effectRef idx="0">
+            <a:schemeClr val="accent1"/>
+          </a:effectRef>
+          <a:fontRef idx="minor">
+            <a:schemeClr val="lt1"/>
+          </a:fontRef>
+        </p:style>
+        <p:txBody>
+          <a:bodyPr rtlCol="0" anchor="ctr"/>
+          <a:lstStyle/>
+          <a:p>
+            <a:pPr algn="ctr"/>
+            <a:r>
+              <a:rPr lang="en-US" altLang="ko-KR" sz="2400" dirty="0" err="1" smtClean="0">
+                <a:latin typeface="나눔스퀘어 Bold" panose="020B0600000101010101" pitchFamily="50" charset="-127"/>
+                <a:ea typeface="나눔스퀘어 Bold" panose="020B0600000101010101" pitchFamily="50" charset="-127"/>
+              </a:rPr>
+              <a:t>UsernamePasswordAuththenticationFilter</a:t>
+            </a:r>
+            <a:endParaRPr lang="ko-KR" altLang="en-US" sz="2800" dirty="0">
+              <a:latin typeface="나눔스퀘어 Bold" panose="020B0600000101010101" pitchFamily="50" charset="-127"/>
+              <a:ea typeface="나눔스퀘어 Bold" panose="020B0600000101010101" pitchFamily="50" charset="-127"/>
+            </a:endParaRPr>
+          </a:p>
+        </p:txBody>
+      </p:sp>
+      <p:sp>
+        <p:nvSpPr>
+          <p:cNvPr id="77" name="직사각형 76"/>
+          <p:cNvSpPr/>
+          <p:nvPr/>
+        </p:nvSpPr>
+        <p:spPr>
+          <a:xfrm>
+            <a:off x="6500" y="3800456"/>
+            <a:ext cx="6480000" cy="720000"/>
+          </a:xfrm>
+          <a:prstGeom prst="rect">
+            <a:avLst/>
+          </a:prstGeom>
+          <a:solidFill>
+            <a:schemeClr val="accent5"/>
+          </a:solidFill>
+          <a:ln>
+            <a:noFill/>
+          </a:ln>
+        </p:spPr>
+        <p:style>
+          <a:lnRef idx="2">
+            <a:schemeClr val="accent1">
+              <a:shade val="50000"/>
+            </a:schemeClr>
+          </a:lnRef>
+          <a:fillRef idx="1">
+            <a:schemeClr val="accent1"/>
+          </a:fillRef>
+          <a:effectRef idx="0">
+            <a:schemeClr val="accent1"/>
+          </a:effectRef>
+          <a:fontRef idx="minor">
+            <a:schemeClr val="lt1"/>
+          </a:fontRef>
+        </p:style>
+        <p:txBody>
+          <a:bodyPr rtlCol="0" anchor="ctr"/>
+          <a:lstStyle/>
+          <a:p>
+            <a:pPr algn="ctr"/>
+            <a:r>
+              <a:rPr lang="en-US" altLang="ko-KR" sz="3200" dirty="0" err="1" smtClean="0">
+                <a:latin typeface="나눔스퀘어 Bold" panose="020B0600000101010101" pitchFamily="50" charset="-127"/>
+                <a:ea typeface="나눔스퀘어 Bold" panose="020B0600000101010101" pitchFamily="50" charset="-127"/>
+              </a:rPr>
+              <a:t>AuthenticationManager</a:t>
+            </a:r>
+            <a:endParaRPr lang="ko-KR" altLang="en-US" sz="3200" dirty="0">
+              <a:latin typeface="나눔스퀘어 Bold" panose="020B0600000101010101" pitchFamily="50" charset="-127"/>
+              <a:ea typeface="나눔스퀘어 Bold" panose="020B0600000101010101" pitchFamily="50" charset="-127"/>
+            </a:endParaRPr>
+          </a:p>
+        </p:txBody>
+      </p:sp>
+      <p:sp>
+        <p:nvSpPr>
+          <p:cNvPr id="78" name="직사각형 77"/>
+          <p:cNvSpPr/>
+          <p:nvPr/>
+        </p:nvSpPr>
+        <p:spPr>
+          <a:xfrm>
+            <a:off x="6500" y="5178059"/>
+            <a:ext cx="6480000" cy="720000"/>
+          </a:xfrm>
+          <a:prstGeom prst="rect">
+            <a:avLst/>
+          </a:prstGeom>
+          <a:solidFill>
+            <a:schemeClr val="accent5"/>
+          </a:solidFill>
+          <a:ln>
+            <a:noFill/>
+          </a:ln>
+        </p:spPr>
+        <p:style>
+          <a:lnRef idx="2">
+            <a:schemeClr val="accent1">
+              <a:shade val="50000"/>
+            </a:schemeClr>
+          </a:lnRef>
+          <a:fillRef idx="1">
+            <a:schemeClr val="accent1"/>
+          </a:fillRef>
+          <a:effectRef idx="0">
+            <a:schemeClr val="accent1"/>
+          </a:effectRef>
+          <a:fontRef idx="minor">
+            <a:schemeClr val="lt1"/>
+          </a:fontRef>
+        </p:style>
+        <p:txBody>
+          <a:bodyPr rtlCol="0" anchor="ctr"/>
+          <a:lstStyle/>
+          <a:p>
+            <a:pPr algn="ctr"/>
+            <a:r>
+              <a:rPr lang="en-US" altLang="ko-KR" sz="3200" dirty="0" err="1" smtClean="0">
+                <a:latin typeface="나눔스퀘어 Bold" panose="020B0600000101010101" pitchFamily="50" charset="-127"/>
+                <a:ea typeface="나눔스퀘어 Bold" panose="020B0600000101010101" pitchFamily="50" charset="-127"/>
+              </a:rPr>
+              <a:t>AuthenticationProvider</a:t>
+            </a:r>
+            <a:endParaRPr lang="ko-KR" altLang="en-US" sz="3200" dirty="0">
+              <a:latin typeface="나눔스퀘어 Bold" panose="020B0600000101010101" pitchFamily="50" charset="-127"/>
+              <a:ea typeface="나눔스퀘어 Bold" panose="020B0600000101010101" pitchFamily="50" charset="-127"/>
+            </a:endParaRPr>
+          </a:p>
+        </p:txBody>
+      </p:sp>
+      <p:sp>
+        <p:nvSpPr>
+          <p:cNvPr id="79" name="모서리가 둥근 직사각형 78"/>
+          <p:cNvSpPr/>
+          <p:nvPr/>
+        </p:nvSpPr>
+        <p:spPr>
+          <a:xfrm>
+            <a:off x="1896500" y="1401403"/>
+            <a:ext cx="2700000" cy="540000"/>
+          </a:xfrm>
+          <a:prstGeom prst="roundRect">
+            <a:avLst/>
+          </a:prstGeom>
+          <a:solidFill>
+            <a:schemeClr val="bg1"/>
+          </a:solidFill>
+          <a:ln w="19050">
+            <a:solidFill>
+              <a:schemeClr val="tx1"/>
+            </a:solidFill>
+          </a:ln>
+        </p:spPr>
+        <p:style>
+          <a:lnRef idx="2">
+            <a:schemeClr val="accent1">
+              <a:shade val="50000"/>
+            </a:schemeClr>
+          </a:lnRef>
+          <a:fillRef idx="1">
+            <a:schemeClr val="accent1"/>
+          </a:fillRef>
+          <a:effectRef idx="0">
+            <a:schemeClr val="accent1"/>
+          </a:effectRef>
+          <a:fontRef idx="minor">
+            <a:schemeClr val="lt1"/>
+          </a:fontRef>
+        </p:style>
+        <p:txBody>
+          <a:bodyPr rtlCol="0" anchor="ctr"/>
+          <a:lstStyle/>
+          <a:p>
+            <a:pPr algn="ctr"/>
+            <a:r>
+              <a:rPr lang="en-US" altLang="ko-KR" sz="2000" dirty="0" smtClean="0">
+                <a:solidFill>
+                  <a:schemeClr val="tx1"/>
+                </a:solidFill>
+                <a:latin typeface="나눔스퀘어 Bold" panose="020B0600000101010101" pitchFamily="50" charset="-127"/>
+                <a:ea typeface="나눔스퀘어 Bold" panose="020B0600000101010101" pitchFamily="50" charset="-127"/>
+              </a:rPr>
+              <a:t>Spring </a:t>
+            </a:r>
+            <a:r>
+              <a:rPr lang="en-US" altLang="ko-KR" sz="2000" dirty="0" err="1" smtClean="0">
+                <a:solidFill>
+                  <a:schemeClr val="tx1"/>
+                </a:solidFill>
+                <a:latin typeface="나눔스퀘어 Bold" panose="020B0600000101010101" pitchFamily="50" charset="-127"/>
+                <a:ea typeface="나눔스퀘어 Bold" panose="020B0600000101010101" pitchFamily="50" charset="-127"/>
+              </a:rPr>
+              <a:t>IoC</a:t>
+            </a:r>
+            <a:r>
+              <a:rPr lang="en-US" altLang="ko-KR" sz="2000" dirty="0" smtClean="0">
+                <a:solidFill>
+                  <a:schemeClr val="tx1"/>
+                </a:solidFill>
+                <a:latin typeface="나눔스퀘어 Bold" panose="020B0600000101010101" pitchFamily="50" charset="-127"/>
+                <a:ea typeface="나눔스퀘어 Bold" panose="020B0600000101010101" pitchFamily="50" charset="-127"/>
+              </a:rPr>
+              <a:t> Container</a:t>
+            </a:r>
+            <a:endParaRPr lang="ko-KR" altLang="en-US" sz="2000" dirty="0">
+              <a:solidFill>
+                <a:schemeClr val="tx1"/>
+              </a:solidFill>
+              <a:latin typeface="나눔스퀘어 Bold" panose="020B0600000101010101" pitchFamily="50" charset="-127"/>
+              <a:ea typeface="나눔스퀘어 Bold" panose="020B0600000101010101" pitchFamily="50" charset="-127"/>
+            </a:endParaRPr>
+          </a:p>
+        </p:txBody>
+      </p:sp>
+      <p:sp>
+        <p:nvSpPr>
+          <p:cNvPr id="80" name="직사각형 79"/>
+          <p:cNvSpPr/>
+          <p:nvPr/>
+        </p:nvSpPr>
+        <p:spPr>
+          <a:xfrm>
+            <a:off x="6500" y="6555662"/>
+            <a:ext cx="6480000" cy="720000"/>
+          </a:xfrm>
+          <a:prstGeom prst="rect">
+            <a:avLst/>
+          </a:prstGeom>
+          <a:solidFill>
+            <a:schemeClr val="accent5"/>
+          </a:solidFill>
+          <a:ln>
+            <a:noFill/>
+          </a:ln>
+        </p:spPr>
+        <p:style>
+          <a:lnRef idx="2">
+            <a:schemeClr val="accent1">
+              <a:shade val="50000"/>
+            </a:schemeClr>
+          </a:lnRef>
+          <a:fillRef idx="1">
+            <a:schemeClr val="accent1"/>
+          </a:fillRef>
+          <a:effectRef idx="0">
+            <a:schemeClr val="accent1"/>
+          </a:effectRef>
+          <a:fontRef idx="minor">
+            <a:schemeClr val="lt1"/>
+          </a:fontRef>
+        </p:style>
+        <p:txBody>
+          <a:bodyPr rtlCol="0" anchor="ctr"/>
+          <a:lstStyle/>
+          <a:p>
+            <a:pPr algn="ctr"/>
+            <a:r>
+              <a:rPr lang="en-US" altLang="ko-KR" sz="3200" dirty="0" err="1" smtClean="0">
+                <a:latin typeface="나눔스퀘어 Bold" panose="020B0600000101010101" pitchFamily="50" charset="-127"/>
+                <a:ea typeface="나눔스퀘어 Bold" panose="020B0600000101010101" pitchFamily="50" charset="-127"/>
+              </a:rPr>
+              <a:t>UserDetailService</a:t>
+            </a:r>
+            <a:endParaRPr lang="ko-KR" altLang="en-US" sz="3200" dirty="0">
+              <a:latin typeface="나눔스퀘어 Bold" panose="020B0600000101010101" pitchFamily="50" charset="-127"/>
+              <a:ea typeface="나눔스퀘어 Bold" panose="020B0600000101010101" pitchFamily="50" charset="-127"/>
+            </a:endParaRPr>
+          </a:p>
+        </p:txBody>
+      </p:sp>
+      <p:sp>
+        <p:nvSpPr>
+          <p:cNvPr id="81" name="직사각형 80"/>
+          <p:cNvSpPr/>
+          <p:nvPr/>
+        </p:nvSpPr>
+        <p:spPr>
+          <a:xfrm>
+            <a:off x="-353500" y="-4900"/>
+            <a:ext cx="3600000" cy="720000"/>
+          </a:xfrm>
+          <a:prstGeom prst="rect">
+            <a:avLst/>
+          </a:prstGeom>
+          <a:solidFill>
+            <a:schemeClr val="accent5"/>
+          </a:solidFill>
+          <a:ln>
+            <a:noFill/>
+          </a:ln>
+        </p:spPr>
+        <p:style>
+          <a:lnRef idx="2">
+            <a:schemeClr val="accent1">
+              <a:shade val="50000"/>
+            </a:schemeClr>
+          </a:lnRef>
+          <a:fillRef idx="1">
+            <a:schemeClr val="accent1"/>
+          </a:fillRef>
+          <a:effectRef idx="0">
+            <a:schemeClr val="accent1"/>
+          </a:effectRef>
+          <a:fontRef idx="minor">
+            <a:schemeClr val="lt1"/>
+          </a:fontRef>
+        </p:style>
+        <p:txBody>
+          <a:bodyPr rtlCol="0" anchor="ctr"/>
+          <a:lstStyle/>
+          <a:p>
+            <a:pPr algn="ctr"/>
+            <a:r>
+              <a:rPr lang="en-US" altLang="ko-KR" sz="3200" dirty="0" smtClean="0">
+                <a:latin typeface="나눔스퀘어 Bold" panose="020B0600000101010101" pitchFamily="50" charset="-127"/>
+                <a:ea typeface="나눔스퀘어 Bold" panose="020B0600000101010101" pitchFamily="50" charset="-127"/>
+              </a:rPr>
+              <a:t>Client</a:t>
+            </a:r>
+            <a:endParaRPr lang="ko-KR" altLang="en-US" sz="3200" dirty="0">
+              <a:latin typeface="나눔스퀘어 Bold" panose="020B0600000101010101" pitchFamily="50" charset="-127"/>
+              <a:ea typeface="나눔스퀘어 Bold" panose="020B0600000101010101" pitchFamily="50" charset="-127"/>
+            </a:endParaRPr>
+          </a:p>
+        </p:txBody>
+      </p:sp>
+      <p:sp>
+        <p:nvSpPr>
+          <p:cNvPr id="82" name="직사각형 81"/>
+          <p:cNvSpPr/>
+          <p:nvPr/>
+        </p:nvSpPr>
+        <p:spPr>
+          <a:xfrm>
+            <a:off x="4298100" y="-4900"/>
+            <a:ext cx="3600000" cy="720000"/>
+          </a:xfrm>
+          <a:prstGeom prst="rect">
+            <a:avLst/>
+          </a:prstGeom>
+          <a:solidFill>
+            <a:schemeClr val="accent5"/>
+          </a:solidFill>
+          <a:ln>
+            <a:noFill/>
+          </a:ln>
+        </p:spPr>
+        <p:style>
+          <a:lnRef idx="2">
+            <a:schemeClr val="accent1">
+              <a:shade val="50000"/>
+            </a:schemeClr>
+          </a:lnRef>
+          <a:fillRef idx="1">
+            <a:schemeClr val="accent1"/>
+          </a:fillRef>
+          <a:effectRef idx="0">
+            <a:schemeClr val="accent1"/>
+          </a:effectRef>
+          <a:fontRef idx="minor">
+            <a:schemeClr val="lt1"/>
+          </a:fontRef>
+        </p:style>
+        <p:txBody>
+          <a:bodyPr rtlCol="0" anchor="ctr"/>
+          <a:lstStyle/>
+          <a:p>
+            <a:pPr algn="ctr"/>
+            <a:r>
+              <a:rPr lang="en-US" altLang="ko-KR" sz="2400" dirty="0" err="1" smtClean="0">
+                <a:latin typeface="나눔스퀘어 Bold" panose="020B0600000101010101" pitchFamily="50" charset="-127"/>
+                <a:ea typeface="나눔스퀘어 Bold" panose="020B0600000101010101" pitchFamily="50" charset="-127"/>
+              </a:rPr>
+              <a:t>DelegatingFilterProxy</a:t>
+            </a:r>
+            <a:endParaRPr lang="ko-KR" altLang="en-US" sz="2400" dirty="0">
+              <a:latin typeface="나눔스퀘어 Bold" panose="020B0600000101010101" pitchFamily="50" charset="-127"/>
+              <a:ea typeface="나눔스퀘어 Bold" panose="020B0600000101010101" pitchFamily="50" charset="-127"/>
+            </a:endParaRPr>
+          </a:p>
+        </p:txBody>
+      </p:sp>
+      <p:sp>
+        <p:nvSpPr>
+          <p:cNvPr id="83" name="직사각형 82"/>
+          <p:cNvSpPr/>
+          <p:nvPr/>
+        </p:nvSpPr>
+        <p:spPr>
+          <a:xfrm>
+            <a:off x="8949700" y="-4900"/>
+            <a:ext cx="3600000" cy="720000"/>
+          </a:xfrm>
+          <a:prstGeom prst="rect">
+            <a:avLst/>
+          </a:prstGeom>
+          <a:solidFill>
+            <a:schemeClr val="accent5"/>
+          </a:solidFill>
+          <a:ln>
+            <a:noFill/>
+          </a:ln>
+        </p:spPr>
+        <p:style>
+          <a:lnRef idx="2">
+            <a:schemeClr val="accent1">
+              <a:shade val="50000"/>
+            </a:schemeClr>
+          </a:lnRef>
+          <a:fillRef idx="1">
+            <a:schemeClr val="accent1"/>
+          </a:fillRef>
+          <a:effectRef idx="0">
+            <a:schemeClr val="accent1"/>
+          </a:effectRef>
+          <a:fontRef idx="minor">
+            <a:schemeClr val="lt1"/>
+          </a:fontRef>
+        </p:style>
+        <p:txBody>
+          <a:bodyPr rtlCol="0" anchor="ctr"/>
+          <a:lstStyle/>
+          <a:p>
+            <a:pPr algn="ctr"/>
+            <a:r>
+              <a:rPr lang="en-US" altLang="ko-KR" sz="2400" dirty="0" smtClean="0">
+                <a:latin typeface="나눔스퀘어 Bold" panose="020B0600000101010101" pitchFamily="50" charset="-127"/>
+                <a:ea typeface="나눔스퀘어 Bold" panose="020B0600000101010101" pitchFamily="50" charset="-127"/>
+              </a:rPr>
+              <a:t>Spring </a:t>
+            </a:r>
+            <a:r>
+              <a:rPr lang="en-US" altLang="ko-KR" sz="2400" dirty="0" err="1" smtClean="0">
+                <a:latin typeface="나눔스퀘어 Bold" panose="020B0600000101010101" pitchFamily="50" charset="-127"/>
+                <a:ea typeface="나눔스퀘어 Bold" panose="020B0600000101010101" pitchFamily="50" charset="-127"/>
+              </a:rPr>
+              <a:t>IoC</a:t>
+            </a:r>
+            <a:r>
+              <a:rPr lang="en-US" altLang="ko-KR" sz="2400" dirty="0" smtClean="0">
+                <a:latin typeface="나눔스퀘어 Bold" panose="020B0600000101010101" pitchFamily="50" charset="-127"/>
+                <a:ea typeface="나눔스퀘어 Bold" panose="020B0600000101010101" pitchFamily="50" charset="-127"/>
+              </a:rPr>
+              <a:t> Container</a:t>
+            </a:r>
+            <a:endParaRPr lang="ko-KR" altLang="en-US" sz="2400" dirty="0">
+              <a:latin typeface="나눔스퀘어 Bold" panose="020B0600000101010101" pitchFamily="50" charset="-127"/>
+              <a:ea typeface="나눔스퀘어 Bold" panose="020B0600000101010101" pitchFamily="50" charset="-127"/>
+            </a:endParaRPr>
+          </a:p>
+        </p:txBody>
+      </p:sp>
+      <p:cxnSp>
+        <p:nvCxnSpPr>
+          <p:cNvPr id="84" name="직선 화살표 연결선 83"/>
+          <p:cNvCxnSpPr>
+            <a:stCxn id="81" idx="3"/>
+            <a:endCxn id="82" idx="1"/>
+          </p:cNvCxnSpPr>
+          <p:nvPr/>
+        </p:nvCxnSpPr>
+        <p:spPr>
+          <a:xfrm>
+            <a:off x="3246500" y="355100"/>
+            <a:ext cx="1051600" cy="0"/>
+          </a:xfrm>
+          <a:prstGeom prst="straightConnector1">
+            <a:avLst/>
+          </a:prstGeom>
+          <a:ln w="76200">
+            <a:solidFill>
+              <a:schemeClr val="accent2"/>
+            </a:solidFill>
+            <a:tailEnd type="triangle"/>
+          </a:ln>
+        </p:spPr>
+        <p:style>
+          <a:lnRef idx="1">
+            <a:schemeClr val="accent1"/>
+          </a:lnRef>
+          <a:fillRef idx="0">
+            <a:schemeClr val="accent1"/>
+          </a:fillRef>
+          <a:effectRef idx="0">
+            <a:schemeClr val="accent1"/>
+          </a:effectRef>
+          <a:fontRef idx="minor">
+            <a:schemeClr val="tx1"/>
+          </a:fontRef>
+        </p:style>
+      </p:cxnSp>
+      <p:cxnSp>
+        <p:nvCxnSpPr>
+          <p:cNvPr id="85" name="직선 화살표 연결선 84"/>
+          <p:cNvCxnSpPr>
+            <a:stCxn id="82" idx="3"/>
+            <a:endCxn id="83" idx="1"/>
+          </p:cNvCxnSpPr>
+          <p:nvPr/>
+        </p:nvCxnSpPr>
+        <p:spPr>
+          <a:xfrm>
+            <a:off x="7898100" y="355100"/>
+            <a:ext cx="1051600" cy="0"/>
+          </a:xfrm>
+          <a:prstGeom prst="straightConnector1">
+            <a:avLst/>
+          </a:prstGeom>
+          <a:ln w="76200">
+            <a:solidFill>
+              <a:schemeClr val="accent2"/>
+            </a:solidFill>
+            <a:tailEnd type="triangle"/>
+          </a:ln>
+        </p:spPr>
+        <p:style>
+          <a:lnRef idx="1">
+            <a:schemeClr val="accent1"/>
+          </a:lnRef>
+          <a:fillRef idx="0">
+            <a:schemeClr val="accent1"/>
+          </a:fillRef>
+          <a:effectRef idx="0">
+            <a:schemeClr val="accent1"/>
+          </a:effectRef>
+          <a:fontRef idx="minor">
+            <a:schemeClr val="tx1"/>
+          </a:fontRef>
+        </p:style>
+      </p:cxnSp>
+      <p:cxnSp>
+        <p:nvCxnSpPr>
+          <p:cNvPr id="86" name="직선 화살표 연결선 85"/>
+          <p:cNvCxnSpPr>
+            <a:stCxn id="76" idx="2"/>
+            <a:endCxn id="77" idx="0"/>
+          </p:cNvCxnSpPr>
+          <p:nvPr/>
+        </p:nvCxnSpPr>
+        <p:spPr>
+          <a:xfrm>
+            <a:off x="3246500" y="3142853"/>
+            <a:ext cx="0" cy="657603"/>
+          </a:xfrm>
+          <a:prstGeom prst="straightConnector1">
+            <a:avLst/>
+          </a:prstGeom>
+          <a:ln w="76200">
+            <a:solidFill>
+              <a:schemeClr val="accent2"/>
+            </a:solidFill>
+            <a:tailEnd type="triangle"/>
+          </a:ln>
+        </p:spPr>
+        <p:style>
+          <a:lnRef idx="1">
+            <a:schemeClr val="accent1"/>
+          </a:lnRef>
+          <a:fillRef idx="0">
+            <a:schemeClr val="accent1"/>
+          </a:fillRef>
+          <a:effectRef idx="0">
+            <a:schemeClr val="accent1"/>
+          </a:effectRef>
+          <a:fontRef idx="minor">
+            <a:schemeClr val="tx1"/>
+          </a:fontRef>
+        </p:style>
+      </p:cxnSp>
+      <p:cxnSp>
+        <p:nvCxnSpPr>
+          <p:cNvPr id="87" name="직선 화살표 연결선 86"/>
+          <p:cNvCxnSpPr>
+            <a:stCxn id="77" idx="2"/>
+            <a:endCxn id="78" idx="0"/>
+          </p:cNvCxnSpPr>
+          <p:nvPr/>
+        </p:nvCxnSpPr>
+        <p:spPr>
+          <a:xfrm>
+            <a:off x="3246500" y="4520456"/>
+            <a:ext cx="0" cy="657603"/>
+          </a:xfrm>
+          <a:prstGeom prst="straightConnector1">
+            <a:avLst/>
+          </a:prstGeom>
+          <a:ln w="76200">
+            <a:solidFill>
+              <a:schemeClr val="accent2"/>
+            </a:solidFill>
+            <a:tailEnd type="triangle"/>
+          </a:ln>
+        </p:spPr>
+        <p:style>
+          <a:lnRef idx="1">
+            <a:schemeClr val="accent1"/>
+          </a:lnRef>
+          <a:fillRef idx="0">
+            <a:schemeClr val="accent1"/>
+          </a:fillRef>
+          <a:effectRef idx="0">
+            <a:schemeClr val="accent1"/>
+          </a:effectRef>
+          <a:fontRef idx="minor">
+            <a:schemeClr val="tx1"/>
+          </a:fontRef>
+        </p:style>
+      </p:cxnSp>
+      <p:cxnSp>
+        <p:nvCxnSpPr>
+          <p:cNvPr id="88" name="직선 화살표 연결선 87"/>
+          <p:cNvCxnSpPr>
+            <a:stCxn id="78" idx="2"/>
+            <a:endCxn id="80" idx="0"/>
+          </p:cNvCxnSpPr>
+          <p:nvPr/>
+        </p:nvCxnSpPr>
+        <p:spPr>
+          <a:xfrm>
+            <a:off x="3246500" y="5898059"/>
+            <a:ext cx="0" cy="657603"/>
+          </a:xfrm>
+          <a:prstGeom prst="straightConnector1">
+            <a:avLst/>
+          </a:prstGeom>
+          <a:ln w="76200">
+            <a:solidFill>
+              <a:schemeClr val="accent2"/>
+            </a:solidFill>
+            <a:tailEnd type="triangle"/>
+          </a:ln>
+        </p:spPr>
+        <p:style>
+          <a:lnRef idx="1">
+            <a:schemeClr val="accent1"/>
+          </a:lnRef>
+          <a:fillRef idx="0">
+            <a:schemeClr val="accent1"/>
+          </a:fillRef>
+          <a:effectRef idx="0">
+            <a:schemeClr val="accent1"/>
+          </a:effectRef>
+          <a:fontRef idx="minor">
+            <a:schemeClr val="tx1"/>
+          </a:fontRef>
+        </p:style>
+      </p:cxnSp>
+      <p:sp>
+        <p:nvSpPr>
+          <p:cNvPr id="89" name="직사각형 88"/>
+          <p:cNvSpPr/>
+          <p:nvPr/>
+        </p:nvSpPr>
+        <p:spPr>
+          <a:xfrm>
+            <a:off x="6500" y="7931827"/>
+            <a:ext cx="6480000" cy="720000"/>
+          </a:xfrm>
+          <a:prstGeom prst="rect">
+            <a:avLst/>
+          </a:prstGeom>
+          <a:solidFill>
+            <a:schemeClr val="accent5"/>
+          </a:solidFill>
+          <a:ln>
+            <a:noFill/>
+          </a:ln>
+        </p:spPr>
+        <p:style>
+          <a:lnRef idx="2">
+            <a:schemeClr val="accent1">
+              <a:shade val="50000"/>
+            </a:schemeClr>
+          </a:lnRef>
+          <a:fillRef idx="1">
+            <a:schemeClr val="accent1"/>
+          </a:fillRef>
+          <a:effectRef idx="0">
+            <a:schemeClr val="accent1"/>
+          </a:effectRef>
+          <a:fontRef idx="minor">
+            <a:schemeClr val="lt1"/>
+          </a:fontRef>
+        </p:style>
+        <p:txBody>
+          <a:bodyPr rtlCol="0" anchor="ctr"/>
+          <a:lstStyle/>
+          <a:p>
+            <a:pPr algn="ctr"/>
+            <a:r>
+              <a:rPr lang="en-US" altLang="ko-KR" sz="3200" dirty="0" err="1" smtClean="0">
+                <a:latin typeface="나눔스퀘어 Bold" panose="020B0600000101010101" pitchFamily="50" charset="-127"/>
+                <a:ea typeface="나눔스퀘어 Bold" panose="020B0600000101010101" pitchFamily="50" charset="-127"/>
+              </a:rPr>
+              <a:t>DispatcherSevlet</a:t>
+            </a:r>
+            <a:endParaRPr lang="ko-KR" altLang="en-US" sz="3200" dirty="0">
+              <a:latin typeface="나눔스퀘어 Bold" panose="020B0600000101010101" pitchFamily="50" charset="-127"/>
+              <a:ea typeface="나눔스퀘어 Bold" panose="020B0600000101010101" pitchFamily="50" charset="-127"/>
+            </a:endParaRPr>
+          </a:p>
+        </p:txBody>
+      </p:sp>
+      <p:cxnSp>
+        <p:nvCxnSpPr>
+          <p:cNvPr id="90" name="직선 화살표 연결선 89"/>
+          <p:cNvCxnSpPr>
+            <a:stCxn id="80" idx="2"/>
+            <a:endCxn id="89" idx="0"/>
+          </p:cNvCxnSpPr>
+          <p:nvPr/>
+        </p:nvCxnSpPr>
+        <p:spPr>
+          <a:xfrm>
+            <a:off x="3246500" y="7275662"/>
+            <a:ext cx="0" cy="656165"/>
+          </a:xfrm>
+          <a:prstGeom prst="straightConnector1">
+            <a:avLst/>
+          </a:prstGeom>
+          <a:ln w="76200">
+            <a:solidFill>
+              <a:schemeClr val="accent2"/>
+            </a:solidFill>
+            <a:tailEnd type="triangle"/>
+          </a:ln>
+        </p:spPr>
+        <p:style>
+          <a:lnRef idx="1">
+            <a:schemeClr val="accent1"/>
+          </a:lnRef>
+          <a:fillRef idx="0">
+            <a:schemeClr val="accent1"/>
+          </a:fillRef>
+          <a:effectRef idx="0">
+            <a:schemeClr val="accent1"/>
+          </a:effectRef>
+          <a:fontRef idx="minor">
+            <a:schemeClr val="tx1"/>
+          </a:fontRef>
+        </p:style>
+      </p:cxnSp>
+      <p:sp>
+        <p:nvSpPr>
+          <p:cNvPr id="91" name="직사각형 90"/>
+          <p:cNvSpPr/>
+          <p:nvPr/>
+        </p:nvSpPr>
+        <p:spPr>
+          <a:xfrm>
+            <a:off x="7628250" y="7930389"/>
+            <a:ext cx="6480000" cy="1800000"/>
+          </a:xfrm>
+          <a:prstGeom prst="rect">
+            <a:avLst/>
+          </a:prstGeom>
+          <a:solidFill>
+            <a:schemeClr val="accent5"/>
+          </a:solidFill>
+          <a:ln>
+            <a:noFill/>
+          </a:ln>
+        </p:spPr>
+        <p:style>
+          <a:lnRef idx="2">
+            <a:schemeClr val="accent1">
+              <a:shade val="50000"/>
+            </a:schemeClr>
+          </a:lnRef>
+          <a:fillRef idx="1">
+            <a:schemeClr val="accent1"/>
+          </a:fillRef>
+          <a:effectRef idx="0">
+            <a:schemeClr val="accent1"/>
+          </a:effectRef>
+          <a:fontRef idx="minor">
+            <a:schemeClr val="lt1"/>
+          </a:fontRef>
+        </p:style>
+        <p:txBody>
+          <a:bodyPr rtlCol="0" anchor="ctr"/>
+          <a:lstStyle/>
+          <a:p>
+            <a:pPr algn="ctr"/>
+            <a:r>
+              <a:rPr lang="en-US" altLang="ko-KR" sz="2800" dirty="0" err="1" smtClean="0">
+                <a:latin typeface="나눔스퀘어 Bold" panose="020B0600000101010101" pitchFamily="50" charset="-127"/>
+                <a:ea typeface="나눔스퀘어 Bold" panose="020B0600000101010101" pitchFamily="50" charset="-127"/>
+              </a:rPr>
+              <a:t>SecurityContextHolder</a:t>
+            </a:r>
+            <a:endParaRPr lang="en-US" altLang="ko-KR" sz="2800" dirty="0" smtClean="0">
+              <a:latin typeface="나눔스퀘어 Bold" panose="020B0600000101010101" pitchFamily="50" charset="-127"/>
+              <a:ea typeface="나눔스퀘어 Bold" panose="020B0600000101010101" pitchFamily="50" charset="-127"/>
+            </a:endParaRPr>
+          </a:p>
+          <a:p>
+            <a:pPr algn="ctr"/>
+            <a:endParaRPr lang="en-US" altLang="ko-KR" sz="2800" dirty="0">
+              <a:latin typeface="나눔스퀘어 Bold" panose="020B0600000101010101" pitchFamily="50" charset="-127"/>
+              <a:ea typeface="나눔스퀘어 Bold" panose="020B0600000101010101" pitchFamily="50" charset="-127"/>
+            </a:endParaRPr>
+          </a:p>
+          <a:p>
+            <a:pPr algn="ctr"/>
+            <a:endParaRPr lang="en-US" altLang="ko-KR" sz="2400" dirty="0" smtClean="0">
+              <a:latin typeface="나눔스퀘어 Bold" panose="020B0600000101010101" pitchFamily="50" charset="-127"/>
+              <a:ea typeface="나눔스퀘어 Bold" panose="020B0600000101010101" pitchFamily="50" charset="-127"/>
+            </a:endParaRPr>
+          </a:p>
+          <a:p>
+            <a:pPr algn="ctr"/>
+            <a:endParaRPr lang="en-US" altLang="ko-KR" sz="2000" dirty="0" smtClean="0">
+              <a:latin typeface="나눔스퀘어 Bold" panose="020B0600000101010101" pitchFamily="50" charset="-127"/>
+              <a:ea typeface="나눔스퀘어 Bold" panose="020B0600000101010101" pitchFamily="50" charset="-127"/>
+            </a:endParaRPr>
+          </a:p>
+        </p:txBody>
+      </p:sp>
+      <p:sp>
+        <p:nvSpPr>
+          <p:cNvPr id="93" name="직사각형 92"/>
+          <p:cNvSpPr/>
+          <p:nvPr/>
+        </p:nvSpPr>
+        <p:spPr>
+          <a:xfrm>
+            <a:off x="8322000" y="8650389"/>
+            <a:ext cx="5040000" cy="720000"/>
+          </a:xfrm>
+          <a:prstGeom prst="rect">
+            <a:avLst/>
+          </a:prstGeom>
+          <a:solidFill>
+            <a:schemeClr val="accent1"/>
+          </a:solidFill>
+          <a:ln>
+            <a:noFill/>
+          </a:ln>
+        </p:spPr>
+        <p:style>
+          <a:lnRef idx="2">
+            <a:schemeClr val="accent1">
+              <a:shade val="50000"/>
+            </a:schemeClr>
+          </a:lnRef>
+          <a:fillRef idx="1">
+            <a:schemeClr val="accent1"/>
+          </a:fillRef>
+          <a:effectRef idx="0">
+            <a:schemeClr val="accent1"/>
+          </a:effectRef>
+          <a:fontRef idx="minor">
+            <a:schemeClr val="lt1"/>
+          </a:fontRef>
+        </p:style>
+        <p:txBody>
+          <a:bodyPr rtlCol="0" anchor="ctr"/>
+          <a:lstStyle/>
+          <a:p>
+            <a:pPr algn="ctr"/>
+            <a:r>
+              <a:rPr lang="en-US" altLang="ko-KR" sz="3600" dirty="0">
+                <a:latin typeface="나눔스퀘어 Bold" panose="020B0600000101010101" pitchFamily="50" charset="-127"/>
+                <a:ea typeface="나눔스퀘어 Bold" panose="020B0600000101010101" pitchFamily="50" charset="-127"/>
+              </a:rPr>
+              <a:t>Principal</a:t>
+            </a:r>
+            <a:endParaRPr lang="ko-KR" altLang="en-US" sz="3600" dirty="0">
+              <a:latin typeface="나눔스퀘어 Bold" panose="020B0600000101010101" pitchFamily="50" charset="-127"/>
+              <a:ea typeface="나눔스퀘어 Bold" panose="020B0600000101010101" pitchFamily="50" charset="-127"/>
+            </a:endParaRPr>
+          </a:p>
+        </p:txBody>
+      </p:sp>
+      <p:cxnSp>
+        <p:nvCxnSpPr>
+          <p:cNvPr id="94" name="직선 화살표 연결선 93"/>
+          <p:cNvCxnSpPr>
+            <a:endCxn id="42" idx="0"/>
+          </p:cNvCxnSpPr>
+          <p:nvPr/>
+        </p:nvCxnSpPr>
+        <p:spPr>
+          <a:xfrm>
+            <a:off x="10866150" y="3142853"/>
+            <a:ext cx="0" cy="657603"/>
+          </a:xfrm>
+          <a:prstGeom prst="straightConnector1">
+            <a:avLst/>
+          </a:prstGeom>
+          <a:ln w="76200">
+            <a:solidFill>
+              <a:schemeClr val="accent2"/>
+            </a:solidFill>
+            <a:tailEnd type="triangle"/>
+          </a:ln>
+        </p:spPr>
+        <p:style>
+          <a:lnRef idx="1">
+            <a:schemeClr val="accent1"/>
+          </a:lnRef>
+          <a:fillRef idx="0">
+            <a:schemeClr val="accent1"/>
+          </a:fillRef>
+          <a:effectRef idx="0">
+            <a:schemeClr val="accent1"/>
+          </a:effectRef>
+          <a:fontRef idx="minor">
+            <a:schemeClr val="tx1"/>
+          </a:fontRef>
+        </p:style>
+      </p:cxnSp>
+      <p:cxnSp>
+        <p:nvCxnSpPr>
+          <p:cNvPr id="97" name="직선 화살표 연결선 96"/>
+          <p:cNvCxnSpPr>
+            <a:stCxn id="42" idx="2"/>
+            <a:endCxn id="41" idx="0"/>
+          </p:cNvCxnSpPr>
+          <p:nvPr/>
+        </p:nvCxnSpPr>
+        <p:spPr>
+          <a:xfrm>
+            <a:off x="10866150" y="4520456"/>
+            <a:ext cx="0" cy="657603"/>
+          </a:xfrm>
+          <a:prstGeom prst="straightConnector1">
+            <a:avLst/>
+          </a:prstGeom>
+          <a:ln w="76200">
+            <a:solidFill>
+              <a:schemeClr val="accent2"/>
+            </a:solidFill>
+            <a:tailEnd type="triangle"/>
+          </a:ln>
+        </p:spPr>
+        <p:style>
+          <a:lnRef idx="1">
+            <a:schemeClr val="accent1"/>
+          </a:lnRef>
+          <a:fillRef idx="0">
+            <a:schemeClr val="accent1"/>
+          </a:fillRef>
+          <a:effectRef idx="0">
+            <a:schemeClr val="accent1"/>
+          </a:effectRef>
+          <a:fontRef idx="minor">
+            <a:schemeClr val="tx1"/>
+          </a:fontRef>
+        </p:style>
+      </p:cxnSp>
+      <p:cxnSp>
+        <p:nvCxnSpPr>
+          <p:cNvPr id="100" name="직선 화살표 연결선 99"/>
+          <p:cNvCxnSpPr>
+            <a:stCxn id="41" idx="2"/>
+            <a:endCxn id="40" idx="0"/>
+          </p:cNvCxnSpPr>
+          <p:nvPr/>
+        </p:nvCxnSpPr>
+        <p:spPr>
+          <a:xfrm>
+            <a:off x="10866150" y="5898059"/>
+            <a:ext cx="0" cy="656165"/>
+          </a:xfrm>
+          <a:prstGeom prst="straightConnector1">
+            <a:avLst/>
+          </a:prstGeom>
+          <a:ln w="76200">
+            <a:solidFill>
+              <a:schemeClr val="accent2"/>
+            </a:solidFill>
+            <a:tailEnd type="triangle"/>
+          </a:ln>
+        </p:spPr>
+        <p:style>
+          <a:lnRef idx="1">
+            <a:schemeClr val="accent1"/>
+          </a:lnRef>
+          <a:fillRef idx="0">
+            <a:schemeClr val="accent1"/>
+          </a:fillRef>
+          <a:effectRef idx="0">
+            <a:schemeClr val="accent1"/>
+          </a:effectRef>
+          <a:fontRef idx="minor">
+            <a:schemeClr val="tx1"/>
+          </a:fontRef>
+        </p:style>
+      </p:cxnSp>
+      <p:cxnSp>
+        <p:nvCxnSpPr>
+          <p:cNvPr id="104" name="직선 화살표 연결선 103"/>
+          <p:cNvCxnSpPr>
+            <a:stCxn id="40" idx="2"/>
+            <a:endCxn id="91" idx="0"/>
+          </p:cNvCxnSpPr>
+          <p:nvPr/>
+        </p:nvCxnSpPr>
+        <p:spPr>
+          <a:xfrm>
+            <a:off x="10866150" y="7274224"/>
+            <a:ext cx="2100" cy="656165"/>
+          </a:xfrm>
+          <a:prstGeom prst="straightConnector1">
+            <a:avLst/>
+          </a:prstGeom>
+          <a:ln w="76200">
+            <a:solidFill>
+              <a:schemeClr val="accent2"/>
+            </a:solidFill>
+            <a:tailEnd type="triangle"/>
+          </a:ln>
+        </p:spPr>
+        <p:style>
+          <a:lnRef idx="1">
+            <a:schemeClr val="accent1"/>
+          </a:lnRef>
+          <a:fillRef idx="0">
+            <a:schemeClr val="accent1"/>
+          </a:fillRef>
+          <a:effectRef idx="0">
+            <a:schemeClr val="accent1"/>
+          </a:effectRef>
+          <a:fontRef idx="minor">
+            <a:schemeClr val="tx1"/>
+          </a:fontRef>
+        </p:style>
+      </p:cxnSp>
+      <p:sp>
+        <p:nvSpPr>
+          <p:cNvPr id="109" name="직사각형 108"/>
+          <p:cNvSpPr/>
+          <p:nvPr/>
+        </p:nvSpPr>
+        <p:spPr>
+          <a:xfrm>
+            <a:off x="7266150" y="1761402"/>
+            <a:ext cx="7200000" cy="8280000"/>
+          </a:xfrm>
+          <a:prstGeom prst="rect">
+            <a:avLst/>
+          </a:prstGeom>
+          <a:noFill/>
+          <a:ln w="19050">
+            <a:solidFill>
+              <a:schemeClr val="tx1"/>
+            </a:solidFill>
+          </a:ln>
+        </p:spPr>
+        <p:style>
+          <a:lnRef idx="2">
+            <a:schemeClr val="accent1">
+              <a:shade val="50000"/>
+            </a:schemeClr>
+          </a:lnRef>
+          <a:fillRef idx="1">
+            <a:schemeClr val="accent1"/>
+          </a:fillRef>
+          <a:effectRef idx="0">
+            <a:schemeClr val="accent1"/>
+          </a:effectRef>
+          <a:fontRef idx="minor">
+            <a:schemeClr val="lt1"/>
+          </a:fontRef>
+        </p:style>
+        <p:txBody>
+          <a:bodyPr rtlCol="0" anchor="ctr"/>
+          <a:lstStyle/>
+          <a:p>
+            <a:pPr algn="ctr"/>
+            <a:endParaRPr lang="ko-KR" altLang="en-US"/>
+          </a:p>
+        </p:txBody>
+      </p:sp>
+      <p:sp>
+        <p:nvSpPr>
+          <p:cNvPr id="2" name="TextBox 1"/>
+          <p:cNvSpPr txBox="1"/>
+          <p:nvPr/>
+        </p:nvSpPr>
+        <p:spPr>
+          <a:xfrm>
+            <a:off x="3469973" y="-6009"/>
+            <a:ext cx="604653" cy="369332"/>
+          </a:xfrm>
+          <a:prstGeom prst="rect">
+            <a:avLst/>
+          </a:prstGeom>
+          <a:noFill/>
+        </p:spPr>
+        <p:txBody>
+          <a:bodyPr wrap="none" rtlCol="0">
+            <a:spAutoFit/>
+          </a:bodyPr>
+          <a:lstStyle/>
+          <a:p>
+            <a:r>
+              <a:rPr lang="ko-KR" altLang="en-US" dirty="0" smtClean="0">
+                <a:latin typeface="나눔스퀘어 Bold" panose="020B0600000101010101" pitchFamily="50" charset="-127"/>
+                <a:ea typeface="나눔스퀘어 Bold" panose="020B0600000101010101" pitchFamily="50" charset="-127"/>
+              </a:rPr>
+              <a:t>요청</a:t>
+            </a:r>
+            <a:endParaRPr lang="ko-KR" altLang="en-US" dirty="0">
+              <a:latin typeface="나눔스퀘어 Bold" panose="020B0600000101010101" pitchFamily="50" charset="-127"/>
+              <a:ea typeface="나눔스퀘어 Bold" panose="020B0600000101010101" pitchFamily="50" charset="-127"/>
+            </a:endParaRPr>
+          </a:p>
+        </p:txBody>
+      </p:sp>
+      <p:sp>
+        <p:nvSpPr>
+          <p:cNvPr id="31" name="TextBox 30"/>
+          <p:cNvSpPr txBox="1"/>
+          <p:nvPr/>
+        </p:nvSpPr>
+        <p:spPr>
+          <a:xfrm>
+            <a:off x="8121573" y="-6009"/>
+            <a:ext cx="604653" cy="369332"/>
+          </a:xfrm>
+          <a:prstGeom prst="rect">
+            <a:avLst/>
+          </a:prstGeom>
+          <a:noFill/>
+        </p:spPr>
+        <p:txBody>
+          <a:bodyPr wrap="none" rtlCol="0">
+            <a:spAutoFit/>
+          </a:bodyPr>
+          <a:lstStyle/>
+          <a:p>
+            <a:r>
+              <a:rPr lang="ko-KR" altLang="en-US" dirty="0" smtClean="0">
+                <a:latin typeface="나눔스퀘어 Bold" panose="020B0600000101010101" pitchFamily="50" charset="-127"/>
+                <a:ea typeface="나눔스퀘어 Bold" panose="020B0600000101010101" pitchFamily="50" charset="-127"/>
+              </a:rPr>
+              <a:t>위임</a:t>
+            </a:r>
+            <a:endParaRPr lang="ko-KR" altLang="en-US" dirty="0">
+              <a:latin typeface="나눔스퀘어 Bold" panose="020B0600000101010101" pitchFamily="50" charset="-127"/>
+              <a:ea typeface="나눔스퀘어 Bold" panose="020B0600000101010101" pitchFamily="50" charset="-127"/>
+            </a:endParaRPr>
+          </a:p>
+        </p:txBody>
+      </p:sp>
+      <p:sp>
+        <p:nvSpPr>
+          <p:cNvPr id="37" name="직사각형 36"/>
+          <p:cNvSpPr/>
+          <p:nvPr/>
+        </p:nvSpPr>
+        <p:spPr>
+          <a:xfrm>
+            <a:off x="4118100" y="-235572"/>
+            <a:ext cx="3960000" cy="1116000"/>
+          </a:xfrm>
+          <a:prstGeom prst="rect">
+            <a:avLst/>
+          </a:prstGeom>
+          <a:noFill/>
+          <a:ln w="19050">
+            <a:solidFill>
+              <a:schemeClr val="tx1"/>
+            </a:solidFill>
+          </a:ln>
+        </p:spPr>
+        <p:style>
+          <a:lnRef idx="2">
+            <a:schemeClr val="accent1">
+              <a:shade val="50000"/>
+            </a:schemeClr>
+          </a:lnRef>
+          <a:fillRef idx="1">
+            <a:schemeClr val="accent1"/>
+          </a:fillRef>
+          <a:effectRef idx="0">
+            <a:schemeClr val="accent1"/>
+          </a:effectRef>
+          <a:fontRef idx="minor">
+            <a:schemeClr val="lt1"/>
+          </a:fontRef>
+        </p:style>
+        <p:txBody>
+          <a:bodyPr rtlCol="0" anchor="ctr"/>
+          <a:lstStyle/>
+          <a:p>
+            <a:pPr algn="ctr"/>
+            <a:endParaRPr lang="ko-KR" altLang="en-US"/>
+          </a:p>
+        </p:txBody>
+      </p:sp>
+      <p:sp>
+        <p:nvSpPr>
+          <p:cNvPr id="38" name="모서리가 둥근 직사각형 37"/>
+          <p:cNvSpPr/>
+          <p:nvPr/>
+        </p:nvSpPr>
+        <p:spPr>
+          <a:xfrm>
+            <a:off x="4748100" y="-497158"/>
+            <a:ext cx="1440000" cy="432000"/>
+          </a:xfrm>
+          <a:prstGeom prst="roundRect">
+            <a:avLst/>
+          </a:prstGeom>
+          <a:solidFill>
+            <a:schemeClr val="bg1"/>
+          </a:solidFill>
+          <a:ln w="19050">
+            <a:solidFill>
+              <a:schemeClr val="tx1"/>
+            </a:solidFill>
+          </a:ln>
+        </p:spPr>
+        <p:style>
+          <a:lnRef idx="2">
+            <a:schemeClr val="accent1">
+              <a:shade val="50000"/>
+            </a:schemeClr>
+          </a:lnRef>
+          <a:fillRef idx="1">
+            <a:schemeClr val="accent1"/>
+          </a:fillRef>
+          <a:effectRef idx="0">
+            <a:schemeClr val="accent1"/>
+          </a:effectRef>
+          <a:fontRef idx="minor">
+            <a:schemeClr val="lt1"/>
+          </a:fontRef>
+        </p:style>
+        <p:txBody>
+          <a:bodyPr rtlCol="0" anchor="ctr"/>
+          <a:lstStyle/>
+          <a:p>
+            <a:pPr algn="ctr"/>
+            <a:r>
+              <a:rPr lang="ko-KR" altLang="en-US" sz="2000" dirty="0" smtClean="0">
+                <a:solidFill>
+                  <a:schemeClr val="tx1"/>
+                </a:solidFill>
+                <a:latin typeface="나눔스퀘어 Bold" panose="020B0600000101010101" pitchFamily="50" charset="-127"/>
+                <a:ea typeface="나눔스퀘어 Bold" panose="020B0600000101010101" pitchFamily="50" charset="-127"/>
+              </a:rPr>
+              <a:t>필터</a:t>
+            </a:r>
+            <a:r>
+              <a:rPr lang="en-US" altLang="ko-KR" sz="2000" dirty="0" smtClean="0">
+                <a:solidFill>
+                  <a:schemeClr val="tx1"/>
+                </a:solidFill>
+                <a:latin typeface="나눔스퀘어 Bold" panose="020B0600000101010101" pitchFamily="50" charset="-127"/>
+                <a:ea typeface="나눔스퀘어 Bold" panose="020B0600000101010101" pitchFamily="50" charset="-127"/>
+              </a:rPr>
+              <a:t> </a:t>
+            </a:r>
+            <a:r>
+              <a:rPr lang="ko-KR" altLang="en-US" sz="2000" dirty="0" smtClean="0">
+                <a:solidFill>
+                  <a:schemeClr val="tx1"/>
+                </a:solidFill>
+                <a:latin typeface="나눔스퀘어 Bold" panose="020B0600000101010101" pitchFamily="50" charset="-127"/>
+                <a:ea typeface="나눔스퀘어 Bold" panose="020B0600000101010101" pitchFamily="50" charset="-127"/>
+              </a:rPr>
+              <a:t>체인</a:t>
+            </a:r>
+            <a:endParaRPr lang="ko-KR" altLang="en-US" sz="2000" dirty="0">
+              <a:solidFill>
+                <a:schemeClr val="tx1"/>
+              </a:solidFill>
+              <a:latin typeface="나눔스퀘어 Bold" panose="020B0600000101010101" pitchFamily="50" charset="-127"/>
+              <a:ea typeface="나눔스퀘어 Bold" panose="020B0600000101010101" pitchFamily="50" charset="-127"/>
+            </a:endParaRPr>
+          </a:p>
+        </p:txBody>
+      </p:sp>
+      <p:sp>
+        <p:nvSpPr>
+          <p:cNvPr id="39" name="모서리가 둥근 직사각형 38"/>
+          <p:cNvSpPr/>
+          <p:nvPr/>
+        </p:nvSpPr>
+        <p:spPr>
+          <a:xfrm>
+            <a:off x="6893899" y="-1015825"/>
+            <a:ext cx="3060000" cy="432000"/>
+          </a:xfrm>
+          <a:prstGeom prst="roundRect">
+            <a:avLst/>
+          </a:prstGeom>
+          <a:solidFill>
+            <a:schemeClr val="bg1"/>
+          </a:solidFill>
+          <a:ln w="19050">
+            <a:solidFill>
+              <a:schemeClr val="tx1"/>
+            </a:solidFill>
+          </a:ln>
+        </p:spPr>
+        <p:style>
+          <a:lnRef idx="2">
+            <a:schemeClr val="accent1">
+              <a:shade val="50000"/>
+            </a:schemeClr>
+          </a:lnRef>
+          <a:fillRef idx="1">
+            <a:schemeClr val="accent1"/>
+          </a:fillRef>
+          <a:effectRef idx="0">
+            <a:schemeClr val="accent1"/>
+          </a:effectRef>
+          <a:fontRef idx="minor">
+            <a:schemeClr val="lt1"/>
+          </a:fontRef>
+        </p:style>
+        <p:txBody>
+          <a:bodyPr rtlCol="0" anchor="ctr"/>
+          <a:lstStyle/>
+          <a:p>
+            <a:pPr algn="ctr"/>
+            <a:r>
+              <a:rPr lang="ko-KR" altLang="en-US" sz="2000" dirty="0" err="1" smtClean="0">
+                <a:solidFill>
+                  <a:schemeClr val="tx1"/>
+                </a:solidFill>
+                <a:latin typeface="나눔스퀘어 Bold" panose="020B0600000101010101" pitchFamily="50" charset="-127"/>
+                <a:ea typeface="나눔스퀘어 Bold" panose="020B0600000101010101" pitchFamily="50" charset="-127"/>
+              </a:rPr>
+              <a:t>서블릿</a:t>
+            </a:r>
+            <a:r>
+              <a:rPr lang="ko-KR" altLang="en-US" sz="2000" dirty="0" smtClean="0">
+                <a:solidFill>
+                  <a:schemeClr val="tx1"/>
+                </a:solidFill>
+                <a:latin typeface="나눔스퀘어 Bold" panose="020B0600000101010101" pitchFamily="50" charset="-127"/>
+                <a:ea typeface="나눔스퀘어 Bold" panose="020B0600000101010101" pitchFamily="50" charset="-127"/>
+              </a:rPr>
+              <a:t> 컨테이너</a:t>
+            </a:r>
+            <a:r>
+              <a:rPr lang="en-US" altLang="ko-KR" sz="2000" dirty="0" smtClean="0">
+                <a:solidFill>
+                  <a:schemeClr val="tx1"/>
+                </a:solidFill>
+                <a:latin typeface="나눔스퀘어 Bold" panose="020B0600000101010101" pitchFamily="50" charset="-127"/>
+                <a:ea typeface="나눔스퀘어 Bold" panose="020B0600000101010101" pitchFamily="50" charset="-127"/>
+              </a:rPr>
+              <a:t>(Tomcat)</a:t>
+            </a:r>
+            <a:endParaRPr lang="ko-KR" altLang="en-US" sz="2000" dirty="0">
+              <a:solidFill>
+                <a:schemeClr val="tx1"/>
+              </a:solidFill>
+              <a:latin typeface="나눔스퀘어 Bold" panose="020B0600000101010101" pitchFamily="50" charset="-127"/>
+              <a:ea typeface="나눔스퀘어 Bold" panose="020B0600000101010101" pitchFamily="50" charset="-127"/>
+            </a:endParaRPr>
+          </a:p>
+        </p:txBody>
+      </p:sp>
+    </p:spTree>
+    <p:extLst>
+      <p:ext uri="{BB962C8B-B14F-4D97-AF65-F5344CB8AC3E}">
+        <p14:creationId xmlns:p14="http://schemas.microsoft.com/office/powerpoint/2010/main" val="128690120"/>
+      </p:ext>
+    </p:extLst>
+  </p:cSld>
+  <p:clrMapOvr>
+    <a:masterClrMapping/>
+  </p:clrMapOvr>
+  <p:timing>
+    <p:tnLst>
+      <p:par>
+        <p:cTn id="1" dur="indefinite" restart="never" nodeType="tmRoot"/>
+      </p:par>
+    </p:tnLst>
+  </p:timing>
+</p:sld>
+</file>
+
+<file path=ppt/slides/slide4.xml><?xml version="1.0" encoding="utf-8"?>
+<p:sld xmlns:a="http://schemas.openxmlformats.org/drawingml/2006/main" xmlns:r="http://schemas.openxmlformats.org/officeDocument/2006/relationships" xmlns:p="http://schemas.openxmlformats.org/presentationml/2006/main">
+  <p:cSld>
+    <p:spTree>
+      <p:nvGrpSpPr>
+        <p:cNvPr id="1" name=""/>
+        <p:cNvGrpSpPr/>
+        <p:nvPr/>
+      </p:nvGrpSpPr>
+      <p:grpSpPr>
+        <a:xfrm>
+          <a:off x="0" y="0"/>
+          <a:ext cx="0" cy="0"/>
+          <a:chOff x="0" y="0"/>
+          <a:chExt cx="0" cy="0"/>
+        </a:xfrm>
+      </p:grpSpPr>
+      <p:sp>
+        <p:nvSpPr>
           <p:cNvPr id="81" name="직사각형 80"/>
           <p:cNvSpPr>
             <a:spLocks noChangeAspect="1"/>
@@ -8394,7 +11939,7 @@
 </p:sld>
 </file>
 
-<file path=ppt/slides/slide3.xml><?xml version="1.0" encoding="utf-8"?>
+<file path=ppt/slides/slide5.xml><?xml version="1.0" encoding="utf-8"?>
 <p:sld xmlns:a="http://schemas.openxmlformats.org/drawingml/2006/main" xmlns:r="http://schemas.openxmlformats.org/officeDocument/2006/relationships" xmlns:p="http://schemas.openxmlformats.org/presentationml/2006/main">
   <p:cSld>
     <p:spTree>

</xml_diff>

<commit_message>
20260918 commit : 2_class
</commit_message>
<xml_diff>
--- a/notion/create_notion_img.pptx
+++ b/notion/create_notion_img.pptx
@@ -5,11 +5,10 @@
     <p:sldMasterId id="2147483648" r:id="rId1"/>
   </p:sldMasterIdLst>
   <p:sldIdLst>
-    <p:sldId id="256" r:id="rId2"/>
-    <p:sldId id="261" r:id="rId3"/>
-    <p:sldId id="262" r:id="rId4"/>
-    <p:sldId id="259" r:id="rId5"/>
-    <p:sldId id="257" r:id="rId6"/>
+    <p:sldId id="260" r:id="rId2"/>
+    <p:sldId id="256" r:id="rId3"/>
+    <p:sldId id="259" r:id="rId4"/>
+    <p:sldId id="257" r:id="rId5"/>
   </p:sldIdLst>
   <p:sldSz cx="12192000" cy="6858000"/>
   <p:notesSz cx="6858000" cy="9144000"/>
@@ -247,7 +246,7 @@
           <a:p>
             <a:fld id="{7237CE1A-8831-48B5-BA93-72483C6E34E8}" type="datetimeFigureOut">
               <a:rPr lang="ko-KR" altLang="en-US" smtClean="0"/>
-              <a:t>2026-09-17</a:t>
+              <a:t>2026-09-18</a:t>
             </a:fld>
             <a:endParaRPr lang="ko-KR" altLang="en-US"/>
           </a:p>
@@ -417,7 +416,7 @@
           <a:p>
             <a:fld id="{7237CE1A-8831-48B5-BA93-72483C6E34E8}" type="datetimeFigureOut">
               <a:rPr lang="ko-KR" altLang="en-US" smtClean="0"/>
-              <a:t>2026-09-17</a:t>
+              <a:t>2026-09-18</a:t>
             </a:fld>
             <a:endParaRPr lang="ko-KR" altLang="en-US"/>
           </a:p>
@@ -597,7 +596,7 @@
           <a:p>
             <a:fld id="{7237CE1A-8831-48B5-BA93-72483C6E34E8}" type="datetimeFigureOut">
               <a:rPr lang="ko-KR" altLang="en-US" smtClean="0"/>
-              <a:t>2026-09-17</a:t>
+              <a:t>2026-09-18</a:t>
             </a:fld>
             <a:endParaRPr lang="ko-KR" altLang="en-US"/>
           </a:p>
@@ -767,7 +766,7 @@
           <a:p>
             <a:fld id="{7237CE1A-8831-48B5-BA93-72483C6E34E8}" type="datetimeFigureOut">
               <a:rPr lang="ko-KR" altLang="en-US" smtClean="0"/>
-              <a:t>2026-09-17</a:t>
+              <a:t>2026-09-18</a:t>
             </a:fld>
             <a:endParaRPr lang="ko-KR" altLang="en-US"/>
           </a:p>
@@ -1013,7 +1012,7 @@
           <a:p>
             <a:fld id="{7237CE1A-8831-48B5-BA93-72483C6E34E8}" type="datetimeFigureOut">
               <a:rPr lang="ko-KR" altLang="en-US" smtClean="0"/>
-              <a:t>2026-09-17</a:t>
+              <a:t>2026-09-18</a:t>
             </a:fld>
             <a:endParaRPr lang="ko-KR" altLang="en-US"/>
           </a:p>
@@ -1245,7 +1244,7 @@
           <a:p>
             <a:fld id="{7237CE1A-8831-48B5-BA93-72483C6E34E8}" type="datetimeFigureOut">
               <a:rPr lang="ko-KR" altLang="en-US" smtClean="0"/>
-              <a:t>2026-09-17</a:t>
+              <a:t>2026-09-18</a:t>
             </a:fld>
             <a:endParaRPr lang="ko-KR" altLang="en-US"/>
           </a:p>
@@ -1612,7 +1611,7 @@
           <a:p>
             <a:fld id="{7237CE1A-8831-48B5-BA93-72483C6E34E8}" type="datetimeFigureOut">
               <a:rPr lang="ko-KR" altLang="en-US" smtClean="0"/>
-              <a:t>2026-09-17</a:t>
+              <a:t>2026-09-18</a:t>
             </a:fld>
             <a:endParaRPr lang="ko-KR" altLang="en-US"/>
           </a:p>
@@ -1730,7 +1729,7 @@
           <a:p>
             <a:fld id="{7237CE1A-8831-48B5-BA93-72483C6E34E8}" type="datetimeFigureOut">
               <a:rPr lang="ko-KR" altLang="en-US" smtClean="0"/>
-              <a:t>2026-09-17</a:t>
+              <a:t>2026-09-18</a:t>
             </a:fld>
             <a:endParaRPr lang="ko-KR" altLang="en-US"/>
           </a:p>
@@ -1825,7 +1824,7 @@
           <a:p>
             <a:fld id="{7237CE1A-8831-48B5-BA93-72483C6E34E8}" type="datetimeFigureOut">
               <a:rPr lang="ko-KR" altLang="en-US" smtClean="0"/>
-              <a:t>2026-09-17</a:t>
+              <a:t>2026-09-18</a:t>
             </a:fld>
             <a:endParaRPr lang="ko-KR" altLang="en-US"/>
           </a:p>
@@ -2102,7 +2101,7 @@
           <a:p>
             <a:fld id="{7237CE1A-8831-48B5-BA93-72483C6E34E8}" type="datetimeFigureOut">
               <a:rPr lang="ko-KR" altLang="en-US" smtClean="0"/>
-              <a:t>2026-09-17</a:t>
+              <a:t>2026-09-18</a:t>
             </a:fld>
             <a:endParaRPr lang="ko-KR" altLang="en-US"/>
           </a:p>
@@ -2355,7 +2354,7 @@
           <a:p>
             <a:fld id="{7237CE1A-8831-48B5-BA93-72483C6E34E8}" type="datetimeFigureOut">
               <a:rPr lang="ko-KR" altLang="en-US" smtClean="0"/>
-              <a:t>2026-09-17</a:t>
+              <a:t>2026-09-18</a:t>
             </a:fld>
             <a:endParaRPr lang="ko-KR" altLang="en-US"/>
           </a:p>
@@ -2568,7 +2567,7 @@
           <a:p>
             <a:fld id="{7237CE1A-8831-48B5-BA93-72483C6E34E8}" type="datetimeFigureOut">
               <a:rPr lang="ko-KR" altLang="en-US" smtClean="0"/>
-              <a:t>2026-09-17</a:t>
+              <a:t>2026-09-18</a:t>
             </a:fld>
             <a:endParaRPr lang="ko-KR" altLang="en-US"/>
           </a:p>
@@ -2975,24 +2974,18 @@
       </p:grpSpPr>
       <p:sp>
         <p:nvSpPr>
-          <p:cNvPr id="76" name="직사각형 75"/>
+          <p:cNvPr id="2" name="직사각형 1"/>
           <p:cNvSpPr/>
           <p:nvPr/>
         </p:nvSpPr>
         <p:spPr>
           <a:xfrm>
-            <a:off x="6500" y="2422853"/>
-            <a:ext cx="6480000" cy="720000"/>
-          </a:xfrm>
-          <a:prstGeom prst="rect">
-            <a:avLst/>
-          </a:prstGeom>
-          <a:solidFill>
-            <a:schemeClr val="accent5"/>
-          </a:solidFill>
-          <a:ln>
-            <a:noFill/>
-          </a:ln>
+            <a:off x="781050" y="323850"/>
+            <a:ext cx="3009900" cy="1200150"/>
+          </a:xfrm>
+          <a:prstGeom prst="rect">
+            <a:avLst/>
+          </a:prstGeom>
         </p:spPr>
         <p:style>
           <a:lnRef idx="2">
@@ -3016,39 +3009,27 @@
           <a:p>
             <a:pPr algn="ctr"/>
             <a:r>
-              <a:rPr lang="en-US" altLang="ko-KR" sz="2400" dirty="0" err="1" smtClean="0">
-                <a:latin typeface="나눔스퀘어 Bold" panose="020B0600000101010101" pitchFamily="50" charset="-127"/>
-                <a:ea typeface="나눔스퀘어 Bold" panose="020B0600000101010101" pitchFamily="50" charset="-127"/>
-              </a:rPr>
-              <a:t>UsernamePasswordAuththenticationFilter</a:t>
-            </a:r>
-            <a:endParaRPr lang="ko-KR" altLang="en-US" sz="2800" dirty="0">
-              <a:latin typeface="나눔스퀘어 Bold" panose="020B0600000101010101" pitchFamily="50" charset="-127"/>
-              <a:ea typeface="나눔스퀘어 Bold" panose="020B0600000101010101" pitchFamily="50" charset="-127"/>
-            </a:endParaRPr>
-          </a:p>
-        </p:txBody>
-      </p:sp>
-      <p:sp>
-        <p:nvSpPr>
-          <p:cNvPr id="77" name="직사각형 76"/>
+              <a:rPr lang="en-US" altLang="ko-KR" dirty="0" smtClean="0"/>
+              <a:t>client</a:t>
+            </a:r>
+            <a:endParaRPr lang="ko-KR" altLang="en-US" dirty="0"/>
+          </a:p>
+        </p:txBody>
+      </p:sp>
+      <p:sp>
+        <p:nvSpPr>
+          <p:cNvPr id="205" name="직사각형 204"/>
           <p:cNvSpPr/>
           <p:nvPr/>
         </p:nvSpPr>
         <p:spPr>
           <a:xfrm>
-            <a:off x="6500" y="3800456"/>
-            <a:ext cx="6480000" cy="720000"/>
-          </a:xfrm>
-          <a:prstGeom prst="rect">
-            <a:avLst/>
-          </a:prstGeom>
-          <a:solidFill>
-            <a:schemeClr val="accent5"/>
-          </a:solidFill>
-          <a:ln>
-            <a:noFill/>
-          </a:ln>
+            <a:off x="8477250" y="323850"/>
+            <a:ext cx="3009900" cy="1200150"/>
+          </a:xfrm>
+          <a:prstGeom prst="rect">
+            <a:avLst/>
+          </a:prstGeom>
         </p:spPr>
         <p:style>
           <a:lnRef idx="2">
@@ -3072,152 +3053,28 @@
           <a:p>
             <a:pPr algn="ctr"/>
             <a:r>
-              <a:rPr lang="en-US" altLang="ko-KR" sz="3200" dirty="0" err="1" smtClean="0">
-                <a:latin typeface="나눔스퀘어 Bold" panose="020B0600000101010101" pitchFamily="50" charset="-127"/>
-                <a:ea typeface="나눔스퀘어 Bold" panose="020B0600000101010101" pitchFamily="50" charset="-127"/>
-              </a:rPr>
-              <a:t>AuthenticationManager</a:t>
-            </a:r>
-            <a:endParaRPr lang="ko-KR" altLang="en-US" sz="3200" dirty="0">
-              <a:latin typeface="나눔스퀘어 Bold" panose="020B0600000101010101" pitchFamily="50" charset="-127"/>
-              <a:ea typeface="나눔스퀘어 Bold" panose="020B0600000101010101" pitchFamily="50" charset="-127"/>
-            </a:endParaRPr>
-          </a:p>
-        </p:txBody>
-      </p:sp>
-      <p:sp>
-        <p:nvSpPr>
-          <p:cNvPr id="78" name="직사각형 77"/>
-          <p:cNvSpPr/>
-          <p:nvPr/>
-        </p:nvSpPr>
-        <p:spPr>
-          <a:xfrm>
-            <a:off x="6500" y="5178059"/>
-            <a:ext cx="6480000" cy="720000"/>
-          </a:xfrm>
-          <a:prstGeom prst="rect">
-            <a:avLst/>
-          </a:prstGeom>
-          <a:solidFill>
-            <a:schemeClr val="accent5"/>
-          </a:solidFill>
-          <a:ln>
-            <a:noFill/>
-          </a:ln>
-        </p:spPr>
-        <p:style>
-          <a:lnRef idx="2">
-            <a:schemeClr val="accent1">
-              <a:shade val="50000"/>
-            </a:schemeClr>
-          </a:lnRef>
-          <a:fillRef idx="1">
-            <a:schemeClr val="accent1"/>
-          </a:fillRef>
-          <a:effectRef idx="0">
-            <a:schemeClr val="accent1"/>
-          </a:effectRef>
-          <a:fontRef idx="minor">
-            <a:schemeClr val="lt1"/>
-          </a:fontRef>
-        </p:style>
-        <p:txBody>
-          <a:bodyPr rtlCol="0" anchor="ctr"/>
-          <a:lstStyle/>
-          <a:p>
-            <a:pPr algn="ctr"/>
-            <a:r>
-              <a:rPr lang="en-US" altLang="ko-KR" sz="3200" dirty="0" err="1" smtClean="0">
-                <a:latin typeface="나눔스퀘어 Bold" panose="020B0600000101010101" pitchFamily="50" charset="-127"/>
-                <a:ea typeface="나눔스퀘어 Bold" panose="020B0600000101010101" pitchFamily="50" charset="-127"/>
-              </a:rPr>
-              <a:t>AuthenticationProvider</a:t>
-            </a:r>
-            <a:endParaRPr lang="ko-KR" altLang="en-US" sz="3200" dirty="0">
-              <a:latin typeface="나눔스퀘어 Bold" panose="020B0600000101010101" pitchFamily="50" charset="-127"/>
-              <a:ea typeface="나눔스퀘어 Bold" panose="020B0600000101010101" pitchFamily="50" charset="-127"/>
-            </a:endParaRPr>
-          </a:p>
-        </p:txBody>
-      </p:sp>
-      <p:sp>
-        <p:nvSpPr>
-          <p:cNvPr id="80" name="직사각형 79"/>
-          <p:cNvSpPr/>
-          <p:nvPr/>
-        </p:nvSpPr>
-        <p:spPr>
-          <a:xfrm>
-            <a:off x="6500" y="6555662"/>
-            <a:ext cx="6480000" cy="720000"/>
-          </a:xfrm>
-          <a:prstGeom prst="rect">
-            <a:avLst/>
-          </a:prstGeom>
-          <a:solidFill>
-            <a:schemeClr val="accent5"/>
-          </a:solidFill>
-          <a:ln>
-            <a:noFill/>
-          </a:ln>
-        </p:spPr>
-        <p:style>
-          <a:lnRef idx="2">
-            <a:schemeClr val="accent1">
-              <a:shade val="50000"/>
-            </a:schemeClr>
-          </a:lnRef>
-          <a:fillRef idx="1">
-            <a:schemeClr val="accent1"/>
-          </a:fillRef>
-          <a:effectRef idx="0">
-            <a:schemeClr val="accent1"/>
-          </a:effectRef>
-          <a:fontRef idx="minor">
-            <a:schemeClr val="lt1"/>
-          </a:fontRef>
-        </p:style>
-        <p:txBody>
-          <a:bodyPr rtlCol="0" anchor="ctr"/>
-          <a:lstStyle/>
-          <a:p>
-            <a:pPr algn="ctr"/>
-            <a:r>
-              <a:rPr lang="en-US" altLang="ko-KR" sz="3200" dirty="0" err="1" smtClean="0">
-                <a:latin typeface="나눔스퀘어 Bold" panose="020B0600000101010101" pitchFamily="50" charset="-127"/>
-                <a:ea typeface="나눔스퀘어 Bold" panose="020B0600000101010101" pitchFamily="50" charset="-127"/>
-              </a:rPr>
-              <a:t>UserDetailService</a:t>
-            </a:r>
-            <a:endParaRPr lang="ko-KR" altLang="en-US" sz="3200" dirty="0">
-              <a:latin typeface="나눔스퀘어 Bold" panose="020B0600000101010101" pitchFamily="50" charset="-127"/>
-              <a:ea typeface="나눔스퀘어 Bold" panose="020B0600000101010101" pitchFamily="50" charset="-127"/>
-            </a:endParaRPr>
+              <a:rPr lang="en-US" altLang="ko-KR" dirty="0" smtClean="0"/>
+              <a:t>server</a:t>
+            </a:r>
+            <a:endParaRPr lang="ko-KR" altLang="en-US" dirty="0"/>
           </a:p>
         </p:txBody>
       </p:sp>
       <p:cxnSp>
         <p:nvCxnSpPr>
-          <p:cNvPr id="86" name="직선 화살표 연결선 85"/>
-          <p:cNvCxnSpPr>
-            <a:stCxn id="76" idx="2"/>
-            <a:endCxn id="77" idx="0"/>
-          </p:cNvCxnSpPr>
+          <p:cNvPr id="4" name="직선 화살표 연결선 3"/>
+          <p:cNvCxnSpPr/>
           <p:nvPr/>
         </p:nvCxnSpPr>
         <p:spPr>
-          <a:xfrm>
-            <a:off x="3246500" y="3142853"/>
-            <a:ext cx="0" cy="657603"/>
+          <a:xfrm flipV="1">
+            <a:off x="4095750" y="476250"/>
+            <a:ext cx="3714750" cy="57150"/>
           </a:xfrm>
           <a:prstGeom prst="straightConnector1">
             <a:avLst/>
           </a:prstGeom>
-          <a:ln w="76200">
-            <a:solidFill>
-              <a:schemeClr val="accent2"/>
-            </a:solidFill>
+          <a:ln>
             <a:tailEnd type="triangle"/>
           </a:ln>
         </p:spPr>
@@ -3238,25 +3095,19 @@
       </p:cxnSp>
       <p:cxnSp>
         <p:nvCxnSpPr>
-          <p:cNvPr id="87" name="직선 화살표 연결선 86"/>
-          <p:cNvCxnSpPr>
-            <a:stCxn id="77" idx="2"/>
-            <a:endCxn id="78" idx="0"/>
-          </p:cNvCxnSpPr>
+          <p:cNvPr id="206" name="직선 화살표 연결선 205"/>
+          <p:cNvCxnSpPr/>
           <p:nvPr/>
         </p:nvCxnSpPr>
         <p:spPr>
-          <a:xfrm>
-            <a:off x="3246500" y="4520456"/>
-            <a:ext cx="0" cy="657603"/>
+          <a:xfrm flipH="1">
+            <a:off x="4457700" y="1066800"/>
+            <a:ext cx="3524250" cy="95250"/>
           </a:xfrm>
           <a:prstGeom prst="straightConnector1">
             <a:avLst/>
           </a:prstGeom>
-          <a:ln w="76200">
-            <a:solidFill>
-              <a:schemeClr val="accent2"/>
-            </a:solidFill>
+          <a:ln>
             <a:tailEnd type="triangle"/>
           </a:ln>
         </p:spPr>
@@ -3275,111 +3126,16 @@
           </a:fontRef>
         </p:style>
       </p:cxnSp>
-      <p:cxnSp>
-        <p:nvCxnSpPr>
-          <p:cNvPr id="88" name="직선 화살표 연결선 87"/>
-          <p:cNvCxnSpPr>
-            <a:stCxn id="78" idx="2"/>
-            <a:endCxn id="80" idx="0"/>
-          </p:cNvCxnSpPr>
-          <p:nvPr/>
-        </p:nvCxnSpPr>
-        <p:spPr>
-          <a:xfrm>
-            <a:off x="3246500" y="5898059"/>
-            <a:ext cx="0" cy="657603"/>
-          </a:xfrm>
-          <a:prstGeom prst="straightConnector1">
-            <a:avLst/>
-          </a:prstGeom>
-          <a:ln w="76200">
-            <a:solidFill>
-              <a:schemeClr val="accent2"/>
-            </a:solidFill>
-            <a:tailEnd type="triangle"/>
-          </a:ln>
-        </p:spPr>
-        <p:style>
-          <a:lnRef idx="1">
-            <a:schemeClr val="accent1"/>
-          </a:lnRef>
-          <a:fillRef idx="0">
-            <a:schemeClr val="accent1"/>
-          </a:fillRef>
-          <a:effectRef idx="0">
-            <a:schemeClr val="accent1"/>
-          </a:effectRef>
-          <a:fontRef idx="minor">
-            <a:schemeClr val="tx1"/>
-          </a:fontRef>
-        </p:style>
-      </p:cxnSp>
-      <p:sp>
-        <p:nvSpPr>
-          <p:cNvPr id="89" name="직사각형 88"/>
-          <p:cNvSpPr/>
-          <p:nvPr/>
-        </p:nvSpPr>
-        <p:spPr>
-          <a:xfrm>
-            <a:off x="3606500" y="7933265"/>
-            <a:ext cx="2880000" cy="720000"/>
-          </a:xfrm>
-          <a:prstGeom prst="rect">
-            <a:avLst/>
-          </a:prstGeom>
-          <a:solidFill>
-            <a:schemeClr val="accent5"/>
-          </a:solidFill>
-          <a:ln>
-            <a:noFill/>
-          </a:ln>
-        </p:spPr>
-        <p:style>
-          <a:lnRef idx="2">
-            <a:schemeClr val="accent1">
-              <a:shade val="50000"/>
-            </a:schemeClr>
-          </a:lnRef>
-          <a:fillRef idx="1">
-            <a:schemeClr val="accent1"/>
-          </a:fillRef>
-          <a:effectRef idx="0">
-            <a:schemeClr val="accent1"/>
-          </a:effectRef>
-          <a:fontRef idx="minor">
-            <a:schemeClr val="lt1"/>
-          </a:fontRef>
-        </p:style>
-        <p:txBody>
-          <a:bodyPr rtlCol="0" anchor="ctr"/>
-          <a:lstStyle/>
-          <a:p>
-            <a:pPr algn="ctr"/>
-            <a:r>
-              <a:rPr lang="en-US" altLang="ko-KR" sz="2400" dirty="0" err="1" smtClean="0">
-                <a:latin typeface="나눔스퀘어 Bold" panose="020B0600000101010101" pitchFamily="50" charset="-127"/>
-                <a:ea typeface="나눔스퀘어 Bold" panose="020B0600000101010101" pitchFamily="50" charset="-127"/>
-              </a:rPr>
-              <a:t>DispatcherSevlet</a:t>
-            </a:r>
-            <a:endParaRPr lang="ko-KR" altLang="en-US" sz="2400" dirty="0">
-              <a:latin typeface="나눔스퀘어 Bold" panose="020B0600000101010101" pitchFamily="50" charset="-127"/>
-              <a:ea typeface="나눔스퀘어 Bold" panose="020B0600000101010101" pitchFamily="50" charset="-127"/>
-            </a:endParaRPr>
-          </a:p>
-        </p:txBody>
-      </p:sp>
-      <p:sp>
-        <p:nvSpPr>
-          <p:cNvPr id="110" name="TextBox 109"/>
+      <p:sp>
+        <p:nvSpPr>
+          <p:cNvPr id="7" name="TextBox 6"/>
           <p:cNvSpPr txBox="1"/>
           <p:nvPr/>
         </p:nvSpPr>
         <p:spPr>
           <a:xfrm>
-            <a:off x="3468627" y="3286269"/>
-            <a:ext cx="2255746" cy="369332"/>
+            <a:off x="5653071" y="154543"/>
+            <a:ext cx="962058" cy="369332"/>
           </a:xfrm>
           <a:prstGeom prst="rect">
             <a:avLst/>
@@ -3393,36 +3149,23 @@
           <a:lstStyle/>
           <a:p>
             <a:r>
-              <a:rPr lang="en-US" altLang="ko-KR" dirty="0" smtClean="0">
-                <a:latin typeface="나눔스퀘어 Bold" panose="020B0600000101010101" pitchFamily="50" charset="-127"/>
-                <a:ea typeface="나눔스퀘어 Bold" panose="020B0600000101010101" pitchFamily="50" charset="-127"/>
-              </a:rPr>
-              <a:t>Authentication </a:t>
-            </a:r>
-            <a:r>
-              <a:rPr lang="ko-KR" altLang="en-US" dirty="0" smtClean="0">
-                <a:latin typeface="나눔스퀘어 Bold" panose="020B0600000101010101" pitchFamily="50" charset="-127"/>
-                <a:ea typeface="나눔스퀘어 Bold" panose="020B0600000101010101" pitchFamily="50" charset="-127"/>
-              </a:rPr>
-              <a:t>전달</a:t>
-            </a:r>
-            <a:endParaRPr lang="ko-KR" altLang="en-US" dirty="0">
-              <a:latin typeface="나눔스퀘어 Bold" panose="020B0600000101010101" pitchFamily="50" charset="-127"/>
-              <a:ea typeface="나눔스퀘어 Bold" panose="020B0600000101010101" pitchFamily="50" charset="-127"/>
-            </a:endParaRPr>
-          </a:p>
-        </p:txBody>
-      </p:sp>
-      <p:sp>
-        <p:nvSpPr>
-          <p:cNvPr id="112" name="TextBox 111"/>
+              <a:rPr lang="en-US" altLang="ko-KR" dirty="0" smtClean="0"/>
+              <a:t>request</a:t>
+            </a:r>
+            <a:endParaRPr lang="ko-KR" altLang="en-US" dirty="0"/>
+          </a:p>
+        </p:txBody>
+      </p:sp>
+      <p:sp>
+        <p:nvSpPr>
+          <p:cNvPr id="207" name="TextBox 206"/>
           <p:cNvSpPr txBox="1"/>
           <p:nvPr/>
         </p:nvSpPr>
         <p:spPr>
           <a:xfrm>
-            <a:off x="3468627" y="4663872"/>
-            <a:ext cx="1588833" cy="369332"/>
+            <a:off x="5661050" y="1154668"/>
+            <a:ext cx="1117550" cy="369332"/>
           </a:xfrm>
           <a:prstGeom prst="rect">
             <a:avLst/>
@@ -3436,36 +3179,23 @@
           <a:lstStyle/>
           <a:p>
             <a:r>
-              <a:rPr lang="en-US" altLang="ko-KR" dirty="0" smtClean="0">
-                <a:latin typeface="나눔스퀘어 Bold" panose="020B0600000101010101" pitchFamily="50" charset="-127"/>
-                <a:ea typeface="나눔스퀘어 Bold" panose="020B0600000101010101" pitchFamily="50" charset="-127"/>
-              </a:rPr>
-              <a:t>Provider </a:t>
-            </a:r>
-            <a:r>
-              <a:rPr lang="ko-KR" altLang="en-US" dirty="0" smtClean="0">
-                <a:latin typeface="나눔스퀘어 Bold" panose="020B0600000101010101" pitchFamily="50" charset="-127"/>
-                <a:ea typeface="나눔스퀘어 Bold" panose="020B0600000101010101" pitchFamily="50" charset="-127"/>
-              </a:rPr>
-              <a:t>선택</a:t>
-            </a:r>
-            <a:endParaRPr lang="ko-KR" altLang="en-US" dirty="0">
-              <a:latin typeface="나눔스퀘어 Bold" panose="020B0600000101010101" pitchFamily="50" charset="-127"/>
-              <a:ea typeface="나눔스퀘어 Bold" panose="020B0600000101010101" pitchFamily="50" charset="-127"/>
-            </a:endParaRPr>
-          </a:p>
-        </p:txBody>
-      </p:sp>
-      <p:sp>
-        <p:nvSpPr>
-          <p:cNvPr id="113" name="TextBox 112"/>
+              <a:rPr lang="en-US" altLang="ko-KR" dirty="0" smtClean="0"/>
+              <a:t>response</a:t>
+            </a:r>
+            <a:endParaRPr lang="ko-KR" altLang="en-US" dirty="0"/>
+          </a:p>
+        </p:txBody>
+      </p:sp>
+      <p:sp>
+        <p:nvSpPr>
+          <p:cNvPr id="208" name="TextBox 207"/>
           <p:cNvSpPr txBox="1"/>
           <p:nvPr/>
         </p:nvSpPr>
         <p:spPr>
           <a:xfrm>
-            <a:off x="3468627" y="6042194"/>
-            <a:ext cx="1864613" cy="369332"/>
+            <a:off x="5524500" y="-247650"/>
+            <a:ext cx="962058" cy="369332"/>
           </a:xfrm>
           <a:prstGeom prst="rect">
             <a:avLst/>
@@ -3479,386 +3209,23 @@
           <a:lstStyle/>
           <a:p>
             <a:r>
-              <a:rPr lang="en-US" altLang="ko-KR" dirty="0" smtClean="0">
-                <a:latin typeface="나눔스퀘어 Bold" panose="020B0600000101010101" pitchFamily="50" charset="-127"/>
-                <a:ea typeface="나눔스퀘어 Bold" panose="020B0600000101010101" pitchFamily="50" charset="-127"/>
-              </a:rPr>
-              <a:t>DB</a:t>
-            </a:r>
-            <a:r>
-              <a:rPr lang="ko-KR" altLang="en-US" dirty="0" smtClean="0">
-                <a:latin typeface="나눔스퀘어 Bold" panose="020B0600000101010101" pitchFamily="50" charset="-127"/>
-                <a:ea typeface="나눔스퀘어 Bold" panose="020B0600000101010101" pitchFamily="50" charset="-127"/>
-              </a:rPr>
-              <a:t>정보 조회 지시</a:t>
-            </a:r>
-            <a:endParaRPr lang="ko-KR" altLang="en-US" dirty="0">
-              <a:latin typeface="나눔스퀘어 Bold" panose="020B0600000101010101" pitchFamily="50" charset="-127"/>
-              <a:ea typeface="나눔스퀘어 Bold" panose="020B0600000101010101" pitchFamily="50" charset="-127"/>
-            </a:endParaRPr>
-          </a:p>
-        </p:txBody>
-      </p:sp>
-      <p:sp>
-        <p:nvSpPr>
-          <p:cNvPr id="114" name="TextBox 113"/>
-          <p:cNvSpPr txBox="1"/>
-          <p:nvPr/>
-        </p:nvSpPr>
-        <p:spPr>
-          <a:xfrm>
-            <a:off x="506712" y="7419797"/>
-            <a:ext cx="1386918" cy="369332"/>
-          </a:xfrm>
-          <a:prstGeom prst="rect">
-            <a:avLst/>
-          </a:prstGeom>
-          <a:noFill/>
-        </p:spPr>
-        <p:txBody>
-          <a:bodyPr wrap="none" rtlCol="0">
-            <a:spAutoFit/>
-          </a:bodyPr>
-          <a:lstStyle/>
-          <a:p>
-            <a:r>
-              <a:rPr lang="en-US" altLang="ko-KR" dirty="0" smtClean="0">
-                <a:latin typeface="나눔스퀘어 Bold" panose="020B0600000101010101" pitchFamily="50" charset="-127"/>
-                <a:ea typeface="나눔스퀘어 Bold" panose="020B0600000101010101" pitchFamily="50" charset="-127"/>
-              </a:rPr>
-              <a:t>DB</a:t>
-            </a:r>
-            <a:r>
-              <a:rPr lang="ko-KR" altLang="en-US" dirty="0" smtClean="0">
-                <a:latin typeface="나눔스퀘어 Bold" panose="020B0600000101010101" pitchFamily="50" charset="-127"/>
-                <a:ea typeface="나눔스퀘어 Bold" panose="020B0600000101010101" pitchFamily="50" charset="-127"/>
-              </a:rPr>
-              <a:t>정보 조회</a:t>
-            </a:r>
-            <a:endParaRPr lang="ko-KR" altLang="en-US" dirty="0">
-              <a:latin typeface="나눔스퀘어 Bold" panose="020B0600000101010101" pitchFamily="50" charset="-127"/>
-              <a:ea typeface="나눔스퀘어 Bold" panose="020B0600000101010101" pitchFamily="50" charset="-127"/>
-            </a:endParaRPr>
-          </a:p>
-        </p:txBody>
-      </p:sp>
-      <p:sp>
-        <p:nvSpPr>
-          <p:cNvPr id="115" name="TextBox 114"/>
-          <p:cNvSpPr txBox="1"/>
-          <p:nvPr/>
-        </p:nvSpPr>
-        <p:spPr>
-          <a:xfrm>
-            <a:off x="4641265" y="7419797"/>
-            <a:ext cx="1082348" cy="369332"/>
-          </a:xfrm>
-          <a:prstGeom prst="rect">
-            <a:avLst/>
-          </a:prstGeom>
-          <a:noFill/>
-        </p:spPr>
-        <p:txBody>
-          <a:bodyPr wrap="none" rtlCol="0">
-            <a:spAutoFit/>
-          </a:bodyPr>
-          <a:lstStyle/>
-          <a:p>
-            <a:r>
-              <a:rPr lang="ko-KR" altLang="en-US" dirty="0" smtClean="0">
-                <a:latin typeface="나눔스퀘어 Bold" panose="020B0600000101010101" pitchFamily="50" charset="-127"/>
-                <a:ea typeface="나눔스퀘어 Bold" panose="020B0600000101010101" pitchFamily="50" charset="-127"/>
-              </a:rPr>
-              <a:t>요청 전달</a:t>
-            </a:r>
-            <a:endParaRPr lang="ko-KR" altLang="en-US" dirty="0">
-              <a:latin typeface="나눔스퀘어 Bold" panose="020B0600000101010101" pitchFamily="50" charset="-127"/>
-              <a:ea typeface="나눔스퀘어 Bold" panose="020B0600000101010101" pitchFamily="50" charset="-127"/>
-            </a:endParaRPr>
-          </a:p>
-        </p:txBody>
-      </p:sp>
-      <p:sp>
-        <p:nvSpPr>
-          <p:cNvPr id="116" name="직사각형 115"/>
-          <p:cNvSpPr/>
-          <p:nvPr/>
-        </p:nvSpPr>
-        <p:spPr>
-          <a:xfrm>
-            <a:off x="6500" y="7933265"/>
-            <a:ext cx="2880000" cy="720000"/>
-          </a:xfrm>
-          <a:prstGeom prst="rect">
-            <a:avLst/>
-          </a:prstGeom>
-          <a:solidFill>
-            <a:schemeClr val="accent5"/>
-          </a:solidFill>
-          <a:ln>
-            <a:noFill/>
-          </a:ln>
-        </p:spPr>
-        <p:style>
-          <a:lnRef idx="2">
-            <a:schemeClr val="accent1">
-              <a:shade val="50000"/>
-            </a:schemeClr>
-          </a:lnRef>
-          <a:fillRef idx="1">
-            <a:schemeClr val="accent1"/>
-          </a:fillRef>
-          <a:effectRef idx="0">
-            <a:schemeClr val="accent1"/>
-          </a:effectRef>
-          <a:fontRef idx="minor">
-            <a:schemeClr val="lt1"/>
-          </a:fontRef>
-        </p:style>
-        <p:txBody>
-          <a:bodyPr rtlCol="0" anchor="ctr"/>
-          <a:lstStyle/>
-          <a:p>
-            <a:pPr algn="ctr"/>
-            <a:r>
-              <a:rPr lang="en-US" altLang="ko-KR" sz="3200" dirty="0" smtClean="0">
-                <a:latin typeface="나눔스퀘어 Bold" panose="020B0600000101010101" pitchFamily="50" charset="-127"/>
-                <a:ea typeface="나눔스퀘어 Bold" panose="020B0600000101010101" pitchFamily="50" charset="-127"/>
-              </a:rPr>
-              <a:t>DB</a:t>
-            </a:r>
-            <a:endParaRPr lang="ko-KR" altLang="en-US" sz="3200" dirty="0">
-              <a:latin typeface="나눔스퀘어 Bold" panose="020B0600000101010101" pitchFamily="50" charset="-127"/>
-              <a:ea typeface="나눔스퀘어 Bold" panose="020B0600000101010101" pitchFamily="50" charset="-127"/>
-            </a:endParaRPr>
-          </a:p>
-        </p:txBody>
-      </p:sp>
-      <p:sp>
-        <p:nvSpPr>
-          <p:cNvPr id="118" name="직사각형 117"/>
-          <p:cNvSpPr/>
-          <p:nvPr/>
-        </p:nvSpPr>
-        <p:spPr>
-          <a:xfrm>
-            <a:off x="-353500" y="1761402"/>
-            <a:ext cx="7200000" cy="7200000"/>
-          </a:xfrm>
-          <a:prstGeom prst="rect">
-            <a:avLst/>
-          </a:prstGeom>
-          <a:noFill/>
-          <a:ln w="19050">
-            <a:solidFill>
-              <a:schemeClr val="tx1"/>
-            </a:solidFill>
-          </a:ln>
-        </p:spPr>
-        <p:style>
-          <a:lnRef idx="2">
-            <a:schemeClr val="accent1">
-              <a:shade val="50000"/>
-            </a:schemeClr>
-          </a:lnRef>
-          <a:fillRef idx="1">
-            <a:schemeClr val="accent1"/>
-          </a:fillRef>
-          <a:effectRef idx="0">
-            <a:schemeClr val="accent1"/>
-          </a:effectRef>
-          <a:fontRef idx="minor">
-            <a:schemeClr val="lt1"/>
-          </a:fontRef>
-        </p:style>
-        <p:txBody>
-          <a:bodyPr rtlCol="0" anchor="ctr"/>
-          <a:lstStyle/>
-          <a:p>
-            <a:pPr algn="ctr"/>
-            <a:endParaRPr lang="ko-KR" altLang="en-US"/>
-          </a:p>
-        </p:txBody>
-      </p:sp>
-      <p:cxnSp>
-        <p:nvCxnSpPr>
-          <p:cNvPr id="119" name="직선 화살표 연결선 118"/>
-          <p:cNvCxnSpPr>
-            <a:stCxn id="80" idx="2"/>
-            <a:endCxn id="116" idx="0"/>
-          </p:cNvCxnSpPr>
-          <p:nvPr/>
-        </p:nvCxnSpPr>
-        <p:spPr>
-          <a:xfrm flipH="1">
-            <a:off x="1446500" y="7275662"/>
-            <a:ext cx="1800000" cy="657603"/>
-          </a:xfrm>
-          <a:prstGeom prst="straightConnector1">
-            <a:avLst/>
-          </a:prstGeom>
-          <a:ln w="76200">
-            <a:solidFill>
-              <a:schemeClr val="accent2"/>
-            </a:solidFill>
-            <a:tailEnd type="triangle"/>
-          </a:ln>
-        </p:spPr>
-        <p:style>
-          <a:lnRef idx="1">
-            <a:schemeClr val="accent1"/>
-          </a:lnRef>
-          <a:fillRef idx="0">
-            <a:schemeClr val="accent1"/>
-          </a:fillRef>
-          <a:effectRef idx="0">
-            <a:schemeClr val="accent1"/>
-          </a:effectRef>
-          <a:fontRef idx="minor">
-            <a:schemeClr val="tx1"/>
-          </a:fontRef>
-        </p:style>
-      </p:cxnSp>
-      <p:cxnSp>
-        <p:nvCxnSpPr>
-          <p:cNvPr id="122" name="직선 화살표 연결선 121"/>
-          <p:cNvCxnSpPr>
-            <a:stCxn id="80" idx="2"/>
-            <a:endCxn id="89" idx="0"/>
-          </p:cNvCxnSpPr>
-          <p:nvPr/>
-        </p:nvCxnSpPr>
-        <p:spPr>
-          <a:xfrm>
-            <a:off x="3246500" y="7275662"/>
-            <a:ext cx="1800000" cy="657603"/>
-          </a:xfrm>
-          <a:prstGeom prst="straightConnector1">
-            <a:avLst/>
-          </a:prstGeom>
-          <a:ln w="76200">
-            <a:solidFill>
-              <a:schemeClr val="accent2"/>
-            </a:solidFill>
-            <a:tailEnd type="triangle"/>
-          </a:ln>
-        </p:spPr>
-        <p:style>
-          <a:lnRef idx="1">
-            <a:schemeClr val="accent1"/>
-          </a:lnRef>
-          <a:fillRef idx="0">
-            <a:schemeClr val="accent1"/>
-          </a:fillRef>
-          <a:effectRef idx="0">
-            <a:schemeClr val="accent1"/>
-          </a:effectRef>
-          <a:fontRef idx="minor">
-            <a:schemeClr val="tx1"/>
-          </a:fontRef>
-        </p:style>
-      </p:cxnSp>
-      <p:sp>
-        <p:nvSpPr>
-          <p:cNvPr id="79" name="모서리가 둥근 직사각형 78"/>
-          <p:cNvSpPr/>
-          <p:nvPr/>
-        </p:nvSpPr>
-        <p:spPr>
-          <a:xfrm>
-            <a:off x="1896500" y="1401403"/>
-            <a:ext cx="2700000" cy="540000"/>
-          </a:xfrm>
-          <a:prstGeom prst="roundRect">
-            <a:avLst/>
-          </a:prstGeom>
-          <a:solidFill>
-            <a:schemeClr val="bg1"/>
-          </a:solidFill>
-          <a:ln w="19050">
-            <a:solidFill>
-              <a:schemeClr val="tx1"/>
-            </a:solidFill>
-          </a:ln>
-        </p:spPr>
-        <p:style>
-          <a:lnRef idx="2">
-            <a:schemeClr val="accent1">
-              <a:shade val="50000"/>
-            </a:schemeClr>
-          </a:lnRef>
-          <a:fillRef idx="1">
-            <a:schemeClr val="accent1"/>
-          </a:fillRef>
-          <a:effectRef idx="0">
-            <a:schemeClr val="accent1"/>
-          </a:effectRef>
-          <a:fontRef idx="minor">
-            <a:schemeClr val="lt1"/>
-          </a:fontRef>
-        </p:style>
-        <p:txBody>
-          <a:bodyPr rtlCol="0" anchor="ctr"/>
-          <a:lstStyle/>
-          <a:p>
-            <a:pPr algn="ctr"/>
-            <a:r>
-              <a:rPr lang="en-US" altLang="ko-KR" sz="2000" dirty="0" smtClean="0">
-                <a:solidFill>
-                  <a:schemeClr val="tx1"/>
-                </a:solidFill>
-                <a:latin typeface="나눔스퀘어 Bold" panose="020B0600000101010101" pitchFamily="50" charset="-127"/>
-                <a:ea typeface="나눔스퀘어 Bold" panose="020B0600000101010101" pitchFamily="50" charset="-127"/>
-              </a:rPr>
-              <a:t>Spring </a:t>
-            </a:r>
-            <a:r>
-              <a:rPr lang="en-US" altLang="ko-KR" sz="2000" dirty="0" err="1" smtClean="0">
-                <a:solidFill>
-                  <a:schemeClr val="tx1"/>
-                </a:solidFill>
-                <a:latin typeface="나눔스퀘어 Bold" panose="020B0600000101010101" pitchFamily="50" charset="-127"/>
-                <a:ea typeface="나눔스퀘어 Bold" panose="020B0600000101010101" pitchFamily="50" charset="-127"/>
-              </a:rPr>
-              <a:t>IoC</a:t>
-            </a:r>
-            <a:r>
-              <a:rPr lang="en-US" altLang="ko-KR" sz="2000" dirty="0" smtClean="0">
-                <a:solidFill>
-                  <a:schemeClr val="tx1"/>
-                </a:solidFill>
-                <a:latin typeface="나눔스퀘어 Bold" panose="020B0600000101010101" pitchFamily="50" charset="-127"/>
-                <a:ea typeface="나눔스퀘어 Bold" panose="020B0600000101010101" pitchFamily="50" charset="-127"/>
-              </a:rPr>
-              <a:t> Container</a:t>
-            </a:r>
-            <a:endParaRPr lang="ko-KR" altLang="en-US" sz="2000" dirty="0">
-              <a:solidFill>
-                <a:schemeClr val="tx1"/>
-              </a:solidFill>
-              <a:latin typeface="나눔스퀘어 Bold" panose="020B0600000101010101" pitchFamily="50" charset="-127"/>
-              <a:ea typeface="나눔스퀘어 Bold" panose="020B0600000101010101" pitchFamily="50" charset="-127"/>
-            </a:endParaRPr>
+              <a:rPr lang="en-US" altLang="ko-KR" dirty="0" smtClean="0"/>
+              <a:t>request</a:t>
+            </a:r>
+            <a:endParaRPr lang="ko-KR" altLang="en-US" dirty="0"/>
           </a:p>
         </p:txBody>
       </p:sp>
     </p:spTree>
     <p:extLst>
       <p:ext uri="{BB962C8B-B14F-4D97-AF65-F5344CB8AC3E}">
-        <p14:creationId xmlns:p14="http://schemas.microsoft.com/office/powerpoint/2010/main" val="2040070256"/>
+        <p14:creationId xmlns:p14="http://schemas.microsoft.com/office/powerpoint/2010/main" val="3662424553"/>
       </p:ext>
     </p:extLst>
   </p:cSld>
   <p:clrMapOvr>
     <a:masterClrMapping/>
   </p:clrMapOvr>
-  <p:timing>
-    <p:tnLst>
-      <p:par>
-        <p:cTn id="1" dur="indefinite" restart="never" nodeType="tmRoot"/>
-      </p:par>
-    </p:tnLst>
-  </p:timing>
 </p:sld>
 </file>
 
@@ -3881,13 +3248,13 @@
       </p:grpSpPr>
       <p:sp>
         <p:nvSpPr>
-          <p:cNvPr id="40" name="직사각형 39"/>
+          <p:cNvPr id="76" name="직사각형 75"/>
           <p:cNvSpPr/>
           <p:nvPr/>
         </p:nvSpPr>
         <p:spPr>
           <a:xfrm>
-            <a:off x="1873050" y="5601724"/>
+            <a:off x="6500" y="2422853"/>
             <a:ext cx="6480000" cy="720000"/>
           </a:xfrm>
           <a:prstGeom prst="rect">
@@ -3937,13 +3304,13 @@
       </p:sp>
       <p:sp>
         <p:nvSpPr>
-          <p:cNvPr id="41" name="직사각형 40"/>
+          <p:cNvPr id="77" name="직사각형 76"/>
           <p:cNvSpPr/>
           <p:nvPr/>
         </p:nvSpPr>
         <p:spPr>
           <a:xfrm>
-            <a:off x="1873050" y="4225559"/>
+            <a:off x="6500" y="3800456"/>
             <a:ext cx="6480000" cy="720000"/>
           </a:xfrm>
           <a:prstGeom prst="rect">
@@ -3993,13 +3360,13 @@
       </p:sp>
       <p:sp>
         <p:nvSpPr>
-          <p:cNvPr id="42" name="직사각형 41"/>
+          <p:cNvPr id="78" name="직사각형 77"/>
           <p:cNvSpPr/>
           <p:nvPr/>
         </p:nvSpPr>
         <p:spPr>
           <a:xfrm>
-            <a:off x="1873050" y="2847956"/>
+            <a:off x="6500" y="5178059"/>
             <a:ext cx="6480000" cy="720000"/>
           </a:xfrm>
           <a:prstGeom prst="rect">
@@ -4049,13 +3416,13 @@
       </p:sp>
       <p:sp>
         <p:nvSpPr>
-          <p:cNvPr id="44" name="직사각형 43"/>
+          <p:cNvPr id="80" name="직사각형 79"/>
           <p:cNvSpPr/>
           <p:nvPr/>
         </p:nvSpPr>
         <p:spPr>
           <a:xfrm>
-            <a:off x="1873050" y="1470353"/>
+            <a:off x="6500" y="6555662"/>
             <a:ext cx="6480000" cy="720000"/>
           </a:xfrm>
           <a:prstGeom prst="rect">
@@ -4103,150 +3470,18 @@
           </a:p>
         </p:txBody>
       </p:sp>
-      <p:sp>
-        <p:nvSpPr>
-          <p:cNvPr id="91" name="직사각형 90"/>
-          <p:cNvSpPr/>
-          <p:nvPr/>
-        </p:nvSpPr>
-        <p:spPr>
-          <a:xfrm>
-            <a:off x="1875150" y="6977889"/>
-            <a:ext cx="6480000" cy="1800000"/>
-          </a:xfrm>
-          <a:prstGeom prst="rect">
-            <a:avLst/>
-          </a:prstGeom>
-          <a:solidFill>
-            <a:schemeClr val="accent5"/>
-          </a:solidFill>
-          <a:ln>
-            <a:noFill/>
-          </a:ln>
-        </p:spPr>
-        <p:style>
-          <a:lnRef idx="2">
-            <a:schemeClr val="accent1">
-              <a:shade val="50000"/>
-            </a:schemeClr>
-          </a:lnRef>
-          <a:fillRef idx="1">
-            <a:schemeClr val="accent1"/>
-          </a:fillRef>
-          <a:effectRef idx="0">
-            <a:schemeClr val="accent1"/>
-          </a:effectRef>
-          <a:fontRef idx="minor">
-            <a:schemeClr val="lt1"/>
-          </a:fontRef>
-        </p:style>
-        <p:txBody>
-          <a:bodyPr rtlCol="0" anchor="ctr"/>
-          <a:lstStyle/>
-          <a:p>
-            <a:pPr algn="ctr"/>
-            <a:r>
-              <a:rPr lang="en-US" altLang="ko-KR" sz="2800" dirty="0" err="1" smtClean="0">
-                <a:latin typeface="나눔스퀘어 Bold" panose="020B0600000101010101" pitchFamily="50" charset="-127"/>
-                <a:ea typeface="나눔스퀘어 Bold" panose="020B0600000101010101" pitchFamily="50" charset="-127"/>
-              </a:rPr>
-              <a:t>SecurityContextHolder</a:t>
-            </a:r>
-            <a:endParaRPr lang="en-US" altLang="ko-KR" sz="2800" dirty="0" smtClean="0">
-              <a:latin typeface="나눔스퀘어 Bold" panose="020B0600000101010101" pitchFamily="50" charset="-127"/>
-              <a:ea typeface="나눔스퀘어 Bold" panose="020B0600000101010101" pitchFamily="50" charset="-127"/>
-            </a:endParaRPr>
-          </a:p>
-          <a:p>
-            <a:pPr algn="ctr"/>
-            <a:endParaRPr lang="en-US" altLang="ko-KR" sz="2800" dirty="0">
-              <a:latin typeface="나눔스퀘어 Bold" panose="020B0600000101010101" pitchFamily="50" charset="-127"/>
-              <a:ea typeface="나눔스퀘어 Bold" panose="020B0600000101010101" pitchFamily="50" charset="-127"/>
-            </a:endParaRPr>
-          </a:p>
-          <a:p>
-            <a:pPr algn="ctr"/>
-            <a:endParaRPr lang="en-US" altLang="ko-KR" sz="2400" dirty="0" smtClean="0">
-              <a:latin typeface="나눔스퀘어 Bold" panose="020B0600000101010101" pitchFamily="50" charset="-127"/>
-              <a:ea typeface="나눔스퀘어 Bold" panose="020B0600000101010101" pitchFamily="50" charset="-127"/>
-            </a:endParaRPr>
-          </a:p>
-          <a:p>
-            <a:pPr algn="ctr"/>
-            <a:endParaRPr lang="en-US" altLang="ko-KR" sz="2000" dirty="0" smtClean="0">
-              <a:latin typeface="나눔스퀘어 Bold" panose="020B0600000101010101" pitchFamily="50" charset="-127"/>
-              <a:ea typeface="나눔스퀘어 Bold" panose="020B0600000101010101" pitchFamily="50" charset="-127"/>
-            </a:endParaRPr>
-          </a:p>
-        </p:txBody>
-      </p:sp>
-      <p:sp>
-        <p:nvSpPr>
-          <p:cNvPr id="93" name="직사각형 92"/>
-          <p:cNvSpPr/>
-          <p:nvPr/>
-        </p:nvSpPr>
-        <p:spPr>
-          <a:xfrm>
-            <a:off x="2568900" y="7697889"/>
-            <a:ext cx="5040000" cy="720000"/>
-          </a:xfrm>
-          <a:prstGeom prst="rect">
-            <a:avLst/>
-          </a:prstGeom>
-          <a:solidFill>
-            <a:schemeClr val="accent1"/>
-          </a:solidFill>
-          <a:ln>
-            <a:noFill/>
-          </a:ln>
-        </p:spPr>
-        <p:style>
-          <a:lnRef idx="2">
-            <a:schemeClr val="accent1">
-              <a:shade val="50000"/>
-            </a:schemeClr>
-          </a:lnRef>
-          <a:fillRef idx="1">
-            <a:schemeClr val="accent1"/>
-          </a:fillRef>
-          <a:effectRef idx="0">
-            <a:schemeClr val="accent1"/>
-          </a:effectRef>
-          <a:fontRef idx="minor">
-            <a:schemeClr val="lt1"/>
-          </a:fontRef>
-        </p:style>
-        <p:txBody>
-          <a:bodyPr rtlCol="0" anchor="ctr"/>
-          <a:lstStyle/>
-          <a:p>
-            <a:pPr algn="ctr"/>
-            <a:r>
-              <a:rPr lang="en-US" altLang="ko-KR" sz="3600" dirty="0">
-                <a:latin typeface="나눔스퀘어 Bold" panose="020B0600000101010101" pitchFamily="50" charset="-127"/>
-                <a:ea typeface="나눔스퀘어 Bold" panose="020B0600000101010101" pitchFamily="50" charset="-127"/>
-              </a:rPr>
-              <a:t>Principal</a:t>
-            </a:r>
-            <a:endParaRPr lang="ko-KR" altLang="en-US" sz="3600" dirty="0">
-              <a:latin typeface="나눔스퀘어 Bold" panose="020B0600000101010101" pitchFamily="50" charset="-127"/>
-              <a:ea typeface="나눔스퀘어 Bold" panose="020B0600000101010101" pitchFamily="50" charset="-127"/>
-            </a:endParaRPr>
-          </a:p>
-        </p:txBody>
-      </p:sp>
       <p:cxnSp>
         <p:nvCxnSpPr>
-          <p:cNvPr id="94" name="직선 화살표 연결선 93"/>
+          <p:cNvPr id="86" name="직선 화살표 연결선 85"/>
           <p:cNvCxnSpPr>
-            <a:endCxn id="42" idx="0"/>
+            <a:stCxn id="76" idx="2"/>
+            <a:endCxn id="77" idx="0"/>
           </p:cNvCxnSpPr>
           <p:nvPr/>
         </p:nvCxnSpPr>
         <p:spPr>
           <a:xfrm>
-            <a:off x="5113050" y="2190353"/>
+            <a:off x="3246500" y="3142853"/>
             <a:ext cx="0" cy="657603"/>
           </a:xfrm>
           <a:prstGeom prst="straightConnector1">
@@ -4276,16 +3511,16 @@
       </p:cxnSp>
       <p:cxnSp>
         <p:nvCxnSpPr>
-          <p:cNvPr id="97" name="직선 화살표 연결선 96"/>
+          <p:cNvPr id="87" name="직선 화살표 연결선 86"/>
           <p:cNvCxnSpPr>
-            <a:stCxn id="42" idx="2"/>
-            <a:endCxn id="41" idx="0"/>
+            <a:stCxn id="77" idx="2"/>
+            <a:endCxn id="78" idx="0"/>
           </p:cNvCxnSpPr>
           <p:nvPr/>
         </p:nvCxnSpPr>
         <p:spPr>
           <a:xfrm>
-            <a:off x="5113050" y="3567956"/>
+            <a:off x="3246500" y="4520456"/>
             <a:ext cx="0" cy="657603"/>
           </a:xfrm>
           <a:prstGeom prst="straightConnector1">
@@ -4315,17 +3550,422 @@
       </p:cxnSp>
       <p:cxnSp>
         <p:nvCxnSpPr>
-          <p:cNvPr id="100" name="직선 화살표 연결선 99"/>
+          <p:cNvPr id="88" name="직선 화살표 연결선 87"/>
           <p:cNvCxnSpPr>
-            <a:stCxn id="41" idx="2"/>
-            <a:endCxn id="40" idx="0"/>
+            <a:stCxn id="78" idx="2"/>
+            <a:endCxn id="80" idx="0"/>
           </p:cNvCxnSpPr>
           <p:nvPr/>
         </p:nvCxnSpPr>
         <p:spPr>
           <a:xfrm>
-            <a:off x="5113050" y="4945559"/>
-            <a:ext cx="0" cy="656165"/>
+            <a:off x="3246500" y="5898059"/>
+            <a:ext cx="0" cy="657603"/>
+          </a:xfrm>
+          <a:prstGeom prst="straightConnector1">
+            <a:avLst/>
+          </a:prstGeom>
+          <a:ln w="76200">
+            <a:solidFill>
+              <a:schemeClr val="accent2"/>
+            </a:solidFill>
+            <a:tailEnd type="triangle"/>
+          </a:ln>
+        </p:spPr>
+        <p:style>
+          <a:lnRef idx="1">
+            <a:schemeClr val="accent1"/>
+          </a:lnRef>
+          <a:fillRef idx="0">
+            <a:schemeClr val="accent1"/>
+          </a:fillRef>
+          <a:effectRef idx="0">
+            <a:schemeClr val="accent1"/>
+          </a:effectRef>
+          <a:fontRef idx="minor">
+            <a:schemeClr val="tx1"/>
+          </a:fontRef>
+        </p:style>
+      </p:cxnSp>
+      <p:sp>
+        <p:nvSpPr>
+          <p:cNvPr id="89" name="직사각형 88"/>
+          <p:cNvSpPr/>
+          <p:nvPr/>
+        </p:nvSpPr>
+        <p:spPr>
+          <a:xfrm>
+            <a:off x="3606500" y="7933265"/>
+            <a:ext cx="2880000" cy="720000"/>
+          </a:xfrm>
+          <a:prstGeom prst="rect">
+            <a:avLst/>
+          </a:prstGeom>
+          <a:solidFill>
+            <a:schemeClr val="accent5"/>
+          </a:solidFill>
+          <a:ln>
+            <a:noFill/>
+          </a:ln>
+        </p:spPr>
+        <p:style>
+          <a:lnRef idx="2">
+            <a:schemeClr val="accent1">
+              <a:shade val="50000"/>
+            </a:schemeClr>
+          </a:lnRef>
+          <a:fillRef idx="1">
+            <a:schemeClr val="accent1"/>
+          </a:fillRef>
+          <a:effectRef idx="0">
+            <a:schemeClr val="accent1"/>
+          </a:effectRef>
+          <a:fontRef idx="minor">
+            <a:schemeClr val="lt1"/>
+          </a:fontRef>
+        </p:style>
+        <p:txBody>
+          <a:bodyPr rtlCol="0" anchor="ctr"/>
+          <a:lstStyle/>
+          <a:p>
+            <a:pPr algn="ctr"/>
+            <a:r>
+              <a:rPr lang="en-US" altLang="ko-KR" sz="2400" dirty="0" err="1" smtClean="0">
+                <a:latin typeface="나눔스퀘어 Bold" panose="020B0600000101010101" pitchFamily="50" charset="-127"/>
+                <a:ea typeface="나눔스퀘어 Bold" panose="020B0600000101010101" pitchFamily="50" charset="-127"/>
+              </a:rPr>
+              <a:t>DispatcherSevlet</a:t>
+            </a:r>
+            <a:endParaRPr lang="ko-KR" altLang="en-US" sz="2400" dirty="0">
+              <a:latin typeface="나눔스퀘어 Bold" panose="020B0600000101010101" pitchFamily="50" charset="-127"/>
+              <a:ea typeface="나눔스퀘어 Bold" panose="020B0600000101010101" pitchFamily="50" charset="-127"/>
+            </a:endParaRPr>
+          </a:p>
+        </p:txBody>
+      </p:sp>
+      <p:sp>
+        <p:nvSpPr>
+          <p:cNvPr id="110" name="TextBox 109"/>
+          <p:cNvSpPr txBox="1"/>
+          <p:nvPr/>
+        </p:nvSpPr>
+        <p:spPr>
+          <a:xfrm>
+            <a:off x="3468627" y="3286269"/>
+            <a:ext cx="2255746" cy="369332"/>
+          </a:xfrm>
+          <a:prstGeom prst="rect">
+            <a:avLst/>
+          </a:prstGeom>
+          <a:noFill/>
+        </p:spPr>
+        <p:txBody>
+          <a:bodyPr wrap="none" rtlCol="0">
+            <a:spAutoFit/>
+          </a:bodyPr>
+          <a:lstStyle/>
+          <a:p>
+            <a:r>
+              <a:rPr lang="en-US" altLang="ko-KR" dirty="0" smtClean="0">
+                <a:latin typeface="나눔스퀘어 Bold" panose="020B0600000101010101" pitchFamily="50" charset="-127"/>
+                <a:ea typeface="나눔스퀘어 Bold" panose="020B0600000101010101" pitchFamily="50" charset="-127"/>
+              </a:rPr>
+              <a:t>Authentication </a:t>
+            </a:r>
+            <a:r>
+              <a:rPr lang="ko-KR" altLang="en-US" dirty="0" smtClean="0">
+                <a:latin typeface="나눔스퀘어 Bold" panose="020B0600000101010101" pitchFamily="50" charset="-127"/>
+                <a:ea typeface="나눔스퀘어 Bold" panose="020B0600000101010101" pitchFamily="50" charset="-127"/>
+              </a:rPr>
+              <a:t>전달</a:t>
+            </a:r>
+            <a:endParaRPr lang="ko-KR" altLang="en-US" dirty="0">
+              <a:latin typeface="나눔스퀘어 Bold" panose="020B0600000101010101" pitchFamily="50" charset="-127"/>
+              <a:ea typeface="나눔스퀘어 Bold" panose="020B0600000101010101" pitchFamily="50" charset="-127"/>
+            </a:endParaRPr>
+          </a:p>
+        </p:txBody>
+      </p:sp>
+      <p:sp>
+        <p:nvSpPr>
+          <p:cNvPr id="112" name="TextBox 111"/>
+          <p:cNvSpPr txBox="1"/>
+          <p:nvPr/>
+        </p:nvSpPr>
+        <p:spPr>
+          <a:xfrm>
+            <a:off x="3468627" y="4663872"/>
+            <a:ext cx="1588833" cy="369332"/>
+          </a:xfrm>
+          <a:prstGeom prst="rect">
+            <a:avLst/>
+          </a:prstGeom>
+          <a:noFill/>
+        </p:spPr>
+        <p:txBody>
+          <a:bodyPr wrap="none" rtlCol="0">
+            <a:spAutoFit/>
+          </a:bodyPr>
+          <a:lstStyle/>
+          <a:p>
+            <a:r>
+              <a:rPr lang="en-US" altLang="ko-KR" dirty="0" smtClean="0">
+                <a:latin typeface="나눔스퀘어 Bold" panose="020B0600000101010101" pitchFamily="50" charset="-127"/>
+                <a:ea typeface="나눔스퀘어 Bold" panose="020B0600000101010101" pitchFamily="50" charset="-127"/>
+              </a:rPr>
+              <a:t>Provider </a:t>
+            </a:r>
+            <a:r>
+              <a:rPr lang="ko-KR" altLang="en-US" dirty="0" smtClean="0">
+                <a:latin typeface="나눔스퀘어 Bold" panose="020B0600000101010101" pitchFamily="50" charset="-127"/>
+                <a:ea typeface="나눔스퀘어 Bold" panose="020B0600000101010101" pitchFamily="50" charset="-127"/>
+              </a:rPr>
+              <a:t>선택</a:t>
+            </a:r>
+            <a:endParaRPr lang="ko-KR" altLang="en-US" dirty="0">
+              <a:latin typeface="나눔스퀘어 Bold" panose="020B0600000101010101" pitchFamily="50" charset="-127"/>
+              <a:ea typeface="나눔스퀘어 Bold" panose="020B0600000101010101" pitchFamily="50" charset="-127"/>
+            </a:endParaRPr>
+          </a:p>
+        </p:txBody>
+      </p:sp>
+      <p:sp>
+        <p:nvSpPr>
+          <p:cNvPr id="113" name="TextBox 112"/>
+          <p:cNvSpPr txBox="1"/>
+          <p:nvPr/>
+        </p:nvSpPr>
+        <p:spPr>
+          <a:xfrm>
+            <a:off x="3468627" y="6042194"/>
+            <a:ext cx="1864613" cy="369332"/>
+          </a:xfrm>
+          <a:prstGeom prst="rect">
+            <a:avLst/>
+          </a:prstGeom>
+          <a:noFill/>
+        </p:spPr>
+        <p:txBody>
+          <a:bodyPr wrap="none" rtlCol="0">
+            <a:spAutoFit/>
+          </a:bodyPr>
+          <a:lstStyle/>
+          <a:p>
+            <a:r>
+              <a:rPr lang="en-US" altLang="ko-KR" dirty="0" smtClean="0">
+                <a:latin typeface="나눔스퀘어 Bold" panose="020B0600000101010101" pitchFamily="50" charset="-127"/>
+                <a:ea typeface="나눔스퀘어 Bold" panose="020B0600000101010101" pitchFamily="50" charset="-127"/>
+              </a:rPr>
+              <a:t>DB</a:t>
+            </a:r>
+            <a:r>
+              <a:rPr lang="ko-KR" altLang="en-US" dirty="0" smtClean="0">
+                <a:latin typeface="나눔스퀘어 Bold" panose="020B0600000101010101" pitchFamily="50" charset="-127"/>
+                <a:ea typeface="나눔스퀘어 Bold" panose="020B0600000101010101" pitchFamily="50" charset="-127"/>
+              </a:rPr>
+              <a:t>정보 조회 지시</a:t>
+            </a:r>
+            <a:endParaRPr lang="ko-KR" altLang="en-US" dirty="0">
+              <a:latin typeface="나눔스퀘어 Bold" panose="020B0600000101010101" pitchFamily="50" charset="-127"/>
+              <a:ea typeface="나눔스퀘어 Bold" panose="020B0600000101010101" pitchFamily="50" charset="-127"/>
+            </a:endParaRPr>
+          </a:p>
+        </p:txBody>
+      </p:sp>
+      <p:sp>
+        <p:nvSpPr>
+          <p:cNvPr id="114" name="TextBox 113"/>
+          <p:cNvSpPr txBox="1"/>
+          <p:nvPr/>
+        </p:nvSpPr>
+        <p:spPr>
+          <a:xfrm>
+            <a:off x="506712" y="7419797"/>
+            <a:ext cx="1386918" cy="369332"/>
+          </a:xfrm>
+          <a:prstGeom prst="rect">
+            <a:avLst/>
+          </a:prstGeom>
+          <a:noFill/>
+        </p:spPr>
+        <p:txBody>
+          <a:bodyPr wrap="none" rtlCol="0">
+            <a:spAutoFit/>
+          </a:bodyPr>
+          <a:lstStyle/>
+          <a:p>
+            <a:r>
+              <a:rPr lang="en-US" altLang="ko-KR" dirty="0" smtClean="0">
+                <a:latin typeface="나눔스퀘어 Bold" panose="020B0600000101010101" pitchFamily="50" charset="-127"/>
+                <a:ea typeface="나눔스퀘어 Bold" panose="020B0600000101010101" pitchFamily="50" charset="-127"/>
+              </a:rPr>
+              <a:t>DB</a:t>
+            </a:r>
+            <a:r>
+              <a:rPr lang="ko-KR" altLang="en-US" dirty="0" smtClean="0">
+                <a:latin typeface="나눔스퀘어 Bold" panose="020B0600000101010101" pitchFamily="50" charset="-127"/>
+                <a:ea typeface="나눔스퀘어 Bold" panose="020B0600000101010101" pitchFamily="50" charset="-127"/>
+              </a:rPr>
+              <a:t>정보 조회</a:t>
+            </a:r>
+            <a:endParaRPr lang="ko-KR" altLang="en-US" dirty="0">
+              <a:latin typeface="나눔스퀘어 Bold" panose="020B0600000101010101" pitchFamily="50" charset="-127"/>
+              <a:ea typeface="나눔스퀘어 Bold" panose="020B0600000101010101" pitchFamily="50" charset="-127"/>
+            </a:endParaRPr>
+          </a:p>
+        </p:txBody>
+      </p:sp>
+      <p:sp>
+        <p:nvSpPr>
+          <p:cNvPr id="115" name="TextBox 114"/>
+          <p:cNvSpPr txBox="1"/>
+          <p:nvPr/>
+        </p:nvSpPr>
+        <p:spPr>
+          <a:xfrm>
+            <a:off x="4641265" y="7419797"/>
+            <a:ext cx="1082348" cy="369332"/>
+          </a:xfrm>
+          <a:prstGeom prst="rect">
+            <a:avLst/>
+          </a:prstGeom>
+          <a:noFill/>
+        </p:spPr>
+        <p:txBody>
+          <a:bodyPr wrap="none" rtlCol="0">
+            <a:spAutoFit/>
+          </a:bodyPr>
+          <a:lstStyle/>
+          <a:p>
+            <a:r>
+              <a:rPr lang="ko-KR" altLang="en-US" dirty="0" smtClean="0">
+                <a:latin typeface="나눔스퀘어 Bold" panose="020B0600000101010101" pitchFamily="50" charset="-127"/>
+                <a:ea typeface="나눔스퀘어 Bold" panose="020B0600000101010101" pitchFamily="50" charset="-127"/>
+              </a:rPr>
+              <a:t>요청 전달</a:t>
+            </a:r>
+            <a:endParaRPr lang="ko-KR" altLang="en-US" dirty="0">
+              <a:latin typeface="나눔스퀘어 Bold" panose="020B0600000101010101" pitchFamily="50" charset="-127"/>
+              <a:ea typeface="나눔스퀘어 Bold" panose="020B0600000101010101" pitchFamily="50" charset="-127"/>
+            </a:endParaRPr>
+          </a:p>
+        </p:txBody>
+      </p:sp>
+      <p:sp>
+        <p:nvSpPr>
+          <p:cNvPr id="116" name="직사각형 115"/>
+          <p:cNvSpPr/>
+          <p:nvPr/>
+        </p:nvSpPr>
+        <p:spPr>
+          <a:xfrm>
+            <a:off x="6500" y="7933265"/>
+            <a:ext cx="2880000" cy="720000"/>
+          </a:xfrm>
+          <a:prstGeom prst="rect">
+            <a:avLst/>
+          </a:prstGeom>
+          <a:solidFill>
+            <a:schemeClr val="accent5"/>
+          </a:solidFill>
+          <a:ln>
+            <a:noFill/>
+          </a:ln>
+        </p:spPr>
+        <p:style>
+          <a:lnRef idx="2">
+            <a:schemeClr val="accent1">
+              <a:shade val="50000"/>
+            </a:schemeClr>
+          </a:lnRef>
+          <a:fillRef idx="1">
+            <a:schemeClr val="accent1"/>
+          </a:fillRef>
+          <a:effectRef idx="0">
+            <a:schemeClr val="accent1"/>
+          </a:effectRef>
+          <a:fontRef idx="minor">
+            <a:schemeClr val="lt1"/>
+          </a:fontRef>
+        </p:style>
+        <p:txBody>
+          <a:bodyPr rtlCol="0" anchor="ctr"/>
+          <a:lstStyle/>
+          <a:p>
+            <a:pPr algn="ctr"/>
+            <a:r>
+              <a:rPr lang="en-US" altLang="ko-KR" sz="3200" dirty="0" smtClean="0">
+                <a:latin typeface="나눔스퀘어 Bold" panose="020B0600000101010101" pitchFamily="50" charset="-127"/>
+                <a:ea typeface="나눔스퀘어 Bold" panose="020B0600000101010101" pitchFamily="50" charset="-127"/>
+              </a:rPr>
+              <a:t>DB</a:t>
+            </a:r>
+            <a:endParaRPr lang="ko-KR" altLang="en-US" sz="3200" dirty="0">
+              <a:latin typeface="나눔스퀘어 Bold" panose="020B0600000101010101" pitchFamily="50" charset="-127"/>
+              <a:ea typeface="나눔스퀘어 Bold" panose="020B0600000101010101" pitchFamily="50" charset="-127"/>
+            </a:endParaRPr>
+          </a:p>
+        </p:txBody>
+      </p:sp>
+      <p:sp>
+        <p:nvSpPr>
+          <p:cNvPr id="118" name="직사각형 117"/>
+          <p:cNvSpPr/>
+          <p:nvPr/>
+        </p:nvSpPr>
+        <p:spPr>
+          <a:xfrm>
+            <a:off x="-353500" y="1761402"/>
+            <a:ext cx="7200000" cy="7200000"/>
+          </a:xfrm>
+          <a:prstGeom prst="rect">
+            <a:avLst/>
+          </a:prstGeom>
+          <a:noFill/>
+          <a:ln w="19050">
+            <a:solidFill>
+              <a:schemeClr val="tx1"/>
+            </a:solidFill>
+          </a:ln>
+        </p:spPr>
+        <p:style>
+          <a:lnRef idx="2">
+            <a:schemeClr val="accent1">
+              <a:shade val="50000"/>
+            </a:schemeClr>
+          </a:lnRef>
+          <a:fillRef idx="1">
+            <a:schemeClr val="accent1"/>
+          </a:fillRef>
+          <a:effectRef idx="0">
+            <a:schemeClr val="accent1"/>
+          </a:effectRef>
+          <a:fontRef idx="minor">
+            <a:schemeClr val="lt1"/>
+          </a:fontRef>
+        </p:style>
+        <p:txBody>
+          <a:bodyPr rtlCol="0" anchor="ctr"/>
+          <a:lstStyle/>
+          <a:p>
+            <a:pPr algn="ctr"/>
+            <a:endParaRPr lang="ko-KR" altLang="en-US"/>
+          </a:p>
+        </p:txBody>
+      </p:sp>
+      <p:cxnSp>
+        <p:nvCxnSpPr>
+          <p:cNvPr id="119" name="직선 화살표 연결선 118"/>
+          <p:cNvCxnSpPr>
+            <a:stCxn id="80" idx="2"/>
+            <a:endCxn id="116" idx="0"/>
+          </p:cNvCxnSpPr>
+          <p:nvPr/>
+        </p:nvCxnSpPr>
+        <p:spPr>
+          <a:xfrm flipH="1">
+            <a:off x="1446500" y="7275662"/>
+            <a:ext cx="1800000" cy="657603"/>
           </a:xfrm>
           <a:prstGeom prst="straightConnector1">
             <a:avLst/>
@@ -4354,17 +3994,17 @@
       </p:cxnSp>
       <p:cxnSp>
         <p:nvCxnSpPr>
-          <p:cNvPr id="104" name="직선 화살표 연결선 103"/>
+          <p:cNvPr id="122" name="직선 화살표 연결선 121"/>
           <p:cNvCxnSpPr>
-            <a:stCxn id="40" idx="2"/>
-            <a:endCxn id="91" idx="0"/>
+            <a:stCxn id="80" idx="2"/>
+            <a:endCxn id="89" idx="0"/>
           </p:cNvCxnSpPr>
           <p:nvPr/>
         </p:nvCxnSpPr>
         <p:spPr>
           <a:xfrm>
-            <a:off x="5113050" y="6321724"/>
-            <a:ext cx="2100" cy="656165"/>
+            <a:off x="3246500" y="7275662"/>
+            <a:ext cx="1800000" cy="657603"/>
           </a:xfrm>
           <a:prstGeom prst="straightConnector1">
             <a:avLst/>
@@ -4393,59 +4033,13 @@
       </p:cxnSp>
       <p:sp>
         <p:nvSpPr>
-          <p:cNvPr id="109" name="직사각형 108"/>
+          <p:cNvPr id="79" name="모서리가 둥근 직사각형 78"/>
           <p:cNvSpPr/>
           <p:nvPr/>
         </p:nvSpPr>
         <p:spPr>
           <a:xfrm>
-            <a:off x="1513050" y="808902"/>
-            <a:ext cx="7200000" cy="8280000"/>
-          </a:xfrm>
-          <a:prstGeom prst="rect">
-            <a:avLst/>
-          </a:prstGeom>
-          <a:noFill/>
-          <a:ln w="19050">
-            <a:solidFill>
-              <a:schemeClr val="tx1"/>
-            </a:solidFill>
-          </a:ln>
-        </p:spPr>
-        <p:style>
-          <a:lnRef idx="2">
-            <a:schemeClr val="accent1">
-              <a:shade val="50000"/>
-            </a:schemeClr>
-          </a:lnRef>
-          <a:fillRef idx="1">
-            <a:schemeClr val="accent1"/>
-          </a:fillRef>
-          <a:effectRef idx="0">
-            <a:schemeClr val="accent1"/>
-          </a:effectRef>
-          <a:fontRef idx="minor">
-            <a:schemeClr val="lt1"/>
-          </a:fontRef>
-        </p:style>
-        <p:txBody>
-          <a:bodyPr rtlCol="0" anchor="ctr"/>
-          <a:lstStyle/>
-          <a:p>
-            <a:pPr algn="ctr"/>
-            <a:endParaRPr lang="ko-KR" altLang="en-US"/>
-          </a:p>
-        </p:txBody>
-      </p:sp>
-      <p:sp>
-        <p:nvSpPr>
-          <p:cNvPr id="43" name="모서리가 둥근 직사각형 42"/>
-          <p:cNvSpPr/>
-          <p:nvPr/>
-        </p:nvSpPr>
-        <p:spPr>
-          <a:xfrm>
-            <a:off x="3738900" y="448903"/>
+            <a:off x="1896500" y="1401403"/>
             <a:ext cx="2700000" cy="540000"/>
           </a:xfrm>
           <a:prstGeom prst="roundRect">
@@ -4523,13 +4117,1247 @@
       </p:sp>
       <p:sp>
         <p:nvSpPr>
-          <p:cNvPr id="3" name="TextBox 2"/>
+          <p:cNvPr id="20" name="직사각형 19"/>
+          <p:cNvSpPr/>
+          <p:nvPr/>
+        </p:nvSpPr>
+        <p:spPr>
+          <a:xfrm>
+            <a:off x="3923899" y="-762144"/>
+            <a:ext cx="9000000" cy="1800000"/>
+          </a:xfrm>
+          <a:prstGeom prst="rect">
+            <a:avLst/>
+          </a:prstGeom>
+          <a:noFill/>
+          <a:ln w="19050">
+            <a:solidFill>
+              <a:schemeClr val="tx1"/>
+            </a:solidFill>
+          </a:ln>
+        </p:spPr>
+        <p:style>
+          <a:lnRef idx="2">
+            <a:schemeClr val="accent1">
+              <a:shade val="50000"/>
+            </a:schemeClr>
+          </a:lnRef>
+          <a:fillRef idx="1">
+            <a:schemeClr val="accent1"/>
+          </a:fillRef>
+          <a:effectRef idx="0">
+            <a:schemeClr val="accent1"/>
+          </a:effectRef>
+          <a:fontRef idx="minor">
+            <a:schemeClr val="lt1"/>
+          </a:fontRef>
+        </p:style>
+        <p:txBody>
+          <a:bodyPr rtlCol="0" anchor="ctr"/>
+          <a:lstStyle/>
+          <a:p>
+            <a:pPr algn="ctr"/>
+            <a:endParaRPr lang="ko-KR" altLang="en-US"/>
+          </a:p>
+        </p:txBody>
+      </p:sp>
+      <p:sp>
+        <p:nvSpPr>
+          <p:cNvPr id="21" name="직사각형 20"/>
+          <p:cNvSpPr/>
+          <p:nvPr/>
+        </p:nvSpPr>
+        <p:spPr>
+          <a:xfrm>
+            <a:off x="-353500" y="-4900"/>
+            <a:ext cx="3600000" cy="720000"/>
+          </a:xfrm>
+          <a:prstGeom prst="rect">
+            <a:avLst/>
+          </a:prstGeom>
+          <a:solidFill>
+            <a:schemeClr val="accent5"/>
+          </a:solidFill>
+          <a:ln>
+            <a:noFill/>
+          </a:ln>
+        </p:spPr>
+        <p:style>
+          <a:lnRef idx="2">
+            <a:schemeClr val="accent1">
+              <a:shade val="50000"/>
+            </a:schemeClr>
+          </a:lnRef>
+          <a:fillRef idx="1">
+            <a:schemeClr val="accent1"/>
+          </a:fillRef>
+          <a:effectRef idx="0">
+            <a:schemeClr val="accent1"/>
+          </a:effectRef>
+          <a:fontRef idx="minor">
+            <a:schemeClr val="lt1"/>
+          </a:fontRef>
+        </p:style>
+        <p:txBody>
+          <a:bodyPr rtlCol="0" anchor="ctr"/>
+          <a:lstStyle/>
+          <a:p>
+            <a:pPr algn="ctr"/>
+            <a:r>
+              <a:rPr lang="en-US" altLang="ko-KR" sz="3200" dirty="0" smtClean="0">
+                <a:latin typeface="나눔스퀘어 Bold" panose="020B0600000101010101" pitchFamily="50" charset="-127"/>
+                <a:ea typeface="나눔스퀘어 Bold" panose="020B0600000101010101" pitchFamily="50" charset="-127"/>
+              </a:rPr>
+              <a:t>Client</a:t>
+            </a:r>
+            <a:endParaRPr lang="ko-KR" altLang="en-US" sz="3200" dirty="0">
+              <a:latin typeface="나눔스퀘어 Bold" panose="020B0600000101010101" pitchFamily="50" charset="-127"/>
+              <a:ea typeface="나눔스퀘어 Bold" panose="020B0600000101010101" pitchFamily="50" charset="-127"/>
+            </a:endParaRPr>
+          </a:p>
+        </p:txBody>
+      </p:sp>
+      <p:sp>
+        <p:nvSpPr>
+          <p:cNvPr id="22" name="직사각형 21"/>
+          <p:cNvSpPr/>
+          <p:nvPr/>
+        </p:nvSpPr>
+        <p:spPr>
+          <a:xfrm>
+            <a:off x="4298100" y="-4900"/>
+            <a:ext cx="3600000" cy="720000"/>
+          </a:xfrm>
+          <a:prstGeom prst="rect">
+            <a:avLst/>
+          </a:prstGeom>
+          <a:solidFill>
+            <a:schemeClr val="accent5"/>
+          </a:solidFill>
+          <a:ln>
+            <a:noFill/>
+          </a:ln>
+        </p:spPr>
+        <p:style>
+          <a:lnRef idx="2">
+            <a:schemeClr val="accent1">
+              <a:shade val="50000"/>
+            </a:schemeClr>
+          </a:lnRef>
+          <a:fillRef idx="1">
+            <a:schemeClr val="accent1"/>
+          </a:fillRef>
+          <a:effectRef idx="0">
+            <a:schemeClr val="accent1"/>
+          </a:effectRef>
+          <a:fontRef idx="minor">
+            <a:schemeClr val="lt1"/>
+          </a:fontRef>
+        </p:style>
+        <p:txBody>
+          <a:bodyPr rtlCol="0" anchor="ctr"/>
+          <a:lstStyle/>
+          <a:p>
+            <a:pPr algn="ctr"/>
+            <a:r>
+              <a:rPr lang="en-US" altLang="ko-KR" sz="2400" dirty="0" err="1" smtClean="0">
+                <a:latin typeface="나눔스퀘어 Bold" panose="020B0600000101010101" pitchFamily="50" charset="-127"/>
+                <a:ea typeface="나눔스퀘어 Bold" panose="020B0600000101010101" pitchFamily="50" charset="-127"/>
+              </a:rPr>
+              <a:t>DelegatingFilterProxy</a:t>
+            </a:r>
+            <a:endParaRPr lang="ko-KR" altLang="en-US" sz="2400" dirty="0">
+              <a:latin typeface="나눔스퀘어 Bold" panose="020B0600000101010101" pitchFamily="50" charset="-127"/>
+              <a:ea typeface="나눔스퀘어 Bold" panose="020B0600000101010101" pitchFamily="50" charset="-127"/>
+            </a:endParaRPr>
+          </a:p>
+        </p:txBody>
+      </p:sp>
+      <p:sp>
+        <p:nvSpPr>
+          <p:cNvPr id="23" name="직사각형 22"/>
+          <p:cNvSpPr/>
+          <p:nvPr/>
+        </p:nvSpPr>
+        <p:spPr>
+          <a:xfrm>
+            <a:off x="8949700" y="-4900"/>
+            <a:ext cx="3600000" cy="720000"/>
+          </a:xfrm>
+          <a:prstGeom prst="rect">
+            <a:avLst/>
+          </a:prstGeom>
+          <a:solidFill>
+            <a:schemeClr val="accent5"/>
+          </a:solidFill>
+          <a:ln>
+            <a:noFill/>
+          </a:ln>
+        </p:spPr>
+        <p:style>
+          <a:lnRef idx="2">
+            <a:schemeClr val="accent1">
+              <a:shade val="50000"/>
+            </a:schemeClr>
+          </a:lnRef>
+          <a:fillRef idx="1">
+            <a:schemeClr val="accent1"/>
+          </a:fillRef>
+          <a:effectRef idx="0">
+            <a:schemeClr val="accent1"/>
+          </a:effectRef>
+          <a:fontRef idx="minor">
+            <a:schemeClr val="lt1"/>
+          </a:fontRef>
+        </p:style>
+        <p:txBody>
+          <a:bodyPr rtlCol="0" anchor="ctr"/>
+          <a:lstStyle/>
+          <a:p>
+            <a:pPr algn="ctr"/>
+            <a:r>
+              <a:rPr lang="en-US" altLang="ko-KR" sz="2400" dirty="0" smtClean="0">
+                <a:latin typeface="나눔스퀘어 Bold" panose="020B0600000101010101" pitchFamily="50" charset="-127"/>
+                <a:ea typeface="나눔스퀘어 Bold" panose="020B0600000101010101" pitchFamily="50" charset="-127"/>
+              </a:rPr>
+              <a:t>Spring </a:t>
+            </a:r>
+            <a:r>
+              <a:rPr lang="en-US" altLang="ko-KR" sz="2400" dirty="0" err="1" smtClean="0">
+                <a:latin typeface="나눔스퀘어 Bold" panose="020B0600000101010101" pitchFamily="50" charset="-127"/>
+                <a:ea typeface="나눔스퀘어 Bold" panose="020B0600000101010101" pitchFamily="50" charset="-127"/>
+              </a:rPr>
+              <a:t>IoC</a:t>
+            </a:r>
+            <a:r>
+              <a:rPr lang="en-US" altLang="ko-KR" sz="2400" dirty="0" smtClean="0">
+                <a:latin typeface="나눔스퀘어 Bold" panose="020B0600000101010101" pitchFamily="50" charset="-127"/>
+                <a:ea typeface="나눔스퀘어 Bold" panose="020B0600000101010101" pitchFamily="50" charset="-127"/>
+              </a:rPr>
+              <a:t> Container</a:t>
+            </a:r>
+            <a:endParaRPr lang="ko-KR" altLang="en-US" sz="2400" dirty="0">
+              <a:latin typeface="나눔스퀘어 Bold" panose="020B0600000101010101" pitchFamily="50" charset="-127"/>
+              <a:ea typeface="나눔스퀘어 Bold" panose="020B0600000101010101" pitchFamily="50" charset="-127"/>
+            </a:endParaRPr>
+          </a:p>
+        </p:txBody>
+      </p:sp>
+      <p:cxnSp>
+        <p:nvCxnSpPr>
+          <p:cNvPr id="24" name="직선 화살표 연결선 23"/>
+          <p:cNvCxnSpPr>
+            <a:stCxn id="21" idx="3"/>
+            <a:endCxn id="22" idx="1"/>
+          </p:cNvCxnSpPr>
+          <p:nvPr/>
+        </p:nvCxnSpPr>
+        <p:spPr>
+          <a:xfrm>
+            <a:off x="3246500" y="355100"/>
+            <a:ext cx="1051600" cy="0"/>
+          </a:xfrm>
+          <a:prstGeom prst="straightConnector1">
+            <a:avLst/>
+          </a:prstGeom>
+          <a:ln w="76200">
+            <a:solidFill>
+              <a:schemeClr val="accent2"/>
+            </a:solidFill>
+            <a:tailEnd type="triangle"/>
+          </a:ln>
+        </p:spPr>
+        <p:style>
+          <a:lnRef idx="1">
+            <a:schemeClr val="accent1"/>
+          </a:lnRef>
+          <a:fillRef idx="0">
+            <a:schemeClr val="accent1"/>
+          </a:fillRef>
+          <a:effectRef idx="0">
+            <a:schemeClr val="accent1"/>
+          </a:effectRef>
+          <a:fontRef idx="minor">
+            <a:schemeClr val="tx1"/>
+          </a:fontRef>
+        </p:style>
+      </p:cxnSp>
+      <p:cxnSp>
+        <p:nvCxnSpPr>
+          <p:cNvPr id="25" name="직선 화살표 연결선 24"/>
+          <p:cNvCxnSpPr>
+            <a:stCxn id="22" idx="3"/>
+            <a:endCxn id="23" idx="1"/>
+          </p:cNvCxnSpPr>
+          <p:nvPr/>
+        </p:nvCxnSpPr>
+        <p:spPr>
+          <a:xfrm>
+            <a:off x="7898100" y="355100"/>
+            <a:ext cx="1051600" cy="0"/>
+          </a:xfrm>
+          <a:prstGeom prst="straightConnector1">
+            <a:avLst/>
+          </a:prstGeom>
+          <a:ln w="76200">
+            <a:solidFill>
+              <a:schemeClr val="accent2"/>
+            </a:solidFill>
+            <a:tailEnd type="triangle"/>
+          </a:ln>
+        </p:spPr>
+        <p:style>
+          <a:lnRef idx="1">
+            <a:schemeClr val="accent1"/>
+          </a:lnRef>
+          <a:fillRef idx="0">
+            <a:schemeClr val="accent1"/>
+          </a:fillRef>
+          <a:effectRef idx="0">
+            <a:schemeClr val="accent1"/>
+          </a:effectRef>
+          <a:fontRef idx="minor">
+            <a:schemeClr val="tx1"/>
+          </a:fontRef>
+        </p:style>
+      </p:cxnSp>
+      <p:sp>
+        <p:nvSpPr>
+          <p:cNvPr id="26" name="TextBox 25"/>
           <p:cNvSpPr txBox="1"/>
           <p:nvPr/>
         </p:nvSpPr>
         <p:spPr>
           <a:xfrm>
-            <a:off x="5324032" y="6465140"/>
+            <a:off x="3469973" y="-6009"/>
+            <a:ext cx="604653" cy="369332"/>
+          </a:xfrm>
+          <a:prstGeom prst="rect">
+            <a:avLst/>
+          </a:prstGeom>
+          <a:noFill/>
+        </p:spPr>
+        <p:txBody>
+          <a:bodyPr wrap="none" rtlCol="0">
+            <a:spAutoFit/>
+          </a:bodyPr>
+          <a:lstStyle/>
+          <a:p>
+            <a:r>
+              <a:rPr lang="ko-KR" altLang="en-US" dirty="0" smtClean="0">
+                <a:latin typeface="나눔스퀘어 Bold" panose="020B0600000101010101" pitchFamily="50" charset="-127"/>
+                <a:ea typeface="나눔스퀘어 Bold" panose="020B0600000101010101" pitchFamily="50" charset="-127"/>
+              </a:rPr>
+              <a:t>요청</a:t>
+            </a:r>
+            <a:endParaRPr lang="ko-KR" altLang="en-US" dirty="0">
+              <a:latin typeface="나눔스퀘어 Bold" panose="020B0600000101010101" pitchFamily="50" charset="-127"/>
+              <a:ea typeface="나눔스퀘어 Bold" panose="020B0600000101010101" pitchFamily="50" charset="-127"/>
+            </a:endParaRPr>
+          </a:p>
+        </p:txBody>
+      </p:sp>
+      <p:sp>
+        <p:nvSpPr>
+          <p:cNvPr id="27" name="TextBox 26"/>
+          <p:cNvSpPr txBox="1"/>
+          <p:nvPr/>
+        </p:nvSpPr>
+        <p:spPr>
+          <a:xfrm>
+            <a:off x="8121573" y="-6009"/>
+            <a:ext cx="604653" cy="369332"/>
+          </a:xfrm>
+          <a:prstGeom prst="rect">
+            <a:avLst/>
+          </a:prstGeom>
+          <a:noFill/>
+        </p:spPr>
+        <p:txBody>
+          <a:bodyPr wrap="none" rtlCol="0">
+            <a:spAutoFit/>
+          </a:bodyPr>
+          <a:lstStyle/>
+          <a:p>
+            <a:r>
+              <a:rPr lang="ko-KR" altLang="en-US" dirty="0" smtClean="0">
+                <a:latin typeface="나눔스퀘어 Bold" panose="020B0600000101010101" pitchFamily="50" charset="-127"/>
+                <a:ea typeface="나눔스퀘어 Bold" panose="020B0600000101010101" pitchFamily="50" charset="-127"/>
+              </a:rPr>
+              <a:t>위임</a:t>
+            </a:r>
+            <a:endParaRPr lang="ko-KR" altLang="en-US" dirty="0">
+              <a:latin typeface="나눔스퀘어 Bold" panose="020B0600000101010101" pitchFamily="50" charset="-127"/>
+              <a:ea typeface="나눔스퀘어 Bold" panose="020B0600000101010101" pitchFamily="50" charset="-127"/>
+            </a:endParaRPr>
+          </a:p>
+        </p:txBody>
+      </p:sp>
+      <p:sp>
+        <p:nvSpPr>
+          <p:cNvPr id="28" name="직사각형 27"/>
+          <p:cNvSpPr/>
+          <p:nvPr/>
+        </p:nvSpPr>
+        <p:spPr>
+          <a:xfrm>
+            <a:off x="4118100" y="-235572"/>
+            <a:ext cx="3960000" cy="1116000"/>
+          </a:xfrm>
+          <a:prstGeom prst="rect">
+            <a:avLst/>
+          </a:prstGeom>
+          <a:noFill/>
+          <a:ln w="19050">
+            <a:solidFill>
+              <a:schemeClr val="tx1"/>
+            </a:solidFill>
+          </a:ln>
+        </p:spPr>
+        <p:style>
+          <a:lnRef idx="2">
+            <a:schemeClr val="accent1">
+              <a:shade val="50000"/>
+            </a:schemeClr>
+          </a:lnRef>
+          <a:fillRef idx="1">
+            <a:schemeClr val="accent1"/>
+          </a:fillRef>
+          <a:effectRef idx="0">
+            <a:schemeClr val="accent1"/>
+          </a:effectRef>
+          <a:fontRef idx="minor">
+            <a:schemeClr val="lt1"/>
+          </a:fontRef>
+        </p:style>
+        <p:txBody>
+          <a:bodyPr rtlCol="0" anchor="ctr"/>
+          <a:lstStyle/>
+          <a:p>
+            <a:pPr algn="ctr"/>
+            <a:endParaRPr lang="ko-KR" altLang="en-US"/>
+          </a:p>
+        </p:txBody>
+      </p:sp>
+      <p:sp>
+        <p:nvSpPr>
+          <p:cNvPr id="29" name="모서리가 둥근 직사각형 28"/>
+          <p:cNvSpPr/>
+          <p:nvPr/>
+        </p:nvSpPr>
+        <p:spPr>
+          <a:xfrm>
+            <a:off x="4748100" y="-497158"/>
+            <a:ext cx="1440000" cy="432000"/>
+          </a:xfrm>
+          <a:prstGeom prst="roundRect">
+            <a:avLst/>
+          </a:prstGeom>
+          <a:solidFill>
+            <a:schemeClr val="bg1"/>
+          </a:solidFill>
+          <a:ln w="19050">
+            <a:solidFill>
+              <a:schemeClr val="tx1"/>
+            </a:solidFill>
+          </a:ln>
+        </p:spPr>
+        <p:style>
+          <a:lnRef idx="2">
+            <a:schemeClr val="accent1">
+              <a:shade val="50000"/>
+            </a:schemeClr>
+          </a:lnRef>
+          <a:fillRef idx="1">
+            <a:schemeClr val="accent1"/>
+          </a:fillRef>
+          <a:effectRef idx="0">
+            <a:schemeClr val="accent1"/>
+          </a:effectRef>
+          <a:fontRef idx="minor">
+            <a:schemeClr val="lt1"/>
+          </a:fontRef>
+        </p:style>
+        <p:txBody>
+          <a:bodyPr rtlCol="0" anchor="ctr"/>
+          <a:lstStyle/>
+          <a:p>
+            <a:pPr algn="ctr"/>
+            <a:r>
+              <a:rPr lang="ko-KR" altLang="en-US" sz="2000" dirty="0" smtClean="0">
+                <a:solidFill>
+                  <a:schemeClr val="tx1"/>
+                </a:solidFill>
+                <a:latin typeface="나눔스퀘어 Bold" panose="020B0600000101010101" pitchFamily="50" charset="-127"/>
+                <a:ea typeface="나눔스퀘어 Bold" panose="020B0600000101010101" pitchFamily="50" charset="-127"/>
+              </a:rPr>
+              <a:t>필터</a:t>
+            </a:r>
+            <a:r>
+              <a:rPr lang="en-US" altLang="ko-KR" sz="2000" dirty="0" smtClean="0">
+                <a:solidFill>
+                  <a:schemeClr val="tx1"/>
+                </a:solidFill>
+                <a:latin typeface="나눔스퀘어 Bold" panose="020B0600000101010101" pitchFamily="50" charset="-127"/>
+                <a:ea typeface="나눔스퀘어 Bold" panose="020B0600000101010101" pitchFamily="50" charset="-127"/>
+              </a:rPr>
+              <a:t> </a:t>
+            </a:r>
+            <a:r>
+              <a:rPr lang="ko-KR" altLang="en-US" sz="2000" dirty="0" smtClean="0">
+                <a:solidFill>
+                  <a:schemeClr val="tx1"/>
+                </a:solidFill>
+                <a:latin typeface="나눔스퀘어 Bold" panose="020B0600000101010101" pitchFamily="50" charset="-127"/>
+                <a:ea typeface="나눔스퀘어 Bold" panose="020B0600000101010101" pitchFamily="50" charset="-127"/>
+              </a:rPr>
+              <a:t>체인</a:t>
+            </a:r>
+            <a:endParaRPr lang="ko-KR" altLang="en-US" sz="2000" dirty="0">
+              <a:solidFill>
+                <a:schemeClr val="tx1"/>
+              </a:solidFill>
+              <a:latin typeface="나눔스퀘어 Bold" panose="020B0600000101010101" pitchFamily="50" charset="-127"/>
+              <a:ea typeface="나눔스퀘어 Bold" panose="020B0600000101010101" pitchFamily="50" charset="-127"/>
+            </a:endParaRPr>
+          </a:p>
+        </p:txBody>
+      </p:sp>
+      <p:sp>
+        <p:nvSpPr>
+          <p:cNvPr id="30" name="모서리가 둥근 직사각형 29"/>
+          <p:cNvSpPr/>
+          <p:nvPr/>
+        </p:nvSpPr>
+        <p:spPr>
+          <a:xfrm>
+            <a:off x="6893899" y="-1015825"/>
+            <a:ext cx="3060000" cy="432000"/>
+          </a:xfrm>
+          <a:prstGeom prst="roundRect">
+            <a:avLst/>
+          </a:prstGeom>
+          <a:solidFill>
+            <a:schemeClr val="bg1"/>
+          </a:solidFill>
+          <a:ln w="19050">
+            <a:solidFill>
+              <a:schemeClr val="tx1"/>
+            </a:solidFill>
+          </a:ln>
+        </p:spPr>
+        <p:style>
+          <a:lnRef idx="2">
+            <a:schemeClr val="accent1">
+              <a:shade val="50000"/>
+            </a:schemeClr>
+          </a:lnRef>
+          <a:fillRef idx="1">
+            <a:schemeClr val="accent1"/>
+          </a:fillRef>
+          <a:effectRef idx="0">
+            <a:schemeClr val="accent1"/>
+          </a:effectRef>
+          <a:fontRef idx="minor">
+            <a:schemeClr val="lt1"/>
+          </a:fontRef>
+        </p:style>
+        <p:txBody>
+          <a:bodyPr rtlCol="0" anchor="ctr"/>
+          <a:lstStyle/>
+          <a:p>
+            <a:pPr algn="ctr"/>
+            <a:r>
+              <a:rPr lang="ko-KR" altLang="en-US" sz="2000" dirty="0" err="1" smtClean="0">
+                <a:solidFill>
+                  <a:schemeClr val="tx1"/>
+                </a:solidFill>
+                <a:latin typeface="나눔스퀘어 Bold" panose="020B0600000101010101" pitchFamily="50" charset="-127"/>
+                <a:ea typeface="나눔스퀘어 Bold" panose="020B0600000101010101" pitchFamily="50" charset="-127"/>
+              </a:rPr>
+              <a:t>서블릿</a:t>
+            </a:r>
+            <a:r>
+              <a:rPr lang="ko-KR" altLang="en-US" sz="2000" dirty="0" smtClean="0">
+                <a:solidFill>
+                  <a:schemeClr val="tx1"/>
+                </a:solidFill>
+                <a:latin typeface="나눔스퀘어 Bold" panose="020B0600000101010101" pitchFamily="50" charset="-127"/>
+                <a:ea typeface="나눔스퀘어 Bold" panose="020B0600000101010101" pitchFamily="50" charset="-127"/>
+              </a:rPr>
+              <a:t> 컨테이너</a:t>
+            </a:r>
+            <a:r>
+              <a:rPr lang="en-US" altLang="ko-KR" sz="2000" dirty="0" smtClean="0">
+                <a:solidFill>
+                  <a:schemeClr val="tx1"/>
+                </a:solidFill>
+                <a:latin typeface="나눔스퀘어 Bold" panose="020B0600000101010101" pitchFamily="50" charset="-127"/>
+                <a:ea typeface="나눔스퀘어 Bold" panose="020B0600000101010101" pitchFamily="50" charset="-127"/>
+              </a:rPr>
+              <a:t>(Tomcat)</a:t>
+            </a:r>
+            <a:endParaRPr lang="ko-KR" altLang="en-US" sz="2000" dirty="0">
+              <a:solidFill>
+                <a:schemeClr val="tx1"/>
+              </a:solidFill>
+              <a:latin typeface="나눔스퀘어 Bold" panose="020B0600000101010101" pitchFamily="50" charset="-127"/>
+              <a:ea typeface="나눔스퀘어 Bold" panose="020B0600000101010101" pitchFamily="50" charset="-127"/>
+            </a:endParaRPr>
+          </a:p>
+        </p:txBody>
+      </p:sp>
+      <p:sp>
+        <p:nvSpPr>
+          <p:cNvPr id="31" name="직사각형 30"/>
+          <p:cNvSpPr/>
+          <p:nvPr/>
+        </p:nvSpPr>
+        <p:spPr>
+          <a:xfrm>
+            <a:off x="7786288" y="6538930"/>
+            <a:ext cx="6480000" cy="720000"/>
+          </a:xfrm>
+          <a:prstGeom prst="rect">
+            <a:avLst/>
+          </a:prstGeom>
+          <a:solidFill>
+            <a:schemeClr val="accent5"/>
+          </a:solidFill>
+          <a:ln>
+            <a:noFill/>
+          </a:ln>
+        </p:spPr>
+        <p:style>
+          <a:lnRef idx="2">
+            <a:schemeClr val="accent1">
+              <a:shade val="50000"/>
+            </a:schemeClr>
+          </a:lnRef>
+          <a:fillRef idx="1">
+            <a:schemeClr val="accent1"/>
+          </a:fillRef>
+          <a:effectRef idx="0">
+            <a:schemeClr val="accent1"/>
+          </a:effectRef>
+          <a:fontRef idx="minor">
+            <a:schemeClr val="lt1"/>
+          </a:fontRef>
+        </p:style>
+        <p:txBody>
+          <a:bodyPr rtlCol="0" anchor="ctr"/>
+          <a:lstStyle/>
+          <a:p>
+            <a:pPr algn="ctr"/>
+            <a:r>
+              <a:rPr lang="en-US" altLang="ko-KR" sz="2400" dirty="0" err="1" smtClean="0">
+                <a:latin typeface="나눔스퀘어 Bold" panose="020B0600000101010101" pitchFamily="50" charset="-127"/>
+                <a:ea typeface="나눔스퀘어 Bold" panose="020B0600000101010101" pitchFamily="50" charset="-127"/>
+              </a:rPr>
+              <a:t>UsernamePasswordAuththenticationFilter</a:t>
+            </a:r>
+            <a:endParaRPr lang="ko-KR" altLang="en-US" sz="2800" dirty="0">
+              <a:latin typeface="나눔스퀘어 Bold" panose="020B0600000101010101" pitchFamily="50" charset="-127"/>
+              <a:ea typeface="나눔스퀘어 Bold" panose="020B0600000101010101" pitchFamily="50" charset="-127"/>
+            </a:endParaRPr>
+          </a:p>
+        </p:txBody>
+      </p:sp>
+      <p:sp>
+        <p:nvSpPr>
+          <p:cNvPr id="32" name="직사각형 31"/>
+          <p:cNvSpPr/>
+          <p:nvPr/>
+        </p:nvSpPr>
+        <p:spPr>
+          <a:xfrm>
+            <a:off x="7786288" y="5162765"/>
+            <a:ext cx="6480000" cy="720000"/>
+          </a:xfrm>
+          <a:prstGeom prst="rect">
+            <a:avLst/>
+          </a:prstGeom>
+          <a:solidFill>
+            <a:schemeClr val="accent5"/>
+          </a:solidFill>
+          <a:ln>
+            <a:noFill/>
+          </a:ln>
+        </p:spPr>
+        <p:style>
+          <a:lnRef idx="2">
+            <a:schemeClr val="accent1">
+              <a:shade val="50000"/>
+            </a:schemeClr>
+          </a:lnRef>
+          <a:fillRef idx="1">
+            <a:schemeClr val="accent1"/>
+          </a:fillRef>
+          <a:effectRef idx="0">
+            <a:schemeClr val="accent1"/>
+          </a:effectRef>
+          <a:fontRef idx="minor">
+            <a:schemeClr val="lt1"/>
+          </a:fontRef>
+        </p:style>
+        <p:txBody>
+          <a:bodyPr rtlCol="0" anchor="ctr"/>
+          <a:lstStyle/>
+          <a:p>
+            <a:pPr algn="ctr"/>
+            <a:r>
+              <a:rPr lang="en-US" altLang="ko-KR" sz="3200" dirty="0" err="1" smtClean="0">
+                <a:latin typeface="나눔스퀘어 Bold" panose="020B0600000101010101" pitchFamily="50" charset="-127"/>
+                <a:ea typeface="나눔스퀘어 Bold" panose="020B0600000101010101" pitchFamily="50" charset="-127"/>
+              </a:rPr>
+              <a:t>AuthenticationManager</a:t>
+            </a:r>
+            <a:endParaRPr lang="ko-KR" altLang="en-US" sz="3200" dirty="0">
+              <a:latin typeface="나눔스퀘어 Bold" panose="020B0600000101010101" pitchFamily="50" charset="-127"/>
+              <a:ea typeface="나눔스퀘어 Bold" panose="020B0600000101010101" pitchFamily="50" charset="-127"/>
+            </a:endParaRPr>
+          </a:p>
+        </p:txBody>
+      </p:sp>
+      <p:sp>
+        <p:nvSpPr>
+          <p:cNvPr id="33" name="직사각형 32"/>
+          <p:cNvSpPr/>
+          <p:nvPr/>
+        </p:nvSpPr>
+        <p:spPr>
+          <a:xfrm>
+            <a:off x="7786288" y="3785162"/>
+            <a:ext cx="6480000" cy="720000"/>
+          </a:xfrm>
+          <a:prstGeom prst="rect">
+            <a:avLst/>
+          </a:prstGeom>
+          <a:solidFill>
+            <a:schemeClr val="accent5"/>
+          </a:solidFill>
+          <a:ln>
+            <a:noFill/>
+          </a:ln>
+        </p:spPr>
+        <p:style>
+          <a:lnRef idx="2">
+            <a:schemeClr val="accent1">
+              <a:shade val="50000"/>
+            </a:schemeClr>
+          </a:lnRef>
+          <a:fillRef idx="1">
+            <a:schemeClr val="accent1"/>
+          </a:fillRef>
+          <a:effectRef idx="0">
+            <a:schemeClr val="accent1"/>
+          </a:effectRef>
+          <a:fontRef idx="minor">
+            <a:schemeClr val="lt1"/>
+          </a:fontRef>
+        </p:style>
+        <p:txBody>
+          <a:bodyPr rtlCol="0" anchor="ctr"/>
+          <a:lstStyle/>
+          <a:p>
+            <a:pPr algn="ctr"/>
+            <a:r>
+              <a:rPr lang="en-US" altLang="ko-KR" sz="3200" dirty="0" err="1" smtClean="0">
+                <a:latin typeface="나눔스퀘어 Bold" panose="020B0600000101010101" pitchFamily="50" charset="-127"/>
+                <a:ea typeface="나눔스퀘어 Bold" panose="020B0600000101010101" pitchFamily="50" charset="-127"/>
+              </a:rPr>
+              <a:t>AuthenticationProvider</a:t>
+            </a:r>
+            <a:endParaRPr lang="ko-KR" altLang="en-US" sz="3200" dirty="0">
+              <a:latin typeface="나눔스퀘어 Bold" panose="020B0600000101010101" pitchFamily="50" charset="-127"/>
+              <a:ea typeface="나눔스퀘어 Bold" panose="020B0600000101010101" pitchFamily="50" charset="-127"/>
+            </a:endParaRPr>
+          </a:p>
+        </p:txBody>
+      </p:sp>
+      <p:sp>
+        <p:nvSpPr>
+          <p:cNvPr id="34" name="직사각형 33"/>
+          <p:cNvSpPr/>
+          <p:nvPr/>
+        </p:nvSpPr>
+        <p:spPr>
+          <a:xfrm>
+            <a:off x="7786288" y="2407559"/>
+            <a:ext cx="6480000" cy="720000"/>
+          </a:xfrm>
+          <a:prstGeom prst="rect">
+            <a:avLst/>
+          </a:prstGeom>
+          <a:solidFill>
+            <a:schemeClr val="accent5"/>
+          </a:solidFill>
+          <a:ln>
+            <a:noFill/>
+          </a:ln>
+        </p:spPr>
+        <p:style>
+          <a:lnRef idx="2">
+            <a:schemeClr val="accent1">
+              <a:shade val="50000"/>
+            </a:schemeClr>
+          </a:lnRef>
+          <a:fillRef idx="1">
+            <a:schemeClr val="accent1"/>
+          </a:fillRef>
+          <a:effectRef idx="0">
+            <a:schemeClr val="accent1"/>
+          </a:effectRef>
+          <a:fontRef idx="minor">
+            <a:schemeClr val="lt1"/>
+          </a:fontRef>
+        </p:style>
+        <p:txBody>
+          <a:bodyPr rtlCol="0" anchor="ctr"/>
+          <a:lstStyle/>
+          <a:p>
+            <a:pPr algn="ctr"/>
+            <a:r>
+              <a:rPr lang="en-US" altLang="ko-KR" sz="3200" dirty="0" err="1" smtClean="0">
+                <a:latin typeface="나눔스퀘어 Bold" panose="020B0600000101010101" pitchFamily="50" charset="-127"/>
+                <a:ea typeface="나눔스퀘어 Bold" panose="020B0600000101010101" pitchFamily="50" charset="-127"/>
+              </a:rPr>
+              <a:t>UserDetailService</a:t>
+            </a:r>
+            <a:endParaRPr lang="ko-KR" altLang="en-US" sz="3200" dirty="0">
+              <a:latin typeface="나눔스퀘어 Bold" panose="020B0600000101010101" pitchFamily="50" charset="-127"/>
+              <a:ea typeface="나눔스퀘어 Bold" panose="020B0600000101010101" pitchFamily="50" charset="-127"/>
+            </a:endParaRPr>
+          </a:p>
+        </p:txBody>
+      </p:sp>
+      <p:sp>
+        <p:nvSpPr>
+          <p:cNvPr id="35" name="직사각형 34"/>
+          <p:cNvSpPr/>
+          <p:nvPr/>
+        </p:nvSpPr>
+        <p:spPr>
+          <a:xfrm>
+            <a:off x="7788388" y="7915095"/>
+            <a:ext cx="6480000" cy="1800000"/>
+          </a:xfrm>
+          <a:prstGeom prst="rect">
+            <a:avLst/>
+          </a:prstGeom>
+          <a:solidFill>
+            <a:schemeClr val="accent5"/>
+          </a:solidFill>
+          <a:ln>
+            <a:noFill/>
+          </a:ln>
+        </p:spPr>
+        <p:style>
+          <a:lnRef idx="2">
+            <a:schemeClr val="accent1">
+              <a:shade val="50000"/>
+            </a:schemeClr>
+          </a:lnRef>
+          <a:fillRef idx="1">
+            <a:schemeClr val="accent1"/>
+          </a:fillRef>
+          <a:effectRef idx="0">
+            <a:schemeClr val="accent1"/>
+          </a:effectRef>
+          <a:fontRef idx="minor">
+            <a:schemeClr val="lt1"/>
+          </a:fontRef>
+        </p:style>
+        <p:txBody>
+          <a:bodyPr rtlCol="0" anchor="ctr"/>
+          <a:lstStyle/>
+          <a:p>
+            <a:pPr algn="ctr"/>
+            <a:r>
+              <a:rPr lang="en-US" altLang="ko-KR" sz="2800" dirty="0" err="1" smtClean="0">
+                <a:latin typeface="나눔스퀘어 Bold" panose="020B0600000101010101" pitchFamily="50" charset="-127"/>
+                <a:ea typeface="나눔스퀘어 Bold" panose="020B0600000101010101" pitchFamily="50" charset="-127"/>
+              </a:rPr>
+              <a:t>SecurityContextHolder</a:t>
+            </a:r>
+            <a:endParaRPr lang="en-US" altLang="ko-KR" sz="2800" dirty="0" smtClean="0">
+              <a:latin typeface="나눔스퀘어 Bold" panose="020B0600000101010101" pitchFamily="50" charset="-127"/>
+              <a:ea typeface="나눔스퀘어 Bold" panose="020B0600000101010101" pitchFamily="50" charset="-127"/>
+            </a:endParaRPr>
+          </a:p>
+          <a:p>
+            <a:pPr algn="ctr"/>
+            <a:endParaRPr lang="en-US" altLang="ko-KR" sz="2800" dirty="0">
+              <a:latin typeface="나눔스퀘어 Bold" panose="020B0600000101010101" pitchFamily="50" charset="-127"/>
+              <a:ea typeface="나눔스퀘어 Bold" panose="020B0600000101010101" pitchFamily="50" charset="-127"/>
+            </a:endParaRPr>
+          </a:p>
+          <a:p>
+            <a:pPr algn="ctr"/>
+            <a:endParaRPr lang="en-US" altLang="ko-KR" sz="2400" dirty="0" smtClean="0">
+              <a:latin typeface="나눔스퀘어 Bold" panose="020B0600000101010101" pitchFamily="50" charset="-127"/>
+              <a:ea typeface="나눔스퀘어 Bold" panose="020B0600000101010101" pitchFamily="50" charset="-127"/>
+            </a:endParaRPr>
+          </a:p>
+          <a:p>
+            <a:pPr algn="ctr"/>
+            <a:endParaRPr lang="en-US" altLang="ko-KR" sz="2000" dirty="0" smtClean="0">
+              <a:latin typeface="나눔스퀘어 Bold" panose="020B0600000101010101" pitchFamily="50" charset="-127"/>
+              <a:ea typeface="나눔스퀘어 Bold" panose="020B0600000101010101" pitchFamily="50" charset="-127"/>
+            </a:endParaRPr>
+          </a:p>
+        </p:txBody>
+      </p:sp>
+      <p:sp>
+        <p:nvSpPr>
+          <p:cNvPr id="36" name="직사각형 35"/>
+          <p:cNvSpPr/>
+          <p:nvPr/>
+        </p:nvSpPr>
+        <p:spPr>
+          <a:xfrm>
+            <a:off x="8482138" y="8635095"/>
+            <a:ext cx="5040000" cy="720000"/>
+          </a:xfrm>
+          <a:prstGeom prst="rect">
+            <a:avLst/>
+          </a:prstGeom>
+          <a:solidFill>
+            <a:schemeClr val="accent1"/>
+          </a:solidFill>
+          <a:ln>
+            <a:noFill/>
+          </a:ln>
+        </p:spPr>
+        <p:style>
+          <a:lnRef idx="2">
+            <a:schemeClr val="accent1">
+              <a:shade val="50000"/>
+            </a:schemeClr>
+          </a:lnRef>
+          <a:fillRef idx="1">
+            <a:schemeClr val="accent1"/>
+          </a:fillRef>
+          <a:effectRef idx="0">
+            <a:schemeClr val="accent1"/>
+          </a:effectRef>
+          <a:fontRef idx="minor">
+            <a:schemeClr val="lt1"/>
+          </a:fontRef>
+        </p:style>
+        <p:txBody>
+          <a:bodyPr rtlCol="0" anchor="ctr"/>
+          <a:lstStyle/>
+          <a:p>
+            <a:pPr algn="ctr"/>
+            <a:r>
+              <a:rPr lang="en-US" altLang="ko-KR" sz="3600" dirty="0">
+                <a:latin typeface="나눔스퀘어 Bold" panose="020B0600000101010101" pitchFamily="50" charset="-127"/>
+                <a:ea typeface="나눔스퀘어 Bold" panose="020B0600000101010101" pitchFamily="50" charset="-127"/>
+              </a:rPr>
+              <a:t>Principal</a:t>
+            </a:r>
+            <a:endParaRPr lang="ko-KR" altLang="en-US" sz="3600" dirty="0">
+              <a:latin typeface="나눔스퀘어 Bold" panose="020B0600000101010101" pitchFamily="50" charset="-127"/>
+              <a:ea typeface="나눔스퀘어 Bold" panose="020B0600000101010101" pitchFamily="50" charset="-127"/>
+            </a:endParaRPr>
+          </a:p>
+        </p:txBody>
+      </p:sp>
+      <p:cxnSp>
+        <p:nvCxnSpPr>
+          <p:cNvPr id="37" name="직선 화살표 연결선 36"/>
+          <p:cNvCxnSpPr>
+            <a:endCxn id="33" idx="0"/>
+          </p:cNvCxnSpPr>
+          <p:nvPr/>
+        </p:nvCxnSpPr>
+        <p:spPr>
+          <a:xfrm>
+            <a:off x="11026288" y="3127559"/>
+            <a:ext cx="0" cy="657603"/>
+          </a:xfrm>
+          <a:prstGeom prst="straightConnector1">
+            <a:avLst/>
+          </a:prstGeom>
+          <a:ln w="76200">
+            <a:solidFill>
+              <a:schemeClr val="accent2"/>
+            </a:solidFill>
+            <a:tailEnd type="triangle"/>
+          </a:ln>
+        </p:spPr>
+        <p:style>
+          <a:lnRef idx="1">
+            <a:schemeClr val="accent1"/>
+          </a:lnRef>
+          <a:fillRef idx="0">
+            <a:schemeClr val="accent1"/>
+          </a:fillRef>
+          <a:effectRef idx="0">
+            <a:schemeClr val="accent1"/>
+          </a:effectRef>
+          <a:fontRef idx="minor">
+            <a:schemeClr val="tx1"/>
+          </a:fontRef>
+        </p:style>
+      </p:cxnSp>
+      <p:cxnSp>
+        <p:nvCxnSpPr>
+          <p:cNvPr id="38" name="직선 화살표 연결선 37"/>
+          <p:cNvCxnSpPr>
+            <a:stCxn id="33" idx="2"/>
+            <a:endCxn id="32" idx="0"/>
+          </p:cNvCxnSpPr>
+          <p:nvPr/>
+        </p:nvCxnSpPr>
+        <p:spPr>
+          <a:xfrm>
+            <a:off x="11026288" y="4505162"/>
+            <a:ext cx="0" cy="657603"/>
+          </a:xfrm>
+          <a:prstGeom prst="straightConnector1">
+            <a:avLst/>
+          </a:prstGeom>
+          <a:ln w="76200">
+            <a:solidFill>
+              <a:schemeClr val="accent2"/>
+            </a:solidFill>
+            <a:tailEnd type="triangle"/>
+          </a:ln>
+        </p:spPr>
+        <p:style>
+          <a:lnRef idx="1">
+            <a:schemeClr val="accent1"/>
+          </a:lnRef>
+          <a:fillRef idx="0">
+            <a:schemeClr val="accent1"/>
+          </a:fillRef>
+          <a:effectRef idx="0">
+            <a:schemeClr val="accent1"/>
+          </a:effectRef>
+          <a:fontRef idx="minor">
+            <a:schemeClr val="tx1"/>
+          </a:fontRef>
+        </p:style>
+      </p:cxnSp>
+      <p:cxnSp>
+        <p:nvCxnSpPr>
+          <p:cNvPr id="39" name="직선 화살표 연결선 38"/>
+          <p:cNvCxnSpPr>
+            <a:stCxn id="32" idx="2"/>
+            <a:endCxn id="31" idx="0"/>
+          </p:cNvCxnSpPr>
+          <p:nvPr/>
+        </p:nvCxnSpPr>
+        <p:spPr>
+          <a:xfrm>
+            <a:off x="11026288" y="5882765"/>
+            <a:ext cx="0" cy="656165"/>
+          </a:xfrm>
+          <a:prstGeom prst="straightConnector1">
+            <a:avLst/>
+          </a:prstGeom>
+          <a:ln w="76200">
+            <a:solidFill>
+              <a:schemeClr val="accent2"/>
+            </a:solidFill>
+            <a:tailEnd type="triangle"/>
+          </a:ln>
+        </p:spPr>
+        <p:style>
+          <a:lnRef idx="1">
+            <a:schemeClr val="accent1"/>
+          </a:lnRef>
+          <a:fillRef idx="0">
+            <a:schemeClr val="accent1"/>
+          </a:fillRef>
+          <a:effectRef idx="0">
+            <a:schemeClr val="accent1"/>
+          </a:effectRef>
+          <a:fontRef idx="minor">
+            <a:schemeClr val="tx1"/>
+          </a:fontRef>
+        </p:style>
+      </p:cxnSp>
+      <p:cxnSp>
+        <p:nvCxnSpPr>
+          <p:cNvPr id="40" name="직선 화살표 연결선 39"/>
+          <p:cNvCxnSpPr>
+            <a:stCxn id="31" idx="2"/>
+            <a:endCxn id="35" idx="0"/>
+          </p:cNvCxnSpPr>
+          <p:nvPr/>
+        </p:nvCxnSpPr>
+        <p:spPr>
+          <a:xfrm>
+            <a:off x="11026288" y="7258930"/>
+            <a:ext cx="2100" cy="656165"/>
+          </a:xfrm>
+          <a:prstGeom prst="straightConnector1">
+            <a:avLst/>
+          </a:prstGeom>
+          <a:ln w="76200">
+            <a:solidFill>
+              <a:schemeClr val="accent2"/>
+            </a:solidFill>
+            <a:tailEnd type="triangle"/>
+          </a:ln>
+        </p:spPr>
+        <p:style>
+          <a:lnRef idx="1">
+            <a:schemeClr val="accent1"/>
+          </a:lnRef>
+          <a:fillRef idx="0">
+            <a:schemeClr val="accent1"/>
+          </a:fillRef>
+          <a:effectRef idx="0">
+            <a:schemeClr val="accent1"/>
+          </a:effectRef>
+          <a:fontRef idx="minor">
+            <a:schemeClr val="tx1"/>
+          </a:fontRef>
+        </p:style>
+      </p:cxnSp>
+      <p:sp>
+        <p:nvSpPr>
+          <p:cNvPr id="41" name="직사각형 40"/>
+          <p:cNvSpPr/>
+          <p:nvPr/>
+        </p:nvSpPr>
+        <p:spPr>
+          <a:xfrm>
+            <a:off x="7426288" y="1746108"/>
+            <a:ext cx="7200000" cy="8280000"/>
+          </a:xfrm>
+          <a:prstGeom prst="rect">
+            <a:avLst/>
+          </a:prstGeom>
+          <a:noFill/>
+          <a:ln w="19050">
+            <a:solidFill>
+              <a:schemeClr val="tx1"/>
+            </a:solidFill>
+          </a:ln>
+        </p:spPr>
+        <p:style>
+          <a:lnRef idx="2">
+            <a:schemeClr val="accent1">
+              <a:shade val="50000"/>
+            </a:schemeClr>
+          </a:lnRef>
+          <a:fillRef idx="1">
+            <a:schemeClr val="accent1"/>
+          </a:fillRef>
+          <a:effectRef idx="0">
+            <a:schemeClr val="accent1"/>
+          </a:effectRef>
+          <a:fontRef idx="minor">
+            <a:schemeClr val="lt1"/>
+          </a:fontRef>
+        </p:style>
+        <p:txBody>
+          <a:bodyPr rtlCol="0" anchor="ctr"/>
+          <a:lstStyle/>
+          <a:p>
+            <a:pPr algn="ctr"/>
+            <a:endParaRPr lang="ko-KR" altLang="en-US"/>
+          </a:p>
+        </p:txBody>
+      </p:sp>
+      <p:sp>
+        <p:nvSpPr>
+          <p:cNvPr id="42" name="모서리가 둥근 직사각형 41"/>
+          <p:cNvSpPr/>
+          <p:nvPr/>
+        </p:nvSpPr>
+        <p:spPr>
+          <a:xfrm>
+            <a:off x="9652138" y="1386109"/>
+            <a:ext cx="2700000" cy="540000"/>
+          </a:xfrm>
+          <a:prstGeom prst="roundRect">
+            <a:avLst/>
+          </a:prstGeom>
+          <a:solidFill>
+            <a:schemeClr val="bg1"/>
+          </a:solidFill>
+          <a:ln w="19050">
+            <a:solidFill>
+              <a:schemeClr val="tx1"/>
+            </a:solidFill>
+          </a:ln>
+        </p:spPr>
+        <p:style>
+          <a:lnRef idx="2">
+            <a:schemeClr val="accent1">
+              <a:shade val="50000"/>
+            </a:schemeClr>
+          </a:lnRef>
+          <a:fillRef idx="1">
+            <a:schemeClr val="accent1"/>
+          </a:fillRef>
+          <a:effectRef idx="0">
+            <a:schemeClr val="accent1"/>
+          </a:effectRef>
+          <a:fontRef idx="minor">
+            <a:schemeClr val="lt1"/>
+          </a:fontRef>
+        </p:style>
+        <p:txBody>
+          <a:bodyPr rtlCol="0" anchor="ctr"/>
+          <a:lstStyle/>
+          <a:p>
+            <a:pPr algn="ctr"/>
+            <a:r>
+              <a:rPr lang="en-US" altLang="ko-KR" sz="2000" dirty="0" smtClean="0">
+                <a:solidFill>
+                  <a:schemeClr val="tx1"/>
+                </a:solidFill>
+                <a:latin typeface="나눔스퀘어 Bold" panose="020B0600000101010101" pitchFamily="50" charset="-127"/>
+                <a:ea typeface="나눔스퀘어 Bold" panose="020B0600000101010101" pitchFamily="50" charset="-127"/>
+              </a:rPr>
+              <a:t>Spring </a:t>
+            </a:r>
+            <a:r>
+              <a:rPr lang="en-US" altLang="ko-KR" sz="2000" dirty="0" err="1" smtClean="0">
+                <a:solidFill>
+                  <a:schemeClr val="tx1"/>
+                </a:solidFill>
+                <a:latin typeface="나눔스퀘어 Bold" panose="020B0600000101010101" pitchFamily="50" charset="-127"/>
+                <a:ea typeface="나눔스퀘어 Bold" panose="020B0600000101010101" pitchFamily="50" charset="-127"/>
+              </a:rPr>
+              <a:t>IoC</a:t>
+            </a:r>
+            <a:r>
+              <a:rPr lang="en-US" altLang="ko-KR" sz="2000" dirty="0" smtClean="0">
+                <a:solidFill>
+                  <a:schemeClr val="tx1"/>
+                </a:solidFill>
+                <a:latin typeface="나눔스퀘어 Bold" panose="020B0600000101010101" pitchFamily="50" charset="-127"/>
+                <a:ea typeface="나눔스퀘어 Bold" panose="020B0600000101010101" pitchFamily="50" charset="-127"/>
+              </a:rPr>
+              <a:t> Container</a:t>
+            </a:r>
+            <a:endParaRPr lang="ko-KR" altLang="en-US" sz="2000" dirty="0">
+              <a:solidFill>
+                <a:schemeClr val="tx1"/>
+              </a:solidFill>
+              <a:latin typeface="나눔스퀘어 Bold" panose="020B0600000101010101" pitchFamily="50" charset="-127"/>
+              <a:ea typeface="나눔스퀘어 Bold" panose="020B0600000101010101" pitchFamily="50" charset="-127"/>
+            </a:endParaRPr>
+          </a:p>
+        </p:txBody>
+      </p:sp>
+      <p:sp>
+        <p:nvSpPr>
+          <p:cNvPr id="43" name="TextBox 42"/>
+          <p:cNvSpPr txBox="1"/>
+          <p:nvPr/>
+        </p:nvSpPr>
+        <p:spPr>
+          <a:xfrm>
+            <a:off x="11237270" y="7402346"/>
             <a:ext cx="1560042" cy="369332"/>
           </a:xfrm>
           <a:prstGeom prst="rect">
@@ -4559,13 +5387,13 @@
       </p:sp>
       <p:sp>
         <p:nvSpPr>
-          <p:cNvPr id="33" name="TextBox 32"/>
+          <p:cNvPr id="44" name="TextBox 43"/>
           <p:cNvSpPr txBox="1"/>
           <p:nvPr/>
         </p:nvSpPr>
         <p:spPr>
           <a:xfrm>
-            <a:off x="5324032" y="5085935"/>
+            <a:off x="11237270" y="6023141"/>
             <a:ext cx="1560042" cy="369332"/>
           </a:xfrm>
           <a:prstGeom prst="rect">
@@ -4595,13 +5423,13 @@
       </p:sp>
       <p:sp>
         <p:nvSpPr>
-          <p:cNvPr id="34" name="TextBox 33"/>
+          <p:cNvPr id="45" name="TextBox 44"/>
           <p:cNvSpPr txBox="1"/>
           <p:nvPr/>
         </p:nvSpPr>
         <p:spPr>
           <a:xfrm>
-            <a:off x="5324032" y="3708730"/>
+            <a:off x="11237270" y="4645936"/>
             <a:ext cx="1560042" cy="369332"/>
           </a:xfrm>
           <a:prstGeom prst="rect">
@@ -4631,13 +5459,13 @@
       </p:sp>
       <p:sp>
         <p:nvSpPr>
-          <p:cNvPr id="35" name="TextBox 34"/>
+          <p:cNvPr id="46" name="TextBox 45"/>
           <p:cNvSpPr txBox="1"/>
           <p:nvPr/>
         </p:nvSpPr>
         <p:spPr>
           <a:xfrm>
-            <a:off x="5324032" y="2332565"/>
+            <a:off x="11237270" y="3269771"/>
             <a:ext cx="1895071" cy="369332"/>
           </a:xfrm>
           <a:prstGeom prst="rect">
@@ -4682,7 +5510,7 @@
     </p:spTree>
     <p:extLst>
       <p:ext uri="{BB962C8B-B14F-4D97-AF65-F5344CB8AC3E}">
-        <p14:creationId xmlns:p14="http://schemas.microsoft.com/office/powerpoint/2010/main" val="1159339994"/>
+        <p14:creationId xmlns:p14="http://schemas.microsoft.com/office/powerpoint/2010/main" val="2040070256"/>
       </p:ext>
     </p:extLst>
   </p:cSld>
@@ -4718,1843 +5546,6 @@
       </p:grpSpPr>
       <p:sp>
         <p:nvSpPr>
-          <p:cNvPr id="7" name="직사각형 6"/>
-          <p:cNvSpPr/>
-          <p:nvPr/>
-        </p:nvSpPr>
-        <p:spPr>
-          <a:xfrm>
-            <a:off x="3923899" y="-762144"/>
-            <a:ext cx="9000000" cy="1800000"/>
-          </a:xfrm>
-          <a:prstGeom prst="rect">
-            <a:avLst/>
-          </a:prstGeom>
-          <a:noFill/>
-          <a:ln w="19050">
-            <a:solidFill>
-              <a:schemeClr val="tx1"/>
-            </a:solidFill>
-          </a:ln>
-        </p:spPr>
-        <p:style>
-          <a:lnRef idx="2">
-            <a:schemeClr val="accent1">
-              <a:shade val="50000"/>
-            </a:schemeClr>
-          </a:lnRef>
-          <a:fillRef idx="1">
-            <a:schemeClr val="accent1"/>
-          </a:fillRef>
-          <a:effectRef idx="0">
-            <a:schemeClr val="accent1"/>
-          </a:effectRef>
-          <a:fontRef idx="minor">
-            <a:schemeClr val="lt1"/>
-          </a:fontRef>
-        </p:style>
-        <p:txBody>
-          <a:bodyPr rtlCol="0" anchor="ctr"/>
-          <a:lstStyle/>
-          <a:p>
-            <a:pPr algn="ctr"/>
-            <a:endParaRPr lang="ko-KR" altLang="en-US"/>
-          </a:p>
-        </p:txBody>
-      </p:sp>
-      <p:sp>
-        <p:nvSpPr>
-          <p:cNvPr id="108" name="직사각형 107"/>
-          <p:cNvSpPr/>
-          <p:nvPr/>
-        </p:nvSpPr>
-        <p:spPr>
-          <a:xfrm>
-            <a:off x="-353500" y="1761402"/>
-            <a:ext cx="7200000" cy="7200000"/>
-          </a:xfrm>
-          <a:prstGeom prst="rect">
-            <a:avLst/>
-          </a:prstGeom>
-          <a:noFill/>
-          <a:ln w="19050">
-            <a:solidFill>
-              <a:schemeClr val="tx1"/>
-            </a:solidFill>
-          </a:ln>
-        </p:spPr>
-        <p:style>
-          <a:lnRef idx="2">
-            <a:schemeClr val="accent1">
-              <a:shade val="50000"/>
-            </a:schemeClr>
-          </a:lnRef>
-          <a:fillRef idx="1">
-            <a:schemeClr val="accent1"/>
-          </a:fillRef>
-          <a:effectRef idx="0">
-            <a:schemeClr val="accent1"/>
-          </a:effectRef>
-          <a:fontRef idx="minor">
-            <a:schemeClr val="lt1"/>
-          </a:fontRef>
-        </p:style>
-        <p:txBody>
-          <a:bodyPr rtlCol="0" anchor="ctr"/>
-          <a:lstStyle/>
-          <a:p>
-            <a:pPr algn="ctr"/>
-            <a:endParaRPr lang="ko-KR" altLang="en-US"/>
-          </a:p>
-        </p:txBody>
-      </p:sp>
-      <p:sp>
-        <p:nvSpPr>
-          <p:cNvPr id="40" name="직사각형 39"/>
-          <p:cNvSpPr/>
-          <p:nvPr/>
-        </p:nvSpPr>
-        <p:spPr>
-          <a:xfrm>
-            <a:off x="7626150" y="6554224"/>
-            <a:ext cx="6480000" cy="720000"/>
-          </a:xfrm>
-          <a:prstGeom prst="rect">
-            <a:avLst/>
-          </a:prstGeom>
-          <a:solidFill>
-            <a:schemeClr val="accent5"/>
-          </a:solidFill>
-          <a:ln>
-            <a:noFill/>
-          </a:ln>
-        </p:spPr>
-        <p:style>
-          <a:lnRef idx="2">
-            <a:schemeClr val="accent1">
-              <a:shade val="50000"/>
-            </a:schemeClr>
-          </a:lnRef>
-          <a:fillRef idx="1">
-            <a:schemeClr val="accent1"/>
-          </a:fillRef>
-          <a:effectRef idx="0">
-            <a:schemeClr val="accent1"/>
-          </a:effectRef>
-          <a:fontRef idx="minor">
-            <a:schemeClr val="lt1"/>
-          </a:fontRef>
-        </p:style>
-        <p:txBody>
-          <a:bodyPr rtlCol="0" anchor="ctr"/>
-          <a:lstStyle/>
-          <a:p>
-            <a:pPr algn="ctr"/>
-            <a:r>
-              <a:rPr lang="en-US" altLang="ko-KR" sz="2400" dirty="0" err="1" smtClean="0">
-                <a:latin typeface="나눔스퀘어 Bold" panose="020B0600000101010101" pitchFamily="50" charset="-127"/>
-                <a:ea typeface="나눔스퀘어 Bold" panose="020B0600000101010101" pitchFamily="50" charset="-127"/>
-              </a:rPr>
-              <a:t>UsernamePasswordAuththenticationFilter</a:t>
-            </a:r>
-            <a:endParaRPr lang="ko-KR" altLang="en-US" sz="2800" dirty="0">
-              <a:latin typeface="나눔스퀘어 Bold" panose="020B0600000101010101" pitchFamily="50" charset="-127"/>
-              <a:ea typeface="나눔스퀘어 Bold" panose="020B0600000101010101" pitchFamily="50" charset="-127"/>
-            </a:endParaRPr>
-          </a:p>
-        </p:txBody>
-      </p:sp>
-      <p:sp>
-        <p:nvSpPr>
-          <p:cNvPr id="41" name="직사각형 40"/>
-          <p:cNvSpPr/>
-          <p:nvPr/>
-        </p:nvSpPr>
-        <p:spPr>
-          <a:xfrm>
-            <a:off x="7626150" y="5178059"/>
-            <a:ext cx="6480000" cy="720000"/>
-          </a:xfrm>
-          <a:prstGeom prst="rect">
-            <a:avLst/>
-          </a:prstGeom>
-          <a:solidFill>
-            <a:schemeClr val="accent5"/>
-          </a:solidFill>
-          <a:ln>
-            <a:noFill/>
-          </a:ln>
-        </p:spPr>
-        <p:style>
-          <a:lnRef idx="2">
-            <a:schemeClr val="accent1">
-              <a:shade val="50000"/>
-            </a:schemeClr>
-          </a:lnRef>
-          <a:fillRef idx="1">
-            <a:schemeClr val="accent1"/>
-          </a:fillRef>
-          <a:effectRef idx="0">
-            <a:schemeClr val="accent1"/>
-          </a:effectRef>
-          <a:fontRef idx="minor">
-            <a:schemeClr val="lt1"/>
-          </a:fontRef>
-        </p:style>
-        <p:txBody>
-          <a:bodyPr rtlCol="0" anchor="ctr"/>
-          <a:lstStyle/>
-          <a:p>
-            <a:pPr algn="ctr"/>
-            <a:r>
-              <a:rPr lang="en-US" altLang="ko-KR" sz="3200" dirty="0" err="1" smtClean="0">
-                <a:latin typeface="나눔스퀘어 Bold" panose="020B0600000101010101" pitchFamily="50" charset="-127"/>
-                <a:ea typeface="나눔스퀘어 Bold" panose="020B0600000101010101" pitchFamily="50" charset="-127"/>
-              </a:rPr>
-              <a:t>AuthenticationManager</a:t>
-            </a:r>
-            <a:endParaRPr lang="ko-KR" altLang="en-US" sz="3200" dirty="0">
-              <a:latin typeface="나눔스퀘어 Bold" panose="020B0600000101010101" pitchFamily="50" charset="-127"/>
-              <a:ea typeface="나눔스퀘어 Bold" panose="020B0600000101010101" pitchFamily="50" charset="-127"/>
-            </a:endParaRPr>
-          </a:p>
-        </p:txBody>
-      </p:sp>
-      <p:sp>
-        <p:nvSpPr>
-          <p:cNvPr id="42" name="직사각형 41"/>
-          <p:cNvSpPr/>
-          <p:nvPr/>
-        </p:nvSpPr>
-        <p:spPr>
-          <a:xfrm>
-            <a:off x="7626150" y="3800456"/>
-            <a:ext cx="6480000" cy="720000"/>
-          </a:xfrm>
-          <a:prstGeom prst="rect">
-            <a:avLst/>
-          </a:prstGeom>
-          <a:solidFill>
-            <a:schemeClr val="accent5"/>
-          </a:solidFill>
-          <a:ln>
-            <a:noFill/>
-          </a:ln>
-        </p:spPr>
-        <p:style>
-          <a:lnRef idx="2">
-            <a:schemeClr val="accent1">
-              <a:shade val="50000"/>
-            </a:schemeClr>
-          </a:lnRef>
-          <a:fillRef idx="1">
-            <a:schemeClr val="accent1"/>
-          </a:fillRef>
-          <a:effectRef idx="0">
-            <a:schemeClr val="accent1"/>
-          </a:effectRef>
-          <a:fontRef idx="minor">
-            <a:schemeClr val="lt1"/>
-          </a:fontRef>
-        </p:style>
-        <p:txBody>
-          <a:bodyPr rtlCol="0" anchor="ctr"/>
-          <a:lstStyle/>
-          <a:p>
-            <a:pPr algn="ctr"/>
-            <a:r>
-              <a:rPr lang="en-US" altLang="ko-KR" sz="3200" dirty="0" err="1" smtClean="0">
-                <a:latin typeface="나눔스퀘어 Bold" panose="020B0600000101010101" pitchFamily="50" charset="-127"/>
-                <a:ea typeface="나눔스퀘어 Bold" panose="020B0600000101010101" pitchFamily="50" charset="-127"/>
-              </a:rPr>
-              <a:t>AuthenticationProvider</a:t>
-            </a:r>
-            <a:endParaRPr lang="ko-KR" altLang="en-US" sz="3200" dirty="0">
-              <a:latin typeface="나눔스퀘어 Bold" panose="020B0600000101010101" pitchFamily="50" charset="-127"/>
-              <a:ea typeface="나눔스퀘어 Bold" panose="020B0600000101010101" pitchFamily="50" charset="-127"/>
-            </a:endParaRPr>
-          </a:p>
-        </p:txBody>
-      </p:sp>
-      <p:sp>
-        <p:nvSpPr>
-          <p:cNvPr id="43" name="모서리가 둥근 직사각형 42"/>
-          <p:cNvSpPr/>
-          <p:nvPr/>
-        </p:nvSpPr>
-        <p:spPr>
-          <a:xfrm>
-            <a:off x="9492000" y="1401403"/>
-            <a:ext cx="2700000" cy="540000"/>
-          </a:xfrm>
-          <a:prstGeom prst="roundRect">
-            <a:avLst/>
-          </a:prstGeom>
-          <a:solidFill>
-            <a:schemeClr val="bg1"/>
-          </a:solidFill>
-          <a:ln w="19050">
-            <a:solidFill>
-              <a:schemeClr val="tx1"/>
-            </a:solidFill>
-          </a:ln>
-        </p:spPr>
-        <p:style>
-          <a:lnRef idx="2">
-            <a:schemeClr val="accent1">
-              <a:shade val="50000"/>
-            </a:schemeClr>
-          </a:lnRef>
-          <a:fillRef idx="1">
-            <a:schemeClr val="accent1"/>
-          </a:fillRef>
-          <a:effectRef idx="0">
-            <a:schemeClr val="accent1"/>
-          </a:effectRef>
-          <a:fontRef idx="minor">
-            <a:schemeClr val="lt1"/>
-          </a:fontRef>
-        </p:style>
-        <p:txBody>
-          <a:bodyPr rtlCol="0" anchor="ctr"/>
-          <a:lstStyle/>
-          <a:p>
-            <a:pPr algn="ctr"/>
-            <a:r>
-              <a:rPr lang="en-US" altLang="ko-KR" sz="2000" dirty="0" smtClean="0">
-                <a:solidFill>
-                  <a:schemeClr val="tx1"/>
-                </a:solidFill>
-                <a:latin typeface="나눔스퀘어 Bold" panose="020B0600000101010101" pitchFamily="50" charset="-127"/>
-                <a:ea typeface="나눔스퀘어 Bold" panose="020B0600000101010101" pitchFamily="50" charset="-127"/>
-              </a:rPr>
-              <a:t>Spring </a:t>
-            </a:r>
-            <a:r>
-              <a:rPr lang="en-US" altLang="ko-KR" sz="2000" dirty="0" err="1" smtClean="0">
-                <a:solidFill>
-                  <a:schemeClr val="tx1"/>
-                </a:solidFill>
-                <a:latin typeface="나눔스퀘어 Bold" panose="020B0600000101010101" pitchFamily="50" charset="-127"/>
-                <a:ea typeface="나눔스퀘어 Bold" panose="020B0600000101010101" pitchFamily="50" charset="-127"/>
-              </a:rPr>
-              <a:t>IoC</a:t>
-            </a:r>
-            <a:r>
-              <a:rPr lang="en-US" altLang="ko-KR" sz="2000" dirty="0" smtClean="0">
-                <a:solidFill>
-                  <a:schemeClr val="tx1"/>
-                </a:solidFill>
-                <a:latin typeface="나눔스퀘어 Bold" panose="020B0600000101010101" pitchFamily="50" charset="-127"/>
-                <a:ea typeface="나눔스퀘어 Bold" panose="020B0600000101010101" pitchFamily="50" charset="-127"/>
-              </a:rPr>
-              <a:t> Container</a:t>
-            </a:r>
-            <a:endParaRPr lang="ko-KR" altLang="en-US" sz="2000" dirty="0">
-              <a:solidFill>
-                <a:schemeClr val="tx1"/>
-              </a:solidFill>
-              <a:latin typeface="나눔스퀘어 Bold" panose="020B0600000101010101" pitchFamily="50" charset="-127"/>
-              <a:ea typeface="나눔스퀘어 Bold" panose="020B0600000101010101" pitchFamily="50" charset="-127"/>
-            </a:endParaRPr>
-          </a:p>
-        </p:txBody>
-      </p:sp>
-      <p:sp>
-        <p:nvSpPr>
-          <p:cNvPr id="44" name="직사각형 43"/>
-          <p:cNvSpPr/>
-          <p:nvPr/>
-        </p:nvSpPr>
-        <p:spPr>
-          <a:xfrm>
-            <a:off x="7626150" y="2422853"/>
-            <a:ext cx="6480000" cy="720000"/>
-          </a:xfrm>
-          <a:prstGeom prst="rect">
-            <a:avLst/>
-          </a:prstGeom>
-          <a:solidFill>
-            <a:schemeClr val="accent5"/>
-          </a:solidFill>
-          <a:ln>
-            <a:noFill/>
-          </a:ln>
-        </p:spPr>
-        <p:style>
-          <a:lnRef idx="2">
-            <a:schemeClr val="accent1">
-              <a:shade val="50000"/>
-            </a:schemeClr>
-          </a:lnRef>
-          <a:fillRef idx="1">
-            <a:schemeClr val="accent1"/>
-          </a:fillRef>
-          <a:effectRef idx="0">
-            <a:schemeClr val="accent1"/>
-          </a:effectRef>
-          <a:fontRef idx="minor">
-            <a:schemeClr val="lt1"/>
-          </a:fontRef>
-        </p:style>
-        <p:txBody>
-          <a:bodyPr rtlCol="0" anchor="ctr"/>
-          <a:lstStyle/>
-          <a:p>
-            <a:pPr algn="ctr"/>
-            <a:r>
-              <a:rPr lang="en-US" altLang="ko-KR" sz="3200" dirty="0" err="1" smtClean="0">
-                <a:latin typeface="나눔스퀘어 Bold" panose="020B0600000101010101" pitchFamily="50" charset="-127"/>
-                <a:ea typeface="나눔스퀘어 Bold" panose="020B0600000101010101" pitchFamily="50" charset="-127"/>
-              </a:rPr>
-              <a:t>UserDetailService</a:t>
-            </a:r>
-            <a:endParaRPr lang="ko-KR" altLang="en-US" sz="3200" dirty="0">
-              <a:latin typeface="나눔스퀘어 Bold" panose="020B0600000101010101" pitchFamily="50" charset="-127"/>
-              <a:ea typeface="나눔스퀘어 Bold" panose="020B0600000101010101" pitchFamily="50" charset="-127"/>
-            </a:endParaRPr>
-          </a:p>
-        </p:txBody>
-      </p:sp>
-      <p:sp>
-        <p:nvSpPr>
-          <p:cNvPr id="76" name="직사각형 75"/>
-          <p:cNvSpPr/>
-          <p:nvPr/>
-        </p:nvSpPr>
-        <p:spPr>
-          <a:xfrm>
-            <a:off x="6500" y="2422853"/>
-            <a:ext cx="6480000" cy="720000"/>
-          </a:xfrm>
-          <a:prstGeom prst="rect">
-            <a:avLst/>
-          </a:prstGeom>
-          <a:solidFill>
-            <a:schemeClr val="accent5"/>
-          </a:solidFill>
-          <a:ln>
-            <a:noFill/>
-          </a:ln>
-        </p:spPr>
-        <p:style>
-          <a:lnRef idx="2">
-            <a:schemeClr val="accent1">
-              <a:shade val="50000"/>
-            </a:schemeClr>
-          </a:lnRef>
-          <a:fillRef idx="1">
-            <a:schemeClr val="accent1"/>
-          </a:fillRef>
-          <a:effectRef idx="0">
-            <a:schemeClr val="accent1"/>
-          </a:effectRef>
-          <a:fontRef idx="minor">
-            <a:schemeClr val="lt1"/>
-          </a:fontRef>
-        </p:style>
-        <p:txBody>
-          <a:bodyPr rtlCol="0" anchor="ctr"/>
-          <a:lstStyle/>
-          <a:p>
-            <a:pPr algn="ctr"/>
-            <a:r>
-              <a:rPr lang="en-US" altLang="ko-KR" sz="2400" dirty="0" err="1" smtClean="0">
-                <a:latin typeface="나눔스퀘어 Bold" panose="020B0600000101010101" pitchFamily="50" charset="-127"/>
-                <a:ea typeface="나눔스퀘어 Bold" panose="020B0600000101010101" pitchFamily="50" charset="-127"/>
-              </a:rPr>
-              <a:t>UsernamePasswordAuththenticationFilter</a:t>
-            </a:r>
-            <a:endParaRPr lang="ko-KR" altLang="en-US" sz="2800" dirty="0">
-              <a:latin typeface="나눔스퀘어 Bold" panose="020B0600000101010101" pitchFamily="50" charset="-127"/>
-              <a:ea typeface="나눔스퀘어 Bold" panose="020B0600000101010101" pitchFamily="50" charset="-127"/>
-            </a:endParaRPr>
-          </a:p>
-        </p:txBody>
-      </p:sp>
-      <p:sp>
-        <p:nvSpPr>
-          <p:cNvPr id="77" name="직사각형 76"/>
-          <p:cNvSpPr/>
-          <p:nvPr/>
-        </p:nvSpPr>
-        <p:spPr>
-          <a:xfrm>
-            <a:off x="6500" y="3800456"/>
-            <a:ext cx="6480000" cy="720000"/>
-          </a:xfrm>
-          <a:prstGeom prst="rect">
-            <a:avLst/>
-          </a:prstGeom>
-          <a:solidFill>
-            <a:schemeClr val="accent5"/>
-          </a:solidFill>
-          <a:ln>
-            <a:noFill/>
-          </a:ln>
-        </p:spPr>
-        <p:style>
-          <a:lnRef idx="2">
-            <a:schemeClr val="accent1">
-              <a:shade val="50000"/>
-            </a:schemeClr>
-          </a:lnRef>
-          <a:fillRef idx="1">
-            <a:schemeClr val="accent1"/>
-          </a:fillRef>
-          <a:effectRef idx="0">
-            <a:schemeClr val="accent1"/>
-          </a:effectRef>
-          <a:fontRef idx="minor">
-            <a:schemeClr val="lt1"/>
-          </a:fontRef>
-        </p:style>
-        <p:txBody>
-          <a:bodyPr rtlCol="0" anchor="ctr"/>
-          <a:lstStyle/>
-          <a:p>
-            <a:pPr algn="ctr"/>
-            <a:r>
-              <a:rPr lang="en-US" altLang="ko-KR" sz="3200" dirty="0" err="1" smtClean="0">
-                <a:latin typeface="나눔스퀘어 Bold" panose="020B0600000101010101" pitchFamily="50" charset="-127"/>
-                <a:ea typeface="나눔스퀘어 Bold" panose="020B0600000101010101" pitchFamily="50" charset="-127"/>
-              </a:rPr>
-              <a:t>AuthenticationManager</a:t>
-            </a:r>
-            <a:endParaRPr lang="ko-KR" altLang="en-US" sz="3200" dirty="0">
-              <a:latin typeface="나눔스퀘어 Bold" panose="020B0600000101010101" pitchFamily="50" charset="-127"/>
-              <a:ea typeface="나눔스퀘어 Bold" panose="020B0600000101010101" pitchFamily="50" charset="-127"/>
-            </a:endParaRPr>
-          </a:p>
-        </p:txBody>
-      </p:sp>
-      <p:sp>
-        <p:nvSpPr>
-          <p:cNvPr id="78" name="직사각형 77"/>
-          <p:cNvSpPr/>
-          <p:nvPr/>
-        </p:nvSpPr>
-        <p:spPr>
-          <a:xfrm>
-            <a:off x="6500" y="5178059"/>
-            <a:ext cx="6480000" cy="720000"/>
-          </a:xfrm>
-          <a:prstGeom prst="rect">
-            <a:avLst/>
-          </a:prstGeom>
-          <a:solidFill>
-            <a:schemeClr val="accent5"/>
-          </a:solidFill>
-          <a:ln>
-            <a:noFill/>
-          </a:ln>
-        </p:spPr>
-        <p:style>
-          <a:lnRef idx="2">
-            <a:schemeClr val="accent1">
-              <a:shade val="50000"/>
-            </a:schemeClr>
-          </a:lnRef>
-          <a:fillRef idx="1">
-            <a:schemeClr val="accent1"/>
-          </a:fillRef>
-          <a:effectRef idx="0">
-            <a:schemeClr val="accent1"/>
-          </a:effectRef>
-          <a:fontRef idx="minor">
-            <a:schemeClr val="lt1"/>
-          </a:fontRef>
-        </p:style>
-        <p:txBody>
-          <a:bodyPr rtlCol="0" anchor="ctr"/>
-          <a:lstStyle/>
-          <a:p>
-            <a:pPr algn="ctr"/>
-            <a:r>
-              <a:rPr lang="en-US" altLang="ko-KR" sz="3200" dirty="0" err="1" smtClean="0">
-                <a:latin typeface="나눔스퀘어 Bold" panose="020B0600000101010101" pitchFamily="50" charset="-127"/>
-                <a:ea typeface="나눔스퀘어 Bold" panose="020B0600000101010101" pitchFamily="50" charset="-127"/>
-              </a:rPr>
-              <a:t>AuthenticationProvider</a:t>
-            </a:r>
-            <a:endParaRPr lang="ko-KR" altLang="en-US" sz="3200" dirty="0">
-              <a:latin typeface="나눔스퀘어 Bold" panose="020B0600000101010101" pitchFamily="50" charset="-127"/>
-              <a:ea typeface="나눔스퀘어 Bold" panose="020B0600000101010101" pitchFamily="50" charset="-127"/>
-            </a:endParaRPr>
-          </a:p>
-        </p:txBody>
-      </p:sp>
-      <p:sp>
-        <p:nvSpPr>
-          <p:cNvPr id="79" name="모서리가 둥근 직사각형 78"/>
-          <p:cNvSpPr/>
-          <p:nvPr/>
-        </p:nvSpPr>
-        <p:spPr>
-          <a:xfrm>
-            <a:off x="1896500" y="1401403"/>
-            <a:ext cx="2700000" cy="540000"/>
-          </a:xfrm>
-          <a:prstGeom prst="roundRect">
-            <a:avLst/>
-          </a:prstGeom>
-          <a:solidFill>
-            <a:schemeClr val="bg1"/>
-          </a:solidFill>
-          <a:ln w="19050">
-            <a:solidFill>
-              <a:schemeClr val="tx1"/>
-            </a:solidFill>
-          </a:ln>
-        </p:spPr>
-        <p:style>
-          <a:lnRef idx="2">
-            <a:schemeClr val="accent1">
-              <a:shade val="50000"/>
-            </a:schemeClr>
-          </a:lnRef>
-          <a:fillRef idx="1">
-            <a:schemeClr val="accent1"/>
-          </a:fillRef>
-          <a:effectRef idx="0">
-            <a:schemeClr val="accent1"/>
-          </a:effectRef>
-          <a:fontRef idx="minor">
-            <a:schemeClr val="lt1"/>
-          </a:fontRef>
-        </p:style>
-        <p:txBody>
-          <a:bodyPr rtlCol="0" anchor="ctr"/>
-          <a:lstStyle/>
-          <a:p>
-            <a:pPr algn="ctr"/>
-            <a:r>
-              <a:rPr lang="en-US" altLang="ko-KR" sz="2000" dirty="0" smtClean="0">
-                <a:solidFill>
-                  <a:schemeClr val="tx1"/>
-                </a:solidFill>
-                <a:latin typeface="나눔스퀘어 Bold" panose="020B0600000101010101" pitchFamily="50" charset="-127"/>
-                <a:ea typeface="나눔스퀘어 Bold" panose="020B0600000101010101" pitchFamily="50" charset="-127"/>
-              </a:rPr>
-              <a:t>Spring </a:t>
-            </a:r>
-            <a:r>
-              <a:rPr lang="en-US" altLang="ko-KR" sz="2000" dirty="0" err="1" smtClean="0">
-                <a:solidFill>
-                  <a:schemeClr val="tx1"/>
-                </a:solidFill>
-                <a:latin typeface="나눔스퀘어 Bold" panose="020B0600000101010101" pitchFamily="50" charset="-127"/>
-                <a:ea typeface="나눔스퀘어 Bold" panose="020B0600000101010101" pitchFamily="50" charset="-127"/>
-              </a:rPr>
-              <a:t>IoC</a:t>
-            </a:r>
-            <a:r>
-              <a:rPr lang="en-US" altLang="ko-KR" sz="2000" dirty="0" smtClean="0">
-                <a:solidFill>
-                  <a:schemeClr val="tx1"/>
-                </a:solidFill>
-                <a:latin typeface="나눔스퀘어 Bold" panose="020B0600000101010101" pitchFamily="50" charset="-127"/>
-                <a:ea typeface="나눔스퀘어 Bold" panose="020B0600000101010101" pitchFamily="50" charset="-127"/>
-              </a:rPr>
-              <a:t> Container</a:t>
-            </a:r>
-            <a:endParaRPr lang="ko-KR" altLang="en-US" sz="2000" dirty="0">
-              <a:solidFill>
-                <a:schemeClr val="tx1"/>
-              </a:solidFill>
-              <a:latin typeface="나눔스퀘어 Bold" panose="020B0600000101010101" pitchFamily="50" charset="-127"/>
-              <a:ea typeface="나눔스퀘어 Bold" panose="020B0600000101010101" pitchFamily="50" charset="-127"/>
-            </a:endParaRPr>
-          </a:p>
-        </p:txBody>
-      </p:sp>
-      <p:sp>
-        <p:nvSpPr>
-          <p:cNvPr id="80" name="직사각형 79"/>
-          <p:cNvSpPr/>
-          <p:nvPr/>
-        </p:nvSpPr>
-        <p:spPr>
-          <a:xfrm>
-            <a:off x="6500" y="6555662"/>
-            <a:ext cx="6480000" cy="720000"/>
-          </a:xfrm>
-          <a:prstGeom prst="rect">
-            <a:avLst/>
-          </a:prstGeom>
-          <a:solidFill>
-            <a:schemeClr val="accent5"/>
-          </a:solidFill>
-          <a:ln>
-            <a:noFill/>
-          </a:ln>
-        </p:spPr>
-        <p:style>
-          <a:lnRef idx="2">
-            <a:schemeClr val="accent1">
-              <a:shade val="50000"/>
-            </a:schemeClr>
-          </a:lnRef>
-          <a:fillRef idx="1">
-            <a:schemeClr val="accent1"/>
-          </a:fillRef>
-          <a:effectRef idx="0">
-            <a:schemeClr val="accent1"/>
-          </a:effectRef>
-          <a:fontRef idx="minor">
-            <a:schemeClr val="lt1"/>
-          </a:fontRef>
-        </p:style>
-        <p:txBody>
-          <a:bodyPr rtlCol="0" anchor="ctr"/>
-          <a:lstStyle/>
-          <a:p>
-            <a:pPr algn="ctr"/>
-            <a:r>
-              <a:rPr lang="en-US" altLang="ko-KR" sz="3200" dirty="0" err="1" smtClean="0">
-                <a:latin typeface="나눔스퀘어 Bold" panose="020B0600000101010101" pitchFamily="50" charset="-127"/>
-                <a:ea typeface="나눔스퀘어 Bold" panose="020B0600000101010101" pitchFamily="50" charset="-127"/>
-              </a:rPr>
-              <a:t>UserDetailService</a:t>
-            </a:r>
-            <a:endParaRPr lang="ko-KR" altLang="en-US" sz="3200" dirty="0">
-              <a:latin typeface="나눔스퀘어 Bold" panose="020B0600000101010101" pitchFamily="50" charset="-127"/>
-              <a:ea typeface="나눔스퀘어 Bold" panose="020B0600000101010101" pitchFamily="50" charset="-127"/>
-            </a:endParaRPr>
-          </a:p>
-        </p:txBody>
-      </p:sp>
-      <p:sp>
-        <p:nvSpPr>
-          <p:cNvPr id="81" name="직사각형 80"/>
-          <p:cNvSpPr/>
-          <p:nvPr/>
-        </p:nvSpPr>
-        <p:spPr>
-          <a:xfrm>
-            <a:off x="-353500" y="-4900"/>
-            <a:ext cx="3600000" cy="720000"/>
-          </a:xfrm>
-          <a:prstGeom prst="rect">
-            <a:avLst/>
-          </a:prstGeom>
-          <a:solidFill>
-            <a:schemeClr val="accent5"/>
-          </a:solidFill>
-          <a:ln>
-            <a:noFill/>
-          </a:ln>
-        </p:spPr>
-        <p:style>
-          <a:lnRef idx="2">
-            <a:schemeClr val="accent1">
-              <a:shade val="50000"/>
-            </a:schemeClr>
-          </a:lnRef>
-          <a:fillRef idx="1">
-            <a:schemeClr val="accent1"/>
-          </a:fillRef>
-          <a:effectRef idx="0">
-            <a:schemeClr val="accent1"/>
-          </a:effectRef>
-          <a:fontRef idx="minor">
-            <a:schemeClr val="lt1"/>
-          </a:fontRef>
-        </p:style>
-        <p:txBody>
-          <a:bodyPr rtlCol="0" anchor="ctr"/>
-          <a:lstStyle/>
-          <a:p>
-            <a:pPr algn="ctr"/>
-            <a:r>
-              <a:rPr lang="en-US" altLang="ko-KR" sz="3200" dirty="0" smtClean="0">
-                <a:latin typeface="나눔스퀘어 Bold" panose="020B0600000101010101" pitchFamily="50" charset="-127"/>
-                <a:ea typeface="나눔스퀘어 Bold" panose="020B0600000101010101" pitchFamily="50" charset="-127"/>
-              </a:rPr>
-              <a:t>Client</a:t>
-            </a:r>
-            <a:endParaRPr lang="ko-KR" altLang="en-US" sz="3200" dirty="0">
-              <a:latin typeface="나눔스퀘어 Bold" panose="020B0600000101010101" pitchFamily="50" charset="-127"/>
-              <a:ea typeface="나눔스퀘어 Bold" panose="020B0600000101010101" pitchFamily="50" charset="-127"/>
-            </a:endParaRPr>
-          </a:p>
-        </p:txBody>
-      </p:sp>
-      <p:sp>
-        <p:nvSpPr>
-          <p:cNvPr id="82" name="직사각형 81"/>
-          <p:cNvSpPr/>
-          <p:nvPr/>
-        </p:nvSpPr>
-        <p:spPr>
-          <a:xfrm>
-            <a:off x="4298100" y="-4900"/>
-            <a:ext cx="3600000" cy="720000"/>
-          </a:xfrm>
-          <a:prstGeom prst="rect">
-            <a:avLst/>
-          </a:prstGeom>
-          <a:solidFill>
-            <a:schemeClr val="accent5"/>
-          </a:solidFill>
-          <a:ln>
-            <a:noFill/>
-          </a:ln>
-        </p:spPr>
-        <p:style>
-          <a:lnRef idx="2">
-            <a:schemeClr val="accent1">
-              <a:shade val="50000"/>
-            </a:schemeClr>
-          </a:lnRef>
-          <a:fillRef idx="1">
-            <a:schemeClr val="accent1"/>
-          </a:fillRef>
-          <a:effectRef idx="0">
-            <a:schemeClr val="accent1"/>
-          </a:effectRef>
-          <a:fontRef idx="minor">
-            <a:schemeClr val="lt1"/>
-          </a:fontRef>
-        </p:style>
-        <p:txBody>
-          <a:bodyPr rtlCol="0" anchor="ctr"/>
-          <a:lstStyle/>
-          <a:p>
-            <a:pPr algn="ctr"/>
-            <a:r>
-              <a:rPr lang="en-US" altLang="ko-KR" sz="2400" dirty="0" err="1" smtClean="0">
-                <a:latin typeface="나눔스퀘어 Bold" panose="020B0600000101010101" pitchFamily="50" charset="-127"/>
-                <a:ea typeface="나눔스퀘어 Bold" panose="020B0600000101010101" pitchFamily="50" charset="-127"/>
-              </a:rPr>
-              <a:t>DelegatingFilterProxy</a:t>
-            </a:r>
-            <a:endParaRPr lang="ko-KR" altLang="en-US" sz="2400" dirty="0">
-              <a:latin typeface="나눔스퀘어 Bold" panose="020B0600000101010101" pitchFamily="50" charset="-127"/>
-              <a:ea typeface="나눔스퀘어 Bold" panose="020B0600000101010101" pitchFamily="50" charset="-127"/>
-            </a:endParaRPr>
-          </a:p>
-        </p:txBody>
-      </p:sp>
-      <p:sp>
-        <p:nvSpPr>
-          <p:cNvPr id="83" name="직사각형 82"/>
-          <p:cNvSpPr/>
-          <p:nvPr/>
-        </p:nvSpPr>
-        <p:spPr>
-          <a:xfrm>
-            <a:off x="8949700" y="-4900"/>
-            <a:ext cx="3600000" cy="720000"/>
-          </a:xfrm>
-          <a:prstGeom prst="rect">
-            <a:avLst/>
-          </a:prstGeom>
-          <a:solidFill>
-            <a:schemeClr val="accent5"/>
-          </a:solidFill>
-          <a:ln>
-            <a:noFill/>
-          </a:ln>
-        </p:spPr>
-        <p:style>
-          <a:lnRef idx="2">
-            <a:schemeClr val="accent1">
-              <a:shade val="50000"/>
-            </a:schemeClr>
-          </a:lnRef>
-          <a:fillRef idx="1">
-            <a:schemeClr val="accent1"/>
-          </a:fillRef>
-          <a:effectRef idx="0">
-            <a:schemeClr val="accent1"/>
-          </a:effectRef>
-          <a:fontRef idx="minor">
-            <a:schemeClr val="lt1"/>
-          </a:fontRef>
-        </p:style>
-        <p:txBody>
-          <a:bodyPr rtlCol="0" anchor="ctr"/>
-          <a:lstStyle/>
-          <a:p>
-            <a:pPr algn="ctr"/>
-            <a:r>
-              <a:rPr lang="en-US" altLang="ko-KR" sz="2400" dirty="0" smtClean="0">
-                <a:latin typeface="나눔스퀘어 Bold" panose="020B0600000101010101" pitchFamily="50" charset="-127"/>
-                <a:ea typeface="나눔스퀘어 Bold" panose="020B0600000101010101" pitchFamily="50" charset="-127"/>
-              </a:rPr>
-              <a:t>Spring </a:t>
-            </a:r>
-            <a:r>
-              <a:rPr lang="en-US" altLang="ko-KR" sz="2400" dirty="0" err="1" smtClean="0">
-                <a:latin typeface="나눔스퀘어 Bold" panose="020B0600000101010101" pitchFamily="50" charset="-127"/>
-                <a:ea typeface="나눔스퀘어 Bold" panose="020B0600000101010101" pitchFamily="50" charset="-127"/>
-              </a:rPr>
-              <a:t>IoC</a:t>
-            </a:r>
-            <a:r>
-              <a:rPr lang="en-US" altLang="ko-KR" sz="2400" dirty="0" smtClean="0">
-                <a:latin typeface="나눔스퀘어 Bold" panose="020B0600000101010101" pitchFamily="50" charset="-127"/>
-                <a:ea typeface="나눔스퀘어 Bold" panose="020B0600000101010101" pitchFamily="50" charset="-127"/>
-              </a:rPr>
-              <a:t> Container</a:t>
-            </a:r>
-            <a:endParaRPr lang="ko-KR" altLang="en-US" sz="2400" dirty="0">
-              <a:latin typeface="나눔스퀘어 Bold" panose="020B0600000101010101" pitchFamily="50" charset="-127"/>
-              <a:ea typeface="나눔스퀘어 Bold" panose="020B0600000101010101" pitchFamily="50" charset="-127"/>
-            </a:endParaRPr>
-          </a:p>
-        </p:txBody>
-      </p:sp>
-      <p:cxnSp>
-        <p:nvCxnSpPr>
-          <p:cNvPr id="84" name="직선 화살표 연결선 83"/>
-          <p:cNvCxnSpPr>
-            <a:stCxn id="81" idx="3"/>
-            <a:endCxn id="82" idx="1"/>
-          </p:cNvCxnSpPr>
-          <p:nvPr/>
-        </p:nvCxnSpPr>
-        <p:spPr>
-          <a:xfrm>
-            <a:off x="3246500" y="355100"/>
-            <a:ext cx="1051600" cy="0"/>
-          </a:xfrm>
-          <a:prstGeom prst="straightConnector1">
-            <a:avLst/>
-          </a:prstGeom>
-          <a:ln w="76200">
-            <a:solidFill>
-              <a:schemeClr val="accent2"/>
-            </a:solidFill>
-            <a:tailEnd type="triangle"/>
-          </a:ln>
-        </p:spPr>
-        <p:style>
-          <a:lnRef idx="1">
-            <a:schemeClr val="accent1"/>
-          </a:lnRef>
-          <a:fillRef idx="0">
-            <a:schemeClr val="accent1"/>
-          </a:fillRef>
-          <a:effectRef idx="0">
-            <a:schemeClr val="accent1"/>
-          </a:effectRef>
-          <a:fontRef idx="minor">
-            <a:schemeClr val="tx1"/>
-          </a:fontRef>
-        </p:style>
-      </p:cxnSp>
-      <p:cxnSp>
-        <p:nvCxnSpPr>
-          <p:cNvPr id="85" name="직선 화살표 연결선 84"/>
-          <p:cNvCxnSpPr>
-            <a:stCxn id="82" idx="3"/>
-            <a:endCxn id="83" idx="1"/>
-          </p:cNvCxnSpPr>
-          <p:nvPr/>
-        </p:nvCxnSpPr>
-        <p:spPr>
-          <a:xfrm>
-            <a:off x="7898100" y="355100"/>
-            <a:ext cx="1051600" cy="0"/>
-          </a:xfrm>
-          <a:prstGeom prst="straightConnector1">
-            <a:avLst/>
-          </a:prstGeom>
-          <a:ln w="76200">
-            <a:solidFill>
-              <a:schemeClr val="accent2"/>
-            </a:solidFill>
-            <a:tailEnd type="triangle"/>
-          </a:ln>
-        </p:spPr>
-        <p:style>
-          <a:lnRef idx="1">
-            <a:schemeClr val="accent1"/>
-          </a:lnRef>
-          <a:fillRef idx="0">
-            <a:schemeClr val="accent1"/>
-          </a:fillRef>
-          <a:effectRef idx="0">
-            <a:schemeClr val="accent1"/>
-          </a:effectRef>
-          <a:fontRef idx="minor">
-            <a:schemeClr val="tx1"/>
-          </a:fontRef>
-        </p:style>
-      </p:cxnSp>
-      <p:cxnSp>
-        <p:nvCxnSpPr>
-          <p:cNvPr id="86" name="직선 화살표 연결선 85"/>
-          <p:cNvCxnSpPr>
-            <a:stCxn id="76" idx="2"/>
-            <a:endCxn id="77" idx="0"/>
-          </p:cNvCxnSpPr>
-          <p:nvPr/>
-        </p:nvCxnSpPr>
-        <p:spPr>
-          <a:xfrm>
-            <a:off x="3246500" y="3142853"/>
-            <a:ext cx="0" cy="657603"/>
-          </a:xfrm>
-          <a:prstGeom prst="straightConnector1">
-            <a:avLst/>
-          </a:prstGeom>
-          <a:ln w="76200">
-            <a:solidFill>
-              <a:schemeClr val="accent2"/>
-            </a:solidFill>
-            <a:tailEnd type="triangle"/>
-          </a:ln>
-        </p:spPr>
-        <p:style>
-          <a:lnRef idx="1">
-            <a:schemeClr val="accent1"/>
-          </a:lnRef>
-          <a:fillRef idx="0">
-            <a:schemeClr val="accent1"/>
-          </a:fillRef>
-          <a:effectRef idx="0">
-            <a:schemeClr val="accent1"/>
-          </a:effectRef>
-          <a:fontRef idx="minor">
-            <a:schemeClr val="tx1"/>
-          </a:fontRef>
-        </p:style>
-      </p:cxnSp>
-      <p:cxnSp>
-        <p:nvCxnSpPr>
-          <p:cNvPr id="87" name="직선 화살표 연결선 86"/>
-          <p:cNvCxnSpPr>
-            <a:stCxn id="77" idx="2"/>
-            <a:endCxn id="78" idx="0"/>
-          </p:cNvCxnSpPr>
-          <p:nvPr/>
-        </p:nvCxnSpPr>
-        <p:spPr>
-          <a:xfrm>
-            <a:off x="3246500" y="4520456"/>
-            <a:ext cx="0" cy="657603"/>
-          </a:xfrm>
-          <a:prstGeom prst="straightConnector1">
-            <a:avLst/>
-          </a:prstGeom>
-          <a:ln w="76200">
-            <a:solidFill>
-              <a:schemeClr val="accent2"/>
-            </a:solidFill>
-            <a:tailEnd type="triangle"/>
-          </a:ln>
-        </p:spPr>
-        <p:style>
-          <a:lnRef idx="1">
-            <a:schemeClr val="accent1"/>
-          </a:lnRef>
-          <a:fillRef idx="0">
-            <a:schemeClr val="accent1"/>
-          </a:fillRef>
-          <a:effectRef idx="0">
-            <a:schemeClr val="accent1"/>
-          </a:effectRef>
-          <a:fontRef idx="minor">
-            <a:schemeClr val="tx1"/>
-          </a:fontRef>
-        </p:style>
-      </p:cxnSp>
-      <p:cxnSp>
-        <p:nvCxnSpPr>
-          <p:cNvPr id="88" name="직선 화살표 연결선 87"/>
-          <p:cNvCxnSpPr>
-            <a:stCxn id="78" idx="2"/>
-            <a:endCxn id="80" idx="0"/>
-          </p:cNvCxnSpPr>
-          <p:nvPr/>
-        </p:nvCxnSpPr>
-        <p:spPr>
-          <a:xfrm>
-            <a:off x="3246500" y="5898059"/>
-            <a:ext cx="0" cy="657603"/>
-          </a:xfrm>
-          <a:prstGeom prst="straightConnector1">
-            <a:avLst/>
-          </a:prstGeom>
-          <a:ln w="76200">
-            <a:solidFill>
-              <a:schemeClr val="accent2"/>
-            </a:solidFill>
-            <a:tailEnd type="triangle"/>
-          </a:ln>
-        </p:spPr>
-        <p:style>
-          <a:lnRef idx="1">
-            <a:schemeClr val="accent1"/>
-          </a:lnRef>
-          <a:fillRef idx="0">
-            <a:schemeClr val="accent1"/>
-          </a:fillRef>
-          <a:effectRef idx="0">
-            <a:schemeClr val="accent1"/>
-          </a:effectRef>
-          <a:fontRef idx="minor">
-            <a:schemeClr val="tx1"/>
-          </a:fontRef>
-        </p:style>
-      </p:cxnSp>
-      <p:sp>
-        <p:nvSpPr>
-          <p:cNvPr id="89" name="직사각형 88"/>
-          <p:cNvSpPr/>
-          <p:nvPr/>
-        </p:nvSpPr>
-        <p:spPr>
-          <a:xfrm>
-            <a:off x="6500" y="7931827"/>
-            <a:ext cx="6480000" cy="720000"/>
-          </a:xfrm>
-          <a:prstGeom prst="rect">
-            <a:avLst/>
-          </a:prstGeom>
-          <a:solidFill>
-            <a:schemeClr val="accent5"/>
-          </a:solidFill>
-          <a:ln>
-            <a:noFill/>
-          </a:ln>
-        </p:spPr>
-        <p:style>
-          <a:lnRef idx="2">
-            <a:schemeClr val="accent1">
-              <a:shade val="50000"/>
-            </a:schemeClr>
-          </a:lnRef>
-          <a:fillRef idx="1">
-            <a:schemeClr val="accent1"/>
-          </a:fillRef>
-          <a:effectRef idx="0">
-            <a:schemeClr val="accent1"/>
-          </a:effectRef>
-          <a:fontRef idx="minor">
-            <a:schemeClr val="lt1"/>
-          </a:fontRef>
-        </p:style>
-        <p:txBody>
-          <a:bodyPr rtlCol="0" anchor="ctr"/>
-          <a:lstStyle/>
-          <a:p>
-            <a:pPr algn="ctr"/>
-            <a:r>
-              <a:rPr lang="en-US" altLang="ko-KR" sz="3200" dirty="0" err="1" smtClean="0">
-                <a:latin typeface="나눔스퀘어 Bold" panose="020B0600000101010101" pitchFamily="50" charset="-127"/>
-                <a:ea typeface="나눔스퀘어 Bold" panose="020B0600000101010101" pitchFamily="50" charset="-127"/>
-              </a:rPr>
-              <a:t>DispatcherSevlet</a:t>
-            </a:r>
-            <a:endParaRPr lang="ko-KR" altLang="en-US" sz="3200" dirty="0">
-              <a:latin typeface="나눔스퀘어 Bold" panose="020B0600000101010101" pitchFamily="50" charset="-127"/>
-              <a:ea typeface="나눔스퀘어 Bold" panose="020B0600000101010101" pitchFamily="50" charset="-127"/>
-            </a:endParaRPr>
-          </a:p>
-        </p:txBody>
-      </p:sp>
-      <p:cxnSp>
-        <p:nvCxnSpPr>
-          <p:cNvPr id="90" name="직선 화살표 연결선 89"/>
-          <p:cNvCxnSpPr>
-            <a:stCxn id="80" idx="2"/>
-            <a:endCxn id="89" idx="0"/>
-          </p:cNvCxnSpPr>
-          <p:nvPr/>
-        </p:nvCxnSpPr>
-        <p:spPr>
-          <a:xfrm>
-            <a:off x="3246500" y="7275662"/>
-            <a:ext cx="0" cy="656165"/>
-          </a:xfrm>
-          <a:prstGeom prst="straightConnector1">
-            <a:avLst/>
-          </a:prstGeom>
-          <a:ln w="76200">
-            <a:solidFill>
-              <a:schemeClr val="accent2"/>
-            </a:solidFill>
-            <a:tailEnd type="triangle"/>
-          </a:ln>
-        </p:spPr>
-        <p:style>
-          <a:lnRef idx="1">
-            <a:schemeClr val="accent1"/>
-          </a:lnRef>
-          <a:fillRef idx="0">
-            <a:schemeClr val="accent1"/>
-          </a:fillRef>
-          <a:effectRef idx="0">
-            <a:schemeClr val="accent1"/>
-          </a:effectRef>
-          <a:fontRef idx="minor">
-            <a:schemeClr val="tx1"/>
-          </a:fontRef>
-        </p:style>
-      </p:cxnSp>
-      <p:sp>
-        <p:nvSpPr>
-          <p:cNvPr id="91" name="직사각형 90"/>
-          <p:cNvSpPr/>
-          <p:nvPr/>
-        </p:nvSpPr>
-        <p:spPr>
-          <a:xfrm>
-            <a:off x="7628250" y="7930389"/>
-            <a:ext cx="6480000" cy="1800000"/>
-          </a:xfrm>
-          <a:prstGeom prst="rect">
-            <a:avLst/>
-          </a:prstGeom>
-          <a:solidFill>
-            <a:schemeClr val="accent5"/>
-          </a:solidFill>
-          <a:ln>
-            <a:noFill/>
-          </a:ln>
-        </p:spPr>
-        <p:style>
-          <a:lnRef idx="2">
-            <a:schemeClr val="accent1">
-              <a:shade val="50000"/>
-            </a:schemeClr>
-          </a:lnRef>
-          <a:fillRef idx="1">
-            <a:schemeClr val="accent1"/>
-          </a:fillRef>
-          <a:effectRef idx="0">
-            <a:schemeClr val="accent1"/>
-          </a:effectRef>
-          <a:fontRef idx="minor">
-            <a:schemeClr val="lt1"/>
-          </a:fontRef>
-        </p:style>
-        <p:txBody>
-          <a:bodyPr rtlCol="0" anchor="ctr"/>
-          <a:lstStyle/>
-          <a:p>
-            <a:pPr algn="ctr"/>
-            <a:r>
-              <a:rPr lang="en-US" altLang="ko-KR" sz="2800" dirty="0" err="1" smtClean="0">
-                <a:latin typeface="나눔스퀘어 Bold" panose="020B0600000101010101" pitchFamily="50" charset="-127"/>
-                <a:ea typeface="나눔스퀘어 Bold" panose="020B0600000101010101" pitchFamily="50" charset="-127"/>
-              </a:rPr>
-              <a:t>SecurityContextHolder</a:t>
-            </a:r>
-            <a:endParaRPr lang="en-US" altLang="ko-KR" sz="2800" dirty="0" smtClean="0">
-              <a:latin typeface="나눔스퀘어 Bold" panose="020B0600000101010101" pitchFamily="50" charset="-127"/>
-              <a:ea typeface="나눔스퀘어 Bold" panose="020B0600000101010101" pitchFamily="50" charset="-127"/>
-            </a:endParaRPr>
-          </a:p>
-          <a:p>
-            <a:pPr algn="ctr"/>
-            <a:endParaRPr lang="en-US" altLang="ko-KR" sz="2800" dirty="0">
-              <a:latin typeface="나눔스퀘어 Bold" panose="020B0600000101010101" pitchFamily="50" charset="-127"/>
-              <a:ea typeface="나눔스퀘어 Bold" panose="020B0600000101010101" pitchFamily="50" charset="-127"/>
-            </a:endParaRPr>
-          </a:p>
-          <a:p>
-            <a:pPr algn="ctr"/>
-            <a:endParaRPr lang="en-US" altLang="ko-KR" sz="2400" dirty="0" smtClean="0">
-              <a:latin typeface="나눔스퀘어 Bold" panose="020B0600000101010101" pitchFamily="50" charset="-127"/>
-              <a:ea typeface="나눔스퀘어 Bold" panose="020B0600000101010101" pitchFamily="50" charset="-127"/>
-            </a:endParaRPr>
-          </a:p>
-          <a:p>
-            <a:pPr algn="ctr"/>
-            <a:endParaRPr lang="en-US" altLang="ko-KR" sz="2000" dirty="0" smtClean="0">
-              <a:latin typeface="나눔스퀘어 Bold" panose="020B0600000101010101" pitchFamily="50" charset="-127"/>
-              <a:ea typeface="나눔스퀘어 Bold" panose="020B0600000101010101" pitchFamily="50" charset="-127"/>
-            </a:endParaRPr>
-          </a:p>
-        </p:txBody>
-      </p:sp>
-      <p:sp>
-        <p:nvSpPr>
-          <p:cNvPr id="93" name="직사각형 92"/>
-          <p:cNvSpPr/>
-          <p:nvPr/>
-        </p:nvSpPr>
-        <p:spPr>
-          <a:xfrm>
-            <a:off x="8322000" y="8650389"/>
-            <a:ext cx="5040000" cy="720000"/>
-          </a:xfrm>
-          <a:prstGeom prst="rect">
-            <a:avLst/>
-          </a:prstGeom>
-          <a:solidFill>
-            <a:schemeClr val="accent1"/>
-          </a:solidFill>
-          <a:ln>
-            <a:noFill/>
-          </a:ln>
-        </p:spPr>
-        <p:style>
-          <a:lnRef idx="2">
-            <a:schemeClr val="accent1">
-              <a:shade val="50000"/>
-            </a:schemeClr>
-          </a:lnRef>
-          <a:fillRef idx="1">
-            <a:schemeClr val="accent1"/>
-          </a:fillRef>
-          <a:effectRef idx="0">
-            <a:schemeClr val="accent1"/>
-          </a:effectRef>
-          <a:fontRef idx="minor">
-            <a:schemeClr val="lt1"/>
-          </a:fontRef>
-        </p:style>
-        <p:txBody>
-          <a:bodyPr rtlCol="0" anchor="ctr"/>
-          <a:lstStyle/>
-          <a:p>
-            <a:pPr algn="ctr"/>
-            <a:r>
-              <a:rPr lang="en-US" altLang="ko-KR" sz="3600" dirty="0">
-                <a:latin typeface="나눔스퀘어 Bold" panose="020B0600000101010101" pitchFamily="50" charset="-127"/>
-                <a:ea typeface="나눔스퀘어 Bold" panose="020B0600000101010101" pitchFamily="50" charset="-127"/>
-              </a:rPr>
-              <a:t>Principal</a:t>
-            </a:r>
-            <a:endParaRPr lang="ko-KR" altLang="en-US" sz="3600" dirty="0">
-              <a:latin typeface="나눔스퀘어 Bold" panose="020B0600000101010101" pitchFamily="50" charset="-127"/>
-              <a:ea typeface="나눔스퀘어 Bold" panose="020B0600000101010101" pitchFamily="50" charset="-127"/>
-            </a:endParaRPr>
-          </a:p>
-        </p:txBody>
-      </p:sp>
-      <p:cxnSp>
-        <p:nvCxnSpPr>
-          <p:cNvPr id="94" name="직선 화살표 연결선 93"/>
-          <p:cNvCxnSpPr>
-            <a:endCxn id="42" idx="0"/>
-          </p:cNvCxnSpPr>
-          <p:nvPr/>
-        </p:nvCxnSpPr>
-        <p:spPr>
-          <a:xfrm>
-            <a:off x="10866150" y="3142853"/>
-            <a:ext cx="0" cy="657603"/>
-          </a:xfrm>
-          <a:prstGeom prst="straightConnector1">
-            <a:avLst/>
-          </a:prstGeom>
-          <a:ln w="76200">
-            <a:solidFill>
-              <a:schemeClr val="accent2"/>
-            </a:solidFill>
-            <a:tailEnd type="triangle"/>
-          </a:ln>
-        </p:spPr>
-        <p:style>
-          <a:lnRef idx="1">
-            <a:schemeClr val="accent1"/>
-          </a:lnRef>
-          <a:fillRef idx="0">
-            <a:schemeClr val="accent1"/>
-          </a:fillRef>
-          <a:effectRef idx="0">
-            <a:schemeClr val="accent1"/>
-          </a:effectRef>
-          <a:fontRef idx="minor">
-            <a:schemeClr val="tx1"/>
-          </a:fontRef>
-        </p:style>
-      </p:cxnSp>
-      <p:cxnSp>
-        <p:nvCxnSpPr>
-          <p:cNvPr id="97" name="직선 화살표 연결선 96"/>
-          <p:cNvCxnSpPr>
-            <a:stCxn id="42" idx="2"/>
-            <a:endCxn id="41" idx="0"/>
-          </p:cNvCxnSpPr>
-          <p:nvPr/>
-        </p:nvCxnSpPr>
-        <p:spPr>
-          <a:xfrm>
-            <a:off x="10866150" y="4520456"/>
-            <a:ext cx="0" cy="657603"/>
-          </a:xfrm>
-          <a:prstGeom prst="straightConnector1">
-            <a:avLst/>
-          </a:prstGeom>
-          <a:ln w="76200">
-            <a:solidFill>
-              <a:schemeClr val="accent2"/>
-            </a:solidFill>
-            <a:tailEnd type="triangle"/>
-          </a:ln>
-        </p:spPr>
-        <p:style>
-          <a:lnRef idx="1">
-            <a:schemeClr val="accent1"/>
-          </a:lnRef>
-          <a:fillRef idx="0">
-            <a:schemeClr val="accent1"/>
-          </a:fillRef>
-          <a:effectRef idx="0">
-            <a:schemeClr val="accent1"/>
-          </a:effectRef>
-          <a:fontRef idx="minor">
-            <a:schemeClr val="tx1"/>
-          </a:fontRef>
-        </p:style>
-      </p:cxnSp>
-      <p:cxnSp>
-        <p:nvCxnSpPr>
-          <p:cNvPr id="100" name="직선 화살표 연결선 99"/>
-          <p:cNvCxnSpPr>
-            <a:stCxn id="41" idx="2"/>
-            <a:endCxn id="40" idx="0"/>
-          </p:cNvCxnSpPr>
-          <p:nvPr/>
-        </p:nvCxnSpPr>
-        <p:spPr>
-          <a:xfrm>
-            <a:off x="10866150" y="5898059"/>
-            <a:ext cx="0" cy="656165"/>
-          </a:xfrm>
-          <a:prstGeom prst="straightConnector1">
-            <a:avLst/>
-          </a:prstGeom>
-          <a:ln w="76200">
-            <a:solidFill>
-              <a:schemeClr val="accent2"/>
-            </a:solidFill>
-            <a:tailEnd type="triangle"/>
-          </a:ln>
-        </p:spPr>
-        <p:style>
-          <a:lnRef idx="1">
-            <a:schemeClr val="accent1"/>
-          </a:lnRef>
-          <a:fillRef idx="0">
-            <a:schemeClr val="accent1"/>
-          </a:fillRef>
-          <a:effectRef idx="0">
-            <a:schemeClr val="accent1"/>
-          </a:effectRef>
-          <a:fontRef idx="minor">
-            <a:schemeClr val="tx1"/>
-          </a:fontRef>
-        </p:style>
-      </p:cxnSp>
-      <p:cxnSp>
-        <p:nvCxnSpPr>
-          <p:cNvPr id="104" name="직선 화살표 연결선 103"/>
-          <p:cNvCxnSpPr>
-            <a:stCxn id="40" idx="2"/>
-            <a:endCxn id="91" idx="0"/>
-          </p:cNvCxnSpPr>
-          <p:nvPr/>
-        </p:nvCxnSpPr>
-        <p:spPr>
-          <a:xfrm>
-            <a:off x="10866150" y="7274224"/>
-            <a:ext cx="2100" cy="656165"/>
-          </a:xfrm>
-          <a:prstGeom prst="straightConnector1">
-            <a:avLst/>
-          </a:prstGeom>
-          <a:ln w="76200">
-            <a:solidFill>
-              <a:schemeClr val="accent2"/>
-            </a:solidFill>
-            <a:tailEnd type="triangle"/>
-          </a:ln>
-        </p:spPr>
-        <p:style>
-          <a:lnRef idx="1">
-            <a:schemeClr val="accent1"/>
-          </a:lnRef>
-          <a:fillRef idx="0">
-            <a:schemeClr val="accent1"/>
-          </a:fillRef>
-          <a:effectRef idx="0">
-            <a:schemeClr val="accent1"/>
-          </a:effectRef>
-          <a:fontRef idx="minor">
-            <a:schemeClr val="tx1"/>
-          </a:fontRef>
-        </p:style>
-      </p:cxnSp>
-      <p:sp>
-        <p:nvSpPr>
-          <p:cNvPr id="109" name="직사각형 108"/>
-          <p:cNvSpPr/>
-          <p:nvPr/>
-        </p:nvSpPr>
-        <p:spPr>
-          <a:xfrm>
-            <a:off x="7266150" y="1761402"/>
-            <a:ext cx="7200000" cy="8280000"/>
-          </a:xfrm>
-          <a:prstGeom prst="rect">
-            <a:avLst/>
-          </a:prstGeom>
-          <a:noFill/>
-          <a:ln w="19050">
-            <a:solidFill>
-              <a:schemeClr val="tx1"/>
-            </a:solidFill>
-          </a:ln>
-        </p:spPr>
-        <p:style>
-          <a:lnRef idx="2">
-            <a:schemeClr val="accent1">
-              <a:shade val="50000"/>
-            </a:schemeClr>
-          </a:lnRef>
-          <a:fillRef idx="1">
-            <a:schemeClr val="accent1"/>
-          </a:fillRef>
-          <a:effectRef idx="0">
-            <a:schemeClr val="accent1"/>
-          </a:effectRef>
-          <a:fontRef idx="minor">
-            <a:schemeClr val="lt1"/>
-          </a:fontRef>
-        </p:style>
-        <p:txBody>
-          <a:bodyPr rtlCol="0" anchor="ctr"/>
-          <a:lstStyle/>
-          <a:p>
-            <a:pPr algn="ctr"/>
-            <a:endParaRPr lang="ko-KR" altLang="en-US"/>
-          </a:p>
-        </p:txBody>
-      </p:sp>
-      <p:sp>
-        <p:nvSpPr>
-          <p:cNvPr id="2" name="TextBox 1"/>
-          <p:cNvSpPr txBox="1"/>
-          <p:nvPr/>
-        </p:nvSpPr>
-        <p:spPr>
-          <a:xfrm>
-            <a:off x="3469973" y="-6009"/>
-            <a:ext cx="604653" cy="369332"/>
-          </a:xfrm>
-          <a:prstGeom prst="rect">
-            <a:avLst/>
-          </a:prstGeom>
-          <a:noFill/>
-        </p:spPr>
-        <p:txBody>
-          <a:bodyPr wrap="none" rtlCol="0">
-            <a:spAutoFit/>
-          </a:bodyPr>
-          <a:lstStyle/>
-          <a:p>
-            <a:r>
-              <a:rPr lang="ko-KR" altLang="en-US" dirty="0" smtClean="0">
-                <a:latin typeface="나눔스퀘어 Bold" panose="020B0600000101010101" pitchFamily="50" charset="-127"/>
-                <a:ea typeface="나눔스퀘어 Bold" panose="020B0600000101010101" pitchFamily="50" charset="-127"/>
-              </a:rPr>
-              <a:t>요청</a:t>
-            </a:r>
-            <a:endParaRPr lang="ko-KR" altLang="en-US" dirty="0">
-              <a:latin typeface="나눔스퀘어 Bold" panose="020B0600000101010101" pitchFamily="50" charset="-127"/>
-              <a:ea typeface="나눔스퀘어 Bold" panose="020B0600000101010101" pitchFamily="50" charset="-127"/>
-            </a:endParaRPr>
-          </a:p>
-        </p:txBody>
-      </p:sp>
-      <p:sp>
-        <p:nvSpPr>
-          <p:cNvPr id="31" name="TextBox 30"/>
-          <p:cNvSpPr txBox="1"/>
-          <p:nvPr/>
-        </p:nvSpPr>
-        <p:spPr>
-          <a:xfrm>
-            <a:off x="8121573" y="-6009"/>
-            <a:ext cx="604653" cy="369332"/>
-          </a:xfrm>
-          <a:prstGeom prst="rect">
-            <a:avLst/>
-          </a:prstGeom>
-          <a:noFill/>
-        </p:spPr>
-        <p:txBody>
-          <a:bodyPr wrap="none" rtlCol="0">
-            <a:spAutoFit/>
-          </a:bodyPr>
-          <a:lstStyle/>
-          <a:p>
-            <a:r>
-              <a:rPr lang="ko-KR" altLang="en-US" dirty="0" smtClean="0">
-                <a:latin typeface="나눔스퀘어 Bold" panose="020B0600000101010101" pitchFamily="50" charset="-127"/>
-                <a:ea typeface="나눔스퀘어 Bold" panose="020B0600000101010101" pitchFamily="50" charset="-127"/>
-              </a:rPr>
-              <a:t>위임</a:t>
-            </a:r>
-            <a:endParaRPr lang="ko-KR" altLang="en-US" dirty="0">
-              <a:latin typeface="나눔스퀘어 Bold" panose="020B0600000101010101" pitchFamily="50" charset="-127"/>
-              <a:ea typeface="나눔스퀘어 Bold" panose="020B0600000101010101" pitchFamily="50" charset="-127"/>
-            </a:endParaRPr>
-          </a:p>
-        </p:txBody>
-      </p:sp>
-      <p:sp>
-        <p:nvSpPr>
-          <p:cNvPr id="37" name="직사각형 36"/>
-          <p:cNvSpPr/>
-          <p:nvPr/>
-        </p:nvSpPr>
-        <p:spPr>
-          <a:xfrm>
-            <a:off x="4118100" y="-235572"/>
-            <a:ext cx="3960000" cy="1116000"/>
-          </a:xfrm>
-          <a:prstGeom prst="rect">
-            <a:avLst/>
-          </a:prstGeom>
-          <a:noFill/>
-          <a:ln w="19050">
-            <a:solidFill>
-              <a:schemeClr val="tx1"/>
-            </a:solidFill>
-          </a:ln>
-        </p:spPr>
-        <p:style>
-          <a:lnRef idx="2">
-            <a:schemeClr val="accent1">
-              <a:shade val="50000"/>
-            </a:schemeClr>
-          </a:lnRef>
-          <a:fillRef idx="1">
-            <a:schemeClr val="accent1"/>
-          </a:fillRef>
-          <a:effectRef idx="0">
-            <a:schemeClr val="accent1"/>
-          </a:effectRef>
-          <a:fontRef idx="minor">
-            <a:schemeClr val="lt1"/>
-          </a:fontRef>
-        </p:style>
-        <p:txBody>
-          <a:bodyPr rtlCol="0" anchor="ctr"/>
-          <a:lstStyle/>
-          <a:p>
-            <a:pPr algn="ctr"/>
-            <a:endParaRPr lang="ko-KR" altLang="en-US"/>
-          </a:p>
-        </p:txBody>
-      </p:sp>
-      <p:sp>
-        <p:nvSpPr>
-          <p:cNvPr id="38" name="모서리가 둥근 직사각형 37"/>
-          <p:cNvSpPr/>
-          <p:nvPr/>
-        </p:nvSpPr>
-        <p:spPr>
-          <a:xfrm>
-            <a:off x="4748100" y="-497158"/>
-            <a:ext cx="1440000" cy="432000"/>
-          </a:xfrm>
-          <a:prstGeom prst="roundRect">
-            <a:avLst/>
-          </a:prstGeom>
-          <a:solidFill>
-            <a:schemeClr val="bg1"/>
-          </a:solidFill>
-          <a:ln w="19050">
-            <a:solidFill>
-              <a:schemeClr val="tx1"/>
-            </a:solidFill>
-          </a:ln>
-        </p:spPr>
-        <p:style>
-          <a:lnRef idx="2">
-            <a:schemeClr val="accent1">
-              <a:shade val="50000"/>
-            </a:schemeClr>
-          </a:lnRef>
-          <a:fillRef idx="1">
-            <a:schemeClr val="accent1"/>
-          </a:fillRef>
-          <a:effectRef idx="0">
-            <a:schemeClr val="accent1"/>
-          </a:effectRef>
-          <a:fontRef idx="minor">
-            <a:schemeClr val="lt1"/>
-          </a:fontRef>
-        </p:style>
-        <p:txBody>
-          <a:bodyPr rtlCol="0" anchor="ctr"/>
-          <a:lstStyle/>
-          <a:p>
-            <a:pPr algn="ctr"/>
-            <a:r>
-              <a:rPr lang="ko-KR" altLang="en-US" sz="2000" dirty="0" smtClean="0">
-                <a:solidFill>
-                  <a:schemeClr val="tx1"/>
-                </a:solidFill>
-                <a:latin typeface="나눔스퀘어 Bold" panose="020B0600000101010101" pitchFamily="50" charset="-127"/>
-                <a:ea typeface="나눔스퀘어 Bold" panose="020B0600000101010101" pitchFamily="50" charset="-127"/>
-              </a:rPr>
-              <a:t>필터</a:t>
-            </a:r>
-            <a:r>
-              <a:rPr lang="en-US" altLang="ko-KR" sz="2000" dirty="0" smtClean="0">
-                <a:solidFill>
-                  <a:schemeClr val="tx1"/>
-                </a:solidFill>
-                <a:latin typeface="나눔스퀘어 Bold" panose="020B0600000101010101" pitchFamily="50" charset="-127"/>
-                <a:ea typeface="나눔스퀘어 Bold" panose="020B0600000101010101" pitchFamily="50" charset="-127"/>
-              </a:rPr>
-              <a:t> </a:t>
-            </a:r>
-            <a:r>
-              <a:rPr lang="ko-KR" altLang="en-US" sz="2000" dirty="0" smtClean="0">
-                <a:solidFill>
-                  <a:schemeClr val="tx1"/>
-                </a:solidFill>
-                <a:latin typeface="나눔스퀘어 Bold" panose="020B0600000101010101" pitchFamily="50" charset="-127"/>
-                <a:ea typeface="나눔스퀘어 Bold" panose="020B0600000101010101" pitchFamily="50" charset="-127"/>
-              </a:rPr>
-              <a:t>체인</a:t>
-            </a:r>
-            <a:endParaRPr lang="ko-KR" altLang="en-US" sz="2000" dirty="0">
-              <a:solidFill>
-                <a:schemeClr val="tx1"/>
-              </a:solidFill>
-              <a:latin typeface="나눔스퀘어 Bold" panose="020B0600000101010101" pitchFamily="50" charset="-127"/>
-              <a:ea typeface="나눔스퀘어 Bold" panose="020B0600000101010101" pitchFamily="50" charset="-127"/>
-            </a:endParaRPr>
-          </a:p>
-        </p:txBody>
-      </p:sp>
-      <p:sp>
-        <p:nvSpPr>
-          <p:cNvPr id="39" name="모서리가 둥근 직사각형 38"/>
-          <p:cNvSpPr/>
-          <p:nvPr/>
-        </p:nvSpPr>
-        <p:spPr>
-          <a:xfrm>
-            <a:off x="6893899" y="-1015825"/>
-            <a:ext cx="3060000" cy="432000"/>
-          </a:xfrm>
-          <a:prstGeom prst="roundRect">
-            <a:avLst/>
-          </a:prstGeom>
-          <a:solidFill>
-            <a:schemeClr val="bg1"/>
-          </a:solidFill>
-          <a:ln w="19050">
-            <a:solidFill>
-              <a:schemeClr val="tx1"/>
-            </a:solidFill>
-          </a:ln>
-        </p:spPr>
-        <p:style>
-          <a:lnRef idx="2">
-            <a:schemeClr val="accent1">
-              <a:shade val="50000"/>
-            </a:schemeClr>
-          </a:lnRef>
-          <a:fillRef idx="1">
-            <a:schemeClr val="accent1"/>
-          </a:fillRef>
-          <a:effectRef idx="0">
-            <a:schemeClr val="accent1"/>
-          </a:effectRef>
-          <a:fontRef idx="minor">
-            <a:schemeClr val="lt1"/>
-          </a:fontRef>
-        </p:style>
-        <p:txBody>
-          <a:bodyPr rtlCol="0" anchor="ctr"/>
-          <a:lstStyle/>
-          <a:p>
-            <a:pPr algn="ctr"/>
-            <a:r>
-              <a:rPr lang="ko-KR" altLang="en-US" sz="2000" dirty="0" err="1" smtClean="0">
-                <a:solidFill>
-                  <a:schemeClr val="tx1"/>
-                </a:solidFill>
-                <a:latin typeface="나눔스퀘어 Bold" panose="020B0600000101010101" pitchFamily="50" charset="-127"/>
-                <a:ea typeface="나눔스퀘어 Bold" panose="020B0600000101010101" pitchFamily="50" charset="-127"/>
-              </a:rPr>
-              <a:t>서블릿</a:t>
-            </a:r>
-            <a:r>
-              <a:rPr lang="ko-KR" altLang="en-US" sz="2000" dirty="0" smtClean="0">
-                <a:solidFill>
-                  <a:schemeClr val="tx1"/>
-                </a:solidFill>
-                <a:latin typeface="나눔스퀘어 Bold" panose="020B0600000101010101" pitchFamily="50" charset="-127"/>
-                <a:ea typeface="나눔스퀘어 Bold" panose="020B0600000101010101" pitchFamily="50" charset="-127"/>
-              </a:rPr>
-              <a:t> 컨테이너</a:t>
-            </a:r>
-            <a:r>
-              <a:rPr lang="en-US" altLang="ko-KR" sz="2000" dirty="0" smtClean="0">
-                <a:solidFill>
-                  <a:schemeClr val="tx1"/>
-                </a:solidFill>
-                <a:latin typeface="나눔스퀘어 Bold" panose="020B0600000101010101" pitchFamily="50" charset="-127"/>
-                <a:ea typeface="나눔스퀘어 Bold" panose="020B0600000101010101" pitchFamily="50" charset="-127"/>
-              </a:rPr>
-              <a:t>(Tomcat)</a:t>
-            </a:r>
-            <a:endParaRPr lang="ko-KR" altLang="en-US" sz="2000" dirty="0">
-              <a:solidFill>
-                <a:schemeClr val="tx1"/>
-              </a:solidFill>
-              <a:latin typeface="나눔스퀘어 Bold" panose="020B0600000101010101" pitchFamily="50" charset="-127"/>
-              <a:ea typeface="나눔스퀘어 Bold" panose="020B0600000101010101" pitchFamily="50" charset="-127"/>
-            </a:endParaRPr>
-          </a:p>
-        </p:txBody>
-      </p:sp>
-    </p:spTree>
-    <p:extLst>
-      <p:ext uri="{BB962C8B-B14F-4D97-AF65-F5344CB8AC3E}">
-        <p14:creationId xmlns:p14="http://schemas.microsoft.com/office/powerpoint/2010/main" val="128690120"/>
-      </p:ext>
-    </p:extLst>
-  </p:cSld>
-  <p:clrMapOvr>
-    <a:masterClrMapping/>
-  </p:clrMapOvr>
-  <p:timing>
-    <p:tnLst>
-      <p:par>
-        <p:cTn id="1" dur="indefinite" restart="never" nodeType="tmRoot"/>
-      </p:par>
-    </p:tnLst>
-  </p:timing>
-</p:sld>
-</file>
-
-<file path=ppt/slides/slide4.xml><?xml version="1.0" encoding="utf-8"?>
-<p:sld xmlns:a="http://schemas.openxmlformats.org/drawingml/2006/main" xmlns:r="http://schemas.openxmlformats.org/officeDocument/2006/relationships" xmlns:p="http://schemas.openxmlformats.org/presentationml/2006/main">
-  <p:cSld>
-    <p:spTree>
-      <p:nvGrpSpPr>
-        <p:cNvPr id="1" name=""/>
-        <p:cNvGrpSpPr/>
-        <p:nvPr/>
-      </p:nvGrpSpPr>
-      <p:grpSpPr>
-        <a:xfrm>
-          <a:off x="0" y="0"/>
-          <a:ext cx="0" cy="0"/>
-          <a:chOff x="0" y="0"/>
-          <a:chExt cx="0" cy="0"/>
-        </a:xfrm>
-      </p:grpSpPr>
-      <p:sp>
-        <p:nvSpPr>
           <p:cNvPr id="81" name="직사각형 80"/>
           <p:cNvSpPr>
             <a:spLocks noChangeAspect="1"/>
@@ -11939,7 +10930,7 @@
 </p:sld>
 </file>
 
-<file path=ppt/slides/slide5.xml><?xml version="1.0" encoding="utf-8"?>
+<file path=ppt/slides/slide4.xml><?xml version="1.0" encoding="utf-8"?>
 <p:sld xmlns:a="http://schemas.openxmlformats.org/drawingml/2006/main" xmlns:r="http://schemas.openxmlformats.org/officeDocument/2006/relationships" xmlns:p="http://schemas.openxmlformats.org/presentationml/2006/main">
   <p:cSld>
     <p:spTree>

</xml_diff>

<commit_message>
20260921 commit : 0955
</commit_message>
<xml_diff>
--- a/notion/create_notion_img.pptx
+++ b/notion/create_notion_img.pptx
@@ -246,7 +246,7 @@
           <a:p>
             <a:fld id="{7237CE1A-8831-48B5-BA93-72483C6E34E8}" type="datetimeFigureOut">
               <a:rPr lang="ko-KR" altLang="en-US" smtClean="0"/>
-              <a:t>2026-09-18</a:t>
+              <a:t>2026-09-21</a:t>
             </a:fld>
             <a:endParaRPr lang="ko-KR" altLang="en-US"/>
           </a:p>
@@ -416,7 +416,7 @@
           <a:p>
             <a:fld id="{7237CE1A-8831-48B5-BA93-72483C6E34E8}" type="datetimeFigureOut">
               <a:rPr lang="ko-KR" altLang="en-US" smtClean="0"/>
-              <a:t>2026-09-18</a:t>
+              <a:t>2026-09-21</a:t>
             </a:fld>
             <a:endParaRPr lang="ko-KR" altLang="en-US"/>
           </a:p>
@@ -596,7 +596,7 @@
           <a:p>
             <a:fld id="{7237CE1A-8831-48B5-BA93-72483C6E34E8}" type="datetimeFigureOut">
               <a:rPr lang="ko-KR" altLang="en-US" smtClean="0"/>
-              <a:t>2026-09-18</a:t>
+              <a:t>2026-09-21</a:t>
             </a:fld>
             <a:endParaRPr lang="ko-KR" altLang="en-US"/>
           </a:p>
@@ -766,7 +766,7 @@
           <a:p>
             <a:fld id="{7237CE1A-8831-48B5-BA93-72483C6E34E8}" type="datetimeFigureOut">
               <a:rPr lang="ko-KR" altLang="en-US" smtClean="0"/>
-              <a:t>2026-09-18</a:t>
+              <a:t>2026-09-21</a:t>
             </a:fld>
             <a:endParaRPr lang="ko-KR" altLang="en-US"/>
           </a:p>
@@ -1012,7 +1012,7 @@
           <a:p>
             <a:fld id="{7237CE1A-8831-48B5-BA93-72483C6E34E8}" type="datetimeFigureOut">
               <a:rPr lang="ko-KR" altLang="en-US" smtClean="0"/>
-              <a:t>2026-09-18</a:t>
+              <a:t>2026-09-21</a:t>
             </a:fld>
             <a:endParaRPr lang="ko-KR" altLang="en-US"/>
           </a:p>
@@ -1244,7 +1244,7 @@
           <a:p>
             <a:fld id="{7237CE1A-8831-48B5-BA93-72483C6E34E8}" type="datetimeFigureOut">
               <a:rPr lang="ko-KR" altLang="en-US" smtClean="0"/>
-              <a:t>2026-09-18</a:t>
+              <a:t>2026-09-21</a:t>
             </a:fld>
             <a:endParaRPr lang="ko-KR" altLang="en-US"/>
           </a:p>
@@ -1611,7 +1611,7 @@
           <a:p>
             <a:fld id="{7237CE1A-8831-48B5-BA93-72483C6E34E8}" type="datetimeFigureOut">
               <a:rPr lang="ko-KR" altLang="en-US" smtClean="0"/>
-              <a:t>2026-09-18</a:t>
+              <a:t>2026-09-21</a:t>
             </a:fld>
             <a:endParaRPr lang="ko-KR" altLang="en-US"/>
           </a:p>
@@ -1729,7 +1729,7 @@
           <a:p>
             <a:fld id="{7237CE1A-8831-48B5-BA93-72483C6E34E8}" type="datetimeFigureOut">
               <a:rPr lang="ko-KR" altLang="en-US" smtClean="0"/>
-              <a:t>2026-09-18</a:t>
+              <a:t>2026-09-21</a:t>
             </a:fld>
             <a:endParaRPr lang="ko-KR" altLang="en-US"/>
           </a:p>
@@ -1824,7 +1824,7 @@
           <a:p>
             <a:fld id="{7237CE1A-8831-48B5-BA93-72483C6E34E8}" type="datetimeFigureOut">
               <a:rPr lang="ko-KR" altLang="en-US" smtClean="0"/>
-              <a:t>2026-09-18</a:t>
+              <a:t>2026-09-21</a:t>
             </a:fld>
             <a:endParaRPr lang="ko-KR" altLang="en-US"/>
           </a:p>
@@ -2101,7 +2101,7 @@
           <a:p>
             <a:fld id="{7237CE1A-8831-48B5-BA93-72483C6E34E8}" type="datetimeFigureOut">
               <a:rPr lang="ko-KR" altLang="en-US" smtClean="0"/>
-              <a:t>2026-09-18</a:t>
+              <a:t>2026-09-21</a:t>
             </a:fld>
             <a:endParaRPr lang="ko-KR" altLang="en-US"/>
           </a:p>
@@ -2354,7 +2354,7 @@
           <a:p>
             <a:fld id="{7237CE1A-8831-48B5-BA93-72483C6E34E8}" type="datetimeFigureOut">
               <a:rPr lang="ko-KR" altLang="en-US" smtClean="0"/>
-              <a:t>2026-09-18</a:t>
+              <a:t>2026-09-21</a:t>
             </a:fld>
             <a:endParaRPr lang="ko-KR" altLang="en-US"/>
           </a:p>
@@ -2567,7 +2567,7 @@
           <a:p>
             <a:fld id="{7237CE1A-8831-48B5-BA93-72483C6E34E8}" type="datetimeFigureOut">
               <a:rPr lang="ko-KR" altLang="en-US" smtClean="0"/>
-              <a:t>2026-09-18</a:t>
+              <a:t>2026-09-21</a:t>
             </a:fld>
             <a:endParaRPr lang="ko-KR" altLang="en-US"/>
           </a:p>
@@ -2972,250 +2972,6 @@
           <a:chExt cx="0" cy="0"/>
         </a:xfrm>
       </p:grpSpPr>
-      <p:sp>
-        <p:nvSpPr>
-          <p:cNvPr id="2" name="직사각형 1"/>
-          <p:cNvSpPr/>
-          <p:nvPr/>
-        </p:nvSpPr>
-        <p:spPr>
-          <a:xfrm>
-            <a:off x="781050" y="323850"/>
-            <a:ext cx="3009900" cy="1200150"/>
-          </a:xfrm>
-          <a:prstGeom prst="rect">
-            <a:avLst/>
-          </a:prstGeom>
-        </p:spPr>
-        <p:style>
-          <a:lnRef idx="2">
-            <a:schemeClr val="accent1">
-              <a:shade val="50000"/>
-            </a:schemeClr>
-          </a:lnRef>
-          <a:fillRef idx="1">
-            <a:schemeClr val="accent1"/>
-          </a:fillRef>
-          <a:effectRef idx="0">
-            <a:schemeClr val="accent1"/>
-          </a:effectRef>
-          <a:fontRef idx="minor">
-            <a:schemeClr val="lt1"/>
-          </a:fontRef>
-        </p:style>
-        <p:txBody>
-          <a:bodyPr rtlCol="0" anchor="ctr"/>
-          <a:lstStyle/>
-          <a:p>
-            <a:pPr algn="ctr"/>
-            <a:r>
-              <a:rPr lang="en-US" altLang="ko-KR" dirty="0" smtClean="0"/>
-              <a:t>client</a:t>
-            </a:r>
-            <a:endParaRPr lang="ko-KR" altLang="en-US" dirty="0"/>
-          </a:p>
-        </p:txBody>
-      </p:sp>
-      <p:sp>
-        <p:nvSpPr>
-          <p:cNvPr id="205" name="직사각형 204"/>
-          <p:cNvSpPr/>
-          <p:nvPr/>
-        </p:nvSpPr>
-        <p:spPr>
-          <a:xfrm>
-            <a:off x="8477250" y="323850"/>
-            <a:ext cx="3009900" cy="1200150"/>
-          </a:xfrm>
-          <a:prstGeom prst="rect">
-            <a:avLst/>
-          </a:prstGeom>
-        </p:spPr>
-        <p:style>
-          <a:lnRef idx="2">
-            <a:schemeClr val="accent1">
-              <a:shade val="50000"/>
-            </a:schemeClr>
-          </a:lnRef>
-          <a:fillRef idx="1">
-            <a:schemeClr val="accent1"/>
-          </a:fillRef>
-          <a:effectRef idx="0">
-            <a:schemeClr val="accent1"/>
-          </a:effectRef>
-          <a:fontRef idx="minor">
-            <a:schemeClr val="lt1"/>
-          </a:fontRef>
-        </p:style>
-        <p:txBody>
-          <a:bodyPr rtlCol="0" anchor="ctr"/>
-          <a:lstStyle/>
-          <a:p>
-            <a:pPr algn="ctr"/>
-            <a:r>
-              <a:rPr lang="en-US" altLang="ko-KR" dirty="0" smtClean="0"/>
-              <a:t>server</a:t>
-            </a:r>
-            <a:endParaRPr lang="ko-KR" altLang="en-US" dirty="0"/>
-          </a:p>
-        </p:txBody>
-      </p:sp>
-      <p:cxnSp>
-        <p:nvCxnSpPr>
-          <p:cNvPr id="4" name="직선 화살표 연결선 3"/>
-          <p:cNvCxnSpPr/>
-          <p:nvPr/>
-        </p:nvCxnSpPr>
-        <p:spPr>
-          <a:xfrm flipV="1">
-            <a:off x="4095750" y="476250"/>
-            <a:ext cx="3714750" cy="57150"/>
-          </a:xfrm>
-          <a:prstGeom prst="straightConnector1">
-            <a:avLst/>
-          </a:prstGeom>
-          <a:ln>
-            <a:tailEnd type="triangle"/>
-          </a:ln>
-        </p:spPr>
-        <p:style>
-          <a:lnRef idx="1">
-            <a:schemeClr val="accent1"/>
-          </a:lnRef>
-          <a:fillRef idx="0">
-            <a:schemeClr val="accent1"/>
-          </a:fillRef>
-          <a:effectRef idx="0">
-            <a:schemeClr val="accent1"/>
-          </a:effectRef>
-          <a:fontRef idx="minor">
-            <a:schemeClr val="tx1"/>
-          </a:fontRef>
-        </p:style>
-      </p:cxnSp>
-      <p:cxnSp>
-        <p:nvCxnSpPr>
-          <p:cNvPr id="206" name="직선 화살표 연결선 205"/>
-          <p:cNvCxnSpPr/>
-          <p:nvPr/>
-        </p:nvCxnSpPr>
-        <p:spPr>
-          <a:xfrm flipH="1">
-            <a:off x="4457700" y="1066800"/>
-            <a:ext cx="3524250" cy="95250"/>
-          </a:xfrm>
-          <a:prstGeom prst="straightConnector1">
-            <a:avLst/>
-          </a:prstGeom>
-          <a:ln>
-            <a:tailEnd type="triangle"/>
-          </a:ln>
-        </p:spPr>
-        <p:style>
-          <a:lnRef idx="1">
-            <a:schemeClr val="accent1"/>
-          </a:lnRef>
-          <a:fillRef idx="0">
-            <a:schemeClr val="accent1"/>
-          </a:fillRef>
-          <a:effectRef idx="0">
-            <a:schemeClr val="accent1"/>
-          </a:effectRef>
-          <a:fontRef idx="minor">
-            <a:schemeClr val="tx1"/>
-          </a:fontRef>
-        </p:style>
-      </p:cxnSp>
-      <p:sp>
-        <p:nvSpPr>
-          <p:cNvPr id="7" name="TextBox 6"/>
-          <p:cNvSpPr txBox="1"/>
-          <p:nvPr/>
-        </p:nvSpPr>
-        <p:spPr>
-          <a:xfrm>
-            <a:off x="5653071" y="154543"/>
-            <a:ext cx="962058" cy="369332"/>
-          </a:xfrm>
-          <a:prstGeom prst="rect">
-            <a:avLst/>
-          </a:prstGeom>
-          <a:noFill/>
-        </p:spPr>
-        <p:txBody>
-          <a:bodyPr wrap="none" rtlCol="0">
-            <a:spAutoFit/>
-          </a:bodyPr>
-          <a:lstStyle/>
-          <a:p>
-            <a:r>
-              <a:rPr lang="en-US" altLang="ko-KR" dirty="0" smtClean="0"/>
-              <a:t>request</a:t>
-            </a:r>
-            <a:endParaRPr lang="ko-KR" altLang="en-US" dirty="0"/>
-          </a:p>
-        </p:txBody>
-      </p:sp>
-      <p:sp>
-        <p:nvSpPr>
-          <p:cNvPr id="207" name="TextBox 206"/>
-          <p:cNvSpPr txBox="1"/>
-          <p:nvPr/>
-        </p:nvSpPr>
-        <p:spPr>
-          <a:xfrm>
-            <a:off x="5661050" y="1154668"/>
-            <a:ext cx="1117550" cy="369332"/>
-          </a:xfrm>
-          <a:prstGeom prst="rect">
-            <a:avLst/>
-          </a:prstGeom>
-          <a:noFill/>
-        </p:spPr>
-        <p:txBody>
-          <a:bodyPr wrap="none" rtlCol="0">
-            <a:spAutoFit/>
-          </a:bodyPr>
-          <a:lstStyle/>
-          <a:p>
-            <a:r>
-              <a:rPr lang="en-US" altLang="ko-KR" dirty="0" smtClean="0"/>
-              <a:t>response</a:t>
-            </a:r>
-            <a:endParaRPr lang="ko-KR" altLang="en-US" dirty="0"/>
-          </a:p>
-        </p:txBody>
-      </p:sp>
-      <p:sp>
-        <p:nvSpPr>
-          <p:cNvPr id="208" name="TextBox 207"/>
-          <p:cNvSpPr txBox="1"/>
-          <p:nvPr/>
-        </p:nvSpPr>
-        <p:spPr>
-          <a:xfrm>
-            <a:off x="5524500" y="-247650"/>
-            <a:ext cx="962058" cy="369332"/>
-          </a:xfrm>
-          <a:prstGeom prst="rect">
-            <a:avLst/>
-          </a:prstGeom>
-          <a:noFill/>
-        </p:spPr>
-        <p:txBody>
-          <a:bodyPr wrap="none" rtlCol="0">
-            <a:spAutoFit/>
-          </a:bodyPr>
-          <a:lstStyle/>
-          <a:p>
-            <a:r>
-              <a:rPr lang="en-US" altLang="ko-KR" dirty="0" smtClean="0"/>
-              <a:t>request</a:t>
-            </a:r>
-            <a:endParaRPr lang="ko-KR" altLang="en-US" dirty="0"/>
-          </a:p>
-        </p:txBody>
-      </p:sp>
     </p:spTree>
     <p:extLst>
       <p:ext uri="{BB962C8B-B14F-4D97-AF65-F5344CB8AC3E}">

</xml_diff>

<commit_message>
20260930 commit : 1_class
</commit_message>
<xml_diff>
--- a/notion/create_notion_img.pptx
+++ b/notion/create_notion_img.pptx
@@ -6,9 +6,10 @@
   </p:sldMasterIdLst>
   <p:sldIdLst>
     <p:sldId id="260" r:id="rId2"/>
-    <p:sldId id="256" r:id="rId3"/>
-    <p:sldId id="259" r:id="rId4"/>
-    <p:sldId id="257" r:id="rId5"/>
+    <p:sldId id="261" r:id="rId3"/>
+    <p:sldId id="256" r:id="rId4"/>
+    <p:sldId id="259" r:id="rId5"/>
+    <p:sldId id="257" r:id="rId6"/>
   </p:sldIdLst>
   <p:sldSz cx="12192000" cy="6858000"/>
   <p:notesSz cx="6858000" cy="9144000"/>
@@ -246,7 +247,7 @@
           <a:p>
             <a:fld id="{7237CE1A-8831-48B5-BA93-72483C6E34E8}" type="datetimeFigureOut">
               <a:rPr lang="ko-KR" altLang="en-US" smtClean="0"/>
-              <a:t>2026-09-21</a:t>
+              <a:t>2026-09-30</a:t>
             </a:fld>
             <a:endParaRPr lang="ko-KR" altLang="en-US"/>
           </a:p>
@@ -416,7 +417,7 @@
           <a:p>
             <a:fld id="{7237CE1A-8831-48B5-BA93-72483C6E34E8}" type="datetimeFigureOut">
               <a:rPr lang="ko-KR" altLang="en-US" smtClean="0"/>
-              <a:t>2026-09-21</a:t>
+              <a:t>2026-09-30</a:t>
             </a:fld>
             <a:endParaRPr lang="ko-KR" altLang="en-US"/>
           </a:p>
@@ -596,7 +597,7 @@
           <a:p>
             <a:fld id="{7237CE1A-8831-48B5-BA93-72483C6E34E8}" type="datetimeFigureOut">
               <a:rPr lang="ko-KR" altLang="en-US" smtClean="0"/>
-              <a:t>2026-09-21</a:t>
+              <a:t>2026-09-30</a:t>
             </a:fld>
             <a:endParaRPr lang="ko-KR" altLang="en-US"/>
           </a:p>
@@ -766,7 +767,7 @@
           <a:p>
             <a:fld id="{7237CE1A-8831-48B5-BA93-72483C6E34E8}" type="datetimeFigureOut">
               <a:rPr lang="ko-KR" altLang="en-US" smtClean="0"/>
-              <a:t>2026-09-21</a:t>
+              <a:t>2026-09-30</a:t>
             </a:fld>
             <a:endParaRPr lang="ko-KR" altLang="en-US"/>
           </a:p>
@@ -1012,7 +1013,7 @@
           <a:p>
             <a:fld id="{7237CE1A-8831-48B5-BA93-72483C6E34E8}" type="datetimeFigureOut">
               <a:rPr lang="ko-KR" altLang="en-US" smtClean="0"/>
-              <a:t>2026-09-21</a:t>
+              <a:t>2026-09-30</a:t>
             </a:fld>
             <a:endParaRPr lang="ko-KR" altLang="en-US"/>
           </a:p>
@@ -1244,7 +1245,7 @@
           <a:p>
             <a:fld id="{7237CE1A-8831-48B5-BA93-72483C6E34E8}" type="datetimeFigureOut">
               <a:rPr lang="ko-KR" altLang="en-US" smtClean="0"/>
-              <a:t>2026-09-21</a:t>
+              <a:t>2026-09-30</a:t>
             </a:fld>
             <a:endParaRPr lang="ko-KR" altLang="en-US"/>
           </a:p>
@@ -1611,7 +1612,7 @@
           <a:p>
             <a:fld id="{7237CE1A-8831-48B5-BA93-72483C6E34E8}" type="datetimeFigureOut">
               <a:rPr lang="ko-KR" altLang="en-US" smtClean="0"/>
-              <a:t>2026-09-21</a:t>
+              <a:t>2026-09-30</a:t>
             </a:fld>
             <a:endParaRPr lang="ko-KR" altLang="en-US"/>
           </a:p>
@@ -1729,7 +1730,7 @@
           <a:p>
             <a:fld id="{7237CE1A-8831-48B5-BA93-72483C6E34E8}" type="datetimeFigureOut">
               <a:rPr lang="ko-KR" altLang="en-US" smtClean="0"/>
-              <a:t>2026-09-21</a:t>
+              <a:t>2026-09-30</a:t>
             </a:fld>
             <a:endParaRPr lang="ko-KR" altLang="en-US"/>
           </a:p>
@@ -1824,7 +1825,7 @@
           <a:p>
             <a:fld id="{7237CE1A-8831-48B5-BA93-72483C6E34E8}" type="datetimeFigureOut">
               <a:rPr lang="ko-KR" altLang="en-US" smtClean="0"/>
-              <a:t>2026-09-21</a:t>
+              <a:t>2026-09-30</a:t>
             </a:fld>
             <a:endParaRPr lang="ko-KR" altLang="en-US"/>
           </a:p>
@@ -2101,7 +2102,7 @@
           <a:p>
             <a:fld id="{7237CE1A-8831-48B5-BA93-72483C6E34E8}" type="datetimeFigureOut">
               <a:rPr lang="ko-KR" altLang="en-US" smtClean="0"/>
-              <a:t>2026-09-21</a:t>
+              <a:t>2026-09-30</a:t>
             </a:fld>
             <a:endParaRPr lang="ko-KR" altLang="en-US"/>
           </a:p>
@@ -2354,7 +2355,7 @@
           <a:p>
             <a:fld id="{7237CE1A-8831-48B5-BA93-72483C6E34E8}" type="datetimeFigureOut">
               <a:rPr lang="ko-KR" altLang="en-US" smtClean="0"/>
-              <a:t>2026-09-21</a:t>
+              <a:t>2026-09-30</a:t>
             </a:fld>
             <a:endParaRPr lang="ko-KR" altLang="en-US"/>
           </a:p>
@@ -2567,7 +2568,7 @@
           <a:p>
             <a:fld id="{7237CE1A-8831-48B5-BA93-72483C6E34E8}" type="datetimeFigureOut">
               <a:rPr lang="ko-KR" altLang="en-US" smtClean="0"/>
-              <a:t>2026-09-21</a:t>
+              <a:t>2026-09-30</a:t>
             </a:fld>
             <a:endParaRPr lang="ko-KR" altLang="en-US"/>
           </a:p>
@@ -2972,6 +2973,1388 @@
           <a:chExt cx="0" cy="0"/>
         </a:xfrm>
       </p:grpSpPr>
+      <p:sp>
+        <p:nvSpPr>
+          <p:cNvPr id="2" name="직사각형 1"/>
+          <p:cNvSpPr/>
+          <p:nvPr/>
+        </p:nvSpPr>
+        <p:spPr>
+          <a:xfrm>
+            <a:off x="0" y="2217107"/>
+            <a:ext cx="2880000" cy="1440000"/>
+          </a:xfrm>
+          <a:prstGeom prst="rect">
+            <a:avLst/>
+          </a:prstGeom>
+          <a:solidFill>
+            <a:schemeClr val="accent5"/>
+          </a:solidFill>
+          <a:ln>
+            <a:solidFill>
+              <a:schemeClr val="tx1"/>
+            </a:solidFill>
+          </a:ln>
+        </p:spPr>
+        <p:style>
+          <a:lnRef idx="2">
+            <a:schemeClr val="accent1">
+              <a:shade val="50000"/>
+            </a:schemeClr>
+          </a:lnRef>
+          <a:fillRef idx="1">
+            <a:schemeClr val="accent1"/>
+          </a:fillRef>
+          <a:effectRef idx="0">
+            <a:schemeClr val="accent1"/>
+          </a:effectRef>
+          <a:fontRef idx="minor">
+            <a:schemeClr val="lt1"/>
+          </a:fontRef>
+        </p:style>
+        <p:txBody>
+          <a:bodyPr rtlCol="0" anchor="ctr"/>
+          <a:lstStyle/>
+          <a:p>
+            <a:pPr algn="ctr"/>
+            <a:r>
+              <a:rPr lang="ko-KR" altLang="en-US" sz="2400" dirty="0" smtClean="0">
+                <a:latin typeface="나눔스퀘어 Bold" panose="020B0600000101010101" pitchFamily="50" charset="-127"/>
+                <a:ea typeface="나눔스퀘어 Bold" panose="020B0600000101010101" pitchFamily="50" charset="-127"/>
+              </a:rPr>
+              <a:t>개발</a:t>
+            </a:r>
+            <a:r>
+              <a:rPr lang="en-US" altLang="ko-KR" sz="2400" dirty="0" smtClean="0">
+                <a:latin typeface="나눔스퀘어 Bold" panose="020B0600000101010101" pitchFamily="50" charset="-127"/>
+                <a:ea typeface="나눔스퀘어 Bold" panose="020B0600000101010101" pitchFamily="50" charset="-127"/>
+              </a:rPr>
+              <a:t>PC(Local)</a:t>
+            </a:r>
+          </a:p>
+          <a:p>
+            <a:pPr algn="ctr"/>
+            <a:r>
+              <a:rPr lang="en-US" altLang="ko-KR" sz="2400" dirty="0" smtClean="0">
+                <a:latin typeface="나눔스퀘어 Bold" panose="020B0600000101010101" pitchFamily="50" charset="-127"/>
+                <a:ea typeface="나눔스퀘어 Bold" panose="020B0600000101010101" pitchFamily="50" charset="-127"/>
+              </a:rPr>
+              <a:t>JDK, </a:t>
+            </a:r>
+            <a:r>
+              <a:rPr lang="en-US" altLang="ko-KR" sz="2400" dirty="0" err="1" smtClean="0">
+                <a:latin typeface="나눔스퀘어 Bold" panose="020B0600000101010101" pitchFamily="50" charset="-127"/>
+                <a:ea typeface="나눔스퀘어 Bold" panose="020B0600000101010101" pitchFamily="50" charset="-127"/>
+              </a:rPr>
+              <a:t>Git</a:t>
+            </a:r>
+            <a:r>
+              <a:rPr lang="en-US" altLang="ko-KR" sz="2400" dirty="0" smtClean="0">
+                <a:latin typeface="나눔스퀘어 Bold" panose="020B0600000101010101" pitchFamily="50" charset="-127"/>
+                <a:ea typeface="나눔스퀘어 Bold" panose="020B0600000101010101" pitchFamily="50" charset="-127"/>
+              </a:rPr>
+              <a:t>, MySQL</a:t>
+            </a:r>
+            <a:endParaRPr lang="ko-KR" altLang="en-US" sz="2400" dirty="0">
+              <a:latin typeface="나눔스퀘어 Bold" panose="020B0600000101010101" pitchFamily="50" charset="-127"/>
+              <a:ea typeface="나눔스퀘어 Bold" panose="020B0600000101010101" pitchFamily="50" charset="-127"/>
+            </a:endParaRPr>
+          </a:p>
+        </p:txBody>
+      </p:sp>
+      <p:sp>
+        <p:nvSpPr>
+          <p:cNvPr id="4" name="직사각형 3"/>
+          <p:cNvSpPr/>
+          <p:nvPr/>
+        </p:nvSpPr>
+        <p:spPr>
+          <a:xfrm>
+            <a:off x="4656000" y="2217107"/>
+            <a:ext cx="2880000" cy="1440000"/>
+          </a:xfrm>
+          <a:prstGeom prst="rect">
+            <a:avLst/>
+          </a:prstGeom>
+          <a:solidFill>
+            <a:schemeClr val="accent5"/>
+          </a:solidFill>
+          <a:ln>
+            <a:solidFill>
+              <a:schemeClr val="tx1"/>
+            </a:solidFill>
+          </a:ln>
+        </p:spPr>
+        <p:style>
+          <a:lnRef idx="2">
+            <a:schemeClr val="accent1">
+              <a:shade val="50000"/>
+            </a:schemeClr>
+          </a:lnRef>
+          <a:fillRef idx="1">
+            <a:schemeClr val="accent1"/>
+          </a:fillRef>
+          <a:effectRef idx="0">
+            <a:schemeClr val="accent1"/>
+          </a:effectRef>
+          <a:fontRef idx="minor">
+            <a:schemeClr val="lt1"/>
+          </a:fontRef>
+        </p:style>
+        <p:txBody>
+          <a:bodyPr rtlCol="0" anchor="ctr"/>
+          <a:lstStyle/>
+          <a:p>
+            <a:pPr algn="ctr"/>
+            <a:r>
+              <a:rPr lang="en-US" altLang="ko-KR" sz="2000" dirty="0" smtClean="0">
+                <a:latin typeface="나눔스퀘어 Bold" panose="020B0600000101010101" pitchFamily="50" charset="-127"/>
+                <a:ea typeface="나눔스퀘어 Bold" panose="020B0600000101010101" pitchFamily="50" charset="-127"/>
+              </a:rPr>
+              <a:t>Dev(Stage) Server</a:t>
+            </a:r>
+          </a:p>
+          <a:p>
+            <a:pPr algn="ctr"/>
+            <a:r>
+              <a:rPr lang="en-US" altLang="ko-KR" sz="2000" dirty="0" err="1" smtClean="0">
+                <a:latin typeface="나눔스퀘어 Bold" panose="020B0600000101010101" pitchFamily="50" charset="-127"/>
+                <a:ea typeface="나눔스퀘어 Bold" panose="020B0600000101010101" pitchFamily="50" charset="-127"/>
+              </a:rPr>
+              <a:t>Gradle</a:t>
+            </a:r>
+            <a:r>
+              <a:rPr lang="en-US" altLang="ko-KR" sz="2000" dirty="0" smtClean="0">
+                <a:latin typeface="나눔스퀘어 Bold" panose="020B0600000101010101" pitchFamily="50" charset="-127"/>
+                <a:ea typeface="나눔스퀘어 Bold" panose="020B0600000101010101" pitchFamily="50" charset="-127"/>
+              </a:rPr>
+              <a:t>, JDK, </a:t>
+            </a:r>
+            <a:r>
+              <a:rPr lang="en-US" altLang="ko-KR" sz="2000" dirty="0" err="1" smtClean="0">
+                <a:latin typeface="나눔스퀘어 Bold" panose="020B0600000101010101" pitchFamily="50" charset="-127"/>
+                <a:ea typeface="나눔스퀘어 Bold" panose="020B0600000101010101" pitchFamily="50" charset="-127"/>
+              </a:rPr>
+              <a:t>Git</a:t>
+            </a:r>
+            <a:r>
+              <a:rPr lang="en-US" altLang="ko-KR" sz="2000" dirty="0" smtClean="0">
+                <a:latin typeface="나눔스퀘어 Bold" panose="020B0600000101010101" pitchFamily="50" charset="-127"/>
+                <a:ea typeface="나눔스퀘어 Bold" panose="020B0600000101010101" pitchFamily="50" charset="-127"/>
+              </a:rPr>
+              <a:t>, Build</a:t>
+            </a:r>
+            <a:endParaRPr lang="ko-KR" altLang="en-US" sz="2000" dirty="0">
+              <a:latin typeface="나눔스퀘어 Bold" panose="020B0600000101010101" pitchFamily="50" charset="-127"/>
+              <a:ea typeface="나눔스퀘어 Bold" panose="020B0600000101010101" pitchFamily="50" charset="-127"/>
+            </a:endParaRPr>
+          </a:p>
+        </p:txBody>
+      </p:sp>
+      <p:sp>
+        <p:nvSpPr>
+          <p:cNvPr id="5" name="직사각형 4"/>
+          <p:cNvSpPr/>
+          <p:nvPr/>
+        </p:nvSpPr>
+        <p:spPr>
+          <a:xfrm>
+            <a:off x="9492000" y="4434214"/>
+            <a:ext cx="2520000" cy="1080000"/>
+          </a:xfrm>
+          <a:prstGeom prst="rect">
+            <a:avLst/>
+          </a:prstGeom>
+          <a:solidFill>
+            <a:schemeClr val="accent5"/>
+          </a:solidFill>
+          <a:ln>
+            <a:solidFill>
+              <a:schemeClr val="tx1"/>
+            </a:solidFill>
+          </a:ln>
+        </p:spPr>
+        <p:style>
+          <a:lnRef idx="2">
+            <a:schemeClr val="accent1">
+              <a:shade val="50000"/>
+            </a:schemeClr>
+          </a:lnRef>
+          <a:fillRef idx="1">
+            <a:schemeClr val="accent1"/>
+          </a:fillRef>
+          <a:effectRef idx="0">
+            <a:schemeClr val="accent1"/>
+          </a:effectRef>
+          <a:fontRef idx="minor">
+            <a:schemeClr val="lt1"/>
+          </a:fontRef>
+        </p:style>
+        <p:txBody>
+          <a:bodyPr rtlCol="0" anchor="ctr"/>
+          <a:lstStyle/>
+          <a:p>
+            <a:pPr algn="ctr"/>
+            <a:r>
+              <a:rPr lang="en-US" altLang="ko-KR" sz="2400" dirty="0" smtClean="0">
+                <a:latin typeface="나눔스퀘어 Bold" panose="020B0600000101010101" pitchFamily="50" charset="-127"/>
+                <a:ea typeface="나눔스퀘어 Bold" panose="020B0600000101010101" pitchFamily="50" charset="-127"/>
+              </a:rPr>
+              <a:t>Product MySQL</a:t>
+            </a:r>
+            <a:endParaRPr lang="ko-KR" altLang="en-US" sz="2400" dirty="0">
+              <a:latin typeface="나눔스퀘어 Bold" panose="020B0600000101010101" pitchFamily="50" charset="-127"/>
+              <a:ea typeface="나눔스퀘어 Bold" panose="020B0600000101010101" pitchFamily="50" charset="-127"/>
+            </a:endParaRPr>
+          </a:p>
+        </p:txBody>
+      </p:sp>
+      <p:sp>
+        <p:nvSpPr>
+          <p:cNvPr id="6" name="직사각형 5"/>
+          <p:cNvSpPr/>
+          <p:nvPr/>
+        </p:nvSpPr>
+        <p:spPr>
+          <a:xfrm>
+            <a:off x="9312000" y="2217107"/>
+            <a:ext cx="2880000" cy="1440000"/>
+          </a:xfrm>
+          <a:prstGeom prst="rect">
+            <a:avLst/>
+          </a:prstGeom>
+          <a:solidFill>
+            <a:schemeClr val="accent5"/>
+          </a:solidFill>
+          <a:ln>
+            <a:solidFill>
+              <a:schemeClr val="tx1"/>
+            </a:solidFill>
+          </a:ln>
+        </p:spPr>
+        <p:style>
+          <a:lnRef idx="2">
+            <a:schemeClr val="accent1">
+              <a:shade val="50000"/>
+            </a:schemeClr>
+          </a:lnRef>
+          <a:fillRef idx="1">
+            <a:schemeClr val="accent1"/>
+          </a:fillRef>
+          <a:effectRef idx="0">
+            <a:schemeClr val="accent1"/>
+          </a:effectRef>
+          <a:fontRef idx="minor">
+            <a:schemeClr val="lt1"/>
+          </a:fontRef>
+        </p:style>
+        <p:txBody>
+          <a:bodyPr rtlCol="0" anchor="ctr"/>
+          <a:lstStyle/>
+          <a:p>
+            <a:pPr algn="ctr"/>
+            <a:r>
+              <a:rPr lang="en-US" altLang="ko-KR" sz="2000" dirty="0" smtClean="0">
+                <a:latin typeface="나눔스퀘어 Bold" panose="020B0600000101010101" pitchFamily="50" charset="-127"/>
+                <a:ea typeface="나눔스퀘어 Bold" panose="020B0600000101010101" pitchFamily="50" charset="-127"/>
+              </a:rPr>
+              <a:t>Product</a:t>
+            </a:r>
+            <a:r>
+              <a:rPr lang="en-US" altLang="ko-KR" sz="2000" dirty="0" smtClean="0">
+                <a:latin typeface="나눔스퀘어 Bold" panose="020B0600000101010101" pitchFamily="50" charset="-127"/>
+                <a:ea typeface="나눔스퀘어 Bold" panose="020B0600000101010101" pitchFamily="50" charset="-127"/>
+              </a:rPr>
+              <a:t> Server</a:t>
+            </a:r>
+          </a:p>
+          <a:p>
+            <a:pPr algn="ctr"/>
+            <a:r>
+              <a:rPr lang="en-US" altLang="ko-KR" sz="2000" dirty="0" err="1" smtClean="0">
+                <a:latin typeface="나눔스퀘어 Bold" panose="020B0600000101010101" pitchFamily="50" charset="-127"/>
+                <a:ea typeface="나눔스퀘어 Bold" panose="020B0600000101010101" pitchFamily="50" charset="-127"/>
+              </a:rPr>
+              <a:t>Gradle</a:t>
+            </a:r>
+            <a:r>
+              <a:rPr lang="en-US" altLang="ko-KR" sz="2000" dirty="0" smtClean="0">
+                <a:latin typeface="나눔스퀘어 Bold" panose="020B0600000101010101" pitchFamily="50" charset="-127"/>
+                <a:ea typeface="나눔스퀘어 Bold" panose="020B0600000101010101" pitchFamily="50" charset="-127"/>
+              </a:rPr>
+              <a:t>, JDK, </a:t>
+            </a:r>
+            <a:r>
+              <a:rPr lang="en-US" altLang="ko-KR" sz="2000" dirty="0" err="1" smtClean="0">
+                <a:latin typeface="나눔스퀘어 Bold" panose="020B0600000101010101" pitchFamily="50" charset="-127"/>
+                <a:ea typeface="나눔스퀘어 Bold" panose="020B0600000101010101" pitchFamily="50" charset="-127"/>
+              </a:rPr>
+              <a:t>Git</a:t>
+            </a:r>
+            <a:r>
+              <a:rPr lang="en-US" altLang="ko-KR" sz="2000" dirty="0" smtClean="0">
+                <a:latin typeface="나눔스퀘어 Bold" panose="020B0600000101010101" pitchFamily="50" charset="-127"/>
+                <a:ea typeface="나눔스퀘어 Bold" panose="020B0600000101010101" pitchFamily="50" charset="-127"/>
+              </a:rPr>
+              <a:t>, Build</a:t>
+            </a:r>
+            <a:endParaRPr lang="ko-KR" altLang="en-US" sz="2000" dirty="0" smtClean="0">
+              <a:latin typeface="나눔스퀘어 Bold" panose="020B0600000101010101" pitchFamily="50" charset="-127"/>
+              <a:ea typeface="나눔스퀘어 Bold" panose="020B0600000101010101" pitchFamily="50" charset="-127"/>
+            </a:endParaRPr>
+          </a:p>
+        </p:txBody>
+      </p:sp>
+      <p:sp>
+        <p:nvSpPr>
+          <p:cNvPr id="11" name="직사각형 10"/>
+          <p:cNvSpPr/>
+          <p:nvPr/>
+        </p:nvSpPr>
+        <p:spPr>
+          <a:xfrm>
+            <a:off x="4836000" y="4434214"/>
+            <a:ext cx="2520000" cy="1080000"/>
+          </a:xfrm>
+          <a:prstGeom prst="rect">
+            <a:avLst/>
+          </a:prstGeom>
+          <a:solidFill>
+            <a:schemeClr val="accent5"/>
+          </a:solidFill>
+          <a:ln>
+            <a:solidFill>
+              <a:schemeClr val="tx1"/>
+            </a:solidFill>
+          </a:ln>
+        </p:spPr>
+        <p:style>
+          <a:lnRef idx="2">
+            <a:schemeClr val="accent1">
+              <a:shade val="50000"/>
+            </a:schemeClr>
+          </a:lnRef>
+          <a:fillRef idx="1">
+            <a:schemeClr val="accent1"/>
+          </a:fillRef>
+          <a:effectRef idx="0">
+            <a:schemeClr val="accent1"/>
+          </a:effectRef>
+          <a:fontRef idx="minor">
+            <a:schemeClr val="lt1"/>
+          </a:fontRef>
+        </p:style>
+        <p:txBody>
+          <a:bodyPr rtlCol="0" anchor="ctr"/>
+          <a:lstStyle/>
+          <a:p>
+            <a:pPr algn="ctr"/>
+            <a:r>
+              <a:rPr lang="en-US" altLang="ko-KR" sz="2400" dirty="0" smtClean="0">
+                <a:latin typeface="나눔스퀘어 Bold" panose="020B0600000101010101" pitchFamily="50" charset="-127"/>
+                <a:ea typeface="나눔스퀘어 Bold" panose="020B0600000101010101" pitchFamily="50" charset="-127"/>
+              </a:rPr>
+              <a:t>Dev MySQL</a:t>
+            </a:r>
+            <a:endParaRPr lang="ko-KR" altLang="en-US" sz="2400" dirty="0">
+              <a:latin typeface="나눔스퀘어 Bold" panose="020B0600000101010101" pitchFamily="50" charset="-127"/>
+              <a:ea typeface="나눔스퀘어 Bold" panose="020B0600000101010101" pitchFamily="50" charset="-127"/>
+            </a:endParaRPr>
+          </a:p>
+        </p:txBody>
+      </p:sp>
+      <p:cxnSp>
+        <p:nvCxnSpPr>
+          <p:cNvPr id="23" name="꺾인 연결선 22"/>
+          <p:cNvCxnSpPr>
+            <a:stCxn id="4" idx="3"/>
+            <a:endCxn id="13" idx="1"/>
+          </p:cNvCxnSpPr>
+          <p:nvPr/>
+        </p:nvCxnSpPr>
+        <p:spPr>
+          <a:xfrm flipH="1" flipV="1">
+            <a:off x="7163999" y="540000"/>
+            <a:ext cx="372001" cy="2397107"/>
+          </a:xfrm>
+          <a:prstGeom prst="bentConnector5">
+            <a:avLst>
+              <a:gd name="adj1" fmla="val -142264"/>
+              <a:gd name="adj2" fmla="val 53755"/>
+              <a:gd name="adj3" fmla="val 238896"/>
+            </a:avLst>
+          </a:prstGeom>
+          <a:ln w="76200">
+            <a:solidFill>
+              <a:schemeClr val="accent2"/>
+            </a:solidFill>
+            <a:tailEnd type="triangle"/>
+          </a:ln>
+        </p:spPr>
+        <p:style>
+          <a:lnRef idx="1">
+            <a:schemeClr val="accent1"/>
+          </a:lnRef>
+          <a:fillRef idx="0">
+            <a:schemeClr val="accent1"/>
+          </a:fillRef>
+          <a:effectRef idx="0">
+            <a:schemeClr val="accent1"/>
+          </a:effectRef>
+          <a:fontRef idx="minor">
+            <a:schemeClr val="tx1"/>
+          </a:fontRef>
+        </p:style>
+      </p:cxnSp>
+      <p:sp>
+        <p:nvSpPr>
+          <p:cNvPr id="3" name="직사각형 2"/>
+          <p:cNvSpPr/>
+          <p:nvPr/>
+        </p:nvSpPr>
+        <p:spPr>
+          <a:xfrm>
+            <a:off x="2507999" y="0"/>
+            <a:ext cx="2520000" cy="1080000"/>
+          </a:xfrm>
+          <a:prstGeom prst="rect">
+            <a:avLst/>
+          </a:prstGeom>
+          <a:solidFill>
+            <a:schemeClr val="accent5"/>
+          </a:solidFill>
+          <a:ln>
+            <a:solidFill>
+              <a:schemeClr val="tx1"/>
+            </a:solidFill>
+          </a:ln>
+        </p:spPr>
+        <p:style>
+          <a:lnRef idx="2">
+            <a:schemeClr val="accent1">
+              <a:shade val="50000"/>
+            </a:schemeClr>
+          </a:lnRef>
+          <a:fillRef idx="1">
+            <a:schemeClr val="accent1"/>
+          </a:fillRef>
+          <a:effectRef idx="0">
+            <a:schemeClr val="accent1"/>
+          </a:effectRef>
+          <a:fontRef idx="minor">
+            <a:schemeClr val="lt1"/>
+          </a:fontRef>
+        </p:style>
+        <p:txBody>
+          <a:bodyPr rtlCol="0" anchor="ctr"/>
+          <a:lstStyle/>
+          <a:p>
+            <a:pPr algn="ctr"/>
+            <a:r>
+              <a:rPr lang="en-US" altLang="ko-KR" sz="2400" dirty="0" smtClean="0">
+                <a:latin typeface="나눔스퀘어 Bold" panose="020B0600000101010101" pitchFamily="50" charset="-127"/>
+                <a:ea typeface="나눔스퀘어 Bold" panose="020B0600000101010101" pitchFamily="50" charset="-127"/>
+              </a:rPr>
+              <a:t>GitHub</a:t>
+            </a:r>
+            <a:endParaRPr lang="ko-KR" altLang="en-US" sz="2400" dirty="0">
+              <a:latin typeface="나눔스퀘어 Bold" panose="020B0600000101010101" pitchFamily="50" charset="-127"/>
+              <a:ea typeface="나눔스퀘어 Bold" panose="020B0600000101010101" pitchFamily="50" charset="-127"/>
+            </a:endParaRPr>
+          </a:p>
+        </p:txBody>
+      </p:sp>
+      <p:sp>
+        <p:nvSpPr>
+          <p:cNvPr id="13" name="직사각형 12"/>
+          <p:cNvSpPr/>
+          <p:nvPr/>
+        </p:nvSpPr>
+        <p:spPr>
+          <a:xfrm>
+            <a:off x="7163999" y="0"/>
+            <a:ext cx="2520000" cy="1080000"/>
+          </a:xfrm>
+          <a:prstGeom prst="rect">
+            <a:avLst/>
+          </a:prstGeom>
+          <a:solidFill>
+            <a:schemeClr val="accent5"/>
+          </a:solidFill>
+          <a:ln>
+            <a:solidFill>
+              <a:schemeClr val="tx1"/>
+            </a:solidFill>
+          </a:ln>
+        </p:spPr>
+        <p:style>
+          <a:lnRef idx="2">
+            <a:schemeClr val="accent1">
+              <a:shade val="50000"/>
+            </a:schemeClr>
+          </a:lnRef>
+          <a:fillRef idx="1">
+            <a:schemeClr val="accent1"/>
+          </a:fillRef>
+          <a:effectRef idx="0">
+            <a:schemeClr val="accent1"/>
+          </a:effectRef>
+          <a:fontRef idx="minor">
+            <a:schemeClr val="lt1"/>
+          </a:fontRef>
+        </p:style>
+        <p:txBody>
+          <a:bodyPr rtlCol="0" anchor="ctr"/>
+          <a:lstStyle/>
+          <a:p>
+            <a:pPr algn="ctr"/>
+            <a:r>
+              <a:rPr lang="en-US" altLang="ko-KR" sz="2400" dirty="0" err="1" smtClean="0">
+                <a:latin typeface="나눔스퀘어 Bold" panose="020B0600000101010101" pitchFamily="50" charset="-127"/>
+                <a:ea typeface="나눔스퀘어 Bold" panose="020B0600000101010101" pitchFamily="50" charset="-127"/>
+              </a:rPr>
+              <a:t>DockerHub</a:t>
+            </a:r>
+            <a:endParaRPr lang="ko-KR" altLang="en-US" sz="2400" dirty="0">
+              <a:latin typeface="나눔스퀘어 Bold" panose="020B0600000101010101" pitchFamily="50" charset="-127"/>
+              <a:ea typeface="나눔스퀘어 Bold" panose="020B0600000101010101" pitchFamily="50" charset="-127"/>
+            </a:endParaRPr>
+          </a:p>
+        </p:txBody>
+      </p:sp>
+      <p:sp>
+        <p:nvSpPr>
+          <p:cNvPr id="25" name="직사각형 24"/>
+          <p:cNvSpPr/>
+          <p:nvPr/>
+        </p:nvSpPr>
+        <p:spPr>
+          <a:xfrm>
+            <a:off x="180000" y="4434214"/>
+            <a:ext cx="2520000" cy="1080000"/>
+          </a:xfrm>
+          <a:prstGeom prst="rect">
+            <a:avLst/>
+          </a:prstGeom>
+          <a:solidFill>
+            <a:schemeClr val="accent5"/>
+          </a:solidFill>
+          <a:ln>
+            <a:solidFill>
+              <a:schemeClr val="tx1"/>
+            </a:solidFill>
+          </a:ln>
+        </p:spPr>
+        <p:style>
+          <a:lnRef idx="2">
+            <a:schemeClr val="accent1">
+              <a:shade val="50000"/>
+            </a:schemeClr>
+          </a:lnRef>
+          <a:fillRef idx="1">
+            <a:schemeClr val="accent1"/>
+          </a:fillRef>
+          <a:effectRef idx="0">
+            <a:schemeClr val="accent1"/>
+          </a:effectRef>
+          <a:fontRef idx="minor">
+            <a:schemeClr val="lt1"/>
+          </a:fontRef>
+        </p:style>
+        <p:txBody>
+          <a:bodyPr rtlCol="0" anchor="ctr"/>
+          <a:lstStyle/>
+          <a:p>
+            <a:pPr algn="ctr"/>
+            <a:r>
+              <a:rPr lang="ko-KR" altLang="en-US" sz="2400" dirty="0" smtClean="0">
+                <a:latin typeface="나눔스퀘어 Bold" panose="020B0600000101010101" pitchFamily="50" charset="-127"/>
+                <a:ea typeface="나눔스퀘어 Bold" panose="020B0600000101010101" pitchFamily="50" charset="-127"/>
+              </a:rPr>
+              <a:t>개발</a:t>
+            </a:r>
+            <a:r>
+              <a:rPr lang="en-US" altLang="ko-KR" sz="2400" dirty="0" smtClean="0">
+                <a:latin typeface="나눔스퀘어 Bold" panose="020B0600000101010101" pitchFamily="50" charset="-127"/>
+                <a:ea typeface="나눔스퀘어 Bold" panose="020B0600000101010101" pitchFamily="50" charset="-127"/>
+              </a:rPr>
+              <a:t> MySQL</a:t>
+            </a:r>
+            <a:endParaRPr lang="ko-KR" altLang="en-US" sz="2400" dirty="0">
+              <a:latin typeface="나눔스퀘어 Bold" panose="020B0600000101010101" pitchFamily="50" charset="-127"/>
+              <a:ea typeface="나눔스퀘어 Bold" panose="020B0600000101010101" pitchFamily="50" charset="-127"/>
+            </a:endParaRPr>
+          </a:p>
+        </p:txBody>
+      </p:sp>
+      <p:sp>
+        <p:nvSpPr>
+          <p:cNvPr id="26" name="TextBox 25"/>
+          <p:cNvSpPr txBox="1"/>
+          <p:nvPr/>
+        </p:nvSpPr>
+        <p:spPr>
+          <a:xfrm>
+            <a:off x="5021340" y="3676328"/>
+            <a:ext cx="1999265" cy="369332"/>
+          </a:xfrm>
+          <a:prstGeom prst="rect">
+            <a:avLst/>
+          </a:prstGeom>
+          <a:noFill/>
+        </p:spPr>
+        <p:txBody>
+          <a:bodyPr wrap="none" rtlCol="0">
+            <a:spAutoFit/>
+          </a:bodyPr>
+          <a:lstStyle/>
+          <a:p>
+            <a:r>
+              <a:rPr lang="ko-KR" altLang="en-US" dirty="0" smtClean="0">
+                <a:latin typeface="나눔스퀘어 Bold" panose="020B0600000101010101" pitchFamily="50" charset="-127"/>
+                <a:ea typeface="나눔스퀘어 Bold" panose="020B0600000101010101" pitchFamily="50" charset="-127"/>
+              </a:rPr>
+              <a:t>개발팀 </a:t>
+            </a:r>
+            <a:r>
+              <a:rPr lang="en-US" altLang="ko-KR" dirty="0" smtClean="0">
+                <a:latin typeface="나눔스퀘어 Bold" panose="020B0600000101010101" pitchFamily="50" charset="-127"/>
+                <a:ea typeface="나눔스퀘어 Bold" panose="020B0600000101010101" pitchFamily="50" charset="-127"/>
+              </a:rPr>
+              <a:t>-&gt; QA(QM)</a:t>
+            </a:r>
+            <a:endParaRPr lang="ko-KR" altLang="en-US" dirty="0">
+              <a:latin typeface="나눔스퀘어 Bold" panose="020B0600000101010101" pitchFamily="50" charset="-127"/>
+              <a:ea typeface="나눔스퀘어 Bold" panose="020B0600000101010101" pitchFamily="50" charset="-127"/>
+            </a:endParaRPr>
+          </a:p>
+        </p:txBody>
+      </p:sp>
+      <p:sp>
+        <p:nvSpPr>
+          <p:cNvPr id="27" name="직사각형 26"/>
+          <p:cNvSpPr/>
+          <p:nvPr/>
+        </p:nvSpPr>
+        <p:spPr>
+          <a:xfrm>
+            <a:off x="6804000" y="1378553"/>
+            <a:ext cx="2160000" cy="540000"/>
+          </a:xfrm>
+          <a:prstGeom prst="rect">
+            <a:avLst/>
+          </a:prstGeom>
+          <a:solidFill>
+            <a:schemeClr val="accent4"/>
+          </a:solidFill>
+          <a:ln>
+            <a:solidFill>
+              <a:schemeClr val="tx1"/>
+            </a:solidFill>
+          </a:ln>
+        </p:spPr>
+        <p:style>
+          <a:lnRef idx="2">
+            <a:schemeClr val="accent1">
+              <a:shade val="50000"/>
+            </a:schemeClr>
+          </a:lnRef>
+          <a:fillRef idx="1">
+            <a:schemeClr val="accent1"/>
+          </a:fillRef>
+          <a:effectRef idx="0">
+            <a:schemeClr val="accent1"/>
+          </a:effectRef>
+          <a:fontRef idx="minor">
+            <a:schemeClr val="lt1"/>
+          </a:fontRef>
+        </p:style>
+        <p:txBody>
+          <a:bodyPr rtlCol="0" anchor="ctr"/>
+          <a:lstStyle/>
+          <a:p>
+            <a:pPr algn="ctr"/>
+            <a:r>
+              <a:rPr lang="en-US" altLang="ko-KR" dirty="0" smtClean="0">
+                <a:solidFill>
+                  <a:schemeClr val="tx1"/>
+                </a:solidFill>
+                <a:latin typeface="나눔스퀘어 Bold" panose="020B0600000101010101" pitchFamily="50" charset="-127"/>
+                <a:ea typeface="나눔스퀘어 Bold" panose="020B0600000101010101" pitchFamily="50" charset="-127"/>
+              </a:rPr>
+              <a:t>Docker Image(Jar)</a:t>
+            </a:r>
+            <a:endParaRPr lang="ko-KR" altLang="en-US" dirty="0">
+              <a:solidFill>
+                <a:schemeClr val="tx1"/>
+              </a:solidFill>
+              <a:latin typeface="나눔스퀘어 Bold" panose="020B0600000101010101" pitchFamily="50" charset="-127"/>
+              <a:ea typeface="나눔스퀘어 Bold" panose="020B0600000101010101" pitchFamily="50" charset="-127"/>
+            </a:endParaRPr>
+          </a:p>
+        </p:txBody>
+      </p:sp>
+      <p:cxnSp>
+        <p:nvCxnSpPr>
+          <p:cNvPr id="32" name="꺾인 연결선 31"/>
+          <p:cNvCxnSpPr>
+            <a:stCxn id="13" idx="3"/>
+            <a:endCxn id="6" idx="0"/>
+          </p:cNvCxnSpPr>
+          <p:nvPr/>
+        </p:nvCxnSpPr>
+        <p:spPr>
+          <a:xfrm>
+            <a:off x="9683999" y="540000"/>
+            <a:ext cx="1068001" cy="1677107"/>
+          </a:xfrm>
+          <a:prstGeom prst="bentConnector2">
+            <a:avLst/>
+          </a:prstGeom>
+          <a:ln w="76200">
+            <a:solidFill>
+              <a:schemeClr val="accent2"/>
+            </a:solidFill>
+            <a:tailEnd type="triangle"/>
+          </a:ln>
+        </p:spPr>
+        <p:style>
+          <a:lnRef idx="1">
+            <a:schemeClr val="accent1"/>
+          </a:lnRef>
+          <a:fillRef idx="0">
+            <a:schemeClr val="accent1"/>
+          </a:fillRef>
+          <a:effectRef idx="0">
+            <a:schemeClr val="accent1"/>
+          </a:effectRef>
+          <a:fontRef idx="minor">
+            <a:schemeClr val="tx1"/>
+          </a:fontRef>
+        </p:style>
+      </p:cxnSp>
+      <p:cxnSp>
+        <p:nvCxnSpPr>
+          <p:cNvPr id="35" name="꺾인 연결선 34"/>
+          <p:cNvCxnSpPr>
+            <a:stCxn id="2" idx="0"/>
+            <a:endCxn id="3" idx="1"/>
+          </p:cNvCxnSpPr>
+          <p:nvPr/>
+        </p:nvCxnSpPr>
+        <p:spPr>
+          <a:xfrm rot="5400000" flipH="1" flipV="1">
+            <a:off x="1135446" y="844555"/>
+            <a:ext cx="1677107" cy="1067999"/>
+          </a:xfrm>
+          <a:prstGeom prst="bentConnector2">
+            <a:avLst/>
+          </a:prstGeom>
+          <a:ln w="76200">
+            <a:solidFill>
+              <a:schemeClr val="accent2"/>
+            </a:solidFill>
+            <a:tailEnd type="triangle"/>
+          </a:ln>
+        </p:spPr>
+        <p:style>
+          <a:lnRef idx="1">
+            <a:schemeClr val="accent1"/>
+          </a:lnRef>
+          <a:fillRef idx="0">
+            <a:schemeClr val="accent1"/>
+          </a:fillRef>
+          <a:effectRef idx="0">
+            <a:schemeClr val="accent1"/>
+          </a:effectRef>
+          <a:fontRef idx="minor">
+            <a:schemeClr val="tx1"/>
+          </a:fontRef>
+        </p:style>
+      </p:cxnSp>
+      <p:cxnSp>
+        <p:nvCxnSpPr>
+          <p:cNvPr id="38" name="꺾인 연결선 37"/>
+          <p:cNvCxnSpPr>
+            <a:stCxn id="3" idx="3"/>
+            <a:endCxn id="4" idx="0"/>
+          </p:cNvCxnSpPr>
+          <p:nvPr/>
+        </p:nvCxnSpPr>
+        <p:spPr>
+          <a:xfrm>
+            <a:off x="5027999" y="540000"/>
+            <a:ext cx="1068001" cy="1677107"/>
+          </a:xfrm>
+          <a:prstGeom prst="bentConnector2">
+            <a:avLst/>
+          </a:prstGeom>
+          <a:ln w="76200">
+            <a:solidFill>
+              <a:schemeClr val="accent2"/>
+            </a:solidFill>
+            <a:tailEnd type="triangle"/>
+          </a:ln>
+        </p:spPr>
+        <p:style>
+          <a:lnRef idx="1">
+            <a:schemeClr val="accent1"/>
+          </a:lnRef>
+          <a:fillRef idx="0">
+            <a:schemeClr val="accent1"/>
+          </a:fillRef>
+          <a:effectRef idx="0">
+            <a:schemeClr val="accent1"/>
+          </a:effectRef>
+          <a:fontRef idx="minor">
+            <a:schemeClr val="tx1"/>
+          </a:fontRef>
+        </p:style>
+      </p:cxnSp>
+      <p:sp>
+        <p:nvSpPr>
+          <p:cNvPr id="41" name="직사각형 40"/>
+          <p:cNvSpPr/>
+          <p:nvPr/>
+        </p:nvSpPr>
+        <p:spPr>
+          <a:xfrm>
+            <a:off x="9672000" y="3423551"/>
+            <a:ext cx="2160000" cy="540000"/>
+          </a:xfrm>
+          <a:prstGeom prst="rect">
+            <a:avLst/>
+          </a:prstGeom>
+          <a:solidFill>
+            <a:schemeClr val="accent4"/>
+          </a:solidFill>
+          <a:ln>
+            <a:solidFill>
+              <a:schemeClr val="tx1"/>
+            </a:solidFill>
+          </a:ln>
+        </p:spPr>
+        <p:style>
+          <a:lnRef idx="2">
+            <a:schemeClr val="accent1">
+              <a:shade val="50000"/>
+            </a:schemeClr>
+          </a:lnRef>
+          <a:fillRef idx="1">
+            <a:schemeClr val="accent1"/>
+          </a:fillRef>
+          <a:effectRef idx="0">
+            <a:schemeClr val="accent1"/>
+          </a:effectRef>
+          <a:fontRef idx="minor">
+            <a:schemeClr val="lt1"/>
+          </a:fontRef>
+        </p:style>
+        <p:txBody>
+          <a:bodyPr rtlCol="0" anchor="ctr"/>
+          <a:lstStyle/>
+          <a:p>
+            <a:pPr algn="ctr"/>
+            <a:r>
+              <a:rPr lang="en-US" altLang="ko-KR" dirty="0" smtClean="0">
+                <a:solidFill>
+                  <a:schemeClr val="tx1"/>
+                </a:solidFill>
+                <a:latin typeface="나눔스퀘어 Bold" panose="020B0600000101010101" pitchFamily="50" charset="-127"/>
+                <a:ea typeface="나눔스퀘어 Bold" panose="020B0600000101010101" pitchFamily="50" charset="-127"/>
+              </a:rPr>
+              <a:t>Docker Image(Jar)</a:t>
+            </a:r>
+            <a:endParaRPr lang="ko-KR" altLang="en-US" dirty="0">
+              <a:solidFill>
+                <a:schemeClr val="tx1"/>
+              </a:solidFill>
+              <a:latin typeface="나눔스퀘어 Bold" panose="020B0600000101010101" pitchFamily="50" charset="-127"/>
+              <a:ea typeface="나눔스퀘어 Bold" panose="020B0600000101010101" pitchFamily="50" charset="-127"/>
+            </a:endParaRPr>
+          </a:p>
+        </p:txBody>
+      </p:sp>
+      <p:sp>
+        <p:nvSpPr>
+          <p:cNvPr id="42" name="직사각형 41"/>
+          <p:cNvSpPr/>
+          <p:nvPr/>
+        </p:nvSpPr>
+        <p:spPr>
+          <a:xfrm>
+            <a:off x="123372" y="2354993"/>
+            <a:ext cx="2880000" cy="1440000"/>
+          </a:xfrm>
+          <a:prstGeom prst="rect">
+            <a:avLst/>
+          </a:prstGeom>
+          <a:solidFill>
+            <a:schemeClr val="accent5"/>
+          </a:solidFill>
+          <a:ln>
+            <a:solidFill>
+              <a:schemeClr val="tx1"/>
+            </a:solidFill>
+          </a:ln>
+        </p:spPr>
+        <p:style>
+          <a:lnRef idx="2">
+            <a:schemeClr val="accent1">
+              <a:shade val="50000"/>
+            </a:schemeClr>
+          </a:lnRef>
+          <a:fillRef idx="1">
+            <a:schemeClr val="accent1"/>
+          </a:fillRef>
+          <a:effectRef idx="0">
+            <a:schemeClr val="accent1"/>
+          </a:effectRef>
+          <a:fontRef idx="minor">
+            <a:schemeClr val="lt1"/>
+          </a:fontRef>
+        </p:style>
+        <p:txBody>
+          <a:bodyPr rtlCol="0" anchor="ctr"/>
+          <a:lstStyle/>
+          <a:p>
+            <a:pPr algn="ctr"/>
+            <a:r>
+              <a:rPr lang="ko-KR" altLang="en-US" sz="2400" dirty="0" smtClean="0">
+                <a:latin typeface="나눔스퀘어 Bold" panose="020B0600000101010101" pitchFamily="50" charset="-127"/>
+                <a:ea typeface="나눔스퀘어 Bold" panose="020B0600000101010101" pitchFamily="50" charset="-127"/>
+              </a:rPr>
+              <a:t>개발</a:t>
+            </a:r>
+            <a:r>
+              <a:rPr lang="en-US" altLang="ko-KR" sz="2400" dirty="0" smtClean="0">
+                <a:latin typeface="나눔스퀘어 Bold" panose="020B0600000101010101" pitchFamily="50" charset="-127"/>
+                <a:ea typeface="나눔스퀘어 Bold" panose="020B0600000101010101" pitchFamily="50" charset="-127"/>
+              </a:rPr>
+              <a:t>PC(Local)</a:t>
+            </a:r>
+          </a:p>
+          <a:p>
+            <a:pPr algn="ctr"/>
+            <a:r>
+              <a:rPr lang="en-US" altLang="ko-KR" sz="2400" dirty="0" smtClean="0">
+                <a:latin typeface="나눔스퀘어 Bold" panose="020B0600000101010101" pitchFamily="50" charset="-127"/>
+                <a:ea typeface="나눔스퀘어 Bold" panose="020B0600000101010101" pitchFamily="50" charset="-127"/>
+              </a:rPr>
+              <a:t>JDK, </a:t>
+            </a:r>
+            <a:r>
+              <a:rPr lang="en-US" altLang="ko-KR" sz="2400" dirty="0" err="1" smtClean="0">
+                <a:latin typeface="나눔스퀘어 Bold" panose="020B0600000101010101" pitchFamily="50" charset="-127"/>
+                <a:ea typeface="나눔스퀘어 Bold" panose="020B0600000101010101" pitchFamily="50" charset="-127"/>
+              </a:rPr>
+              <a:t>Git</a:t>
+            </a:r>
+            <a:r>
+              <a:rPr lang="en-US" altLang="ko-KR" sz="2400" dirty="0" smtClean="0">
+                <a:latin typeface="나눔스퀘어 Bold" panose="020B0600000101010101" pitchFamily="50" charset="-127"/>
+                <a:ea typeface="나눔스퀘어 Bold" panose="020B0600000101010101" pitchFamily="50" charset="-127"/>
+              </a:rPr>
+              <a:t>, MySQL</a:t>
+            </a:r>
+            <a:endParaRPr lang="ko-KR" altLang="en-US" sz="2400" dirty="0">
+              <a:latin typeface="나눔스퀘어 Bold" panose="020B0600000101010101" pitchFamily="50" charset="-127"/>
+              <a:ea typeface="나눔스퀘어 Bold" panose="020B0600000101010101" pitchFamily="50" charset="-127"/>
+            </a:endParaRPr>
+          </a:p>
+        </p:txBody>
+      </p:sp>
+      <p:sp>
+        <p:nvSpPr>
+          <p:cNvPr id="43" name="직사각형 42"/>
+          <p:cNvSpPr/>
+          <p:nvPr/>
+        </p:nvSpPr>
+        <p:spPr>
+          <a:xfrm>
+            <a:off x="290286" y="2492879"/>
+            <a:ext cx="2880000" cy="1440000"/>
+          </a:xfrm>
+          <a:prstGeom prst="rect">
+            <a:avLst/>
+          </a:prstGeom>
+          <a:solidFill>
+            <a:schemeClr val="accent5"/>
+          </a:solidFill>
+          <a:ln>
+            <a:solidFill>
+              <a:schemeClr val="tx1"/>
+            </a:solidFill>
+          </a:ln>
+        </p:spPr>
+        <p:style>
+          <a:lnRef idx="2">
+            <a:schemeClr val="accent1">
+              <a:shade val="50000"/>
+            </a:schemeClr>
+          </a:lnRef>
+          <a:fillRef idx="1">
+            <a:schemeClr val="accent1"/>
+          </a:fillRef>
+          <a:effectRef idx="0">
+            <a:schemeClr val="accent1"/>
+          </a:effectRef>
+          <a:fontRef idx="minor">
+            <a:schemeClr val="lt1"/>
+          </a:fontRef>
+        </p:style>
+        <p:txBody>
+          <a:bodyPr rtlCol="0" anchor="ctr"/>
+          <a:lstStyle/>
+          <a:p>
+            <a:pPr algn="ctr"/>
+            <a:r>
+              <a:rPr lang="ko-KR" altLang="en-US" sz="2400" dirty="0" smtClean="0">
+                <a:latin typeface="나눔스퀘어 Bold" panose="020B0600000101010101" pitchFamily="50" charset="-127"/>
+                <a:ea typeface="나눔스퀘어 Bold" panose="020B0600000101010101" pitchFamily="50" charset="-127"/>
+              </a:rPr>
+              <a:t>개발</a:t>
+            </a:r>
+            <a:r>
+              <a:rPr lang="en-US" altLang="ko-KR" sz="2400" dirty="0" smtClean="0">
+                <a:latin typeface="나눔스퀘어 Bold" panose="020B0600000101010101" pitchFamily="50" charset="-127"/>
+                <a:ea typeface="나눔스퀘어 Bold" panose="020B0600000101010101" pitchFamily="50" charset="-127"/>
+              </a:rPr>
+              <a:t>PC(Local)</a:t>
+            </a:r>
+          </a:p>
+          <a:p>
+            <a:pPr algn="ctr"/>
+            <a:r>
+              <a:rPr lang="en-US" altLang="ko-KR" sz="2400" dirty="0" smtClean="0">
+                <a:latin typeface="나눔스퀘어 Bold" panose="020B0600000101010101" pitchFamily="50" charset="-127"/>
+                <a:ea typeface="나눔스퀘어 Bold" panose="020B0600000101010101" pitchFamily="50" charset="-127"/>
+              </a:rPr>
+              <a:t>JDK, </a:t>
+            </a:r>
+            <a:r>
+              <a:rPr lang="en-US" altLang="ko-KR" sz="2400" dirty="0" err="1" smtClean="0">
+                <a:latin typeface="나눔스퀘어 Bold" panose="020B0600000101010101" pitchFamily="50" charset="-127"/>
+                <a:ea typeface="나눔스퀘어 Bold" panose="020B0600000101010101" pitchFamily="50" charset="-127"/>
+              </a:rPr>
+              <a:t>Git</a:t>
+            </a:r>
+            <a:r>
+              <a:rPr lang="en-US" altLang="ko-KR" sz="2400" dirty="0" smtClean="0">
+                <a:latin typeface="나눔스퀘어 Bold" panose="020B0600000101010101" pitchFamily="50" charset="-127"/>
+                <a:ea typeface="나눔스퀘어 Bold" panose="020B0600000101010101" pitchFamily="50" charset="-127"/>
+              </a:rPr>
+              <a:t>, MySQL</a:t>
+            </a:r>
+            <a:endParaRPr lang="ko-KR" altLang="en-US" sz="2400" dirty="0">
+              <a:latin typeface="나눔스퀘어 Bold" panose="020B0600000101010101" pitchFamily="50" charset="-127"/>
+              <a:ea typeface="나눔스퀘어 Bold" panose="020B0600000101010101" pitchFamily="50" charset="-127"/>
+            </a:endParaRPr>
+          </a:p>
+        </p:txBody>
+      </p:sp>
+      <p:sp>
+        <p:nvSpPr>
+          <p:cNvPr id="44" name="직사각형 43"/>
+          <p:cNvSpPr/>
+          <p:nvPr/>
+        </p:nvSpPr>
+        <p:spPr>
+          <a:xfrm>
+            <a:off x="9780858" y="3546923"/>
+            <a:ext cx="2160000" cy="540000"/>
+          </a:xfrm>
+          <a:prstGeom prst="rect">
+            <a:avLst/>
+          </a:prstGeom>
+          <a:solidFill>
+            <a:schemeClr val="accent4"/>
+          </a:solidFill>
+          <a:ln>
+            <a:solidFill>
+              <a:schemeClr val="tx1"/>
+            </a:solidFill>
+          </a:ln>
+        </p:spPr>
+        <p:style>
+          <a:lnRef idx="2">
+            <a:schemeClr val="accent1">
+              <a:shade val="50000"/>
+            </a:schemeClr>
+          </a:lnRef>
+          <a:fillRef idx="1">
+            <a:schemeClr val="accent1"/>
+          </a:fillRef>
+          <a:effectRef idx="0">
+            <a:schemeClr val="accent1"/>
+          </a:effectRef>
+          <a:fontRef idx="minor">
+            <a:schemeClr val="lt1"/>
+          </a:fontRef>
+        </p:style>
+        <p:txBody>
+          <a:bodyPr rtlCol="0" anchor="ctr"/>
+          <a:lstStyle/>
+          <a:p>
+            <a:pPr algn="ctr"/>
+            <a:r>
+              <a:rPr lang="en-US" altLang="ko-KR" dirty="0" smtClean="0">
+                <a:solidFill>
+                  <a:schemeClr val="tx1"/>
+                </a:solidFill>
+                <a:latin typeface="나눔스퀘어 Bold" panose="020B0600000101010101" pitchFamily="50" charset="-127"/>
+                <a:ea typeface="나눔스퀘어 Bold" panose="020B0600000101010101" pitchFamily="50" charset="-127"/>
+              </a:rPr>
+              <a:t>Docker Image(Jar)</a:t>
+            </a:r>
+            <a:endParaRPr lang="ko-KR" altLang="en-US" dirty="0">
+              <a:solidFill>
+                <a:schemeClr val="tx1"/>
+              </a:solidFill>
+              <a:latin typeface="나눔스퀘어 Bold" panose="020B0600000101010101" pitchFamily="50" charset="-127"/>
+              <a:ea typeface="나눔스퀘어 Bold" panose="020B0600000101010101" pitchFamily="50" charset="-127"/>
+            </a:endParaRPr>
+          </a:p>
+        </p:txBody>
+      </p:sp>
+      <p:sp>
+        <p:nvSpPr>
+          <p:cNvPr id="45" name="직사각형 44"/>
+          <p:cNvSpPr/>
+          <p:nvPr/>
+        </p:nvSpPr>
+        <p:spPr>
+          <a:xfrm>
+            <a:off x="9904230" y="3670295"/>
+            <a:ext cx="2160000" cy="540000"/>
+          </a:xfrm>
+          <a:prstGeom prst="rect">
+            <a:avLst/>
+          </a:prstGeom>
+          <a:solidFill>
+            <a:schemeClr val="accent4"/>
+          </a:solidFill>
+          <a:ln>
+            <a:solidFill>
+              <a:schemeClr val="tx1"/>
+            </a:solidFill>
+          </a:ln>
+        </p:spPr>
+        <p:style>
+          <a:lnRef idx="2">
+            <a:schemeClr val="accent1">
+              <a:shade val="50000"/>
+            </a:schemeClr>
+          </a:lnRef>
+          <a:fillRef idx="1">
+            <a:schemeClr val="accent1"/>
+          </a:fillRef>
+          <a:effectRef idx="0">
+            <a:schemeClr val="accent1"/>
+          </a:effectRef>
+          <a:fontRef idx="minor">
+            <a:schemeClr val="lt1"/>
+          </a:fontRef>
+        </p:style>
+        <p:txBody>
+          <a:bodyPr rtlCol="0" anchor="ctr"/>
+          <a:lstStyle/>
+          <a:p>
+            <a:pPr algn="ctr"/>
+            <a:r>
+              <a:rPr lang="en-US" altLang="ko-KR" dirty="0" smtClean="0">
+                <a:solidFill>
+                  <a:schemeClr val="tx1"/>
+                </a:solidFill>
+                <a:latin typeface="나눔스퀘어 Bold" panose="020B0600000101010101" pitchFamily="50" charset="-127"/>
+                <a:ea typeface="나눔스퀘어 Bold" panose="020B0600000101010101" pitchFamily="50" charset="-127"/>
+              </a:rPr>
+              <a:t>Docker Image(Jar)</a:t>
+            </a:r>
+            <a:endParaRPr lang="ko-KR" altLang="en-US" dirty="0">
+              <a:solidFill>
+                <a:schemeClr val="tx1"/>
+              </a:solidFill>
+              <a:latin typeface="나눔스퀘어 Bold" panose="020B0600000101010101" pitchFamily="50" charset="-127"/>
+              <a:ea typeface="나눔스퀘어 Bold" panose="020B0600000101010101" pitchFamily="50" charset="-127"/>
+            </a:endParaRPr>
+          </a:p>
+        </p:txBody>
+      </p:sp>
+      <p:sp>
+        <p:nvSpPr>
+          <p:cNvPr id="46" name="직사각형 45"/>
+          <p:cNvSpPr/>
+          <p:nvPr/>
+        </p:nvSpPr>
+        <p:spPr>
+          <a:xfrm>
+            <a:off x="4365714" y="1832065"/>
+            <a:ext cx="1440000" cy="720000"/>
+          </a:xfrm>
+          <a:prstGeom prst="rect">
+            <a:avLst/>
+          </a:prstGeom>
+          <a:solidFill>
+            <a:schemeClr val="accent5"/>
+          </a:solidFill>
+          <a:ln>
+            <a:solidFill>
+              <a:schemeClr val="tx1"/>
+            </a:solidFill>
+          </a:ln>
+        </p:spPr>
+        <p:style>
+          <a:lnRef idx="2">
+            <a:schemeClr val="accent1">
+              <a:shade val="50000"/>
+            </a:schemeClr>
+          </a:lnRef>
+          <a:fillRef idx="1">
+            <a:schemeClr val="accent1"/>
+          </a:fillRef>
+          <a:effectRef idx="0">
+            <a:schemeClr val="accent1"/>
+          </a:effectRef>
+          <a:fontRef idx="minor">
+            <a:schemeClr val="lt1"/>
+          </a:fontRef>
+        </p:style>
+        <p:txBody>
+          <a:bodyPr rtlCol="0" anchor="ctr"/>
+          <a:lstStyle/>
+          <a:p>
+            <a:pPr algn="ctr"/>
+            <a:r>
+              <a:rPr lang="en-US" altLang="ko-KR" sz="2400" dirty="0" err="1" smtClean="0">
+                <a:latin typeface="나눔스퀘어 Bold" panose="020B0600000101010101" pitchFamily="50" charset="-127"/>
+                <a:ea typeface="나눔스퀘어 Bold" panose="020B0600000101010101" pitchFamily="50" charset="-127"/>
+              </a:rPr>
+              <a:t>Ngnix</a:t>
+            </a:r>
+            <a:endParaRPr lang="ko-KR" altLang="en-US" sz="2400" dirty="0">
+              <a:latin typeface="나눔스퀘어 Bold" panose="020B0600000101010101" pitchFamily="50" charset="-127"/>
+              <a:ea typeface="나눔스퀘어 Bold" panose="020B0600000101010101" pitchFamily="50" charset="-127"/>
+            </a:endParaRPr>
+          </a:p>
+        </p:txBody>
+      </p:sp>
+      <p:sp>
+        <p:nvSpPr>
+          <p:cNvPr id="47" name="직사각형 46"/>
+          <p:cNvSpPr/>
+          <p:nvPr/>
+        </p:nvSpPr>
+        <p:spPr>
+          <a:xfrm>
+            <a:off x="11003142" y="1831043"/>
+            <a:ext cx="1440000" cy="720000"/>
+          </a:xfrm>
+          <a:prstGeom prst="rect">
+            <a:avLst/>
+          </a:prstGeom>
+          <a:solidFill>
+            <a:schemeClr val="accent5"/>
+          </a:solidFill>
+          <a:ln>
+            <a:solidFill>
+              <a:schemeClr val="tx1"/>
+            </a:solidFill>
+          </a:ln>
+        </p:spPr>
+        <p:style>
+          <a:lnRef idx="2">
+            <a:schemeClr val="accent1">
+              <a:shade val="50000"/>
+            </a:schemeClr>
+          </a:lnRef>
+          <a:fillRef idx="1">
+            <a:schemeClr val="accent1"/>
+          </a:fillRef>
+          <a:effectRef idx="0">
+            <a:schemeClr val="accent1"/>
+          </a:effectRef>
+          <a:fontRef idx="minor">
+            <a:schemeClr val="lt1"/>
+          </a:fontRef>
+        </p:style>
+        <p:txBody>
+          <a:bodyPr rtlCol="0" anchor="ctr"/>
+          <a:lstStyle/>
+          <a:p>
+            <a:pPr algn="ctr"/>
+            <a:r>
+              <a:rPr lang="en-US" altLang="ko-KR" sz="2400" dirty="0" err="1" smtClean="0">
+                <a:latin typeface="나눔스퀘어 Bold" panose="020B0600000101010101" pitchFamily="50" charset="-127"/>
+                <a:ea typeface="나눔스퀘어 Bold" panose="020B0600000101010101" pitchFamily="50" charset="-127"/>
+              </a:rPr>
+              <a:t>Ngnix</a:t>
+            </a:r>
+            <a:endParaRPr lang="ko-KR" altLang="en-US" sz="2400" dirty="0">
+              <a:latin typeface="나눔스퀘어 Bold" panose="020B0600000101010101" pitchFamily="50" charset="-127"/>
+              <a:ea typeface="나눔스퀘어 Bold" panose="020B0600000101010101" pitchFamily="50" charset="-127"/>
+            </a:endParaRPr>
+          </a:p>
+        </p:txBody>
+      </p:sp>
+      <p:sp>
+        <p:nvSpPr>
+          <p:cNvPr id="48" name="직사각형 47"/>
+          <p:cNvSpPr/>
+          <p:nvPr/>
+        </p:nvSpPr>
+        <p:spPr>
+          <a:xfrm>
+            <a:off x="9060858" y="1824689"/>
+            <a:ext cx="1440000" cy="720000"/>
+          </a:xfrm>
+          <a:prstGeom prst="rect">
+            <a:avLst/>
+          </a:prstGeom>
+          <a:solidFill>
+            <a:schemeClr val="accent5"/>
+          </a:solidFill>
+          <a:ln>
+            <a:solidFill>
+              <a:schemeClr val="tx1"/>
+            </a:solidFill>
+          </a:ln>
+        </p:spPr>
+        <p:style>
+          <a:lnRef idx="2">
+            <a:schemeClr val="accent1">
+              <a:shade val="50000"/>
+            </a:schemeClr>
+          </a:lnRef>
+          <a:fillRef idx="1">
+            <a:schemeClr val="accent1"/>
+          </a:fillRef>
+          <a:effectRef idx="0">
+            <a:schemeClr val="accent1"/>
+          </a:effectRef>
+          <a:fontRef idx="minor">
+            <a:schemeClr val="lt1"/>
+          </a:fontRef>
+        </p:style>
+        <p:txBody>
+          <a:bodyPr rtlCol="0" anchor="ctr"/>
+          <a:lstStyle/>
+          <a:p>
+            <a:pPr algn="ctr"/>
+            <a:r>
+              <a:rPr lang="en-US" altLang="ko-KR" sz="2400" dirty="0" smtClean="0">
+                <a:latin typeface="나눔스퀘어 Bold" panose="020B0600000101010101" pitchFamily="50" charset="-127"/>
+                <a:ea typeface="나눔스퀘어 Bold" panose="020B0600000101010101" pitchFamily="50" charset="-127"/>
+              </a:rPr>
+              <a:t>DNS</a:t>
+            </a:r>
+            <a:endParaRPr lang="ko-KR" altLang="en-US" sz="2400" dirty="0">
+              <a:latin typeface="나눔스퀘어 Bold" panose="020B0600000101010101" pitchFamily="50" charset="-127"/>
+              <a:ea typeface="나눔스퀘어 Bold" panose="020B0600000101010101" pitchFamily="50" charset="-127"/>
+            </a:endParaRPr>
+          </a:p>
+        </p:txBody>
+      </p:sp>
     </p:spTree>
     <p:extLst>
       <p:ext uri="{BB962C8B-B14F-4D97-AF65-F5344CB8AC3E}">
@@ -3004,6 +4387,813 @@
       </p:grpSpPr>
       <p:sp>
         <p:nvSpPr>
+          <p:cNvPr id="4" name="직사각형 3"/>
+          <p:cNvSpPr/>
+          <p:nvPr/>
+        </p:nvSpPr>
+        <p:spPr>
+          <a:xfrm>
+            <a:off x="2874567" y="729733"/>
+            <a:ext cx="5872057" cy="584775"/>
+          </a:xfrm>
+          <a:prstGeom prst="rect">
+            <a:avLst/>
+          </a:prstGeom>
+        </p:spPr>
+        <p:txBody>
+          <a:bodyPr wrap="none">
+            <a:spAutoFit/>
+          </a:bodyPr>
+          <a:lstStyle/>
+          <a:p>
+            <a:r>
+              <a:rPr lang="en-US" altLang="ko-KR" sz="3200" b="1" dirty="0" smtClean="0">
+                <a:latin typeface="나눔스퀘어 Bold" panose="020B0600000101010101" pitchFamily="50" charset="-127"/>
+                <a:ea typeface="나눔스퀘어 Bold" panose="020B0600000101010101" pitchFamily="50" charset="-127"/>
+              </a:rPr>
+              <a:t>WAS(Web </a:t>
+            </a:r>
+            <a:r>
+              <a:rPr lang="en-US" altLang="ko-KR" sz="3200" b="1" dirty="0">
+                <a:latin typeface="나눔스퀘어 Bold" panose="020B0600000101010101" pitchFamily="50" charset="-127"/>
+                <a:ea typeface="나눔스퀘어 Bold" panose="020B0600000101010101" pitchFamily="50" charset="-127"/>
+              </a:rPr>
+              <a:t>Application Server)</a:t>
+            </a:r>
+          </a:p>
+        </p:txBody>
+      </p:sp>
+      <p:sp>
+        <p:nvSpPr>
+          <p:cNvPr id="6" name="직사각형 5"/>
+          <p:cNvSpPr/>
+          <p:nvPr/>
+        </p:nvSpPr>
+        <p:spPr>
+          <a:xfrm>
+            <a:off x="1103086" y="2235200"/>
+            <a:ext cx="2160000" cy="2880000"/>
+          </a:xfrm>
+          <a:prstGeom prst="rect">
+            <a:avLst/>
+          </a:prstGeom>
+          <a:solidFill>
+            <a:schemeClr val="accent5"/>
+          </a:solidFill>
+          <a:ln>
+            <a:solidFill>
+              <a:schemeClr val="tx1"/>
+            </a:solidFill>
+          </a:ln>
+        </p:spPr>
+        <p:style>
+          <a:lnRef idx="2">
+            <a:schemeClr val="accent1">
+              <a:shade val="50000"/>
+            </a:schemeClr>
+          </a:lnRef>
+          <a:fillRef idx="1">
+            <a:schemeClr val="accent1"/>
+          </a:fillRef>
+          <a:effectRef idx="0">
+            <a:schemeClr val="accent1"/>
+          </a:effectRef>
+          <a:fontRef idx="minor">
+            <a:schemeClr val="lt1"/>
+          </a:fontRef>
+        </p:style>
+        <p:txBody>
+          <a:bodyPr rtlCol="0" anchor="ctr"/>
+          <a:lstStyle/>
+          <a:p>
+            <a:pPr algn="ctr"/>
+            <a:r>
+              <a:rPr lang="en-US" altLang="ko-KR" sz="4000" dirty="0" smtClean="0">
+                <a:latin typeface="나눔스퀘어 Bold" panose="020B0600000101010101" pitchFamily="50" charset="-127"/>
+                <a:ea typeface="나눔스퀘어 Bold" panose="020B0600000101010101" pitchFamily="50" charset="-127"/>
+              </a:rPr>
+              <a:t>Client</a:t>
+            </a:r>
+            <a:endParaRPr lang="ko-KR" altLang="en-US" sz="4000" dirty="0">
+              <a:latin typeface="나눔스퀘어 Bold" panose="020B0600000101010101" pitchFamily="50" charset="-127"/>
+              <a:ea typeface="나눔스퀘어 Bold" panose="020B0600000101010101" pitchFamily="50" charset="-127"/>
+            </a:endParaRPr>
+          </a:p>
+        </p:txBody>
+      </p:sp>
+      <p:sp>
+        <p:nvSpPr>
+          <p:cNvPr id="7" name="직사각형 6"/>
+          <p:cNvSpPr/>
+          <p:nvPr/>
+        </p:nvSpPr>
+        <p:spPr>
+          <a:xfrm>
+            <a:off x="7560942" y="2235200"/>
+            <a:ext cx="4320000" cy="2880000"/>
+          </a:xfrm>
+          <a:prstGeom prst="rect">
+            <a:avLst/>
+          </a:prstGeom>
+          <a:solidFill>
+            <a:schemeClr val="accent5"/>
+          </a:solidFill>
+          <a:ln>
+            <a:solidFill>
+              <a:schemeClr val="tx1"/>
+            </a:solidFill>
+          </a:ln>
+        </p:spPr>
+        <p:style>
+          <a:lnRef idx="2">
+            <a:schemeClr val="accent1">
+              <a:shade val="50000"/>
+            </a:schemeClr>
+          </a:lnRef>
+          <a:fillRef idx="1">
+            <a:schemeClr val="accent1"/>
+          </a:fillRef>
+          <a:effectRef idx="0">
+            <a:schemeClr val="accent1"/>
+          </a:effectRef>
+          <a:fontRef idx="minor">
+            <a:schemeClr val="lt1"/>
+          </a:fontRef>
+        </p:style>
+        <p:txBody>
+          <a:bodyPr rtlCol="0" anchor="ctr"/>
+          <a:lstStyle/>
+          <a:p>
+            <a:pPr algn="ctr"/>
+            <a:r>
+              <a:rPr lang="en-US" altLang="ko-KR" sz="3600" dirty="0" smtClean="0">
+                <a:latin typeface="나눔스퀘어 Bold" panose="020B0600000101010101" pitchFamily="50" charset="-127"/>
+                <a:ea typeface="나눔스퀘어 Bold" panose="020B0600000101010101" pitchFamily="50" charset="-127"/>
+              </a:rPr>
+              <a:t>Server</a:t>
+            </a:r>
+            <a:endParaRPr lang="en-US" altLang="ko-KR" sz="3200" dirty="0">
+              <a:latin typeface="나눔스퀘어 Bold" panose="020B0600000101010101" pitchFamily="50" charset="-127"/>
+              <a:ea typeface="나눔스퀘어 Bold" panose="020B0600000101010101" pitchFamily="50" charset="-127"/>
+            </a:endParaRPr>
+          </a:p>
+          <a:p>
+            <a:pPr algn="ctr"/>
+            <a:endParaRPr lang="en-US" altLang="ko-KR" sz="3200" dirty="0" smtClean="0">
+              <a:latin typeface="나눔스퀘어 Bold" panose="020B0600000101010101" pitchFamily="50" charset="-127"/>
+              <a:ea typeface="나눔스퀘어 Bold" panose="020B0600000101010101" pitchFamily="50" charset="-127"/>
+            </a:endParaRPr>
+          </a:p>
+          <a:p>
+            <a:pPr algn="ctr"/>
+            <a:endParaRPr lang="en-US" altLang="ko-KR" sz="3200" dirty="0">
+              <a:latin typeface="나눔스퀘어 Bold" panose="020B0600000101010101" pitchFamily="50" charset="-127"/>
+              <a:ea typeface="나눔스퀘어 Bold" panose="020B0600000101010101" pitchFamily="50" charset="-127"/>
+            </a:endParaRPr>
+          </a:p>
+          <a:p>
+            <a:pPr algn="ctr"/>
+            <a:endParaRPr lang="en-US" altLang="ko-KR" sz="3200" dirty="0" smtClean="0">
+              <a:latin typeface="나눔스퀘어 Bold" panose="020B0600000101010101" pitchFamily="50" charset="-127"/>
+              <a:ea typeface="나눔스퀘어 Bold" panose="020B0600000101010101" pitchFamily="50" charset="-127"/>
+            </a:endParaRPr>
+          </a:p>
+          <a:p>
+            <a:pPr algn="ctr"/>
+            <a:endParaRPr lang="ko-KR" altLang="en-US" sz="3200" dirty="0">
+              <a:latin typeface="나눔스퀘어 Bold" panose="020B0600000101010101" pitchFamily="50" charset="-127"/>
+              <a:ea typeface="나눔스퀘어 Bold" panose="020B0600000101010101" pitchFamily="50" charset="-127"/>
+            </a:endParaRPr>
+          </a:p>
+        </p:txBody>
+      </p:sp>
+      <p:sp>
+        <p:nvSpPr>
+          <p:cNvPr id="8" name="직사각형 7"/>
+          <p:cNvSpPr/>
+          <p:nvPr/>
+        </p:nvSpPr>
+        <p:spPr>
+          <a:xfrm>
+            <a:off x="9886913" y="3394068"/>
+            <a:ext cx="1800000" cy="1080000"/>
+          </a:xfrm>
+          <a:prstGeom prst="rect">
+            <a:avLst/>
+          </a:prstGeom>
+          <a:solidFill>
+            <a:schemeClr val="accent5"/>
+          </a:solidFill>
+          <a:ln>
+            <a:solidFill>
+              <a:schemeClr val="tx1"/>
+            </a:solidFill>
+          </a:ln>
+        </p:spPr>
+        <p:style>
+          <a:lnRef idx="2">
+            <a:schemeClr val="accent1">
+              <a:shade val="50000"/>
+            </a:schemeClr>
+          </a:lnRef>
+          <a:fillRef idx="1">
+            <a:schemeClr val="accent1"/>
+          </a:fillRef>
+          <a:effectRef idx="0">
+            <a:schemeClr val="accent1"/>
+          </a:effectRef>
+          <a:fontRef idx="minor">
+            <a:schemeClr val="lt1"/>
+          </a:fontRef>
+        </p:style>
+        <p:txBody>
+          <a:bodyPr rtlCol="0" anchor="ctr"/>
+          <a:lstStyle/>
+          <a:p>
+            <a:pPr algn="ctr"/>
+            <a:r>
+              <a:rPr lang="en-US" altLang="ko-KR" dirty="0" smtClean="0">
+                <a:latin typeface="나눔스퀘어 Bold" panose="020B0600000101010101" pitchFamily="50" charset="-127"/>
+                <a:ea typeface="나눔스퀘어 Bold" panose="020B0600000101010101" pitchFamily="50" charset="-127"/>
+              </a:rPr>
+              <a:t>WAS</a:t>
+            </a:r>
+          </a:p>
+          <a:p>
+            <a:pPr algn="ctr"/>
+            <a:r>
+              <a:rPr lang="en-US" altLang="ko-KR" dirty="0" smtClean="0">
+                <a:latin typeface="나눔스퀘어 Bold" panose="020B0600000101010101" pitchFamily="50" charset="-127"/>
+                <a:ea typeface="나눔스퀘어 Bold" panose="020B0600000101010101" pitchFamily="50" charset="-127"/>
+              </a:rPr>
+              <a:t>(Tomcat)</a:t>
+            </a:r>
+            <a:endParaRPr lang="ko-KR" altLang="en-US" dirty="0">
+              <a:latin typeface="나눔스퀘어 Bold" panose="020B0600000101010101" pitchFamily="50" charset="-127"/>
+              <a:ea typeface="나눔스퀘어 Bold" panose="020B0600000101010101" pitchFamily="50" charset="-127"/>
+            </a:endParaRPr>
+          </a:p>
+        </p:txBody>
+      </p:sp>
+      <p:sp>
+        <p:nvSpPr>
+          <p:cNvPr id="9" name="직사각형 8"/>
+          <p:cNvSpPr/>
+          <p:nvPr/>
+        </p:nvSpPr>
+        <p:spPr>
+          <a:xfrm>
+            <a:off x="7754971" y="3401326"/>
+            <a:ext cx="1800000" cy="1080000"/>
+          </a:xfrm>
+          <a:prstGeom prst="rect">
+            <a:avLst/>
+          </a:prstGeom>
+          <a:solidFill>
+            <a:schemeClr val="accent5"/>
+          </a:solidFill>
+          <a:ln>
+            <a:solidFill>
+              <a:schemeClr val="tx1"/>
+            </a:solidFill>
+          </a:ln>
+        </p:spPr>
+        <p:style>
+          <a:lnRef idx="2">
+            <a:schemeClr val="accent1">
+              <a:shade val="50000"/>
+            </a:schemeClr>
+          </a:lnRef>
+          <a:fillRef idx="1">
+            <a:schemeClr val="accent1"/>
+          </a:fillRef>
+          <a:effectRef idx="0">
+            <a:schemeClr val="accent1"/>
+          </a:effectRef>
+          <a:fontRef idx="minor">
+            <a:schemeClr val="lt1"/>
+          </a:fontRef>
+        </p:style>
+        <p:txBody>
+          <a:bodyPr rtlCol="0" anchor="ctr"/>
+          <a:lstStyle/>
+          <a:p>
+            <a:pPr algn="ctr"/>
+            <a:r>
+              <a:rPr lang="en-US" altLang="ko-KR" dirty="0" smtClean="0">
+                <a:latin typeface="나눔스퀘어 Bold" panose="020B0600000101010101" pitchFamily="50" charset="-127"/>
+                <a:ea typeface="나눔스퀘어 Bold" panose="020B0600000101010101" pitchFamily="50" charset="-127"/>
+              </a:rPr>
+              <a:t>Web Server</a:t>
+            </a:r>
+          </a:p>
+          <a:p>
+            <a:pPr algn="ctr"/>
+            <a:r>
+              <a:rPr lang="en-US" altLang="ko-KR" dirty="0" smtClean="0">
+                <a:latin typeface="나눔스퀘어 Bold" panose="020B0600000101010101" pitchFamily="50" charset="-127"/>
+                <a:ea typeface="나눔스퀘어 Bold" panose="020B0600000101010101" pitchFamily="50" charset="-127"/>
+              </a:rPr>
+              <a:t>(</a:t>
+            </a:r>
+            <a:r>
+              <a:rPr lang="en-US" altLang="ko-KR" dirty="0" err="1" smtClean="0">
+                <a:latin typeface="나눔스퀘어 Bold" panose="020B0600000101010101" pitchFamily="50" charset="-127"/>
+                <a:ea typeface="나눔스퀘어 Bold" panose="020B0600000101010101" pitchFamily="50" charset="-127"/>
+              </a:rPr>
+              <a:t>Ngnix</a:t>
+            </a:r>
+            <a:r>
+              <a:rPr lang="en-US" altLang="ko-KR" dirty="0" smtClean="0">
+                <a:latin typeface="나눔스퀘어 Bold" panose="020B0600000101010101" pitchFamily="50" charset="-127"/>
+                <a:ea typeface="나눔스퀘어 Bold" panose="020B0600000101010101" pitchFamily="50" charset="-127"/>
+              </a:rPr>
+              <a:t>)</a:t>
+            </a:r>
+            <a:endParaRPr lang="ko-KR" altLang="en-US" dirty="0">
+              <a:latin typeface="나눔스퀘어 Bold" panose="020B0600000101010101" pitchFamily="50" charset="-127"/>
+              <a:ea typeface="나눔스퀘어 Bold" panose="020B0600000101010101" pitchFamily="50" charset="-127"/>
+            </a:endParaRPr>
+          </a:p>
+        </p:txBody>
+      </p:sp>
+      <p:cxnSp>
+        <p:nvCxnSpPr>
+          <p:cNvPr id="11" name="직선 화살표 연결선 10"/>
+          <p:cNvCxnSpPr>
+            <a:stCxn id="6" idx="3"/>
+            <a:endCxn id="7" idx="1"/>
+          </p:cNvCxnSpPr>
+          <p:nvPr/>
+        </p:nvCxnSpPr>
+        <p:spPr>
+          <a:xfrm>
+            <a:off x="3263086" y="3675200"/>
+            <a:ext cx="4297856" cy="0"/>
+          </a:xfrm>
+          <a:prstGeom prst="straightConnector1">
+            <a:avLst/>
+          </a:prstGeom>
+          <a:ln w="76200">
+            <a:solidFill>
+              <a:schemeClr val="accent2"/>
+            </a:solidFill>
+            <a:tailEnd type="triangle"/>
+          </a:ln>
+        </p:spPr>
+        <p:style>
+          <a:lnRef idx="1">
+            <a:schemeClr val="accent1"/>
+          </a:lnRef>
+          <a:fillRef idx="0">
+            <a:schemeClr val="accent1"/>
+          </a:fillRef>
+          <a:effectRef idx="0">
+            <a:schemeClr val="accent1"/>
+          </a:effectRef>
+          <a:fontRef idx="minor">
+            <a:schemeClr val="tx1"/>
+          </a:fontRef>
+        </p:style>
+      </p:cxnSp>
+      <p:sp>
+        <p:nvSpPr>
+          <p:cNvPr id="13" name="TextBox 12"/>
+          <p:cNvSpPr txBox="1"/>
+          <p:nvPr/>
+        </p:nvSpPr>
+        <p:spPr>
+          <a:xfrm>
+            <a:off x="4304467" y="3302239"/>
+            <a:ext cx="2215094" cy="369332"/>
+          </a:xfrm>
+          <a:prstGeom prst="rect">
+            <a:avLst/>
+          </a:prstGeom>
+          <a:noFill/>
+        </p:spPr>
+        <p:txBody>
+          <a:bodyPr wrap="none" rtlCol="0">
+            <a:spAutoFit/>
+          </a:bodyPr>
+          <a:lstStyle/>
+          <a:p>
+            <a:r>
+              <a:rPr lang="en-US" altLang="ko-KR" dirty="0" smtClean="0">
+                <a:latin typeface="나눔스퀘어 Bold" panose="020B0600000101010101" pitchFamily="50" charset="-127"/>
+                <a:ea typeface="나눔스퀘어 Bold" panose="020B0600000101010101" pitchFamily="50" charset="-127"/>
+              </a:rPr>
+              <a:t>Request(</a:t>
+            </a:r>
+            <a:r>
+              <a:rPr lang="ko-KR" altLang="en-US" dirty="0" smtClean="0">
+                <a:latin typeface="나눔스퀘어 Bold" panose="020B0600000101010101" pitchFamily="50" charset="-127"/>
+                <a:ea typeface="나눔스퀘어 Bold" panose="020B0600000101010101" pitchFamily="50" charset="-127"/>
+              </a:rPr>
+              <a:t>정적</a:t>
+            </a:r>
+            <a:r>
+              <a:rPr lang="en-US" altLang="ko-KR" dirty="0" smtClean="0">
+                <a:latin typeface="나눔스퀘어 Bold" panose="020B0600000101010101" pitchFamily="50" charset="-127"/>
+                <a:ea typeface="나눔스퀘어 Bold" panose="020B0600000101010101" pitchFamily="50" charset="-127"/>
+              </a:rPr>
+              <a:t>, </a:t>
+            </a:r>
+            <a:r>
+              <a:rPr lang="ko-KR" altLang="en-US" dirty="0" smtClean="0">
+                <a:latin typeface="나눔스퀘어 Bold" panose="020B0600000101010101" pitchFamily="50" charset="-127"/>
+                <a:ea typeface="나눔스퀘어 Bold" panose="020B0600000101010101" pitchFamily="50" charset="-127"/>
+              </a:rPr>
+              <a:t>동적</a:t>
+            </a:r>
+            <a:r>
+              <a:rPr lang="en-US" altLang="ko-KR" dirty="0" smtClean="0">
+                <a:latin typeface="나눔스퀘어 Bold" panose="020B0600000101010101" pitchFamily="50" charset="-127"/>
+                <a:ea typeface="나눔스퀘어 Bold" panose="020B0600000101010101" pitchFamily="50" charset="-127"/>
+              </a:rPr>
+              <a:t>)</a:t>
+            </a:r>
+            <a:endParaRPr lang="ko-KR" altLang="en-US" dirty="0">
+              <a:latin typeface="나눔스퀘어 Bold" panose="020B0600000101010101" pitchFamily="50" charset="-127"/>
+              <a:ea typeface="나눔스퀘어 Bold" panose="020B0600000101010101" pitchFamily="50" charset="-127"/>
+            </a:endParaRPr>
+          </a:p>
+        </p:txBody>
+      </p:sp>
+      <p:sp>
+        <p:nvSpPr>
+          <p:cNvPr id="14" name="TextBox 13"/>
+          <p:cNvSpPr txBox="1"/>
+          <p:nvPr/>
+        </p:nvSpPr>
+        <p:spPr>
+          <a:xfrm>
+            <a:off x="6606481" y="5200762"/>
+            <a:ext cx="1908921" cy="369332"/>
+          </a:xfrm>
+          <a:prstGeom prst="rect">
+            <a:avLst/>
+          </a:prstGeom>
+          <a:noFill/>
+        </p:spPr>
+        <p:txBody>
+          <a:bodyPr wrap="none" rtlCol="0">
+            <a:spAutoFit/>
+          </a:bodyPr>
+          <a:lstStyle/>
+          <a:p>
+            <a:r>
+              <a:rPr lang="en-US" altLang="ko-KR" dirty="0" smtClean="0">
+                <a:latin typeface="나눔스퀘어 Bold" panose="020B0600000101010101" pitchFamily="50" charset="-127"/>
+                <a:ea typeface="나눔스퀘어 Bold" panose="020B0600000101010101" pitchFamily="50" charset="-127"/>
+              </a:rPr>
+              <a:t>Response (</a:t>
+            </a:r>
+            <a:r>
+              <a:rPr lang="ko-KR" altLang="en-US" dirty="0" smtClean="0">
+                <a:latin typeface="나눔스퀘어 Bold" panose="020B0600000101010101" pitchFamily="50" charset="-127"/>
+                <a:ea typeface="나눔스퀘어 Bold" panose="020B0600000101010101" pitchFamily="50" charset="-127"/>
+              </a:rPr>
+              <a:t>정적</a:t>
+            </a:r>
+            <a:r>
+              <a:rPr lang="en-US" altLang="ko-KR" dirty="0" smtClean="0">
+                <a:latin typeface="나눔스퀘어 Bold" panose="020B0600000101010101" pitchFamily="50" charset="-127"/>
+                <a:ea typeface="나눔스퀘어 Bold" panose="020B0600000101010101" pitchFamily="50" charset="-127"/>
+              </a:rPr>
+              <a:t>)</a:t>
+            </a:r>
+            <a:endParaRPr lang="ko-KR" altLang="en-US" dirty="0">
+              <a:latin typeface="나눔스퀘어 Bold" panose="020B0600000101010101" pitchFamily="50" charset="-127"/>
+              <a:ea typeface="나눔스퀘어 Bold" panose="020B0600000101010101" pitchFamily="50" charset="-127"/>
+            </a:endParaRPr>
+          </a:p>
+        </p:txBody>
+      </p:sp>
+      <p:sp>
+        <p:nvSpPr>
+          <p:cNvPr id="15" name="직사각형 14"/>
+          <p:cNvSpPr/>
+          <p:nvPr/>
+        </p:nvSpPr>
+        <p:spPr>
+          <a:xfrm>
+            <a:off x="7754971" y="4488151"/>
+            <a:ext cx="604653" cy="369332"/>
+          </a:xfrm>
+          <a:prstGeom prst="rect">
+            <a:avLst/>
+          </a:prstGeom>
+        </p:spPr>
+        <p:txBody>
+          <a:bodyPr wrap="none">
+            <a:spAutoFit/>
+          </a:bodyPr>
+          <a:lstStyle/>
+          <a:p>
+            <a:r>
+              <a:rPr lang="ko-KR" altLang="en-US" dirty="0">
+                <a:solidFill>
+                  <a:schemeClr val="bg1"/>
+                </a:solidFill>
+                <a:latin typeface="나눔스퀘어 Bold" panose="020B0600000101010101" pitchFamily="50" charset="-127"/>
+                <a:ea typeface="나눔스퀘어 Bold" panose="020B0600000101010101" pitchFamily="50" charset="-127"/>
+              </a:rPr>
+              <a:t>정적</a:t>
+            </a:r>
+          </a:p>
+        </p:txBody>
+      </p:sp>
+      <p:sp>
+        <p:nvSpPr>
+          <p:cNvPr id="18" name="직사각형 17"/>
+          <p:cNvSpPr/>
+          <p:nvPr/>
+        </p:nvSpPr>
+        <p:spPr>
+          <a:xfrm>
+            <a:off x="9886913" y="4488151"/>
+            <a:ext cx="604653" cy="369332"/>
+          </a:xfrm>
+          <a:prstGeom prst="rect">
+            <a:avLst/>
+          </a:prstGeom>
+        </p:spPr>
+        <p:txBody>
+          <a:bodyPr wrap="none">
+            <a:spAutoFit/>
+          </a:bodyPr>
+          <a:lstStyle/>
+          <a:p>
+            <a:r>
+              <a:rPr lang="ko-KR" altLang="en-US" dirty="0">
+                <a:solidFill>
+                  <a:schemeClr val="bg1"/>
+                </a:solidFill>
+                <a:latin typeface="나눔스퀘어 Bold" panose="020B0600000101010101" pitchFamily="50" charset="-127"/>
+                <a:ea typeface="나눔스퀘어 Bold" panose="020B0600000101010101" pitchFamily="50" charset="-127"/>
+              </a:rPr>
+              <a:t>동</a:t>
+            </a:r>
+            <a:r>
+              <a:rPr lang="ko-KR" altLang="en-US" dirty="0" smtClean="0">
+                <a:solidFill>
+                  <a:schemeClr val="bg1"/>
+                </a:solidFill>
+                <a:latin typeface="나눔스퀘어 Bold" panose="020B0600000101010101" pitchFamily="50" charset="-127"/>
+                <a:ea typeface="나눔스퀘어 Bold" panose="020B0600000101010101" pitchFamily="50" charset="-127"/>
+              </a:rPr>
+              <a:t>적</a:t>
+            </a:r>
+            <a:endParaRPr lang="ko-KR" altLang="en-US" dirty="0">
+              <a:solidFill>
+                <a:schemeClr val="bg1"/>
+              </a:solidFill>
+              <a:latin typeface="나눔스퀘어 Bold" panose="020B0600000101010101" pitchFamily="50" charset="-127"/>
+              <a:ea typeface="나눔스퀘어 Bold" panose="020B0600000101010101" pitchFamily="50" charset="-127"/>
+            </a:endParaRPr>
+          </a:p>
+        </p:txBody>
+      </p:sp>
+      <p:sp>
+        <p:nvSpPr>
+          <p:cNvPr id="22" name="TextBox 21"/>
+          <p:cNvSpPr txBox="1"/>
+          <p:nvPr/>
+        </p:nvSpPr>
+        <p:spPr>
+          <a:xfrm>
+            <a:off x="8792130" y="5378272"/>
+            <a:ext cx="1857624" cy="369332"/>
+          </a:xfrm>
+          <a:prstGeom prst="rect">
+            <a:avLst/>
+          </a:prstGeom>
+          <a:noFill/>
+        </p:spPr>
+        <p:txBody>
+          <a:bodyPr wrap="none" rtlCol="0">
+            <a:spAutoFit/>
+          </a:bodyPr>
+          <a:lstStyle/>
+          <a:p>
+            <a:r>
+              <a:rPr lang="en-US" altLang="ko-KR" smtClean="0">
+                <a:latin typeface="나눔스퀘어 Bold" panose="020B0600000101010101" pitchFamily="50" charset="-127"/>
+                <a:ea typeface="나눔스퀘어 Bold" panose="020B0600000101010101" pitchFamily="50" charset="-127"/>
+              </a:rPr>
+              <a:t>Response (</a:t>
+            </a:r>
+            <a:r>
+              <a:rPr lang="ko-KR" altLang="en-US" dirty="0">
+                <a:latin typeface="나눔스퀘어 Bold" panose="020B0600000101010101" pitchFamily="50" charset="-127"/>
+                <a:ea typeface="나눔스퀘어 Bold" panose="020B0600000101010101" pitchFamily="50" charset="-127"/>
+              </a:rPr>
+              <a:t>동</a:t>
+            </a:r>
+            <a:r>
+              <a:rPr lang="ko-KR" altLang="en-US" dirty="0" smtClean="0">
+                <a:latin typeface="나눔스퀘어 Bold" panose="020B0600000101010101" pitchFamily="50" charset="-127"/>
+                <a:ea typeface="나눔스퀘어 Bold" panose="020B0600000101010101" pitchFamily="50" charset="-127"/>
+              </a:rPr>
+              <a:t>적</a:t>
+            </a:r>
+            <a:r>
+              <a:rPr lang="en-US" altLang="ko-KR" dirty="0" smtClean="0">
+                <a:latin typeface="나눔스퀘어 Bold" panose="020B0600000101010101" pitchFamily="50" charset="-127"/>
+                <a:ea typeface="나눔스퀘어 Bold" panose="020B0600000101010101" pitchFamily="50" charset="-127"/>
+              </a:rPr>
+              <a:t>)</a:t>
+            </a:r>
+            <a:endParaRPr lang="ko-KR" altLang="en-US" dirty="0">
+              <a:latin typeface="나눔스퀘어 Bold" panose="020B0600000101010101" pitchFamily="50" charset="-127"/>
+              <a:ea typeface="나눔스퀘어 Bold" panose="020B0600000101010101" pitchFamily="50" charset="-127"/>
+            </a:endParaRPr>
+          </a:p>
+        </p:txBody>
+      </p:sp>
+      <p:sp>
+        <p:nvSpPr>
+          <p:cNvPr id="24" name="직사각형 23"/>
+          <p:cNvSpPr/>
+          <p:nvPr/>
+        </p:nvSpPr>
+        <p:spPr>
+          <a:xfrm>
+            <a:off x="4690811" y="3864251"/>
+            <a:ext cx="1442405" cy="921657"/>
+          </a:xfrm>
+          <a:prstGeom prst="rect">
+            <a:avLst/>
+          </a:prstGeom>
+          <a:solidFill>
+            <a:schemeClr val="accent5"/>
+          </a:solidFill>
+          <a:ln>
+            <a:solidFill>
+              <a:schemeClr val="tx1"/>
+            </a:solidFill>
+          </a:ln>
+        </p:spPr>
+        <p:style>
+          <a:lnRef idx="2">
+            <a:schemeClr val="accent1">
+              <a:shade val="50000"/>
+            </a:schemeClr>
+          </a:lnRef>
+          <a:fillRef idx="1">
+            <a:schemeClr val="accent1"/>
+          </a:fillRef>
+          <a:effectRef idx="0">
+            <a:schemeClr val="accent1"/>
+          </a:effectRef>
+          <a:fontRef idx="minor">
+            <a:schemeClr val="lt1"/>
+          </a:fontRef>
+        </p:style>
+        <p:txBody>
+          <a:bodyPr rtlCol="0" anchor="ctr"/>
+          <a:lstStyle/>
+          <a:p>
+            <a:pPr algn="ctr"/>
+            <a:r>
+              <a:rPr lang="en-US" altLang="ko-KR" dirty="0" smtClean="0">
+                <a:latin typeface="나눔스퀘어 Bold" panose="020B0600000101010101" pitchFamily="50" charset="-127"/>
+                <a:ea typeface="나눔스퀘어 Bold" panose="020B0600000101010101" pitchFamily="50" charset="-127"/>
+              </a:rPr>
+              <a:t>DNS</a:t>
+            </a:r>
+          </a:p>
+          <a:p>
+            <a:pPr algn="ctr"/>
+            <a:r>
+              <a:rPr lang="en-US" altLang="ko-KR" dirty="0" smtClean="0">
+                <a:latin typeface="나눔스퀘어 Bold" panose="020B0600000101010101" pitchFamily="50" charset="-127"/>
+                <a:ea typeface="나눔스퀘어 Bold" panose="020B0600000101010101" pitchFamily="50" charset="-127"/>
+              </a:rPr>
+              <a:t>(8.8.8.8)</a:t>
+            </a:r>
+            <a:endParaRPr lang="ko-KR" altLang="en-US" dirty="0">
+              <a:latin typeface="나눔스퀘어 Bold" panose="020B0600000101010101" pitchFamily="50" charset="-127"/>
+              <a:ea typeface="나눔스퀘어 Bold" panose="020B0600000101010101" pitchFamily="50" charset="-127"/>
+            </a:endParaRPr>
+          </a:p>
+        </p:txBody>
+      </p:sp>
+      <p:cxnSp>
+        <p:nvCxnSpPr>
+          <p:cNvPr id="27" name="꺾인 연결선 26"/>
+          <p:cNvCxnSpPr>
+            <a:stCxn id="9" idx="2"/>
+            <a:endCxn id="6" idx="2"/>
+          </p:cNvCxnSpPr>
+          <p:nvPr/>
+        </p:nvCxnSpPr>
+        <p:spPr>
+          <a:xfrm rot="5400000">
+            <a:off x="5102092" y="1562321"/>
+            <a:ext cx="633874" cy="6471885"/>
+          </a:xfrm>
+          <a:prstGeom prst="bentConnector3">
+            <a:avLst>
+              <a:gd name="adj1" fmla="val 186440"/>
+            </a:avLst>
+          </a:prstGeom>
+          <a:ln w="76200">
+            <a:solidFill>
+              <a:schemeClr val="accent2"/>
+            </a:solidFill>
+            <a:tailEnd type="triangle"/>
+          </a:ln>
+        </p:spPr>
+        <p:style>
+          <a:lnRef idx="1">
+            <a:schemeClr val="accent1"/>
+          </a:lnRef>
+          <a:fillRef idx="0">
+            <a:schemeClr val="accent1"/>
+          </a:fillRef>
+          <a:effectRef idx="0">
+            <a:schemeClr val="accent1"/>
+          </a:effectRef>
+          <a:fontRef idx="minor">
+            <a:schemeClr val="tx1"/>
+          </a:fontRef>
+        </p:style>
+      </p:cxnSp>
+      <p:cxnSp>
+        <p:nvCxnSpPr>
+          <p:cNvPr id="33" name="꺾인 연결선 32"/>
+          <p:cNvCxnSpPr>
+            <a:stCxn id="8" idx="2"/>
+            <a:endCxn id="6" idx="2"/>
+          </p:cNvCxnSpPr>
+          <p:nvPr/>
+        </p:nvCxnSpPr>
+        <p:spPr>
+          <a:xfrm rot="5400000">
+            <a:off x="6164434" y="492721"/>
+            <a:ext cx="641132" cy="8603827"/>
+          </a:xfrm>
+          <a:prstGeom prst="bentConnector3">
+            <a:avLst>
+              <a:gd name="adj1" fmla="val 221681"/>
+            </a:avLst>
+          </a:prstGeom>
+          <a:ln w="76200">
+            <a:solidFill>
+              <a:schemeClr val="accent2"/>
+            </a:solidFill>
+            <a:tailEnd type="triangle"/>
+          </a:ln>
+        </p:spPr>
+        <p:style>
+          <a:lnRef idx="1">
+            <a:schemeClr val="accent1"/>
+          </a:lnRef>
+          <a:fillRef idx="0">
+            <a:schemeClr val="accent1"/>
+          </a:fillRef>
+          <a:effectRef idx="0">
+            <a:schemeClr val="accent1"/>
+          </a:effectRef>
+          <a:fontRef idx="minor">
+            <a:schemeClr val="tx1"/>
+          </a:fontRef>
+        </p:style>
+      </p:cxnSp>
+    </p:spTree>
+    <p:extLst>
+      <p:ext uri="{BB962C8B-B14F-4D97-AF65-F5344CB8AC3E}">
+        <p14:creationId xmlns:p14="http://schemas.microsoft.com/office/powerpoint/2010/main" val="3009171530"/>
+      </p:ext>
+    </p:extLst>
+  </p:cSld>
+  <p:clrMapOvr>
+    <a:masterClrMapping/>
+  </p:clrMapOvr>
+</p:sld>
+</file>
+
+<file path=ppt/slides/slide3.xml><?xml version="1.0" encoding="utf-8"?>
+<p:sld xmlns:a="http://schemas.openxmlformats.org/drawingml/2006/main" xmlns:r="http://schemas.openxmlformats.org/officeDocument/2006/relationships" xmlns:p="http://schemas.openxmlformats.org/presentationml/2006/main">
+  <p:cSld>
+    <p:spTree>
+      <p:nvGrpSpPr>
+        <p:cNvPr id="1" name=""/>
+        <p:cNvGrpSpPr/>
+        <p:nvPr/>
+      </p:nvGrpSpPr>
+      <p:grpSpPr>
+        <a:xfrm>
+          <a:off x="0" y="0"/>
+          <a:ext cx="0" cy="0"/>
+          <a:chOff x="0" y="0"/>
+          <a:chExt cx="0" cy="0"/>
+        </a:xfrm>
+      </p:grpSpPr>
+      <p:sp>
+        <p:nvSpPr>
           <p:cNvPr id="76" name="직사각형 75"/>
           <p:cNvSpPr/>
           <p:nvPr/>
@@ -5283,7 +7473,7 @@
 </p:sld>
 </file>
 
-<file path=ppt/slides/slide3.xml><?xml version="1.0" encoding="utf-8"?>
+<file path=ppt/slides/slide4.xml><?xml version="1.0" encoding="utf-8"?>
 <p:sld xmlns:a="http://schemas.openxmlformats.org/drawingml/2006/main" xmlns:r="http://schemas.openxmlformats.org/officeDocument/2006/relationships" xmlns:p="http://schemas.openxmlformats.org/presentationml/2006/main">
   <p:cSld>
     <p:spTree>
@@ -10686,7 +12876,7 @@
 </p:sld>
 </file>
 
-<file path=ppt/slides/slide4.xml><?xml version="1.0" encoding="utf-8"?>
+<file path=ppt/slides/slide5.xml><?xml version="1.0" encoding="utf-8"?>
 <p:sld xmlns:a="http://schemas.openxmlformats.org/drawingml/2006/main" xmlns:r="http://schemas.openxmlformats.org/officeDocument/2006/relationships" xmlns:p="http://schemas.openxmlformats.org/presentationml/2006/main">
   <p:cSld>
     <p:spTree>

</xml_diff>

<commit_message>
20260930 commit : 2_class
</commit_message>
<xml_diff>
--- a/notion/create_notion_img.pptx
+++ b/notion/create_notion_img.pptx
@@ -2973,1388 +2973,1403 @@
           <a:chExt cx="0" cy="0"/>
         </a:xfrm>
       </p:grpSpPr>
-      <p:sp>
-        <p:nvSpPr>
-          <p:cNvPr id="2" name="직사각형 1"/>
-          <p:cNvSpPr/>
-          <p:nvPr/>
-        </p:nvSpPr>
-        <p:spPr>
-          <a:xfrm>
-            <a:off x="0" y="2217107"/>
-            <a:ext cx="2880000" cy="1440000"/>
-          </a:xfrm>
-          <a:prstGeom prst="rect">
-            <a:avLst/>
-          </a:prstGeom>
-          <a:solidFill>
-            <a:schemeClr val="accent5"/>
-          </a:solidFill>
-          <a:ln>
+      <p:grpSp>
+        <p:nvGrpSpPr>
+          <p:cNvPr id="49" name="그룹 48"/>
+          <p:cNvGrpSpPr/>
+          <p:nvPr/>
+        </p:nvGrpSpPr>
+        <p:grpSpPr>
+          <a:xfrm>
+            <a:off x="0" y="0"/>
+            <a:ext cx="12443142" cy="5514214"/>
+            <a:chOff x="0" y="0"/>
+            <a:chExt cx="12443142" cy="5514214"/>
+          </a:xfrm>
+        </p:grpSpPr>
+        <p:sp>
+          <p:nvSpPr>
+            <p:cNvPr id="2" name="직사각형 1"/>
+            <p:cNvSpPr/>
+            <p:nvPr/>
+          </p:nvSpPr>
+          <p:spPr>
+            <a:xfrm>
+              <a:off x="0" y="2217107"/>
+              <a:ext cx="2880000" cy="1440000"/>
+            </a:xfrm>
+            <a:prstGeom prst="rect">
+              <a:avLst/>
+            </a:prstGeom>
             <a:solidFill>
+              <a:schemeClr val="accent5"/>
+            </a:solidFill>
+            <a:ln>
+              <a:solidFill>
+                <a:schemeClr val="tx1"/>
+              </a:solidFill>
+            </a:ln>
+          </p:spPr>
+          <p:style>
+            <a:lnRef idx="2">
+              <a:schemeClr val="accent1">
+                <a:shade val="50000"/>
+              </a:schemeClr>
+            </a:lnRef>
+            <a:fillRef idx="1">
+              <a:schemeClr val="accent1"/>
+            </a:fillRef>
+            <a:effectRef idx="0">
+              <a:schemeClr val="accent1"/>
+            </a:effectRef>
+            <a:fontRef idx="minor">
+              <a:schemeClr val="lt1"/>
+            </a:fontRef>
+          </p:style>
+          <p:txBody>
+            <a:bodyPr rtlCol="0" anchor="ctr"/>
+            <a:lstStyle/>
+            <a:p>
+              <a:pPr algn="ctr"/>
+              <a:r>
+                <a:rPr lang="ko-KR" altLang="en-US" sz="2400" dirty="0" smtClean="0">
+                  <a:latin typeface="나눔스퀘어 Bold" panose="020B0600000101010101" pitchFamily="50" charset="-127"/>
+                  <a:ea typeface="나눔스퀘어 Bold" panose="020B0600000101010101" pitchFamily="50" charset="-127"/>
+                </a:rPr>
+                <a:t>개발</a:t>
+              </a:r>
+              <a:r>
+                <a:rPr lang="en-US" altLang="ko-KR" sz="2400" dirty="0" smtClean="0">
+                  <a:latin typeface="나눔스퀘어 Bold" panose="020B0600000101010101" pitchFamily="50" charset="-127"/>
+                  <a:ea typeface="나눔스퀘어 Bold" panose="020B0600000101010101" pitchFamily="50" charset="-127"/>
+                </a:rPr>
+                <a:t>PC(Local)</a:t>
+              </a:r>
+            </a:p>
+            <a:p>
+              <a:pPr algn="ctr"/>
+              <a:r>
+                <a:rPr lang="en-US" altLang="ko-KR" sz="2400" dirty="0" smtClean="0">
+                  <a:latin typeface="나눔스퀘어 Bold" panose="020B0600000101010101" pitchFamily="50" charset="-127"/>
+                  <a:ea typeface="나눔스퀘어 Bold" panose="020B0600000101010101" pitchFamily="50" charset="-127"/>
+                </a:rPr>
+                <a:t>JDK, </a:t>
+              </a:r>
+              <a:r>
+                <a:rPr lang="en-US" altLang="ko-KR" sz="2400" dirty="0" err="1" smtClean="0">
+                  <a:latin typeface="나눔스퀘어 Bold" panose="020B0600000101010101" pitchFamily="50" charset="-127"/>
+                  <a:ea typeface="나눔스퀘어 Bold" panose="020B0600000101010101" pitchFamily="50" charset="-127"/>
+                </a:rPr>
+                <a:t>Git</a:t>
+              </a:r>
+              <a:r>
+                <a:rPr lang="en-US" altLang="ko-KR" sz="2400" dirty="0" smtClean="0">
+                  <a:latin typeface="나눔스퀘어 Bold" panose="020B0600000101010101" pitchFamily="50" charset="-127"/>
+                  <a:ea typeface="나눔스퀘어 Bold" panose="020B0600000101010101" pitchFamily="50" charset="-127"/>
+                </a:rPr>
+                <a:t>, MySQL</a:t>
+              </a:r>
+              <a:endParaRPr lang="ko-KR" altLang="en-US" sz="2400" dirty="0">
+                <a:latin typeface="나눔스퀘어 Bold" panose="020B0600000101010101" pitchFamily="50" charset="-127"/>
+                <a:ea typeface="나눔스퀘어 Bold" panose="020B0600000101010101" pitchFamily="50" charset="-127"/>
+              </a:endParaRPr>
+            </a:p>
+          </p:txBody>
+        </p:sp>
+        <p:sp>
+          <p:nvSpPr>
+            <p:cNvPr id="4" name="직사각형 3"/>
+            <p:cNvSpPr/>
+            <p:nvPr/>
+          </p:nvSpPr>
+          <p:spPr>
+            <a:xfrm>
+              <a:off x="4656000" y="2217107"/>
+              <a:ext cx="2880000" cy="1440000"/>
+            </a:xfrm>
+            <a:prstGeom prst="rect">
+              <a:avLst/>
+            </a:prstGeom>
+            <a:solidFill>
+              <a:schemeClr val="accent5"/>
+            </a:solidFill>
+            <a:ln>
+              <a:solidFill>
+                <a:schemeClr val="tx1"/>
+              </a:solidFill>
+            </a:ln>
+          </p:spPr>
+          <p:style>
+            <a:lnRef idx="2">
+              <a:schemeClr val="accent1">
+                <a:shade val="50000"/>
+              </a:schemeClr>
+            </a:lnRef>
+            <a:fillRef idx="1">
+              <a:schemeClr val="accent1"/>
+            </a:fillRef>
+            <a:effectRef idx="0">
+              <a:schemeClr val="accent1"/>
+            </a:effectRef>
+            <a:fontRef idx="minor">
+              <a:schemeClr val="lt1"/>
+            </a:fontRef>
+          </p:style>
+          <p:txBody>
+            <a:bodyPr rtlCol="0" anchor="ctr"/>
+            <a:lstStyle/>
+            <a:p>
+              <a:pPr algn="ctr"/>
+              <a:r>
+                <a:rPr lang="en-US" altLang="ko-KR" sz="2000" dirty="0" smtClean="0">
+                  <a:latin typeface="나눔스퀘어 Bold" panose="020B0600000101010101" pitchFamily="50" charset="-127"/>
+                  <a:ea typeface="나눔스퀘어 Bold" panose="020B0600000101010101" pitchFamily="50" charset="-127"/>
+                </a:rPr>
+                <a:t>Dev(Stage) Server</a:t>
+              </a:r>
+            </a:p>
+            <a:p>
+              <a:pPr algn="ctr"/>
+              <a:r>
+                <a:rPr lang="en-US" altLang="ko-KR" sz="2000" dirty="0" err="1" smtClean="0">
+                  <a:latin typeface="나눔스퀘어 Bold" panose="020B0600000101010101" pitchFamily="50" charset="-127"/>
+                  <a:ea typeface="나눔스퀘어 Bold" panose="020B0600000101010101" pitchFamily="50" charset="-127"/>
+                </a:rPr>
+                <a:t>Gradle</a:t>
+              </a:r>
+              <a:r>
+                <a:rPr lang="en-US" altLang="ko-KR" sz="2000" dirty="0" smtClean="0">
+                  <a:latin typeface="나눔스퀘어 Bold" panose="020B0600000101010101" pitchFamily="50" charset="-127"/>
+                  <a:ea typeface="나눔스퀘어 Bold" panose="020B0600000101010101" pitchFamily="50" charset="-127"/>
+                </a:rPr>
+                <a:t>, JDK, </a:t>
+              </a:r>
+              <a:r>
+                <a:rPr lang="en-US" altLang="ko-KR" sz="2000" dirty="0" err="1" smtClean="0">
+                  <a:latin typeface="나눔스퀘어 Bold" panose="020B0600000101010101" pitchFamily="50" charset="-127"/>
+                  <a:ea typeface="나눔스퀘어 Bold" panose="020B0600000101010101" pitchFamily="50" charset="-127"/>
+                </a:rPr>
+                <a:t>Git</a:t>
+              </a:r>
+              <a:r>
+                <a:rPr lang="en-US" altLang="ko-KR" sz="2000" dirty="0" smtClean="0">
+                  <a:latin typeface="나눔스퀘어 Bold" panose="020B0600000101010101" pitchFamily="50" charset="-127"/>
+                  <a:ea typeface="나눔스퀘어 Bold" panose="020B0600000101010101" pitchFamily="50" charset="-127"/>
+                </a:rPr>
+                <a:t>, Build</a:t>
+              </a:r>
+              <a:endParaRPr lang="ko-KR" altLang="en-US" sz="2000" dirty="0">
+                <a:latin typeface="나눔스퀘어 Bold" panose="020B0600000101010101" pitchFamily="50" charset="-127"/>
+                <a:ea typeface="나눔스퀘어 Bold" panose="020B0600000101010101" pitchFamily="50" charset="-127"/>
+              </a:endParaRPr>
+            </a:p>
+          </p:txBody>
+        </p:sp>
+        <p:sp>
+          <p:nvSpPr>
+            <p:cNvPr id="5" name="직사각형 4"/>
+            <p:cNvSpPr/>
+            <p:nvPr/>
+          </p:nvSpPr>
+          <p:spPr>
+            <a:xfrm>
+              <a:off x="9492000" y="4434214"/>
+              <a:ext cx="2520000" cy="1080000"/>
+            </a:xfrm>
+            <a:prstGeom prst="rect">
+              <a:avLst/>
+            </a:prstGeom>
+            <a:solidFill>
+              <a:schemeClr val="accent5"/>
+            </a:solidFill>
+            <a:ln>
+              <a:solidFill>
+                <a:schemeClr val="tx1"/>
+              </a:solidFill>
+            </a:ln>
+          </p:spPr>
+          <p:style>
+            <a:lnRef idx="2">
+              <a:schemeClr val="accent1">
+                <a:shade val="50000"/>
+              </a:schemeClr>
+            </a:lnRef>
+            <a:fillRef idx="1">
+              <a:schemeClr val="accent1"/>
+            </a:fillRef>
+            <a:effectRef idx="0">
+              <a:schemeClr val="accent1"/>
+            </a:effectRef>
+            <a:fontRef idx="minor">
+              <a:schemeClr val="lt1"/>
+            </a:fontRef>
+          </p:style>
+          <p:txBody>
+            <a:bodyPr rtlCol="0" anchor="ctr"/>
+            <a:lstStyle/>
+            <a:p>
+              <a:pPr algn="ctr"/>
+              <a:r>
+                <a:rPr lang="en-US" altLang="ko-KR" sz="2400" dirty="0" smtClean="0">
+                  <a:latin typeface="나눔스퀘어 Bold" panose="020B0600000101010101" pitchFamily="50" charset="-127"/>
+                  <a:ea typeface="나눔스퀘어 Bold" panose="020B0600000101010101" pitchFamily="50" charset="-127"/>
+                </a:rPr>
+                <a:t>Product MySQL</a:t>
+              </a:r>
+              <a:endParaRPr lang="ko-KR" altLang="en-US" sz="2400" dirty="0">
+                <a:latin typeface="나눔스퀘어 Bold" panose="020B0600000101010101" pitchFamily="50" charset="-127"/>
+                <a:ea typeface="나눔스퀘어 Bold" panose="020B0600000101010101" pitchFamily="50" charset="-127"/>
+              </a:endParaRPr>
+            </a:p>
+          </p:txBody>
+        </p:sp>
+        <p:sp>
+          <p:nvSpPr>
+            <p:cNvPr id="6" name="직사각형 5"/>
+            <p:cNvSpPr/>
+            <p:nvPr/>
+          </p:nvSpPr>
+          <p:spPr>
+            <a:xfrm>
+              <a:off x="9312000" y="2217107"/>
+              <a:ext cx="2880000" cy="1440000"/>
+            </a:xfrm>
+            <a:prstGeom prst="rect">
+              <a:avLst/>
+            </a:prstGeom>
+            <a:solidFill>
+              <a:schemeClr val="accent5"/>
+            </a:solidFill>
+            <a:ln>
+              <a:solidFill>
+                <a:schemeClr val="tx1"/>
+              </a:solidFill>
+            </a:ln>
+          </p:spPr>
+          <p:style>
+            <a:lnRef idx="2">
+              <a:schemeClr val="accent1">
+                <a:shade val="50000"/>
+              </a:schemeClr>
+            </a:lnRef>
+            <a:fillRef idx="1">
+              <a:schemeClr val="accent1"/>
+            </a:fillRef>
+            <a:effectRef idx="0">
+              <a:schemeClr val="accent1"/>
+            </a:effectRef>
+            <a:fontRef idx="minor">
+              <a:schemeClr val="lt1"/>
+            </a:fontRef>
+          </p:style>
+          <p:txBody>
+            <a:bodyPr rtlCol="0" anchor="ctr"/>
+            <a:lstStyle/>
+            <a:p>
+              <a:pPr algn="ctr"/>
+              <a:r>
+                <a:rPr lang="en-US" altLang="ko-KR" sz="2000" dirty="0" smtClean="0">
+                  <a:latin typeface="나눔스퀘어 Bold" panose="020B0600000101010101" pitchFamily="50" charset="-127"/>
+                  <a:ea typeface="나눔스퀘어 Bold" panose="020B0600000101010101" pitchFamily="50" charset="-127"/>
+                </a:rPr>
+                <a:t>Product</a:t>
+              </a:r>
+              <a:r>
+                <a:rPr lang="en-US" altLang="ko-KR" sz="2000" dirty="0" smtClean="0">
+                  <a:latin typeface="나눔스퀘어 Bold" panose="020B0600000101010101" pitchFamily="50" charset="-127"/>
+                  <a:ea typeface="나눔스퀘어 Bold" panose="020B0600000101010101" pitchFamily="50" charset="-127"/>
+                </a:rPr>
+                <a:t> Server</a:t>
+              </a:r>
+            </a:p>
+            <a:p>
+              <a:pPr algn="ctr"/>
+              <a:r>
+                <a:rPr lang="en-US" altLang="ko-KR" sz="2000" dirty="0" err="1" smtClean="0">
+                  <a:latin typeface="나눔스퀘어 Bold" panose="020B0600000101010101" pitchFamily="50" charset="-127"/>
+                  <a:ea typeface="나눔스퀘어 Bold" panose="020B0600000101010101" pitchFamily="50" charset="-127"/>
+                </a:rPr>
+                <a:t>Gradle</a:t>
+              </a:r>
+              <a:r>
+                <a:rPr lang="en-US" altLang="ko-KR" sz="2000" dirty="0" smtClean="0">
+                  <a:latin typeface="나눔스퀘어 Bold" panose="020B0600000101010101" pitchFamily="50" charset="-127"/>
+                  <a:ea typeface="나눔스퀘어 Bold" panose="020B0600000101010101" pitchFamily="50" charset="-127"/>
+                </a:rPr>
+                <a:t>, JDK, </a:t>
+              </a:r>
+              <a:r>
+                <a:rPr lang="en-US" altLang="ko-KR" sz="2000" dirty="0" err="1" smtClean="0">
+                  <a:latin typeface="나눔스퀘어 Bold" panose="020B0600000101010101" pitchFamily="50" charset="-127"/>
+                  <a:ea typeface="나눔스퀘어 Bold" panose="020B0600000101010101" pitchFamily="50" charset="-127"/>
+                </a:rPr>
+                <a:t>Git</a:t>
+              </a:r>
+              <a:r>
+                <a:rPr lang="en-US" altLang="ko-KR" sz="2000" dirty="0" smtClean="0">
+                  <a:latin typeface="나눔스퀘어 Bold" panose="020B0600000101010101" pitchFamily="50" charset="-127"/>
+                  <a:ea typeface="나눔스퀘어 Bold" panose="020B0600000101010101" pitchFamily="50" charset="-127"/>
+                </a:rPr>
+                <a:t>, Build</a:t>
+              </a:r>
+              <a:endParaRPr lang="ko-KR" altLang="en-US" sz="2000" dirty="0" smtClean="0">
+                <a:latin typeface="나눔스퀘어 Bold" panose="020B0600000101010101" pitchFamily="50" charset="-127"/>
+                <a:ea typeface="나눔스퀘어 Bold" panose="020B0600000101010101" pitchFamily="50" charset="-127"/>
+              </a:endParaRPr>
+            </a:p>
+          </p:txBody>
+        </p:sp>
+        <p:sp>
+          <p:nvSpPr>
+            <p:cNvPr id="11" name="직사각형 10"/>
+            <p:cNvSpPr/>
+            <p:nvPr/>
+          </p:nvSpPr>
+          <p:spPr>
+            <a:xfrm>
+              <a:off x="4836000" y="4434214"/>
+              <a:ext cx="2520000" cy="1080000"/>
+            </a:xfrm>
+            <a:prstGeom prst="rect">
+              <a:avLst/>
+            </a:prstGeom>
+            <a:solidFill>
+              <a:schemeClr val="accent5"/>
+            </a:solidFill>
+            <a:ln>
+              <a:solidFill>
+                <a:schemeClr val="tx1"/>
+              </a:solidFill>
+            </a:ln>
+          </p:spPr>
+          <p:style>
+            <a:lnRef idx="2">
+              <a:schemeClr val="accent1">
+                <a:shade val="50000"/>
+              </a:schemeClr>
+            </a:lnRef>
+            <a:fillRef idx="1">
+              <a:schemeClr val="accent1"/>
+            </a:fillRef>
+            <a:effectRef idx="0">
+              <a:schemeClr val="accent1"/>
+            </a:effectRef>
+            <a:fontRef idx="minor">
+              <a:schemeClr val="lt1"/>
+            </a:fontRef>
+          </p:style>
+          <p:txBody>
+            <a:bodyPr rtlCol="0" anchor="ctr"/>
+            <a:lstStyle/>
+            <a:p>
+              <a:pPr algn="ctr"/>
+              <a:r>
+                <a:rPr lang="en-US" altLang="ko-KR" sz="2400" dirty="0" smtClean="0">
+                  <a:latin typeface="나눔스퀘어 Bold" panose="020B0600000101010101" pitchFamily="50" charset="-127"/>
+                  <a:ea typeface="나눔스퀘어 Bold" panose="020B0600000101010101" pitchFamily="50" charset="-127"/>
+                </a:rPr>
+                <a:t>Dev MySQL</a:t>
+              </a:r>
+              <a:endParaRPr lang="ko-KR" altLang="en-US" sz="2400" dirty="0">
+                <a:latin typeface="나눔스퀘어 Bold" panose="020B0600000101010101" pitchFamily="50" charset="-127"/>
+                <a:ea typeface="나눔스퀘어 Bold" panose="020B0600000101010101" pitchFamily="50" charset="-127"/>
+              </a:endParaRPr>
+            </a:p>
+          </p:txBody>
+        </p:sp>
+        <p:cxnSp>
+          <p:nvCxnSpPr>
+            <p:cNvPr id="23" name="꺾인 연결선 22"/>
+            <p:cNvCxnSpPr>
+              <a:stCxn id="4" idx="3"/>
+              <a:endCxn id="13" idx="1"/>
+            </p:cNvCxnSpPr>
+            <p:nvPr/>
+          </p:nvCxnSpPr>
+          <p:spPr>
+            <a:xfrm flipH="1" flipV="1">
+              <a:off x="7163999" y="540000"/>
+              <a:ext cx="372001" cy="2397107"/>
+            </a:xfrm>
+            <a:prstGeom prst="bentConnector5">
+              <a:avLst>
+                <a:gd name="adj1" fmla="val -142264"/>
+                <a:gd name="adj2" fmla="val 53755"/>
+                <a:gd name="adj3" fmla="val 238896"/>
+              </a:avLst>
+            </a:prstGeom>
+            <a:ln w="76200">
+              <a:solidFill>
+                <a:schemeClr val="accent2"/>
+              </a:solidFill>
+              <a:tailEnd type="triangle"/>
+            </a:ln>
+          </p:spPr>
+          <p:style>
+            <a:lnRef idx="1">
+              <a:schemeClr val="accent1"/>
+            </a:lnRef>
+            <a:fillRef idx="0">
+              <a:schemeClr val="accent1"/>
+            </a:fillRef>
+            <a:effectRef idx="0">
+              <a:schemeClr val="accent1"/>
+            </a:effectRef>
+            <a:fontRef idx="minor">
               <a:schemeClr val="tx1"/>
+            </a:fontRef>
+          </p:style>
+        </p:cxnSp>
+        <p:sp>
+          <p:nvSpPr>
+            <p:cNvPr id="3" name="직사각형 2"/>
+            <p:cNvSpPr/>
+            <p:nvPr/>
+          </p:nvSpPr>
+          <p:spPr>
+            <a:xfrm>
+              <a:off x="2507999" y="0"/>
+              <a:ext cx="2520000" cy="1080000"/>
+            </a:xfrm>
+            <a:prstGeom prst="rect">
+              <a:avLst/>
+            </a:prstGeom>
+            <a:solidFill>
+              <a:schemeClr val="accent5"/>
             </a:solidFill>
-          </a:ln>
-        </p:spPr>
-        <p:style>
-          <a:lnRef idx="2">
-            <a:schemeClr val="accent1">
-              <a:shade val="50000"/>
-            </a:schemeClr>
-          </a:lnRef>
-          <a:fillRef idx="1">
-            <a:schemeClr val="accent1"/>
-          </a:fillRef>
-          <a:effectRef idx="0">
-            <a:schemeClr val="accent1"/>
-          </a:effectRef>
-          <a:fontRef idx="minor">
-            <a:schemeClr val="lt1"/>
-          </a:fontRef>
-        </p:style>
-        <p:txBody>
-          <a:bodyPr rtlCol="0" anchor="ctr"/>
-          <a:lstStyle/>
-          <a:p>
-            <a:pPr algn="ctr"/>
-            <a:r>
-              <a:rPr lang="ko-KR" altLang="en-US" sz="2400" dirty="0" smtClean="0">
-                <a:latin typeface="나눔스퀘어 Bold" panose="020B0600000101010101" pitchFamily="50" charset="-127"/>
-                <a:ea typeface="나눔스퀘어 Bold" panose="020B0600000101010101" pitchFamily="50" charset="-127"/>
-              </a:rPr>
-              <a:t>개발</a:t>
-            </a:r>
-            <a:r>
-              <a:rPr lang="en-US" altLang="ko-KR" sz="2400" dirty="0" smtClean="0">
-                <a:latin typeface="나눔스퀘어 Bold" panose="020B0600000101010101" pitchFamily="50" charset="-127"/>
-                <a:ea typeface="나눔스퀘어 Bold" panose="020B0600000101010101" pitchFamily="50" charset="-127"/>
-              </a:rPr>
-              <a:t>PC(Local)</a:t>
-            </a:r>
-          </a:p>
-          <a:p>
-            <a:pPr algn="ctr"/>
-            <a:r>
-              <a:rPr lang="en-US" altLang="ko-KR" sz="2400" dirty="0" smtClean="0">
-                <a:latin typeface="나눔스퀘어 Bold" panose="020B0600000101010101" pitchFamily="50" charset="-127"/>
-                <a:ea typeface="나눔스퀘어 Bold" panose="020B0600000101010101" pitchFamily="50" charset="-127"/>
-              </a:rPr>
-              <a:t>JDK, </a:t>
-            </a:r>
-            <a:r>
-              <a:rPr lang="en-US" altLang="ko-KR" sz="2400" dirty="0" err="1" smtClean="0">
-                <a:latin typeface="나눔스퀘어 Bold" panose="020B0600000101010101" pitchFamily="50" charset="-127"/>
-                <a:ea typeface="나눔스퀘어 Bold" panose="020B0600000101010101" pitchFamily="50" charset="-127"/>
-              </a:rPr>
-              <a:t>Git</a:t>
-            </a:r>
-            <a:r>
-              <a:rPr lang="en-US" altLang="ko-KR" sz="2400" dirty="0" smtClean="0">
-                <a:latin typeface="나눔스퀘어 Bold" panose="020B0600000101010101" pitchFamily="50" charset="-127"/>
-                <a:ea typeface="나눔스퀘어 Bold" panose="020B0600000101010101" pitchFamily="50" charset="-127"/>
-              </a:rPr>
-              <a:t>, MySQL</a:t>
-            </a:r>
-            <a:endParaRPr lang="ko-KR" altLang="en-US" sz="2400" dirty="0">
-              <a:latin typeface="나눔스퀘어 Bold" panose="020B0600000101010101" pitchFamily="50" charset="-127"/>
-              <a:ea typeface="나눔스퀘어 Bold" panose="020B0600000101010101" pitchFamily="50" charset="-127"/>
-            </a:endParaRPr>
-          </a:p>
-        </p:txBody>
-      </p:sp>
-      <p:sp>
-        <p:nvSpPr>
-          <p:cNvPr id="4" name="직사각형 3"/>
-          <p:cNvSpPr/>
-          <p:nvPr/>
-        </p:nvSpPr>
-        <p:spPr>
-          <a:xfrm>
-            <a:off x="4656000" y="2217107"/>
-            <a:ext cx="2880000" cy="1440000"/>
-          </a:xfrm>
-          <a:prstGeom prst="rect">
-            <a:avLst/>
-          </a:prstGeom>
-          <a:solidFill>
-            <a:schemeClr val="accent5"/>
-          </a:solidFill>
-          <a:ln>
+            <a:ln>
+              <a:solidFill>
+                <a:schemeClr val="tx1"/>
+              </a:solidFill>
+            </a:ln>
+          </p:spPr>
+          <p:style>
+            <a:lnRef idx="2">
+              <a:schemeClr val="accent1">
+                <a:shade val="50000"/>
+              </a:schemeClr>
+            </a:lnRef>
+            <a:fillRef idx="1">
+              <a:schemeClr val="accent1"/>
+            </a:fillRef>
+            <a:effectRef idx="0">
+              <a:schemeClr val="accent1"/>
+            </a:effectRef>
+            <a:fontRef idx="minor">
+              <a:schemeClr val="lt1"/>
+            </a:fontRef>
+          </p:style>
+          <p:txBody>
+            <a:bodyPr rtlCol="0" anchor="ctr"/>
+            <a:lstStyle/>
+            <a:p>
+              <a:pPr algn="ctr"/>
+              <a:r>
+                <a:rPr lang="en-US" altLang="ko-KR" sz="2400" dirty="0" smtClean="0">
+                  <a:latin typeface="나눔스퀘어 Bold" panose="020B0600000101010101" pitchFamily="50" charset="-127"/>
+                  <a:ea typeface="나눔스퀘어 Bold" panose="020B0600000101010101" pitchFamily="50" charset="-127"/>
+                </a:rPr>
+                <a:t>GitHub</a:t>
+              </a:r>
+              <a:endParaRPr lang="ko-KR" altLang="en-US" sz="2400" dirty="0">
+                <a:latin typeface="나눔스퀘어 Bold" panose="020B0600000101010101" pitchFamily="50" charset="-127"/>
+                <a:ea typeface="나눔스퀘어 Bold" panose="020B0600000101010101" pitchFamily="50" charset="-127"/>
+              </a:endParaRPr>
+            </a:p>
+          </p:txBody>
+        </p:sp>
+        <p:sp>
+          <p:nvSpPr>
+            <p:cNvPr id="13" name="직사각형 12"/>
+            <p:cNvSpPr/>
+            <p:nvPr/>
+          </p:nvSpPr>
+          <p:spPr>
+            <a:xfrm>
+              <a:off x="7163999" y="0"/>
+              <a:ext cx="2520000" cy="1080000"/>
+            </a:xfrm>
+            <a:prstGeom prst="rect">
+              <a:avLst/>
+            </a:prstGeom>
             <a:solidFill>
-              <a:schemeClr val="tx1"/>
+              <a:schemeClr val="accent5"/>
             </a:solidFill>
-          </a:ln>
-        </p:spPr>
-        <p:style>
-          <a:lnRef idx="2">
-            <a:schemeClr val="accent1">
-              <a:shade val="50000"/>
-            </a:schemeClr>
-          </a:lnRef>
-          <a:fillRef idx="1">
-            <a:schemeClr val="accent1"/>
-          </a:fillRef>
-          <a:effectRef idx="0">
-            <a:schemeClr val="accent1"/>
-          </a:effectRef>
-          <a:fontRef idx="minor">
-            <a:schemeClr val="lt1"/>
-          </a:fontRef>
-        </p:style>
-        <p:txBody>
-          <a:bodyPr rtlCol="0" anchor="ctr"/>
-          <a:lstStyle/>
-          <a:p>
-            <a:pPr algn="ctr"/>
-            <a:r>
-              <a:rPr lang="en-US" altLang="ko-KR" sz="2000" dirty="0" smtClean="0">
-                <a:latin typeface="나눔스퀘어 Bold" panose="020B0600000101010101" pitchFamily="50" charset="-127"/>
-                <a:ea typeface="나눔스퀘어 Bold" panose="020B0600000101010101" pitchFamily="50" charset="-127"/>
-              </a:rPr>
-              <a:t>Dev(Stage) Server</a:t>
-            </a:r>
-          </a:p>
-          <a:p>
-            <a:pPr algn="ctr"/>
-            <a:r>
-              <a:rPr lang="en-US" altLang="ko-KR" sz="2000" dirty="0" err="1" smtClean="0">
-                <a:latin typeface="나눔스퀘어 Bold" panose="020B0600000101010101" pitchFamily="50" charset="-127"/>
-                <a:ea typeface="나눔스퀘어 Bold" panose="020B0600000101010101" pitchFamily="50" charset="-127"/>
-              </a:rPr>
-              <a:t>Gradle</a:t>
-            </a:r>
-            <a:r>
-              <a:rPr lang="en-US" altLang="ko-KR" sz="2000" dirty="0" smtClean="0">
-                <a:latin typeface="나눔스퀘어 Bold" panose="020B0600000101010101" pitchFamily="50" charset="-127"/>
-                <a:ea typeface="나눔스퀘어 Bold" panose="020B0600000101010101" pitchFamily="50" charset="-127"/>
-              </a:rPr>
-              <a:t>, JDK, </a:t>
-            </a:r>
-            <a:r>
-              <a:rPr lang="en-US" altLang="ko-KR" sz="2000" dirty="0" err="1" smtClean="0">
-                <a:latin typeface="나눔스퀘어 Bold" panose="020B0600000101010101" pitchFamily="50" charset="-127"/>
-                <a:ea typeface="나눔스퀘어 Bold" panose="020B0600000101010101" pitchFamily="50" charset="-127"/>
-              </a:rPr>
-              <a:t>Git</a:t>
-            </a:r>
-            <a:r>
-              <a:rPr lang="en-US" altLang="ko-KR" sz="2000" dirty="0" smtClean="0">
-                <a:latin typeface="나눔스퀘어 Bold" panose="020B0600000101010101" pitchFamily="50" charset="-127"/>
-                <a:ea typeface="나눔스퀘어 Bold" panose="020B0600000101010101" pitchFamily="50" charset="-127"/>
-              </a:rPr>
-              <a:t>, Build</a:t>
-            </a:r>
-            <a:endParaRPr lang="ko-KR" altLang="en-US" sz="2000" dirty="0">
-              <a:latin typeface="나눔스퀘어 Bold" panose="020B0600000101010101" pitchFamily="50" charset="-127"/>
-              <a:ea typeface="나눔스퀘어 Bold" panose="020B0600000101010101" pitchFamily="50" charset="-127"/>
-            </a:endParaRPr>
-          </a:p>
-        </p:txBody>
-      </p:sp>
-      <p:sp>
-        <p:nvSpPr>
-          <p:cNvPr id="5" name="직사각형 4"/>
-          <p:cNvSpPr/>
-          <p:nvPr/>
-        </p:nvSpPr>
-        <p:spPr>
-          <a:xfrm>
-            <a:off x="9492000" y="4434214"/>
-            <a:ext cx="2520000" cy="1080000"/>
-          </a:xfrm>
-          <a:prstGeom prst="rect">
-            <a:avLst/>
-          </a:prstGeom>
-          <a:solidFill>
-            <a:schemeClr val="accent5"/>
-          </a:solidFill>
-          <a:ln>
+            <a:ln>
+              <a:solidFill>
+                <a:schemeClr val="tx1"/>
+              </a:solidFill>
+            </a:ln>
+          </p:spPr>
+          <p:style>
+            <a:lnRef idx="2">
+              <a:schemeClr val="accent1">
+                <a:shade val="50000"/>
+              </a:schemeClr>
+            </a:lnRef>
+            <a:fillRef idx="1">
+              <a:schemeClr val="accent1"/>
+            </a:fillRef>
+            <a:effectRef idx="0">
+              <a:schemeClr val="accent1"/>
+            </a:effectRef>
+            <a:fontRef idx="minor">
+              <a:schemeClr val="lt1"/>
+            </a:fontRef>
+          </p:style>
+          <p:txBody>
+            <a:bodyPr rtlCol="0" anchor="ctr"/>
+            <a:lstStyle/>
+            <a:p>
+              <a:pPr algn="ctr"/>
+              <a:r>
+                <a:rPr lang="en-US" altLang="ko-KR" sz="2400" dirty="0" err="1" smtClean="0">
+                  <a:latin typeface="나눔스퀘어 Bold" panose="020B0600000101010101" pitchFamily="50" charset="-127"/>
+                  <a:ea typeface="나눔스퀘어 Bold" panose="020B0600000101010101" pitchFamily="50" charset="-127"/>
+                </a:rPr>
+                <a:t>DockerHub</a:t>
+              </a:r>
+              <a:endParaRPr lang="ko-KR" altLang="en-US" sz="2400" dirty="0">
+                <a:latin typeface="나눔스퀘어 Bold" panose="020B0600000101010101" pitchFamily="50" charset="-127"/>
+                <a:ea typeface="나눔스퀘어 Bold" panose="020B0600000101010101" pitchFamily="50" charset="-127"/>
+              </a:endParaRPr>
+            </a:p>
+          </p:txBody>
+        </p:sp>
+        <p:sp>
+          <p:nvSpPr>
+            <p:cNvPr id="25" name="직사각형 24"/>
+            <p:cNvSpPr/>
+            <p:nvPr/>
+          </p:nvSpPr>
+          <p:spPr>
+            <a:xfrm>
+              <a:off x="180000" y="4434214"/>
+              <a:ext cx="2520000" cy="1080000"/>
+            </a:xfrm>
+            <a:prstGeom prst="rect">
+              <a:avLst/>
+            </a:prstGeom>
             <a:solidFill>
-              <a:schemeClr val="tx1"/>
+              <a:schemeClr val="accent5"/>
             </a:solidFill>
-          </a:ln>
-        </p:spPr>
-        <p:style>
-          <a:lnRef idx="2">
-            <a:schemeClr val="accent1">
-              <a:shade val="50000"/>
-            </a:schemeClr>
-          </a:lnRef>
-          <a:fillRef idx="1">
-            <a:schemeClr val="accent1"/>
-          </a:fillRef>
-          <a:effectRef idx="0">
-            <a:schemeClr val="accent1"/>
-          </a:effectRef>
-          <a:fontRef idx="minor">
-            <a:schemeClr val="lt1"/>
-          </a:fontRef>
-        </p:style>
-        <p:txBody>
-          <a:bodyPr rtlCol="0" anchor="ctr"/>
-          <a:lstStyle/>
-          <a:p>
-            <a:pPr algn="ctr"/>
-            <a:r>
-              <a:rPr lang="en-US" altLang="ko-KR" sz="2400" dirty="0" smtClean="0">
-                <a:latin typeface="나눔스퀘어 Bold" panose="020B0600000101010101" pitchFamily="50" charset="-127"/>
-                <a:ea typeface="나눔스퀘어 Bold" panose="020B0600000101010101" pitchFamily="50" charset="-127"/>
-              </a:rPr>
-              <a:t>Product MySQL</a:t>
-            </a:r>
-            <a:endParaRPr lang="ko-KR" altLang="en-US" sz="2400" dirty="0">
-              <a:latin typeface="나눔스퀘어 Bold" panose="020B0600000101010101" pitchFamily="50" charset="-127"/>
-              <a:ea typeface="나눔스퀘어 Bold" panose="020B0600000101010101" pitchFamily="50" charset="-127"/>
-            </a:endParaRPr>
-          </a:p>
-        </p:txBody>
-      </p:sp>
-      <p:sp>
-        <p:nvSpPr>
-          <p:cNvPr id="6" name="직사각형 5"/>
-          <p:cNvSpPr/>
-          <p:nvPr/>
-        </p:nvSpPr>
-        <p:spPr>
-          <a:xfrm>
-            <a:off x="9312000" y="2217107"/>
-            <a:ext cx="2880000" cy="1440000"/>
-          </a:xfrm>
-          <a:prstGeom prst="rect">
-            <a:avLst/>
-          </a:prstGeom>
-          <a:solidFill>
-            <a:schemeClr val="accent5"/>
-          </a:solidFill>
-          <a:ln>
+            <a:ln>
+              <a:solidFill>
+                <a:schemeClr val="tx1"/>
+              </a:solidFill>
+            </a:ln>
+          </p:spPr>
+          <p:style>
+            <a:lnRef idx="2">
+              <a:schemeClr val="accent1">
+                <a:shade val="50000"/>
+              </a:schemeClr>
+            </a:lnRef>
+            <a:fillRef idx="1">
+              <a:schemeClr val="accent1"/>
+            </a:fillRef>
+            <a:effectRef idx="0">
+              <a:schemeClr val="accent1"/>
+            </a:effectRef>
+            <a:fontRef idx="minor">
+              <a:schemeClr val="lt1"/>
+            </a:fontRef>
+          </p:style>
+          <p:txBody>
+            <a:bodyPr rtlCol="0" anchor="ctr"/>
+            <a:lstStyle/>
+            <a:p>
+              <a:pPr algn="ctr"/>
+              <a:r>
+                <a:rPr lang="ko-KR" altLang="en-US" sz="2400" dirty="0" smtClean="0">
+                  <a:latin typeface="나눔스퀘어 Bold" panose="020B0600000101010101" pitchFamily="50" charset="-127"/>
+                  <a:ea typeface="나눔스퀘어 Bold" panose="020B0600000101010101" pitchFamily="50" charset="-127"/>
+                </a:rPr>
+                <a:t>개발</a:t>
+              </a:r>
+              <a:r>
+                <a:rPr lang="en-US" altLang="ko-KR" sz="2400" dirty="0" smtClean="0">
+                  <a:latin typeface="나눔스퀘어 Bold" panose="020B0600000101010101" pitchFamily="50" charset="-127"/>
+                  <a:ea typeface="나눔스퀘어 Bold" panose="020B0600000101010101" pitchFamily="50" charset="-127"/>
+                </a:rPr>
+                <a:t> MySQL</a:t>
+              </a:r>
+              <a:endParaRPr lang="ko-KR" altLang="en-US" sz="2400" dirty="0">
+                <a:latin typeface="나눔스퀘어 Bold" panose="020B0600000101010101" pitchFamily="50" charset="-127"/>
+                <a:ea typeface="나눔스퀘어 Bold" panose="020B0600000101010101" pitchFamily="50" charset="-127"/>
+              </a:endParaRPr>
+            </a:p>
+          </p:txBody>
+        </p:sp>
+        <p:sp>
+          <p:nvSpPr>
+            <p:cNvPr id="26" name="TextBox 25"/>
+            <p:cNvSpPr txBox="1"/>
+            <p:nvPr/>
+          </p:nvSpPr>
+          <p:spPr>
+            <a:xfrm>
+              <a:off x="5021340" y="3676328"/>
+              <a:ext cx="1999265" cy="369332"/>
+            </a:xfrm>
+            <a:prstGeom prst="rect">
+              <a:avLst/>
+            </a:prstGeom>
+            <a:noFill/>
+          </p:spPr>
+          <p:txBody>
+            <a:bodyPr wrap="none" rtlCol="0">
+              <a:spAutoFit/>
+            </a:bodyPr>
+            <a:lstStyle/>
+            <a:p>
+              <a:r>
+                <a:rPr lang="ko-KR" altLang="en-US" dirty="0" smtClean="0">
+                  <a:latin typeface="나눔스퀘어 Bold" panose="020B0600000101010101" pitchFamily="50" charset="-127"/>
+                  <a:ea typeface="나눔스퀘어 Bold" panose="020B0600000101010101" pitchFamily="50" charset="-127"/>
+                </a:rPr>
+                <a:t>개발팀 </a:t>
+              </a:r>
+              <a:r>
+                <a:rPr lang="en-US" altLang="ko-KR" dirty="0" smtClean="0">
+                  <a:latin typeface="나눔스퀘어 Bold" panose="020B0600000101010101" pitchFamily="50" charset="-127"/>
+                  <a:ea typeface="나눔스퀘어 Bold" panose="020B0600000101010101" pitchFamily="50" charset="-127"/>
+                </a:rPr>
+                <a:t>-&gt; QA(QM)</a:t>
+              </a:r>
+              <a:endParaRPr lang="ko-KR" altLang="en-US" dirty="0">
+                <a:latin typeface="나눔스퀘어 Bold" panose="020B0600000101010101" pitchFamily="50" charset="-127"/>
+                <a:ea typeface="나눔스퀘어 Bold" panose="020B0600000101010101" pitchFamily="50" charset="-127"/>
+              </a:endParaRPr>
+            </a:p>
+          </p:txBody>
+        </p:sp>
+        <p:sp>
+          <p:nvSpPr>
+            <p:cNvPr id="27" name="직사각형 26"/>
+            <p:cNvSpPr/>
+            <p:nvPr/>
+          </p:nvSpPr>
+          <p:spPr>
+            <a:xfrm>
+              <a:off x="6804000" y="1378553"/>
+              <a:ext cx="2160000" cy="540000"/>
+            </a:xfrm>
+            <a:prstGeom prst="rect">
+              <a:avLst/>
+            </a:prstGeom>
             <a:solidFill>
-              <a:schemeClr val="tx1"/>
+              <a:schemeClr val="accent4"/>
             </a:solidFill>
-          </a:ln>
-        </p:spPr>
-        <p:style>
-          <a:lnRef idx="2">
-            <a:schemeClr val="accent1">
-              <a:shade val="50000"/>
-            </a:schemeClr>
-          </a:lnRef>
-          <a:fillRef idx="1">
-            <a:schemeClr val="accent1"/>
-          </a:fillRef>
-          <a:effectRef idx="0">
-            <a:schemeClr val="accent1"/>
-          </a:effectRef>
-          <a:fontRef idx="minor">
-            <a:schemeClr val="lt1"/>
-          </a:fontRef>
-        </p:style>
-        <p:txBody>
-          <a:bodyPr rtlCol="0" anchor="ctr"/>
-          <a:lstStyle/>
-          <a:p>
-            <a:pPr algn="ctr"/>
-            <a:r>
-              <a:rPr lang="en-US" altLang="ko-KR" sz="2000" dirty="0" smtClean="0">
-                <a:latin typeface="나눔스퀘어 Bold" panose="020B0600000101010101" pitchFamily="50" charset="-127"/>
-                <a:ea typeface="나눔스퀘어 Bold" panose="020B0600000101010101" pitchFamily="50" charset="-127"/>
-              </a:rPr>
-              <a:t>Product</a:t>
-            </a:r>
-            <a:r>
-              <a:rPr lang="en-US" altLang="ko-KR" sz="2000" dirty="0" smtClean="0">
-                <a:latin typeface="나눔스퀘어 Bold" panose="020B0600000101010101" pitchFamily="50" charset="-127"/>
-                <a:ea typeface="나눔스퀘어 Bold" panose="020B0600000101010101" pitchFamily="50" charset="-127"/>
-              </a:rPr>
-              <a:t> Server</a:t>
-            </a:r>
-          </a:p>
-          <a:p>
-            <a:pPr algn="ctr"/>
-            <a:r>
-              <a:rPr lang="en-US" altLang="ko-KR" sz="2000" dirty="0" err="1" smtClean="0">
-                <a:latin typeface="나눔스퀘어 Bold" panose="020B0600000101010101" pitchFamily="50" charset="-127"/>
-                <a:ea typeface="나눔스퀘어 Bold" panose="020B0600000101010101" pitchFamily="50" charset="-127"/>
-              </a:rPr>
-              <a:t>Gradle</a:t>
-            </a:r>
-            <a:r>
-              <a:rPr lang="en-US" altLang="ko-KR" sz="2000" dirty="0" smtClean="0">
-                <a:latin typeface="나눔스퀘어 Bold" panose="020B0600000101010101" pitchFamily="50" charset="-127"/>
-                <a:ea typeface="나눔스퀘어 Bold" panose="020B0600000101010101" pitchFamily="50" charset="-127"/>
-              </a:rPr>
-              <a:t>, JDK, </a:t>
-            </a:r>
-            <a:r>
-              <a:rPr lang="en-US" altLang="ko-KR" sz="2000" dirty="0" err="1" smtClean="0">
-                <a:latin typeface="나눔스퀘어 Bold" panose="020B0600000101010101" pitchFamily="50" charset="-127"/>
-                <a:ea typeface="나눔스퀘어 Bold" panose="020B0600000101010101" pitchFamily="50" charset="-127"/>
-              </a:rPr>
-              <a:t>Git</a:t>
-            </a:r>
-            <a:r>
-              <a:rPr lang="en-US" altLang="ko-KR" sz="2000" dirty="0" smtClean="0">
-                <a:latin typeface="나눔스퀘어 Bold" panose="020B0600000101010101" pitchFamily="50" charset="-127"/>
-                <a:ea typeface="나눔스퀘어 Bold" panose="020B0600000101010101" pitchFamily="50" charset="-127"/>
-              </a:rPr>
-              <a:t>, Build</a:t>
-            </a:r>
-            <a:endParaRPr lang="ko-KR" altLang="en-US" sz="2000" dirty="0" smtClean="0">
-              <a:latin typeface="나눔스퀘어 Bold" panose="020B0600000101010101" pitchFamily="50" charset="-127"/>
-              <a:ea typeface="나눔스퀘어 Bold" panose="020B0600000101010101" pitchFamily="50" charset="-127"/>
-            </a:endParaRPr>
-          </a:p>
-        </p:txBody>
-      </p:sp>
-      <p:sp>
-        <p:nvSpPr>
-          <p:cNvPr id="11" name="직사각형 10"/>
-          <p:cNvSpPr/>
-          <p:nvPr/>
-        </p:nvSpPr>
-        <p:spPr>
-          <a:xfrm>
-            <a:off x="4836000" y="4434214"/>
-            <a:ext cx="2520000" cy="1080000"/>
-          </a:xfrm>
-          <a:prstGeom prst="rect">
-            <a:avLst/>
-          </a:prstGeom>
-          <a:solidFill>
-            <a:schemeClr val="accent5"/>
-          </a:solidFill>
-          <a:ln>
-            <a:solidFill>
-              <a:schemeClr val="tx1"/>
-            </a:solidFill>
-          </a:ln>
-        </p:spPr>
-        <p:style>
-          <a:lnRef idx="2">
-            <a:schemeClr val="accent1">
-              <a:shade val="50000"/>
-            </a:schemeClr>
-          </a:lnRef>
-          <a:fillRef idx="1">
-            <a:schemeClr val="accent1"/>
-          </a:fillRef>
-          <a:effectRef idx="0">
-            <a:schemeClr val="accent1"/>
-          </a:effectRef>
-          <a:fontRef idx="minor">
-            <a:schemeClr val="lt1"/>
-          </a:fontRef>
-        </p:style>
-        <p:txBody>
-          <a:bodyPr rtlCol="0" anchor="ctr"/>
-          <a:lstStyle/>
-          <a:p>
-            <a:pPr algn="ctr"/>
-            <a:r>
-              <a:rPr lang="en-US" altLang="ko-KR" sz="2400" dirty="0" smtClean="0">
-                <a:latin typeface="나눔스퀘어 Bold" panose="020B0600000101010101" pitchFamily="50" charset="-127"/>
-                <a:ea typeface="나눔스퀘어 Bold" panose="020B0600000101010101" pitchFamily="50" charset="-127"/>
-              </a:rPr>
-              <a:t>Dev MySQL</a:t>
-            </a:r>
-            <a:endParaRPr lang="ko-KR" altLang="en-US" sz="2400" dirty="0">
-              <a:latin typeface="나눔스퀘어 Bold" panose="020B0600000101010101" pitchFamily="50" charset="-127"/>
-              <a:ea typeface="나눔스퀘어 Bold" panose="020B0600000101010101" pitchFamily="50" charset="-127"/>
-            </a:endParaRPr>
-          </a:p>
-        </p:txBody>
-      </p:sp>
-      <p:cxnSp>
-        <p:nvCxnSpPr>
-          <p:cNvPr id="23" name="꺾인 연결선 22"/>
-          <p:cNvCxnSpPr>
-            <a:stCxn id="4" idx="3"/>
-            <a:endCxn id="13" idx="1"/>
-          </p:cNvCxnSpPr>
-          <p:nvPr/>
-        </p:nvCxnSpPr>
-        <p:spPr>
-          <a:xfrm flipH="1" flipV="1">
-            <a:off x="7163999" y="540000"/>
-            <a:ext cx="372001" cy="2397107"/>
-          </a:xfrm>
-          <a:prstGeom prst="bentConnector5">
-            <a:avLst>
-              <a:gd name="adj1" fmla="val -142264"/>
-              <a:gd name="adj2" fmla="val 53755"/>
-              <a:gd name="adj3" fmla="val 238896"/>
-            </a:avLst>
-          </a:prstGeom>
-          <a:ln w="76200">
-            <a:solidFill>
-              <a:schemeClr val="accent2"/>
-            </a:solidFill>
-            <a:tailEnd type="triangle"/>
-          </a:ln>
-        </p:spPr>
-        <p:style>
-          <a:lnRef idx="1">
-            <a:schemeClr val="accent1"/>
-          </a:lnRef>
-          <a:fillRef idx="0">
-            <a:schemeClr val="accent1"/>
-          </a:fillRef>
-          <a:effectRef idx="0">
-            <a:schemeClr val="accent1"/>
-          </a:effectRef>
-          <a:fontRef idx="minor">
-            <a:schemeClr val="tx1"/>
-          </a:fontRef>
-        </p:style>
-      </p:cxnSp>
-      <p:sp>
-        <p:nvSpPr>
-          <p:cNvPr id="3" name="직사각형 2"/>
-          <p:cNvSpPr/>
-          <p:nvPr/>
-        </p:nvSpPr>
-        <p:spPr>
-          <a:xfrm>
-            <a:off x="2507999" y="0"/>
-            <a:ext cx="2520000" cy="1080000"/>
-          </a:xfrm>
-          <a:prstGeom prst="rect">
-            <a:avLst/>
-          </a:prstGeom>
-          <a:solidFill>
-            <a:schemeClr val="accent5"/>
-          </a:solidFill>
-          <a:ln>
-            <a:solidFill>
-              <a:schemeClr val="tx1"/>
-            </a:solidFill>
-          </a:ln>
-        </p:spPr>
-        <p:style>
-          <a:lnRef idx="2">
-            <a:schemeClr val="accent1">
-              <a:shade val="50000"/>
-            </a:schemeClr>
-          </a:lnRef>
-          <a:fillRef idx="1">
-            <a:schemeClr val="accent1"/>
-          </a:fillRef>
-          <a:effectRef idx="0">
-            <a:schemeClr val="accent1"/>
-          </a:effectRef>
-          <a:fontRef idx="minor">
-            <a:schemeClr val="lt1"/>
-          </a:fontRef>
-        </p:style>
-        <p:txBody>
-          <a:bodyPr rtlCol="0" anchor="ctr"/>
-          <a:lstStyle/>
-          <a:p>
-            <a:pPr algn="ctr"/>
-            <a:r>
-              <a:rPr lang="en-US" altLang="ko-KR" sz="2400" dirty="0" smtClean="0">
-                <a:latin typeface="나눔스퀘어 Bold" panose="020B0600000101010101" pitchFamily="50" charset="-127"/>
-                <a:ea typeface="나눔스퀘어 Bold" panose="020B0600000101010101" pitchFamily="50" charset="-127"/>
-              </a:rPr>
-              <a:t>GitHub</a:t>
-            </a:r>
-            <a:endParaRPr lang="ko-KR" altLang="en-US" sz="2400" dirty="0">
-              <a:latin typeface="나눔스퀘어 Bold" panose="020B0600000101010101" pitchFamily="50" charset="-127"/>
-              <a:ea typeface="나눔스퀘어 Bold" panose="020B0600000101010101" pitchFamily="50" charset="-127"/>
-            </a:endParaRPr>
-          </a:p>
-        </p:txBody>
-      </p:sp>
-      <p:sp>
-        <p:nvSpPr>
-          <p:cNvPr id="13" name="직사각형 12"/>
-          <p:cNvSpPr/>
-          <p:nvPr/>
-        </p:nvSpPr>
-        <p:spPr>
-          <a:xfrm>
-            <a:off x="7163999" y="0"/>
-            <a:ext cx="2520000" cy="1080000"/>
-          </a:xfrm>
-          <a:prstGeom prst="rect">
-            <a:avLst/>
-          </a:prstGeom>
-          <a:solidFill>
-            <a:schemeClr val="accent5"/>
-          </a:solidFill>
-          <a:ln>
-            <a:solidFill>
-              <a:schemeClr val="tx1"/>
-            </a:solidFill>
-          </a:ln>
-        </p:spPr>
-        <p:style>
-          <a:lnRef idx="2">
-            <a:schemeClr val="accent1">
-              <a:shade val="50000"/>
-            </a:schemeClr>
-          </a:lnRef>
-          <a:fillRef idx="1">
-            <a:schemeClr val="accent1"/>
-          </a:fillRef>
-          <a:effectRef idx="0">
-            <a:schemeClr val="accent1"/>
-          </a:effectRef>
-          <a:fontRef idx="minor">
-            <a:schemeClr val="lt1"/>
-          </a:fontRef>
-        </p:style>
-        <p:txBody>
-          <a:bodyPr rtlCol="0" anchor="ctr"/>
-          <a:lstStyle/>
-          <a:p>
-            <a:pPr algn="ctr"/>
-            <a:r>
-              <a:rPr lang="en-US" altLang="ko-KR" sz="2400" dirty="0" err="1" smtClean="0">
-                <a:latin typeface="나눔스퀘어 Bold" panose="020B0600000101010101" pitchFamily="50" charset="-127"/>
-                <a:ea typeface="나눔스퀘어 Bold" panose="020B0600000101010101" pitchFamily="50" charset="-127"/>
-              </a:rPr>
-              <a:t>DockerHub</a:t>
-            </a:r>
-            <a:endParaRPr lang="ko-KR" altLang="en-US" sz="2400" dirty="0">
-              <a:latin typeface="나눔스퀘어 Bold" panose="020B0600000101010101" pitchFamily="50" charset="-127"/>
-              <a:ea typeface="나눔스퀘어 Bold" panose="020B0600000101010101" pitchFamily="50" charset="-127"/>
-            </a:endParaRPr>
-          </a:p>
-        </p:txBody>
-      </p:sp>
-      <p:sp>
-        <p:nvSpPr>
-          <p:cNvPr id="25" name="직사각형 24"/>
-          <p:cNvSpPr/>
-          <p:nvPr/>
-        </p:nvSpPr>
-        <p:spPr>
-          <a:xfrm>
-            <a:off x="180000" y="4434214"/>
-            <a:ext cx="2520000" cy="1080000"/>
-          </a:xfrm>
-          <a:prstGeom prst="rect">
-            <a:avLst/>
-          </a:prstGeom>
-          <a:solidFill>
-            <a:schemeClr val="accent5"/>
-          </a:solidFill>
-          <a:ln>
-            <a:solidFill>
-              <a:schemeClr val="tx1"/>
-            </a:solidFill>
-          </a:ln>
-        </p:spPr>
-        <p:style>
-          <a:lnRef idx="2">
-            <a:schemeClr val="accent1">
-              <a:shade val="50000"/>
-            </a:schemeClr>
-          </a:lnRef>
-          <a:fillRef idx="1">
-            <a:schemeClr val="accent1"/>
-          </a:fillRef>
-          <a:effectRef idx="0">
-            <a:schemeClr val="accent1"/>
-          </a:effectRef>
-          <a:fontRef idx="minor">
-            <a:schemeClr val="lt1"/>
-          </a:fontRef>
-        </p:style>
-        <p:txBody>
-          <a:bodyPr rtlCol="0" anchor="ctr"/>
-          <a:lstStyle/>
-          <a:p>
-            <a:pPr algn="ctr"/>
-            <a:r>
-              <a:rPr lang="ko-KR" altLang="en-US" sz="2400" dirty="0" smtClean="0">
-                <a:latin typeface="나눔스퀘어 Bold" panose="020B0600000101010101" pitchFamily="50" charset="-127"/>
-                <a:ea typeface="나눔스퀘어 Bold" panose="020B0600000101010101" pitchFamily="50" charset="-127"/>
-              </a:rPr>
-              <a:t>개발</a:t>
-            </a:r>
-            <a:r>
-              <a:rPr lang="en-US" altLang="ko-KR" sz="2400" dirty="0" smtClean="0">
-                <a:latin typeface="나눔스퀘어 Bold" panose="020B0600000101010101" pitchFamily="50" charset="-127"/>
-                <a:ea typeface="나눔스퀘어 Bold" panose="020B0600000101010101" pitchFamily="50" charset="-127"/>
-              </a:rPr>
-              <a:t> MySQL</a:t>
-            </a:r>
-            <a:endParaRPr lang="ko-KR" altLang="en-US" sz="2400" dirty="0">
-              <a:latin typeface="나눔스퀘어 Bold" panose="020B0600000101010101" pitchFamily="50" charset="-127"/>
-              <a:ea typeface="나눔스퀘어 Bold" panose="020B0600000101010101" pitchFamily="50" charset="-127"/>
-            </a:endParaRPr>
-          </a:p>
-        </p:txBody>
-      </p:sp>
-      <p:sp>
-        <p:nvSpPr>
-          <p:cNvPr id="26" name="TextBox 25"/>
-          <p:cNvSpPr txBox="1"/>
-          <p:nvPr/>
-        </p:nvSpPr>
-        <p:spPr>
-          <a:xfrm>
-            <a:off x="5021340" y="3676328"/>
-            <a:ext cx="1999265" cy="369332"/>
-          </a:xfrm>
-          <a:prstGeom prst="rect">
-            <a:avLst/>
-          </a:prstGeom>
-          <a:noFill/>
-        </p:spPr>
-        <p:txBody>
-          <a:bodyPr wrap="none" rtlCol="0">
-            <a:spAutoFit/>
-          </a:bodyPr>
-          <a:lstStyle/>
-          <a:p>
-            <a:r>
-              <a:rPr lang="ko-KR" altLang="en-US" dirty="0" smtClean="0">
-                <a:latin typeface="나눔스퀘어 Bold" panose="020B0600000101010101" pitchFamily="50" charset="-127"/>
-                <a:ea typeface="나눔스퀘어 Bold" panose="020B0600000101010101" pitchFamily="50" charset="-127"/>
-              </a:rPr>
-              <a:t>개발팀 </a:t>
-            </a:r>
-            <a:r>
-              <a:rPr lang="en-US" altLang="ko-KR" dirty="0" smtClean="0">
-                <a:latin typeface="나눔스퀘어 Bold" panose="020B0600000101010101" pitchFamily="50" charset="-127"/>
-                <a:ea typeface="나눔스퀘어 Bold" panose="020B0600000101010101" pitchFamily="50" charset="-127"/>
-              </a:rPr>
-              <a:t>-&gt; QA(QM)</a:t>
-            </a:r>
-            <a:endParaRPr lang="ko-KR" altLang="en-US" dirty="0">
-              <a:latin typeface="나눔스퀘어 Bold" panose="020B0600000101010101" pitchFamily="50" charset="-127"/>
-              <a:ea typeface="나눔스퀘어 Bold" panose="020B0600000101010101" pitchFamily="50" charset="-127"/>
-            </a:endParaRPr>
-          </a:p>
-        </p:txBody>
-      </p:sp>
-      <p:sp>
-        <p:nvSpPr>
-          <p:cNvPr id="27" name="직사각형 26"/>
-          <p:cNvSpPr/>
-          <p:nvPr/>
-        </p:nvSpPr>
-        <p:spPr>
-          <a:xfrm>
-            <a:off x="6804000" y="1378553"/>
-            <a:ext cx="2160000" cy="540000"/>
-          </a:xfrm>
-          <a:prstGeom prst="rect">
-            <a:avLst/>
-          </a:prstGeom>
-          <a:solidFill>
-            <a:schemeClr val="accent4"/>
-          </a:solidFill>
-          <a:ln>
-            <a:solidFill>
-              <a:schemeClr val="tx1"/>
-            </a:solidFill>
-          </a:ln>
-        </p:spPr>
-        <p:style>
-          <a:lnRef idx="2">
-            <a:schemeClr val="accent1">
-              <a:shade val="50000"/>
-            </a:schemeClr>
-          </a:lnRef>
-          <a:fillRef idx="1">
-            <a:schemeClr val="accent1"/>
-          </a:fillRef>
-          <a:effectRef idx="0">
-            <a:schemeClr val="accent1"/>
-          </a:effectRef>
-          <a:fontRef idx="minor">
-            <a:schemeClr val="lt1"/>
-          </a:fontRef>
-        </p:style>
-        <p:txBody>
-          <a:bodyPr rtlCol="0" anchor="ctr"/>
-          <a:lstStyle/>
-          <a:p>
-            <a:pPr algn="ctr"/>
-            <a:r>
-              <a:rPr lang="en-US" altLang="ko-KR" dirty="0" smtClean="0">
+            <a:ln>
+              <a:solidFill>
+                <a:schemeClr val="tx1"/>
+              </a:solidFill>
+            </a:ln>
+          </p:spPr>
+          <p:style>
+            <a:lnRef idx="2">
+              <a:schemeClr val="accent1">
+                <a:shade val="50000"/>
+              </a:schemeClr>
+            </a:lnRef>
+            <a:fillRef idx="1">
+              <a:schemeClr val="accent1"/>
+            </a:fillRef>
+            <a:effectRef idx="0">
+              <a:schemeClr val="accent1"/>
+            </a:effectRef>
+            <a:fontRef idx="minor">
+              <a:schemeClr val="lt1"/>
+            </a:fontRef>
+          </p:style>
+          <p:txBody>
+            <a:bodyPr rtlCol="0" anchor="ctr"/>
+            <a:lstStyle/>
+            <a:p>
+              <a:pPr algn="ctr"/>
+              <a:r>
+                <a:rPr lang="en-US" altLang="ko-KR" dirty="0" smtClean="0">
+                  <a:solidFill>
+                    <a:schemeClr val="tx1"/>
+                  </a:solidFill>
+                  <a:latin typeface="나눔스퀘어 Bold" panose="020B0600000101010101" pitchFamily="50" charset="-127"/>
+                  <a:ea typeface="나눔스퀘어 Bold" panose="020B0600000101010101" pitchFamily="50" charset="-127"/>
+                </a:rPr>
+                <a:t>Docker Image(Jar)</a:t>
+              </a:r>
+              <a:endParaRPr lang="ko-KR" altLang="en-US" dirty="0">
                 <a:solidFill>
                   <a:schemeClr val="tx1"/>
                 </a:solidFill>
                 <a:latin typeface="나눔스퀘어 Bold" panose="020B0600000101010101" pitchFamily="50" charset="-127"/>
                 <a:ea typeface="나눔스퀘어 Bold" panose="020B0600000101010101" pitchFamily="50" charset="-127"/>
-              </a:rPr>
-              <a:t>Docker Image(Jar)</a:t>
-            </a:r>
-            <a:endParaRPr lang="ko-KR" altLang="en-US" dirty="0">
+              </a:endParaRPr>
+            </a:p>
+          </p:txBody>
+        </p:sp>
+        <p:cxnSp>
+          <p:nvCxnSpPr>
+            <p:cNvPr id="32" name="꺾인 연결선 31"/>
+            <p:cNvCxnSpPr>
+              <a:stCxn id="13" idx="3"/>
+              <a:endCxn id="6" idx="0"/>
+            </p:cNvCxnSpPr>
+            <p:nvPr/>
+          </p:nvCxnSpPr>
+          <p:spPr>
+            <a:xfrm>
+              <a:off x="9683999" y="540000"/>
+              <a:ext cx="1068001" cy="1677107"/>
+            </a:xfrm>
+            <a:prstGeom prst="bentConnector2">
+              <a:avLst/>
+            </a:prstGeom>
+            <a:ln w="76200">
+              <a:solidFill>
+                <a:schemeClr val="accent2"/>
+              </a:solidFill>
+              <a:tailEnd type="triangle"/>
+            </a:ln>
+          </p:spPr>
+          <p:style>
+            <a:lnRef idx="1">
+              <a:schemeClr val="accent1"/>
+            </a:lnRef>
+            <a:fillRef idx="0">
+              <a:schemeClr val="accent1"/>
+            </a:fillRef>
+            <a:effectRef idx="0">
+              <a:schemeClr val="accent1"/>
+            </a:effectRef>
+            <a:fontRef idx="minor">
+              <a:schemeClr val="tx1"/>
+            </a:fontRef>
+          </p:style>
+        </p:cxnSp>
+        <p:cxnSp>
+          <p:nvCxnSpPr>
+            <p:cNvPr id="35" name="꺾인 연결선 34"/>
+            <p:cNvCxnSpPr>
+              <a:stCxn id="2" idx="0"/>
+              <a:endCxn id="3" idx="1"/>
+            </p:cNvCxnSpPr>
+            <p:nvPr/>
+          </p:nvCxnSpPr>
+          <p:spPr>
+            <a:xfrm rot="5400000" flipH="1" flipV="1">
+              <a:off x="1135446" y="844555"/>
+              <a:ext cx="1677107" cy="1067999"/>
+            </a:xfrm>
+            <a:prstGeom prst="bentConnector2">
+              <a:avLst/>
+            </a:prstGeom>
+            <a:ln w="76200">
+              <a:solidFill>
+                <a:schemeClr val="accent2"/>
+              </a:solidFill>
+              <a:tailEnd type="triangle"/>
+            </a:ln>
+          </p:spPr>
+          <p:style>
+            <a:lnRef idx="1">
+              <a:schemeClr val="accent1"/>
+            </a:lnRef>
+            <a:fillRef idx="0">
+              <a:schemeClr val="accent1"/>
+            </a:fillRef>
+            <a:effectRef idx="0">
+              <a:schemeClr val="accent1"/>
+            </a:effectRef>
+            <a:fontRef idx="minor">
+              <a:schemeClr val="tx1"/>
+            </a:fontRef>
+          </p:style>
+        </p:cxnSp>
+        <p:cxnSp>
+          <p:nvCxnSpPr>
+            <p:cNvPr id="38" name="꺾인 연결선 37"/>
+            <p:cNvCxnSpPr>
+              <a:stCxn id="3" idx="3"/>
+              <a:endCxn id="4" idx="0"/>
+            </p:cNvCxnSpPr>
+            <p:nvPr/>
+          </p:nvCxnSpPr>
+          <p:spPr>
+            <a:xfrm>
+              <a:off x="5027999" y="540000"/>
+              <a:ext cx="1068001" cy="1677107"/>
+            </a:xfrm>
+            <a:prstGeom prst="bentConnector2">
+              <a:avLst/>
+            </a:prstGeom>
+            <a:ln w="76200">
+              <a:solidFill>
+                <a:schemeClr val="accent2"/>
+              </a:solidFill>
+              <a:tailEnd type="triangle"/>
+            </a:ln>
+          </p:spPr>
+          <p:style>
+            <a:lnRef idx="1">
+              <a:schemeClr val="accent1"/>
+            </a:lnRef>
+            <a:fillRef idx="0">
+              <a:schemeClr val="accent1"/>
+            </a:fillRef>
+            <a:effectRef idx="0">
+              <a:schemeClr val="accent1"/>
+            </a:effectRef>
+            <a:fontRef idx="minor">
+              <a:schemeClr val="tx1"/>
+            </a:fontRef>
+          </p:style>
+        </p:cxnSp>
+        <p:sp>
+          <p:nvSpPr>
+            <p:cNvPr id="41" name="직사각형 40"/>
+            <p:cNvSpPr/>
+            <p:nvPr/>
+          </p:nvSpPr>
+          <p:spPr>
+            <a:xfrm>
+              <a:off x="9672000" y="3423551"/>
+              <a:ext cx="2160000" cy="540000"/>
+            </a:xfrm>
+            <a:prstGeom prst="rect">
+              <a:avLst/>
+            </a:prstGeom>
+            <a:solidFill>
+              <a:schemeClr val="accent4"/>
+            </a:solidFill>
+            <a:ln>
               <a:solidFill>
                 <a:schemeClr val="tx1"/>
               </a:solidFill>
-              <a:latin typeface="나눔스퀘어 Bold" panose="020B0600000101010101" pitchFamily="50" charset="-127"/>
-              <a:ea typeface="나눔스퀘어 Bold" panose="020B0600000101010101" pitchFamily="50" charset="-127"/>
-            </a:endParaRPr>
-          </a:p>
-        </p:txBody>
-      </p:sp>
-      <p:cxnSp>
-        <p:nvCxnSpPr>
-          <p:cNvPr id="32" name="꺾인 연결선 31"/>
-          <p:cNvCxnSpPr>
-            <a:stCxn id="13" idx="3"/>
-            <a:endCxn id="6" idx="0"/>
-          </p:cNvCxnSpPr>
-          <p:nvPr/>
-        </p:nvCxnSpPr>
-        <p:spPr>
-          <a:xfrm>
-            <a:off x="9683999" y="540000"/>
-            <a:ext cx="1068001" cy="1677107"/>
-          </a:xfrm>
-          <a:prstGeom prst="bentConnector2">
-            <a:avLst/>
-          </a:prstGeom>
-          <a:ln w="76200">
-            <a:solidFill>
-              <a:schemeClr val="accent2"/>
-            </a:solidFill>
-            <a:tailEnd type="triangle"/>
-          </a:ln>
-        </p:spPr>
-        <p:style>
-          <a:lnRef idx="1">
-            <a:schemeClr val="accent1"/>
-          </a:lnRef>
-          <a:fillRef idx="0">
-            <a:schemeClr val="accent1"/>
-          </a:fillRef>
-          <a:effectRef idx="0">
-            <a:schemeClr val="accent1"/>
-          </a:effectRef>
-          <a:fontRef idx="minor">
-            <a:schemeClr val="tx1"/>
-          </a:fontRef>
-        </p:style>
-      </p:cxnSp>
-      <p:cxnSp>
-        <p:nvCxnSpPr>
-          <p:cNvPr id="35" name="꺾인 연결선 34"/>
-          <p:cNvCxnSpPr>
-            <a:stCxn id="2" idx="0"/>
-            <a:endCxn id="3" idx="1"/>
-          </p:cNvCxnSpPr>
-          <p:nvPr/>
-        </p:nvCxnSpPr>
-        <p:spPr>
-          <a:xfrm rot="5400000" flipH="1" flipV="1">
-            <a:off x="1135446" y="844555"/>
-            <a:ext cx="1677107" cy="1067999"/>
-          </a:xfrm>
-          <a:prstGeom prst="bentConnector2">
-            <a:avLst/>
-          </a:prstGeom>
-          <a:ln w="76200">
-            <a:solidFill>
-              <a:schemeClr val="accent2"/>
-            </a:solidFill>
-            <a:tailEnd type="triangle"/>
-          </a:ln>
-        </p:spPr>
-        <p:style>
-          <a:lnRef idx="1">
-            <a:schemeClr val="accent1"/>
-          </a:lnRef>
-          <a:fillRef idx="0">
-            <a:schemeClr val="accent1"/>
-          </a:fillRef>
-          <a:effectRef idx="0">
-            <a:schemeClr val="accent1"/>
-          </a:effectRef>
-          <a:fontRef idx="minor">
-            <a:schemeClr val="tx1"/>
-          </a:fontRef>
-        </p:style>
-      </p:cxnSp>
-      <p:cxnSp>
-        <p:nvCxnSpPr>
-          <p:cNvPr id="38" name="꺾인 연결선 37"/>
-          <p:cNvCxnSpPr>
-            <a:stCxn id="3" idx="3"/>
-            <a:endCxn id="4" idx="0"/>
-          </p:cNvCxnSpPr>
-          <p:nvPr/>
-        </p:nvCxnSpPr>
-        <p:spPr>
-          <a:xfrm>
-            <a:off x="5027999" y="540000"/>
-            <a:ext cx="1068001" cy="1677107"/>
-          </a:xfrm>
-          <a:prstGeom prst="bentConnector2">
-            <a:avLst/>
-          </a:prstGeom>
-          <a:ln w="76200">
-            <a:solidFill>
-              <a:schemeClr val="accent2"/>
-            </a:solidFill>
-            <a:tailEnd type="triangle"/>
-          </a:ln>
-        </p:spPr>
-        <p:style>
-          <a:lnRef idx="1">
-            <a:schemeClr val="accent1"/>
-          </a:lnRef>
-          <a:fillRef idx="0">
-            <a:schemeClr val="accent1"/>
-          </a:fillRef>
-          <a:effectRef idx="0">
-            <a:schemeClr val="accent1"/>
-          </a:effectRef>
-          <a:fontRef idx="minor">
-            <a:schemeClr val="tx1"/>
-          </a:fontRef>
-        </p:style>
-      </p:cxnSp>
-      <p:sp>
-        <p:nvSpPr>
-          <p:cNvPr id="41" name="직사각형 40"/>
-          <p:cNvSpPr/>
-          <p:nvPr/>
-        </p:nvSpPr>
-        <p:spPr>
-          <a:xfrm>
-            <a:off x="9672000" y="3423551"/>
-            <a:ext cx="2160000" cy="540000"/>
-          </a:xfrm>
-          <a:prstGeom prst="rect">
-            <a:avLst/>
-          </a:prstGeom>
-          <a:solidFill>
-            <a:schemeClr val="accent4"/>
-          </a:solidFill>
-          <a:ln>
-            <a:solidFill>
-              <a:schemeClr val="tx1"/>
-            </a:solidFill>
-          </a:ln>
-        </p:spPr>
-        <p:style>
-          <a:lnRef idx="2">
-            <a:schemeClr val="accent1">
-              <a:shade val="50000"/>
-            </a:schemeClr>
-          </a:lnRef>
-          <a:fillRef idx="1">
-            <a:schemeClr val="accent1"/>
-          </a:fillRef>
-          <a:effectRef idx="0">
-            <a:schemeClr val="accent1"/>
-          </a:effectRef>
-          <a:fontRef idx="minor">
-            <a:schemeClr val="lt1"/>
-          </a:fontRef>
-        </p:style>
-        <p:txBody>
-          <a:bodyPr rtlCol="0" anchor="ctr"/>
-          <a:lstStyle/>
-          <a:p>
-            <a:pPr algn="ctr"/>
-            <a:r>
-              <a:rPr lang="en-US" altLang="ko-KR" dirty="0" smtClean="0">
+            </a:ln>
+          </p:spPr>
+          <p:style>
+            <a:lnRef idx="2">
+              <a:schemeClr val="accent1">
+                <a:shade val="50000"/>
+              </a:schemeClr>
+            </a:lnRef>
+            <a:fillRef idx="1">
+              <a:schemeClr val="accent1"/>
+            </a:fillRef>
+            <a:effectRef idx="0">
+              <a:schemeClr val="accent1"/>
+            </a:effectRef>
+            <a:fontRef idx="minor">
+              <a:schemeClr val="lt1"/>
+            </a:fontRef>
+          </p:style>
+          <p:txBody>
+            <a:bodyPr rtlCol="0" anchor="ctr"/>
+            <a:lstStyle/>
+            <a:p>
+              <a:pPr algn="ctr"/>
+              <a:r>
+                <a:rPr lang="en-US" altLang="ko-KR" dirty="0" smtClean="0">
+                  <a:solidFill>
+                    <a:schemeClr val="tx1"/>
+                  </a:solidFill>
+                  <a:latin typeface="나눔스퀘어 Bold" panose="020B0600000101010101" pitchFamily="50" charset="-127"/>
+                  <a:ea typeface="나눔스퀘어 Bold" panose="020B0600000101010101" pitchFamily="50" charset="-127"/>
+                </a:rPr>
+                <a:t>Docker Image(Jar)</a:t>
+              </a:r>
+              <a:endParaRPr lang="ko-KR" altLang="en-US" dirty="0">
                 <a:solidFill>
                   <a:schemeClr val="tx1"/>
                 </a:solidFill>
                 <a:latin typeface="나눔스퀘어 Bold" panose="020B0600000101010101" pitchFamily="50" charset="-127"/>
                 <a:ea typeface="나눔스퀘어 Bold" panose="020B0600000101010101" pitchFamily="50" charset="-127"/>
-              </a:rPr>
-              <a:t>Docker Image(Jar)</a:t>
-            </a:r>
-            <a:endParaRPr lang="ko-KR" altLang="en-US" dirty="0">
+              </a:endParaRPr>
+            </a:p>
+          </p:txBody>
+        </p:sp>
+        <p:sp>
+          <p:nvSpPr>
+            <p:cNvPr id="42" name="직사각형 41"/>
+            <p:cNvSpPr/>
+            <p:nvPr/>
+          </p:nvSpPr>
+          <p:spPr>
+            <a:xfrm>
+              <a:off x="123372" y="2354993"/>
+              <a:ext cx="2880000" cy="1440000"/>
+            </a:xfrm>
+            <a:prstGeom prst="rect">
+              <a:avLst/>
+            </a:prstGeom>
+            <a:solidFill>
+              <a:schemeClr val="accent5"/>
+            </a:solidFill>
+            <a:ln>
               <a:solidFill>
                 <a:schemeClr val="tx1"/>
               </a:solidFill>
-              <a:latin typeface="나눔스퀘어 Bold" panose="020B0600000101010101" pitchFamily="50" charset="-127"/>
-              <a:ea typeface="나눔스퀘어 Bold" panose="020B0600000101010101" pitchFamily="50" charset="-127"/>
-            </a:endParaRPr>
-          </a:p>
-        </p:txBody>
-      </p:sp>
-      <p:sp>
-        <p:nvSpPr>
-          <p:cNvPr id="42" name="직사각형 41"/>
-          <p:cNvSpPr/>
-          <p:nvPr/>
-        </p:nvSpPr>
-        <p:spPr>
-          <a:xfrm>
-            <a:off x="123372" y="2354993"/>
-            <a:ext cx="2880000" cy="1440000"/>
-          </a:xfrm>
-          <a:prstGeom prst="rect">
-            <a:avLst/>
-          </a:prstGeom>
-          <a:solidFill>
-            <a:schemeClr val="accent5"/>
-          </a:solidFill>
-          <a:ln>
+            </a:ln>
+          </p:spPr>
+          <p:style>
+            <a:lnRef idx="2">
+              <a:schemeClr val="accent1">
+                <a:shade val="50000"/>
+              </a:schemeClr>
+            </a:lnRef>
+            <a:fillRef idx="1">
+              <a:schemeClr val="accent1"/>
+            </a:fillRef>
+            <a:effectRef idx="0">
+              <a:schemeClr val="accent1"/>
+            </a:effectRef>
+            <a:fontRef idx="minor">
+              <a:schemeClr val="lt1"/>
+            </a:fontRef>
+          </p:style>
+          <p:txBody>
+            <a:bodyPr rtlCol="0" anchor="ctr"/>
+            <a:lstStyle/>
+            <a:p>
+              <a:pPr algn="ctr"/>
+              <a:r>
+                <a:rPr lang="ko-KR" altLang="en-US" sz="2400" dirty="0" smtClean="0">
+                  <a:latin typeface="나눔스퀘어 Bold" panose="020B0600000101010101" pitchFamily="50" charset="-127"/>
+                  <a:ea typeface="나눔스퀘어 Bold" panose="020B0600000101010101" pitchFamily="50" charset="-127"/>
+                </a:rPr>
+                <a:t>개발</a:t>
+              </a:r>
+              <a:r>
+                <a:rPr lang="en-US" altLang="ko-KR" sz="2400" dirty="0" smtClean="0">
+                  <a:latin typeface="나눔스퀘어 Bold" panose="020B0600000101010101" pitchFamily="50" charset="-127"/>
+                  <a:ea typeface="나눔스퀘어 Bold" panose="020B0600000101010101" pitchFamily="50" charset="-127"/>
+                </a:rPr>
+                <a:t>PC(Local)</a:t>
+              </a:r>
+            </a:p>
+            <a:p>
+              <a:pPr algn="ctr"/>
+              <a:r>
+                <a:rPr lang="en-US" altLang="ko-KR" sz="2400" dirty="0" smtClean="0">
+                  <a:latin typeface="나눔스퀘어 Bold" panose="020B0600000101010101" pitchFamily="50" charset="-127"/>
+                  <a:ea typeface="나눔스퀘어 Bold" panose="020B0600000101010101" pitchFamily="50" charset="-127"/>
+                </a:rPr>
+                <a:t>JDK, </a:t>
+              </a:r>
+              <a:r>
+                <a:rPr lang="en-US" altLang="ko-KR" sz="2400" dirty="0" err="1" smtClean="0">
+                  <a:latin typeface="나눔스퀘어 Bold" panose="020B0600000101010101" pitchFamily="50" charset="-127"/>
+                  <a:ea typeface="나눔스퀘어 Bold" panose="020B0600000101010101" pitchFamily="50" charset="-127"/>
+                </a:rPr>
+                <a:t>Git</a:t>
+              </a:r>
+              <a:r>
+                <a:rPr lang="en-US" altLang="ko-KR" sz="2400" dirty="0" smtClean="0">
+                  <a:latin typeface="나눔스퀘어 Bold" panose="020B0600000101010101" pitchFamily="50" charset="-127"/>
+                  <a:ea typeface="나눔스퀘어 Bold" panose="020B0600000101010101" pitchFamily="50" charset="-127"/>
+                </a:rPr>
+                <a:t>, MySQL</a:t>
+              </a:r>
+              <a:endParaRPr lang="ko-KR" altLang="en-US" sz="2400" dirty="0">
+                <a:latin typeface="나눔스퀘어 Bold" panose="020B0600000101010101" pitchFamily="50" charset="-127"/>
+                <a:ea typeface="나눔스퀘어 Bold" panose="020B0600000101010101" pitchFamily="50" charset="-127"/>
+              </a:endParaRPr>
+            </a:p>
+          </p:txBody>
+        </p:sp>
+        <p:sp>
+          <p:nvSpPr>
+            <p:cNvPr id="43" name="직사각형 42"/>
+            <p:cNvSpPr/>
+            <p:nvPr/>
+          </p:nvSpPr>
+          <p:spPr>
+            <a:xfrm>
+              <a:off x="290286" y="2492879"/>
+              <a:ext cx="2880000" cy="1440000"/>
+            </a:xfrm>
+            <a:prstGeom prst="rect">
+              <a:avLst/>
+            </a:prstGeom>
             <a:solidFill>
-              <a:schemeClr val="tx1"/>
+              <a:schemeClr val="accent5"/>
             </a:solidFill>
-          </a:ln>
-        </p:spPr>
-        <p:style>
-          <a:lnRef idx="2">
-            <a:schemeClr val="accent1">
-              <a:shade val="50000"/>
-            </a:schemeClr>
-          </a:lnRef>
-          <a:fillRef idx="1">
-            <a:schemeClr val="accent1"/>
-          </a:fillRef>
-          <a:effectRef idx="0">
-            <a:schemeClr val="accent1"/>
-          </a:effectRef>
-          <a:fontRef idx="minor">
-            <a:schemeClr val="lt1"/>
-          </a:fontRef>
-        </p:style>
-        <p:txBody>
-          <a:bodyPr rtlCol="0" anchor="ctr"/>
-          <a:lstStyle/>
-          <a:p>
-            <a:pPr algn="ctr"/>
-            <a:r>
-              <a:rPr lang="ko-KR" altLang="en-US" sz="2400" dirty="0" smtClean="0">
-                <a:latin typeface="나눔스퀘어 Bold" panose="020B0600000101010101" pitchFamily="50" charset="-127"/>
-                <a:ea typeface="나눔스퀘어 Bold" panose="020B0600000101010101" pitchFamily="50" charset="-127"/>
-              </a:rPr>
-              <a:t>개발</a:t>
-            </a:r>
-            <a:r>
-              <a:rPr lang="en-US" altLang="ko-KR" sz="2400" dirty="0" smtClean="0">
-                <a:latin typeface="나눔스퀘어 Bold" panose="020B0600000101010101" pitchFamily="50" charset="-127"/>
-                <a:ea typeface="나눔스퀘어 Bold" panose="020B0600000101010101" pitchFamily="50" charset="-127"/>
-              </a:rPr>
-              <a:t>PC(Local)</a:t>
-            </a:r>
-          </a:p>
-          <a:p>
-            <a:pPr algn="ctr"/>
-            <a:r>
-              <a:rPr lang="en-US" altLang="ko-KR" sz="2400" dirty="0" smtClean="0">
-                <a:latin typeface="나눔스퀘어 Bold" panose="020B0600000101010101" pitchFamily="50" charset="-127"/>
-                <a:ea typeface="나눔스퀘어 Bold" panose="020B0600000101010101" pitchFamily="50" charset="-127"/>
-              </a:rPr>
-              <a:t>JDK, </a:t>
-            </a:r>
-            <a:r>
-              <a:rPr lang="en-US" altLang="ko-KR" sz="2400" dirty="0" err="1" smtClean="0">
-                <a:latin typeface="나눔스퀘어 Bold" panose="020B0600000101010101" pitchFamily="50" charset="-127"/>
-                <a:ea typeface="나눔스퀘어 Bold" panose="020B0600000101010101" pitchFamily="50" charset="-127"/>
-              </a:rPr>
-              <a:t>Git</a:t>
-            </a:r>
-            <a:r>
-              <a:rPr lang="en-US" altLang="ko-KR" sz="2400" dirty="0" smtClean="0">
-                <a:latin typeface="나눔스퀘어 Bold" panose="020B0600000101010101" pitchFamily="50" charset="-127"/>
-                <a:ea typeface="나눔스퀘어 Bold" panose="020B0600000101010101" pitchFamily="50" charset="-127"/>
-              </a:rPr>
-              <a:t>, MySQL</a:t>
-            </a:r>
-            <a:endParaRPr lang="ko-KR" altLang="en-US" sz="2400" dirty="0">
-              <a:latin typeface="나눔스퀘어 Bold" panose="020B0600000101010101" pitchFamily="50" charset="-127"/>
-              <a:ea typeface="나눔스퀘어 Bold" panose="020B0600000101010101" pitchFamily="50" charset="-127"/>
-            </a:endParaRPr>
-          </a:p>
-        </p:txBody>
-      </p:sp>
-      <p:sp>
-        <p:nvSpPr>
-          <p:cNvPr id="43" name="직사각형 42"/>
-          <p:cNvSpPr/>
-          <p:nvPr/>
-        </p:nvSpPr>
-        <p:spPr>
-          <a:xfrm>
-            <a:off x="290286" y="2492879"/>
-            <a:ext cx="2880000" cy="1440000"/>
-          </a:xfrm>
-          <a:prstGeom prst="rect">
-            <a:avLst/>
-          </a:prstGeom>
-          <a:solidFill>
-            <a:schemeClr val="accent5"/>
-          </a:solidFill>
-          <a:ln>
+            <a:ln>
+              <a:solidFill>
+                <a:schemeClr val="tx1"/>
+              </a:solidFill>
+            </a:ln>
+          </p:spPr>
+          <p:style>
+            <a:lnRef idx="2">
+              <a:schemeClr val="accent1">
+                <a:shade val="50000"/>
+              </a:schemeClr>
+            </a:lnRef>
+            <a:fillRef idx="1">
+              <a:schemeClr val="accent1"/>
+            </a:fillRef>
+            <a:effectRef idx="0">
+              <a:schemeClr val="accent1"/>
+            </a:effectRef>
+            <a:fontRef idx="minor">
+              <a:schemeClr val="lt1"/>
+            </a:fontRef>
+          </p:style>
+          <p:txBody>
+            <a:bodyPr rtlCol="0" anchor="ctr"/>
+            <a:lstStyle/>
+            <a:p>
+              <a:pPr algn="ctr"/>
+              <a:r>
+                <a:rPr lang="ko-KR" altLang="en-US" sz="2400" dirty="0" smtClean="0">
+                  <a:latin typeface="나눔스퀘어 Bold" panose="020B0600000101010101" pitchFamily="50" charset="-127"/>
+                  <a:ea typeface="나눔스퀘어 Bold" panose="020B0600000101010101" pitchFamily="50" charset="-127"/>
+                </a:rPr>
+                <a:t>개발</a:t>
+              </a:r>
+              <a:r>
+                <a:rPr lang="en-US" altLang="ko-KR" sz="2400" dirty="0" smtClean="0">
+                  <a:latin typeface="나눔스퀘어 Bold" panose="020B0600000101010101" pitchFamily="50" charset="-127"/>
+                  <a:ea typeface="나눔스퀘어 Bold" panose="020B0600000101010101" pitchFamily="50" charset="-127"/>
+                </a:rPr>
+                <a:t>PC(Local)</a:t>
+              </a:r>
+            </a:p>
+            <a:p>
+              <a:pPr algn="ctr"/>
+              <a:r>
+                <a:rPr lang="en-US" altLang="ko-KR" sz="2400" dirty="0" smtClean="0">
+                  <a:latin typeface="나눔스퀘어 Bold" panose="020B0600000101010101" pitchFamily="50" charset="-127"/>
+                  <a:ea typeface="나눔스퀘어 Bold" panose="020B0600000101010101" pitchFamily="50" charset="-127"/>
+                </a:rPr>
+                <a:t>JDK, </a:t>
+              </a:r>
+              <a:r>
+                <a:rPr lang="en-US" altLang="ko-KR" sz="2400" dirty="0" err="1" smtClean="0">
+                  <a:latin typeface="나눔스퀘어 Bold" panose="020B0600000101010101" pitchFamily="50" charset="-127"/>
+                  <a:ea typeface="나눔스퀘어 Bold" panose="020B0600000101010101" pitchFamily="50" charset="-127"/>
+                </a:rPr>
+                <a:t>Git</a:t>
+              </a:r>
+              <a:r>
+                <a:rPr lang="en-US" altLang="ko-KR" sz="2400" dirty="0" smtClean="0">
+                  <a:latin typeface="나눔스퀘어 Bold" panose="020B0600000101010101" pitchFamily="50" charset="-127"/>
+                  <a:ea typeface="나눔스퀘어 Bold" panose="020B0600000101010101" pitchFamily="50" charset="-127"/>
+                </a:rPr>
+                <a:t>, MySQL</a:t>
+              </a:r>
+              <a:endParaRPr lang="ko-KR" altLang="en-US" sz="2400" dirty="0">
+                <a:latin typeface="나눔스퀘어 Bold" panose="020B0600000101010101" pitchFamily="50" charset="-127"/>
+                <a:ea typeface="나눔스퀘어 Bold" panose="020B0600000101010101" pitchFamily="50" charset="-127"/>
+              </a:endParaRPr>
+            </a:p>
+          </p:txBody>
+        </p:sp>
+        <p:sp>
+          <p:nvSpPr>
+            <p:cNvPr id="44" name="직사각형 43"/>
+            <p:cNvSpPr/>
+            <p:nvPr/>
+          </p:nvSpPr>
+          <p:spPr>
+            <a:xfrm>
+              <a:off x="9780858" y="3546923"/>
+              <a:ext cx="2160000" cy="540000"/>
+            </a:xfrm>
+            <a:prstGeom prst="rect">
+              <a:avLst/>
+            </a:prstGeom>
             <a:solidFill>
-              <a:schemeClr val="tx1"/>
+              <a:schemeClr val="accent4"/>
             </a:solidFill>
-          </a:ln>
-        </p:spPr>
-        <p:style>
-          <a:lnRef idx="2">
-            <a:schemeClr val="accent1">
-              <a:shade val="50000"/>
-            </a:schemeClr>
-          </a:lnRef>
-          <a:fillRef idx="1">
-            <a:schemeClr val="accent1"/>
-          </a:fillRef>
-          <a:effectRef idx="0">
-            <a:schemeClr val="accent1"/>
-          </a:effectRef>
-          <a:fontRef idx="minor">
-            <a:schemeClr val="lt1"/>
-          </a:fontRef>
-        </p:style>
-        <p:txBody>
-          <a:bodyPr rtlCol="0" anchor="ctr"/>
-          <a:lstStyle/>
-          <a:p>
-            <a:pPr algn="ctr"/>
-            <a:r>
-              <a:rPr lang="ko-KR" altLang="en-US" sz="2400" dirty="0" smtClean="0">
-                <a:latin typeface="나눔스퀘어 Bold" panose="020B0600000101010101" pitchFamily="50" charset="-127"/>
-                <a:ea typeface="나눔스퀘어 Bold" panose="020B0600000101010101" pitchFamily="50" charset="-127"/>
-              </a:rPr>
-              <a:t>개발</a:t>
-            </a:r>
-            <a:r>
-              <a:rPr lang="en-US" altLang="ko-KR" sz="2400" dirty="0" smtClean="0">
-                <a:latin typeface="나눔스퀘어 Bold" panose="020B0600000101010101" pitchFamily="50" charset="-127"/>
-                <a:ea typeface="나눔스퀘어 Bold" panose="020B0600000101010101" pitchFamily="50" charset="-127"/>
-              </a:rPr>
-              <a:t>PC(Local)</a:t>
-            </a:r>
-          </a:p>
-          <a:p>
-            <a:pPr algn="ctr"/>
-            <a:r>
-              <a:rPr lang="en-US" altLang="ko-KR" sz="2400" dirty="0" smtClean="0">
-                <a:latin typeface="나눔스퀘어 Bold" panose="020B0600000101010101" pitchFamily="50" charset="-127"/>
-                <a:ea typeface="나눔스퀘어 Bold" panose="020B0600000101010101" pitchFamily="50" charset="-127"/>
-              </a:rPr>
-              <a:t>JDK, </a:t>
-            </a:r>
-            <a:r>
-              <a:rPr lang="en-US" altLang="ko-KR" sz="2400" dirty="0" err="1" smtClean="0">
-                <a:latin typeface="나눔스퀘어 Bold" panose="020B0600000101010101" pitchFamily="50" charset="-127"/>
-                <a:ea typeface="나눔스퀘어 Bold" panose="020B0600000101010101" pitchFamily="50" charset="-127"/>
-              </a:rPr>
-              <a:t>Git</a:t>
-            </a:r>
-            <a:r>
-              <a:rPr lang="en-US" altLang="ko-KR" sz="2400" dirty="0" smtClean="0">
-                <a:latin typeface="나눔스퀘어 Bold" panose="020B0600000101010101" pitchFamily="50" charset="-127"/>
-                <a:ea typeface="나눔스퀘어 Bold" panose="020B0600000101010101" pitchFamily="50" charset="-127"/>
-              </a:rPr>
-              <a:t>, MySQL</a:t>
-            </a:r>
-            <a:endParaRPr lang="ko-KR" altLang="en-US" sz="2400" dirty="0">
-              <a:latin typeface="나눔스퀘어 Bold" panose="020B0600000101010101" pitchFamily="50" charset="-127"/>
-              <a:ea typeface="나눔스퀘어 Bold" panose="020B0600000101010101" pitchFamily="50" charset="-127"/>
-            </a:endParaRPr>
-          </a:p>
-        </p:txBody>
-      </p:sp>
-      <p:sp>
-        <p:nvSpPr>
-          <p:cNvPr id="44" name="직사각형 43"/>
-          <p:cNvSpPr/>
-          <p:nvPr/>
-        </p:nvSpPr>
-        <p:spPr>
-          <a:xfrm>
-            <a:off x="9780858" y="3546923"/>
-            <a:ext cx="2160000" cy="540000"/>
-          </a:xfrm>
-          <a:prstGeom prst="rect">
-            <a:avLst/>
-          </a:prstGeom>
-          <a:solidFill>
-            <a:schemeClr val="accent4"/>
-          </a:solidFill>
-          <a:ln>
-            <a:solidFill>
-              <a:schemeClr val="tx1"/>
-            </a:solidFill>
-          </a:ln>
-        </p:spPr>
-        <p:style>
-          <a:lnRef idx="2">
-            <a:schemeClr val="accent1">
-              <a:shade val="50000"/>
-            </a:schemeClr>
-          </a:lnRef>
-          <a:fillRef idx="1">
-            <a:schemeClr val="accent1"/>
-          </a:fillRef>
-          <a:effectRef idx="0">
-            <a:schemeClr val="accent1"/>
-          </a:effectRef>
-          <a:fontRef idx="minor">
-            <a:schemeClr val="lt1"/>
-          </a:fontRef>
-        </p:style>
-        <p:txBody>
-          <a:bodyPr rtlCol="0" anchor="ctr"/>
-          <a:lstStyle/>
-          <a:p>
-            <a:pPr algn="ctr"/>
-            <a:r>
-              <a:rPr lang="en-US" altLang="ko-KR" dirty="0" smtClean="0">
+            <a:ln>
+              <a:solidFill>
+                <a:schemeClr val="tx1"/>
+              </a:solidFill>
+            </a:ln>
+          </p:spPr>
+          <p:style>
+            <a:lnRef idx="2">
+              <a:schemeClr val="accent1">
+                <a:shade val="50000"/>
+              </a:schemeClr>
+            </a:lnRef>
+            <a:fillRef idx="1">
+              <a:schemeClr val="accent1"/>
+            </a:fillRef>
+            <a:effectRef idx="0">
+              <a:schemeClr val="accent1"/>
+            </a:effectRef>
+            <a:fontRef idx="minor">
+              <a:schemeClr val="lt1"/>
+            </a:fontRef>
+          </p:style>
+          <p:txBody>
+            <a:bodyPr rtlCol="0" anchor="ctr"/>
+            <a:lstStyle/>
+            <a:p>
+              <a:pPr algn="ctr"/>
+              <a:r>
+                <a:rPr lang="en-US" altLang="ko-KR" dirty="0" smtClean="0">
+                  <a:solidFill>
+                    <a:schemeClr val="tx1"/>
+                  </a:solidFill>
+                  <a:latin typeface="나눔스퀘어 Bold" panose="020B0600000101010101" pitchFamily="50" charset="-127"/>
+                  <a:ea typeface="나눔스퀘어 Bold" panose="020B0600000101010101" pitchFamily="50" charset="-127"/>
+                </a:rPr>
+                <a:t>Docker Image(Jar)</a:t>
+              </a:r>
+              <a:endParaRPr lang="ko-KR" altLang="en-US" dirty="0">
                 <a:solidFill>
                   <a:schemeClr val="tx1"/>
                 </a:solidFill>
                 <a:latin typeface="나눔스퀘어 Bold" panose="020B0600000101010101" pitchFamily="50" charset="-127"/>
                 <a:ea typeface="나눔스퀘어 Bold" panose="020B0600000101010101" pitchFamily="50" charset="-127"/>
-              </a:rPr>
-              <a:t>Docker Image(Jar)</a:t>
-            </a:r>
-            <a:endParaRPr lang="ko-KR" altLang="en-US" dirty="0">
+              </a:endParaRPr>
+            </a:p>
+          </p:txBody>
+        </p:sp>
+        <p:sp>
+          <p:nvSpPr>
+            <p:cNvPr id="45" name="직사각형 44"/>
+            <p:cNvSpPr/>
+            <p:nvPr/>
+          </p:nvSpPr>
+          <p:spPr>
+            <a:xfrm>
+              <a:off x="9904230" y="3670295"/>
+              <a:ext cx="2160000" cy="540000"/>
+            </a:xfrm>
+            <a:prstGeom prst="rect">
+              <a:avLst/>
+            </a:prstGeom>
+            <a:solidFill>
+              <a:schemeClr val="accent4"/>
+            </a:solidFill>
+            <a:ln>
               <a:solidFill>
                 <a:schemeClr val="tx1"/>
               </a:solidFill>
-              <a:latin typeface="나눔스퀘어 Bold" panose="020B0600000101010101" pitchFamily="50" charset="-127"/>
-              <a:ea typeface="나눔스퀘어 Bold" panose="020B0600000101010101" pitchFamily="50" charset="-127"/>
-            </a:endParaRPr>
-          </a:p>
-        </p:txBody>
-      </p:sp>
-      <p:sp>
-        <p:nvSpPr>
-          <p:cNvPr id="45" name="직사각형 44"/>
-          <p:cNvSpPr/>
-          <p:nvPr/>
-        </p:nvSpPr>
-        <p:spPr>
-          <a:xfrm>
-            <a:off x="9904230" y="3670295"/>
-            <a:ext cx="2160000" cy="540000"/>
-          </a:xfrm>
-          <a:prstGeom prst="rect">
-            <a:avLst/>
-          </a:prstGeom>
-          <a:solidFill>
-            <a:schemeClr val="accent4"/>
-          </a:solidFill>
-          <a:ln>
-            <a:solidFill>
-              <a:schemeClr val="tx1"/>
-            </a:solidFill>
-          </a:ln>
-        </p:spPr>
-        <p:style>
-          <a:lnRef idx="2">
-            <a:schemeClr val="accent1">
-              <a:shade val="50000"/>
-            </a:schemeClr>
-          </a:lnRef>
-          <a:fillRef idx="1">
-            <a:schemeClr val="accent1"/>
-          </a:fillRef>
-          <a:effectRef idx="0">
-            <a:schemeClr val="accent1"/>
-          </a:effectRef>
-          <a:fontRef idx="minor">
-            <a:schemeClr val="lt1"/>
-          </a:fontRef>
-        </p:style>
-        <p:txBody>
-          <a:bodyPr rtlCol="0" anchor="ctr"/>
-          <a:lstStyle/>
-          <a:p>
-            <a:pPr algn="ctr"/>
-            <a:r>
-              <a:rPr lang="en-US" altLang="ko-KR" dirty="0" smtClean="0">
+            </a:ln>
+          </p:spPr>
+          <p:style>
+            <a:lnRef idx="2">
+              <a:schemeClr val="accent1">
+                <a:shade val="50000"/>
+              </a:schemeClr>
+            </a:lnRef>
+            <a:fillRef idx="1">
+              <a:schemeClr val="accent1"/>
+            </a:fillRef>
+            <a:effectRef idx="0">
+              <a:schemeClr val="accent1"/>
+            </a:effectRef>
+            <a:fontRef idx="minor">
+              <a:schemeClr val="lt1"/>
+            </a:fontRef>
+          </p:style>
+          <p:txBody>
+            <a:bodyPr rtlCol="0" anchor="ctr"/>
+            <a:lstStyle/>
+            <a:p>
+              <a:pPr algn="ctr"/>
+              <a:r>
+                <a:rPr lang="en-US" altLang="ko-KR" dirty="0" smtClean="0">
+                  <a:solidFill>
+                    <a:schemeClr val="tx1"/>
+                  </a:solidFill>
+                  <a:latin typeface="나눔스퀘어 Bold" panose="020B0600000101010101" pitchFamily="50" charset="-127"/>
+                  <a:ea typeface="나눔스퀘어 Bold" panose="020B0600000101010101" pitchFamily="50" charset="-127"/>
+                </a:rPr>
+                <a:t>Docker Image(Jar)</a:t>
+              </a:r>
+              <a:endParaRPr lang="ko-KR" altLang="en-US" dirty="0">
                 <a:solidFill>
                   <a:schemeClr val="tx1"/>
                 </a:solidFill>
                 <a:latin typeface="나눔스퀘어 Bold" panose="020B0600000101010101" pitchFamily="50" charset="-127"/>
                 <a:ea typeface="나눔스퀘어 Bold" panose="020B0600000101010101" pitchFamily="50" charset="-127"/>
-              </a:rPr>
-              <a:t>Docker Image(Jar)</a:t>
-            </a:r>
-            <a:endParaRPr lang="ko-KR" altLang="en-US" dirty="0">
+              </a:endParaRPr>
+            </a:p>
+          </p:txBody>
+        </p:sp>
+        <p:sp>
+          <p:nvSpPr>
+            <p:cNvPr id="46" name="직사각형 45"/>
+            <p:cNvSpPr/>
+            <p:nvPr/>
+          </p:nvSpPr>
+          <p:spPr>
+            <a:xfrm>
+              <a:off x="4365714" y="1832065"/>
+              <a:ext cx="1440000" cy="720000"/>
+            </a:xfrm>
+            <a:prstGeom prst="rect">
+              <a:avLst/>
+            </a:prstGeom>
+            <a:solidFill>
+              <a:schemeClr val="accent5"/>
+            </a:solidFill>
+            <a:ln>
               <a:solidFill>
                 <a:schemeClr val="tx1"/>
               </a:solidFill>
-              <a:latin typeface="나눔스퀘어 Bold" panose="020B0600000101010101" pitchFamily="50" charset="-127"/>
-              <a:ea typeface="나눔스퀘어 Bold" panose="020B0600000101010101" pitchFamily="50" charset="-127"/>
-            </a:endParaRPr>
-          </a:p>
-        </p:txBody>
-      </p:sp>
-      <p:sp>
-        <p:nvSpPr>
-          <p:cNvPr id="46" name="직사각형 45"/>
-          <p:cNvSpPr/>
-          <p:nvPr/>
-        </p:nvSpPr>
-        <p:spPr>
-          <a:xfrm>
-            <a:off x="4365714" y="1832065"/>
-            <a:ext cx="1440000" cy="720000"/>
-          </a:xfrm>
-          <a:prstGeom prst="rect">
-            <a:avLst/>
-          </a:prstGeom>
-          <a:solidFill>
-            <a:schemeClr val="accent5"/>
-          </a:solidFill>
-          <a:ln>
+            </a:ln>
+          </p:spPr>
+          <p:style>
+            <a:lnRef idx="2">
+              <a:schemeClr val="accent1">
+                <a:shade val="50000"/>
+              </a:schemeClr>
+            </a:lnRef>
+            <a:fillRef idx="1">
+              <a:schemeClr val="accent1"/>
+            </a:fillRef>
+            <a:effectRef idx="0">
+              <a:schemeClr val="accent1"/>
+            </a:effectRef>
+            <a:fontRef idx="minor">
+              <a:schemeClr val="lt1"/>
+            </a:fontRef>
+          </p:style>
+          <p:txBody>
+            <a:bodyPr rtlCol="0" anchor="ctr"/>
+            <a:lstStyle/>
+            <a:p>
+              <a:pPr algn="ctr"/>
+              <a:r>
+                <a:rPr lang="en-US" altLang="ko-KR" sz="2400" dirty="0" err="1" smtClean="0">
+                  <a:latin typeface="나눔스퀘어 Bold" panose="020B0600000101010101" pitchFamily="50" charset="-127"/>
+                  <a:ea typeface="나눔스퀘어 Bold" panose="020B0600000101010101" pitchFamily="50" charset="-127"/>
+                </a:rPr>
+                <a:t>Ngnix</a:t>
+              </a:r>
+              <a:endParaRPr lang="ko-KR" altLang="en-US" sz="2400" dirty="0">
+                <a:latin typeface="나눔스퀘어 Bold" panose="020B0600000101010101" pitchFamily="50" charset="-127"/>
+                <a:ea typeface="나눔스퀘어 Bold" panose="020B0600000101010101" pitchFamily="50" charset="-127"/>
+              </a:endParaRPr>
+            </a:p>
+          </p:txBody>
+        </p:sp>
+        <p:sp>
+          <p:nvSpPr>
+            <p:cNvPr id="47" name="직사각형 46"/>
+            <p:cNvSpPr/>
+            <p:nvPr/>
+          </p:nvSpPr>
+          <p:spPr>
+            <a:xfrm>
+              <a:off x="11003142" y="1831043"/>
+              <a:ext cx="1440000" cy="720000"/>
+            </a:xfrm>
+            <a:prstGeom prst="rect">
+              <a:avLst/>
+            </a:prstGeom>
             <a:solidFill>
-              <a:schemeClr val="tx1"/>
+              <a:schemeClr val="accent5"/>
             </a:solidFill>
-          </a:ln>
-        </p:spPr>
-        <p:style>
-          <a:lnRef idx="2">
-            <a:schemeClr val="accent1">
-              <a:shade val="50000"/>
-            </a:schemeClr>
-          </a:lnRef>
-          <a:fillRef idx="1">
-            <a:schemeClr val="accent1"/>
-          </a:fillRef>
-          <a:effectRef idx="0">
-            <a:schemeClr val="accent1"/>
-          </a:effectRef>
-          <a:fontRef idx="minor">
-            <a:schemeClr val="lt1"/>
-          </a:fontRef>
-        </p:style>
-        <p:txBody>
-          <a:bodyPr rtlCol="0" anchor="ctr"/>
-          <a:lstStyle/>
-          <a:p>
-            <a:pPr algn="ctr"/>
-            <a:r>
-              <a:rPr lang="en-US" altLang="ko-KR" sz="2400" dirty="0" err="1" smtClean="0">
-                <a:latin typeface="나눔스퀘어 Bold" panose="020B0600000101010101" pitchFamily="50" charset="-127"/>
-                <a:ea typeface="나눔스퀘어 Bold" panose="020B0600000101010101" pitchFamily="50" charset="-127"/>
-              </a:rPr>
-              <a:t>Ngnix</a:t>
-            </a:r>
-            <a:endParaRPr lang="ko-KR" altLang="en-US" sz="2400" dirty="0">
-              <a:latin typeface="나눔스퀘어 Bold" panose="020B0600000101010101" pitchFamily="50" charset="-127"/>
-              <a:ea typeface="나눔스퀘어 Bold" panose="020B0600000101010101" pitchFamily="50" charset="-127"/>
-            </a:endParaRPr>
-          </a:p>
-        </p:txBody>
-      </p:sp>
-      <p:sp>
-        <p:nvSpPr>
-          <p:cNvPr id="47" name="직사각형 46"/>
-          <p:cNvSpPr/>
-          <p:nvPr/>
-        </p:nvSpPr>
-        <p:spPr>
-          <a:xfrm>
-            <a:off x="11003142" y="1831043"/>
-            <a:ext cx="1440000" cy="720000"/>
-          </a:xfrm>
-          <a:prstGeom prst="rect">
-            <a:avLst/>
-          </a:prstGeom>
-          <a:solidFill>
-            <a:schemeClr val="accent5"/>
-          </a:solidFill>
-          <a:ln>
+            <a:ln>
+              <a:solidFill>
+                <a:schemeClr val="tx1"/>
+              </a:solidFill>
+            </a:ln>
+          </p:spPr>
+          <p:style>
+            <a:lnRef idx="2">
+              <a:schemeClr val="accent1">
+                <a:shade val="50000"/>
+              </a:schemeClr>
+            </a:lnRef>
+            <a:fillRef idx="1">
+              <a:schemeClr val="accent1"/>
+            </a:fillRef>
+            <a:effectRef idx="0">
+              <a:schemeClr val="accent1"/>
+            </a:effectRef>
+            <a:fontRef idx="minor">
+              <a:schemeClr val="lt1"/>
+            </a:fontRef>
+          </p:style>
+          <p:txBody>
+            <a:bodyPr rtlCol="0" anchor="ctr"/>
+            <a:lstStyle/>
+            <a:p>
+              <a:pPr algn="ctr"/>
+              <a:r>
+                <a:rPr lang="en-US" altLang="ko-KR" sz="2400" dirty="0" err="1" smtClean="0">
+                  <a:latin typeface="나눔스퀘어 Bold" panose="020B0600000101010101" pitchFamily="50" charset="-127"/>
+                  <a:ea typeface="나눔스퀘어 Bold" panose="020B0600000101010101" pitchFamily="50" charset="-127"/>
+                </a:rPr>
+                <a:t>Ngnix</a:t>
+              </a:r>
+              <a:endParaRPr lang="ko-KR" altLang="en-US" sz="2400" dirty="0">
+                <a:latin typeface="나눔스퀘어 Bold" panose="020B0600000101010101" pitchFamily="50" charset="-127"/>
+                <a:ea typeface="나눔스퀘어 Bold" panose="020B0600000101010101" pitchFamily="50" charset="-127"/>
+              </a:endParaRPr>
+            </a:p>
+          </p:txBody>
+        </p:sp>
+        <p:sp>
+          <p:nvSpPr>
+            <p:cNvPr id="48" name="직사각형 47"/>
+            <p:cNvSpPr/>
+            <p:nvPr/>
+          </p:nvSpPr>
+          <p:spPr>
+            <a:xfrm>
+              <a:off x="9060858" y="1824689"/>
+              <a:ext cx="1440000" cy="720000"/>
+            </a:xfrm>
+            <a:prstGeom prst="rect">
+              <a:avLst/>
+            </a:prstGeom>
             <a:solidFill>
-              <a:schemeClr val="tx1"/>
+              <a:schemeClr val="accent5"/>
             </a:solidFill>
-          </a:ln>
-        </p:spPr>
-        <p:style>
-          <a:lnRef idx="2">
-            <a:schemeClr val="accent1">
-              <a:shade val="50000"/>
-            </a:schemeClr>
-          </a:lnRef>
-          <a:fillRef idx="1">
-            <a:schemeClr val="accent1"/>
-          </a:fillRef>
-          <a:effectRef idx="0">
-            <a:schemeClr val="accent1"/>
-          </a:effectRef>
-          <a:fontRef idx="minor">
-            <a:schemeClr val="lt1"/>
-          </a:fontRef>
-        </p:style>
-        <p:txBody>
-          <a:bodyPr rtlCol="0" anchor="ctr"/>
-          <a:lstStyle/>
-          <a:p>
-            <a:pPr algn="ctr"/>
-            <a:r>
-              <a:rPr lang="en-US" altLang="ko-KR" sz="2400" dirty="0" err="1" smtClean="0">
-                <a:latin typeface="나눔스퀘어 Bold" panose="020B0600000101010101" pitchFamily="50" charset="-127"/>
-                <a:ea typeface="나눔스퀘어 Bold" panose="020B0600000101010101" pitchFamily="50" charset="-127"/>
-              </a:rPr>
-              <a:t>Ngnix</a:t>
-            </a:r>
-            <a:endParaRPr lang="ko-KR" altLang="en-US" sz="2400" dirty="0">
-              <a:latin typeface="나눔스퀘어 Bold" panose="020B0600000101010101" pitchFamily="50" charset="-127"/>
-              <a:ea typeface="나눔스퀘어 Bold" panose="020B0600000101010101" pitchFamily="50" charset="-127"/>
-            </a:endParaRPr>
-          </a:p>
-        </p:txBody>
-      </p:sp>
-      <p:sp>
-        <p:nvSpPr>
-          <p:cNvPr id="48" name="직사각형 47"/>
-          <p:cNvSpPr/>
-          <p:nvPr/>
-        </p:nvSpPr>
-        <p:spPr>
-          <a:xfrm>
-            <a:off x="9060858" y="1824689"/>
-            <a:ext cx="1440000" cy="720000"/>
-          </a:xfrm>
-          <a:prstGeom prst="rect">
-            <a:avLst/>
-          </a:prstGeom>
-          <a:solidFill>
-            <a:schemeClr val="accent5"/>
-          </a:solidFill>
-          <a:ln>
-            <a:solidFill>
-              <a:schemeClr val="tx1"/>
-            </a:solidFill>
-          </a:ln>
-        </p:spPr>
-        <p:style>
-          <a:lnRef idx="2">
-            <a:schemeClr val="accent1">
-              <a:shade val="50000"/>
-            </a:schemeClr>
-          </a:lnRef>
-          <a:fillRef idx="1">
-            <a:schemeClr val="accent1"/>
-          </a:fillRef>
-          <a:effectRef idx="0">
-            <a:schemeClr val="accent1"/>
-          </a:effectRef>
-          <a:fontRef idx="minor">
-            <a:schemeClr val="lt1"/>
-          </a:fontRef>
-        </p:style>
-        <p:txBody>
-          <a:bodyPr rtlCol="0" anchor="ctr"/>
-          <a:lstStyle/>
-          <a:p>
-            <a:pPr algn="ctr"/>
-            <a:r>
-              <a:rPr lang="en-US" altLang="ko-KR" sz="2400" dirty="0" smtClean="0">
-                <a:latin typeface="나눔스퀘어 Bold" panose="020B0600000101010101" pitchFamily="50" charset="-127"/>
-                <a:ea typeface="나눔스퀘어 Bold" panose="020B0600000101010101" pitchFamily="50" charset="-127"/>
-              </a:rPr>
-              <a:t>DNS</a:t>
-            </a:r>
-            <a:endParaRPr lang="ko-KR" altLang="en-US" sz="2400" dirty="0">
-              <a:latin typeface="나눔스퀘어 Bold" panose="020B0600000101010101" pitchFamily="50" charset="-127"/>
-              <a:ea typeface="나눔스퀘어 Bold" panose="020B0600000101010101" pitchFamily="50" charset="-127"/>
-            </a:endParaRPr>
-          </a:p>
-        </p:txBody>
-      </p:sp>
+            <a:ln>
+              <a:solidFill>
+                <a:schemeClr val="tx1"/>
+              </a:solidFill>
+            </a:ln>
+          </p:spPr>
+          <p:style>
+            <a:lnRef idx="2">
+              <a:schemeClr val="accent1">
+                <a:shade val="50000"/>
+              </a:schemeClr>
+            </a:lnRef>
+            <a:fillRef idx="1">
+              <a:schemeClr val="accent1"/>
+            </a:fillRef>
+            <a:effectRef idx="0">
+              <a:schemeClr val="accent1"/>
+            </a:effectRef>
+            <a:fontRef idx="minor">
+              <a:schemeClr val="lt1"/>
+            </a:fontRef>
+          </p:style>
+          <p:txBody>
+            <a:bodyPr rtlCol="0" anchor="ctr"/>
+            <a:lstStyle/>
+            <a:p>
+              <a:pPr algn="ctr"/>
+              <a:r>
+                <a:rPr lang="en-US" altLang="ko-KR" sz="2400" dirty="0" smtClean="0">
+                  <a:latin typeface="나눔스퀘어 Bold" panose="020B0600000101010101" pitchFamily="50" charset="-127"/>
+                  <a:ea typeface="나눔스퀘어 Bold" panose="020B0600000101010101" pitchFamily="50" charset="-127"/>
+                </a:rPr>
+                <a:t>DNS</a:t>
+              </a:r>
+              <a:endParaRPr lang="ko-KR" altLang="en-US" sz="2400" dirty="0">
+                <a:latin typeface="나눔스퀘어 Bold" panose="020B0600000101010101" pitchFamily="50" charset="-127"/>
+                <a:ea typeface="나눔스퀘어 Bold" panose="020B0600000101010101" pitchFamily="50" charset="-127"/>
+              </a:endParaRPr>
+            </a:p>
+          </p:txBody>
+        </p:sp>
+      </p:grpSp>
     </p:spTree>
     <p:extLst>
       <p:ext uri="{BB962C8B-B14F-4D97-AF65-F5344CB8AC3E}">
@@ -4423,745 +4438,760 @@
           </a:p>
         </p:txBody>
       </p:sp>
-      <p:sp>
-        <p:nvSpPr>
-          <p:cNvPr id="6" name="직사각형 5"/>
-          <p:cNvSpPr/>
-          <p:nvPr/>
-        </p:nvSpPr>
-        <p:spPr>
+      <p:grpSp>
+        <p:nvGrpSpPr>
+          <p:cNvPr id="47" name="그룹 46"/>
+          <p:cNvGrpSpPr/>
+          <p:nvPr/>
+        </p:nvGrpSpPr>
+        <p:grpSpPr>
           <a:xfrm>
             <a:off x="1103086" y="2235200"/>
-            <a:ext cx="2160000" cy="2880000"/>
-          </a:xfrm>
-          <a:prstGeom prst="rect">
-            <a:avLst/>
-          </a:prstGeom>
-          <a:solidFill>
-            <a:schemeClr val="accent5"/>
-          </a:solidFill>
-          <a:ln>
+            <a:ext cx="10777856" cy="3512404"/>
+            <a:chOff x="1103086" y="2235200"/>
+            <a:chExt cx="10777856" cy="3512404"/>
+          </a:xfrm>
+        </p:grpSpPr>
+        <p:sp>
+          <p:nvSpPr>
+            <p:cNvPr id="6" name="직사각형 5"/>
+            <p:cNvSpPr/>
+            <p:nvPr/>
+          </p:nvSpPr>
+          <p:spPr>
+            <a:xfrm>
+              <a:off x="1103086" y="2235200"/>
+              <a:ext cx="2160000" cy="2880000"/>
+            </a:xfrm>
+            <a:prstGeom prst="rect">
+              <a:avLst/>
+            </a:prstGeom>
             <a:solidFill>
+              <a:schemeClr val="accent5"/>
+            </a:solidFill>
+            <a:ln>
+              <a:solidFill>
+                <a:schemeClr val="tx1"/>
+              </a:solidFill>
+            </a:ln>
+          </p:spPr>
+          <p:style>
+            <a:lnRef idx="2">
+              <a:schemeClr val="accent1">
+                <a:shade val="50000"/>
+              </a:schemeClr>
+            </a:lnRef>
+            <a:fillRef idx="1">
+              <a:schemeClr val="accent1"/>
+            </a:fillRef>
+            <a:effectRef idx="0">
+              <a:schemeClr val="accent1"/>
+            </a:effectRef>
+            <a:fontRef idx="minor">
+              <a:schemeClr val="lt1"/>
+            </a:fontRef>
+          </p:style>
+          <p:txBody>
+            <a:bodyPr rtlCol="0" anchor="ctr"/>
+            <a:lstStyle/>
+            <a:p>
+              <a:pPr algn="ctr"/>
+              <a:r>
+                <a:rPr lang="en-US" altLang="ko-KR" sz="4000" dirty="0" smtClean="0">
+                  <a:latin typeface="나눔스퀘어 Bold" panose="020B0600000101010101" pitchFamily="50" charset="-127"/>
+                  <a:ea typeface="나눔스퀘어 Bold" panose="020B0600000101010101" pitchFamily="50" charset="-127"/>
+                </a:rPr>
+                <a:t>Client</a:t>
+              </a:r>
+              <a:endParaRPr lang="ko-KR" altLang="en-US" sz="4000" dirty="0">
+                <a:latin typeface="나눔스퀘어 Bold" panose="020B0600000101010101" pitchFamily="50" charset="-127"/>
+                <a:ea typeface="나눔스퀘어 Bold" panose="020B0600000101010101" pitchFamily="50" charset="-127"/>
+              </a:endParaRPr>
+            </a:p>
+          </p:txBody>
+        </p:sp>
+        <p:sp>
+          <p:nvSpPr>
+            <p:cNvPr id="7" name="직사각형 6"/>
+            <p:cNvSpPr/>
+            <p:nvPr/>
+          </p:nvSpPr>
+          <p:spPr>
+            <a:xfrm>
+              <a:off x="7560942" y="2235200"/>
+              <a:ext cx="4320000" cy="2880000"/>
+            </a:xfrm>
+            <a:prstGeom prst="rect">
+              <a:avLst/>
+            </a:prstGeom>
+            <a:solidFill>
+              <a:schemeClr val="accent5"/>
+            </a:solidFill>
+            <a:ln>
+              <a:solidFill>
+                <a:schemeClr val="tx1"/>
+              </a:solidFill>
+            </a:ln>
+          </p:spPr>
+          <p:style>
+            <a:lnRef idx="2">
+              <a:schemeClr val="accent1">
+                <a:shade val="50000"/>
+              </a:schemeClr>
+            </a:lnRef>
+            <a:fillRef idx="1">
+              <a:schemeClr val="accent1"/>
+            </a:fillRef>
+            <a:effectRef idx="0">
+              <a:schemeClr val="accent1"/>
+            </a:effectRef>
+            <a:fontRef idx="minor">
+              <a:schemeClr val="lt1"/>
+            </a:fontRef>
+          </p:style>
+          <p:txBody>
+            <a:bodyPr rtlCol="0" anchor="ctr"/>
+            <a:lstStyle/>
+            <a:p>
+              <a:pPr algn="ctr"/>
+              <a:r>
+                <a:rPr lang="en-US" altLang="ko-KR" sz="3600" dirty="0" smtClean="0">
+                  <a:latin typeface="나눔스퀘어 Bold" panose="020B0600000101010101" pitchFamily="50" charset="-127"/>
+                  <a:ea typeface="나눔스퀘어 Bold" panose="020B0600000101010101" pitchFamily="50" charset="-127"/>
+                </a:rPr>
+                <a:t>Server</a:t>
+              </a:r>
+              <a:endParaRPr lang="en-US" altLang="ko-KR" sz="3200" dirty="0">
+                <a:latin typeface="나눔스퀘어 Bold" panose="020B0600000101010101" pitchFamily="50" charset="-127"/>
+                <a:ea typeface="나눔스퀘어 Bold" panose="020B0600000101010101" pitchFamily="50" charset="-127"/>
+              </a:endParaRPr>
+            </a:p>
+            <a:p>
+              <a:pPr algn="ctr"/>
+              <a:endParaRPr lang="en-US" altLang="ko-KR" sz="3200" dirty="0" smtClean="0">
+                <a:latin typeface="나눔스퀘어 Bold" panose="020B0600000101010101" pitchFamily="50" charset="-127"/>
+                <a:ea typeface="나눔스퀘어 Bold" panose="020B0600000101010101" pitchFamily="50" charset="-127"/>
+              </a:endParaRPr>
+            </a:p>
+            <a:p>
+              <a:pPr algn="ctr"/>
+              <a:endParaRPr lang="en-US" altLang="ko-KR" sz="3200" dirty="0">
+                <a:latin typeface="나눔스퀘어 Bold" panose="020B0600000101010101" pitchFamily="50" charset="-127"/>
+                <a:ea typeface="나눔스퀘어 Bold" panose="020B0600000101010101" pitchFamily="50" charset="-127"/>
+              </a:endParaRPr>
+            </a:p>
+            <a:p>
+              <a:pPr algn="ctr"/>
+              <a:endParaRPr lang="en-US" altLang="ko-KR" sz="3200" dirty="0" smtClean="0">
+                <a:latin typeface="나눔스퀘어 Bold" panose="020B0600000101010101" pitchFamily="50" charset="-127"/>
+                <a:ea typeface="나눔스퀘어 Bold" panose="020B0600000101010101" pitchFamily="50" charset="-127"/>
+              </a:endParaRPr>
+            </a:p>
+            <a:p>
+              <a:pPr algn="ctr"/>
+              <a:endParaRPr lang="ko-KR" altLang="en-US" sz="3200" dirty="0">
+                <a:latin typeface="나눔스퀘어 Bold" panose="020B0600000101010101" pitchFamily="50" charset="-127"/>
+                <a:ea typeface="나눔스퀘어 Bold" panose="020B0600000101010101" pitchFamily="50" charset="-127"/>
+              </a:endParaRPr>
+            </a:p>
+          </p:txBody>
+        </p:sp>
+        <p:sp>
+          <p:nvSpPr>
+            <p:cNvPr id="8" name="직사각형 7"/>
+            <p:cNvSpPr/>
+            <p:nvPr/>
+          </p:nvSpPr>
+          <p:spPr>
+            <a:xfrm>
+              <a:off x="9886913" y="3394068"/>
+              <a:ext cx="1800000" cy="1080000"/>
+            </a:xfrm>
+            <a:prstGeom prst="rect">
+              <a:avLst/>
+            </a:prstGeom>
+            <a:solidFill>
+              <a:schemeClr val="accent5"/>
+            </a:solidFill>
+            <a:ln>
+              <a:solidFill>
+                <a:schemeClr val="tx1"/>
+              </a:solidFill>
+            </a:ln>
+          </p:spPr>
+          <p:style>
+            <a:lnRef idx="2">
+              <a:schemeClr val="accent1">
+                <a:shade val="50000"/>
+              </a:schemeClr>
+            </a:lnRef>
+            <a:fillRef idx="1">
+              <a:schemeClr val="accent1"/>
+            </a:fillRef>
+            <a:effectRef idx="0">
+              <a:schemeClr val="accent1"/>
+            </a:effectRef>
+            <a:fontRef idx="minor">
+              <a:schemeClr val="lt1"/>
+            </a:fontRef>
+          </p:style>
+          <p:txBody>
+            <a:bodyPr rtlCol="0" anchor="ctr"/>
+            <a:lstStyle/>
+            <a:p>
+              <a:pPr algn="ctr"/>
+              <a:r>
+                <a:rPr lang="en-US" altLang="ko-KR" dirty="0" smtClean="0">
+                  <a:latin typeface="나눔스퀘어 Bold" panose="020B0600000101010101" pitchFamily="50" charset="-127"/>
+                  <a:ea typeface="나눔스퀘어 Bold" panose="020B0600000101010101" pitchFamily="50" charset="-127"/>
+                </a:rPr>
+                <a:t>WAS</a:t>
+              </a:r>
+            </a:p>
+            <a:p>
+              <a:pPr algn="ctr"/>
+              <a:r>
+                <a:rPr lang="en-US" altLang="ko-KR" dirty="0" smtClean="0">
+                  <a:latin typeface="나눔스퀘어 Bold" panose="020B0600000101010101" pitchFamily="50" charset="-127"/>
+                  <a:ea typeface="나눔스퀘어 Bold" panose="020B0600000101010101" pitchFamily="50" charset="-127"/>
+                </a:rPr>
+                <a:t>(Tomcat)</a:t>
+              </a:r>
+              <a:endParaRPr lang="ko-KR" altLang="en-US" dirty="0">
+                <a:latin typeface="나눔스퀘어 Bold" panose="020B0600000101010101" pitchFamily="50" charset="-127"/>
+                <a:ea typeface="나눔스퀘어 Bold" panose="020B0600000101010101" pitchFamily="50" charset="-127"/>
+              </a:endParaRPr>
+            </a:p>
+          </p:txBody>
+        </p:sp>
+        <p:sp>
+          <p:nvSpPr>
+            <p:cNvPr id="9" name="직사각형 8"/>
+            <p:cNvSpPr/>
+            <p:nvPr/>
+          </p:nvSpPr>
+          <p:spPr>
+            <a:xfrm>
+              <a:off x="7754971" y="3401326"/>
+              <a:ext cx="1800000" cy="1080000"/>
+            </a:xfrm>
+            <a:prstGeom prst="rect">
+              <a:avLst/>
+            </a:prstGeom>
+            <a:solidFill>
+              <a:schemeClr val="accent5"/>
+            </a:solidFill>
+            <a:ln>
+              <a:solidFill>
+                <a:schemeClr val="tx1"/>
+              </a:solidFill>
+            </a:ln>
+          </p:spPr>
+          <p:style>
+            <a:lnRef idx="2">
+              <a:schemeClr val="accent1">
+                <a:shade val="50000"/>
+              </a:schemeClr>
+            </a:lnRef>
+            <a:fillRef idx="1">
+              <a:schemeClr val="accent1"/>
+            </a:fillRef>
+            <a:effectRef idx="0">
+              <a:schemeClr val="accent1"/>
+            </a:effectRef>
+            <a:fontRef idx="minor">
+              <a:schemeClr val="lt1"/>
+            </a:fontRef>
+          </p:style>
+          <p:txBody>
+            <a:bodyPr rtlCol="0" anchor="ctr"/>
+            <a:lstStyle/>
+            <a:p>
+              <a:pPr algn="ctr"/>
+              <a:r>
+                <a:rPr lang="en-US" altLang="ko-KR" dirty="0" smtClean="0">
+                  <a:latin typeface="나눔스퀘어 Bold" panose="020B0600000101010101" pitchFamily="50" charset="-127"/>
+                  <a:ea typeface="나눔스퀘어 Bold" panose="020B0600000101010101" pitchFamily="50" charset="-127"/>
+                </a:rPr>
+                <a:t>Web Server</a:t>
+              </a:r>
+            </a:p>
+            <a:p>
+              <a:pPr algn="ctr"/>
+              <a:r>
+                <a:rPr lang="en-US" altLang="ko-KR" dirty="0" smtClean="0">
+                  <a:latin typeface="나눔스퀘어 Bold" panose="020B0600000101010101" pitchFamily="50" charset="-127"/>
+                  <a:ea typeface="나눔스퀘어 Bold" panose="020B0600000101010101" pitchFamily="50" charset="-127"/>
+                </a:rPr>
+                <a:t>(</a:t>
+              </a:r>
+              <a:r>
+                <a:rPr lang="en-US" altLang="ko-KR" dirty="0" err="1" smtClean="0">
+                  <a:latin typeface="나눔스퀘어 Bold" panose="020B0600000101010101" pitchFamily="50" charset="-127"/>
+                  <a:ea typeface="나눔스퀘어 Bold" panose="020B0600000101010101" pitchFamily="50" charset="-127"/>
+                </a:rPr>
+                <a:t>Ngnix</a:t>
+              </a:r>
+              <a:r>
+                <a:rPr lang="en-US" altLang="ko-KR" dirty="0" smtClean="0">
+                  <a:latin typeface="나눔스퀘어 Bold" panose="020B0600000101010101" pitchFamily="50" charset="-127"/>
+                  <a:ea typeface="나눔스퀘어 Bold" panose="020B0600000101010101" pitchFamily="50" charset="-127"/>
+                </a:rPr>
+                <a:t>)</a:t>
+              </a:r>
+              <a:endParaRPr lang="ko-KR" altLang="en-US" dirty="0">
+                <a:latin typeface="나눔스퀘어 Bold" panose="020B0600000101010101" pitchFamily="50" charset="-127"/>
+                <a:ea typeface="나눔스퀘어 Bold" panose="020B0600000101010101" pitchFamily="50" charset="-127"/>
+              </a:endParaRPr>
+            </a:p>
+          </p:txBody>
+        </p:sp>
+        <p:cxnSp>
+          <p:nvCxnSpPr>
+            <p:cNvPr id="11" name="직선 화살표 연결선 10"/>
+            <p:cNvCxnSpPr>
+              <a:stCxn id="6" idx="3"/>
+              <a:endCxn id="7" idx="1"/>
+            </p:cNvCxnSpPr>
+            <p:nvPr/>
+          </p:nvCxnSpPr>
+          <p:spPr>
+            <a:xfrm>
+              <a:off x="3263086" y="3675200"/>
+              <a:ext cx="4297856" cy="0"/>
+            </a:xfrm>
+            <a:prstGeom prst="straightConnector1">
+              <a:avLst/>
+            </a:prstGeom>
+            <a:ln w="76200">
+              <a:solidFill>
+                <a:schemeClr val="accent2"/>
+              </a:solidFill>
+              <a:tailEnd type="triangle"/>
+            </a:ln>
+          </p:spPr>
+          <p:style>
+            <a:lnRef idx="1">
+              <a:schemeClr val="accent1"/>
+            </a:lnRef>
+            <a:fillRef idx="0">
+              <a:schemeClr val="accent1"/>
+            </a:fillRef>
+            <a:effectRef idx="0">
+              <a:schemeClr val="accent1"/>
+            </a:effectRef>
+            <a:fontRef idx="minor">
               <a:schemeClr val="tx1"/>
-            </a:solidFill>
-          </a:ln>
-        </p:spPr>
-        <p:style>
-          <a:lnRef idx="2">
-            <a:schemeClr val="accent1">
-              <a:shade val="50000"/>
-            </a:schemeClr>
-          </a:lnRef>
-          <a:fillRef idx="1">
-            <a:schemeClr val="accent1"/>
-          </a:fillRef>
-          <a:effectRef idx="0">
-            <a:schemeClr val="accent1"/>
-          </a:effectRef>
-          <a:fontRef idx="minor">
-            <a:schemeClr val="lt1"/>
-          </a:fontRef>
-        </p:style>
-        <p:txBody>
-          <a:bodyPr rtlCol="0" anchor="ctr"/>
-          <a:lstStyle/>
-          <a:p>
-            <a:pPr algn="ctr"/>
-            <a:r>
-              <a:rPr lang="en-US" altLang="ko-KR" sz="4000" dirty="0" smtClean="0">
-                <a:latin typeface="나눔스퀘어 Bold" panose="020B0600000101010101" pitchFamily="50" charset="-127"/>
-                <a:ea typeface="나눔스퀘어 Bold" panose="020B0600000101010101" pitchFamily="50" charset="-127"/>
-              </a:rPr>
-              <a:t>Client</a:t>
-            </a:r>
-            <a:endParaRPr lang="ko-KR" altLang="en-US" sz="4000" dirty="0">
-              <a:latin typeface="나눔스퀘어 Bold" panose="020B0600000101010101" pitchFamily="50" charset="-127"/>
-              <a:ea typeface="나눔스퀘어 Bold" panose="020B0600000101010101" pitchFamily="50" charset="-127"/>
-            </a:endParaRPr>
-          </a:p>
-        </p:txBody>
-      </p:sp>
-      <p:sp>
-        <p:nvSpPr>
-          <p:cNvPr id="7" name="직사각형 6"/>
-          <p:cNvSpPr/>
-          <p:nvPr/>
-        </p:nvSpPr>
-        <p:spPr>
-          <a:xfrm>
-            <a:off x="7560942" y="2235200"/>
-            <a:ext cx="4320000" cy="2880000"/>
-          </a:xfrm>
-          <a:prstGeom prst="rect">
-            <a:avLst/>
-          </a:prstGeom>
-          <a:solidFill>
-            <a:schemeClr val="accent5"/>
-          </a:solidFill>
-          <a:ln>
-            <a:solidFill>
-              <a:schemeClr val="tx1"/>
-            </a:solidFill>
-          </a:ln>
-        </p:spPr>
-        <p:style>
-          <a:lnRef idx="2">
-            <a:schemeClr val="accent1">
-              <a:shade val="50000"/>
-            </a:schemeClr>
-          </a:lnRef>
-          <a:fillRef idx="1">
-            <a:schemeClr val="accent1"/>
-          </a:fillRef>
-          <a:effectRef idx="0">
-            <a:schemeClr val="accent1"/>
-          </a:effectRef>
-          <a:fontRef idx="minor">
-            <a:schemeClr val="lt1"/>
-          </a:fontRef>
-        </p:style>
-        <p:txBody>
-          <a:bodyPr rtlCol="0" anchor="ctr"/>
-          <a:lstStyle/>
-          <a:p>
-            <a:pPr algn="ctr"/>
-            <a:r>
-              <a:rPr lang="en-US" altLang="ko-KR" sz="3600" dirty="0" smtClean="0">
-                <a:latin typeface="나눔스퀘어 Bold" panose="020B0600000101010101" pitchFamily="50" charset="-127"/>
-                <a:ea typeface="나눔스퀘어 Bold" panose="020B0600000101010101" pitchFamily="50" charset="-127"/>
-              </a:rPr>
-              <a:t>Server</a:t>
-            </a:r>
-            <a:endParaRPr lang="en-US" altLang="ko-KR" sz="3200" dirty="0">
-              <a:latin typeface="나눔스퀘어 Bold" panose="020B0600000101010101" pitchFamily="50" charset="-127"/>
-              <a:ea typeface="나눔스퀘어 Bold" panose="020B0600000101010101" pitchFamily="50" charset="-127"/>
-            </a:endParaRPr>
-          </a:p>
-          <a:p>
-            <a:pPr algn="ctr"/>
-            <a:endParaRPr lang="en-US" altLang="ko-KR" sz="3200" dirty="0" smtClean="0">
-              <a:latin typeface="나눔스퀘어 Bold" panose="020B0600000101010101" pitchFamily="50" charset="-127"/>
-              <a:ea typeface="나눔스퀘어 Bold" panose="020B0600000101010101" pitchFamily="50" charset="-127"/>
-            </a:endParaRPr>
-          </a:p>
-          <a:p>
-            <a:pPr algn="ctr"/>
-            <a:endParaRPr lang="en-US" altLang="ko-KR" sz="3200" dirty="0">
-              <a:latin typeface="나눔스퀘어 Bold" panose="020B0600000101010101" pitchFamily="50" charset="-127"/>
-              <a:ea typeface="나눔스퀘어 Bold" panose="020B0600000101010101" pitchFamily="50" charset="-127"/>
-            </a:endParaRPr>
-          </a:p>
-          <a:p>
-            <a:pPr algn="ctr"/>
-            <a:endParaRPr lang="en-US" altLang="ko-KR" sz="3200" dirty="0" smtClean="0">
-              <a:latin typeface="나눔스퀘어 Bold" panose="020B0600000101010101" pitchFamily="50" charset="-127"/>
-              <a:ea typeface="나눔스퀘어 Bold" panose="020B0600000101010101" pitchFamily="50" charset="-127"/>
-            </a:endParaRPr>
-          </a:p>
-          <a:p>
-            <a:pPr algn="ctr"/>
-            <a:endParaRPr lang="ko-KR" altLang="en-US" sz="3200" dirty="0">
-              <a:latin typeface="나눔스퀘어 Bold" panose="020B0600000101010101" pitchFamily="50" charset="-127"/>
-              <a:ea typeface="나눔스퀘어 Bold" panose="020B0600000101010101" pitchFamily="50" charset="-127"/>
-            </a:endParaRPr>
-          </a:p>
-        </p:txBody>
-      </p:sp>
-      <p:sp>
-        <p:nvSpPr>
-          <p:cNvPr id="8" name="직사각형 7"/>
-          <p:cNvSpPr/>
-          <p:nvPr/>
-        </p:nvSpPr>
-        <p:spPr>
-          <a:xfrm>
-            <a:off x="9886913" y="3394068"/>
-            <a:ext cx="1800000" cy="1080000"/>
-          </a:xfrm>
-          <a:prstGeom prst="rect">
-            <a:avLst/>
-          </a:prstGeom>
-          <a:solidFill>
-            <a:schemeClr val="accent5"/>
-          </a:solidFill>
-          <a:ln>
-            <a:solidFill>
-              <a:schemeClr val="tx1"/>
-            </a:solidFill>
-          </a:ln>
-        </p:spPr>
-        <p:style>
-          <a:lnRef idx="2">
-            <a:schemeClr val="accent1">
-              <a:shade val="50000"/>
-            </a:schemeClr>
-          </a:lnRef>
-          <a:fillRef idx="1">
-            <a:schemeClr val="accent1"/>
-          </a:fillRef>
-          <a:effectRef idx="0">
-            <a:schemeClr val="accent1"/>
-          </a:effectRef>
-          <a:fontRef idx="minor">
-            <a:schemeClr val="lt1"/>
-          </a:fontRef>
-        </p:style>
-        <p:txBody>
-          <a:bodyPr rtlCol="0" anchor="ctr"/>
-          <a:lstStyle/>
-          <a:p>
-            <a:pPr algn="ctr"/>
-            <a:r>
-              <a:rPr lang="en-US" altLang="ko-KR" dirty="0" smtClean="0">
-                <a:latin typeface="나눔스퀘어 Bold" panose="020B0600000101010101" pitchFamily="50" charset="-127"/>
-                <a:ea typeface="나눔스퀘어 Bold" panose="020B0600000101010101" pitchFamily="50" charset="-127"/>
-              </a:rPr>
-              <a:t>WAS</a:t>
-            </a:r>
-          </a:p>
-          <a:p>
-            <a:pPr algn="ctr"/>
-            <a:r>
-              <a:rPr lang="en-US" altLang="ko-KR" dirty="0" smtClean="0">
-                <a:latin typeface="나눔스퀘어 Bold" panose="020B0600000101010101" pitchFamily="50" charset="-127"/>
-                <a:ea typeface="나눔스퀘어 Bold" panose="020B0600000101010101" pitchFamily="50" charset="-127"/>
-              </a:rPr>
-              <a:t>(Tomcat)</a:t>
-            </a:r>
-            <a:endParaRPr lang="ko-KR" altLang="en-US" dirty="0">
-              <a:latin typeface="나눔스퀘어 Bold" panose="020B0600000101010101" pitchFamily="50" charset="-127"/>
-              <a:ea typeface="나눔스퀘어 Bold" panose="020B0600000101010101" pitchFamily="50" charset="-127"/>
-            </a:endParaRPr>
-          </a:p>
-        </p:txBody>
-      </p:sp>
-      <p:sp>
-        <p:nvSpPr>
-          <p:cNvPr id="9" name="직사각형 8"/>
-          <p:cNvSpPr/>
-          <p:nvPr/>
-        </p:nvSpPr>
-        <p:spPr>
-          <a:xfrm>
-            <a:off x="7754971" y="3401326"/>
-            <a:ext cx="1800000" cy="1080000"/>
-          </a:xfrm>
-          <a:prstGeom prst="rect">
-            <a:avLst/>
-          </a:prstGeom>
-          <a:solidFill>
-            <a:schemeClr val="accent5"/>
-          </a:solidFill>
-          <a:ln>
-            <a:solidFill>
-              <a:schemeClr val="tx1"/>
-            </a:solidFill>
-          </a:ln>
-        </p:spPr>
-        <p:style>
-          <a:lnRef idx="2">
-            <a:schemeClr val="accent1">
-              <a:shade val="50000"/>
-            </a:schemeClr>
-          </a:lnRef>
-          <a:fillRef idx="1">
-            <a:schemeClr val="accent1"/>
-          </a:fillRef>
-          <a:effectRef idx="0">
-            <a:schemeClr val="accent1"/>
-          </a:effectRef>
-          <a:fontRef idx="minor">
-            <a:schemeClr val="lt1"/>
-          </a:fontRef>
-        </p:style>
-        <p:txBody>
-          <a:bodyPr rtlCol="0" anchor="ctr"/>
-          <a:lstStyle/>
-          <a:p>
-            <a:pPr algn="ctr"/>
-            <a:r>
-              <a:rPr lang="en-US" altLang="ko-KR" dirty="0" smtClean="0">
-                <a:latin typeface="나눔스퀘어 Bold" panose="020B0600000101010101" pitchFamily="50" charset="-127"/>
-                <a:ea typeface="나눔스퀘어 Bold" panose="020B0600000101010101" pitchFamily="50" charset="-127"/>
-              </a:rPr>
-              <a:t>Web Server</a:t>
-            </a:r>
-          </a:p>
-          <a:p>
-            <a:pPr algn="ctr"/>
-            <a:r>
-              <a:rPr lang="en-US" altLang="ko-KR" dirty="0" smtClean="0">
-                <a:latin typeface="나눔스퀘어 Bold" panose="020B0600000101010101" pitchFamily="50" charset="-127"/>
-                <a:ea typeface="나눔스퀘어 Bold" panose="020B0600000101010101" pitchFamily="50" charset="-127"/>
-              </a:rPr>
-              <a:t>(</a:t>
-            </a:r>
-            <a:r>
-              <a:rPr lang="en-US" altLang="ko-KR" dirty="0" err="1" smtClean="0">
-                <a:latin typeface="나눔스퀘어 Bold" panose="020B0600000101010101" pitchFamily="50" charset="-127"/>
-                <a:ea typeface="나눔스퀘어 Bold" panose="020B0600000101010101" pitchFamily="50" charset="-127"/>
-              </a:rPr>
-              <a:t>Ngnix</a:t>
-            </a:r>
-            <a:r>
-              <a:rPr lang="en-US" altLang="ko-KR" dirty="0" smtClean="0">
-                <a:latin typeface="나눔스퀘어 Bold" panose="020B0600000101010101" pitchFamily="50" charset="-127"/>
-                <a:ea typeface="나눔스퀘어 Bold" panose="020B0600000101010101" pitchFamily="50" charset="-127"/>
-              </a:rPr>
-              <a:t>)</a:t>
-            </a:r>
-            <a:endParaRPr lang="ko-KR" altLang="en-US" dirty="0">
-              <a:latin typeface="나눔스퀘어 Bold" panose="020B0600000101010101" pitchFamily="50" charset="-127"/>
-              <a:ea typeface="나눔스퀘어 Bold" panose="020B0600000101010101" pitchFamily="50" charset="-127"/>
-            </a:endParaRPr>
-          </a:p>
-        </p:txBody>
-      </p:sp>
-      <p:cxnSp>
-        <p:nvCxnSpPr>
-          <p:cNvPr id="11" name="직선 화살표 연결선 10"/>
-          <p:cNvCxnSpPr>
-            <a:stCxn id="6" idx="3"/>
-            <a:endCxn id="7" idx="1"/>
-          </p:cNvCxnSpPr>
-          <p:nvPr/>
-        </p:nvCxnSpPr>
-        <p:spPr>
-          <a:xfrm>
-            <a:off x="3263086" y="3675200"/>
-            <a:ext cx="4297856" cy="0"/>
-          </a:xfrm>
-          <a:prstGeom prst="straightConnector1">
-            <a:avLst/>
-          </a:prstGeom>
-          <a:ln w="76200">
-            <a:solidFill>
-              <a:schemeClr val="accent2"/>
-            </a:solidFill>
-            <a:tailEnd type="triangle"/>
-          </a:ln>
-        </p:spPr>
-        <p:style>
-          <a:lnRef idx="1">
-            <a:schemeClr val="accent1"/>
-          </a:lnRef>
-          <a:fillRef idx="0">
-            <a:schemeClr val="accent1"/>
-          </a:fillRef>
-          <a:effectRef idx="0">
-            <a:schemeClr val="accent1"/>
-          </a:effectRef>
-          <a:fontRef idx="minor">
-            <a:schemeClr val="tx1"/>
-          </a:fontRef>
-        </p:style>
-      </p:cxnSp>
-      <p:sp>
-        <p:nvSpPr>
-          <p:cNvPr id="13" name="TextBox 12"/>
-          <p:cNvSpPr txBox="1"/>
-          <p:nvPr/>
-        </p:nvSpPr>
-        <p:spPr>
-          <a:xfrm>
-            <a:off x="4304467" y="3302239"/>
-            <a:ext cx="2215094" cy="369332"/>
-          </a:xfrm>
-          <a:prstGeom prst="rect">
-            <a:avLst/>
-          </a:prstGeom>
-          <a:noFill/>
-        </p:spPr>
-        <p:txBody>
-          <a:bodyPr wrap="none" rtlCol="0">
-            <a:spAutoFit/>
-          </a:bodyPr>
-          <a:lstStyle/>
-          <a:p>
-            <a:r>
-              <a:rPr lang="en-US" altLang="ko-KR" dirty="0" smtClean="0">
-                <a:latin typeface="나눔스퀘어 Bold" panose="020B0600000101010101" pitchFamily="50" charset="-127"/>
-                <a:ea typeface="나눔스퀘어 Bold" panose="020B0600000101010101" pitchFamily="50" charset="-127"/>
-              </a:rPr>
-              <a:t>Request(</a:t>
-            </a:r>
-            <a:r>
-              <a:rPr lang="ko-KR" altLang="en-US" dirty="0" smtClean="0">
-                <a:latin typeface="나눔스퀘어 Bold" panose="020B0600000101010101" pitchFamily="50" charset="-127"/>
-                <a:ea typeface="나눔스퀘어 Bold" panose="020B0600000101010101" pitchFamily="50" charset="-127"/>
-              </a:rPr>
-              <a:t>정적</a:t>
-            </a:r>
-            <a:r>
-              <a:rPr lang="en-US" altLang="ko-KR" dirty="0" smtClean="0">
-                <a:latin typeface="나눔스퀘어 Bold" panose="020B0600000101010101" pitchFamily="50" charset="-127"/>
-                <a:ea typeface="나눔스퀘어 Bold" panose="020B0600000101010101" pitchFamily="50" charset="-127"/>
-              </a:rPr>
-              <a:t>, </a:t>
-            </a:r>
-            <a:r>
-              <a:rPr lang="ko-KR" altLang="en-US" dirty="0" smtClean="0">
-                <a:latin typeface="나눔스퀘어 Bold" panose="020B0600000101010101" pitchFamily="50" charset="-127"/>
-                <a:ea typeface="나눔스퀘어 Bold" panose="020B0600000101010101" pitchFamily="50" charset="-127"/>
-              </a:rPr>
-              <a:t>동적</a:t>
-            </a:r>
-            <a:r>
-              <a:rPr lang="en-US" altLang="ko-KR" dirty="0" smtClean="0">
-                <a:latin typeface="나눔스퀘어 Bold" panose="020B0600000101010101" pitchFamily="50" charset="-127"/>
-                <a:ea typeface="나눔스퀘어 Bold" panose="020B0600000101010101" pitchFamily="50" charset="-127"/>
-              </a:rPr>
-              <a:t>)</a:t>
-            </a:r>
-            <a:endParaRPr lang="ko-KR" altLang="en-US" dirty="0">
-              <a:latin typeface="나눔스퀘어 Bold" panose="020B0600000101010101" pitchFamily="50" charset="-127"/>
-              <a:ea typeface="나눔스퀘어 Bold" panose="020B0600000101010101" pitchFamily="50" charset="-127"/>
-            </a:endParaRPr>
-          </a:p>
-        </p:txBody>
-      </p:sp>
-      <p:sp>
-        <p:nvSpPr>
-          <p:cNvPr id="14" name="TextBox 13"/>
-          <p:cNvSpPr txBox="1"/>
-          <p:nvPr/>
-        </p:nvSpPr>
-        <p:spPr>
-          <a:xfrm>
-            <a:off x="6606481" y="5200762"/>
-            <a:ext cx="1908921" cy="369332"/>
-          </a:xfrm>
-          <a:prstGeom prst="rect">
-            <a:avLst/>
-          </a:prstGeom>
-          <a:noFill/>
-        </p:spPr>
-        <p:txBody>
-          <a:bodyPr wrap="none" rtlCol="0">
-            <a:spAutoFit/>
-          </a:bodyPr>
-          <a:lstStyle/>
-          <a:p>
-            <a:r>
-              <a:rPr lang="en-US" altLang="ko-KR" dirty="0" smtClean="0">
-                <a:latin typeface="나눔스퀘어 Bold" panose="020B0600000101010101" pitchFamily="50" charset="-127"/>
-                <a:ea typeface="나눔스퀘어 Bold" panose="020B0600000101010101" pitchFamily="50" charset="-127"/>
-              </a:rPr>
-              <a:t>Response (</a:t>
-            </a:r>
-            <a:r>
-              <a:rPr lang="ko-KR" altLang="en-US" dirty="0" smtClean="0">
-                <a:latin typeface="나눔스퀘어 Bold" panose="020B0600000101010101" pitchFamily="50" charset="-127"/>
-                <a:ea typeface="나눔스퀘어 Bold" panose="020B0600000101010101" pitchFamily="50" charset="-127"/>
-              </a:rPr>
-              <a:t>정적</a:t>
-            </a:r>
-            <a:r>
-              <a:rPr lang="en-US" altLang="ko-KR" dirty="0" smtClean="0">
-                <a:latin typeface="나눔스퀘어 Bold" panose="020B0600000101010101" pitchFamily="50" charset="-127"/>
-                <a:ea typeface="나눔스퀘어 Bold" panose="020B0600000101010101" pitchFamily="50" charset="-127"/>
-              </a:rPr>
-              <a:t>)</a:t>
-            </a:r>
-            <a:endParaRPr lang="ko-KR" altLang="en-US" dirty="0">
-              <a:latin typeface="나눔스퀘어 Bold" panose="020B0600000101010101" pitchFamily="50" charset="-127"/>
-              <a:ea typeface="나눔스퀘어 Bold" panose="020B0600000101010101" pitchFamily="50" charset="-127"/>
-            </a:endParaRPr>
-          </a:p>
-        </p:txBody>
-      </p:sp>
-      <p:sp>
-        <p:nvSpPr>
-          <p:cNvPr id="15" name="직사각형 14"/>
-          <p:cNvSpPr/>
-          <p:nvPr/>
-        </p:nvSpPr>
-        <p:spPr>
-          <a:xfrm>
-            <a:off x="7754971" y="4488151"/>
-            <a:ext cx="604653" cy="369332"/>
-          </a:xfrm>
-          <a:prstGeom prst="rect">
-            <a:avLst/>
-          </a:prstGeom>
-        </p:spPr>
-        <p:txBody>
-          <a:bodyPr wrap="none">
-            <a:spAutoFit/>
-          </a:bodyPr>
-          <a:lstStyle/>
-          <a:p>
-            <a:r>
-              <a:rPr lang="ko-KR" altLang="en-US" dirty="0">
+            </a:fontRef>
+          </p:style>
+        </p:cxnSp>
+        <p:sp>
+          <p:nvSpPr>
+            <p:cNvPr id="13" name="TextBox 12"/>
+            <p:cNvSpPr txBox="1"/>
+            <p:nvPr/>
+          </p:nvSpPr>
+          <p:spPr>
+            <a:xfrm>
+              <a:off x="4304467" y="3302239"/>
+              <a:ext cx="2215094" cy="369332"/>
+            </a:xfrm>
+            <a:prstGeom prst="rect">
+              <a:avLst/>
+            </a:prstGeom>
+            <a:noFill/>
+          </p:spPr>
+          <p:txBody>
+            <a:bodyPr wrap="none" rtlCol="0">
+              <a:spAutoFit/>
+            </a:bodyPr>
+            <a:lstStyle/>
+            <a:p>
+              <a:r>
+                <a:rPr lang="en-US" altLang="ko-KR" dirty="0" smtClean="0">
+                  <a:latin typeface="나눔스퀘어 Bold" panose="020B0600000101010101" pitchFamily="50" charset="-127"/>
+                  <a:ea typeface="나눔스퀘어 Bold" panose="020B0600000101010101" pitchFamily="50" charset="-127"/>
+                </a:rPr>
+                <a:t>Request(</a:t>
+              </a:r>
+              <a:r>
+                <a:rPr lang="ko-KR" altLang="en-US" dirty="0" smtClean="0">
+                  <a:latin typeface="나눔스퀘어 Bold" panose="020B0600000101010101" pitchFamily="50" charset="-127"/>
+                  <a:ea typeface="나눔스퀘어 Bold" panose="020B0600000101010101" pitchFamily="50" charset="-127"/>
+                </a:rPr>
+                <a:t>정적</a:t>
+              </a:r>
+              <a:r>
+                <a:rPr lang="en-US" altLang="ko-KR" dirty="0" smtClean="0">
+                  <a:latin typeface="나눔스퀘어 Bold" panose="020B0600000101010101" pitchFamily="50" charset="-127"/>
+                  <a:ea typeface="나눔스퀘어 Bold" panose="020B0600000101010101" pitchFamily="50" charset="-127"/>
+                </a:rPr>
+                <a:t>, </a:t>
+              </a:r>
+              <a:r>
+                <a:rPr lang="ko-KR" altLang="en-US" dirty="0" smtClean="0">
+                  <a:latin typeface="나눔스퀘어 Bold" panose="020B0600000101010101" pitchFamily="50" charset="-127"/>
+                  <a:ea typeface="나눔스퀘어 Bold" panose="020B0600000101010101" pitchFamily="50" charset="-127"/>
+                </a:rPr>
+                <a:t>동적</a:t>
+              </a:r>
+              <a:r>
+                <a:rPr lang="en-US" altLang="ko-KR" dirty="0" smtClean="0">
+                  <a:latin typeface="나눔스퀘어 Bold" panose="020B0600000101010101" pitchFamily="50" charset="-127"/>
+                  <a:ea typeface="나눔스퀘어 Bold" panose="020B0600000101010101" pitchFamily="50" charset="-127"/>
+                </a:rPr>
+                <a:t>)</a:t>
+              </a:r>
+              <a:endParaRPr lang="ko-KR" altLang="en-US" dirty="0">
+                <a:latin typeface="나눔스퀘어 Bold" panose="020B0600000101010101" pitchFamily="50" charset="-127"/>
+                <a:ea typeface="나눔스퀘어 Bold" panose="020B0600000101010101" pitchFamily="50" charset="-127"/>
+              </a:endParaRPr>
+            </a:p>
+          </p:txBody>
+        </p:sp>
+        <p:sp>
+          <p:nvSpPr>
+            <p:cNvPr id="14" name="TextBox 13"/>
+            <p:cNvSpPr txBox="1"/>
+            <p:nvPr/>
+          </p:nvSpPr>
+          <p:spPr>
+            <a:xfrm>
+              <a:off x="6606481" y="5200762"/>
+              <a:ext cx="1908921" cy="369332"/>
+            </a:xfrm>
+            <a:prstGeom prst="rect">
+              <a:avLst/>
+            </a:prstGeom>
+            <a:noFill/>
+          </p:spPr>
+          <p:txBody>
+            <a:bodyPr wrap="none" rtlCol="0">
+              <a:spAutoFit/>
+            </a:bodyPr>
+            <a:lstStyle/>
+            <a:p>
+              <a:r>
+                <a:rPr lang="en-US" altLang="ko-KR" dirty="0" smtClean="0">
+                  <a:latin typeface="나눔스퀘어 Bold" panose="020B0600000101010101" pitchFamily="50" charset="-127"/>
+                  <a:ea typeface="나눔스퀘어 Bold" panose="020B0600000101010101" pitchFamily="50" charset="-127"/>
+                </a:rPr>
+                <a:t>Response (</a:t>
+              </a:r>
+              <a:r>
+                <a:rPr lang="ko-KR" altLang="en-US" dirty="0" smtClean="0">
+                  <a:latin typeface="나눔스퀘어 Bold" panose="020B0600000101010101" pitchFamily="50" charset="-127"/>
+                  <a:ea typeface="나눔스퀘어 Bold" panose="020B0600000101010101" pitchFamily="50" charset="-127"/>
+                </a:rPr>
+                <a:t>정적</a:t>
+              </a:r>
+              <a:r>
+                <a:rPr lang="en-US" altLang="ko-KR" dirty="0" smtClean="0">
+                  <a:latin typeface="나눔스퀘어 Bold" panose="020B0600000101010101" pitchFamily="50" charset="-127"/>
+                  <a:ea typeface="나눔스퀘어 Bold" panose="020B0600000101010101" pitchFamily="50" charset="-127"/>
+                </a:rPr>
+                <a:t>)</a:t>
+              </a:r>
+              <a:endParaRPr lang="ko-KR" altLang="en-US" dirty="0">
+                <a:latin typeface="나눔스퀘어 Bold" panose="020B0600000101010101" pitchFamily="50" charset="-127"/>
+                <a:ea typeface="나눔스퀘어 Bold" panose="020B0600000101010101" pitchFamily="50" charset="-127"/>
+              </a:endParaRPr>
+            </a:p>
+          </p:txBody>
+        </p:sp>
+        <p:sp>
+          <p:nvSpPr>
+            <p:cNvPr id="15" name="직사각형 14"/>
+            <p:cNvSpPr/>
+            <p:nvPr/>
+          </p:nvSpPr>
+          <p:spPr>
+            <a:xfrm>
+              <a:off x="7754971" y="4488151"/>
+              <a:ext cx="604653" cy="369332"/>
+            </a:xfrm>
+            <a:prstGeom prst="rect">
+              <a:avLst/>
+            </a:prstGeom>
+          </p:spPr>
+          <p:txBody>
+            <a:bodyPr wrap="none">
+              <a:spAutoFit/>
+            </a:bodyPr>
+            <a:lstStyle/>
+            <a:p>
+              <a:r>
+                <a:rPr lang="ko-KR" altLang="en-US" dirty="0">
+                  <a:solidFill>
+                    <a:schemeClr val="bg1"/>
+                  </a:solidFill>
+                  <a:latin typeface="나눔스퀘어 Bold" panose="020B0600000101010101" pitchFamily="50" charset="-127"/>
+                  <a:ea typeface="나눔스퀘어 Bold" panose="020B0600000101010101" pitchFamily="50" charset="-127"/>
+                </a:rPr>
+                <a:t>정적</a:t>
+              </a:r>
+            </a:p>
+          </p:txBody>
+        </p:sp>
+        <p:sp>
+          <p:nvSpPr>
+            <p:cNvPr id="18" name="직사각형 17"/>
+            <p:cNvSpPr/>
+            <p:nvPr/>
+          </p:nvSpPr>
+          <p:spPr>
+            <a:xfrm>
+              <a:off x="9886913" y="4488151"/>
+              <a:ext cx="604653" cy="369332"/>
+            </a:xfrm>
+            <a:prstGeom prst="rect">
+              <a:avLst/>
+            </a:prstGeom>
+          </p:spPr>
+          <p:txBody>
+            <a:bodyPr wrap="none">
+              <a:spAutoFit/>
+            </a:bodyPr>
+            <a:lstStyle/>
+            <a:p>
+              <a:r>
+                <a:rPr lang="ko-KR" altLang="en-US" dirty="0">
+                  <a:solidFill>
+                    <a:schemeClr val="bg1"/>
+                  </a:solidFill>
+                  <a:latin typeface="나눔스퀘어 Bold" panose="020B0600000101010101" pitchFamily="50" charset="-127"/>
+                  <a:ea typeface="나눔스퀘어 Bold" panose="020B0600000101010101" pitchFamily="50" charset="-127"/>
+                </a:rPr>
+                <a:t>동</a:t>
+              </a:r>
+              <a:r>
+                <a:rPr lang="ko-KR" altLang="en-US" dirty="0" smtClean="0">
+                  <a:solidFill>
+                    <a:schemeClr val="bg1"/>
+                  </a:solidFill>
+                  <a:latin typeface="나눔스퀘어 Bold" panose="020B0600000101010101" pitchFamily="50" charset="-127"/>
+                  <a:ea typeface="나눔스퀘어 Bold" panose="020B0600000101010101" pitchFamily="50" charset="-127"/>
+                </a:rPr>
+                <a:t>적</a:t>
+              </a:r>
+              <a:endParaRPr lang="ko-KR" altLang="en-US" dirty="0">
                 <a:solidFill>
                   <a:schemeClr val="bg1"/>
                 </a:solidFill>
                 <a:latin typeface="나눔스퀘어 Bold" panose="020B0600000101010101" pitchFamily="50" charset="-127"/>
                 <a:ea typeface="나눔스퀘어 Bold" panose="020B0600000101010101" pitchFamily="50" charset="-127"/>
-              </a:rPr>
-              <a:t>정적</a:t>
-            </a:r>
-          </a:p>
-        </p:txBody>
-      </p:sp>
-      <p:sp>
-        <p:nvSpPr>
-          <p:cNvPr id="18" name="직사각형 17"/>
-          <p:cNvSpPr/>
-          <p:nvPr/>
-        </p:nvSpPr>
-        <p:spPr>
-          <a:xfrm>
-            <a:off x="9886913" y="4488151"/>
-            <a:ext cx="604653" cy="369332"/>
-          </a:xfrm>
-          <a:prstGeom prst="rect">
-            <a:avLst/>
-          </a:prstGeom>
-        </p:spPr>
-        <p:txBody>
-          <a:bodyPr wrap="none">
-            <a:spAutoFit/>
-          </a:bodyPr>
-          <a:lstStyle/>
-          <a:p>
-            <a:r>
-              <a:rPr lang="ko-KR" altLang="en-US" dirty="0">
-                <a:solidFill>
-                  <a:schemeClr val="bg1"/>
-                </a:solidFill>
-                <a:latin typeface="나눔스퀘어 Bold" panose="020B0600000101010101" pitchFamily="50" charset="-127"/>
-                <a:ea typeface="나눔스퀘어 Bold" panose="020B0600000101010101" pitchFamily="50" charset="-127"/>
-              </a:rPr>
-              <a:t>동</a:t>
-            </a:r>
-            <a:r>
-              <a:rPr lang="ko-KR" altLang="en-US" dirty="0" smtClean="0">
-                <a:solidFill>
-                  <a:schemeClr val="bg1"/>
-                </a:solidFill>
-                <a:latin typeface="나눔스퀘어 Bold" panose="020B0600000101010101" pitchFamily="50" charset="-127"/>
-                <a:ea typeface="나눔스퀘어 Bold" panose="020B0600000101010101" pitchFamily="50" charset="-127"/>
-              </a:rPr>
-              <a:t>적</a:t>
-            </a:r>
-            <a:endParaRPr lang="ko-KR" altLang="en-US" dirty="0">
+              </a:endParaRPr>
+            </a:p>
+          </p:txBody>
+        </p:sp>
+        <p:sp>
+          <p:nvSpPr>
+            <p:cNvPr id="22" name="TextBox 21"/>
+            <p:cNvSpPr txBox="1"/>
+            <p:nvPr/>
+          </p:nvSpPr>
+          <p:spPr>
+            <a:xfrm>
+              <a:off x="8792130" y="5378272"/>
+              <a:ext cx="1857624" cy="369332"/>
+            </a:xfrm>
+            <a:prstGeom prst="rect">
+              <a:avLst/>
+            </a:prstGeom>
+            <a:noFill/>
+          </p:spPr>
+          <p:txBody>
+            <a:bodyPr wrap="none" rtlCol="0">
+              <a:spAutoFit/>
+            </a:bodyPr>
+            <a:lstStyle/>
+            <a:p>
+              <a:r>
+                <a:rPr lang="en-US" altLang="ko-KR" smtClean="0">
+                  <a:latin typeface="나눔스퀘어 Bold" panose="020B0600000101010101" pitchFamily="50" charset="-127"/>
+                  <a:ea typeface="나눔스퀘어 Bold" panose="020B0600000101010101" pitchFamily="50" charset="-127"/>
+                </a:rPr>
+                <a:t>Response (</a:t>
+              </a:r>
+              <a:r>
+                <a:rPr lang="ko-KR" altLang="en-US" dirty="0">
+                  <a:latin typeface="나눔스퀘어 Bold" panose="020B0600000101010101" pitchFamily="50" charset="-127"/>
+                  <a:ea typeface="나눔스퀘어 Bold" panose="020B0600000101010101" pitchFamily="50" charset="-127"/>
+                </a:rPr>
+                <a:t>동</a:t>
+              </a:r>
+              <a:r>
+                <a:rPr lang="ko-KR" altLang="en-US" dirty="0" smtClean="0">
+                  <a:latin typeface="나눔스퀘어 Bold" panose="020B0600000101010101" pitchFamily="50" charset="-127"/>
+                  <a:ea typeface="나눔스퀘어 Bold" panose="020B0600000101010101" pitchFamily="50" charset="-127"/>
+                </a:rPr>
+                <a:t>적</a:t>
+              </a:r>
+              <a:r>
+                <a:rPr lang="en-US" altLang="ko-KR" dirty="0" smtClean="0">
+                  <a:latin typeface="나눔스퀘어 Bold" panose="020B0600000101010101" pitchFamily="50" charset="-127"/>
+                  <a:ea typeface="나눔스퀘어 Bold" panose="020B0600000101010101" pitchFamily="50" charset="-127"/>
+                </a:rPr>
+                <a:t>)</a:t>
+              </a:r>
+              <a:endParaRPr lang="ko-KR" altLang="en-US" dirty="0">
+                <a:latin typeface="나눔스퀘어 Bold" panose="020B0600000101010101" pitchFamily="50" charset="-127"/>
+                <a:ea typeface="나눔스퀘어 Bold" panose="020B0600000101010101" pitchFamily="50" charset="-127"/>
+              </a:endParaRPr>
+            </a:p>
+          </p:txBody>
+        </p:sp>
+        <p:sp>
+          <p:nvSpPr>
+            <p:cNvPr id="24" name="직사각형 23"/>
+            <p:cNvSpPr/>
+            <p:nvPr/>
+          </p:nvSpPr>
+          <p:spPr>
+            <a:xfrm>
+              <a:off x="4690811" y="3864251"/>
+              <a:ext cx="1442405" cy="921657"/>
+            </a:xfrm>
+            <a:prstGeom prst="rect">
+              <a:avLst/>
+            </a:prstGeom>
+            <a:solidFill>
+              <a:schemeClr val="accent5"/>
+            </a:solidFill>
+            <a:ln>
               <a:solidFill>
-                <a:schemeClr val="bg1"/>
+                <a:schemeClr val="tx1"/>
               </a:solidFill>
-              <a:latin typeface="나눔스퀘어 Bold" panose="020B0600000101010101" pitchFamily="50" charset="-127"/>
-              <a:ea typeface="나눔스퀘어 Bold" panose="020B0600000101010101" pitchFamily="50" charset="-127"/>
-            </a:endParaRPr>
-          </a:p>
-        </p:txBody>
-      </p:sp>
-      <p:sp>
-        <p:nvSpPr>
-          <p:cNvPr id="22" name="TextBox 21"/>
-          <p:cNvSpPr txBox="1"/>
-          <p:nvPr/>
-        </p:nvSpPr>
-        <p:spPr>
-          <a:xfrm>
-            <a:off x="8792130" y="5378272"/>
-            <a:ext cx="1857624" cy="369332"/>
-          </a:xfrm>
-          <a:prstGeom prst="rect">
-            <a:avLst/>
-          </a:prstGeom>
-          <a:noFill/>
-        </p:spPr>
-        <p:txBody>
-          <a:bodyPr wrap="none" rtlCol="0">
-            <a:spAutoFit/>
-          </a:bodyPr>
-          <a:lstStyle/>
-          <a:p>
-            <a:r>
-              <a:rPr lang="en-US" altLang="ko-KR" smtClean="0">
-                <a:latin typeface="나눔스퀘어 Bold" panose="020B0600000101010101" pitchFamily="50" charset="-127"/>
-                <a:ea typeface="나눔스퀘어 Bold" panose="020B0600000101010101" pitchFamily="50" charset="-127"/>
-              </a:rPr>
-              <a:t>Response (</a:t>
-            </a:r>
-            <a:r>
-              <a:rPr lang="ko-KR" altLang="en-US" dirty="0">
-                <a:latin typeface="나눔스퀘어 Bold" panose="020B0600000101010101" pitchFamily="50" charset="-127"/>
-                <a:ea typeface="나눔스퀘어 Bold" panose="020B0600000101010101" pitchFamily="50" charset="-127"/>
-              </a:rPr>
-              <a:t>동</a:t>
-            </a:r>
-            <a:r>
-              <a:rPr lang="ko-KR" altLang="en-US" dirty="0" smtClean="0">
-                <a:latin typeface="나눔스퀘어 Bold" panose="020B0600000101010101" pitchFamily="50" charset="-127"/>
-                <a:ea typeface="나눔스퀘어 Bold" panose="020B0600000101010101" pitchFamily="50" charset="-127"/>
-              </a:rPr>
-              <a:t>적</a:t>
-            </a:r>
-            <a:r>
-              <a:rPr lang="en-US" altLang="ko-KR" dirty="0" smtClean="0">
-                <a:latin typeface="나눔스퀘어 Bold" panose="020B0600000101010101" pitchFamily="50" charset="-127"/>
-                <a:ea typeface="나눔스퀘어 Bold" panose="020B0600000101010101" pitchFamily="50" charset="-127"/>
-              </a:rPr>
-              <a:t>)</a:t>
-            </a:r>
-            <a:endParaRPr lang="ko-KR" altLang="en-US" dirty="0">
-              <a:latin typeface="나눔스퀘어 Bold" panose="020B0600000101010101" pitchFamily="50" charset="-127"/>
-              <a:ea typeface="나눔스퀘어 Bold" panose="020B0600000101010101" pitchFamily="50" charset="-127"/>
-            </a:endParaRPr>
-          </a:p>
-        </p:txBody>
-      </p:sp>
-      <p:sp>
-        <p:nvSpPr>
-          <p:cNvPr id="24" name="직사각형 23"/>
-          <p:cNvSpPr/>
-          <p:nvPr/>
-        </p:nvSpPr>
-        <p:spPr>
-          <a:xfrm>
-            <a:off x="4690811" y="3864251"/>
-            <a:ext cx="1442405" cy="921657"/>
-          </a:xfrm>
-          <a:prstGeom prst="rect">
-            <a:avLst/>
-          </a:prstGeom>
-          <a:solidFill>
-            <a:schemeClr val="accent5"/>
-          </a:solidFill>
-          <a:ln>
-            <a:solidFill>
+            </a:ln>
+          </p:spPr>
+          <p:style>
+            <a:lnRef idx="2">
+              <a:schemeClr val="accent1">
+                <a:shade val="50000"/>
+              </a:schemeClr>
+            </a:lnRef>
+            <a:fillRef idx="1">
+              <a:schemeClr val="accent1"/>
+            </a:fillRef>
+            <a:effectRef idx="0">
+              <a:schemeClr val="accent1"/>
+            </a:effectRef>
+            <a:fontRef idx="minor">
+              <a:schemeClr val="lt1"/>
+            </a:fontRef>
+          </p:style>
+          <p:txBody>
+            <a:bodyPr rtlCol="0" anchor="ctr"/>
+            <a:lstStyle/>
+            <a:p>
+              <a:pPr algn="ctr"/>
+              <a:r>
+                <a:rPr lang="en-US" altLang="ko-KR" dirty="0" smtClean="0">
+                  <a:latin typeface="나눔스퀘어 Bold" panose="020B0600000101010101" pitchFamily="50" charset="-127"/>
+                  <a:ea typeface="나눔스퀘어 Bold" panose="020B0600000101010101" pitchFamily="50" charset="-127"/>
+                </a:rPr>
+                <a:t>DNS</a:t>
+              </a:r>
+            </a:p>
+            <a:p>
+              <a:pPr algn="ctr"/>
+              <a:r>
+                <a:rPr lang="en-US" altLang="ko-KR" dirty="0" smtClean="0">
+                  <a:latin typeface="나눔스퀘어 Bold" panose="020B0600000101010101" pitchFamily="50" charset="-127"/>
+                  <a:ea typeface="나눔스퀘어 Bold" panose="020B0600000101010101" pitchFamily="50" charset="-127"/>
+                </a:rPr>
+                <a:t>(8.8.8.8)</a:t>
+              </a:r>
+              <a:endParaRPr lang="ko-KR" altLang="en-US" dirty="0">
+                <a:latin typeface="나눔스퀘어 Bold" panose="020B0600000101010101" pitchFamily="50" charset="-127"/>
+                <a:ea typeface="나눔스퀘어 Bold" panose="020B0600000101010101" pitchFamily="50" charset="-127"/>
+              </a:endParaRPr>
+            </a:p>
+          </p:txBody>
+        </p:sp>
+        <p:cxnSp>
+          <p:nvCxnSpPr>
+            <p:cNvPr id="27" name="꺾인 연결선 26"/>
+            <p:cNvCxnSpPr>
+              <a:stCxn id="9" idx="2"/>
+              <a:endCxn id="6" idx="2"/>
+            </p:cNvCxnSpPr>
+            <p:nvPr/>
+          </p:nvCxnSpPr>
+          <p:spPr>
+            <a:xfrm rot="5400000">
+              <a:off x="5102092" y="1562321"/>
+              <a:ext cx="633874" cy="6471885"/>
+            </a:xfrm>
+            <a:prstGeom prst="bentConnector3">
+              <a:avLst>
+                <a:gd name="adj1" fmla="val 186440"/>
+              </a:avLst>
+            </a:prstGeom>
+            <a:ln w="76200">
+              <a:solidFill>
+                <a:schemeClr val="accent2"/>
+              </a:solidFill>
+              <a:tailEnd type="triangle"/>
+            </a:ln>
+          </p:spPr>
+          <p:style>
+            <a:lnRef idx="1">
+              <a:schemeClr val="accent1"/>
+            </a:lnRef>
+            <a:fillRef idx="0">
+              <a:schemeClr val="accent1"/>
+            </a:fillRef>
+            <a:effectRef idx="0">
+              <a:schemeClr val="accent1"/>
+            </a:effectRef>
+            <a:fontRef idx="minor">
               <a:schemeClr val="tx1"/>
-            </a:solidFill>
-          </a:ln>
-        </p:spPr>
-        <p:style>
-          <a:lnRef idx="2">
-            <a:schemeClr val="accent1">
-              <a:shade val="50000"/>
-            </a:schemeClr>
-          </a:lnRef>
-          <a:fillRef idx="1">
-            <a:schemeClr val="accent1"/>
-          </a:fillRef>
-          <a:effectRef idx="0">
-            <a:schemeClr val="accent1"/>
-          </a:effectRef>
-          <a:fontRef idx="minor">
-            <a:schemeClr val="lt1"/>
-          </a:fontRef>
-        </p:style>
-        <p:txBody>
-          <a:bodyPr rtlCol="0" anchor="ctr"/>
-          <a:lstStyle/>
-          <a:p>
-            <a:pPr algn="ctr"/>
-            <a:r>
-              <a:rPr lang="en-US" altLang="ko-KR" dirty="0" smtClean="0">
-                <a:latin typeface="나눔스퀘어 Bold" panose="020B0600000101010101" pitchFamily="50" charset="-127"/>
-                <a:ea typeface="나눔스퀘어 Bold" panose="020B0600000101010101" pitchFamily="50" charset="-127"/>
-              </a:rPr>
-              <a:t>DNS</a:t>
-            </a:r>
-          </a:p>
-          <a:p>
-            <a:pPr algn="ctr"/>
-            <a:r>
-              <a:rPr lang="en-US" altLang="ko-KR" dirty="0" smtClean="0">
-                <a:latin typeface="나눔스퀘어 Bold" panose="020B0600000101010101" pitchFamily="50" charset="-127"/>
-                <a:ea typeface="나눔스퀘어 Bold" panose="020B0600000101010101" pitchFamily="50" charset="-127"/>
-              </a:rPr>
-              <a:t>(8.8.8.8)</a:t>
-            </a:r>
-            <a:endParaRPr lang="ko-KR" altLang="en-US" dirty="0">
-              <a:latin typeface="나눔스퀘어 Bold" panose="020B0600000101010101" pitchFamily="50" charset="-127"/>
-              <a:ea typeface="나눔스퀘어 Bold" panose="020B0600000101010101" pitchFamily="50" charset="-127"/>
-            </a:endParaRPr>
-          </a:p>
-        </p:txBody>
-      </p:sp>
-      <p:cxnSp>
-        <p:nvCxnSpPr>
-          <p:cNvPr id="27" name="꺾인 연결선 26"/>
-          <p:cNvCxnSpPr>
-            <a:stCxn id="9" idx="2"/>
-            <a:endCxn id="6" idx="2"/>
-          </p:cNvCxnSpPr>
-          <p:nvPr/>
-        </p:nvCxnSpPr>
-        <p:spPr>
-          <a:xfrm rot="5400000">
-            <a:off x="5102092" y="1562321"/>
-            <a:ext cx="633874" cy="6471885"/>
-          </a:xfrm>
-          <a:prstGeom prst="bentConnector3">
-            <a:avLst>
-              <a:gd name="adj1" fmla="val 186440"/>
-            </a:avLst>
-          </a:prstGeom>
-          <a:ln w="76200">
-            <a:solidFill>
-              <a:schemeClr val="accent2"/>
-            </a:solidFill>
-            <a:tailEnd type="triangle"/>
-          </a:ln>
-        </p:spPr>
-        <p:style>
-          <a:lnRef idx="1">
-            <a:schemeClr val="accent1"/>
-          </a:lnRef>
-          <a:fillRef idx="0">
-            <a:schemeClr val="accent1"/>
-          </a:fillRef>
-          <a:effectRef idx="0">
-            <a:schemeClr val="accent1"/>
-          </a:effectRef>
-          <a:fontRef idx="minor">
-            <a:schemeClr val="tx1"/>
-          </a:fontRef>
-        </p:style>
-      </p:cxnSp>
-      <p:cxnSp>
-        <p:nvCxnSpPr>
-          <p:cNvPr id="33" name="꺾인 연결선 32"/>
-          <p:cNvCxnSpPr>
-            <a:stCxn id="8" idx="2"/>
-            <a:endCxn id="6" idx="2"/>
-          </p:cNvCxnSpPr>
-          <p:nvPr/>
-        </p:nvCxnSpPr>
-        <p:spPr>
-          <a:xfrm rot="5400000">
-            <a:off x="6164434" y="492721"/>
-            <a:ext cx="641132" cy="8603827"/>
-          </a:xfrm>
-          <a:prstGeom prst="bentConnector3">
-            <a:avLst>
-              <a:gd name="adj1" fmla="val 221681"/>
-            </a:avLst>
-          </a:prstGeom>
-          <a:ln w="76200">
-            <a:solidFill>
-              <a:schemeClr val="accent2"/>
-            </a:solidFill>
-            <a:tailEnd type="triangle"/>
-          </a:ln>
-        </p:spPr>
-        <p:style>
-          <a:lnRef idx="1">
-            <a:schemeClr val="accent1"/>
-          </a:lnRef>
-          <a:fillRef idx="0">
-            <a:schemeClr val="accent1"/>
-          </a:fillRef>
-          <a:effectRef idx="0">
-            <a:schemeClr val="accent1"/>
-          </a:effectRef>
-          <a:fontRef idx="minor">
-            <a:schemeClr val="tx1"/>
-          </a:fontRef>
-        </p:style>
-      </p:cxnSp>
+            </a:fontRef>
+          </p:style>
+        </p:cxnSp>
+        <p:cxnSp>
+          <p:nvCxnSpPr>
+            <p:cNvPr id="33" name="꺾인 연결선 32"/>
+            <p:cNvCxnSpPr>
+              <a:stCxn id="8" idx="2"/>
+              <a:endCxn id="6" idx="2"/>
+            </p:cNvCxnSpPr>
+            <p:nvPr/>
+          </p:nvCxnSpPr>
+          <p:spPr>
+            <a:xfrm rot="5400000">
+              <a:off x="6164434" y="492721"/>
+              <a:ext cx="641132" cy="8603827"/>
+            </a:xfrm>
+            <a:prstGeom prst="bentConnector3">
+              <a:avLst>
+                <a:gd name="adj1" fmla="val 221681"/>
+              </a:avLst>
+            </a:prstGeom>
+            <a:ln w="76200">
+              <a:solidFill>
+                <a:schemeClr val="accent2"/>
+              </a:solidFill>
+              <a:tailEnd type="triangle"/>
+            </a:ln>
+          </p:spPr>
+          <p:style>
+            <a:lnRef idx="1">
+              <a:schemeClr val="accent1"/>
+            </a:lnRef>
+            <a:fillRef idx="0">
+              <a:schemeClr val="accent1"/>
+            </a:fillRef>
+            <a:effectRef idx="0">
+              <a:schemeClr val="accent1"/>
+            </a:effectRef>
+            <a:fontRef idx="minor">
+              <a:schemeClr val="tx1"/>
+            </a:fontRef>
+          </p:style>
+        </p:cxnSp>
+      </p:grpSp>
     </p:spTree>
     <p:extLst>
       <p:ext uri="{BB962C8B-B14F-4D97-AF65-F5344CB8AC3E}">

</xml_diff>

<commit_message>
20261001 commit : 1_class
</commit_message>
<xml_diff>
--- a/notion/create_notion_img.pptx
+++ b/notion/create_notion_img.pptx
@@ -247,7 +247,7 @@
           <a:p>
             <a:fld id="{7237CE1A-8831-48B5-BA93-72483C6E34E8}" type="datetimeFigureOut">
               <a:rPr lang="ko-KR" altLang="en-US" smtClean="0"/>
-              <a:t>2026-09-30</a:t>
+              <a:t>2026-10-01</a:t>
             </a:fld>
             <a:endParaRPr lang="ko-KR" altLang="en-US"/>
           </a:p>
@@ -417,7 +417,7 @@
           <a:p>
             <a:fld id="{7237CE1A-8831-48B5-BA93-72483C6E34E8}" type="datetimeFigureOut">
               <a:rPr lang="ko-KR" altLang="en-US" smtClean="0"/>
-              <a:t>2026-09-30</a:t>
+              <a:t>2026-10-01</a:t>
             </a:fld>
             <a:endParaRPr lang="ko-KR" altLang="en-US"/>
           </a:p>
@@ -597,7 +597,7 @@
           <a:p>
             <a:fld id="{7237CE1A-8831-48B5-BA93-72483C6E34E8}" type="datetimeFigureOut">
               <a:rPr lang="ko-KR" altLang="en-US" smtClean="0"/>
-              <a:t>2026-09-30</a:t>
+              <a:t>2026-10-01</a:t>
             </a:fld>
             <a:endParaRPr lang="ko-KR" altLang="en-US"/>
           </a:p>
@@ -767,7 +767,7 @@
           <a:p>
             <a:fld id="{7237CE1A-8831-48B5-BA93-72483C6E34E8}" type="datetimeFigureOut">
               <a:rPr lang="ko-KR" altLang="en-US" smtClean="0"/>
-              <a:t>2026-09-30</a:t>
+              <a:t>2026-10-01</a:t>
             </a:fld>
             <a:endParaRPr lang="ko-KR" altLang="en-US"/>
           </a:p>
@@ -1013,7 +1013,7 @@
           <a:p>
             <a:fld id="{7237CE1A-8831-48B5-BA93-72483C6E34E8}" type="datetimeFigureOut">
               <a:rPr lang="ko-KR" altLang="en-US" smtClean="0"/>
-              <a:t>2026-09-30</a:t>
+              <a:t>2026-10-01</a:t>
             </a:fld>
             <a:endParaRPr lang="ko-KR" altLang="en-US"/>
           </a:p>
@@ -1245,7 +1245,7 @@
           <a:p>
             <a:fld id="{7237CE1A-8831-48B5-BA93-72483C6E34E8}" type="datetimeFigureOut">
               <a:rPr lang="ko-KR" altLang="en-US" smtClean="0"/>
-              <a:t>2026-09-30</a:t>
+              <a:t>2026-10-01</a:t>
             </a:fld>
             <a:endParaRPr lang="ko-KR" altLang="en-US"/>
           </a:p>
@@ -1612,7 +1612,7 @@
           <a:p>
             <a:fld id="{7237CE1A-8831-48B5-BA93-72483C6E34E8}" type="datetimeFigureOut">
               <a:rPr lang="ko-KR" altLang="en-US" smtClean="0"/>
-              <a:t>2026-09-30</a:t>
+              <a:t>2026-10-01</a:t>
             </a:fld>
             <a:endParaRPr lang="ko-KR" altLang="en-US"/>
           </a:p>
@@ -1730,7 +1730,7 @@
           <a:p>
             <a:fld id="{7237CE1A-8831-48B5-BA93-72483C6E34E8}" type="datetimeFigureOut">
               <a:rPr lang="ko-KR" altLang="en-US" smtClean="0"/>
-              <a:t>2026-09-30</a:t>
+              <a:t>2026-10-01</a:t>
             </a:fld>
             <a:endParaRPr lang="ko-KR" altLang="en-US"/>
           </a:p>
@@ -1825,7 +1825,7 @@
           <a:p>
             <a:fld id="{7237CE1A-8831-48B5-BA93-72483C6E34E8}" type="datetimeFigureOut">
               <a:rPr lang="ko-KR" altLang="en-US" smtClean="0"/>
-              <a:t>2026-09-30</a:t>
+              <a:t>2026-10-01</a:t>
             </a:fld>
             <a:endParaRPr lang="ko-KR" altLang="en-US"/>
           </a:p>
@@ -2102,7 +2102,7 @@
           <a:p>
             <a:fld id="{7237CE1A-8831-48B5-BA93-72483C6E34E8}" type="datetimeFigureOut">
               <a:rPr lang="ko-KR" altLang="en-US" smtClean="0"/>
-              <a:t>2026-09-30</a:t>
+              <a:t>2026-10-01</a:t>
             </a:fld>
             <a:endParaRPr lang="ko-KR" altLang="en-US"/>
           </a:p>
@@ -2355,7 +2355,7 @@
           <a:p>
             <a:fld id="{7237CE1A-8831-48B5-BA93-72483C6E34E8}" type="datetimeFigureOut">
               <a:rPr lang="ko-KR" altLang="en-US" smtClean="0"/>
-              <a:t>2026-09-30</a:t>
+              <a:t>2026-10-01</a:t>
             </a:fld>
             <a:endParaRPr lang="ko-KR" altLang="en-US"/>
           </a:p>
@@ -2568,7 +2568,7 @@
           <a:p>
             <a:fld id="{7237CE1A-8831-48B5-BA93-72483C6E34E8}" type="datetimeFigureOut">
               <a:rPr lang="ko-KR" altLang="en-US" smtClean="0"/>
-              <a:t>2026-09-30</a:t>
+              <a:t>2026-10-01</a:t>
             </a:fld>
             <a:endParaRPr lang="ko-KR" altLang="en-US"/>
           </a:p>
@@ -2973,1403 +2973,1500 @@
           <a:chExt cx="0" cy="0"/>
         </a:xfrm>
       </p:grpSpPr>
-      <p:grpSp>
-        <p:nvGrpSpPr>
-          <p:cNvPr id="49" name="그룹 48"/>
-          <p:cNvGrpSpPr/>
-          <p:nvPr/>
-        </p:nvGrpSpPr>
-        <p:grpSpPr>
-          <a:xfrm>
-            <a:off x="0" y="0"/>
-            <a:ext cx="12443142" cy="5514214"/>
-            <a:chOff x="0" y="0"/>
-            <a:chExt cx="12443142" cy="5514214"/>
-          </a:xfrm>
-        </p:grpSpPr>
-        <p:sp>
-          <p:nvSpPr>
-            <p:cNvPr id="2" name="직사각형 1"/>
-            <p:cNvSpPr/>
-            <p:nvPr/>
-          </p:nvSpPr>
-          <p:spPr>
-            <a:xfrm>
-              <a:off x="0" y="2217107"/>
-              <a:ext cx="2880000" cy="1440000"/>
-            </a:xfrm>
-            <a:prstGeom prst="rect">
-              <a:avLst/>
-            </a:prstGeom>
+      <p:sp>
+        <p:nvSpPr>
+          <p:cNvPr id="2" name="직사각형 1"/>
+          <p:cNvSpPr/>
+          <p:nvPr/>
+        </p:nvSpPr>
+        <p:spPr>
+          <a:xfrm>
+            <a:off x="0" y="2217107"/>
+            <a:ext cx="2880000" cy="1440000"/>
+          </a:xfrm>
+          <a:prstGeom prst="rect">
+            <a:avLst/>
+          </a:prstGeom>
+          <a:solidFill>
+            <a:schemeClr val="accent5"/>
+          </a:solidFill>
+          <a:ln>
             <a:solidFill>
-              <a:schemeClr val="accent5"/>
+              <a:schemeClr val="tx1"/>
             </a:solidFill>
-            <a:ln>
+          </a:ln>
+        </p:spPr>
+        <p:style>
+          <a:lnRef idx="2">
+            <a:schemeClr val="accent1">
+              <a:shade val="50000"/>
+            </a:schemeClr>
+          </a:lnRef>
+          <a:fillRef idx="1">
+            <a:schemeClr val="accent1"/>
+          </a:fillRef>
+          <a:effectRef idx="0">
+            <a:schemeClr val="accent1"/>
+          </a:effectRef>
+          <a:fontRef idx="minor">
+            <a:schemeClr val="lt1"/>
+          </a:fontRef>
+        </p:style>
+        <p:txBody>
+          <a:bodyPr rtlCol="0" anchor="ctr"/>
+          <a:lstStyle/>
+          <a:p>
+            <a:pPr algn="ctr"/>
+            <a:r>
+              <a:rPr lang="ko-KR" altLang="en-US" sz="2400" dirty="0" smtClean="0">
+                <a:latin typeface="나눔스퀘어 Bold" panose="020B0600000101010101" pitchFamily="50" charset="-127"/>
+                <a:ea typeface="나눔스퀘어 Bold" panose="020B0600000101010101" pitchFamily="50" charset="-127"/>
+              </a:rPr>
+              <a:t>개발</a:t>
+            </a:r>
+            <a:r>
+              <a:rPr lang="en-US" altLang="ko-KR" sz="2400" dirty="0" smtClean="0">
+                <a:latin typeface="나눔스퀘어 Bold" panose="020B0600000101010101" pitchFamily="50" charset="-127"/>
+                <a:ea typeface="나눔스퀘어 Bold" panose="020B0600000101010101" pitchFamily="50" charset="-127"/>
+              </a:rPr>
+              <a:t>PC(Local)</a:t>
+            </a:r>
+          </a:p>
+          <a:p>
+            <a:pPr algn="ctr"/>
+            <a:r>
+              <a:rPr lang="en-US" altLang="ko-KR" sz="2400" dirty="0" smtClean="0">
+                <a:latin typeface="나눔스퀘어 Bold" panose="020B0600000101010101" pitchFamily="50" charset="-127"/>
+                <a:ea typeface="나눔스퀘어 Bold" panose="020B0600000101010101" pitchFamily="50" charset="-127"/>
+              </a:rPr>
+              <a:t>JDK, </a:t>
+            </a:r>
+            <a:r>
+              <a:rPr lang="en-US" altLang="ko-KR" sz="2400" dirty="0" err="1" smtClean="0">
+                <a:latin typeface="나눔스퀘어 Bold" panose="020B0600000101010101" pitchFamily="50" charset="-127"/>
+                <a:ea typeface="나눔스퀘어 Bold" panose="020B0600000101010101" pitchFamily="50" charset="-127"/>
+              </a:rPr>
+              <a:t>Git</a:t>
+            </a:r>
+            <a:r>
+              <a:rPr lang="en-US" altLang="ko-KR" sz="2400" dirty="0" smtClean="0">
+                <a:latin typeface="나눔스퀘어 Bold" panose="020B0600000101010101" pitchFamily="50" charset="-127"/>
+                <a:ea typeface="나눔스퀘어 Bold" panose="020B0600000101010101" pitchFamily="50" charset="-127"/>
+              </a:rPr>
+              <a:t>, MySQL</a:t>
+            </a:r>
+            <a:endParaRPr lang="ko-KR" altLang="en-US" sz="2400" dirty="0">
+              <a:latin typeface="나눔스퀘어 Bold" panose="020B0600000101010101" pitchFamily="50" charset="-127"/>
+              <a:ea typeface="나눔스퀘어 Bold" panose="020B0600000101010101" pitchFamily="50" charset="-127"/>
+            </a:endParaRPr>
+          </a:p>
+        </p:txBody>
+      </p:sp>
+      <p:sp>
+        <p:nvSpPr>
+          <p:cNvPr id="4" name="직사각형 3"/>
+          <p:cNvSpPr/>
+          <p:nvPr/>
+        </p:nvSpPr>
+        <p:spPr>
+          <a:xfrm>
+            <a:off x="4656000" y="2217107"/>
+            <a:ext cx="2880000" cy="1440000"/>
+          </a:xfrm>
+          <a:prstGeom prst="rect">
+            <a:avLst/>
+          </a:prstGeom>
+          <a:solidFill>
+            <a:schemeClr val="accent5"/>
+          </a:solidFill>
+          <a:ln>
+            <a:solidFill>
+              <a:schemeClr val="tx1"/>
+            </a:solidFill>
+          </a:ln>
+        </p:spPr>
+        <p:style>
+          <a:lnRef idx="2">
+            <a:schemeClr val="accent1">
+              <a:shade val="50000"/>
+            </a:schemeClr>
+          </a:lnRef>
+          <a:fillRef idx="1">
+            <a:schemeClr val="accent1"/>
+          </a:fillRef>
+          <a:effectRef idx="0">
+            <a:schemeClr val="accent1"/>
+          </a:effectRef>
+          <a:fontRef idx="minor">
+            <a:schemeClr val="lt1"/>
+          </a:fontRef>
+        </p:style>
+        <p:txBody>
+          <a:bodyPr rtlCol="0" anchor="ctr"/>
+          <a:lstStyle/>
+          <a:p>
+            <a:pPr algn="ctr"/>
+            <a:r>
+              <a:rPr lang="en-US" altLang="ko-KR" sz="2000" dirty="0" smtClean="0">
+                <a:latin typeface="나눔스퀘어 Bold" panose="020B0600000101010101" pitchFamily="50" charset="-127"/>
+                <a:ea typeface="나눔스퀘어 Bold" panose="020B0600000101010101" pitchFamily="50" charset="-127"/>
+              </a:rPr>
+              <a:t>Dev(Stage) Server</a:t>
+            </a:r>
+          </a:p>
+          <a:p>
+            <a:pPr algn="ctr"/>
+            <a:r>
+              <a:rPr lang="en-US" altLang="ko-KR" sz="2000" dirty="0" err="1" smtClean="0">
+                <a:latin typeface="나눔스퀘어 Bold" panose="020B0600000101010101" pitchFamily="50" charset="-127"/>
+                <a:ea typeface="나눔스퀘어 Bold" panose="020B0600000101010101" pitchFamily="50" charset="-127"/>
+              </a:rPr>
+              <a:t>Gradle</a:t>
+            </a:r>
+            <a:r>
+              <a:rPr lang="en-US" altLang="ko-KR" sz="2000" dirty="0" smtClean="0">
+                <a:latin typeface="나눔스퀘어 Bold" panose="020B0600000101010101" pitchFamily="50" charset="-127"/>
+                <a:ea typeface="나눔스퀘어 Bold" panose="020B0600000101010101" pitchFamily="50" charset="-127"/>
+              </a:rPr>
+              <a:t>, JDK, </a:t>
+            </a:r>
+            <a:r>
+              <a:rPr lang="en-US" altLang="ko-KR" sz="2000" dirty="0" err="1" smtClean="0">
+                <a:latin typeface="나눔스퀘어 Bold" panose="020B0600000101010101" pitchFamily="50" charset="-127"/>
+                <a:ea typeface="나눔스퀘어 Bold" panose="020B0600000101010101" pitchFamily="50" charset="-127"/>
+              </a:rPr>
+              <a:t>Git</a:t>
+            </a:r>
+            <a:r>
+              <a:rPr lang="en-US" altLang="ko-KR" sz="2000" dirty="0" smtClean="0">
+                <a:latin typeface="나눔스퀘어 Bold" panose="020B0600000101010101" pitchFamily="50" charset="-127"/>
+                <a:ea typeface="나눔스퀘어 Bold" panose="020B0600000101010101" pitchFamily="50" charset="-127"/>
+              </a:rPr>
+              <a:t>, Build</a:t>
+            </a:r>
+            <a:endParaRPr lang="ko-KR" altLang="en-US" sz="2000" dirty="0">
+              <a:latin typeface="나눔스퀘어 Bold" panose="020B0600000101010101" pitchFamily="50" charset="-127"/>
+              <a:ea typeface="나눔스퀘어 Bold" panose="020B0600000101010101" pitchFamily="50" charset="-127"/>
+            </a:endParaRPr>
+          </a:p>
+        </p:txBody>
+      </p:sp>
+      <p:sp>
+        <p:nvSpPr>
+          <p:cNvPr id="5" name="직사각형 4"/>
+          <p:cNvSpPr/>
+          <p:nvPr/>
+        </p:nvSpPr>
+        <p:spPr>
+          <a:xfrm>
+            <a:off x="9492000" y="4434214"/>
+            <a:ext cx="2520000" cy="1080000"/>
+          </a:xfrm>
+          <a:prstGeom prst="rect">
+            <a:avLst/>
+          </a:prstGeom>
+          <a:solidFill>
+            <a:schemeClr val="accent5"/>
+          </a:solidFill>
+          <a:ln>
+            <a:solidFill>
+              <a:schemeClr val="tx1"/>
+            </a:solidFill>
+          </a:ln>
+        </p:spPr>
+        <p:style>
+          <a:lnRef idx="2">
+            <a:schemeClr val="accent1">
+              <a:shade val="50000"/>
+            </a:schemeClr>
+          </a:lnRef>
+          <a:fillRef idx="1">
+            <a:schemeClr val="accent1"/>
+          </a:fillRef>
+          <a:effectRef idx="0">
+            <a:schemeClr val="accent1"/>
+          </a:effectRef>
+          <a:fontRef idx="minor">
+            <a:schemeClr val="lt1"/>
+          </a:fontRef>
+        </p:style>
+        <p:txBody>
+          <a:bodyPr rtlCol="0" anchor="ctr"/>
+          <a:lstStyle/>
+          <a:p>
+            <a:pPr algn="ctr"/>
+            <a:r>
+              <a:rPr lang="en-US" altLang="ko-KR" sz="2400" dirty="0" smtClean="0">
+                <a:latin typeface="나눔스퀘어 Bold" panose="020B0600000101010101" pitchFamily="50" charset="-127"/>
+                <a:ea typeface="나눔스퀘어 Bold" panose="020B0600000101010101" pitchFamily="50" charset="-127"/>
+              </a:rPr>
+              <a:t>Product MySQL</a:t>
+            </a:r>
+            <a:endParaRPr lang="ko-KR" altLang="en-US" sz="2400" dirty="0">
+              <a:latin typeface="나눔스퀘어 Bold" panose="020B0600000101010101" pitchFamily="50" charset="-127"/>
+              <a:ea typeface="나눔스퀘어 Bold" panose="020B0600000101010101" pitchFamily="50" charset="-127"/>
+            </a:endParaRPr>
+          </a:p>
+        </p:txBody>
+      </p:sp>
+      <p:sp>
+        <p:nvSpPr>
+          <p:cNvPr id="6" name="직사각형 5"/>
+          <p:cNvSpPr/>
+          <p:nvPr/>
+        </p:nvSpPr>
+        <p:spPr>
+          <a:xfrm>
+            <a:off x="9312000" y="2217107"/>
+            <a:ext cx="2880000" cy="1440000"/>
+          </a:xfrm>
+          <a:prstGeom prst="rect">
+            <a:avLst/>
+          </a:prstGeom>
+          <a:solidFill>
+            <a:schemeClr val="accent5"/>
+          </a:solidFill>
+          <a:ln>
+            <a:solidFill>
+              <a:schemeClr val="tx1"/>
+            </a:solidFill>
+          </a:ln>
+        </p:spPr>
+        <p:style>
+          <a:lnRef idx="2">
+            <a:schemeClr val="accent1">
+              <a:shade val="50000"/>
+            </a:schemeClr>
+          </a:lnRef>
+          <a:fillRef idx="1">
+            <a:schemeClr val="accent1"/>
+          </a:fillRef>
+          <a:effectRef idx="0">
+            <a:schemeClr val="accent1"/>
+          </a:effectRef>
+          <a:fontRef idx="minor">
+            <a:schemeClr val="lt1"/>
+          </a:fontRef>
+        </p:style>
+        <p:txBody>
+          <a:bodyPr rtlCol="0" anchor="ctr"/>
+          <a:lstStyle/>
+          <a:p>
+            <a:pPr algn="ctr"/>
+            <a:r>
+              <a:rPr lang="en-US" altLang="ko-KR" sz="2000" dirty="0" smtClean="0">
+                <a:latin typeface="나눔스퀘어 Bold" panose="020B0600000101010101" pitchFamily="50" charset="-127"/>
+                <a:ea typeface="나눔스퀘어 Bold" panose="020B0600000101010101" pitchFamily="50" charset="-127"/>
+              </a:rPr>
+              <a:t>Product Server</a:t>
+            </a:r>
+          </a:p>
+          <a:p>
+            <a:pPr algn="ctr"/>
+            <a:r>
+              <a:rPr lang="en-US" altLang="ko-KR" sz="2000" dirty="0" err="1" smtClean="0">
+                <a:latin typeface="나눔스퀘어 Bold" panose="020B0600000101010101" pitchFamily="50" charset="-127"/>
+                <a:ea typeface="나눔스퀘어 Bold" panose="020B0600000101010101" pitchFamily="50" charset="-127"/>
+              </a:rPr>
+              <a:t>Gradle</a:t>
+            </a:r>
+            <a:r>
+              <a:rPr lang="en-US" altLang="ko-KR" sz="2000" dirty="0" smtClean="0">
+                <a:latin typeface="나눔스퀘어 Bold" panose="020B0600000101010101" pitchFamily="50" charset="-127"/>
+                <a:ea typeface="나눔스퀘어 Bold" panose="020B0600000101010101" pitchFamily="50" charset="-127"/>
+              </a:rPr>
+              <a:t>, JDK, </a:t>
+            </a:r>
+            <a:r>
+              <a:rPr lang="en-US" altLang="ko-KR" sz="2000" dirty="0" err="1" smtClean="0">
+                <a:latin typeface="나눔스퀘어 Bold" panose="020B0600000101010101" pitchFamily="50" charset="-127"/>
+                <a:ea typeface="나눔스퀘어 Bold" panose="020B0600000101010101" pitchFamily="50" charset="-127"/>
+              </a:rPr>
+              <a:t>Git</a:t>
+            </a:r>
+            <a:r>
+              <a:rPr lang="en-US" altLang="ko-KR" sz="2000" dirty="0" smtClean="0">
+                <a:latin typeface="나눔스퀘어 Bold" panose="020B0600000101010101" pitchFamily="50" charset="-127"/>
+                <a:ea typeface="나눔스퀘어 Bold" panose="020B0600000101010101" pitchFamily="50" charset="-127"/>
+              </a:rPr>
+              <a:t>, Build</a:t>
+            </a:r>
+            <a:endParaRPr lang="ko-KR" altLang="en-US" sz="2000" dirty="0" smtClean="0">
+              <a:latin typeface="나눔스퀘어 Bold" panose="020B0600000101010101" pitchFamily="50" charset="-127"/>
+              <a:ea typeface="나눔스퀘어 Bold" panose="020B0600000101010101" pitchFamily="50" charset="-127"/>
+            </a:endParaRPr>
+          </a:p>
+        </p:txBody>
+      </p:sp>
+      <p:sp>
+        <p:nvSpPr>
+          <p:cNvPr id="11" name="직사각형 10"/>
+          <p:cNvSpPr/>
+          <p:nvPr/>
+        </p:nvSpPr>
+        <p:spPr>
+          <a:xfrm>
+            <a:off x="4760972" y="4434214"/>
+            <a:ext cx="2520000" cy="1080000"/>
+          </a:xfrm>
+          <a:prstGeom prst="rect">
+            <a:avLst/>
+          </a:prstGeom>
+          <a:solidFill>
+            <a:schemeClr val="accent5"/>
+          </a:solidFill>
+          <a:ln>
+            <a:solidFill>
+              <a:schemeClr val="tx1"/>
+            </a:solidFill>
+          </a:ln>
+        </p:spPr>
+        <p:style>
+          <a:lnRef idx="2">
+            <a:schemeClr val="accent1">
+              <a:shade val="50000"/>
+            </a:schemeClr>
+          </a:lnRef>
+          <a:fillRef idx="1">
+            <a:schemeClr val="accent1"/>
+          </a:fillRef>
+          <a:effectRef idx="0">
+            <a:schemeClr val="accent1"/>
+          </a:effectRef>
+          <a:fontRef idx="minor">
+            <a:schemeClr val="lt1"/>
+          </a:fontRef>
+        </p:style>
+        <p:txBody>
+          <a:bodyPr rtlCol="0" anchor="ctr"/>
+          <a:lstStyle/>
+          <a:p>
+            <a:pPr algn="ctr"/>
+            <a:r>
+              <a:rPr lang="en-US" altLang="ko-KR" sz="2400" dirty="0" smtClean="0">
+                <a:latin typeface="나눔스퀘어 Bold" panose="020B0600000101010101" pitchFamily="50" charset="-127"/>
+                <a:ea typeface="나눔스퀘어 Bold" panose="020B0600000101010101" pitchFamily="50" charset="-127"/>
+              </a:rPr>
+              <a:t>Dev MySQL</a:t>
+            </a:r>
+            <a:endParaRPr lang="ko-KR" altLang="en-US" sz="2400" dirty="0">
+              <a:latin typeface="나눔스퀘어 Bold" panose="020B0600000101010101" pitchFamily="50" charset="-127"/>
+              <a:ea typeface="나눔스퀘어 Bold" panose="020B0600000101010101" pitchFamily="50" charset="-127"/>
+            </a:endParaRPr>
+          </a:p>
+        </p:txBody>
+      </p:sp>
+      <p:cxnSp>
+        <p:nvCxnSpPr>
+          <p:cNvPr id="23" name="꺾인 연결선 22"/>
+          <p:cNvCxnSpPr>
+            <a:stCxn id="4" idx="3"/>
+            <a:endCxn id="13" idx="1"/>
+          </p:cNvCxnSpPr>
+          <p:nvPr/>
+        </p:nvCxnSpPr>
+        <p:spPr>
+          <a:xfrm flipH="1" flipV="1">
+            <a:off x="7163999" y="540000"/>
+            <a:ext cx="372001" cy="2397107"/>
+          </a:xfrm>
+          <a:prstGeom prst="bentConnector5">
+            <a:avLst>
+              <a:gd name="adj1" fmla="val -142264"/>
+              <a:gd name="adj2" fmla="val 53755"/>
+              <a:gd name="adj3" fmla="val 238896"/>
+            </a:avLst>
+          </a:prstGeom>
+          <a:ln w="76200">
+            <a:solidFill>
+              <a:schemeClr val="accent2"/>
+            </a:solidFill>
+            <a:tailEnd type="triangle"/>
+          </a:ln>
+        </p:spPr>
+        <p:style>
+          <a:lnRef idx="1">
+            <a:schemeClr val="accent1"/>
+          </a:lnRef>
+          <a:fillRef idx="0">
+            <a:schemeClr val="accent1"/>
+          </a:fillRef>
+          <a:effectRef idx="0">
+            <a:schemeClr val="accent1"/>
+          </a:effectRef>
+          <a:fontRef idx="minor">
+            <a:schemeClr val="tx1"/>
+          </a:fontRef>
+        </p:style>
+      </p:cxnSp>
+      <p:sp>
+        <p:nvSpPr>
+          <p:cNvPr id="3" name="직사각형 2"/>
+          <p:cNvSpPr/>
+          <p:nvPr/>
+        </p:nvSpPr>
+        <p:spPr>
+          <a:xfrm>
+            <a:off x="2507999" y="0"/>
+            <a:ext cx="2520000" cy="1080000"/>
+          </a:xfrm>
+          <a:prstGeom prst="rect">
+            <a:avLst/>
+          </a:prstGeom>
+          <a:solidFill>
+            <a:schemeClr val="accent5"/>
+          </a:solidFill>
+          <a:ln>
+            <a:solidFill>
+              <a:schemeClr val="tx1"/>
+            </a:solidFill>
+          </a:ln>
+        </p:spPr>
+        <p:style>
+          <a:lnRef idx="2">
+            <a:schemeClr val="accent1">
+              <a:shade val="50000"/>
+            </a:schemeClr>
+          </a:lnRef>
+          <a:fillRef idx="1">
+            <a:schemeClr val="accent1"/>
+          </a:fillRef>
+          <a:effectRef idx="0">
+            <a:schemeClr val="accent1"/>
+          </a:effectRef>
+          <a:fontRef idx="minor">
+            <a:schemeClr val="lt1"/>
+          </a:fontRef>
+        </p:style>
+        <p:txBody>
+          <a:bodyPr rtlCol="0" anchor="ctr"/>
+          <a:lstStyle/>
+          <a:p>
+            <a:pPr algn="ctr"/>
+            <a:r>
+              <a:rPr lang="en-US" altLang="ko-KR" sz="2400" dirty="0" smtClean="0">
+                <a:latin typeface="나눔스퀘어 Bold" panose="020B0600000101010101" pitchFamily="50" charset="-127"/>
+                <a:ea typeface="나눔스퀘어 Bold" panose="020B0600000101010101" pitchFamily="50" charset="-127"/>
+              </a:rPr>
+              <a:t>GitHub</a:t>
+            </a:r>
+            <a:endParaRPr lang="ko-KR" altLang="en-US" sz="2400" dirty="0">
+              <a:latin typeface="나눔스퀘어 Bold" panose="020B0600000101010101" pitchFamily="50" charset="-127"/>
+              <a:ea typeface="나눔스퀘어 Bold" panose="020B0600000101010101" pitchFamily="50" charset="-127"/>
+            </a:endParaRPr>
+          </a:p>
+        </p:txBody>
+      </p:sp>
+      <p:sp>
+        <p:nvSpPr>
+          <p:cNvPr id="13" name="직사각형 12"/>
+          <p:cNvSpPr/>
+          <p:nvPr/>
+        </p:nvSpPr>
+        <p:spPr>
+          <a:xfrm>
+            <a:off x="7163999" y="0"/>
+            <a:ext cx="2520000" cy="1080000"/>
+          </a:xfrm>
+          <a:prstGeom prst="rect">
+            <a:avLst/>
+          </a:prstGeom>
+          <a:solidFill>
+            <a:schemeClr val="accent5"/>
+          </a:solidFill>
+          <a:ln>
+            <a:solidFill>
+              <a:schemeClr val="tx1"/>
+            </a:solidFill>
+          </a:ln>
+        </p:spPr>
+        <p:style>
+          <a:lnRef idx="2">
+            <a:schemeClr val="accent1">
+              <a:shade val="50000"/>
+            </a:schemeClr>
+          </a:lnRef>
+          <a:fillRef idx="1">
+            <a:schemeClr val="accent1"/>
+          </a:fillRef>
+          <a:effectRef idx="0">
+            <a:schemeClr val="accent1"/>
+          </a:effectRef>
+          <a:fontRef idx="minor">
+            <a:schemeClr val="lt1"/>
+          </a:fontRef>
+        </p:style>
+        <p:txBody>
+          <a:bodyPr rtlCol="0" anchor="ctr"/>
+          <a:lstStyle/>
+          <a:p>
+            <a:pPr algn="ctr"/>
+            <a:r>
+              <a:rPr lang="en-US" altLang="ko-KR" sz="2400" dirty="0" err="1" smtClean="0">
+                <a:latin typeface="나눔스퀘어 Bold" panose="020B0600000101010101" pitchFamily="50" charset="-127"/>
+                <a:ea typeface="나눔스퀘어 Bold" panose="020B0600000101010101" pitchFamily="50" charset="-127"/>
+              </a:rPr>
+              <a:t>DockerHub</a:t>
+            </a:r>
+            <a:endParaRPr lang="ko-KR" altLang="en-US" sz="2400" dirty="0">
+              <a:latin typeface="나눔스퀘어 Bold" panose="020B0600000101010101" pitchFamily="50" charset="-127"/>
+              <a:ea typeface="나눔스퀘어 Bold" panose="020B0600000101010101" pitchFamily="50" charset="-127"/>
+            </a:endParaRPr>
+          </a:p>
+        </p:txBody>
+      </p:sp>
+      <p:sp>
+        <p:nvSpPr>
+          <p:cNvPr id="25" name="직사각형 24"/>
+          <p:cNvSpPr/>
+          <p:nvPr/>
+        </p:nvSpPr>
+        <p:spPr>
+          <a:xfrm>
+            <a:off x="180000" y="4434214"/>
+            <a:ext cx="2520000" cy="1080000"/>
+          </a:xfrm>
+          <a:prstGeom prst="rect">
+            <a:avLst/>
+          </a:prstGeom>
+          <a:solidFill>
+            <a:schemeClr val="accent5"/>
+          </a:solidFill>
+          <a:ln>
+            <a:solidFill>
+              <a:schemeClr val="tx1"/>
+            </a:solidFill>
+          </a:ln>
+        </p:spPr>
+        <p:style>
+          <a:lnRef idx="2">
+            <a:schemeClr val="accent1">
+              <a:shade val="50000"/>
+            </a:schemeClr>
+          </a:lnRef>
+          <a:fillRef idx="1">
+            <a:schemeClr val="accent1"/>
+          </a:fillRef>
+          <a:effectRef idx="0">
+            <a:schemeClr val="accent1"/>
+          </a:effectRef>
+          <a:fontRef idx="minor">
+            <a:schemeClr val="lt1"/>
+          </a:fontRef>
+        </p:style>
+        <p:txBody>
+          <a:bodyPr rtlCol="0" anchor="ctr"/>
+          <a:lstStyle/>
+          <a:p>
+            <a:pPr algn="ctr"/>
+            <a:r>
+              <a:rPr lang="ko-KR" altLang="en-US" sz="2400" dirty="0" smtClean="0">
+                <a:latin typeface="나눔스퀘어 Bold" panose="020B0600000101010101" pitchFamily="50" charset="-127"/>
+                <a:ea typeface="나눔스퀘어 Bold" panose="020B0600000101010101" pitchFamily="50" charset="-127"/>
+              </a:rPr>
+              <a:t>개발</a:t>
+            </a:r>
+            <a:r>
+              <a:rPr lang="en-US" altLang="ko-KR" sz="2400" dirty="0" smtClean="0">
+                <a:latin typeface="나눔스퀘어 Bold" panose="020B0600000101010101" pitchFamily="50" charset="-127"/>
+                <a:ea typeface="나눔스퀘어 Bold" panose="020B0600000101010101" pitchFamily="50" charset="-127"/>
+              </a:rPr>
+              <a:t> MySQL</a:t>
+            </a:r>
+            <a:endParaRPr lang="ko-KR" altLang="en-US" sz="2400" dirty="0">
+              <a:latin typeface="나눔스퀘어 Bold" panose="020B0600000101010101" pitchFamily="50" charset="-127"/>
+              <a:ea typeface="나눔스퀘어 Bold" panose="020B0600000101010101" pitchFamily="50" charset="-127"/>
+            </a:endParaRPr>
+          </a:p>
+        </p:txBody>
+      </p:sp>
+      <p:sp>
+        <p:nvSpPr>
+          <p:cNvPr id="27" name="직사각형 26"/>
+          <p:cNvSpPr/>
+          <p:nvPr/>
+        </p:nvSpPr>
+        <p:spPr>
+          <a:xfrm>
+            <a:off x="6804000" y="1378553"/>
+            <a:ext cx="2160000" cy="540000"/>
+          </a:xfrm>
+          <a:prstGeom prst="rect">
+            <a:avLst/>
+          </a:prstGeom>
+          <a:solidFill>
+            <a:schemeClr val="accent4"/>
+          </a:solidFill>
+          <a:ln>
+            <a:solidFill>
+              <a:schemeClr val="tx1"/>
+            </a:solidFill>
+          </a:ln>
+        </p:spPr>
+        <p:style>
+          <a:lnRef idx="2">
+            <a:schemeClr val="accent1">
+              <a:shade val="50000"/>
+            </a:schemeClr>
+          </a:lnRef>
+          <a:fillRef idx="1">
+            <a:schemeClr val="accent1"/>
+          </a:fillRef>
+          <a:effectRef idx="0">
+            <a:schemeClr val="accent1"/>
+          </a:effectRef>
+          <a:fontRef idx="minor">
+            <a:schemeClr val="lt1"/>
+          </a:fontRef>
+        </p:style>
+        <p:txBody>
+          <a:bodyPr rtlCol="0" anchor="ctr"/>
+          <a:lstStyle/>
+          <a:p>
+            <a:pPr algn="ctr"/>
+            <a:r>
+              <a:rPr lang="en-US" altLang="ko-KR" dirty="0" smtClean="0">
+                <a:solidFill>
+                  <a:schemeClr val="tx1"/>
+                </a:solidFill>
+                <a:latin typeface="나눔스퀘어 Bold" panose="020B0600000101010101" pitchFamily="50" charset="-127"/>
+                <a:ea typeface="나눔스퀘어 Bold" panose="020B0600000101010101" pitchFamily="50" charset="-127"/>
+              </a:rPr>
+              <a:t>Docker Image(Jar)</a:t>
+            </a:r>
+            <a:endParaRPr lang="ko-KR" altLang="en-US" dirty="0">
               <a:solidFill>
                 <a:schemeClr val="tx1"/>
               </a:solidFill>
-            </a:ln>
-          </p:spPr>
-          <p:style>
-            <a:lnRef idx="2">
-              <a:schemeClr val="accent1">
-                <a:shade val="50000"/>
-              </a:schemeClr>
-            </a:lnRef>
-            <a:fillRef idx="1">
-              <a:schemeClr val="accent1"/>
-            </a:fillRef>
-            <a:effectRef idx="0">
-              <a:schemeClr val="accent1"/>
-            </a:effectRef>
-            <a:fontRef idx="minor">
-              <a:schemeClr val="lt1"/>
-            </a:fontRef>
-          </p:style>
-          <p:txBody>
-            <a:bodyPr rtlCol="0" anchor="ctr"/>
-            <a:lstStyle/>
-            <a:p>
-              <a:pPr algn="ctr"/>
-              <a:r>
-                <a:rPr lang="ko-KR" altLang="en-US" sz="2400" dirty="0" smtClean="0">
-                  <a:latin typeface="나눔스퀘어 Bold" panose="020B0600000101010101" pitchFamily="50" charset="-127"/>
-                  <a:ea typeface="나눔스퀘어 Bold" panose="020B0600000101010101" pitchFamily="50" charset="-127"/>
-                </a:rPr>
-                <a:t>개발</a:t>
-              </a:r>
-              <a:r>
-                <a:rPr lang="en-US" altLang="ko-KR" sz="2400" dirty="0" smtClean="0">
-                  <a:latin typeface="나눔스퀘어 Bold" panose="020B0600000101010101" pitchFamily="50" charset="-127"/>
-                  <a:ea typeface="나눔스퀘어 Bold" panose="020B0600000101010101" pitchFamily="50" charset="-127"/>
-                </a:rPr>
-                <a:t>PC(Local)</a:t>
-              </a:r>
-            </a:p>
-            <a:p>
-              <a:pPr algn="ctr"/>
-              <a:r>
-                <a:rPr lang="en-US" altLang="ko-KR" sz="2400" dirty="0" smtClean="0">
-                  <a:latin typeface="나눔스퀘어 Bold" panose="020B0600000101010101" pitchFamily="50" charset="-127"/>
-                  <a:ea typeface="나눔스퀘어 Bold" panose="020B0600000101010101" pitchFamily="50" charset="-127"/>
-                </a:rPr>
-                <a:t>JDK, </a:t>
-              </a:r>
-              <a:r>
-                <a:rPr lang="en-US" altLang="ko-KR" sz="2400" dirty="0" err="1" smtClean="0">
-                  <a:latin typeface="나눔스퀘어 Bold" panose="020B0600000101010101" pitchFamily="50" charset="-127"/>
-                  <a:ea typeface="나눔스퀘어 Bold" panose="020B0600000101010101" pitchFamily="50" charset="-127"/>
-                </a:rPr>
-                <a:t>Git</a:t>
-              </a:r>
-              <a:r>
-                <a:rPr lang="en-US" altLang="ko-KR" sz="2400" dirty="0" smtClean="0">
-                  <a:latin typeface="나눔스퀘어 Bold" panose="020B0600000101010101" pitchFamily="50" charset="-127"/>
-                  <a:ea typeface="나눔스퀘어 Bold" panose="020B0600000101010101" pitchFamily="50" charset="-127"/>
-                </a:rPr>
-                <a:t>, MySQL</a:t>
-              </a:r>
-              <a:endParaRPr lang="ko-KR" altLang="en-US" sz="2400" dirty="0">
-                <a:latin typeface="나눔스퀘어 Bold" panose="020B0600000101010101" pitchFamily="50" charset="-127"/>
-                <a:ea typeface="나눔스퀘어 Bold" panose="020B0600000101010101" pitchFamily="50" charset="-127"/>
-              </a:endParaRPr>
-            </a:p>
-          </p:txBody>
-        </p:sp>
-        <p:sp>
-          <p:nvSpPr>
-            <p:cNvPr id="4" name="직사각형 3"/>
-            <p:cNvSpPr/>
-            <p:nvPr/>
-          </p:nvSpPr>
-          <p:spPr>
-            <a:xfrm>
-              <a:off x="4656000" y="2217107"/>
-              <a:ext cx="2880000" cy="1440000"/>
-            </a:xfrm>
-            <a:prstGeom prst="rect">
-              <a:avLst/>
-            </a:prstGeom>
+              <a:latin typeface="나눔스퀘어 Bold" panose="020B0600000101010101" pitchFamily="50" charset="-127"/>
+              <a:ea typeface="나눔스퀘어 Bold" panose="020B0600000101010101" pitchFamily="50" charset="-127"/>
+            </a:endParaRPr>
+          </a:p>
+        </p:txBody>
+      </p:sp>
+      <p:cxnSp>
+        <p:nvCxnSpPr>
+          <p:cNvPr id="32" name="꺾인 연결선 31"/>
+          <p:cNvCxnSpPr>
+            <a:stCxn id="13" idx="3"/>
+            <a:endCxn id="6" idx="0"/>
+          </p:cNvCxnSpPr>
+          <p:nvPr/>
+        </p:nvCxnSpPr>
+        <p:spPr>
+          <a:xfrm>
+            <a:off x="9683999" y="540000"/>
+            <a:ext cx="1068001" cy="1677107"/>
+          </a:xfrm>
+          <a:prstGeom prst="bentConnector2">
+            <a:avLst/>
+          </a:prstGeom>
+          <a:ln w="76200">
             <a:solidFill>
-              <a:schemeClr val="accent5"/>
+              <a:schemeClr val="accent2"/>
             </a:solidFill>
-            <a:ln>
+            <a:tailEnd type="triangle"/>
+          </a:ln>
+        </p:spPr>
+        <p:style>
+          <a:lnRef idx="1">
+            <a:schemeClr val="accent1"/>
+          </a:lnRef>
+          <a:fillRef idx="0">
+            <a:schemeClr val="accent1"/>
+          </a:fillRef>
+          <a:effectRef idx="0">
+            <a:schemeClr val="accent1"/>
+          </a:effectRef>
+          <a:fontRef idx="minor">
+            <a:schemeClr val="tx1"/>
+          </a:fontRef>
+        </p:style>
+      </p:cxnSp>
+      <p:cxnSp>
+        <p:nvCxnSpPr>
+          <p:cNvPr id="35" name="꺾인 연결선 34"/>
+          <p:cNvCxnSpPr>
+            <a:stCxn id="2" idx="0"/>
+            <a:endCxn id="3" idx="1"/>
+          </p:cNvCxnSpPr>
+          <p:nvPr/>
+        </p:nvCxnSpPr>
+        <p:spPr>
+          <a:xfrm rot="5400000" flipH="1" flipV="1">
+            <a:off x="1135446" y="844555"/>
+            <a:ext cx="1677107" cy="1067999"/>
+          </a:xfrm>
+          <a:prstGeom prst="bentConnector2">
+            <a:avLst/>
+          </a:prstGeom>
+          <a:ln w="76200">
+            <a:solidFill>
+              <a:schemeClr val="accent2"/>
+            </a:solidFill>
+            <a:tailEnd type="triangle"/>
+          </a:ln>
+        </p:spPr>
+        <p:style>
+          <a:lnRef idx="1">
+            <a:schemeClr val="accent1"/>
+          </a:lnRef>
+          <a:fillRef idx="0">
+            <a:schemeClr val="accent1"/>
+          </a:fillRef>
+          <a:effectRef idx="0">
+            <a:schemeClr val="accent1"/>
+          </a:effectRef>
+          <a:fontRef idx="minor">
+            <a:schemeClr val="tx1"/>
+          </a:fontRef>
+        </p:style>
+      </p:cxnSp>
+      <p:cxnSp>
+        <p:nvCxnSpPr>
+          <p:cNvPr id="38" name="꺾인 연결선 37"/>
+          <p:cNvCxnSpPr>
+            <a:stCxn id="3" idx="3"/>
+            <a:endCxn id="4" idx="0"/>
+          </p:cNvCxnSpPr>
+          <p:nvPr/>
+        </p:nvCxnSpPr>
+        <p:spPr>
+          <a:xfrm>
+            <a:off x="5027999" y="540000"/>
+            <a:ext cx="1068001" cy="1677107"/>
+          </a:xfrm>
+          <a:prstGeom prst="bentConnector2">
+            <a:avLst/>
+          </a:prstGeom>
+          <a:ln w="76200">
+            <a:solidFill>
+              <a:schemeClr val="accent2"/>
+            </a:solidFill>
+            <a:tailEnd type="triangle"/>
+          </a:ln>
+        </p:spPr>
+        <p:style>
+          <a:lnRef idx="1">
+            <a:schemeClr val="accent1"/>
+          </a:lnRef>
+          <a:fillRef idx="0">
+            <a:schemeClr val="accent1"/>
+          </a:fillRef>
+          <a:effectRef idx="0">
+            <a:schemeClr val="accent1"/>
+          </a:effectRef>
+          <a:fontRef idx="minor">
+            <a:schemeClr val="tx1"/>
+          </a:fontRef>
+        </p:style>
+      </p:cxnSp>
+      <p:sp>
+        <p:nvSpPr>
+          <p:cNvPr id="46" name="직사각형 45"/>
+          <p:cNvSpPr/>
+          <p:nvPr/>
+        </p:nvSpPr>
+        <p:spPr>
+          <a:xfrm>
+            <a:off x="4365714" y="1832065"/>
+            <a:ext cx="1440000" cy="720000"/>
+          </a:xfrm>
+          <a:prstGeom prst="rect">
+            <a:avLst/>
+          </a:prstGeom>
+          <a:solidFill>
+            <a:schemeClr val="accent5"/>
+          </a:solidFill>
+          <a:ln>
+            <a:solidFill>
+              <a:schemeClr val="tx1"/>
+            </a:solidFill>
+          </a:ln>
+        </p:spPr>
+        <p:style>
+          <a:lnRef idx="2">
+            <a:schemeClr val="accent1">
+              <a:shade val="50000"/>
+            </a:schemeClr>
+          </a:lnRef>
+          <a:fillRef idx="1">
+            <a:schemeClr val="accent1"/>
+          </a:fillRef>
+          <a:effectRef idx="0">
+            <a:schemeClr val="accent1"/>
+          </a:effectRef>
+          <a:fontRef idx="minor">
+            <a:schemeClr val="lt1"/>
+          </a:fontRef>
+        </p:style>
+        <p:txBody>
+          <a:bodyPr rtlCol="0" anchor="ctr"/>
+          <a:lstStyle/>
+          <a:p>
+            <a:pPr algn="ctr"/>
+            <a:r>
+              <a:rPr lang="en-US" altLang="ko-KR" sz="2400" dirty="0" err="1" smtClean="0">
+                <a:latin typeface="나눔스퀘어 Bold" panose="020B0600000101010101" pitchFamily="50" charset="-127"/>
+                <a:ea typeface="나눔스퀘어 Bold" panose="020B0600000101010101" pitchFamily="50" charset="-127"/>
+              </a:rPr>
+              <a:t>Ngnix</a:t>
+            </a:r>
+            <a:endParaRPr lang="ko-KR" altLang="en-US" sz="2400" dirty="0">
+              <a:latin typeface="나눔스퀘어 Bold" panose="020B0600000101010101" pitchFamily="50" charset="-127"/>
+              <a:ea typeface="나눔스퀘어 Bold" panose="020B0600000101010101" pitchFamily="50" charset="-127"/>
+            </a:endParaRPr>
+          </a:p>
+        </p:txBody>
+      </p:sp>
+      <p:sp>
+        <p:nvSpPr>
+          <p:cNvPr id="47" name="직사각형 46"/>
+          <p:cNvSpPr/>
+          <p:nvPr/>
+        </p:nvSpPr>
+        <p:spPr>
+          <a:xfrm>
+            <a:off x="11003142" y="1831043"/>
+            <a:ext cx="1440000" cy="720000"/>
+          </a:xfrm>
+          <a:prstGeom prst="rect">
+            <a:avLst/>
+          </a:prstGeom>
+          <a:solidFill>
+            <a:schemeClr val="accent5"/>
+          </a:solidFill>
+          <a:ln>
+            <a:solidFill>
+              <a:schemeClr val="tx1"/>
+            </a:solidFill>
+          </a:ln>
+        </p:spPr>
+        <p:style>
+          <a:lnRef idx="2">
+            <a:schemeClr val="accent1">
+              <a:shade val="50000"/>
+            </a:schemeClr>
+          </a:lnRef>
+          <a:fillRef idx="1">
+            <a:schemeClr val="accent1"/>
+          </a:fillRef>
+          <a:effectRef idx="0">
+            <a:schemeClr val="accent1"/>
+          </a:effectRef>
+          <a:fontRef idx="minor">
+            <a:schemeClr val="lt1"/>
+          </a:fontRef>
+        </p:style>
+        <p:txBody>
+          <a:bodyPr rtlCol="0" anchor="ctr"/>
+          <a:lstStyle/>
+          <a:p>
+            <a:pPr algn="ctr"/>
+            <a:r>
+              <a:rPr lang="en-US" altLang="ko-KR" sz="2400" dirty="0" err="1" smtClean="0">
+                <a:latin typeface="나눔스퀘어 Bold" panose="020B0600000101010101" pitchFamily="50" charset="-127"/>
+                <a:ea typeface="나눔스퀘어 Bold" panose="020B0600000101010101" pitchFamily="50" charset="-127"/>
+              </a:rPr>
+              <a:t>Ngnix</a:t>
+            </a:r>
+            <a:endParaRPr lang="ko-KR" altLang="en-US" sz="2400" dirty="0">
+              <a:latin typeface="나눔스퀘어 Bold" panose="020B0600000101010101" pitchFamily="50" charset="-127"/>
+              <a:ea typeface="나눔스퀘어 Bold" panose="020B0600000101010101" pitchFamily="50" charset="-127"/>
+            </a:endParaRPr>
+          </a:p>
+        </p:txBody>
+      </p:sp>
+      <p:sp>
+        <p:nvSpPr>
+          <p:cNvPr id="48" name="직사각형 47"/>
+          <p:cNvSpPr/>
+          <p:nvPr/>
+        </p:nvSpPr>
+        <p:spPr>
+          <a:xfrm>
+            <a:off x="10055998" y="182490"/>
+            <a:ext cx="1440000" cy="720000"/>
+          </a:xfrm>
+          <a:prstGeom prst="rect">
+            <a:avLst/>
+          </a:prstGeom>
+          <a:solidFill>
+            <a:schemeClr val="accent5"/>
+          </a:solidFill>
+          <a:ln>
+            <a:solidFill>
+              <a:schemeClr val="tx1"/>
+            </a:solidFill>
+          </a:ln>
+        </p:spPr>
+        <p:style>
+          <a:lnRef idx="2">
+            <a:schemeClr val="accent1">
+              <a:shade val="50000"/>
+            </a:schemeClr>
+          </a:lnRef>
+          <a:fillRef idx="1">
+            <a:schemeClr val="accent1"/>
+          </a:fillRef>
+          <a:effectRef idx="0">
+            <a:schemeClr val="accent1"/>
+          </a:effectRef>
+          <a:fontRef idx="minor">
+            <a:schemeClr val="lt1"/>
+          </a:fontRef>
+        </p:style>
+        <p:txBody>
+          <a:bodyPr rtlCol="0" anchor="ctr"/>
+          <a:lstStyle/>
+          <a:p>
+            <a:pPr algn="ctr"/>
+            <a:r>
+              <a:rPr lang="en-US" altLang="ko-KR" sz="2400" dirty="0" smtClean="0">
+                <a:latin typeface="나눔스퀘어 Bold" panose="020B0600000101010101" pitchFamily="50" charset="-127"/>
+                <a:ea typeface="나눔스퀘어 Bold" panose="020B0600000101010101" pitchFamily="50" charset="-127"/>
+              </a:rPr>
+              <a:t>DNS</a:t>
+            </a:r>
+            <a:endParaRPr lang="ko-KR" altLang="en-US" sz="2400" dirty="0">
+              <a:latin typeface="나눔스퀘어 Bold" panose="020B0600000101010101" pitchFamily="50" charset="-127"/>
+              <a:ea typeface="나눔스퀘어 Bold" panose="020B0600000101010101" pitchFamily="50" charset="-127"/>
+            </a:endParaRPr>
+          </a:p>
+        </p:txBody>
+      </p:sp>
+      <p:cxnSp>
+        <p:nvCxnSpPr>
+          <p:cNvPr id="8" name="직선 화살표 연결선 7"/>
+          <p:cNvCxnSpPr>
+            <a:stCxn id="25" idx="0"/>
+          </p:cNvCxnSpPr>
+          <p:nvPr/>
+        </p:nvCxnSpPr>
+        <p:spPr>
+          <a:xfrm flipV="1">
+            <a:off x="1440000" y="3940295"/>
+            <a:ext cx="0" cy="493919"/>
+          </a:xfrm>
+          <a:prstGeom prst="straightConnector1">
+            <a:avLst/>
+          </a:prstGeom>
+          <a:ln w="76200">
+            <a:solidFill>
+              <a:schemeClr val="accent2"/>
+            </a:solidFill>
+            <a:prstDash val="sysDot"/>
+            <a:tailEnd type="triangle"/>
+          </a:ln>
+        </p:spPr>
+        <p:style>
+          <a:lnRef idx="1">
+            <a:schemeClr val="accent1"/>
+          </a:lnRef>
+          <a:fillRef idx="0">
+            <a:schemeClr val="accent1"/>
+          </a:fillRef>
+          <a:effectRef idx="0">
+            <a:schemeClr val="accent1"/>
+          </a:effectRef>
+          <a:fontRef idx="minor">
+            <a:schemeClr val="tx1"/>
+          </a:fontRef>
+        </p:style>
+      </p:cxnSp>
+      <p:sp>
+        <p:nvSpPr>
+          <p:cNvPr id="29" name="직사각형 28"/>
+          <p:cNvSpPr/>
+          <p:nvPr/>
+        </p:nvSpPr>
+        <p:spPr>
+          <a:xfrm>
+            <a:off x="152400" y="2369507"/>
+            <a:ext cx="2880000" cy="1440000"/>
+          </a:xfrm>
+          <a:prstGeom prst="rect">
+            <a:avLst/>
+          </a:prstGeom>
+          <a:solidFill>
+            <a:schemeClr val="accent5"/>
+          </a:solidFill>
+          <a:ln>
+            <a:solidFill>
+              <a:schemeClr val="tx1"/>
+            </a:solidFill>
+          </a:ln>
+        </p:spPr>
+        <p:style>
+          <a:lnRef idx="2">
+            <a:schemeClr val="accent1">
+              <a:shade val="50000"/>
+            </a:schemeClr>
+          </a:lnRef>
+          <a:fillRef idx="1">
+            <a:schemeClr val="accent1"/>
+          </a:fillRef>
+          <a:effectRef idx="0">
+            <a:schemeClr val="accent1"/>
+          </a:effectRef>
+          <a:fontRef idx="minor">
+            <a:schemeClr val="lt1"/>
+          </a:fontRef>
+        </p:style>
+        <p:txBody>
+          <a:bodyPr rtlCol="0" anchor="ctr"/>
+          <a:lstStyle/>
+          <a:p>
+            <a:pPr algn="ctr"/>
+            <a:r>
+              <a:rPr lang="ko-KR" altLang="en-US" sz="2400" dirty="0" smtClean="0">
+                <a:latin typeface="나눔스퀘어 Bold" panose="020B0600000101010101" pitchFamily="50" charset="-127"/>
+                <a:ea typeface="나눔스퀘어 Bold" panose="020B0600000101010101" pitchFamily="50" charset="-127"/>
+              </a:rPr>
+              <a:t>개발</a:t>
+            </a:r>
+            <a:r>
+              <a:rPr lang="en-US" altLang="ko-KR" sz="2400" dirty="0" smtClean="0">
+                <a:latin typeface="나눔스퀘어 Bold" panose="020B0600000101010101" pitchFamily="50" charset="-127"/>
+                <a:ea typeface="나눔스퀘어 Bold" panose="020B0600000101010101" pitchFamily="50" charset="-127"/>
+              </a:rPr>
+              <a:t>PC(Local)</a:t>
+            </a:r>
+          </a:p>
+          <a:p>
+            <a:pPr algn="ctr"/>
+            <a:r>
+              <a:rPr lang="en-US" altLang="ko-KR" sz="2400" dirty="0" smtClean="0">
+                <a:latin typeface="나눔스퀘어 Bold" panose="020B0600000101010101" pitchFamily="50" charset="-127"/>
+                <a:ea typeface="나눔스퀘어 Bold" panose="020B0600000101010101" pitchFamily="50" charset="-127"/>
+              </a:rPr>
+              <a:t>JDK, </a:t>
+            </a:r>
+            <a:r>
+              <a:rPr lang="en-US" altLang="ko-KR" sz="2400" dirty="0" err="1" smtClean="0">
+                <a:latin typeface="나눔스퀘어 Bold" panose="020B0600000101010101" pitchFamily="50" charset="-127"/>
+                <a:ea typeface="나눔스퀘어 Bold" panose="020B0600000101010101" pitchFamily="50" charset="-127"/>
+              </a:rPr>
+              <a:t>Git</a:t>
+            </a:r>
+            <a:r>
+              <a:rPr lang="en-US" altLang="ko-KR" sz="2400" dirty="0" smtClean="0">
+                <a:latin typeface="나눔스퀘어 Bold" panose="020B0600000101010101" pitchFamily="50" charset="-127"/>
+                <a:ea typeface="나눔스퀘어 Bold" panose="020B0600000101010101" pitchFamily="50" charset="-127"/>
+              </a:rPr>
+              <a:t>, MySQL</a:t>
+            </a:r>
+            <a:endParaRPr lang="ko-KR" altLang="en-US" sz="2400" dirty="0">
+              <a:latin typeface="나눔스퀘어 Bold" panose="020B0600000101010101" pitchFamily="50" charset="-127"/>
+              <a:ea typeface="나눔스퀘어 Bold" panose="020B0600000101010101" pitchFamily="50" charset="-127"/>
+            </a:endParaRPr>
+          </a:p>
+        </p:txBody>
+      </p:sp>
+      <p:sp>
+        <p:nvSpPr>
+          <p:cNvPr id="30" name="직사각형 29"/>
+          <p:cNvSpPr/>
+          <p:nvPr/>
+        </p:nvSpPr>
+        <p:spPr>
+          <a:xfrm>
+            <a:off x="304800" y="2521907"/>
+            <a:ext cx="2880000" cy="1440000"/>
+          </a:xfrm>
+          <a:prstGeom prst="rect">
+            <a:avLst/>
+          </a:prstGeom>
+          <a:solidFill>
+            <a:schemeClr val="accent5"/>
+          </a:solidFill>
+          <a:ln>
+            <a:solidFill>
+              <a:schemeClr val="tx1"/>
+            </a:solidFill>
+          </a:ln>
+        </p:spPr>
+        <p:style>
+          <a:lnRef idx="2">
+            <a:schemeClr val="accent1">
+              <a:shade val="50000"/>
+            </a:schemeClr>
+          </a:lnRef>
+          <a:fillRef idx="1">
+            <a:schemeClr val="accent1"/>
+          </a:fillRef>
+          <a:effectRef idx="0">
+            <a:schemeClr val="accent1"/>
+          </a:effectRef>
+          <a:fontRef idx="minor">
+            <a:schemeClr val="lt1"/>
+          </a:fontRef>
+        </p:style>
+        <p:txBody>
+          <a:bodyPr rtlCol="0" anchor="ctr"/>
+          <a:lstStyle/>
+          <a:p>
+            <a:pPr algn="ctr"/>
+            <a:r>
+              <a:rPr lang="ko-KR" altLang="en-US" sz="2400" dirty="0" smtClean="0">
+                <a:latin typeface="나눔스퀘어 Bold" panose="020B0600000101010101" pitchFamily="50" charset="-127"/>
+                <a:ea typeface="나눔스퀘어 Bold" panose="020B0600000101010101" pitchFamily="50" charset="-127"/>
+              </a:rPr>
+              <a:t>개발</a:t>
+            </a:r>
+            <a:r>
+              <a:rPr lang="en-US" altLang="ko-KR" sz="2400" dirty="0" smtClean="0">
+                <a:latin typeface="나눔스퀘어 Bold" panose="020B0600000101010101" pitchFamily="50" charset="-127"/>
+                <a:ea typeface="나눔스퀘어 Bold" panose="020B0600000101010101" pitchFamily="50" charset="-127"/>
+              </a:rPr>
+              <a:t>PC(Local)</a:t>
+            </a:r>
+          </a:p>
+          <a:p>
+            <a:pPr algn="ctr"/>
+            <a:r>
+              <a:rPr lang="en-US" altLang="ko-KR" sz="2400" dirty="0" smtClean="0">
+                <a:latin typeface="나눔스퀘어 Bold" panose="020B0600000101010101" pitchFamily="50" charset="-127"/>
+                <a:ea typeface="나눔스퀘어 Bold" panose="020B0600000101010101" pitchFamily="50" charset="-127"/>
+              </a:rPr>
+              <a:t>JDK, </a:t>
+            </a:r>
+            <a:r>
+              <a:rPr lang="en-US" altLang="ko-KR" sz="2400" dirty="0" err="1" smtClean="0">
+                <a:latin typeface="나눔스퀘어 Bold" panose="020B0600000101010101" pitchFamily="50" charset="-127"/>
+                <a:ea typeface="나눔스퀘어 Bold" panose="020B0600000101010101" pitchFamily="50" charset="-127"/>
+              </a:rPr>
+              <a:t>Git</a:t>
+            </a:r>
+            <a:r>
+              <a:rPr lang="en-US" altLang="ko-KR" sz="2400" dirty="0" smtClean="0">
+                <a:latin typeface="나눔스퀘어 Bold" panose="020B0600000101010101" pitchFamily="50" charset="-127"/>
+                <a:ea typeface="나눔스퀘어 Bold" panose="020B0600000101010101" pitchFamily="50" charset="-127"/>
+              </a:rPr>
+              <a:t>, MySQL</a:t>
+            </a:r>
+            <a:endParaRPr lang="ko-KR" altLang="en-US" sz="2400" dirty="0">
+              <a:latin typeface="나눔스퀘어 Bold" panose="020B0600000101010101" pitchFamily="50" charset="-127"/>
+              <a:ea typeface="나눔스퀘어 Bold" panose="020B0600000101010101" pitchFamily="50" charset="-127"/>
+            </a:endParaRPr>
+          </a:p>
+        </p:txBody>
+      </p:sp>
+      <p:cxnSp>
+        <p:nvCxnSpPr>
+          <p:cNvPr id="33" name="직선 화살표 연결선 32"/>
+          <p:cNvCxnSpPr>
+            <a:stCxn id="11" idx="0"/>
+            <a:endCxn id="26" idx="0"/>
+          </p:cNvCxnSpPr>
+          <p:nvPr/>
+        </p:nvCxnSpPr>
+        <p:spPr>
+          <a:xfrm flipV="1">
+            <a:off x="6020972" y="3676328"/>
+            <a:ext cx="1" cy="757886"/>
+          </a:xfrm>
+          <a:prstGeom prst="straightConnector1">
+            <a:avLst/>
+          </a:prstGeom>
+          <a:ln w="76200">
+            <a:solidFill>
+              <a:schemeClr val="accent2"/>
+            </a:solidFill>
+            <a:prstDash val="sysDot"/>
+            <a:tailEnd type="triangle"/>
+          </a:ln>
+        </p:spPr>
+        <p:style>
+          <a:lnRef idx="1">
+            <a:schemeClr val="accent1"/>
+          </a:lnRef>
+          <a:fillRef idx="0">
+            <a:schemeClr val="accent1"/>
+          </a:fillRef>
+          <a:effectRef idx="0">
+            <a:schemeClr val="accent1"/>
+          </a:effectRef>
+          <a:fontRef idx="minor">
+            <a:schemeClr val="tx1"/>
+          </a:fontRef>
+        </p:style>
+      </p:cxnSp>
+      <p:sp>
+        <p:nvSpPr>
+          <p:cNvPr id="26" name="TextBox 25"/>
+          <p:cNvSpPr txBox="1"/>
+          <p:nvPr/>
+        </p:nvSpPr>
+        <p:spPr>
+          <a:xfrm>
+            <a:off x="5021340" y="3676328"/>
+            <a:ext cx="1999265" cy="369332"/>
+          </a:xfrm>
+          <a:prstGeom prst="rect">
+            <a:avLst/>
+          </a:prstGeom>
+          <a:noFill/>
+        </p:spPr>
+        <p:txBody>
+          <a:bodyPr wrap="none" rtlCol="0">
+            <a:spAutoFit/>
+          </a:bodyPr>
+          <a:lstStyle/>
+          <a:p>
+            <a:r>
+              <a:rPr lang="ko-KR" altLang="en-US" dirty="0" smtClean="0">
+                <a:latin typeface="나눔스퀘어 Bold" panose="020B0600000101010101" pitchFamily="50" charset="-127"/>
+                <a:ea typeface="나눔스퀘어 Bold" panose="020B0600000101010101" pitchFamily="50" charset="-127"/>
+              </a:rPr>
+              <a:t>개발팀 </a:t>
+            </a:r>
+            <a:r>
+              <a:rPr lang="en-US" altLang="ko-KR" dirty="0" smtClean="0">
+                <a:latin typeface="나눔스퀘어 Bold" panose="020B0600000101010101" pitchFamily="50" charset="-127"/>
+                <a:ea typeface="나눔스퀘어 Bold" panose="020B0600000101010101" pitchFamily="50" charset="-127"/>
+              </a:rPr>
+              <a:t>-&gt; QA(QM)</a:t>
+            </a:r>
+            <a:endParaRPr lang="ko-KR" altLang="en-US" dirty="0">
+              <a:latin typeface="나눔스퀘어 Bold" panose="020B0600000101010101" pitchFamily="50" charset="-127"/>
+              <a:ea typeface="나눔스퀘어 Bold" panose="020B0600000101010101" pitchFamily="50" charset="-127"/>
+            </a:endParaRPr>
+          </a:p>
+        </p:txBody>
+      </p:sp>
+      <p:cxnSp>
+        <p:nvCxnSpPr>
+          <p:cNvPr id="36" name="직선 화살표 연결선 35"/>
+          <p:cNvCxnSpPr>
+            <a:stCxn id="5" idx="0"/>
+            <a:endCxn id="6" idx="2"/>
+          </p:cNvCxnSpPr>
+          <p:nvPr/>
+        </p:nvCxnSpPr>
+        <p:spPr>
+          <a:xfrm flipV="1">
+            <a:off x="10752000" y="3657107"/>
+            <a:ext cx="0" cy="777107"/>
+          </a:xfrm>
+          <a:prstGeom prst="straightConnector1">
+            <a:avLst/>
+          </a:prstGeom>
+          <a:ln w="76200">
+            <a:solidFill>
+              <a:schemeClr val="accent2"/>
+            </a:solidFill>
+            <a:prstDash val="sysDot"/>
+            <a:tailEnd type="triangle"/>
+          </a:ln>
+        </p:spPr>
+        <p:style>
+          <a:lnRef idx="1">
+            <a:schemeClr val="accent1"/>
+          </a:lnRef>
+          <a:fillRef idx="0">
+            <a:schemeClr val="accent1"/>
+          </a:fillRef>
+          <a:effectRef idx="0">
+            <a:schemeClr val="accent1"/>
+          </a:effectRef>
+          <a:fontRef idx="minor">
+            <a:schemeClr val="tx1"/>
+          </a:fontRef>
+        </p:style>
+      </p:cxnSp>
+      <p:sp>
+        <p:nvSpPr>
+          <p:cNvPr id="40" name="직사각형 39"/>
+          <p:cNvSpPr/>
+          <p:nvPr/>
+        </p:nvSpPr>
+        <p:spPr>
+          <a:xfrm>
+            <a:off x="9672000" y="3423551"/>
+            <a:ext cx="2160000" cy="540000"/>
+          </a:xfrm>
+          <a:prstGeom prst="rect">
+            <a:avLst/>
+          </a:prstGeom>
+          <a:solidFill>
+            <a:schemeClr val="accent4"/>
+          </a:solidFill>
+          <a:ln>
+            <a:solidFill>
+              <a:schemeClr val="tx1"/>
+            </a:solidFill>
+          </a:ln>
+        </p:spPr>
+        <p:style>
+          <a:lnRef idx="2">
+            <a:schemeClr val="accent1">
+              <a:shade val="50000"/>
+            </a:schemeClr>
+          </a:lnRef>
+          <a:fillRef idx="1">
+            <a:schemeClr val="accent1"/>
+          </a:fillRef>
+          <a:effectRef idx="0">
+            <a:schemeClr val="accent1"/>
+          </a:effectRef>
+          <a:fontRef idx="minor">
+            <a:schemeClr val="lt1"/>
+          </a:fontRef>
+        </p:style>
+        <p:txBody>
+          <a:bodyPr rtlCol="0" anchor="ctr"/>
+          <a:lstStyle/>
+          <a:p>
+            <a:pPr algn="ctr"/>
+            <a:r>
+              <a:rPr lang="en-US" altLang="ko-KR" dirty="0" smtClean="0">
+                <a:solidFill>
+                  <a:schemeClr val="tx1"/>
+                </a:solidFill>
+                <a:latin typeface="나눔스퀘어 Bold" panose="020B0600000101010101" pitchFamily="50" charset="-127"/>
+                <a:ea typeface="나눔스퀘어 Bold" panose="020B0600000101010101" pitchFamily="50" charset="-127"/>
+              </a:rPr>
+              <a:t>Docker Image(Jar)</a:t>
+            </a:r>
+            <a:endParaRPr lang="ko-KR" altLang="en-US" dirty="0">
               <a:solidFill>
                 <a:schemeClr val="tx1"/>
               </a:solidFill>
-            </a:ln>
-          </p:spPr>
-          <p:style>
-            <a:lnRef idx="2">
-              <a:schemeClr val="accent1">
-                <a:shade val="50000"/>
-              </a:schemeClr>
-            </a:lnRef>
-            <a:fillRef idx="1">
-              <a:schemeClr val="accent1"/>
-            </a:fillRef>
-            <a:effectRef idx="0">
-              <a:schemeClr val="accent1"/>
-            </a:effectRef>
-            <a:fontRef idx="minor">
-              <a:schemeClr val="lt1"/>
-            </a:fontRef>
-          </p:style>
-          <p:txBody>
-            <a:bodyPr rtlCol="0" anchor="ctr"/>
-            <a:lstStyle/>
-            <a:p>
-              <a:pPr algn="ctr"/>
-              <a:r>
-                <a:rPr lang="en-US" altLang="ko-KR" sz="2000" dirty="0" smtClean="0">
-                  <a:latin typeface="나눔스퀘어 Bold" panose="020B0600000101010101" pitchFamily="50" charset="-127"/>
-                  <a:ea typeface="나눔스퀘어 Bold" panose="020B0600000101010101" pitchFamily="50" charset="-127"/>
-                </a:rPr>
-                <a:t>Dev(Stage) Server</a:t>
-              </a:r>
-            </a:p>
-            <a:p>
-              <a:pPr algn="ctr"/>
-              <a:r>
-                <a:rPr lang="en-US" altLang="ko-KR" sz="2000" dirty="0" err="1" smtClean="0">
-                  <a:latin typeface="나눔스퀘어 Bold" panose="020B0600000101010101" pitchFamily="50" charset="-127"/>
-                  <a:ea typeface="나눔스퀘어 Bold" panose="020B0600000101010101" pitchFamily="50" charset="-127"/>
-                </a:rPr>
-                <a:t>Gradle</a:t>
-              </a:r>
-              <a:r>
-                <a:rPr lang="en-US" altLang="ko-KR" sz="2000" dirty="0" smtClean="0">
-                  <a:latin typeface="나눔스퀘어 Bold" panose="020B0600000101010101" pitchFamily="50" charset="-127"/>
-                  <a:ea typeface="나눔스퀘어 Bold" panose="020B0600000101010101" pitchFamily="50" charset="-127"/>
-                </a:rPr>
-                <a:t>, JDK, </a:t>
-              </a:r>
-              <a:r>
-                <a:rPr lang="en-US" altLang="ko-KR" sz="2000" dirty="0" err="1" smtClean="0">
-                  <a:latin typeface="나눔스퀘어 Bold" panose="020B0600000101010101" pitchFamily="50" charset="-127"/>
-                  <a:ea typeface="나눔스퀘어 Bold" panose="020B0600000101010101" pitchFamily="50" charset="-127"/>
-                </a:rPr>
-                <a:t>Git</a:t>
-              </a:r>
-              <a:r>
-                <a:rPr lang="en-US" altLang="ko-KR" sz="2000" dirty="0" smtClean="0">
-                  <a:latin typeface="나눔스퀘어 Bold" panose="020B0600000101010101" pitchFamily="50" charset="-127"/>
-                  <a:ea typeface="나눔스퀘어 Bold" panose="020B0600000101010101" pitchFamily="50" charset="-127"/>
-                </a:rPr>
-                <a:t>, Build</a:t>
-              </a:r>
-              <a:endParaRPr lang="ko-KR" altLang="en-US" sz="2000" dirty="0">
-                <a:latin typeface="나눔스퀘어 Bold" panose="020B0600000101010101" pitchFamily="50" charset="-127"/>
-                <a:ea typeface="나눔스퀘어 Bold" panose="020B0600000101010101" pitchFamily="50" charset="-127"/>
-              </a:endParaRPr>
-            </a:p>
-          </p:txBody>
-        </p:sp>
-        <p:sp>
-          <p:nvSpPr>
-            <p:cNvPr id="5" name="직사각형 4"/>
-            <p:cNvSpPr/>
-            <p:nvPr/>
-          </p:nvSpPr>
-          <p:spPr>
-            <a:xfrm>
-              <a:off x="9492000" y="4434214"/>
-              <a:ext cx="2520000" cy="1080000"/>
-            </a:xfrm>
-            <a:prstGeom prst="rect">
-              <a:avLst/>
-            </a:prstGeom>
+              <a:latin typeface="나눔스퀘어 Bold" panose="020B0600000101010101" pitchFamily="50" charset="-127"/>
+              <a:ea typeface="나눔스퀘어 Bold" panose="020B0600000101010101" pitchFamily="50" charset="-127"/>
+            </a:endParaRPr>
+          </a:p>
+        </p:txBody>
+      </p:sp>
+      <p:sp>
+        <p:nvSpPr>
+          <p:cNvPr id="50" name="직사각형 49"/>
+          <p:cNvSpPr/>
+          <p:nvPr/>
+        </p:nvSpPr>
+        <p:spPr>
+          <a:xfrm>
+            <a:off x="9780858" y="3546923"/>
+            <a:ext cx="2160000" cy="540000"/>
+          </a:xfrm>
+          <a:prstGeom prst="rect">
+            <a:avLst/>
+          </a:prstGeom>
+          <a:solidFill>
+            <a:schemeClr val="accent4"/>
+          </a:solidFill>
+          <a:ln>
             <a:solidFill>
-              <a:schemeClr val="accent5"/>
+              <a:schemeClr val="tx1"/>
             </a:solidFill>
-            <a:ln>
+          </a:ln>
+        </p:spPr>
+        <p:style>
+          <a:lnRef idx="2">
+            <a:schemeClr val="accent1">
+              <a:shade val="50000"/>
+            </a:schemeClr>
+          </a:lnRef>
+          <a:fillRef idx="1">
+            <a:schemeClr val="accent1"/>
+          </a:fillRef>
+          <a:effectRef idx="0">
+            <a:schemeClr val="accent1"/>
+          </a:effectRef>
+          <a:fontRef idx="minor">
+            <a:schemeClr val="lt1"/>
+          </a:fontRef>
+        </p:style>
+        <p:txBody>
+          <a:bodyPr rtlCol="0" anchor="ctr"/>
+          <a:lstStyle/>
+          <a:p>
+            <a:pPr algn="ctr"/>
+            <a:r>
+              <a:rPr lang="en-US" altLang="ko-KR" dirty="0" smtClean="0">
+                <a:solidFill>
+                  <a:schemeClr val="tx1"/>
+                </a:solidFill>
+                <a:latin typeface="나눔스퀘어 Bold" panose="020B0600000101010101" pitchFamily="50" charset="-127"/>
+                <a:ea typeface="나눔스퀘어 Bold" panose="020B0600000101010101" pitchFamily="50" charset="-127"/>
+              </a:rPr>
+              <a:t>Docker Image(Jar)</a:t>
+            </a:r>
+            <a:endParaRPr lang="ko-KR" altLang="en-US" dirty="0">
               <a:solidFill>
                 <a:schemeClr val="tx1"/>
               </a:solidFill>
-            </a:ln>
-          </p:spPr>
-          <p:style>
-            <a:lnRef idx="2">
-              <a:schemeClr val="accent1">
-                <a:shade val="50000"/>
-              </a:schemeClr>
-            </a:lnRef>
-            <a:fillRef idx="1">
-              <a:schemeClr val="accent1"/>
-            </a:fillRef>
-            <a:effectRef idx="0">
-              <a:schemeClr val="accent1"/>
-            </a:effectRef>
-            <a:fontRef idx="minor">
-              <a:schemeClr val="lt1"/>
-            </a:fontRef>
-          </p:style>
-          <p:txBody>
-            <a:bodyPr rtlCol="0" anchor="ctr"/>
-            <a:lstStyle/>
-            <a:p>
-              <a:pPr algn="ctr"/>
-              <a:r>
-                <a:rPr lang="en-US" altLang="ko-KR" sz="2400" dirty="0" smtClean="0">
-                  <a:latin typeface="나눔스퀘어 Bold" panose="020B0600000101010101" pitchFamily="50" charset="-127"/>
-                  <a:ea typeface="나눔스퀘어 Bold" panose="020B0600000101010101" pitchFamily="50" charset="-127"/>
-                </a:rPr>
-                <a:t>Product MySQL</a:t>
-              </a:r>
-              <a:endParaRPr lang="ko-KR" altLang="en-US" sz="2400" dirty="0">
-                <a:latin typeface="나눔스퀘어 Bold" panose="020B0600000101010101" pitchFamily="50" charset="-127"/>
-                <a:ea typeface="나눔스퀘어 Bold" panose="020B0600000101010101" pitchFamily="50" charset="-127"/>
-              </a:endParaRPr>
-            </a:p>
-          </p:txBody>
-        </p:sp>
-        <p:sp>
-          <p:nvSpPr>
-            <p:cNvPr id="6" name="직사각형 5"/>
-            <p:cNvSpPr/>
-            <p:nvPr/>
-          </p:nvSpPr>
-          <p:spPr>
-            <a:xfrm>
-              <a:off x="9312000" y="2217107"/>
-              <a:ext cx="2880000" cy="1440000"/>
-            </a:xfrm>
-            <a:prstGeom prst="rect">
-              <a:avLst/>
-            </a:prstGeom>
+              <a:latin typeface="나눔스퀘어 Bold" panose="020B0600000101010101" pitchFamily="50" charset="-127"/>
+              <a:ea typeface="나눔스퀘어 Bold" panose="020B0600000101010101" pitchFamily="50" charset="-127"/>
+            </a:endParaRPr>
+          </a:p>
+        </p:txBody>
+      </p:sp>
+      <p:sp>
+        <p:nvSpPr>
+          <p:cNvPr id="51" name="직사각형 50"/>
+          <p:cNvSpPr/>
+          <p:nvPr/>
+        </p:nvSpPr>
+        <p:spPr>
+          <a:xfrm>
+            <a:off x="9904230" y="3670295"/>
+            <a:ext cx="2160000" cy="540000"/>
+          </a:xfrm>
+          <a:prstGeom prst="rect">
+            <a:avLst/>
+          </a:prstGeom>
+          <a:solidFill>
+            <a:schemeClr val="accent4"/>
+          </a:solidFill>
+          <a:ln>
             <a:solidFill>
-              <a:schemeClr val="accent5"/>
+              <a:schemeClr val="tx1"/>
             </a:solidFill>
-            <a:ln>
+          </a:ln>
+        </p:spPr>
+        <p:style>
+          <a:lnRef idx="2">
+            <a:schemeClr val="accent1">
+              <a:shade val="50000"/>
+            </a:schemeClr>
+          </a:lnRef>
+          <a:fillRef idx="1">
+            <a:schemeClr val="accent1"/>
+          </a:fillRef>
+          <a:effectRef idx="0">
+            <a:schemeClr val="accent1"/>
+          </a:effectRef>
+          <a:fontRef idx="minor">
+            <a:schemeClr val="lt1"/>
+          </a:fontRef>
+        </p:style>
+        <p:txBody>
+          <a:bodyPr rtlCol="0" anchor="ctr"/>
+          <a:lstStyle/>
+          <a:p>
+            <a:pPr algn="ctr"/>
+            <a:r>
+              <a:rPr lang="en-US" altLang="ko-KR" dirty="0" smtClean="0">
+                <a:solidFill>
+                  <a:schemeClr val="tx1"/>
+                </a:solidFill>
+                <a:latin typeface="나눔스퀘어 Bold" panose="020B0600000101010101" pitchFamily="50" charset="-127"/>
+                <a:ea typeface="나눔스퀘어 Bold" panose="020B0600000101010101" pitchFamily="50" charset="-127"/>
+              </a:rPr>
+              <a:t>Docker Image(Jar)</a:t>
+            </a:r>
+            <a:endParaRPr lang="ko-KR" altLang="en-US" dirty="0">
               <a:solidFill>
                 <a:schemeClr val="tx1"/>
               </a:solidFill>
-            </a:ln>
-          </p:spPr>
-          <p:style>
-            <a:lnRef idx="2">
-              <a:schemeClr val="accent1">
-                <a:shade val="50000"/>
-              </a:schemeClr>
-            </a:lnRef>
-            <a:fillRef idx="1">
-              <a:schemeClr val="accent1"/>
-            </a:fillRef>
-            <a:effectRef idx="0">
-              <a:schemeClr val="accent1"/>
-            </a:effectRef>
-            <a:fontRef idx="minor">
-              <a:schemeClr val="lt1"/>
-            </a:fontRef>
-          </p:style>
-          <p:txBody>
-            <a:bodyPr rtlCol="0" anchor="ctr"/>
-            <a:lstStyle/>
-            <a:p>
-              <a:pPr algn="ctr"/>
-              <a:r>
-                <a:rPr lang="en-US" altLang="ko-KR" sz="2000" dirty="0" smtClean="0">
-                  <a:latin typeface="나눔스퀘어 Bold" panose="020B0600000101010101" pitchFamily="50" charset="-127"/>
-                  <a:ea typeface="나눔스퀘어 Bold" panose="020B0600000101010101" pitchFamily="50" charset="-127"/>
-                </a:rPr>
-                <a:t>Product</a:t>
-              </a:r>
-              <a:r>
-                <a:rPr lang="en-US" altLang="ko-KR" sz="2000" dirty="0" smtClean="0">
-                  <a:latin typeface="나눔스퀘어 Bold" panose="020B0600000101010101" pitchFamily="50" charset="-127"/>
-                  <a:ea typeface="나눔스퀘어 Bold" panose="020B0600000101010101" pitchFamily="50" charset="-127"/>
-                </a:rPr>
-                <a:t> Server</a:t>
-              </a:r>
-            </a:p>
-            <a:p>
-              <a:pPr algn="ctr"/>
-              <a:r>
-                <a:rPr lang="en-US" altLang="ko-KR" sz="2000" dirty="0" err="1" smtClean="0">
-                  <a:latin typeface="나눔스퀘어 Bold" panose="020B0600000101010101" pitchFamily="50" charset="-127"/>
-                  <a:ea typeface="나눔스퀘어 Bold" panose="020B0600000101010101" pitchFamily="50" charset="-127"/>
-                </a:rPr>
-                <a:t>Gradle</a:t>
-              </a:r>
-              <a:r>
-                <a:rPr lang="en-US" altLang="ko-KR" sz="2000" dirty="0" smtClean="0">
-                  <a:latin typeface="나눔스퀘어 Bold" panose="020B0600000101010101" pitchFamily="50" charset="-127"/>
-                  <a:ea typeface="나눔스퀘어 Bold" panose="020B0600000101010101" pitchFamily="50" charset="-127"/>
-                </a:rPr>
-                <a:t>, JDK, </a:t>
-              </a:r>
-              <a:r>
-                <a:rPr lang="en-US" altLang="ko-KR" sz="2000" dirty="0" err="1" smtClean="0">
-                  <a:latin typeface="나눔스퀘어 Bold" panose="020B0600000101010101" pitchFamily="50" charset="-127"/>
-                  <a:ea typeface="나눔스퀘어 Bold" panose="020B0600000101010101" pitchFamily="50" charset="-127"/>
-                </a:rPr>
-                <a:t>Git</a:t>
-              </a:r>
-              <a:r>
-                <a:rPr lang="en-US" altLang="ko-KR" sz="2000" dirty="0" smtClean="0">
-                  <a:latin typeface="나눔스퀘어 Bold" panose="020B0600000101010101" pitchFamily="50" charset="-127"/>
-                  <a:ea typeface="나눔스퀘어 Bold" panose="020B0600000101010101" pitchFamily="50" charset="-127"/>
-                </a:rPr>
-                <a:t>, Build</a:t>
-              </a:r>
-              <a:endParaRPr lang="ko-KR" altLang="en-US" sz="2000" dirty="0" smtClean="0">
-                <a:latin typeface="나눔스퀘어 Bold" panose="020B0600000101010101" pitchFamily="50" charset="-127"/>
-                <a:ea typeface="나눔스퀘어 Bold" panose="020B0600000101010101" pitchFamily="50" charset="-127"/>
-              </a:endParaRPr>
-            </a:p>
-          </p:txBody>
-        </p:sp>
-        <p:sp>
-          <p:nvSpPr>
-            <p:cNvPr id="11" name="직사각형 10"/>
-            <p:cNvSpPr/>
-            <p:nvPr/>
-          </p:nvSpPr>
-          <p:spPr>
-            <a:xfrm>
-              <a:off x="4836000" y="4434214"/>
-              <a:ext cx="2520000" cy="1080000"/>
-            </a:xfrm>
-            <a:prstGeom prst="rect">
-              <a:avLst/>
-            </a:prstGeom>
-            <a:solidFill>
-              <a:schemeClr val="accent5"/>
-            </a:solidFill>
-            <a:ln>
-              <a:solidFill>
-                <a:schemeClr val="tx1"/>
-              </a:solidFill>
-            </a:ln>
-          </p:spPr>
-          <p:style>
-            <a:lnRef idx="2">
-              <a:schemeClr val="accent1">
-                <a:shade val="50000"/>
-              </a:schemeClr>
-            </a:lnRef>
-            <a:fillRef idx="1">
-              <a:schemeClr val="accent1"/>
-            </a:fillRef>
-            <a:effectRef idx="0">
-              <a:schemeClr val="accent1"/>
-            </a:effectRef>
-            <a:fontRef idx="minor">
-              <a:schemeClr val="lt1"/>
-            </a:fontRef>
-          </p:style>
-          <p:txBody>
-            <a:bodyPr rtlCol="0" anchor="ctr"/>
-            <a:lstStyle/>
-            <a:p>
-              <a:pPr algn="ctr"/>
-              <a:r>
-                <a:rPr lang="en-US" altLang="ko-KR" sz="2400" dirty="0" smtClean="0">
-                  <a:latin typeface="나눔스퀘어 Bold" panose="020B0600000101010101" pitchFamily="50" charset="-127"/>
-                  <a:ea typeface="나눔스퀘어 Bold" panose="020B0600000101010101" pitchFamily="50" charset="-127"/>
-                </a:rPr>
-                <a:t>Dev MySQL</a:t>
-              </a:r>
-              <a:endParaRPr lang="ko-KR" altLang="en-US" sz="2400" dirty="0">
-                <a:latin typeface="나눔스퀘어 Bold" panose="020B0600000101010101" pitchFamily="50" charset="-127"/>
-                <a:ea typeface="나눔스퀘어 Bold" panose="020B0600000101010101" pitchFamily="50" charset="-127"/>
-              </a:endParaRPr>
-            </a:p>
-          </p:txBody>
-        </p:sp>
-        <p:cxnSp>
-          <p:nvCxnSpPr>
-            <p:cNvPr id="23" name="꺾인 연결선 22"/>
-            <p:cNvCxnSpPr>
-              <a:stCxn id="4" idx="3"/>
-              <a:endCxn id="13" idx="1"/>
-            </p:cNvCxnSpPr>
-            <p:nvPr/>
-          </p:nvCxnSpPr>
-          <p:spPr>
-            <a:xfrm flipH="1" flipV="1">
-              <a:off x="7163999" y="540000"/>
-              <a:ext cx="372001" cy="2397107"/>
-            </a:xfrm>
-            <a:prstGeom prst="bentConnector5">
-              <a:avLst>
-                <a:gd name="adj1" fmla="val -142264"/>
-                <a:gd name="adj2" fmla="val 53755"/>
-                <a:gd name="adj3" fmla="val 238896"/>
-              </a:avLst>
-            </a:prstGeom>
-            <a:ln w="76200">
-              <a:solidFill>
-                <a:schemeClr val="accent2"/>
-              </a:solidFill>
-              <a:tailEnd type="triangle"/>
-            </a:ln>
-          </p:spPr>
-          <p:style>
-            <a:lnRef idx="1">
-              <a:schemeClr val="accent1"/>
-            </a:lnRef>
-            <a:fillRef idx="0">
-              <a:schemeClr val="accent1"/>
-            </a:fillRef>
-            <a:effectRef idx="0">
-              <a:schemeClr val="accent1"/>
-            </a:effectRef>
-            <a:fontRef idx="minor">
-              <a:schemeClr val="tx1"/>
-            </a:fontRef>
-          </p:style>
-        </p:cxnSp>
-        <p:sp>
-          <p:nvSpPr>
-            <p:cNvPr id="3" name="직사각형 2"/>
-            <p:cNvSpPr/>
-            <p:nvPr/>
-          </p:nvSpPr>
-          <p:spPr>
-            <a:xfrm>
-              <a:off x="2507999" y="0"/>
-              <a:ext cx="2520000" cy="1080000"/>
-            </a:xfrm>
-            <a:prstGeom prst="rect">
-              <a:avLst/>
-            </a:prstGeom>
-            <a:solidFill>
-              <a:schemeClr val="accent5"/>
-            </a:solidFill>
-            <a:ln>
-              <a:solidFill>
-                <a:schemeClr val="tx1"/>
-              </a:solidFill>
-            </a:ln>
-          </p:spPr>
-          <p:style>
-            <a:lnRef idx="2">
-              <a:schemeClr val="accent1">
-                <a:shade val="50000"/>
-              </a:schemeClr>
-            </a:lnRef>
-            <a:fillRef idx="1">
-              <a:schemeClr val="accent1"/>
-            </a:fillRef>
-            <a:effectRef idx="0">
-              <a:schemeClr val="accent1"/>
-            </a:effectRef>
-            <a:fontRef idx="minor">
-              <a:schemeClr val="lt1"/>
-            </a:fontRef>
-          </p:style>
-          <p:txBody>
-            <a:bodyPr rtlCol="0" anchor="ctr"/>
-            <a:lstStyle/>
-            <a:p>
-              <a:pPr algn="ctr"/>
-              <a:r>
-                <a:rPr lang="en-US" altLang="ko-KR" sz="2400" dirty="0" smtClean="0">
-                  <a:latin typeface="나눔스퀘어 Bold" panose="020B0600000101010101" pitchFamily="50" charset="-127"/>
-                  <a:ea typeface="나눔스퀘어 Bold" panose="020B0600000101010101" pitchFamily="50" charset="-127"/>
-                </a:rPr>
-                <a:t>GitHub</a:t>
-              </a:r>
-              <a:endParaRPr lang="ko-KR" altLang="en-US" sz="2400" dirty="0">
-                <a:latin typeface="나눔스퀘어 Bold" panose="020B0600000101010101" pitchFamily="50" charset="-127"/>
-                <a:ea typeface="나눔스퀘어 Bold" panose="020B0600000101010101" pitchFamily="50" charset="-127"/>
-              </a:endParaRPr>
-            </a:p>
-          </p:txBody>
-        </p:sp>
-        <p:sp>
-          <p:nvSpPr>
-            <p:cNvPr id="13" name="직사각형 12"/>
-            <p:cNvSpPr/>
-            <p:nvPr/>
-          </p:nvSpPr>
-          <p:spPr>
-            <a:xfrm>
-              <a:off x="7163999" y="0"/>
-              <a:ext cx="2520000" cy="1080000"/>
-            </a:xfrm>
-            <a:prstGeom prst="rect">
-              <a:avLst/>
-            </a:prstGeom>
-            <a:solidFill>
-              <a:schemeClr val="accent5"/>
-            </a:solidFill>
-            <a:ln>
-              <a:solidFill>
-                <a:schemeClr val="tx1"/>
-              </a:solidFill>
-            </a:ln>
-          </p:spPr>
-          <p:style>
-            <a:lnRef idx="2">
-              <a:schemeClr val="accent1">
-                <a:shade val="50000"/>
-              </a:schemeClr>
-            </a:lnRef>
-            <a:fillRef idx="1">
-              <a:schemeClr val="accent1"/>
-            </a:fillRef>
-            <a:effectRef idx="0">
-              <a:schemeClr val="accent1"/>
-            </a:effectRef>
-            <a:fontRef idx="minor">
-              <a:schemeClr val="lt1"/>
-            </a:fontRef>
-          </p:style>
-          <p:txBody>
-            <a:bodyPr rtlCol="0" anchor="ctr"/>
-            <a:lstStyle/>
-            <a:p>
-              <a:pPr algn="ctr"/>
-              <a:r>
-                <a:rPr lang="en-US" altLang="ko-KR" sz="2400" dirty="0" err="1" smtClean="0">
-                  <a:latin typeface="나눔스퀘어 Bold" panose="020B0600000101010101" pitchFamily="50" charset="-127"/>
-                  <a:ea typeface="나눔스퀘어 Bold" panose="020B0600000101010101" pitchFamily="50" charset="-127"/>
-                </a:rPr>
-                <a:t>DockerHub</a:t>
-              </a:r>
-              <a:endParaRPr lang="ko-KR" altLang="en-US" sz="2400" dirty="0">
-                <a:latin typeface="나눔스퀘어 Bold" panose="020B0600000101010101" pitchFamily="50" charset="-127"/>
-                <a:ea typeface="나눔스퀘어 Bold" panose="020B0600000101010101" pitchFamily="50" charset="-127"/>
-              </a:endParaRPr>
-            </a:p>
-          </p:txBody>
-        </p:sp>
-        <p:sp>
-          <p:nvSpPr>
-            <p:cNvPr id="25" name="직사각형 24"/>
-            <p:cNvSpPr/>
-            <p:nvPr/>
-          </p:nvSpPr>
-          <p:spPr>
-            <a:xfrm>
-              <a:off x="180000" y="4434214"/>
-              <a:ext cx="2520000" cy="1080000"/>
-            </a:xfrm>
-            <a:prstGeom prst="rect">
-              <a:avLst/>
-            </a:prstGeom>
-            <a:solidFill>
-              <a:schemeClr val="accent5"/>
-            </a:solidFill>
-            <a:ln>
-              <a:solidFill>
-                <a:schemeClr val="tx1"/>
-              </a:solidFill>
-            </a:ln>
-          </p:spPr>
-          <p:style>
-            <a:lnRef idx="2">
-              <a:schemeClr val="accent1">
-                <a:shade val="50000"/>
-              </a:schemeClr>
-            </a:lnRef>
-            <a:fillRef idx="1">
-              <a:schemeClr val="accent1"/>
-            </a:fillRef>
-            <a:effectRef idx="0">
-              <a:schemeClr val="accent1"/>
-            </a:effectRef>
-            <a:fontRef idx="minor">
-              <a:schemeClr val="lt1"/>
-            </a:fontRef>
-          </p:style>
-          <p:txBody>
-            <a:bodyPr rtlCol="0" anchor="ctr"/>
-            <a:lstStyle/>
-            <a:p>
-              <a:pPr algn="ctr"/>
-              <a:r>
-                <a:rPr lang="ko-KR" altLang="en-US" sz="2400" dirty="0" smtClean="0">
-                  <a:latin typeface="나눔스퀘어 Bold" panose="020B0600000101010101" pitchFamily="50" charset="-127"/>
-                  <a:ea typeface="나눔스퀘어 Bold" panose="020B0600000101010101" pitchFamily="50" charset="-127"/>
-                </a:rPr>
-                <a:t>개발</a:t>
-              </a:r>
-              <a:r>
-                <a:rPr lang="en-US" altLang="ko-KR" sz="2400" dirty="0" smtClean="0">
-                  <a:latin typeface="나눔스퀘어 Bold" panose="020B0600000101010101" pitchFamily="50" charset="-127"/>
-                  <a:ea typeface="나눔스퀘어 Bold" panose="020B0600000101010101" pitchFamily="50" charset="-127"/>
-                </a:rPr>
-                <a:t> MySQL</a:t>
-              </a:r>
-              <a:endParaRPr lang="ko-KR" altLang="en-US" sz="2400" dirty="0">
-                <a:latin typeface="나눔스퀘어 Bold" panose="020B0600000101010101" pitchFamily="50" charset="-127"/>
-                <a:ea typeface="나눔스퀘어 Bold" panose="020B0600000101010101" pitchFamily="50" charset="-127"/>
-              </a:endParaRPr>
-            </a:p>
-          </p:txBody>
-        </p:sp>
-        <p:sp>
-          <p:nvSpPr>
-            <p:cNvPr id="26" name="TextBox 25"/>
-            <p:cNvSpPr txBox="1"/>
-            <p:nvPr/>
-          </p:nvSpPr>
-          <p:spPr>
-            <a:xfrm>
-              <a:off x="5021340" y="3676328"/>
-              <a:ext cx="1999265" cy="369332"/>
-            </a:xfrm>
-            <a:prstGeom prst="rect">
-              <a:avLst/>
-            </a:prstGeom>
-            <a:noFill/>
-          </p:spPr>
-          <p:txBody>
-            <a:bodyPr wrap="none" rtlCol="0">
-              <a:spAutoFit/>
-            </a:bodyPr>
-            <a:lstStyle/>
-            <a:p>
-              <a:r>
-                <a:rPr lang="ko-KR" altLang="en-US" dirty="0" smtClean="0">
-                  <a:latin typeface="나눔스퀘어 Bold" panose="020B0600000101010101" pitchFamily="50" charset="-127"/>
-                  <a:ea typeface="나눔스퀘어 Bold" panose="020B0600000101010101" pitchFamily="50" charset="-127"/>
-                </a:rPr>
-                <a:t>개발팀 </a:t>
-              </a:r>
-              <a:r>
-                <a:rPr lang="en-US" altLang="ko-KR" dirty="0" smtClean="0">
-                  <a:latin typeface="나눔스퀘어 Bold" panose="020B0600000101010101" pitchFamily="50" charset="-127"/>
-                  <a:ea typeface="나눔스퀘어 Bold" panose="020B0600000101010101" pitchFamily="50" charset="-127"/>
-                </a:rPr>
-                <a:t>-&gt; QA(QM)</a:t>
-              </a:r>
-              <a:endParaRPr lang="ko-KR" altLang="en-US" dirty="0">
-                <a:latin typeface="나눔스퀘어 Bold" panose="020B0600000101010101" pitchFamily="50" charset="-127"/>
-                <a:ea typeface="나눔스퀘어 Bold" panose="020B0600000101010101" pitchFamily="50" charset="-127"/>
-              </a:endParaRPr>
-            </a:p>
-          </p:txBody>
-        </p:sp>
-        <p:sp>
-          <p:nvSpPr>
-            <p:cNvPr id="27" name="직사각형 26"/>
-            <p:cNvSpPr/>
-            <p:nvPr/>
-          </p:nvSpPr>
-          <p:spPr>
-            <a:xfrm>
-              <a:off x="6804000" y="1378553"/>
-              <a:ext cx="2160000" cy="540000"/>
-            </a:xfrm>
-            <a:prstGeom prst="rect">
-              <a:avLst/>
-            </a:prstGeom>
-            <a:solidFill>
-              <a:schemeClr val="accent4"/>
-            </a:solidFill>
-            <a:ln>
-              <a:solidFill>
-                <a:schemeClr val="tx1"/>
-              </a:solidFill>
-            </a:ln>
-          </p:spPr>
-          <p:style>
-            <a:lnRef idx="2">
-              <a:schemeClr val="accent1">
-                <a:shade val="50000"/>
-              </a:schemeClr>
-            </a:lnRef>
-            <a:fillRef idx="1">
-              <a:schemeClr val="accent1"/>
-            </a:fillRef>
-            <a:effectRef idx="0">
-              <a:schemeClr val="accent1"/>
-            </a:effectRef>
-            <a:fontRef idx="minor">
-              <a:schemeClr val="lt1"/>
-            </a:fontRef>
-          </p:style>
-          <p:txBody>
-            <a:bodyPr rtlCol="0" anchor="ctr"/>
-            <a:lstStyle/>
-            <a:p>
-              <a:pPr algn="ctr"/>
-              <a:r>
-                <a:rPr lang="en-US" altLang="ko-KR" dirty="0" smtClean="0">
-                  <a:solidFill>
-                    <a:schemeClr val="tx1"/>
-                  </a:solidFill>
-                  <a:latin typeface="나눔스퀘어 Bold" panose="020B0600000101010101" pitchFamily="50" charset="-127"/>
-                  <a:ea typeface="나눔스퀘어 Bold" panose="020B0600000101010101" pitchFamily="50" charset="-127"/>
-                </a:rPr>
-                <a:t>Docker Image(Jar)</a:t>
-              </a:r>
-              <a:endParaRPr lang="ko-KR" altLang="en-US" dirty="0">
-                <a:solidFill>
-                  <a:schemeClr val="tx1"/>
-                </a:solidFill>
-                <a:latin typeface="나눔스퀘어 Bold" panose="020B0600000101010101" pitchFamily="50" charset="-127"/>
-                <a:ea typeface="나눔스퀘어 Bold" panose="020B0600000101010101" pitchFamily="50" charset="-127"/>
-              </a:endParaRPr>
-            </a:p>
-          </p:txBody>
-        </p:sp>
-        <p:cxnSp>
-          <p:nvCxnSpPr>
-            <p:cNvPr id="32" name="꺾인 연결선 31"/>
-            <p:cNvCxnSpPr>
-              <a:stCxn id="13" idx="3"/>
-              <a:endCxn id="6" idx="0"/>
-            </p:cNvCxnSpPr>
-            <p:nvPr/>
-          </p:nvCxnSpPr>
-          <p:spPr>
-            <a:xfrm>
-              <a:off x="9683999" y="540000"/>
-              <a:ext cx="1068001" cy="1677107"/>
-            </a:xfrm>
-            <a:prstGeom prst="bentConnector2">
-              <a:avLst/>
-            </a:prstGeom>
-            <a:ln w="76200">
-              <a:solidFill>
-                <a:schemeClr val="accent2"/>
-              </a:solidFill>
-              <a:tailEnd type="triangle"/>
-            </a:ln>
-          </p:spPr>
-          <p:style>
-            <a:lnRef idx="1">
-              <a:schemeClr val="accent1"/>
-            </a:lnRef>
-            <a:fillRef idx="0">
-              <a:schemeClr val="accent1"/>
-            </a:fillRef>
-            <a:effectRef idx="0">
-              <a:schemeClr val="accent1"/>
-            </a:effectRef>
-            <a:fontRef idx="minor">
-              <a:schemeClr val="tx1"/>
-            </a:fontRef>
-          </p:style>
-        </p:cxnSp>
-        <p:cxnSp>
-          <p:nvCxnSpPr>
-            <p:cNvPr id="35" name="꺾인 연결선 34"/>
-            <p:cNvCxnSpPr>
-              <a:stCxn id="2" idx="0"/>
-              <a:endCxn id="3" idx="1"/>
-            </p:cNvCxnSpPr>
-            <p:nvPr/>
-          </p:nvCxnSpPr>
-          <p:spPr>
-            <a:xfrm rot="5400000" flipH="1" flipV="1">
-              <a:off x="1135446" y="844555"/>
-              <a:ext cx="1677107" cy="1067999"/>
-            </a:xfrm>
-            <a:prstGeom prst="bentConnector2">
-              <a:avLst/>
-            </a:prstGeom>
-            <a:ln w="76200">
-              <a:solidFill>
-                <a:schemeClr val="accent2"/>
-              </a:solidFill>
-              <a:tailEnd type="triangle"/>
-            </a:ln>
-          </p:spPr>
-          <p:style>
-            <a:lnRef idx="1">
-              <a:schemeClr val="accent1"/>
-            </a:lnRef>
-            <a:fillRef idx="0">
-              <a:schemeClr val="accent1"/>
-            </a:fillRef>
-            <a:effectRef idx="0">
-              <a:schemeClr val="accent1"/>
-            </a:effectRef>
-            <a:fontRef idx="minor">
-              <a:schemeClr val="tx1"/>
-            </a:fontRef>
-          </p:style>
-        </p:cxnSp>
-        <p:cxnSp>
-          <p:nvCxnSpPr>
-            <p:cNvPr id="38" name="꺾인 연결선 37"/>
-            <p:cNvCxnSpPr>
-              <a:stCxn id="3" idx="3"/>
-              <a:endCxn id="4" idx="0"/>
-            </p:cNvCxnSpPr>
-            <p:nvPr/>
-          </p:nvCxnSpPr>
-          <p:spPr>
-            <a:xfrm>
-              <a:off x="5027999" y="540000"/>
-              <a:ext cx="1068001" cy="1677107"/>
-            </a:xfrm>
-            <a:prstGeom prst="bentConnector2">
-              <a:avLst/>
-            </a:prstGeom>
-            <a:ln w="76200">
-              <a:solidFill>
-                <a:schemeClr val="accent2"/>
-              </a:solidFill>
-              <a:tailEnd type="triangle"/>
-            </a:ln>
-          </p:spPr>
-          <p:style>
-            <a:lnRef idx="1">
-              <a:schemeClr val="accent1"/>
-            </a:lnRef>
-            <a:fillRef idx="0">
-              <a:schemeClr val="accent1"/>
-            </a:fillRef>
-            <a:effectRef idx="0">
-              <a:schemeClr val="accent1"/>
-            </a:effectRef>
-            <a:fontRef idx="minor">
-              <a:schemeClr val="tx1"/>
-            </a:fontRef>
-          </p:style>
-        </p:cxnSp>
-        <p:sp>
-          <p:nvSpPr>
-            <p:cNvPr id="41" name="직사각형 40"/>
-            <p:cNvSpPr/>
-            <p:nvPr/>
-          </p:nvSpPr>
-          <p:spPr>
-            <a:xfrm>
-              <a:off x="9672000" y="3423551"/>
-              <a:ext cx="2160000" cy="540000"/>
-            </a:xfrm>
-            <a:prstGeom prst="rect">
-              <a:avLst/>
-            </a:prstGeom>
-            <a:solidFill>
-              <a:schemeClr val="accent4"/>
-            </a:solidFill>
-            <a:ln>
-              <a:solidFill>
-                <a:schemeClr val="tx1"/>
-              </a:solidFill>
-            </a:ln>
-          </p:spPr>
-          <p:style>
-            <a:lnRef idx="2">
-              <a:schemeClr val="accent1">
-                <a:shade val="50000"/>
-              </a:schemeClr>
-            </a:lnRef>
-            <a:fillRef idx="1">
-              <a:schemeClr val="accent1"/>
-            </a:fillRef>
-            <a:effectRef idx="0">
-              <a:schemeClr val="accent1"/>
-            </a:effectRef>
-            <a:fontRef idx="minor">
-              <a:schemeClr val="lt1"/>
-            </a:fontRef>
-          </p:style>
-          <p:txBody>
-            <a:bodyPr rtlCol="0" anchor="ctr"/>
-            <a:lstStyle/>
-            <a:p>
-              <a:pPr algn="ctr"/>
-              <a:r>
-                <a:rPr lang="en-US" altLang="ko-KR" dirty="0" smtClean="0">
-                  <a:solidFill>
-                    <a:schemeClr val="tx1"/>
-                  </a:solidFill>
-                  <a:latin typeface="나눔스퀘어 Bold" panose="020B0600000101010101" pitchFamily="50" charset="-127"/>
-                  <a:ea typeface="나눔스퀘어 Bold" panose="020B0600000101010101" pitchFamily="50" charset="-127"/>
-                </a:rPr>
-                <a:t>Docker Image(Jar)</a:t>
-              </a:r>
-              <a:endParaRPr lang="ko-KR" altLang="en-US" dirty="0">
-                <a:solidFill>
-                  <a:schemeClr val="tx1"/>
-                </a:solidFill>
-                <a:latin typeface="나눔스퀘어 Bold" panose="020B0600000101010101" pitchFamily="50" charset="-127"/>
-                <a:ea typeface="나눔스퀘어 Bold" panose="020B0600000101010101" pitchFamily="50" charset="-127"/>
-              </a:endParaRPr>
-            </a:p>
-          </p:txBody>
-        </p:sp>
-        <p:sp>
-          <p:nvSpPr>
-            <p:cNvPr id="42" name="직사각형 41"/>
-            <p:cNvSpPr/>
-            <p:nvPr/>
-          </p:nvSpPr>
-          <p:spPr>
-            <a:xfrm>
-              <a:off x="123372" y="2354993"/>
-              <a:ext cx="2880000" cy="1440000"/>
-            </a:xfrm>
-            <a:prstGeom prst="rect">
-              <a:avLst/>
-            </a:prstGeom>
-            <a:solidFill>
-              <a:schemeClr val="accent5"/>
-            </a:solidFill>
-            <a:ln>
-              <a:solidFill>
-                <a:schemeClr val="tx1"/>
-              </a:solidFill>
-            </a:ln>
-          </p:spPr>
-          <p:style>
-            <a:lnRef idx="2">
-              <a:schemeClr val="accent1">
-                <a:shade val="50000"/>
-              </a:schemeClr>
-            </a:lnRef>
-            <a:fillRef idx="1">
-              <a:schemeClr val="accent1"/>
-            </a:fillRef>
-            <a:effectRef idx="0">
-              <a:schemeClr val="accent1"/>
-            </a:effectRef>
-            <a:fontRef idx="minor">
-              <a:schemeClr val="lt1"/>
-            </a:fontRef>
-          </p:style>
-          <p:txBody>
-            <a:bodyPr rtlCol="0" anchor="ctr"/>
-            <a:lstStyle/>
-            <a:p>
-              <a:pPr algn="ctr"/>
-              <a:r>
-                <a:rPr lang="ko-KR" altLang="en-US" sz="2400" dirty="0" smtClean="0">
-                  <a:latin typeface="나눔스퀘어 Bold" panose="020B0600000101010101" pitchFamily="50" charset="-127"/>
-                  <a:ea typeface="나눔스퀘어 Bold" panose="020B0600000101010101" pitchFamily="50" charset="-127"/>
-                </a:rPr>
-                <a:t>개발</a:t>
-              </a:r>
-              <a:r>
-                <a:rPr lang="en-US" altLang="ko-KR" sz="2400" dirty="0" smtClean="0">
-                  <a:latin typeface="나눔스퀘어 Bold" panose="020B0600000101010101" pitchFamily="50" charset="-127"/>
-                  <a:ea typeface="나눔스퀘어 Bold" panose="020B0600000101010101" pitchFamily="50" charset="-127"/>
-                </a:rPr>
-                <a:t>PC(Local)</a:t>
-              </a:r>
-            </a:p>
-            <a:p>
-              <a:pPr algn="ctr"/>
-              <a:r>
-                <a:rPr lang="en-US" altLang="ko-KR" sz="2400" dirty="0" smtClean="0">
-                  <a:latin typeface="나눔스퀘어 Bold" panose="020B0600000101010101" pitchFamily="50" charset="-127"/>
-                  <a:ea typeface="나눔스퀘어 Bold" panose="020B0600000101010101" pitchFamily="50" charset="-127"/>
-                </a:rPr>
-                <a:t>JDK, </a:t>
-              </a:r>
-              <a:r>
-                <a:rPr lang="en-US" altLang="ko-KR" sz="2400" dirty="0" err="1" smtClean="0">
-                  <a:latin typeface="나눔스퀘어 Bold" panose="020B0600000101010101" pitchFamily="50" charset="-127"/>
-                  <a:ea typeface="나눔스퀘어 Bold" panose="020B0600000101010101" pitchFamily="50" charset="-127"/>
-                </a:rPr>
-                <a:t>Git</a:t>
-              </a:r>
-              <a:r>
-                <a:rPr lang="en-US" altLang="ko-KR" sz="2400" dirty="0" smtClean="0">
-                  <a:latin typeface="나눔스퀘어 Bold" panose="020B0600000101010101" pitchFamily="50" charset="-127"/>
-                  <a:ea typeface="나눔스퀘어 Bold" panose="020B0600000101010101" pitchFamily="50" charset="-127"/>
-                </a:rPr>
-                <a:t>, MySQL</a:t>
-              </a:r>
-              <a:endParaRPr lang="ko-KR" altLang="en-US" sz="2400" dirty="0">
-                <a:latin typeface="나눔스퀘어 Bold" panose="020B0600000101010101" pitchFamily="50" charset="-127"/>
-                <a:ea typeface="나눔스퀘어 Bold" panose="020B0600000101010101" pitchFamily="50" charset="-127"/>
-              </a:endParaRPr>
-            </a:p>
-          </p:txBody>
-        </p:sp>
-        <p:sp>
-          <p:nvSpPr>
-            <p:cNvPr id="43" name="직사각형 42"/>
-            <p:cNvSpPr/>
-            <p:nvPr/>
-          </p:nvSpPr>
-          <p:spPr>
-            <a:xfrm>
-              <a:off x="290286" y="2492879"/>
-              <a:ext cx="2880000" cy="1440000"/>
-            </a:xfrm>
-            <a:prstGeom prst="rect">
-              <a:avLst/>
-            </a:prstGeom>
-            <a:solidFill>
-              <a:schemeClr val="accent5"/>
-            </a:solidFill>
-            <a:ln>
-              <a:solidFill>
-                <a:schemeClr val="tx1"/>
-              </a:solidFill>
-            </a:ln>
-          </p:spPr>
-          <p:style>
-            <a:lnRef idx="2">
-              <a:schemeClr val="accent1">
-                <a:shade val="50000"/>
-              </a:schemeClr>
-            </a:lnRef>
-            <a:fillRef idx="1">
-              <a:schemeClr val="accent1"/>
-            </a:fillRef>
-            <a:effectRef idx="0">
-              <a:schemeClr val="accent1"/>
-            </a:effectRef>
-            <a:fontRef idx="minor">
-              <a:schemeClr val="lt1"/>
-            </a:fontRef>
-          </p:style>
-          <p:txBody>
-            <a:bodyPr rtlCol="0" anchor="ctr"/>
-            <a:lstStyle/>
-            <a:p>
-              <a:pPr algn="ctr"/>
-              <a:r>
-                <a:rPr lang="ko-KR" altLang="en-US" sz="2400" dirty="0" smtClean="0">
-                  <a:latin typeface="나눔스퀘어 Bold" panose="020B0600000101010101" pitchFamily="50" charset="-127"/>
-                  <a:ea typeface="나눔스퀘어 Bold" panose="020B0600000101010101" pitchFamily="50" charset="-127"/>
-                </a:rPr>
-                <a:t>개발</a:t>
-              </a:r>
-              <a:r>
-                <a:rPr lang="en-US" altLang="ko-KR" sz="2400" dirty="0" smtClean="0">
-                  <a:latin typeface="나눔스퀘어 Bold" panose="020B0600000101010101" pitchFamily="50" charset="-127"/>
-                  <a:ea typeface="나눔스퀘어 Bold" panose="020B0600000101010101" pitchFamily="50" charset="-127"/>
-                </a:rPr>
-                <a:t>PC(Local)</a:t>
-              </a:r>
-            </a:p>
-            <a:p>
-              <a:pPr algn="ctr"/>
-              <a:r>
-                <a:rPr lang="en-US" altLang="ko-KR" sz="2400" dirty="0" smtClean="0">
-                  <a:latin typeface="나눔스퀘어 Bold" panose="020B0600000101010101" pitchFamily="50" charset="-127"/>
-                  <a:ea typeface="나눔스퀘어 Bold" panose="020B0600000101010101" pitchFamily="50" charset="-127"/>
-                </a:rPr>
-                <a:t>JDK, </a:t>
-              </a:r>
-              <a:r>
-                <a:rPr lang="en-US" altLang="ko-KR" sz="2400" dirty="0" err="1" smtClean="0">
-                  <a:latin typeface="나눔스퀘어 Bold" panose="020B0600000101010101" pitchFamily="50" charset="-127"/>
-                  <a:ea typeface="나눔스퀘어 Bold" panose="020B0600000101010101" pitchFamily="50" charset="-127"/>
-                </a:rPr>
-                <a:t>Git</a:t>
-              </a:r>
-              <a:r>
-                <a:rPr lang="en-US" altLang="ko-KR" sz="2400" dirty="0" smtClean="0">
-                  <a:latin typeface="나눔스퀘어 Bold" panose="020B0600000101010101" pitchFamily="50" charset="-127"/>
-                  <a:ea typeface="나눔스퀘어 Bold" panose="020B0600000101010101" pitchFamily="50" charset="-127"/>
-                </a:rPr>
-                <a:t>, MySQL</a:t>
-              </a:r>
-              <a:endParaRPr lang="ko-KR" altLang="en-US" sz="2400" dirty="0">
-                <a:latin typeface="나눔스퀘어 Bold" panose="020B0600000101010101" pitchFamily="50" charset="-127"/>
-                <a:ea typeface="나눔스퀘어 Bold" panose="020B0600000101010101" pitchFamily="50" charset="-127"/>
-              </a:endParaRPr>
-            </a:p>
-          </p:txBody>
-        </p:sp>
-        <p:sp>
-          <p:nvSpPr>
-            <p:cNvPr id="44" name="직사각형 43"/>
-            <p:cNvSpPr/>
-            <p:nvPr/>
-          </p:nvSpPr>
-          <p:spPr>
-            <a:xfrm>
-              <a:off x="9780858" y="3546923"/>
-              <a:ext cx="2160000" cy="540000"/>
-            </a:xfrm>
-            <a:prstGeom prst="rect">
-              <a:avLst/>
-            </a:prstGeom>
-            <a:solidFill>
-              <a:schemeClr val="accent4"/>
-            </a:solidFill>
-            <a:ln>
-              <a:solidFill>
-                <a:schemeClr val="tx1"/>
-              </a:solidFill>
-            </a:ln>
-          </p:spPr>
-          <p:style>
-            <a:lnRef idx="2">
-              <a:schemeClr val="accent1">
-                <a:shade val="50000"/>
-              </a:schemeClr>
-            </a:lnRef>
-            <a:fillRef idx="1">
-              <a:schemeClr val="accent1"/>
-            </a:fillRef>
-            <a:effectRef idx="0">
-              <a:schemeClr val="accent1"/>
-            </a:effectRef>
-            <a:fontRef idx="minor">
-              <a:schemeClr val="lt1"/>
-            </a:fontRef>
-          </p:style>
-          <p:txBody>
-            <a:bodyPr rtlCol="0" anchor="ctr"/>
-            <a:lstStyle/>
-            <a:p>
-              <a:pPr algn="ctr"/>
-              <a:r>
-                <a:rPr lang="en-US" altLang="ko-KR" dirty="0" smtClean="0">
-                  <a:solidFill>
-                    <a:schemeClr val="tx1"/>
-                  </a:solidFill>
-                  <a:latin typeface="나눔스퀘어 Bold" panose="020B0600000101010101" pitchFamily="50" charset="-127"/>
-                  <a:ea typeface="나눔스퀘어 Bold" panose="020B0600000101010101" pitchFamily="50" charset="-127"/>
-                </a:rPr>
-                <a:t>Docker Image(Jar)</a:t>
-              </a:r>
-              <a:endParaRPr lang="ko-KR" altLang="en-US" dirty="0">
-                <a:solidFill>
-                  <a:schemeClr val="tx1"/>
-                </a:solidFill>
-                <a:latin typeface="나눔스퀘어 Bold" panose="020B0600000101010101" pitchFamily="50" charset="-127"/>
-                <a:ea typeface="나눔스퀘어 Bold" panose="020B0600000101010101" pitchFamily="50" charset="-127"/>
-              </a:endParaRPr>
-            </a:p>
-          </p:txBody>
-        </p:sp>
-        <p:sp>
-          <p:nvSpPr>
-            <p:cNvPr id="45" name="직사각형 44"/>
-            <p:cNvSpPr/>
-            <p:nvPr/>
-          </p:nvSpPr>
-          <p:spPr>
-            <a:xfrm>
-              <a:off x="9904230" y="3670295"/>
-              <a:ext cx="2160000" cy="540000"/>
-            </a:xfrm>
-            <a:prstGeom prst="rect">
-              <a:avLst/>
-            </a:prstGeom>
-            <a:solidFill>
-              <a:schemeClr val="accent4"/>
-            </a:solidFill>
-            <a:ln>
-              <a:solidFill>
-                <a:schemeClr val="tx1"/>
-              </a:solidFill>
-            </a:ln>
-          </p:spPr>
-          <p:style>
-            <a:lnRef idx="2">
-              <a:schemeClr val="accent1">
-                <a:shade val="50000"/>
-              </a:schemeClr>
-            </a:lnRef>
-            <a:fillRef idx="1">
-              <a:schemeClr val="accent1"/>
-            </a:fillRef>
-            <a:effectRef idx="0">
-              <a:schemeClr val="accent1"/>
-            </a:effectRef>
-            <a:fontRef idx="minor">
-              <a:schemeClr val="lt1"/>
-            </a:fontRef>
-          </p:style>
-          <p:txBody>
-            <a:bodyPr rtlCol="0" anchor="ctr"/>
-            <a:lstStyle/>
-            <a:p>
-              <a:pPr algn="ctr"/>
-              <a:r>
-                <a:rPr lang="en-US" altLang="ko-KR" dirty="0" smtClean="0">
-                  <a:solidFill>
-                    <a:schemeClr val="tx1"/>
-                  </a:solidFill>
-                  <a:latin typeface="나눔스퀘어 Bold" panose="020B0600000101010101" pitchFamily="50" charset="-127"/>
-                  <a:ea typeface="나눔스퀘어 Bold" panose="020B0600000101010101" pitchFamily="50" charset="-127"/>
-                </a:rPr>
-                <a:t>Docker Image(Jar)</a:t>
-              </a:r>
-              <a:endParaRPr lang="ko-KR" altLang="en-US" dirty="0">
-                <a:solidFill>
-                  <a:schemeClr val="tx1"/>
-                </a:solidFill>
-                <a:latin typeface="나눔스퀘어 Bold" panose="020B0600000101010101" pitchFamily="50" charset="-127"/>
-                <a:ea typeface="나눔스퀘어 Bold" panose="020B0600000101010101" pitchFamily="50" charset="-127"/>
-              </a:endParaRPr>
-            </a:p>
-          </p:txBody>
-        </p:sp>
-        <p:sp>
-          <p:nvSpPr>
-            <p:cNvPr id="46" name="직사각형 45"/>
-            <p:cNvSpPr/>
-            <p:nvPr/>
-          </p:nvSpPr>
-          <p:spPr>
-            <a:xfrm>
-              <a:off x="4365714" y="1832065"/>
-              <a:ext cx="1440000" cy="720000"/>
-            </a:xfrm>
-            <a:prstGeom prst="rect">
-              <a:avLst/>
-            </a:prstGeom>
-            <a:solidFill>
-              <a:schemeClr val="accent5"/>
-            </a:solidFill>
-            <a:ln>
-              <a:solidFill>
-                <a:schemeClr val="tx1"/>
-              </a:solidFill>
-            </a:ln>
-          </p:spPr>
-          <p:style>
-            <a:lnRef idx="2">
-              <a:schemeClr val="accent1">
-                <a:shade val="50000"/>
-              </a:schemeClr>
-            </a:lnRef>
-            <a:fillRef idx="1">
-              <a:schemeClr val="accent1"/>
-            </a:fillRef>
-            <a:effectRef idx="0">
-              <a:schemeClr val="accent1"/>
-            </a:effectRef>
-            <a:fontRef idx="minor">
-              <a:schemeClr val="lt1"/>
-            </a:fontRef>
-          </p:style>
-          <p:txBody>
-            <a:bodyPr rtlCol="0" anchor="ctr"/>
-            <a:lstStyle/>
-            <a:p>
-              <a:pPr algn="ctr"/>
-              <a:r>
-                <a:rPr lang="en-US" altLang="ko-KR" sz="2400" dirty="0" err="1" smtClean="0">
-                  <a:latin typeface="나눔스퀘어 Bold" panose="020B0600000101010101" pitchFamily="50" charset="-127"/>
-                  <a:ea typeface="나눔스퀘어 Bold" panose="020B0600000101010101" pitchFamily="50" charset="-127"/>
-                </a:rPr>
-                <a:t>Ngnix</a:t>
-              </a:r>
-              <a:endParaRPr lang="ko-KR" altLang="en-US" sz="2400" dirty="0">
-                <a:latin typeface="나눔스퀘어 Bold" panose="020B0600000101010101" pitchFamily="50" charset="-127"/>
-                <a:ea typeface="나눔스퀘어 Bold" panose="020B0600000101010101" pitchFamily="50" charset="-127"/>
-              </a:endParaRPr>
-            </a:p>
-          </p:txBody>
-        </p:sp>
-        <p:sp>
-          <p:nvSpPr>
-            <p:cNvPr id="47" name="직사각형 46"/>
-            <p:cNvSpPr/>
-            <p:nvPr/>
-          </p:nvSpPr>
-          <p:spPr>
-            <a:xfrm>
-              <a:off x="11003142" y="1831043"/>
-              <a:ext cx="1440000" cy="720000"/>
-            </a:xfrm>
-            <a:prstGeom prst="rect">
-              <a:avLst/>
-            </a:prstGeom>
-            <a:solidFill>
-              <a:schemeClr val="accent5"/>
-            </a:solidFill>
-            <a:ln>
-              <a:solidFill>
-                <a:schemeClr val="tx1"/>
-              </a:solidFill>
-            </a:ln>
-          </p:spPr>
-          <p:style>
-            <a:lnRef idx="2">
-              <a:schemeClr val="accent1">
-                <a:shade val="50000"/>
-              </a:schemeClr>
-            </a:lnRef>
-            <a:fillRef idx="1">
-              <a:schemeClr val="accent1"/>
-            </a:fillRef>
-            <a:effectRef idx="0">
-              <a:schemeClr val="accent1"/>
-            </a:effectRef>
-            <a:fontRef idx="minor">
-              <a:schemeClr val="lt1"/>
-            </a:fontRef>
-          </p:style>
-          <p:txBody>
-            <a:bodyPr rtlCol="0" anchor="ctr"/>
-            <a:lstStyle/>
-            <a:p>
-              <a:pPr algn="ctr"/>
-              <a:r>
-                <a:rPr lang="en-US" altLang="ko-KR" sz="2400" dirty="0" err="1" smtClean="0">
-                  <a:latin typeface="나눔스퀘어 Bold" panose="020B0600000101010101" pitchFamily="50" charset="-127"/>
-                  <a:ea typeface="나눔스퀘어 Bold" panose="020B0600000101010101" pitchFamily="50" charset="-127"/>
-                </a:rPr>
-                <a:t>Ngnix</a:t>
-              </a:r>
-              <a:endParaRPr lang="ko-KR" altLang="en-US" sz="2400" dirty="0">
-                <a:latin typeface="나눔스퀘어 Bold" panose="020B0600000101010101" pitchFamily="50" charset="-127"/>
-                <a:ea typeface="나눔스퀘어 Bold" panose="020B0600000101010101" pitchFamily="50" charset="-127"/>
-              </a:endParaRPr>
-            </a:p>
-          </p:txBody>
-        </p:sp>
-        <p:sp>
-          <p:nvSpPr>
-            <p:cNvPr id="48" name="직사각형 47"/>
-            <p:cNvSpPr/>
-            <p:nvPr/>
-          </p:nvSpPr>
-          <p:spPr>
-            <a:xfrm>
-              <a:off x="9060858" y="1824689"/>
-              <a:ext cx="1440000" cy="720000"/>
-            </a:xfrm>
-            <a:prstGeom prst="rect">
-              <a:avLst/>
-            </a:prstGeom>
-            <a:solidFill>
-              <a:schemeClr val="accent5"/>
-            </a:solidFill>
-            <a:ln>
-              <a:solidFill>
-                <a:schemeClr val="tx1"/>
-              </a:solidFill>
-            </a:ln>
-          </p:spPr>
-          <p:style>
-            <a:lnRef idx="2">
-              <a:schemeClr val="accent1">
-                <a:shade val="50000"/>
-              </a:schemeClr>
-            </a:lnRef>
-            <a:fillRef idx="1">
-              <a:schemeClr val="accent1"/>
-            </a:fillRef>
-            <a:effectRef idx="0">
-              <a:schemeClr val="accent1"/>
-            </a:effectRef>
-            <a:fontRef idx="minor">
-              <a:schemeClr val="lt1"/>
-            </a:fontRef>
-          </p:style>
-          <p:txBody>
-            <a:bodyPr rtlCol="0" anchor="ctr"/>
-            <a:lstStyle/>
-            <a:p>
-              <a:pPr algn="ctr"/>
-              <a:r>
-                <a:rPr lang="en-US" altLang="ko-KR" sz="2400" dirty="0" smtClean="0">
-                  <a:latin typeface="나눔스퀘어 Bold" panose="020B0600000101010101" pitchFamily="50" charset="-127"/>
-                  <a:ea typeface="나눔스퀘어 Bold" panose="020B0600000101010101" pitchFamily="50" charset="-127"/>
-                </a:rPr>
-                <a:t>DNS</a:t>
-              </a:r>
-              <a:endParaRPr lang="ko-KR" altLang="en-US" sz="2400" dirty="0">
-                <a:latin typeface="나눔스퀘어 Bold" panose="020B0600000101010101" pitchFamily="50" charset="-127"/>
-                <a:ea typeface="나눔스퀘어 Bold" panose="020B0600000101010101" pitchFamily="50" charset="-127"/>
-              </a:endParaRPr>
-            </a:p>
-          </p:txBody>
-        </p:sp>
-      </p:grpSp>
+              <a:latin typeface="나눔스퀘어 Bold" panose="020B0600000101010101" pitchFamily="50" charset="-127"/>
+              <a:ea typeface="나눔스퀘어 Bold" panose="020B0600000101010101" pitchFamily="50" charset="-127"/>
+            </a:endParaRPr>
+          </a:p>
+        </p:txBody>
+      </p:sp>
     </p:spTree>
     <p:extLst>
       <p:ext uri="{BB962C8B-B14F-4D97-AF65-F5344CB8AC3E}">

</xml_diff>

<commit_message>
20261001 commit : 4.5_class
</commit_message>
<xml_diff>
--- a/notion/create_notion_img.pptx
+++ b/notion/create_notion_img.pptx
@@ -2973,1500 +2973,1515 @@
           <a:chExt cx="0" cy="0"/>
         </a:xfrm>
       </p:grpSpPr>
-      <p:sp>
-        <p:nvSpPr>
-          <p:cNvPr id="2" name="직사각형 1"/>
-          <p:cNvSpPr/>
-          <p:nvPr/>
-        </p:nvSpPr>
-        <p:spPr>
-          <a:xfrm>
-            <a:off x="0" y="2217107"/>
-            <a:ext cx="2880000" cy="1440000"/>
-          </a:xfrm>
-          <a:prstGeom prst="rect">
-            <a:avLst/>
-          </a:prstGeom>
-          <a:solidFill>
-            <a:schemeClr val="accent5"/>
-          </a:solidFill>
-          <a:ln>
+      <p:grpSp>
+        <p:nvGrpSpPr>
+          <p:cNvPr id="20" name="그룹 19"/>
+          <p:cNvGrpSpPr/>
+          <p:nvPr/>
+        </p:nvGrpSpPr>
+        <p:grpSpPr>
+          <a:xfrm>
+            <a:off x="0" y="0"/>
+            <a:ext cx="12443142" cy="5514214"/>
+            <a:chOff x="0" y="0"/>
+            <a:chExt cx="12443142" cy="5514214"/>
+          </a:xfrm>
+        </p:grpSpPr>
+        <p:sp>
+          <p:nvSpPr>
+            <p:cNvPr id="2" name="직사각형 1"/>
+            <p:cNvSpPr/>
+            <p:nvPr/>
+          </p:nvSpPr>
+          <p:spPr>
+            <a:xfrm>
+              <a:off x="0" y="2217107"/>
+              <a:ext cx="2880000" cy="1440000"/>
+            </a:xfrm>
+            <a:prstGeom prst="rect">
+              <a:avLst/>
+            </a:prstGeom>
             <a:solidFill>
+              <a:schemeClr val="accent5"/>
+            </a:solidFill>
+            <a:ln>
+              <a:solidFill>
+                <a:schemeClr val="tx1"/>
+              </a:solidFill>
+            </a:ln>
+          </p:spPr>
+          <p:style>
+            <a:lnRef idx="2">
+              <a:schemeClr val="accent1">
+                <a:shade val="50000"/>
+              </a:schemeClr>
+            </a:lnRef>
+            <a:fillRef idx="1">
+              <a:schemeClr val="accent1"/>
+            </a:fillRef>
+            <a:effectRef idx="0">
+              <a:schemeClr val="accent1"/>
+            </a:effectRef>
+            <a:fontRef idx="minor">
+              <a:schemeClr val="lt1"/>
+            </a:fontRef>
+          </p:style>
+          <p:txBody>
+            <a:bodyPr rtlCol="0" anchor="ctr"/>
+            <a:lstStyle/>
+            <a:p>
+              <a:pPr algn="ctr"/>
+              <a:r>
+                <a:rPr lang="ko-KR" altLang="en-US" sz="2400" dirty="0" smtClean="0">
+                  <a:latin typeface="나눔스퀘어 Bold" panose="020B0600000101010101" pitchFamily="50" charset="-127"/>
+                  <a:ea typeface="나눔스퀘어 Bold" panose="020B0600000101010101" pitchFamily="50" charset="-127"/>
+                </a:rPr>
+                <a:t>개발</a:t>
+              </a:r>
+              <a:r>
+                <a:rPr lang="en-US" altLang="ko-KR" sz="2400" dirty="0" smtClean="0">
+                  <a:latin typeface="나눔스퀘어 Bold" panose="020B0600000101010101" pitchFamily="50" charset="-127"/>
+                  <a:ea typeface="나눔스퀘어 Bold" panose="020B0600000101010101" pitchFamily="50" charset="-127"/>
+                </a:rPr>
+                <a:t>PC(Local)</a:t>
+              </a:r>
+            </a:p>
+            <a:p>
+              <a:pPr algn="ctr"/>
+              <a:r>
+                <a:rPr lang="en-US" altLang="ko-KR" sz="2400" dirty="0" smtClean="0">
+                  <a:latin typeface="나눔스퀘어 Bold" panose="020B0600000101010101" pitchFamily="50" charset="-127"/>
+                  <a:ea typeface="나눔스퀘어 Bold" panose="020B0600000101010101" pitchFamily="50" charset="-127"/>
+                </a:rPr>
+                <a:t>JDK, </a:t>
+              </a:r>
+              <a:r>
+                <a:rPr lang="en-US" altLang="ko-KR" sz="2400" dirty="0" err="1" smtClean="0">
+                  <a:latin typeface="나눔스퀘어 Bold" panose="020B0600000101010101" pitchFamily="50" charset="-127"/>
+                  <a:ea typeface="나눔스퀘어 Bold" panose="020B0600000101010101" pitchFamily="50" charset="-127"/>
+                </a:rPr>
+                <a:t>Git</a:t>
+              </a:r>
+              <a:r>
+                <a:rPr lang="en-US" altLang="ko-KR" sz="2400" dirty="0" smtClean="0">
+                  <a:latin typeface="나눔스퀘어 Bold" panose="020B0600000101010101" pitchFamily="50" charset="-127"/>
+                  <a:ea typeface="나눔스퀘어 Bold" panose="020B0600000101010101" pitchFamily="50" charset="-127"/>
+                </a:rPr>
+                <a:t>, MySQL</a:t>
+              </a:r>
+              <a:endParaRPr lang="ko-KR" altLang="en-US" sz="2400" dirty="0">
+                <a:latin typeface="나눔스퀘어 Bold" panose="020B0600000101010101" pitchFamily="50" charset="-127"/>
+                <a:ea typeface="나눔스퀘어 Bold" panose="020B0600000101010101" pitchFamily="50" charset="-127"/>
+              </a:endParaRPr>
+            </a:p>
+          </p:txBody>
+        </p:sp>
+        <p:sp>
+          <p:nvSpPr>
+            <p:cNvPr id="4" name="직사각형 3"/>
+            <p:cNvSpPr/>
+            <p:nvPr/>
+          </p:nvSpPr>
+          <p:spPr>
+            <a:xfrm>
+              <a:off x="4656000" y="2217107"/>
+              <a:ext cx="2880000" cy="1440000"/>
+            </a:xfrm>
+            <a:prstGeom prst="rect">
+              <a:avLst/>
+            </a:prstGeom>
+            <a:solidFill>
+              <a:schemeClr val="accent5"/>
+            </a:solidFill>
+            <a:ln>
+              <a:solidFill>
+                <a:schemeClr val="tx1"/>
+              </a:solidFill>
+            </a:ln>
+          </p:spPr>
+          <p:style>
+            <a:lnRef idx="2">
+              <a:schemeClr val="accent1">
+                <a:shade val="50000"/>
+              </a:schemeClr>
+            </a:lnRef>
+            <a:fillRef idx="1">
+              <a:schemeClr val="accent1"/>
+            </a:fillRef>
+            <a:effectRef idx="0">
+              <a:schemeClr val="accent1"/>
+            </a:effectRef>
+            <a:fontRef idx="minor">
+              <a:schemeClr val="lt1"/>
+            </a:fontRef>
+          </p:style>
+          <p:txBody>
+            <a:bodyPr rtlCol="0" anchor="ctr"/>
+            <a:lstStyle/>
+            <a:p>
+              <a:pPr algn="ctr"/>
+              <a:r>
+                <a:rPr lang="en-US" altLang="ko-KR" sz="2000" dirty="0" smtClean="0">
+                  <a:latin typeface="나눔스퀘어 Bold" panose="020B0600000101010101" pitchFamily="50" charset="-127"/>
+                  <a:ea typeface="나눔스퀘어 Bold" panose="020B0600000101010101" pitchFamily="50" charset="-127"/>
+                </a:rPr>
+                <a:t>Dev(Stage) Server</a:t>
+              </a:r>
+            </a:p>
+            <a:p>
+              <a:pPr algn="ctr"/>
+              <a:r>
+                <a:rPr lang="en-US" altLang="ko-KR" sz="2000" dirty="0" err="1" smtClean="0">
+                  <a:latin typeface="나눔스퀘어 Bold" panose="020B0600000101010101" pitchFamily="50" charset="-127"/>
+                  <a:ea typeface="나눔스퀘어 Bold" panose="020B0600000101010101" pitchFamily="50" charset="-127"/>
+                </a:rPr>
+                <a:t>Gradle</a:t>
+              </a:r>
+              <a:r>
+                <a:rPr lang="en-US" altLang="ko-KR" sz="2000" dirty="0" smtClean="0">
+                  <a:latin typeface="나눔스퀘어 Bold" panose="020B0600000101010101" pitchFamily="50" charset="-127"/>
+                  <a:ea typeface="나눔스퀘어 Bold" panose="020B0600000101010101" pitchFamily="50" charset="-127"/>
+                </a:rPr>
+                <a:t>, JDK, </a:t>
+              </a:r>
+              <a:r>
+                <a:rPr lang="en-US" altLang="ko-KR" sz="2000" dirty="0" err="1" smtClean="0">
+                  <a:latin typeface="나눔스퀘어 Bold" panose="020B0600000101010101" pitchFamily="50" charset="-127"/>
+                  <a:ea typeface="나눔스퀘어 Bold" panose="020B0600000101010101" pitchFamily="50" charset="-127"/>
+                </a:rPr>
+                <a:t>Git</a:t>
+              </a:r>
+              <a:r>
+                <a:rPr lang="en-US" altLang="ko-KR" sz="2000" dirty="0" smtClean="0">
+                  <a:latin typeface="나눔스퀘어 Bold" panose="020B0600000101010101" pitchFamily="50" charset="-127"/>
+                  <a:ea typeface="나눔스퀘어 Bold" panose="020B0600000101010101" pitchFamily="50" charset="-127"/>
+                </a:rPr>
+                <a:t>, Build</a:t>
+              </a:r>
+              <a:endParaRPr lang="ko-KR" altLang="en-US" sz="2000" dirty="0">
+                <a:latin typeface="나눔스퀘어 Bold" panose="020B0600000101010101" pitchFamily="50" charset="-127"/>
+                <a:ea typeface="나눔스퀘어 Bold" panose="020B0600000101010101" pitchFamily="50" charset="-127"/>
+              </a:endParaRPr>
+            </a:p>
+          </p:txBody>
+        </p:sp>
+        <p:sp>
+          <p:nvSpPr>
+            <p:cNvPr id="5" name="직사각형 4"/>
+            <p:cNvSpPr/>
+            <p:nvPr/>
+          </p:nvSpPr>
+          <p:spPr>
+            <a:xfrm>
+              <a:off x="9492000" y="4434214"/>
+              <a:ext cx="2520000" cy="1080000"/>
+            </a:xfrm>
+            <a:prstGeom prst="rect">
+              <a:avLst/>
+            </a:prstGeom>
+            <a:solidFill>
+              <a:schemeClr val="accent5"/>
+            </a:solidFill>
+            <a:ln>
+              <a:solidFill>
+                <a:schemeClr val="tx1"/>
+              </a:solidFill>
+            </a:ln>
+          </p:spPr>
+          <p:style>
+            <a:lnRef idx="2">
+              <a:schemeClr val="accent1">
+                <a:shade val="50000"/>
+              </a:schemeClr>
+            </a:lnRef>
+            <a:fillRef idx="1">
+              <a:schemeClr val="accent1"/>
+            </a:fillRef>
+            <a:effectRef idx="0">
+              <a:schemeClr val="accent1"/>
+            </a:effectRef>
+            <a:fontRef idx="minor">
+              <a:schemeClr val="lt1"/>
+            </a:fontRef>
+          </p:style>
+          <p:txBody>
+            <a:bodyPr rtlCol="0" anchor="ctr"/>
+            <a:lstStyle/>
+            <a:p>
+              <a:pPr algn="ctr"/>
+              <a:r>
+                <a:rPr lang="en-US" altLang="ko-KR" sz="2400" dirty="0" smtClean="0">
+                  <a:latin typeface="나눔스퀘어 Bold" panose="020B0600000101010101" pitchFamily="50" charset="-127"/>
+                  <a:ea typeface="나눔스퀘어 Bold" panose="020B0600000101010101" pitchFamily="50" charset="-127"/>
+                </a:rPr>
+                <a:t>Product MySQL</a:t>
+              </a:r>
+              <a:endParaRPr lang="ko-KR" altLang="en-US" sz="2400" dirty="0">
+                <a:latin typeface="나눔스퀘어 Bold" panose="020B0600000101010101" pitchFamily="50" charset="-127"/>
+                <a:ea typeface="나눔스퀘어 Bold" panose="020B0600000101010101" pitchFamily="50" charset="-127"/>
+              </a:endParaRPr>
+            </a:p>
+          </p:txBody>
+        </p:sp>
+        <p:sp>
+          <p:nvSpPr>
+            <p:cNvPr id="6" name="직사각형 5"/>
+            <p:cNvSpPr/>
+            <p:nvPr/>
+          </p:nvSpPr>
+          <p:spPr>
+            <a:xfrm>
+              <a:off x="9312000" y="2217107"/>
+              <a:ext cx="2880000" cy="1440000"/>
+            </a:xfrm>
+            <a:prstGeom prst="rect">
+              <a:avLst/>
+            </a:prstGeom>
+            <a:solidFill>
+              <a:schemeClr val="accent5"/>
+            </a:solidFill>
+            <a:ln>
+              <a:solidFill>
+                <a:schemeClr val="tx1"/>
+              </a:solidFill>
+            </a:ln>
+          </p:spPr>
+          <p:style>
+            <a:lnRef idx="2">
+              <a:schemeClr val="accent1">
+                <a:shade val="50000"/>
+              </a:schemeClr>
+            </a:lnRef>
+            <a:fillRef idx="1">
+              <a:schemeClr val="accent1"/>
+            </a:fillRef>
+            <a:effectRef idx="0">
+              <a:schemeClr val="accent1"/>
+            </a:effectRef>
+            <a:fontRef idx="minor">
+              <a:schemeClr val="lt1"/>
+            </a:fontRef>
+          </p:style>
+          <p:txBody>
+            <a:bodyPr rtlCol="0" anchor="ctr"/>
+            <a:lstStyle/>
+            <a:p>
+              <a:pPr algn="ctr"/>
+              <a:r>
+                <a:rPr lang="en-US" altLang="ko-KR" sz="2000" dirty="0" smtClean="0">
+                  <a:latin typeface="나눔스퀘어 Bold" panose="020B0600000101010101" pitchFamily="50" charset="-127"/>
+                  <a:ea typeface="나눔스퀘어 Bold" panose="020B0600000101010101" pitchFamily="50" charset="-127"/>
+                </a:rPr>
+                <a:t>Product Server</a:t>
+              </a:r>
+            </a:p>
+            <a:p>
+              <a:pPr algn="ctr"/>
+              <a:r>
+                <a:rPr lang="en-US" altLang="ko-KR" sz="2000" dirty="0" err="1" smtClean="0">
+                  <a:latin typeface="나눔스퀘어 Bold" panose="020B0600000101010101" pitchFamily="50" charset="-127"/>
+                  <a:ea typeface="나눔스퀘어 Bold" panose="020B0600000101010101" pitchFamily="50" charset="-127"/>
+                </a:rPr>
+                <a:t>Gradle</a:t>
+              </a:r>
+              <a:r>
+                <a:rPr lang="en-US" altLang="ko-KR" sz="2000" dirty="0" smtClean="0">
+                  <a:latin typeface="나눔스퀘어 Bold" panose="020B0600000101010101" pitchFamily="50" charset="-127"/>
+                  <a:ea typeface="나눔스퀘어 Bold" panose="020B0600000101010101" pitchFamily="50" charset="-127"/>
+                </a:rPr>
+                <a:t>, JDK, </a:t>
+              </a:r>
+              <a:r>
+                <a:rPr lang="en-US" altLang="ko-KR" sz="2000" dirty="0" err="1" smtClean="0">
+                  <a:latin typeface="나눔스퀘어 Bold" panose="020B0600000101010101" pitchFamily="50" charset="-127"/>
+                  <a:ea typeface="나눔스퀘어 Bold" panose="020B0600000101010101" pitchFamily="50" charset="-127"/>
+                </a:rPr>
+                <a:t>Git</a:t>
+              </a:r>
+              <a:r>
+                <a:rPr lang="en-US" altLang="ko-KR" sz="2000" dirty="0" smtClean="0">
+                  <a:latin typeface="나눔스퀘어 Bold" panose="020B0600000101010101" pitchFamily="50" charset="-127"/>
+                  <a:ea typeface="나눔스퀘어 Bold" panose="020B0600000101010101" pitchFamily="50" charset="-127"/>
+                </a:rPr>
+                <a:t>, Build</a:t>
+              </a:r>
+              <a:endParaRPr lang="ko-KR" altLang="en-US" sz="2000" dirty="0" smtClean="0">
+                <a:latin typeface="나눔스퀘어 Bold" panose="020B0600000101010101" pitchFamily="50" charset="-127"/>
+                <a:ea typeface="나눔스퀘어 Bold" panose="020B0600000101010101" pitchFamily="50" charset="-127"/>
+              </a:endParaRPr>
+            </a:p>
+          </p:txBody>
+        </p:sp>
+        <p:sp>
+          <p:nvSpPr>
+            <p:cNvPr id="11" name="직사각형 10"/>
+            <p:cNvSpPr/>
+            <p:nvPr/>
+          </p:nvSpPr>
+          <p:spPr>
+            <a:xfrm>
+              <a:off x="4760972" y="4434214"/>
+              <a:ext cx="2520000" cy="1080000"/>
+            </a:xfrm>
+            <a:prstGeom prst="rect">
+              <a:avLst/>
+            </a:prstGeom>
+            <a:solidFill>
+              <a:schemeClr val="accent5"/>
+            </a:solidFill>
+            <a:ln>
+              <a:solidFill>
+                <a:schemeClr val="tx1"/>
+              </a:solidFill>
+            </a:ln>
+          </p:spPr>
+          <p:style>
+            <a:lnRef idx="2">
+              <a:schemeClr val="accent1">
+                <a:shade val="50000"/>
+              </a:schemeClr>
+            </a:lnRef>
+            <a:fillRef idx="1">
+              <a:schemeClr val="accent1"/>
+            </a:fillRef>
+            <a:effectRef idx="0">
+              <a:schemeClr val="accent1"/>
+            </a:effectRef>
+            <a:fontRef idx="minor">
+              <a:schemeClr val="lt1"/>
+            </a:fontRef>
+          </p:style>
+          <p:txBody>
+            <a:bodyPr rtlCol="0" anchor="ctr"/>
+            <a:lstStyle/>
+            <a:p>
+              <a:pPr algn="ctr"/>
+              <a:r>
+                <a:rPr lang="en-US" altLang="ko-KR" sz="2400" dirty="0" smtClean="0">
+                  <a:latin typeface="나눔스퀘어 Bold" panose="020B0600000101010101" pitchFamily="50" charset="-127"/>
+                  <a:ea typeface="나눔스퀘어 Bold" panose="020B0600000101010101" pitchFamily="50" charset="-127"/>
+                </a:rPr>
+                <a:t>Dev MySQL</a:t>
+              </a:r>
+              <a:endParaRPr lang="ko-KR" altLang="en-US" sz="2400" dirty="0">
+                <a:latin typeface="나눔스퀘어 Bold" panose="020B0600000101010101" pitchFamily="50" charset="-127"/>
+                <a:ea typeface="나눔스퀘어 Bold" panose="020B0600000101010101" pitchFamily="50" charset="-127"/>
+              </a:endParaRPr>
+            </a:p>
+          </p:txBody>
+        </p:sp>
+        <p:cxnSp>
+          <p:nvCxnSpPr>
+            <p:cNvPr id="23" name="꺾인 연결선 22"/>
+            <p:cNvCxnSpPr>
+              <a:stCxn id="4" idx="3"/>
+              <a:endCxn id="13" idx="1"/>
+            </p:cNvCxnSpPr>
+            <p:nvPr/>
+          </p:nvCxnSpPr>
+          <p:spPr>
+            <a:xfrm flipH="1" flipV="1">
+              <a:off x="7163999" y="540000"/>
+              <a:ext cx="372001" cy="2397107"/>
+            </a:xfrm>
+            <a:prstGeom prst="bentConnector5">
+              <a:avLst>
+                <a:gd name="adj1" fmla="val -142264"/>
+                <a:gd name="adj2" fmla="val 53755"/>
+                <a:gd name="adj3" fmla="val 238896"/>
+              </a:avLst>
+            </a:prstGeom>
+            <a:ln w="76200">
+              <a:solidFill>
+                <a:schemeClr val="accent2"/>
+              </a:solidFill>
+              <a:tailEnd type="triangle"/>
+            </a:ln>
+          </p:spPr>
+          <p:style>
+            <a:lnRef idx="1">
+              <a:schemeClr val="accent1"/>
+            </a:lnRef>
+            <a:fillRef idx="0">
+              <a:schemeClr val="accent1"/>
+            </a:fillRef>
+            <a:effectRef idx="0">
+              <a:schemeClr val="accent1"/>
+            </a:effectRef>
+            <a:fontRef idx="minor">
               <a:schemeClr val="tx1"/>
+            </a:fontRef>
+          </p:style>
+        </p:cxnSp>
+        <p:sp>
+          <p:nvSpPr>
+            <p:cNvPr id="3" name="직사각형 2"/>
+            <p:cNvSpPr/>
+            <p:nvPr/>
+          </p:nvSpPr>
+          <p:spPr>
+            <a:xfrm>
+              <a:off x="2507999" y="0"/>
+              <a:ext cx="2520000" cy="1080000"/>
+            </a:xfrm>
+            <a:prstGeom prst="rect">
+              <a:avLst/>
+            </a:prstGeom>
+            <a:solidFill>
+              <a:schemeClr val="accent5"/>
             </a:solidFill>
-          </a:ln>
-        </p:spPr>
-        <p:style>
-          <a:lnRef idx="2">
-            <a:schemeClr val="accent1">
-              <a:shade val="50000"/>
-            </a:schemeClr>
-          </a:lnRef>
-          <a:fillRef idx="1">
-            <a:schemeClr val="accent1"/>
-          </a:fillRef>
-          <a:effectRef idx="0">
-            <a:schemeClr val="accent1"/>
-          </a:effectRef>
-          <a:fontRef idx="minor">
-            <a:schemeClr val="lt1"/>
-          </a:fontRef>
-        </p:style>
-        <p:txBody>
-          <a:bodyPr rtlCol="0" anchor="ctr"/>
-          <a:lstStyle/>
-          <a:p>
-            <a:pPr algn="ctr"/>
-            <a:r>
-              <a:rPr lang="ko-KR" altLang="en-US" sz="2400" dirty="0" smtClean="0">
-                <a:latin typeface="나눔스퀘어 Bold" panose="020B0600000101010101" pitchFamily="50" charset="-127"/>
-                <a:ea typeface="나눔스퀘어 Bold" panose="020B0600000101010101" pitchFamily="50" charset="-127"/>
-              </a:rPr>
-              <a:t>개발</a:t>
-            </a:r>
-            <a:r>
-              <a:rPr lang="en-US" altLang="ko-KR" sz="2400" dirty="0" smtClean="0">
-                <a:latin typeface="나눔스퀘어 Bold" panose="020B0600000101010101" pitchFamily="50" charset="-127"/>
-                <a:ea typeface="나눔스퀘어 Bold" panose="020B0600000101010101" pitchFamily="50" charset="-127"/>
-              </a:rPr>
-              <a:t>PC(Local)</a:t>
-            </a:r>
-          </a:p>
-          <a:p>
-            <a:pPr algn="ctr"/>
-            <a:r>
-              <a:rPr lang="en-US" altLang="ko-KR" sz="2400" dirty="0" smtClean="0">
-                <a:latin typeface="나눔스퀘어 Bold" panose="020B0600000101010101" pitchFamily="50" charset="-127"/>
-                <a:ea typeface="나눔스퀘어 Bold" panose="020B0600000101010101" pitchFamily="50" charset="-127"/>
-              </a:rPr>
-              <a:t>JDK, </a:t>
-            </a:r>
-            <a:r>
-              <a:rPr lang="en-US" altLang="ko-KR" sz="2400" dirty="0" err="1" smtClean="0">
-                <a:latin typeface="나눔스퀘어 Bold" panose="020B0600000101010101" pitchFamily="50" charset="-127"/>
-                <a:ea typeface="나눔스퀘어 Bold" panose="020B0600000101010101" pitchFamily="50" charset="-127"/>
-              </a:rPr>
-              <a:t>Git</a:t>
-            </a:r>
-            <a:r>
-              <a:rPr lang="en-US" altLang="ko-KR" sz="2400" dirty="0" smtClean="0">
-                <a:latin typeface="나눔스퀘어 Bold" panose="020B0600000101010101" pitchFamily="50" charset="-127"/>
-                <a:ea typeface="나눔스퀘어 Bold" panose="020B0600000101010101" pitchFamily="50" charset="-127"/>
-              </a:rPr>
-              <a:t>, MySQL</a:t>
-            </a:r>
-            <a:endParaRPr lang="ko-KR" altLang="en-US" sz="2400" dirty="0">
-              <a:latin typeface="나눔스퀘어 Bold" panose="020B0600000101010101" pitchFamily="50" charset="-127"/>
-              <a:ea typeface="나눔스퀘어 Bold" panose="020B0600000101010101" pitchFamily="50" charset="-127"/>
-            </a:endParaRPr>
-          </a:p>
-        </p:txBody>
-      </p:sp>
-      <p:sp>
-        <p:nvSpPr>
-          <p:cNvPr id="4" name="직사각형 3"/>
-          <p:cNvSpPr/>
-          <p:nvPr/>
-        </p:nvSpPr>
-        <p:spPr>
-          <a:xfrm>
-            <a:off x="4656000" y="2217107"/>
-            <a:ext cx="2880000" cy="1440000"/>
-          </a:xfrm>
-          <a:prstGeom prst="rect">
-            <a:avLst/>
-          </a:prstGeom>
-          <a:solidFill>
-            <a:schemeClr val="accent5"/>
-          </a:solidFill>
-          <a:ln>
+            <a:ln>
+              <a:solidFill>
+                <a:schemeClr val="tx1"/>
+              </a:solidFill>
+            </a:ln>
+          </p:spPr>
+          <p:style>
+            <a:lnRef idx="2">
+              <a:schemeClr val="accent1">
+                <a:shade val="50000"/>
+              </a:schemeClr>
+            </a:lnRef>
+            <a:fillRef idx="1">
+              <a:schemeClr val="accent1"/>
+            </a:fillRef>
+            <a:effectRef idx="0">
+              <a:schemeClr val="accent1"/>
+            </a:effectRef>
+            <a:fontRef idx="minor">
+              <a:schemeClr val="lt1"/>
+            </a:fontRef>
+          </p:style>
+          <p:txBody>
+            <a:bodyPr rtlCol="0" anchor="ctr"/>
+            <a:lstStyle/>
+            <a:p>
+              <a:pPr algn="ctr"/>
+              <a:r>
+                <a:rPr lang="en-US" altLang="ko-KR" sz="2400" dirty="0" smtClean="0">
+                  <a:latin typeface="나눔스퀘어 Bold" panose="020B0600000101010101" pitchFamily="50" charset="-127"/>
+                  <a:ea typeface="나눔스퀘어 Bold" panose="020B0600000101010101" pitchFamily="50" charset="-127"/>
+                </a:rPr>
+                <a:t>GitHub</a:t>
+              </a:r>
+              <a:endParaRPr lang="ko-KR" altLang="en-US" sz="2400" dirty="0">
+                <a:latin typeface="나눔스퀘어 Bold" panose="020B0600000101010101" pitchFamily="50" charset="-127"/>
+                <a:ea typeface="나눔스퀘어 Bold" panose="020B0600000101010101" pitchFamily="50" charset="-127"/>
+              </a:endParaRPr>
+            </a:p>
+          </p:txBody>
+        </p:sp>
+        <p:sp>
+          <p:nvSpPr>
+            <p:cNvPr id="13" name="직사각형 12"/>
+            <p:cNvSpPr/>
+            <p:nvPr/>
+          </p:nvSpPr>
+          <p:spPr>
+            <a:xfrm>
+              <a:off x="7163999" y="0"/>
+              <a:ext cx="2520000" cy="1080000"/>
+            </a:xfrm>
+            <a:prstGeom prst="rect">
+              <a:avLst/>
+            </a:prstGeom>
             <a:solidFill>
-              <a:schemeClr val="tx1"/>
+              <a:schemeClr val="accent5"/>
             </a:solidFill>
-          </a:ln>
-        </p:spPr>
-        <p:style>
-          <a:lnRef idx="2">
-            <a:schemeClr val="accent1">
-              <a:shade val="50000"/>
-            </a:schemeClr>
-          </a:lnRef>
-          <a:fillRef idx="1">
-            <a:schemeClr val="accent1"/>
-          </a:fillRef>
-          <a:effectRef idx="0">
-            <a:schemeClr val="accent1"/>
-          </a:effectRef>
-          <a:fontRef idx="minor">
-            <a:schemeClr val="lt1"/>
-          </a:fontRef>
-        </p:style>
-        <p:txBody>
-          <a:bodyPr rtlCol="0" anchor="ctr"/>
-          <a:lstStyle/>
-          <a:p>
-            <a:pPr algn="ctr"/>
-            <a:r>
-              <a:rPr lang="en-US" altLang="ko-KR" sz="2000" dirty="0" smtClean="0">
-                <a:latin typeface="나눔스퀘어 Bold" panose="020B0600000101010101" pitchFamily="50" charset="-127"/>
-                <a:ea typeface="나눔스퀘어 Bold" panose="020B0600000101010101" pitchFamily="50" charset="-127"/>
-              </a:rPr>
-              <a:t>Dev(Stage) Server</a:t>
-            </a:r>
-          </a:p>
-          <a:p>
-            <a:pPr algn="ctr"/>
-            <a:r>
-              <a:rPr lang="en-US" altLang="ko-KR" sz="2000" dirty="0" err="1" smtClean="0">
-                <a:latin typeface="나눔스퀘어 Bold" panose="020B0600000101010101" pitchFamily="50" charset="-127"/>
-                <a:ea typeface="나눔스퀘어 Bold" panose="020B0600000101010101" pitchFamily="50" charset="-127"/>
-              </a:rPr>
-              <a:t>Gradle</a:t>
-            </a:r>
-            <a:r>
-              <a:rPr lang="en-US" altLang="ko-KR" sz="2000" dirty="0" smtClean="0">
-                <a:latin typeface="나눔스퀘어 Bold" panose="020B0600000101010101" pitchFamily="50" charset="-127"/>
-                <a:ea typeface="나눔스퀘어 Bold" panose="020B0600000101010101" pitchFamily="50" charset="-127"/>
-              </a:rPr>
-              <a:t>, JDK, </a:t>
-            </a:r>
-            <a:r>
-              <a:rPr lang="en-US" altLang="ko-KR" sz="2000" dirty="0" err="1" smtClean="0">
-                <a:latin typeface="나눔스퀘어 Bold" panose="020B0600000101010101" pitchFamily="50" charset="-127"/>
-                <a:ea typeface="나눔스퀘어 Bold" panose="020B0600000101010101" pitchFamily="50" charset="-127"/>
-              </a:rPr>
-              <a:t>Git</a:t>
-            </a:r>
-            <a:r>
-              <a:rPr lang="en-US" altLang="ko-KR" sz="2000" dirty="0" smtClean="0">
-                <a:latin typeface="나눔스퀘어 Bold" panose="020B0600000101010101" pitchFamily="50" charset="-127"/>
-                <a:ea typeface="나눔스퀘어 Bold" panose="020B0600000101010101" pitchFamily="50" charset="-127"/>
-              </a:rPr>
-              <a:t>, Build</a:t>
-            </a:r>
-            <a:endParaRPr lang="ko-KR" altLang="en-US" sz="2000" dirty="0">
-              <a:latin typeface="나눔스퀘어 Bold" panose="020B0600000101010101" pitchFamily="50" charset="-127"/>
-              <a:ea typeface="나눔스퀘어 Bold" panose="020B0600000101010101" pitchFamily="50" charset="-127"/>
-            </a:endParaRPr>
-          </a:p>
-        </p:txBody>
-      </p:sp>
-      <p:sp>
-        <p:nvSpPr>
-          <p:cNvPr id="5" name="직사각형 4"/>
-          <p:cNvSpPr/>
-          <p:nvPr/>
-        </p:nvSpPr>
-        <p:spPr>
-          <a:xfrm>
-            <a:off x="9492000" y="4434214"/>
-            <a:ext cx="2520000" cy="1080000"/>
-          </a:xfrm>
-          <a:prstGeom prst="rect">
-            <a:avLst/>
-          </a:prstGeom>
-          <a:solidFill>
-            <a:schemeClr val="accent5"/>
-          </a:solidFill>
-          <a:ln>
+            <a:ln>
+              <a:solidFill>
+                <a:schemeClr val="tx1"/>
+              </a:solidFill>
+            </a:ln>
+          </p:spPr>
+          <p:style>
+            <a:lnRef idx="2">
+              <a:schemeClr val="accent1">
+                <a:shade val="50000"/>
+              </a:schemeClr>
+            </a:lnRef>
+            <a:fillRef idx="1">
+              <a:schemeClr val="accent1"/>
+            </a:fillRef>
+            <a:effectRef idx="0">
+              <a:schemeClr val="accent1"/>
+            </a:effectRef>
+            <a:fontRef idx="minor">
+              <a:schemeClr val="lt1"/>
+            </a:fontRef>
+          </p:style>
+          <p:txBody>
+            <a:bodyPr rtlCol="0" anchor="ctr"/>
+            <a:lstStyle/>
+            <a:p>
+              <a:pPr algn="ctr"/>
+              <a:r>
+                <a:rPr lang="en-US" altLang="ko-KR" sz="2400" dirty="0" err="1" smtClean="0">
+                  <a:latin typeface="나눔스퀘어 Bold" panose="020B0600000101010101" pitchFamily="50" charset="-127"/>
+                  <a:ea typeface="나눔스퀘어 Bold" panose="020B0600000101010101" pitchFamily="50" charset="-127"/>
+                </a:rPr>
+                <a:t>DockerHub</a:t>
+              </a:r>
+              <a:endParaRPr lang="ko-KR" altLang="en-US" sz="2400" dirty="0">
+                <a:latin typeface="나눔스퀘어 Bold" panose="020B0600000101010101" pitchFamily="50" charset="-127"/>
+                <a:ea typeface="나눔스퀘어 Bold" panose="020B0600000101010101" pitchFamily="50" charset="-127"/>
+              </a:endParaRPr>
+            </a:p>
+          </p:txBody>
+        </p:sp>
+        <p:sp>
+          <p:nvSpPr>
+            <p:cNvPr id="25" name="직사각형 24"/>
+            <p:cNvSpPr/>
+            <p:nvPr/>
+          </p:nvSpPr>
+          <p:spPr>
+            <a:xfrm>
+              <a:off x="180000" y="4434214"/>
+              <a:ext cx="2520000" cy="1080000"/>
+            </a:xfrm>
+            <a:prstGeom prst="rect">
+              <a:avLst/>
+            </a:prstGeom>
             <a:solidFill>
-              <a:schemeClr val="tx1"/>
+              <a:schemeClr val="accent5"/>
             </a:solidFill>
-          </a:ln>
-        </p:spPr>
-        <p:style>
-          <a:lnRef idx="2">
-            <a:schemeClr val="accent1">
-              <a:shade val="50000"/>
-            </a:schemeClr>
-          </a:lnRef>
-          <a:fillRef idx="1">
-            <a:schemeClr val="accent1"/>
-          </a:fillRef>
-          <a:effectRef idx="0">
-            <a:schemeClr val="accent1"/>
-          </a:effectRef>
-          <a:fontRef idx="minor">
-            <a:schemeClr val="lt1"/>
-          </a:fontRef>
-        </p:style>
-        <p:txBody>
-          <a:bodyPr rtlCol="0" anchor="ctr"/>
-          <a:lstStyle/>
-          <a:p>
-            <a:pPr algn="ctr"/>
-            <a:r>
-              <a:rPr lang="en-US" altLang="ko-KR" sz="2400" dirty="0" smtClean="0">
-                <a:latin typeface="나눔스퀘어 Bold" panose="020B0600000101010101" pitchFamily="50" charset="-127"/>
-                <a:ea typeface="나눔스퀘어 Bold" panose="020B0600000101010101" pitchFamily="50" charset="-127"/>
-              </a:rPr>
-              <a:t>Product MySQL</a:t>
-            </a:r>
-            <a:endParaRPr lang="ko-KR" altLang="en-US" sz="2400" dirty="0">
-              <a:latin typeface="나눔스퀘어 Bold" panose="020B0600000101010101" pitchFamily="50" charset="-127"/>
-              <a:ea typeface="나눔스퀘어 Bold" panose="020B0600000101010101" pitchFamily="50" charset="-127"/>
-            </a:endParaRPr>
-          </a:p>
-        </p:txBody>
-      </p:sp>
-      <p:sp>
-        <p:nvSpPr>
-          <p:cNvPr id="6" name="직사각형 5"/>
-          <p:cNvSpPr/>
-          <p:nvPr/>
-        </p:nvSpPr>
-        <p:spPr>
-          <a:xfrm>
-            <a:off x="9312000" y="2217107"/>
-            <a:ext cx="2880000" cy="1440000"/>
-          </a:xfrm>
-          <a:prstGeom prst="rect">
-            <a:avLst/>
-          </a:prstGeom>
-          <a:solidFill>
-            <a:schemeClr val="accent5"/>
-          </a:solidFill>
-          <a:ln>
+            <a:ln>
+              <a:solidFill>
+                <a:schemeClr val="tx1"/>
+              </a:solidFill>
+            </a:ln>
+          </p:spPr>
+          <p:style>
+            <a:lnRef idx="2">
+              <a:schemeClr val="accent1">
+                <a:shade val="50000"/>
+              </a:schemeClr>
+            </a:lnRef>
+            <a:fillRef idx="1">
+              <a:schemeClr val="accent1"/>
+            </a:fillRef>
+            <a:effectRef idx="0">
+              <a:schemeClr val="accent1"/>
+            </a:effectRef>
+            <a:fontRef idx="minor">
+              <a:schemeClr val="lt1"/>
+            </a:fontRef>
+          </p:style>
+          <p:txBody>
+            <a:bodyPr rtlCol="0" anchor="ctr"/>
+            <a:lstStyle/>
+            <a:p>
+              <a:pPr algn="ctr"/>
+              <a:r>
+                <a:rPr lang="ko-KR" altLang="en-US" sz="2400" dirty="0" smtClean="0">
+                  <a:latin typeface="나눔스퀘어 Bold" panose="020B0600000101010101" pitchFamily="50" charset="-127"/>
+                  <a:ea typeface="나눔스퀘어 Bold" panose="020B0600000101010101" pitchFamily="50" charset="-127"/>
+                </a:rPr>
+                <a:t>개발</a:t>
+              </a:r>
+              <a:r>
+                <a:rPr lang="en-US" altLang="ko-KR" sz="2400" dirty="0" smtClean="0">
+                  <a:latin typeface="나눔스퀘어 Bold" panose="020B0600000101010101" pitchFamily="50" charset="-127"/>
+                  <a:ea typeface="나눔스퀘어 Bold" panose="020B0600000101010101" pitchFamily="50" charset="-127"/>
+                </a:rPr>
+                <a:t> MySQL</a:t>
+              </a:r>
+              <a:endParaRPr lang="ko-KR" altLang="en-US" sz="2400" dirty="0">
+                <a:latin typeface="나눔스퀘어 Bold" panose="020B0600000101010101" pitchFamily="50" charset="-127"/>
+                <a:ea typeface="나눔스퀘어 Bold" panose="020B0600000101010101" pitchFamily="50" charset="-127"/>
+              </a:endParaRPr>
+            </a:p>
+          </p:txBody>
+        </p:sp>
+        <p:sp>
+          <p:nvSpPr>
+            <p:cNvPr id="27" name="직사각형 26"/>
+            <p:cNvSpPr/>
+            <p:nvPr/>
+          </p:nvSpPr>
+          <p:spPr>
+            <a:xfrm>
+              <a:off x="6804000" y="1378553"/>
+              <a:ext cx="2160000" cy="540000"/>
+            </a:xfrm>
+            <a:prstGeom prst="rect">
+              <a:avLst/>
+            </a:prstGeom>
             <a:solidFill>
-              <a:schemeClr val="tx1"/>
+              <a:schemeClr val="accent4"/>
             </a:solidFill>
-          </a:ln>
-        </p:spPr>
-        <p:style>
-          <a:lnRef idx="2">
-            <a:schemeClr val="accent1">
-              <a:shade val="50000"/>
-            </a:schemeClr>
-          </a:lnRef>
-          <a:fillRef idx="1">
-            <a:schemeClr val="accent1"/>
-          </a:fillRef>
-          <a:effectRef idx="0">
-            <a:schemeClr val="accent1"/>
-          </a:effectRef>
-          <a:fontRef idx="minor">
-            <a:schemeClr val="lt1"/>
-          </a:fontRef>
-        </p:style>
-        <p:txBody>
-          <a:bodyPr rtlCol="0" anchor="ctr"/>
-          <a:lstStyle/>
-          <a:p>
-            <a:pPr algn="ctr"/>
-            <a:r>
-              <a:rPr lang="en-US" altLang="ko-KR" sz="2000" dirty="0" smtClean="0">
-                <a:latin typeface="나눔스퀘어 Bold" panose="020B0600000101010101" pitchFamily="50" charset="-127"/>
-                <a:ea typeface="나눔스퀘어 Bold" panose="020B0600000101010101" pitchFamily="50" charset="-127"/>
-              </a:rPr>
-              <a:t>Product Server</a:t>
-            </a:r>
-          </a:p>
-          <a:p>
-            <a:pPr algn="ctr"/>
-            <a:r>
-              <a:rPr lang="en-US" altLang="ko-KR" sz="2000" dirty="0" err="1" smtClean="0">
-                <a:latin typeface="나눔스퀘어 Bold" panose="020B0600000101010101" pitchFamily="50" charset="-127"/>
-                <a:ea typeface="나눔스퀘어 Bold" panose="020B0600000101010101" pitchFamily="50" charset="-127"/>
-              </a:rPr>
-              <a:t>Gradle</a:t>
-            </a:r>
-            <a:r>
-              <a:rPr lang="en-US" altLang="ko-KR" sz="2000" dirty="0" smtClean="0">
-                <a:latin typeface="나눔스퀘어 Bold" panose="020B0600000101010101" pitchFamily="50" charset="-127"/>
-                <a:ea typeface="나눔스퀘어 Bold" panose="020B0600000101010101" pitchFamily="50" charset="-127"/>
-              </a:rPr>
-              <a:t>, JDK, </a:t>
-            </a:r>
-            <a:r>
-              <a:rPr lang="en-US" altLang="ko-KR" sz="2000" dirty="0" err="1" smtClean="0">
-                <a:latin typeface="나눔스퀘어 Bold" panose="020B0600000101010101" pitchFamily="50" charset="-127"/>
-                <a:ea typeface="나눔스퀘어 Bold" panose="020B0600000101010101" pitchFamily="50" charset="-127"/>
-              </a:rPr>
-              <a:t>Git</a:t>
-            </a:r>
-            <a:r>
-              <a:rPr lang="en-US" altLang="ko-KR" sz="2000" dirty="0" smtClean="0">
-                <a:latin typeface="나눔스퀘어 Bold" panose="020B0600000101010101" pitchFamily="50" charset="-127"/>
-                <a:ea typeface="나눔스퀘어 Bold" panose="020B0600000101010101" pitchFamily="50" charset="-127"/>
-              </a:rPr>
-              <a:t>, Build</a:t>
-            </a:r>
-            <a:endParaRPr lang="ko-KR" altLang="en-US" sz="2000" dirty="0" smtClean="0">
-              <a:latin typeface="나눔스퀘어 Bold" panose="020B0600000101010101" pitchFamily="50" charset="-127"/>
-              <a:ea typeface="나눔스퀘어 Bold" panose="020B0600000101010101" pitchFamily="50" charset="-127"/>
-            </a:endParaRPr>
-          </a:p>
-        </p:txBody>
-      </p:sp>
-      <p:sp>
-        <p:nvSpPr>
-          <p:cNvPr id="11" name="직사각형 10"/>
-          <p:cNvSpPr/>
-          <p:nvPr/>
-        </p:nvSpPr>
-        <p:spPr>
-          <a:xfrm>
-            <a:off x="4760972" y="4434214"/>
-            <a:ext cx="2520000" cy="1080000"/>
-          </a:xfrm>
-          <a:prstGeom prst="rect">
-            <a:avLst/>
-          </a:prstGeom>
-          <a:solidFill>
-            <a:schemeClr val="accent5"/>
-          </a:solidFill>
-          <a:ln>
-            <a:solidFill>
-              <a:schemeClr val="tx1"/>
-            </a:solidFill>
-          </a:ln>
-        </p:spPr>
-        <p:style>
-          <a:lnRef idx="2">
-            <a:schemeClr val="accent1">
-              <a:shade val="50000"/>
-            </a:schemeClr>
-          </a:lnRef>
-          <a:fillRef idx="1">
-            <a:schemeClr val="accent1"/>
-          </a:fillRef>
-          <a:effectRef idx="0">
-            <a:schemeClr val="accent1"/>
-          </a:effectRef>
-          <a:fontRef idx="minor">
-            <a:schemeClr val="lt1"/>
-          </a:fontRef>
-        </p:style>
-        <p:txBody>
-          <a:bodyPr rtlCol="0" anchor="ctr"/>
-          <a:lstStyle/>
-          <a:p>
-            <a:pPr algn="ctr"/>
-            <a:r>
-              <a:rPr lang="en-US" altLang="ko-KR" sz="2400" dirty="0" smtClean="0">
-                <a:latin typeface="나눔스퀘어 Bold" panose="020B0600000101010101" pitchFamily="50" charset="-127"/>
-                <a:ea typeface="나눔스퀘어 Bold" panose="020B0600000101010101" pitchFamily="50" charset="-127"/>
-              </a:rPr>
-              <a:t>Dev MySQL</a:t>
-            </a:r>
-            <a:endParaRPr lang="ko-KR" altLang="en-US" sz="2400" dirty="0">
-              <a:latin typeface="나눔스퀘어 Bold" panose="020B0600000101010101" pitchFamily="50" charset="-127"/>
-              <a:ea typeface="나눔스퀘어 Bold" panose="020B0600000101010101" pitchFamily="50" charset="-127"/>
-            </a:endParaRPr>
-          </a:p>
-        </p:txBody>
-      </p:sp>
-      <p:cxnSp>
-        <p:nvCxnSpPr>
-          <p:cNvPr id="23" name="꺾인 연결선 22"/>
-          <p:cNvCxnSpPr>
-            <a:stCxn id="4" idx="3"/>
-            <a:endCxn id="13" idx="1"/>
-          </p:cNvCxnSpPr>
-          <p:nvPr/>
-        </p:nvCxnSpPr>
-        <p:spPr>
-          <a:xfrm flipH="1" flipV="1">
-            <a:off x="7163999" y="540000"/>
-            <a:ext cx="372001" cy="2397107"/>
-          </a:xfrm>
-          <a:prstGeom prst="bentConnector5">
-            <a:avLst>
-              <a:gd name="adj1" fmla="val -142264"/>
-              <a:gd name="adj2" fmla="val 53755"/>
-              <a:gd name="adj3" fmla="val 238896"/>
-            </a:avLst>
-          </a:prstGeom>
-          <a:ln w="76200">
-            <a:solidFill>
-              <a:schemeClr val="accent2"/>
-            </a:solidFill>
-            <a:tailEnd type="triangle"/>
-          </a:ln>
-        </p:spPr>
-        <p:style>
-          <a:lnRef idx="1">
-            <a:schemeClr val="accent1"/>
-          </a:lnRef>
-          <a:fillRef idx="0">
-            <a:schemeClr val="accent1"/>
-          </a:fillRef>
-          <a:effectRef idx="0">
-            <a:schemeClr val="accent1"/>
-          </a:effectRef>
-          <a:fontRef idx="minor">
-            <a:schemeClr val="tx1"/>
-          </a:fontRef>
-        </p:style>
-      </p:cxnSp>
-      <p:sp>
-        <p:nvSpPr>
-          <p:cNvPr id="3" name="직사각형 2"/>
-          <p:cNvSpPr/>
-          <p:nvPr/>
-        </p:nvSpPr>
-        <p:spPr>
-          <a:xfrm>
-            <a:off x="2507999" y="0"/>
-            <a:ext cx="2520000" cy="1080000"/>
-          </a:xfrm>
-          <a:prstGeom prst="rect">
-            <a:avLst/>
-          </a:prstGeom>
-          <a:solidFill>
-            <a:schemeClr val="accent5"/>
-          </a:solidFill>
-          <a:ln>
-            <a:solidFill>
-              <a:schemeClr val="tx1"/>
-            </a:solidFill>
-          </a:ln>
-        </p:spPr>
-        <p:style>
-          <a:lnRef idx="2">
-            <a:schemeClr val="accent1">
-              <a:shade val="50000"/>
-            </a:schemeClr>
-          </a:lnRef>
-          <a:fillRef idx="1">
-            <a:schemeClr val="accent1"/>
-          </a:fillRef>
-          <a:effectRef idx="0">
-            <a:schemeClr val="accent1"/>
-          </a:effectRef>
-          <a:fontRef idx="minor">
-            <a:schemeClr val="lt1"/>
-          </a:fontRef>
-        </p:style>
-        <p:txBody>
-          <a:bodyPr rtlCol="0" anchor="ctr"/>
-          <a:lstStyle/>
-          <a:p>
-            <a:pPr algn="ctr"/>
-            <a:r>
-              <a:rPr lang="en-US" altLang="ko-KR" sz="2400" dirty="0" smtClean="0">
-                <a:latin typeface="나눔스퀘어 Bold" panose="020B0600000101010101" pitchFamily="50" charset="-127"/>
-                <a:ea typeface="나눔스퀘어 Bold" panose="020B0600000101010101" pitchFamily="50" charset="-127"/>
-              </a:rPr>
-              <a:t>GitHub</a:t>
-            </a:r>
-            <a:endParaRPr lang="ko-KR" altLang="en-US" sz="2400" dirty="0">
-              <a:latin typeface="나눔스퀘어 Bold" panose="020B0600000101010101" pitchFamily="50" charset="-127"/>
-              <a:ea typeface="나눔스퀘어 Bold" panose="020B0600000101010101" pitchFamily="50" charset="-127"/>
-            </a:endParaRPr>
-          </a:p>
-        </p:txBody>
-      </p:sp>
-      <p:sp>
-        <p:nvSpPr>
-          <p:cNvPr id="13" name="직사각형 12"/>
-          <p:cNvSpPr/>
-          <p:nvPr/>
-        </p:nvSpPr>
-        <p:spPr>
-          <a:xfrm>
-            <a:off x="7163999" y="0"/>
-            <a:ext cx="2520000" cy="1080000"/>
-          </a:xfrm>
-          <a:prstGeom prst="rect">
-            <a:avLst/>
-          </a:prstGeom>
-          <a:solidFill>
-            <a:schemeClr val="accent5"/>
-          </a:solidFill>
-          <a:ln>
-            <a:solidFill>
-              <a:schemeClr val="tx1"/>
-            </a:solidFill>
-          </a:ln>
-        </p:spPr>
-        <p:style>
-          <a:lnRef idx="2">
-            <a:schemeClr val="accent1">
-              <a:shade val="50000"/>
-            </a:schemeClr>
-          </a:lnRef>
-          <a:fillRef idx="1">
-            <a:schemeClr val="accent1"/>
-          </a:fillRef>
-          <a:effectRef idx="0">
-            <a:schemeClr val="accent1"/>
-          </a:effectRef>
-          <a:fontRef idx="minor">
-            <a:schemeClr val="lt1"/>
-          </a:fontRef>
-        </p:style>
-        <p:txBody>
-          <a:bodyPr rtlCol="0" anchor="ctr"/>
-          <a:lstStyle/>
-          <a:p>
-            <a:pPr algn="ctr"/>
-            <a:r>
-              <a:rPr lang="en-US" altLang="ko-KR" sz="2400" dirty="0" err="1" smtClean="0">
-                <a:latin typeface="나눔스퀘어 Bold" panose="020B0600000101010101" pitchFamily="50" charset="-127"/>
-                <a:ea typeface="나눔스퀘어 Bold" panose="020B0600000101010101" pitchFamily="50" charset="-127"/>
-              </a:rPr>
-              <a:t>DockerHub</a:t>
-            </a:r>
-            <a:endParaRPr lang="ko-KR" altLang="en-US" sz="2400" dirty="0">
-              <a:latin typeface="나눔스퀘어 Bold" panose="020B0600000101010101" pitchFamily="50" charset="-127"/>
-              <a:ea typeface="나눔스퀘어 Bold" panose="020B0600000101010101" pitchFamily="50" charset="-127"/>
-            </a:endParaRPr>
-          </a:p>
-        </p:txBody>
-      </p:sp>
-      <p:sp>
-        <p:nvSpPr>
-          <p:cNvPr id="25" name="직사각형 24"/>
-          <p:cNvSpPr/>
-          <p:nvPr/>
-        </p:nvSpPr>
-        <p:spPr>
-          <a:xfrm>
-            <a:off x="180000" y="4434214"/>
-            <a:ext cx="2520000" cy="1080000"/>
-          </a:xfrm>
-          <a:prstGeom prst="rect">
-            <a:avLst/>
-          </a:prstGeom>
-          <a:solidFill>
-            <a:schemeClr val="accent5"/>
-          </a:solidFill>
-          <a:ln>
-            <a:solidFill>
-              <a:schemeClr val="tx1"/>
-            </a:solidFill>
-          </a:ln>
-        </p:spPr>
-        <p:style>
-          <a:lnRef idx="2">
-            <a:schemeClr val="accent1">
-              <a:shade val="50000"/>
-            </a:schemeClr>
-          </a:lnRef>
-          <a:fillRef idx="1">
-            <a:schemeClr val="accent1"/>
-          </a:fillRef>
-          <a:effectRef idx="0">
-            <a:schemeClr val="accent1"/>
-          </a:effectRef>
-          <a:fontRef idx="minor">
-            <a:schemeClr val="lt1"/>
-          </a:fontRef>
-        </p:style>
-        <p:txBody>
-          <a:bodyPr rtlCol="0" anchor="ctr"/>
-          <a:lstStyle/>
-          <a:p>
-            <a:pPr algn="ctr"/>
-            <a:r>
-              <a:rPr lang="ko-KR" altLang="en-US" sz="2400" dirty="0" smtClean="0">
-                <a:latin typeface="나눔스퀘어 Bold" panose="020B0600000101010101" pitchFamily="50" charset="-127"/>
-                <a:ea typeface="나눔스퀘어 Bold" panose="020B0600000101010101" pitchFamily="50" charset="-127"/>
-              </a:rPr>
-              <a:t>개발</a:t>
-            </a:r>
-            <a:r>
-              <a:rPr lang="en-US" altLang="ko-KR" sz="2400" dirty="0" smtClean="0">
-                <a:latin typeface="나눔스퀘어 Bold" panose="020B0600000101010101" pitchFamily="50" charset="-127"/>
-                <a:ea typeface="나눔스퀘어 Bold" panose="020B0600000101010101" pitchFamily="50" charset="-127"/>
-              </a:rPr>
-              <a:t> MySQL</a:t>
-            </a:r>
-            <a:endParaRPr lang="ko-KR" altLang="en-US" sz="2400" dirty="0">
-              <a:latin typeface="나눔스퀘어 Bold" panose="020B0600000101010101" pitchFamily="50" charset="-127"/>
-              <a:ea typeface="나눔스퀘어 Bold" panose="020B0600000101010101" pitchFamily="50" charset="-127"/>
-            </a:endParaRPr>
-          </a:p>
-        </p:txBody>
-      </p:sp>
-      <p:sp>
-        <p:nvSpPr>
-          <p:cNvPr id="27" name="직사각형 26"/>
-          <p:cNvSpPr/>
-          <p:nvPr/>
-        </p:nvSpPr>
-        <p:spPr>
-          <a:xfrm>
-            <a:off x="6804000" y="1378553"/>
-            <a:ext cx="2160000" cy="540000"/>
-          </a:xfrm>
-          <a:prstGeom prst="rect">
-            <a:avLst/>
-          </a:prstGeom>
-          <a:solidFill>
-            <a:schemeClr val="accent4"/>
-          </a:solidFill>
-          <a:ln>
-            <a:solidFill>
-              <a:schemeClr val="tx1"/>
-            </a:solidFill>
-          </a:ln>
-        </p:spPr>
-        <p:style>
-          <a:lnRef idx="2">
-            <a:schemeClr val="accent1">
-              <a:shade val="50000"/>
-            </a:schemeClr>
-          </a:lnRef>
-          <a:fillRef idx="1">
-            <a:schemeClr val="accent1"/>
-          </a:fillRef>
-          <a:effectRef idx="0">
-            <a:schemeClr val="accent1"/>
-          </a:effectRef>
-          <a:fontRef idx="minor">
-            <a:schemeClr val="lt1"/>
-          </a:fontRef>
-        </p:style>
-        <p:txBody>
-          <a:bodyPr rtlCol="0" anchor="ctr"/>
-          <a:lstStyle/>
-          <a:p>
-            <a:pPr algn="ctr"/>
-            <a:r>
-              <a:rPr lang="en-US" altLang="ko-KR" dirty="0" smtClean="0">
+            <a:ln>
+              <a:solidFill>
+                <a:schemeClr val="tx1"/>
+              </a:solidFill>
+            </a:ln>
+          </p:spPr>
+          <p:style>
+            <a:lnRef idx="2">
+              <a:schemeClr val="accent1">
+                <a:shade val="50000"/>
+              </a:schemeClr>
+            </a:lnRef>
+            <a:fillRef idx="1">
+              <a:schemeClr val="accent1"/>
+            </a:fillRef>
+            <a:effectRef idx="0">
+              <a:schemeClr val="accent1"/>
+            </a:effectRef>
+            <a:fontRef idx="minor">
+              <a:schemeClr val="lt1"/>
+            </a:fontRef>
+          </p:style>
+          <p:txBody>
+            <a:bodyPr rtlCol="0" anchor="ctr"/>
+            <a:lstStyle/>
+            <a:p>
+              <a:pPr algn="ctr"/>
+              <a:r>
+                <a:rPr lang="en-US" altLang="ko-KR" dirty="0" smtClean="0">
+                  <a:solidFill>
+                    <a:schemeClr val="tx1"/>
+                  </a:solidFill>
+                  <a:latin typeface="나눔스퀘어 Bold" panose="020B0600000101010101" pitchFamily="50" charset="-127"/>
+                  <a:ea typeface="나눔스퀘어 Bold" panose="020B0600000101010101" pitchFamily="50" charset="-127"/>
+                </a:rPr>
+                <a:t>Docker Image(Jar)</a:t>
+              </a:r>
+              <a:endParaRPr lang="ko-KR" altLang="en-US" dirty="0">
                 <a:solidFill>
                   <a:schemeClr val="tx1"/>
                 </a:solidFill>
                 <a:latin typeface="나눔스퀘어 Bold" panose="020B0600000101010101" pitchFamily="50" charset="-127"/>
                 <a:ea typeface="나눔스퀘어 Bold" panose="020B0600000101010101" pitchFamily="50" charset="-127"/>
-              </a:rPr>
-              <a:t>Docker Image(Jar)</a:t>
-            </a:r>
-            <a:endParaRPr lang="ko-KR" altLang="en-US" dirty="0">
+              </a:endParaRPr>
+            </a:p>
+          </p:txBody>
+        </p:sp>
+        <p:cxnSp>
+          <p:nvCxnSpPr>
+            <p:cNvPr id="32" name="꺾인 연결선 31"/>
+            <p:cNvCxnSpPr>
+              <a:stCxn id="13" idx="3"/>
+              <a:endCxn id="6" idx="0"/>
+            </p:cNvCxnSpPr>
+            <p:nvPr/>
+          </p:nvCxnSpPr>
+          <p:spPr>
+            <a:xfrm>
+              <a:off x="9683999" y="540000"/>
+              <a:ext cx="1068001" cy="1677107"/>
+            </a:xfrm>
+            <a:prstGeom prst="bentConnector2">
+              <a:avLst/>
+            </a:prstGeom>
+            <a:ln w="76200">
+              <a:solidFill>
+                <a:schemeClr val="accent2"/>
+              </a:solidFill>
+              <a:tailEnd type="triangle"/>
+            </a:ln>
+          </p:spPr>
+          <p:style>
+            <a:lnRef idx="1">
+              <a:schemeClr val="accent1"/>
+            </a:lnRef>
+            <a:fillRef idx="0">
+              <a:schemeClr val="accent1"/>
+            </a:fillRef>
+            <a:effectRef idx="0">
+              <a:schemeClr val="accent1"/>
+            </a:effectRef>
+            <a:fontRef idx="minor">
+              <a:schemeClr val="tx1"/>
+            </a:fontRef>
+          </p:style>
+        </p:cxnSp>
+        <p:cxnSp>
+          <p:nvCxnSpPr>
+            <p:cNvPr id="35" name="꺾인 연결선 34"/>
+            <p:cNvCxnSpPr>
+              <a:stCxn id="2" idx="0"/>
+              <a:endCxn id="3" idx="1"/>
+            </p:cNvCxnSpPr>
+            <p:nvPr/>
+          </p:nvCxnSpPr>
+          <p:spPr>
+            <a:xfrm rot="5400000" flipH="1" flipV="1">
+              <a:off x="1135446" y="844555"/>
+              <a:ext cx="1677107" cy="1067999"/>
+            </a:xfrm>
+            <a:prstGeom prst="bentConnector2">
+              <a:avLst/>
+            </a:prstGeom>
+            <a:ln w="76200">
+              <a:solidFill>
+                <a:schemeClr val="accent2"/>
+              </a:solidFill>
+              <a:tailEnd type="triangle"/>
+            </a:ln>
+          </p:spPr>
+          <p:style>
+            <a:lnRef idx="1">
+              <a:schemeClr val="accent1"/>
+            </a:lnRef>
+            <a:fillRef idx="0">
+              <a:schemeClr val="accent1"/>
+            </a:fillRef>
+            <a:effectRef idx="0">
+              <a:schemeClr val="accent1"/>
+            </a:effectRef>
+            <a:fontRef idx="minor">
+              <a:schemeClr val="tx1"/>
+            </a:fontRef>
+          </p:style>
+        </p:cxnSp>
+        <p:cxnSp>
+          <p:nvCxnSpPr>
+            <p:cNvPr id="38" name="꺾인 연결선 37"/>
+            <p:cNvCxnSpPr>
+              <a:stCxn id="3" idx="3"/>
+              <a:endCxn id="4" idx="0"/>
+            </p:cNvCxnSpPr>
+            <p:nvPr/>
+          </p:nvCxnSpPr>
+          <p:spPr>
+            <a:xfrm>
+              <a:off x="5027999" y="540000"/>
+              <a:ext cx="1068001" cy="1677107"/>
+            </a:xfrm>
+            <a:prstGeom prst="bentConnector2">
+              <a:avLst/>
+            </a:prstGeom>
+            <a:ln w="76200">
+              <a:solidFill>
+                <a:schemeClr val="accent2"/>
+              </a:solidFill>
+              <a:tailEnd type="triangle"/>
+            </a:ln>
+          </p:spPr>
+          <p:style>
+            <a:lnRef idx="1">
+              <a:schemeClr val="accent1"/>
+            </a:lnRef>
+            <a:fillRef idx="0">
+              <a:schemeClr val="accent1"/>
+            </a:fillRef>
+            <a:effectRef idx="0">
+              <a:schemeClr val="accent1"/>
+            </a:effectRef>
+            <a:fontRef idx="minor">
+              <a:schemeClr val="tx1"/>
+            </a:fontRef>
+          </p:style>
+        </p:cxnSp>
+        <p:sp>
+          <p:nvSpPr>
+            <p:cNvPr id="46" name="직사각형 45"/>
+            <p:cNvSpPr/>
+            <p:nvPr/>
+          </p:nvSpPr>
+          <p:spPr>
+            <a:xfrm>
+              <a:off x="4365714" y="1832065"/>
+              <a:ext cx="1440000" cy="720000"/>
+            </a:xfrm>
+            <a:prstGeom prst="rect">
+              <a:avLst/>
+            </a:prstGeom>
+            <a:solidFill>
+              <a:schemeClr val="accent5"/>
+            </a:solidFill>
+            <a:ln>
               <a:solidFill>
                 <a:schemeClr val="tx1"/>
               </a:solidFill>
-              <a:latin typeface="나눔스퀘어 Bold" panose="020B0600000101010101" pitchFamily="50" charset="-127"/>
-              <a:ea typeface="나눔스퀘어 Bold" panose="020B0600000101010101" pitchFamily="50" charset="-127"/>
-            </a:endParaRPr>
-          </a:p>
-        </p:txBody>
-      </p:sp>
-      <p:cxnSp>
-        <p:nvCxnSpPr>
-          <p:cNvPr id="32" name="꺾인 연결선 31"/>
-          <p:cNvCxnSpPr>
-            <a:stCxn id="13" idx="3"/>
-            <a:endCxn id="6" idx="0"/>
-          </p:cNvCxnSpPr>
-          <p:nvPr/>
-        </p:nvCxnSpPr>
-        <p:spPr>
-          <a:xfrm>
-            <a:off x="9683999" y="540000"/>
-            <a:ext cx="1068001" cy="1677107"/>
-          </a:xfrm>
-          <a:prstGeom prst="bentConnector2">
-            <a:avLst/>
-          </a:prstGeom>
-          <a:ln w="76200">
+            </a:ln>
+          </p:spPr>
+          <p:style>
+            <a:lnRef idx="2">
+              <a:schemeClr val="accent1">
+                <a:shade val="50000"/>
+              </a:schemeClr>
+            </a:lnRef>
+            <a:fillRef idx="1">
+              <a:schemeClr val="accent1"/>
+            </a:fillRef>
+            <a:effectRef idx="0">
+              <a:schemeClr val="accent1"/>
+            </a:effectRef>
+            <a:fontRef idx="minor">
+              <a:schemeClr val="lt1"/>
+            </a:fontRef>
+          </p:style>
+          <p:txBody>
+            <a:bodyPr rtlCol="0" anchor="ctr"/>
+            <a:lstStyle/>
+            <a:p>
+              <a:pPr algn="ctr"/>
+              <a:r>
+                <a:rPr lang="en-US" altLang="ko-KR" sz="2400" dirty="0" err="1" smtClean="0">
+                  <a:latin typeface="나눔스퀘어 Bold" panose="020B0600000101010101" pitchFamily="50" charset="-127"/>
+                  <a:ea typeface="나눔스퀘어 Bold" panose="020B0600000101010101" pitchFamily="50" charset="-127"/>
+                </a:rPr>
+                <a:t>Ngnix</a:t>
+              </a:r>
+              <a:endParaRPr lang="ko-KR" altLang="en-US" sz="2400" dirty="0">
+                <a:latin typeface="나눔스퀘어 Bold" panose="020B0600000101010101" pitchFamily="50" charset="-127"/>
+                <a:ea typeface="나눔스퀘어 Bold" panose="020B0600000101010101" pitchFamily="50" charset="-127"/>
+              </a:endParaRPr>
+            </a:p>
+          </p:txBody>
+        </p:sp>
+        <p:sp>
+          <p:nvSpPr>
+            <p:cNvPr id="47" name="직사각형 46"/>
+            <p:cNvSpPr/>
+            <p:nvPr/>
+          </p:nvSpPr>
+          <p:spPr>
+            <a:xfrm>
+              <a:off x="11003142" y="1831043"/>
+              <a:ext cx="1440000" cy="720000"/>
+            </a:xfrm>
+            <a:prstGeom prst="rect">
+              <a:avLst/>
+            </a:prstGeom>
             <a:solidFill>
-              <a:schemeClr val="accent2"/>
+              <a:schemeClr val="accent5"/>
             </a:solidFill>
-            <a:tailEnd type="triangle"/>
-          </a:ln>
-        </p:spPr>
-        <p:style>
-          <a:lnRef idx="1">
-            <a:schemeClr val="accent1"/>
-          </a:lnRef>
-          <a:fillRef idx="0">
-            <a:schemeClr val="accent1"/>
-          </a:fillRef>
-          <a:effectRef idx="0">
-            <a:schemeClr val="accent1"/>
-          </a:effectRef>
-          <a:fontRef idx="minor">
-            <a:schemeClr val="tx1"/>
-          </a:fontRef>
-        </p:style>
-      </p:cxnSp>
-      <p:cxnSp>
-        <p:nvCxnSpPr>
-          <p:cNvPr id="35" name="꺾인 연결선 34"/>
-          <p:cNvCxnSpPr>
-            <a:stCxn id="2" idx="0"/>
-            <a:endCxn id="3" idx="1"/>
-          </p:cNvCxnSpPr>
-          <p:nvPr/>
-        </p:nvCxnSpPr>
-        <p:spPr>
-          <a:xfrm rot="5400000" flipH="1" flipV="1">
-            <a:off x="1135446" y="844555"/>
-            <a:ext cx="1677107" cy="1067999"/>
-          </a:xfrm>
-          <a:prstGeom prst="bentConnector2">
-            <a:avLst/>
-          </a:prstGeom>
-          <a:ln w="76200">
+            <a:ln>
+              <a:solidFill>
+                <a:schemeClr val="tx1"/>
+              </a:solidFill>
+            </a:ln>
+          </p:spPr>
+          <p:style>
+            <a:lnRef idx="2">
+              <a:schemeClr val="accent1">
+                <a:shade val="50000"/>
+              </a:schemeClr>
+            </a:lnRef>
+            <a:fillRef idx="1">
+              <a:schemeClr val="accent1"/>
+            </a:fillRef>
+            <a:effectRef idx="0">
+              <a:schemeClr val="accent1"/>
+            </a:effectRef>
+            <a:fontRef idx="minor">
+              <a:schemeClr val="lt1"/>
+            </a:fontRef>
+          </p:style>
+          <p:txBody>
+            <a:bodyPr rtlCol="0" anchor="ctr"/>
+            <a:lstStyle/>
+            <a:p>
+              <a:pPr algn="ctr"/>
+              <a:r>
+                <a:rPr lang="en-US" altLang="ko-KR" sz="2400" dirty="0" err="1" smtClean="0">
+                  <a:latin typeface="나눔스퀘어 Bold" panose="020B0600000101010101" pitchFamily="50" charset="-127"/>
+                  <a:ea typeface="나눔스퀘어 Bold" panose="020B0600000101010101" pitchFamily="50" charset="-127"/>
+                </a:rPr>
+                <a:t>Ngnix</a:t>
+              </a:r>
+              <a:endParaRPr lang="ko-KR" altLang="en-US" sz="2400" dirty="0">
+                <a:latin typeface="나눔스퀘어 Bold" panose="020B0600000101010101" pitchFamily="50" charset="-127"/>
+                <a:ea typeface="나눔스퀘어 Bold" panose="020B0600000101010101" pitchFamily="50" charset="-127"/>
+              </a:endParaRPr>
+            </a:p>
+          </p:txBody>
+        </p:sp>
+        <p:sp>
+          <p:nvSpPr>
+            <p:cNvPr id="48" name="직사각형 47"/>
+            <p:cNvSpPr/>
+            <p:nvPr/>
+          </p:nvSpPr>
+          <p:spPr>
+            <a:xfrm>
+              <a:off x="10055998" y="182490"/>
+              <a:ext cx="1440000" cy="720000"/>
+            </a:xfrm>
+            <a:prstGeom prst="rect">
+              <a:avLst/>
+            </a:prstGeom>
             <a:solidFill>
-              <a:schemeClr val="accent2"/>
+              <a:schemeClr val="accent5"/>
             </a:solidFill>
-            <a:tailEnd type="triangle"/>
-          </a:ln>
-        </p:spPr>
-        <p:style>
-          <a:lnRef idx="1">
-            <a:schemeClr val="accent1"/>
-          </a:lnRef>
-          <a:fillRef idx="0">
-            <a:schemeClr val="accent1"/>
-          </a:fillRef>
-          <a:effectRef idx="0">
-            <a:schemeClr val="accent1"/>
-          </a:effectRef>
-          <a:fontRef idx="minor">
-            <a:schemeClr val="tx1"/>
-          </a:fontRef>
-        </p:style>
-      </p:cxnSp>
-      <p:cxnSp>
-        <p:nvCxnSpPr>
-          <p:cNvPr id="38" name="꺾인 연결선 37"/>
-          <p:cNvCxnSpPr>
-            <a:stCxn id="3" idx="3"/>
-            <a:endCxn id="4" idx="0"/>
-          </p:cNvCxnSpPr>
-          <p:nvPr/>
-        </p:nvCxnSpPr>
-        <p:spPr>
-          <a:xfrm>
-            <a:off x="5027999" y="540000"/>
-            <a:ext cx="1068001" cy="1677107"/>
-          </a:xfrm>
-          <a:prstGeom prst="bentConnector2">
-            <a:avLst/>
-          </a:prstGeom>
-          <a:ln w="76200">
+            <a:ln>
+              <a:solidFill>
+                <a:schemeClr val="tx1"/>
+              </a:solidFill>
+            </a:ln>
+          </p:spPr>
+          <p:style>
+            <a:lnRef idx="2">
+              <a:schemeClr val="accent1">
+                <a:shade val="50000"/>
+              </a:schemeClr>
+            </a:lnRef>
+            <a:fillRef idx="1">
+              <a:schemeClr val="accent1"/>
+            </a:fillRef>
+            <a:effectRef idx="0">
+              <a:schemeClr val="accent1"/>
+            </a:effectRef>
+            <a:fontRef idx="minor">
+              <a:schemeClr val="lt1"/>
+            </a:fontRef>
+          </p:style>
+          <p:txBody>
+            <a:bodyPr rtlCol="0" anchor="ctr"/>
+            <a:lstStyle/>
+            <a:p>
+              <a:pPr algn="ctr"/>
+              <a:r>
+                <a:rPr lang="en-US" altLang="ko-KR" sz="2400" dirty="0" smtClean="0">
+                  <a:latin typeface="나눔스퀘어 Bold" panose="020B0600000101010101" pitchFamily="50" charset="-127"/>
+                  <a:ea typeface="나눔스퀘어 Bold" panose="020B0600000101010101" pitchFamily="50" charset="-127"/>
+                </a:rPr>
+                <a:t>DNS</a:t>
+              </a:r>
+              <a:endParaRPr lang="ko-KR" altLang="en-US" sz="2400" dirty="0">
+                <a:latin typeface="나눔스퀘어 Bold" panose="020B0600000101010101" pitchFamily="50" charset="-127"/>
+                <a:ea typeface="나눔스퀘어 Bold" panose="020B0600000101010101" pitchFamily="50" charset="-127"/>
+              </a:endParaRPr>
+            </a:p>
+          </p:txBody>
+        </p:sp>
+        <p:cxnSp>
+          <p:nvCxnSpPr>
+            <p:cNvPr id="8" name="직선 화살표 연결선 7"/>
+            <p:cNvCxnSpPr>
+              <a:stCxn id="25" idx="0"/>
+            </p:cNvCxnSpPr>
+            <p:nvPr/>
+          </p:nvCxnSpPr>
+          <p:spPr>
+            <a:xfrm flipV="1">
+              <a:off x="1440000" y="3940295"/>
+              <a:ext cx="0" cy="493919"/>
+            </a:xfrm>
+            <a:prstGeom prst="straightConnector1">
+              <a:avLst/>
+            </a:prstGeom>
+            <a:ln w="76200">
+              <a:solidFill>
+                <a:schemeClr val="accent2"/>
+              </a:solidFill>
+              <a:prstDash val="sysDot"/>
+              <a:tailEnd type="triangle"/>
+            </a:ln>
+          </p:spPr>
+          <p:style>
+            <a:lnRef idx="1">
+              <a:schemeClr val="accent1"/>
+            </a:lnRef>
+            <a:fillRef idx="0">
+              <a:schemeClr val="accent1"/>
+            </a:fillRef>
+            <a:effectRef idx="0">
+              <a:schemeClr val="accent1"/>
+            </a:effectRef>
+            <a:fontRef idx="minor">
+              <a:schemeClr val="tx1"/>
+            </a:fontRef>
+          </p:style>
+        </p:cxnSp>
+        <p:sp>
+          <p:nvSpPr>
+            <p:cNvPr id="29" name="직사각형 28"/>
+            <p:cNvSpPr/>
+            <p:nvPr/>
+          </p:nvSpPr>
+          <p:spPr>
+            <a:xfrm>
+              <a:off x="152400" y="2369507"/>
+              <a:ext cx="2880000" cy="1440000"/>
+            </a:xfrm>
+            <a:prstGeom prst="rect">
+              <a:avLst/>
+            </a:prstGeom>
             <a:solidFill>
-              <a:schemeClr val="accent2"/>
+              <a:schemeClr val="accent5"/>
             </a:solidFill>
-            <a:tailEnd type="triangle"/>
-          </a:ln>
-        </p:spPr>
-        <p:style>
-          <a:lnRef idx="1">
-            <a:schemeClr val="accent1"/>
-          </a:lnRef>
-          <a:fillRef idx="0">
-            <a:schemeClr val="accent1"/>
-          </a:fillRef>
-          <a:effectRef idx="0">
-            <a:schemeClr val="accent1"/>
-          </a:effectRef>
-          <a:fontRef idx="minor">
-            <a:schemeClr val="tx1"/>
-          </a:fontRef>
-        </p:style>
-      </p:cxnSp>
-      <p:sp>
-        <p:nvSpPr>
-          <p:cNvPr id="46" name="직사각형 45"/>
-          <p:cNvSpPr/>
-          <p:nvPr/>
-        </p:nvSpPr>
-        <p:spPr>
-          <a:xfrm>
-            <a:off x="4365714" y="1832065"/>
-            <a:ext cx="1440000" cy="720000"/>
-          </a:xfrm>
-          <a:prstGeom prst="rect">
-            <a:avLst/>
-          </a:prstGeom>
-          <a:solidFill>
-            <a:schemeClr val="accent5"/>
-          </a:solidFill>
-          <a:ln>
+            <a:ln>
+              <a:solidFill>
+                <a:schemeClr val="tx1"/>
+              </a:solidFill>
+            </a:ln>
+          </p:spPr>
+          <p:style>
+            <a:lnRef idx="2">
+              <a:schemeClr val="accent1">
+                <a:shade val="50000"/>
+              </a:schemeClr>
+            </a:lnRef>
+            <a:fillRef idx="1">
+              <a:schemeClr val="accent1"/>
+            </a:fillRef>
+            <a:effectRef idx="0">
+              <a:schemeClr val="accent1"/>
+            </a:effectRef>
+            <a:fontRef idx="minor">
+              <a:schemeClr val="lt1"/>
+            </a:fontRef>
+          </p:style>
+          <p:txBody>
+            <a:bodyPr rtlCol="0" anchor="ctr"/>
+            <a:lstStyle/>
+            <a:p>
+              <a:pPr algn="ctr"/>
+              <a:r>
+                <a:rPr lang="ko-KR" altLang="en-US" sz="2400" dirty="0" smtClean="0">
+                  <a:latin typeface="나눔스퀘어 Bold" panose="020B0600000101010101" pitchFamily="50" charset="-127"/>
+                  <a:ea typeface="나눔스퀘어 Bold" panose="020B0600000101010101" pitchFamily="50" charset="-127"/>
+                </a:rPr>
+                <a:t>개발</a:t>
+              </a:r>
+              <a:r>
+                <a:rPr lang="en-US" altLang="ko-KR" sz="2400" dirty="0" smtClean="0">
+                  <a:latin typeface="나눔스퀘어 Bold" panose="020B0600000101010101" pitchFamily="50" charset="-127"/>
+                  <a:ea typeface="나눔스퀘어 Bold" panose="020B0600000101010101" pitchFamily="50" charset="-127"/>
+                </a:rPr>
+                <a:t>PC(Local)</a:t>
+              </a:r>
+            </a:p>
+            <a:p>
+              <a:pPr algn="ctr"/>
+              <a:r>
+                <a:rPr lang="en-US" altLang="ko-KR" sz="2400" dirty="0" smtClean="0">
+                  <a:latin typeface="나눔스퀘어 Bold" panose="020B0600000101010101" pitchFamily="50" charset="-127"/>
+                  <a:ea typeface="나눔스퀘어 Bold" panose="020B0600000101010101" pitchFamily="50" charset="-127"/>
+                </a:rPr>
+                <a:t>JDK, </a:t>
+              </a:r>
+              <a:r>
+                <a:rPr lang="en-US" altLang="ko-KR" sz="2400" dirty="0" err="1" smtClean="0">
+                  <a:latin typeface="나눔스퀘어 Bold" panose="020B0600000101010101" pitchFamily="50" charset="-127"/>
+                  <a:ea typeface="나눔스퀘어 Bold" panose="020B0600000101010101" pitchFamily="50" charset="-127"/>
+                </a:rPr>
+                <a:t>Git</a:t>
+              </a:r>
+              <a:r>
+                <a:rPr lang="en-US" altLang="ko-KR" sz="2400" dirty="0" smtClean="0">
+                  <a:latin typeface="나눔스퀘어 Bold" panose="020B0600000101010101" pitchFamily="50" charset="-127"/>
+                  <a:ea typeface="나눔스퀘어 Bold" panose="020B0600000101010101" pitchFamily="50" charset="-127"/>
+                </a:rPr>
+                <a:t>, MySQL</a:t>
+              </a:r>
+              <a:endParaRPr lang="ko-KR" altLang="en-US" sz="2400" dirty="0">
+                <a:latin typeface="나눔스퀘어 Bold" panose="020B0600000101010101" pitchFamily="50" charset="-127"/>
+                <a:ea typeface="나눔스퀘어 Bold" panose="020B0600000101010101" pitchFamily="50" charset="-127"/>
+              </a:endParaRPr>
+            </a:p>
+          </p:txBody>
+        </p:sp>
+        <p:sp>
+          <p:nvSpPr>
+            <p:cNvPr id="30" name="직사각형 29"/>
+            <p:cNvSpPr/>
+            <p:nvPr/>
+          </p:nvSpPr>
+          <p:spPr>
+            <a:xfrm>
+              <a:off x="304800" y="2521907"/>
+              <a:ext cx="2880000" cy="1440000"/>
+            </a:xfrm>
+            <a:prstGeom prst="rect">
+              <a:avLst/>
+            </a:prstGeom>
             <a:solidFill>
+              <a:schemeClr val="accent5"/>
+            </a:solidFill>
+            <a:ln>
+              <a:solidFill>
+                <a:schemeClr val="tx1"/>
+              </a:solidFill>
+            </a:ln>
+          </p:spPr>
+          <p:style>
+            <a:lnRef idx="2">
+              <a:schemeClr val="accent1">
+                <a:shade val="50000"/>
+              </a:schemeClr>
+            </a:lnRef>
+            <a:fillRef idx="1">
+              <a:schemeClr val="accent1"/>
+            </a:fillRef>
+            <a:effectRef idx="0">
+              <a:schemeClr val="accent1"/>
+            </a:effectRef>
+            <a:fontRef idx="minor">
+              <a:schemeClr val="lt1"/>
+            </a:fontRef>
+          </p:style>
+          <p:txBody>
+            <a:bodyPr rtlCol="0" anchor="ctr"/>
+            <a:lstStyle/>
+            <a:p>
+              <a:pPr algn="ctr"/>
+              <a:r>
+                <a:rPr lang="ko-KR" altLang="en-US" sz="2400" dirty="0" smtClean="0">
+                  <a:latin typeface="나눔스퀘어 Bold" panose="020B0600000101010101" pitchFamily="50" charset="-127"/>
+                  <a:ea typeface="나눔스퀘어 Bold" panose="020B0600000101010101" pitchFamily="50" charset="-127"/>
+                </a:rPr>
+                <a:t>개발</a:t>
+              </a:r>
+              <a:r>
+                <a:rPr lang="en-US" altLang="ko-KR" sz="2400" dirty="0" smtClean="0">
+                  <a:latin typeface="나눔스퀘어 Bold" panose="020B0600000101010101" pitchFamily="50" charset="-127"/>
+                  <a:ea typeface="나눔스퀘어 Bold" panose="020B0600000101010101" pitchFamily="50" charset="-127"/>
+                </a:rPr>
+                <a:t>PC(Local)</a:t>
+              </a:r>
+            </a:p>
+            <a:p>
+              <a:pPr algn="ctr"/>
+              <a:r>
+                <a:rPr lang="en-US" altLang="ko-KR" sz="2400" dirty="0" smtClean="0">
+                  <a:latin typeface="나눔스퀘어 Bold" panose="020B0600000101010101" pitchFamily="50" charset="-127"/>
+                  <a:ea typeface="나눔스퀘어 Bold" panose="020B0600000101010101" pitchFamily="50" charset="-127"/>
+                </a:rPr>
+                <a:t>JDK, </a:t>
+              </a:r>
+              <a:r>
+                <a:rPr lang="en-US" altLang="ko-KR" sz="2400" dirty="0" err="1" smtClean="0">
+                  <a:latin typeface="나눔스퀘어 Bold" panose="020B0600000101010101" pitchFamily="50" charset="-127"/>
+                  <a:ea typeface="나눔스퀘어 Bold" panose="020B0600000101010101" pitchFamily="50" charset="-127"/>
+                </a:rPr>
+                <a:t>Git</a:t>
+              </a:r>
+              <a:r>
+                <a:rPr lang="en-US" altLang="ko-KR" sz="2400" dirty="0" smtClean="0">
+                  <a:latin typeface="나눔스퀘어 Bold" panose="020B0600000101010101" pitchFamily="50" charset="-127"/>
+                  <a:ea typeface="나눔스퀘어 Bold" panose="020B0600000101010101" pitchFamily="50" charset="-127"/>
+                </a:rPr>
+                <a:t>, MySQL</a:t>
+              </a:r>
+              <a:endParaRPr lang="ko-KR" altLang="en-US" sz="2400" dirty="0">
+                <a:latin typeface="나눔스퀘어 Bold" panose="020B0600000101010101" pitchFamily="50" charset="-127"/>
+                <a:ea typeface="나눔스퀘어 Bold" panose="020B0600000101010101" pitchFamily="50" charset="-127"/>
+              </a:endParaRPr>
+            </a:p>
+          </p:txBody>
+        </p:sp>
+        <p:cxnSp>
+          <p:nvCxnSpPr>
+            <p:cNvPr id="33" name="직선 화살표 연결선 32"/>
+            <p:cNvCxnSpPr>
+              <a:stCxn id="11" idx="0"/>
+              <a:endCxn id="26" idx="0"/>
+            </p:cNvCxnSpPr>
+            <p:nvPr/>
+          </p:nvCxnSpPr>
+          <p:spPr>
+            <a:xfrm flipV="1">
+              <a:off x="6020972" y="3676328"/>
+              <a:ext cx="1" cy="757886"/>
+            </a:xfrm>
+            <a:prstGeom prst="straightConnector1">
+              <a:avLst/>
+            </a:prstGeom>
+            <a:ln w="76200">
+              <a:solidFill>
+                <a:schemeClr val="accent2"/>
+              </a:solidFill>
+              <a:prstDash val="sysDot"/>
+              <a:tailEnd type="triangle"/>
+            </a:ln>
+          </p:spPr>
+          <p:style>
+            <a:lnRef idx="1">
+              <a:schemeClr val="accent1"/>
+            </a:lnRef>
+            <a:fillRef idx="0">
+              <a:schemeClr val="accent1"/>
+            </a:fillRef>
+            <a:effectRef idx="0">
+              <a:schemeClr val="accent1"/>
+            </a:effectRef>
+            <a:fontRef idx="minor">
               <a:schemeClr val="tx1"/>
+            </a:fontRef>
+          </p:style>
+        </p:cxnSp>
+        <p:sp>
+          <p:nvSpPr>
+            <p:cNvPr id="26" name="TextBox 25"/>
+            <p:cNvSpPr txBox="1"/>
+            <p:nvPr/>
+          </p:nvSpPr>
+          <p:spPr>
+            <a:xfrm>
+              <a:off x="5021340" y="3676328"/>
+              <a:ext cx="1999265" cy="369332"/>
+            </a:xfrm>
+            <a:prstGeom prst="rect">
+              <a:avLst/>
+            </a:prstGeom>
+            <a:noFill/>
+          </p:spPr>
+          <p:txBody>
+            <a:bodyPr wrap="none" rtlCol="0">
+              <a:spAutoFit/>
+            </a:bodyPr>
+            <a:lstStyle/>
+            <a:p>
+              <a:r>
+                <a:rPr lang="ko-KR" altLang="en-US" dirty="0" smtClean="0">
+                  <a:latin typeface="나눔스퀘어 Bold" panose="020B0600000101010101" pitchFamily="50" charset="-127"/>
+                  <a:ea typeface="나눔스퀘어 Bold" panose="020B0600000101010101" pitchFamily="50" charset="-127"/>
+                </a:rPr>
+                <a:t>개발팀 </a:t>
+              </a:r>
+              <a:r>
+                <a:rPr lang="en-US" altLang="ko-KR" dirty="0" smtClean="0">
+                  <a:latin typeface="나눔스퀘어 Bold" panose="020B0600000101010101" pitchFamily="50" charset="-127"/>
+                  <a:ea typeface="나눔스퀘어 Bold" panose="020B0600000101010101" pitchFamily="50" charset="-127"/>
+                </a:rPr>
+                <a:t>-&gt; QA(QM)</a:t>
+              </a:r>
+              <a:endParaRPr lang="ko-KR" altLang="en-US" dirty="0">
+                <a:latin typeface="나눔스퀘어 Bold" panose="020B0600000101010101" pitchFamily="50" charset="-127"/>
+                <a:ea typeface="나눔스퀘어 Bold" panose="020B0600000101010101" pitchFamily="50" charset="-127"/>
+              </a:endParaRPr>
+            </a:p>
+          </p:txBody>
+        </p:sp>
+        <p:cxnSp>
+          <p:nvCxnSpPr>
+            <p:cNvPr id="36" name="직선 화살표 연결선 35"/>
+            <p:cNvCxnSpPr>
+              <a:stCxn id="5" idx="0"/>
+              <a:endCxn id="6" idx="2"/>
+            </p:cNvCxnSpPr>
+            <p:nvPr/>
+          </p:nvCxnSpPr>
+          <p:spPr>
+            <a:xfrm flipV="1">
+              <a:off x="10752000" y="3657107"/>
+              <a:ext cx="0" cy="777107"/>
+            </a:xfrm>
+            <a:prstGeom prst="straightConnector1">
+              <a:avLst/>
+            </a:prstGeom>
+            <a:ln w="76200">
+              <a:solidFill>
+                <a:schemeClr val="accent2"/>
+              </a:solidFill>
+              <a:prstDash val="sysDot"/>
+              <a:tailEnd type="triangle"/>
+            </a:ln>
+          </p:spPr>
+          <p:style>
+            <a:lnRef idx="1">
+              <a:schemeClr val="accent1"/>
+            </a:lnRef>
+            <a:fillRef idx="0">
+              <a:schemeClr val="accent1"/>
+            </a:fillRef>
+            <a:effectRef idx="0">
+              <a:schemeClr val="accent1"/>
+            </a:effectRef>
+            <a:fontRef idx="minor">
+              <a:schemeClr val="tx1"/>
+            </a:fontRef>
+          </p:style>
+        </p:cxnSp>
+        <p:sp>
+          <p:nvSpPr>
+            <p:cNvPr id="40" name="직사각형 39"/>
+            <p:cNvSpPr/>
+            <p:nvPr/>
+          </p:nvSpPr>
+          <p:spPr>
+            <a:xfrm>
+              <a:off x="9672000" y="3423551"/>
+              <a:ext cx="2160000" cy="540000"/>
+            </a:xfrm>
+            <a:prstGeom prst="rect">
+              <a:avLst/>
+            </a:prstGeom>
+            <a:solidFill>
+              <a:schemeClr val="accent4"/>
             </a:solidFill>
-          </a:ln>
-        </p:spPr>
-        <p:style>
-          <a:lnRef idx="2">
-            <a:schemeClr val="accent1">
-              <a:shade val="50000"/>
-            </a:schemeClr>
-          </a:lnRef>
-          <a:fillRef idx="1">
-            <a:schemeClr val="accent1"/>
-          </a:fillRef>
-          <a:effectRef idx="0">
-            <a:schemeClr val="accent1"/>
-          </a:effectRef>
-          <a:fontRef idx="minor">
-            <a:schemeClr val="lt1"/>
-          </a:fontRef>
-        </p:style>
-        <p:txBody>
-          <a:bodyPr rtlCol="0" anchor="ctr"/>
-          <a:lstStyle/>
-          <a:p>
-            <a:pPr algn="ctr"/>
-            <a:r>
-              <a:rPr lang="en-US" altLang="ko-KR" sz="2400" dirty="0" err="1" smtClean="0">
-                <a:latin typeface="나눔스퀘어 Bold" panose="020B0600000101010101" pitchFamily="50" charset="-127"/>
-                <a:ea typeface="나눔스퀘어 Bold" panose="020B0600000101010101" pitchFamily="50" charset="-127"/>
-              </a:rPr>
-              <a:t>Ngnix</a:t>
-            </a:r>
-            <a:endParaRPr lang="ko-KR" altLang="en-US" sz="2400" dirty="0">
-              <a:latin typeface="나눔스퀘어 Bold" panose="020B0600000101010101" pitchFamily="50" charset="-127"/>
-              <a:ea typeface="나눔스퀘어 Bold" panose="020B0600000101010101" pitchFamily="50" charset="-127"/>
-            </a:endParaRPr>
-          </a:p>
-        </p:txBody>
-      </p:sp>
-      <p:sp>
-        <p:nvSpPr>
-          <p:cNvPr id="47" name="직사각형 46"/>
-          <p:cNvSpPr/>
-          <p:nvPr/>
-        </p:nvSpPr>
-        <p:spPr>
-          <a:xfrm>
-            <a:off x="11003142" y="1831043"/>
-            <a:ext cx="1440000" cy="720000"/>
-          </a:xfrm>
-          <a:prstGeom prst="rect">
-            <a:avLst/>
-          </a:prstGeom>
-          <a:solidFill>
-            <a:schemeClr val="accent5"/>
-          </a:solidFill>
-          <a:ln>
-            <a:solidFill>
-              <a:schemeClr val="tx1"/>
-            </a:solidFill>
-          </a:ln>
-        </p:spPr>
-        <p:style>
-          <a:lnRef idx="2">
-            <a:schemeClr val="accent1">
-              <a:shade val="50000"/>
-            </a:schemeClr>
-          </a:lnRef>
-          <a:fillRef idx="1">
-            <a:schemeClr val="accent1"/>
-          </a:fillRef>
-          <a:effectRef idx="0">
-            <a:schemeClr val="accent1"/>
-          </a:effectRef>
-          <a:fontRef idx="minor">
-            <a:schemeClr val="lt1"/>
-          </a:fontRef>
-        </p:style>
-        <p:txBody>
-          <a:bodyPr rtlCol="0" anchor="ctr"/>
-          <a:lstStyle/>
-          <a:p>
-            <a:pPr algn="ctr"/>
-            <a:r>
-              <a:rPr lang="en-US" altLang="ko-KR" sz="2400" dirty="0" err="1" smtClean="0">
-                <a:latin typeface="나눔스퀘어 Bold" panose="020B0600000101010101" pitchFamily="50" charset="-127"/>
-                <a:ea typeface="나눔스퀘어 Bold" panose="020B0600000101010101" pitchFamily="50" charset="-127"/>
-              </a:rPr>
-              <a:t>Ngnix</a:t>
-            </a:r>
-            <a:endParaRPr lang="ko-KR" altLang="en-US" sz="2400" dirty="0">
-              <a:latin typeface="나눔스퀘어 Bold" panose="020B0600000101010101" pitchFamily="50" charset="-127"/>
-              <a:ea typeface="나눔스퀘어 Bold" panose="020B0600000101010101" pitchFamily="50" charset="-127"/>
-            </a:endParaRPr>
-          </a:p>
-        </p:txBody>
-      </p:sp>
-      <p:sp>
-        <p:nvSpPr>
-          <p:cNvPr id="48" name="직사각형 47"/>
-          <p:cNvSpPr/>
-          <p:nvPr/>
-        </p:nvSpPr>
-        <p:spPr>
-          <a:xfrm>
-            <a:off x="10055998" y="182490"/>
-            <a:ext cx="1440000" cy="720000"/>
-          </a:xfrm>
-          <a:prstGeom prst="rect">
-            <a:avLst/>
-          </a:prstGeom>
-          <a:solidFill>
-            <a:schemeClr val="accent5"/>
-          </a:solidFill>
-          <a:ln>
-            <a:solidFill>
-              <a:schemeClr val="tx1"/>
-            </a:solidFill>
-          </a:ln>
-        </p:spPr>
-        <p:style>
-          <a:lnRef idx="2">
-            <a:schemeClr val="accent1">
-              <a:shade val="50000"/>
-            </a:schemeClr>
-          </a:lnRef>
-          <a:fillRef idx="1">
-            <a:schemeClr val="accent1"/>
-          </a:fillRef>
-          <a:effectRef idx="0">
-            <a:schemeClr val="accent1"/>
-          </a:effectRef>
-          <a:fontRef idx="minor">
-            <a:schemeClr val="lt1"/>
-          </a:fontRef>
-        </p:style>
-        <p:txBody>
-          <a:bodyPr rtlCol="0" anchor="ctr"/>
-          <a:lstStyle/>
-          <a:p>
-            <a:pPr algn="ctr"/>
-            <a:r>
-              <a:rPr lang="en-US" altLang="ko-KR" sz="2400" dirty="0" smtClean="0">
-                <a:latin typeface="나눔스퀘어 Bold" panose="020B0600000101010101" pitchFamily="50" charset="-127"/>
-                <a:ea typeface="나눔스퀘어 Bold" panose="020B0600000101010101" pitchFamily="50" charset="-127"/>
-              </a:rPr>
-              <a:t>DNS</a:t>
-            </a:r>
-            <a:endParaRPr lang="ko-KR" altLang="en-US" sz="2400" dirty="0">
-              <a:latin typeface="나눔스퀘어 Bold" panose="020B0600000101010101" pitchFamily="50" charset="-127"/>
-              <a:ea typeface="나눔스퀘어 Bold" panose="020B0600000101010101" pitchFamily="50" charset="-127"/>
-            </a:endParaRPr>
-          </a:p>
-        </p:txBody>
-      </p:sp>
-      <p:cxnSp>
-        <p:nvCxnSpPr>
-          <p:cNvPr id="8" name="직선 화살표 연결선 7"/>
-          <p:cNvCxnSpPr>
-            <a:stCxn id="25" idx="0"/>
-          </p:cNvCxnSpPr>
-          <p:nvPr/>
-        </p:nvCxnSpPr>
-        <p:spPr>
-          <a:xfrm flipV="1">
-            <a:off x="1440000" y="3940295"/>
-            <a:ext cx="0" cy="493919"/>
-          </a:xfrm>
-          <a:prstGeom prst="straightConnector1">
-            <a:avLst/>
-          </a:prstGeom>
-          <a:ln w="76200">
-            <a:solidFill>
-              <a:schemeClr val="accent2"/>
-            </a:solidFill>
-            <a:prstDash val="sysDot"/>
-            <a:tailEnd type="triangle"/>
-          </a:ln>
-        </p:spPr>
-        <p:style>
-          <a:lnRef idx="1">
-            <a:schemeClr val="accent1"/>
-          </a:lnRef>
-          <a:fillRef idx="0">
-            <a:schemeClr val="accent1"/>
-          </a:fillRef>
-          <a:effectRef idx="0">
-            <a:schemeClr val="accent1"/>
-          </a:effectRef>
-          <a:fontRef idx="minor">
-            <a:schemeClr val="tx1"/>
-          </a:fontRef>
-        </p:style>
-      </p:cxnSp>
-      <p:sp>
-        <p:nvSpPr>
-          <p:cNvPr id="29" name="직사각형 28"/>
-          <p:cNvSpPr/>
-          <p:nvPr/>
-        </p:nvSpPr>
-        <p:spPr>
-          <a:xfrm>
-            <a:off x="152400" y="2369507"/>
-            <a:ext cx="2880000" cy="1440000"/>
-          </a:xfrm>
-          <a:prstGeom prst="rect">
-            <a:avLst/>
-          </a:prstGeom>
-          <a:solidFill>
-            <a:schemeClr val="accent5"/>
-          </a:solidFill>
-          <a:ln>
-            <a:solidFill>
-              <a:schemeClr val="tx1"/>
-            </a:solidFill>
-          </a:ln>
-        </p:spPr>
-        <p:style>
-          <a:lnRef idx="2">
-            <a:schemeClr val="accent1">
-              <a:shade val="50000"/>
-            </a:schemeClr>
-          </a:lnRef>
-          <a:fillRef idx="1">
-            <a:schemeClr val="accent1"/>
-          </a:fillRef>
-          <a:effectRef idx="0">
-            <a:schemeClr val="accent1"/>
-          </a:effectRef>
-          <a:fontRef idx="minor">
-            <a:schemeClr val="lt1"/>
-          </a:fontRef>
-        </p:style>
-        <p:txBody>
-          <a:bodyPr rtlCol="0" anchor="ctr"/>
-          <a:lstStyle/>
-          <a:p>
-            <a:pPr algn="ctr"/>
-            <a:r>
-              <a:rPr lang="ko-KR" altLang="en-US" sz="2400" dirty="0" smtClean="0">
-                <a:latin typeface="나눔스퀘어 Bold" panose="020B0600000101010101" pitchFamily="50" charset="-127"/>
-                <a:ea typeface="나눔스퀘어 Bold" panose="020B0600000101010101" pitchFamily="50" charset="-127"/>
-              </a:rPr>
-              <a:t>개발</a:t>
-            </a:r>
-            <a:r>
-              <a:rPr lang="en-US" altLang="ko-KR" sz="2400" dirty="0" smtClean="0">
-                <a:latin typeface="나눔스퀘어 Bold" panose="020B0600000101010101" pitchFamily="50" charset="-127"/>
-                <a:ea typeface="나눔스퀘어 Bold" panose="020B0600000101010101" pitchFamily="50" charset="-127"/>
-              </a:rPr>
-              <a:t>PC(Local)</a:t>
-            </a:r>
-          </a:p>
-          <a:p>
-            <a:pPr algn="ctr"/>
-            <a:r>
-              <a:rPr lang="en-US" altLang="ko-KR" sz="2400" dirty="0" smtClean="0">
-                <a:latin typeface="나눔스퀘어 Bold" panose="020B0600000101010101" pitchFamily="50" charset="-127"/>
-                <a:ea typeface="나눔스퀘어 Bold" panose="020B0600000101010101" pitchFamily="50" charset="-127"/>
-              </a:rPr>
-              <a:t>JDK, </a:t>
-            </a:r>
-            <a:r>
-              <a:rPr lang="en-US" altLang="ko-KR" sz="2400" dirty="0" err="1" smtClean="0">
-                <a:latin typeface="나눔스퀘어 Bold" panose="020B0600000101010101" pitchFamily="50" charset="-127"/>
-                <a:ea typeface="나눔스퀘어 Bold" panose="020B0600000101010101" pitchFamily="50" charset="-127"/>
-              </a:rPr>
-              <a:t>Git</a:t>
-            </a:r>
-            <a:r>
-              <a:rPr lang="en-US" altLang="ko-KR" sz="2400" dirty="0" smtClean="0">
-                <a:latin typeface="나눔스퀘어 Bold" panose="020B0600000101010101" pitchFamily="50" charset="-127"/>
-                <a:ea typeface="나눔스퀘어 Bold" panose="020B0600000101010101" pitchFamily="50" charset="-127"/>
-              </a:rPr>
-              <a:t>, MySQL</a:t>
-            </a:r>
-            <a:endParaRPr lang="ko-KR" altLang="en-US" sz="2400" dirty="0">
-              <a:latin typeface="나눔스퀘어 Bold" panose="020B0600000101010101" pitchFamily="50" charset="-127"/>
-              <a:ea typeface="나눔스퀘어 Bold" panose="020B0600000101010101" pitchFamily="50" charset="-127"/>
-            </a:endParaRPr>
-          </a:p>
-        </p:txBody>
-      </p:sp>
-      <p:sp>
-        <p:nvSpPr>
-          <p:cNvPr id="30" name="직사각형 29"/>
-          <p:cNvSpPr/>
-          <p:nvPr/>
-        </p:nvSpPr>
-        <p:spPr>
-          <a:xfrm>
-            <a:off x="304800" y="2521907"/>
-            <a:ext cx="2880000" cy="1440000"/>
-          </a:xfrm>
-          <a:prstGeom prst="rect">
-            <a:avLst/>
-          </a:prstGeom>
-          <a:solidFill>
-            <a:schemeClr val="accent5"/>
-          </a:solidFill>
-          <a:ln>
-            <a:solidFill>
-              <a:schemeClr val="tx1"/>
-            </a:solidFill>
-          </a:ln>
-        </p:spPr>
-        <p:style>
-          <a:lnRef idx="2">
-            <a:schemeClr val="accent1">
-              <a:shade val="50000"/>
-            </a:schemeClr>
-          </a:lnRef>
-          <a:fillRef idx="1">
-            <a:schemeClr val="accent1"/>
-          </a:fillRef>
-          <a:effectRef idx="0">
-            <a:schemeClr val="accent1"/>
-          </a:effectRef>
-          <a:fontRef idx="minor">
-            <a:schemeClr val="lt1"/>
-          </a:fontRef>
-        </p:style>
-        <p:txBody>
-          <a:bodyPr rtlCol="0" anchor="ctr"/>
-          <a:lstStyle/>
-          <a:p>
-            <a:pPr algn="ctr"/>
-            <a:r>
-              <a:rPr lang="ko-KR" altLang="en-US" sz="2400" dirty="0" smtClean="0">
-                <a:latin typeface="나눔스퀘어 Bold" panose="020B0600000101010101" pitchFamily="50" charset="-127"/>
-                <a:ea typeface="나눔스퀘어 Bold" panose="020B0600000101010101" pitchFamily="50" charset="-127"/>
-              </a:rPr>
-              <a:t>개발</a:t>
-            </a:r>
-            <a:r>
-              <a:rPr lang="en-US" altLang="ko-KR" sz="2400" dirty="0" smtClean="0">
-                <a:latin typeface="나눔스퀘어 Bold" panose="020B0600000101010101" pitchFamily="50" charset="-127"/>
-                <a:ea typeface="나눔스퀘어 Bold" panose="020B0600000101010101" pitchFamily="50" charset="-127"/>
-              </a:rPr>
-              <a:t>PC(Local)</a:t>
-            </a:r>
-          </a:p>
-          <a:p>
-            <a:pPr algn="ctr"/>
-            <a:r>
-              <a:rPr lang="en-US" altLang="ko-KR" sz="2400" dirty="0" smtClean="0">
-                <a:latin typeface="나눔스퀘어 Bold" panose="020B0600000101010101" pitchFamily="50" charset="-127"/>
-                <a:ea typeface="나눔스퀘어 Bold" panose="020B0600000101010101" pitchFamily="50" charset="-127"/>
-              </a:rPr>
-              <a:t>JDK, </a:t>
-            </a:r>
-            <a:r>
-              <a:rPr lang="en-US" altLang="ko-KR" sz="2400" dirty="0" err="1" smtClean="0">
-                <a:latin typeface="나눔스퀘어 Bold" panose="020B0600000101010101" pitchFamily="50" charset="-127"/>
-                <a:ea typeface="나눔스퀘어 Bold" panose="020B0600000101010101" pitchFamily="50" charset="-127"/>
-              </a:rPr>
-              <a:t>Git</a:t>
-            </a:r>
-            <a:r>
-              <a:rPr lang="en-US" altLang="ko-KR" sz="2400" dirty="0" smtClean="0">
-                <a:latin typeface="나눔스퀘어 Bold" panose="020B0600000101010101" pitchFamily="50" charset="-127"/>
-                <a:ea typeface="나눔스퀘어 Bold" panose="020B0600000101010101" pitchFamily="50" charset="-127"/>
-              </a:rPr>
-              <a:t>, MySQL</a:t>
-            </a:r>
-            <a:endParaRPr lang="ko-KR" altLang="en-US" sz="2400" dirty="0">
-              <a:latin typeface="나눔스퀘어 Bold" panose="020B0600000101010101" pitchFamily="50" charset="-127"/>
-              <a:ea typeface="나눔스퀘어 Bold" panose="020B0600000101010101" pitchFamily="50" charset="-127"/>
-            </a:endParaRPr>
-          </a:p>
-        </p:txBody>
-      </p:sp>
-      <p:cxnSp>
-        <p:nvCxnSpPr>
-          <p:cNvPr id="33" name="직선 화살표 연결선 32"/>
-          <p:cNvCxnSpPr>
-            <a:stCxn id="11" idx="0"/>
-            <a:endCxn id="26" idx="0"/>
-          </p:cNvCxnSpPr>
-          <p:nvPr/>
-        </p:nvCxnSpPr>
-        <p:spPr>
-          <a:xfrm flipV="1">
-            <a:off x="6020972" y="3676328"/>
-            <a:ext cx="1" cy="757886"/>
-          </a:xfrm>
-          <a:prstGeom prst="straightConnector1">
-            <a:avLst/>
-          </a:prstGeom>
-          <a:ln w="76200">
-            <a:solidFill>
-              <a:schemeClr val="accent2"/>
-            </a:solidFill>
-            <a:prstDash val="sysDot"/>
-            <a:tailEnd type="triangle"/>
-          </a:ln>
-        </p:spPr>
-        <p:style>
-          <a:lnRef idx="1">
-            <a:schemeClr val="accent1"/>
-          </a:lnRef>
-          <a:fillRef idx="0">
-            <a:schemeClr val="accent1"/>
-          </a:fillRef>
-          <a:effectRef idx="0">
-            <a:schemeClr val="accent1"/>
-          </a:effectRef>
-          <a:fontRef idx="minor">
-            <a:schemeClr val="tx1"/>
-          </a:fontRef>
-        </p:style>
-      </p:cxnSp>
-      <p:sp>
-        <p:nvSpPr>
-          <p:cNvPr id="26" name="TextBox 25"/>
-          <p:cNvSpPr txBox="1"/>
-          <p:nvPr/>
-        </p:nvSpPr>
-        <p:spPr>
-          <a:xfrm>
-            <a:off x="5021340" y="3676328"/>
-            <a:ext cx="1999265" cy="369332"/>
-          </a:xfrm>
-          <a:prstGeom prst="rect">
-            <a:avLst/>
-          </a:prstGeom>
-          <a:noFill/>
-        </p:spPr>
-        <p:txBody>
-          <a:bodyPr wrap="none" rtlCol="0">
-            <a:spAutoFit/>
-          </a:bodyPr>
-          <a:lstStyle/>
-          <a:p>
-            <a:r>
-              <a:rPr lang="ko-KR" altLang="en-US" dirty="0" smtClean="0">
-                <a:latin typeface="나눔스퀘어 Bold" panose="020B0600000101010101" pitchFamily="50" charset="-127"/>
-                <a:ea typeface="나눔스퀘어 Bold" panose="020B0600000101010101" pitchFamily="50" charset="-127"/>
-              </a:rPr>
-              <a:t>개발팀 </a:t>
-            </a:r>
-            <a:r>
-              <a:rPr lang="en-US" altLang="ko-KR" dirty="0" smtClean="0">
-                <a:latin typeface="나눔스퀘어 Bold" panose="020B0600000101010101" pitchFamily="50" charset="-127"/>
-                <a:ea typeface="나눔스퀘어 Bold" panose="020B0600000101010101" pitchFamily="50" charset="-127"/>
-              </a:rPr>
-              <a:t>-&gt; QA(QM)</a:t>
-            </a:r>
-            <a:endParaRPr lang="ko-KR" altLang="en-US" dirty="0">
-              <a:latin typeface="나눔스퀘어 Bold" panose="020B0600000101010101" pitchFamily="50" charset="-127"/>
-              <a:ea typeface="나눔스퀘어 Bold" panose="020B0600000101010101" pitchFamily="50" charset="-127"/>
-            </a:endParaRPr>
-          </a:p>
-        </p:txBody>
-      </p:sp>
-      <p:cxnSp>
-        <p:nvCxnSpPr>
-          <p:cNvPr id="36" name="직선 화살표 연결선 35"/>
-          <p:cNvCxnSpPr>
-            <a:stCxn id="5" idx="0"/>
-            <a:endCxn id="6" idx="2"/>
-          </p:cNvCxnSpPr>
-          <p:nvPr/>
-        </p:nvCxnSpPr>
-        <p:spPr>
-          <a:xfrm flipV="1">
-            <a:off x="10752000" y="3657107"/>
-            <a:ext cx="0" cy="777107"/>
-          </a:xfrm>
-          <a:prstGeom prst="straightConnector1">
-            <a:avLst/>
-          </a:prstGeom>
-          <a:ln w="76200">
-            <a:solidFill>
-              <a:schemeClr val="accent2"/>
-            </a:solidFill>
-            <a:prstDash val="sysDot"/>
-            <a:tailEnd type="triangle"/>
-          </a:ln>
-        </p:spPr>
-        <p:style>
-          <a:lnRef idx="1">
-            <a:schemeClr val="accent1"/>
-          </a:lnRef>
-          <a:fillRef idx="0">
-            <a:schemeClr val="accent1"/>
-          </a:fillRef>
-          <a:effectRef idx="0">
-            <a:schemeClr val="accent1"/>
-          </a:effectRef>
-          <a:fontRef idx="minor">
-            <a:schemeClr val="tx1"/>
-          </a:fontRef>
-        </p:style>
-      </p:cxnSp>
-      <p:sp>
-        <p:nvSpPr>
-          <p:cNvPr id="40" name="직사각형 39"/>
-          <p:cNvSpPr/>
-          <p:nvPr/>
-        </p:nvSpPr>
-        <p:spPr>
-          <a:xfrm>
-            <a:off x="9672000" y="3423551"/>
-            <a:ext cx="2160000" cy="540000"/>
-          </a:xfrm>
-          <a:prstGeom prst="rect">
-            <a:avLst/>
-          </a:prstGeom>
-          <a:solidFill>
-            <a:schemeClr val="accent4"/>
-          </a:solidFill>
-          <a:ln>
-            <a:solidFill>
-              <a:schemeClr val="tx1"/>
-            </a:solidFill>
-          </a:ln>
-        </p:spPr>
-        <p:style>
-          <a:lnRef idx="2">
-            <a:schemeClr val="accent1">
-              <a:shade val="50000"/>
-            </a:schemeClr>
-          </a:lnRef>
-          <a:fillRef idx="1">
-            <a:schemeClr val="accent1"/>
-          </a:fillRef>
-          <a:effectRef idx="0">
-            <a:schemeClr val="accent1"/>
-          </a:effectRef>
-          <a:fontRef idx="minor">
-            <a:schemeClr val="lt1"/>
-          </a:fontRef>
-        </p:style>
-        <p:txBody>
-          <a:bodyPr rtlCol="0" anchor="ctr"/>
-          <a:lstStyle/>
-          <a:p>
-            <a:pPr algn="ctr"/>
-            <a:r>
-              <a:rPr lang="en-US" altLang="ko-KR" dirty="0" smtClean="0">
+            <a:ln>
+              <a:solidFill>
+                <a:schemeClr val="tx1"/>
+              </a:solidFill>
+            </a:ln>
+          </p:spPr>
+          <p:style>
+            <a:lnRef idx="2">
+              <a:schemeClr val="accent1">
+                <a:shade val="50000"/>
+              </a:schemeClr>
+            </a:lnRef>
+            <a:fillRef idx="1">
+              <a:schemeClr val="accent1"/>
+            </a:fillRef>
+            <a:effectRef idx="0">
+              <a:schemeClr val="accent1"/>
+            </a:effectRef>
+            <a:fontRef idx="minor">
+              <a:schemeClr val="lt1"/>
+            </a:fontRef>
+          </p:style>
+          <p:txBody>
+            <a:bodyPr rtlCol="0" anchor="ctr"/>
+            <a:lstStyle/>
+            <a:p>
+              <a:pPr algn="ctr"/>
+              <a:r>
+                <a:rPr lang="en-US" altLang="ko-KR" dirty="0" smtClean="0">
+                  <a:solidFill>
+                    <a:schemeClr val="tx1"/>
+                  </a:solidFill>
+                  <a:latin typeface="나눔스퀘어 Bold" panose="020B0600000101010101" pitchFamily="50" charset="-127"/>
+                  <a:ea typeface="나눔스퀘어 Bold" panose="020B0600000101010101" pitchFamily="50" charset="-127"/>
+                </a:rPr>
+                <a:t>Docker Image(Jar)</a:t>
+              </a:r>
+              <a:endParaRPr lang="ko-KR" altLang="en-US" dirty="0">
                 <a:solidFill>
                   <a:schemeClr val="tx1"/>
                 </a:solidFill>
                 <a:latin typeface="나눔스퀘어 Bold" panose="020B0600000101010101" pitchFamily="50" charset="-127"/>
                 <a:ea typeface="나눔스퀘어 Bold" panose="020B0600000101010101" pitchFamily="50" charset="-127"/>
-              </a:rPr>
-              <a:t>Docker Image(Jar)</a:t>
-            </a:r>
-            <a:endParaRPr lang="ko-KR" altLang="en-US" dirty="0">
+              </a:endParaRPr>
+            </a:p>
+          </p:txBody>
+        </p:sp>
+        <p:sp>
+          <p:nvSpPr>
+            <p:cNvPr id="50" name="직사각형 49"/>
+            <p:cNvSpPr/>
+            <p:nvPr/>
+          </p:nvSpPr>
+          <p:spPr>
+            <a:xfrm>
+              <a:off x="9780858" y="3546923"/>
+              <a:ext cx="2160000" cy="540000"/>
+            </a:xfrm>
+            <a:prstGeom prst="rect">
+              <a:avLst/>
+            </a:prstGeom>
+            <a:solidFill>
+              <a:schemeClr val="accent4"/>
+            </a:solidFill>
+            <a:ln>
               <a:solidFill>
                 <a:schemeClr val="tx1"/>
               </a:solidFill>
-              <a:latin typeface="나눔스퀘어 Bold" panose="020B0600000101010101" pitchFamily="50" charset="-127"/>
-              <a:ea typeface="나눔스퀘어 Bold" panose="020B0600000101010101" pitchFamily="50" charset="-127"/>
-            </a:endParaRPr>
-          </a:p>
-        </p:txBody>
-      </p:sp>
-      <p:sp>
-        <p:nvSpPr>
-          <p:cNvPr id="50" name="직사각형 49"/>
-          <p:cNvSpPr/>
-          <p:nvPr/>
-        </p:nvSpPr>
-        <p:spPr>
-          <a:xfrm>
-            <a:off x="9780858" y="3546923"/>
-            <a:ext cx="2160000" cy="540000"/>
-          </a:xfrm>
-          <a:prstGeom prst="rect">
-            <a:avLst/>
-          </a:prstGeom>
-          <a:solidFill>
-            <a:schemeClr val="accent4"/>
-          </a:solidFill>
-          <a:ln>
-            <a:solidFill>
-              <a:schemeClr val="tx1"/>
-            </a:solidFill>
-          </a:ln>
-        </p:spPr>
-        <p:style>
-          <a:lnRef idx="2">
-            <a:schemeClr val="accent1">
-              <a:shade val="50000"/>
-            </a:schemeClr>
-          </a:lnRef>
-          <a:fillRef idx="1">
-            <a:schemeClr val="accent1"/>
-          </a:fillRef>
-          <a:effectRef idx="0">
-            <a:schemeClr val="accent1"/>
-          </a:effectRef>
-          <a:fontRef idx="minor">
-            <a:schemeClr val="lt1"/>
-          </a:fontRef>
-        </p:style>
-        <p:txBody>
-          <a:bodyPr rtlCol="0" anchor="ctr"/>
-          <a:lstStyle/>
-          <a:p>
-            <a:pPr algn="ctr"/>
-            <a:r>
-              <a:rPr lang="en-US" altLang="ko-KR" dirty="0" smtClean="0">
+            </a:ln>
+          </p:spPr>
+          <p:style>
+            <a:lnRef idx="2">
+              <a:schemeClr val="accent1">
+                <a:shade val="50000"/>
+              </a:schemeClr>
+            </a:lnRef>
+            <a:fillRef idx="1">
+              <a:schemeClr val="accent1"/>
+            </a:fillRef>
+            <a:effectRef idx="0">
+              <a:schemeClr val="accent1"/>
+            </a:effectRef>
+            <a:fontRef idx="minor">
+              <a:schemeClr val="lt1"/>
+            </a:fontRef>
+          </p:style>
+          <p:txBody>
+            <a:bodyPr rtlCol="0" anchor="ctr"/>
+            <a:lstStyle/>
+            <a:p>
+              <a:pPr algn="ctr"/>
+              <a:r>
+                <a:rPr lang="en-US" altLang="ko-KR" dirty="0" smtClean="0">
+                  <a:solidFill>
+                    <a:schemeClr val="tx1"/>
+                  </a:solidFill>
+                  <a:latin typeface="나눔스퀘어 Bold" panose="020B0600000101010101" pitchFamily="50" charset="-127"/>
+                  <a:ea typeface="나눔스퀘어 Bold" panose="020B0600000101010101" pitchFamily="50" charset="-127"/>
+                </a:rPr>
+                <a:t>Docker Image(Jar)</a:t>
+              </a:r>
+              <a:endParaRPr lang="ko-KR" altLang="en-US" dirty="0">
                 <a:solidFill>
                   <a:schemeClr val="tx1"/>
                 </a:solidFill>
                 <a:latin typeface="나눔스퀘어 Bold" panose="020B0600000101010101" pitchFamily="50" charset="-127"/>
                 <a:ea typeface="나눔스퀘어 Bold" panose="020B0600000101010101" pitchFamily="50" charset="-127"/>
-              </a:rPr>
-              <a:t>Docker Image(Jar)</a:t>
-            </a:r>
-            <a:endParaRPr lang="ko-KR" altLang="en-US" dirty="0">
+              </a:endParaRPr>
+            </a:p>
+          </p:txBody>
+        </p:sp>
+        <p:sp>
+          <p:nvSpPr>
+            <p:cNvPr id="51" name="직사각형 50"/>
+            <p:cNvSpPr/>
+            <p:nvPr/>
+          </p:nvSpPr>
+          <p:spPr>
+            <a:xfrm>
+              <a:off x="9904230" y="3670295"/>
+              <a:ext cx="2160000" cy="540000"/>
+            </a:xfrm>
+            <a:prstGeom prst="rect">
+              <a:avLst/>
+            </a:prstGeom>
+            <a:solidFill>
+              <a:schemeClr val="accent4"/>
+            </a:solidFill>
+            <a:ln>
               <a:solidFill>
                 <a:schemeClr val="tx1"/>
               </a:solidFill>
-              <a:latin typeface="나눔스퀘어 Bold" panose="020B0600000101010101" pitchFamily="50" charset="-127"/>
-              <a:ea typeface="나눔스퀘어 Bold" panose="020B0600000101010101" pitchFamily="50" charset="-127"/>
-            </a:endParaRPr>
-          </a:p>
-        </p:txBody>
-      </p:sp>
-      <p:sp>
-        <p:nvSpPr>
-          <p:cNvPr id="51" name="직사각형 50"/>
-          <p:cNvSpPr/>
-          <p:nvPr/>
-        </p:nvSpPr>
-        <p:spPr>
-          <a:xfrm>
-            <a:off x="9904230" y="3670295"/>
-            <a:ext cx="2160000" cy="540000"/>
-          </a:xfrm>
-          <a:prstGeom prst="rect">
-            <a:avLst/>
-          </a:prstGeom>
-          <a:solidFill>
-            <a:schemeClr val="accent4"/>
-          </a:solidFill>
-          <a:ln>
-            <a:solidFill>
-              <a:schemeClr val="tx1"/>
-            </a:solidFill>
-          </a:ln>
-        </p:spPr>
-        <p:style>
-          <a:lnRef idx="2">
-            <a:schemeClr val="accent1">
-              <a:shade val="50000"/>
-            </a:schemeClr>
-          </a:lnRef>
-          <a:fillRef idx="1">
-            <a:schemeClr val="accent1"/>
-          </a:fillRef>
-          <a:effectRef idx="0">
-            <a:schemeClr val="accent1"/>
-          </a:effectRef>
-          <a:fontRef idx="minor">
-            <a:schemeClr val="lt1"/>
-          </a:fontRef>
-        </p:style>
-        <p:txBody>
-          <a:bodyPr rtlCol="0" anchor="ctr"/>
-          <a:lstStyle/>
-          <a:p>
-            <a:pPr algn="ctr"/>
-            <a:r>
-              <a:rPr lang="en-US" altLang="ko-KR" dirty="0" smtClean="0">
+            </a:ln>
+          </p:spPr>
+          <p:style>
+            <a:lnRef idx="2">
+              <a:schemeClr val="accent1">
+                <a:shade val="50000"/>
+              </a:schemeClr>
+            </a:lnRef>
+            <a:fillRef idx="1">
+              <a:schemeClr val="accent1"/>
+            </a:fillRef>
+            <a:effectRef idx="0">
+              <a:schemeClr val="accent1"/>
+            </a:effectRef>
+            <a:fontRef idx="minor">
+              <a:schemeClr val="lt1"/>
+            </a:fontRef>
+          </p:style>
+          <p:txBody>
+            <a:bodyPr rtlCol="0" anchor="ctr"/>
+            <a:lstStyle/>
+            <a:p>
+              <a:pPr algn="ctr"/>
+              <a:r>
+                <a:rPr lang="en-US" altLang="ko-KR" dirty="0" smtClean="0">
+                  <a:solidFill>
+                    <a:schemeClr val="tx1"/>
+                  </a:solidFill>
+                  <a:latin typeface="나눔스퀘어 Bold" panose="020B0600000101010101" pitchFamily="50" charset="-127"/>
+                  <a:ea typeface="나눔스퀘어 Bold" panose="020B0600000101010101" pitchFamily="50" charset="-127"/>
+                </a:rPr>
+                <a:t>Docker Image(Jar)</a:t>
+              </a:r>
+              <a:endParaRPr lang="ko-KR" altLang="en-US" dirty="0">
                 <a:solidFill>
                   <a:schemeClr val="tx1"/>
                 </a:solidFill>
                 <a:latin typeface="나눔스퀘어 Bold" panose="020B0600000101010101" pitchFamily="50" charset="-127"/>
                 <a:ea typeface="나눔스퀘어 Bold" panose="020B0600000101010101" pitchFamily="50" charset="-127"/>
-              </a:rPr>
-              <a:t>Docker Image(Jar)</a:t>
-            </a:r>
-            <a:endParaRPr lang="ko-KR" altLang="en-US" dirty="0">
-              <a:solidFill>
-                <a:schemeClr val="tx1"/>
-              </a:solidFill>
-              <a:latin typeface="나눔스퀘어 Bold" panose="020B0600000101010101" pitchFamily="50" charset="-127"/>
-              <a:ea typeface="나눔스퀘어 Bold" panose="020B0600000101010101" pitchFamily="50" charset="-127"/>
-            </a:endParaRPr>
-          </a:p>
-        </p:txBody>
-      </p:sp>
+              </a:endParaRPr>
+            </a:p>
+          </p:txBody>
+        </p:sp>
+      </p:grpSp>
     </p:spTree>
     <p:extLst>
       <p:ext uri="{BB962C8B-B14F-4D97-AF65-F5344CB8AC3E}">

</xml_diff>

<commit_message>
20261002 commit : 4_class
</commit_message>
<xml_diff>
--- a/notion/create_notion_img.pptx
+++ b/notion/create_notion_img.pptx
@@ -5,11 +5,12 @@
     <p:sldMasterId id="2147483648" r:id="rId1"/>
   </p:sldMasterIdLst>
   <p:sldIdLst>
-    <p:sldId id="260" r:id="rId2"/>
-    <p:sldId id="261" r:id="rId3"/>
-    <p:sldId id="256" r:id="rId4"/>
-    <p:sldId id="259" r:id="rId5"/>
-    <p:sldId id="257" r:id="rId6"/>
+    <p:sldId id="264" r:id="rId2"/>
+    <p:sldId id="262" r:id="rId3"/>
+    <p:sldId id="261" r:id="rId4"/>
+    <p:sldId id="256" r:id="rId5"/>
+    <p:sldId id="259" r:id="rId6"/>
+    <p:sldId id="257" r:id="rId7"/>
   </p:sldIdLst>
   <p:sldSz cx="12192000" cy="6858000"/>
   <p:notesSz cx="6858000" cy="9144000"/>
@@ -247,7 +248,7 @@
           <a:p>
             <a:fld id="{7237CE1A-8831-48B5-BA93-72483C6E34E8}" type="datetimeFigureOut">
               <a:rPr lang="ko-KR" altLang="en-US" smtClean="0"/>
-              <a:t>2026-10-01</a:t>
+              <a:t>2026-10-02</a:t>
             </a:fld>
             <a:endParaRPr lang="ko-KR" altLang="en-US"/>
           </a:p>
@@ -417,7 +418,7 @@
           <a:p>
             <a:fld id="{7237CE1A-8831-48B5-BA93-72483C6E34E8}" type="datetimeFigureOut">
               <a:rPr lang="ko-KR" altLang="en-US" smtClean="0"/>
-              <a:t>2026-10-01</a:t>
+              <a:t>2026-10-02</a:t>
             </a:fld>
             <a:endParaRPr lang="ko-KR" altLang="en-US"/>
           </a:p>
@@ -597,7 +598,7 @@
           <a:p>
             <a:fld id="{7237CE1A-8831-48B5-BA93-72483C6E34E8}" type="datetimeFigureOut">
               <a:rPr lang="ko-KR" altLang="en-US" smtClean="0"/>
-              <a:t>2026-10-01</a:t>
+              <a:t>2026-10-02</a:t>
             </a:fld>
             <a:endParaRPr lang="ko-KR" altLang="en-US"/>
           </a:p>
@@ -767,7 +768,7 @@
           <a:p>
             <a:fld id="{7237CE1A-8831-48B5-BA93-72483C6E34E8}" type="datetimeFigureOut">
               <a:rPr lang="ko-KR" altLang="en-US" smtClean="0"/>
-              <a:t>2026-10-01</a:t>
+              <a:t>2026-10-02</a:t>
             </a:fld>
             <a:endParaRPr lang="ko-KR" altLang="en-US"/>
           </a:p>
@@ -1013,7 +1014,7 @@
           <a:p>
             <a:fld id="{7237CE1A-8831-48B5-BA93-72483C6E34E8}" type="datetimeFigureOut">
               <a:rPr lang="ko-KR" altLang="en-US" smtClean="0"/>
-              <a:t>2026-10-01</a:t>
+              <a:t>2026-10-02</a:t>
             </a:fld>
             <a:endParaRPr lang="ko-KR" altLang="en-US"/>
           </a:p>
@@ -1245,7 +1246,7 @@
           <a:p>
             <a:fld id="{7237CE1A-8831-48B5-BA93-72483C6E34E8}" type="datetimeFigureOut">
               <a:rPr lang="ko-KR" altLang="en-US" smtClean="0"/>
-              <a:t>2026-10-01</a:t>
+              <a:t>2026-10-02</a:t>
             </a:fld>
             <a:endParaRPr lang="ko-KR" altLang="en-US"/>
           </a:p>
@@ -1612,7 +1613,7 @@
           <a:p>
             <a:fld id="{7237CE1A-8831-48B5-BA93-72483C6E34E8}" type="datetimeFigureOut">
               <a:rPr lang="ko-KR" altLang="en-US" smtClean="0"/>
-              <a:t>2026-10-01</a:t>
+              <a:t>2026-10-02</a:t>
             </a:fld>
             <a:endParaRPr lang="ko-KR" altLang="en-US"/>
           </a:p>
@@ -1730,7 +1731,7 @@
           <a:p>
             <a:fld id="{7237CE1A-8831-48B5-BA93-72483C6E34E8}" type="datetimeFigureOut">
               <a:rPr lang="ko-KR" altLang="en-US" smtClean="0"/>
-              <a:t>2026-10-01</a:t>
+              <a:t>2026-10-02</a:t>
             </a:fld>
             <a:endParaRPr lang="ko-KR" altLang="en-US"/>
           </a:p>
@@ -1825,7 +1826,7 @@
           <a:p>
             <a:fld id="{7237CE1A-8831-48B5-BA93-72483C6E34E8}" type="datetimeFigureOut">
               <a:rPr lang="ko-KR" altLang="en-US" smtClean="0"/>
-              <a:t>2026-10-01</a:t>
+              <a:t>2026-10-02</a:t>
             </a:fld>
             <a:endParaRPr lang="ko-KR" altLang="en-US"/>
           </a:p>
@@ -2102,7 +2103,7 @@
           <a:p>
             <a:fld id="{7237CE1A-8831-48B5-BA93-72483C6E34E8}" type="datetimeFigureOut">
               <a:rPr lang="ko-KR" altLang="en-US" smtClean="0"/>
-              <a:t>2026-10-01</a:t>
+              <a:t>2026-10-02</a:t>
             </a:fld>
             <a:endParaRPr lang="ko-KR" altLang="en-US"/>
           </a:p>
@@ -2355,7 +2356,7 @@
           <a:p>
             <a:fld id="{7237CE1A-8831-48B5-BA93-72483C6E34E8}" type="datetimeFigureOut">
               <a:rPr lang="ko-KR" altLang="en-US" smtClean="0"/>
-              <a:t>2026-10-01</a:t>
+              <a:t>2026-10-02</a:t>
             </a:fld>
             <a:endParaRPr lang="ko-KR" altLang="en-US"/>
           </a:p>
@@ -2568,7 +2569,7 @@
           <a:p>
             <a:fld id="{7237CE1A-8831-48B5-BA93-72483C6E34E8}" type="datetimeFigureOut">
               <a:rPr lang="ko-KR" altLang="en-US" smtClean="0"/>
-              <a:t>2026-10-01</a:t>
+              <a:t>2026-10-02</a:t>
             </a:fld>
             <a:endParaRPr lang="ko-KR" altLang="en-US"/>
           </a:p>
@@ -2975,6 +2976,1174 @@
       </p:grpSpPr>
       <p:grpSp>
         <p:nvGrpSpPr>
+          <p:cNvPr id="9" name="그룹 8"/>
+          <p:cNvGrpSpPr/>
+          <p:nvPr/>
+        </p:nvGrpSpPr>
+        <p:grpSpPr>
+          <a:xfrm>
+            <a:off x="-1181100" y="-1293777"/>
+            <a:ext cx="15072000" cy="3749901"/>
+            <a:chOff x="0" y="916023"/>
+            <a:chExt cx="15072000" cy="3749901"/>
+          </a:xfrm>
+        </p:grpSpPr>
+        <p:sp>
+          <p:nvSpPr>
+            <p:cNvPr id="31" name="직사각형 30"/>
+            <p:cNvSpPr/>
+            <p:nvPr/>
+          </p:nvSpPr>
+          <p:spPr>
+            <a:xfrm>
+              <a:off x="0" y="3225924"/>
+              <a:ext cx="5760000" cy="1440000"/>
+            </a:xfrm>
+            <a:prstGeom prst="rect">
+              <a:avLst/>
+            </a:prstGeom>
+            <a:solidFill>
+              <a:schemeClr val="accent5"/>
+            </a:solidFill>
+            <a:ln>
+              <a:solidFill>
+                <a:schemeClr val="tx1"/>
+              </a:solidFill>
+            </a:ln>
+          </p:spPr>
+          <p:style>
+            <a:lnRef idx="2">
+              <a:schemeClr val="accent1">
+                <a:shade val="50000"/>
+              </a:schemeClr>
+            </a:lnRef>
+            <a:fillRef idx="1">
+              <a:schemeClr val="accent1"/>
+            </a:fillRef>
+            <a:effectRef idx="0">
+              <a:schemeClr val="accent1"/>
+            </a:effectRef>
+            <a:fontRef idx="minor">
+              <a:schemeClr val="lt1"/>
+            </a:fontRef>
+          </p:style>
+          <p:txBody>
+            <a:bodyPr rtlCol="0" anchor="ctr"/>
+            <a:lstStyle/>
+            <a:p>
+              <a:pPr algn="ctr"/>
+              <a:r>
+                <a:rPr lang="en-US" altLang="ko-KR" sz="3200" dirty="0" err="1" smtClean="0">
+                  <a:latin typeface="나눔스퀘어 Bold" panose="020B0600000101010101" pitchFamily="50" charset="-127"/>
+                  <a:ea typeface="나눔스퀘어 Bold" panose="020B0600000101010101" pitchFamily="50" charset="-127"/>
+                </a:rPr>
+                <a:t>application.properties</a:t>
+              </a:r>
+              <a:endParaRPr lang="ko-KR" altLang="en-US" sz="3200" dirty="0">
+                <a:latin typeface="나눔스퀘어 Bold" panose="020B0600000101010101" pitchFamily="50" charset="-127"/>
+                <a:ea typeface="나눔스퀘어 Bold" panose="020B0600000101010101" pitchFamily="50" charset="-127"/>
+              </a:endParaRPr>
+            </a:p>
+          </p:txBody>
+        </p:sp>
+        <p:sp>
+          <p:nvSpPr>
+            <p:cNvPr id="39" name="직사각형 38"/>
+            <p:cNvSpPr/>
+            <p:nvPr/>
+          </p:nvSpPr>
+          <p:spPr>
+            <a:xfrm>
+              <a:off x="9312000" y="3225924"/>
+              <a:ext cx="5760000" cy="1440000"/>
+            </a:xfrm>
+            <a:prstGeom prst="rect">
+              <a:avLst/>
+            </a:prstGeom>
+            <a:solidFill>
+              <a:schemeClr val="accent5"/>
+            </a:solidFill>
+            <a:ln>
+              <a:solidFill>
+                <a:schemeClr val="tx1"/>
+              </a:solidFill>
+            </a:ln>
+          </p:spPr>
+          <p:style>
+            <a:lnRef idx="2">
+              <a:schemeClr val="accent1">
+                <a:shade val="50000"/>
+              </a:schemeClr>
+            </a:lnRef>
+            <a:fillRef idx="1">
+              <a:schemeClr val="accent1"/>
+            </a:fillRef>
+            <a:effectRef idx="0">
+              <a:schemeClr val="accent1"/>
+            </a:effectRef>
+            <a:fontRef idx="minor">
+              <a:schemeClr val="lt1"/>
+            </a:fontRef>
+          </p:style>
+          <p:txBody>
+            <a:bodyPr rtlCol="0" anchor="ctr"/>
+            <a:lstStyle/>
+            <a:p>
+              <a:pPr algn="ctr"/>
+              <a:r>
+                <a:rPr lang="en-US" altLang="ko-KR" sz="3200" dirty="0">
+                  <a:latin typeface="나눔스퀘어 Bold" panose="020B0600000101010101" pitchFamily="50" charset="-127"/>
+                  <a:ea typeface="나눔스퀘어 Bold" panose="020B0600000101010101" pitchFamily="50" charset="-127"/>
+                </a:rPr>
+                <a:t>a</a:t>
+              </a:r>
+              <a:r>
+                <a:rPr lang="en-US" altLang="ko-KR" sz="3200" dirty="0" smtClean="0">
+                  <a:latin typeface="나눔스퀘어 Bold" panose="020B0600000101010101" pitchFamily="50" charset="-127"/>
+                  <a:ea typeface="나눔스퀘어 Bold" panose="020B0600000101010101" pitchFamily="50" charset="-127"/>
+                </a:rPr>
+                <a:t>pplication-</a:t>
+              </a:r>
+              <a:r>
+                <a:rPr lang="en-US" altLang="ko-KR" sz="3200" dirty="0" err="1" smtClean="0">
+                  <a:latin typeface="나눔스퀘어 Bold" panose="020B0600000101010101" pitchFamily="50" charset="-127"/>
+                  <a:ea typeface="나눔스퀘어 Bold" panose="020B0600000101010101" pitchFamily="50" charset="-127"/>
+                </a:rPr>
+                <a:t>local.properties</a:t>
+              </a:r>
+              <a:endParaRPr lang="ko-KR" altLang="en-US" sz="3200" dirty="0">
+                <a:latin typeface="나눔스퀘어 Bold" panose="020B0600000101010101" pitchFamily="50" charset="-127"/>
+                <a:ea typeface="나눔스퀘어 Bold" panose="020B0600000101010101" pitchFamily="50" charset="-127"/>
+              </a:endParaRPr>
+            </a:p>
+          </p:txBody>
+        </p:sp>
+        <p:sp>
+          <p:nvSpPr>
+            <p:cNvPr id="2" name="덧셈 기호 1"/>
+            <p:cNvSpPr/>
+            <p:nvPr/>
+          </p:nvSpPr>
+          <p:spPr>
+            <a:xfrm>
+              <a:off x="6912619" y="3225924"/>
+              <a:ext cx="1440000" cy="1440000"/>
+            </a:xfrm>
+            <a:prstGeom prst="mathPlus">
+              <a:avLst/>
+            </a:prstGeom>
+            <a:solidFill>
+              <a:schemeClr val="tx1"/>
+            </a:solidFill>
+            <a:ln>
+              <a:noFill/>
+            </a:ln>
+          </p:spPr>
+          <p:style>
+            <a:lnRef idx="2">
+              <a:schemeClr val="accent1">
+                <a:shade val="50000"/>
+              </a:schemeClr>
+            </a:lnRef>
+            <a:fillRef idx="1">
+              <a:schemeClr val="accent1"/>
+            </a:fillRef>
+            <a:effectRef idx="0">
+              <a:schemeClr val="accent1"/>
+            </a:effectRef>
+            <a:fontRef idx="minor">
+              <a:schemeClr val="lt1"/>
+            </a:fontRef>
+          </p:style>
+          <p:txBody>
+            <a:bodyPr rtlCol="0" anchor="ctr"/>
+            <a:lstStyle/>
+            <a:p>
+              <a:pPr algn="ctr"/>
+              <a:endParaRPr lang="ko-KR" altLang="en-US"/>
+            </a:p>
+          </p:txBody>
+        </p:sp>
+        <p:sp>
+          <p:nvSpPr>
+            <p:cNvPr id="3" name="TextBox 2"/>
+            <p:cNvSpPr txBox="1"/>
+            <p:nvPr/>
+          </p:nvSpPr>
+          <p:spPr>
+            <a:xfrm>
+              <a:off x="2669112" y="973395"/>
+              <a:ext cx="9927013" cy="1015663"/>
+            </a:xfrm>
+            <a:prstGeom prst="rect">
+              <a:avLst/>
+            </a:prstGeom>
+            <a:noFill/>
+          </p:spPr>
+          <p:txBody>
+            <a:bodyPr wrap="none" rtlCol="0">
+              <a:spAutoFit/>
+            </a:bodyPr>
+            <a:lstStyle/>
+            <a:p>
+              <a:r>
+                <a:rPr lang="en-US" altLang="ko-KR" sz="6000" dirty="0" err="1">
+                  <a:latin typeface="나눔스퀘어 Bold" panose="020B0600000101010101" pitchFamily="50" charset="-127"/>
+                  <a:ea typeface="나눔스퀘어 Bold" panose="020B0600000101010101" pitchFamily="50" charset="-127"/>
+                </a:rPr>
+                <a:t>s</a:t>
+              </a:r>
+              <a:r>
+                <a:rPr lang="en-US" altLang="ko-KR" sz="6000" dirty="0" err="1" smtClean="0">
+                  <a:latin typeface="나눔스퀘어 Bold" panose="020B0600000101010101" pitchFamily="50" charset="-127"/>
+                  <a:ea typeface="나눔스퀘어 Bold" panose="020B0600000101010101" pitchFamily="50" charset="-127"/>
+                </a:rPr>
+                <a:t>pring.profiles.active</a:t>
+              </a:r>
+              <a:r>
+                <a:rPr lang="en-US" altLang="ko-KR" sz="6000" dirty="0" smtClean="0">
+                  <a:latin typeface="나눔스퀘어 Bold" panose="020B0600000101010101" pitchFamily="50" charset="-127"/>
+                  <a:ea typeface="나눔스퀘어 Bold" panose="020B0600000101010101" pitchFamily="50" charset="-127"/>
+                </a:rPr>
+                <a:t>=local</a:t>
+              </a:r>
+              <a:endParaRPr lang="ko-KR" altLang="en-US" sz="6000" dirty="0">
+                <a:latin typeface="나눔스퀘어 Bold" panose="020B0600000101010101" pitchFamily="50" charset="-127"/>
+                <a:ea typeface="나눔스퀘어 Bold" panose="020B0600000101010101" pitchFamily="50" charset="-127"/>
+              </a:endParaRPr>
+            </a:p>
+          </p:txBody>
+        </p:sp>
+        <p:sp>
+          <p:nvSpPr>
+            <p:cNvPr id="4" name="액자 3"/>
+            <p:cNvSpPr/>
+            <p:nvPr/>
+          </p:nvSpPr>
+          <p:spPr>
+            <a:xfrm>
+              <a:off x="11640456" y="3592971"/>
+              <a:ext cx="1248228" cy="705905"/>
+            </a:xfrm>
+            <a:prstGeom prst="frame">
+              <a:avLst/>
+            </a:prstGeom>
+            <a:solidFill>
+              <a:srgbClr val="FF0000"/>
+            </a:solidFill>
+            <a:ln>
+              <a:solidFill>
+                <a:srgbClr val="FF0000"/>
+              </a:solidFill>
+            </a:ln>
+          </p:spPr>
+          <p:style>
+            <a:lnRef idx="2">
+              <a:schemeClr val="accent1">
+                <a:shade val="50000"/>
+              </a:schemeClr>
+            </a:lnRef>
+            <a:fillRef idx="1">
+              <a:schemeClr val="accent1"/>
+            </a:fillRef>
+            <a:effectRef idx="0">
+              <a:schemeClr val="accent1"/>
+            </a:effectRef>
+            <a:fontRef idx="minor">
+              <a:schemeClr val="lt1"/>
+            </a:fontRef>
+          </p:style>
+          <p:txBody>
+            <a:bodyPr rtlCol="0" anchor="ctr"/>
+            <a:lstStyle/>
+            <a:p>
+              <a:pPr algn="ctr"/>
+              <a:endParaRPr lang="ko-KR" altLang="en-US">
+                <a:solidFill>
+                  <a:schemeClr val="tx1"/>
+                </a:solidFill>
+              </a:endParaRPr>
+            </a:p>
+          </p:txBody>
+        </p:sp>
+        <p:cxnSp>
+          <p:nvCxnSpPr>
+            <p:cNvPr id="6" name="직선 화살표 연결선 5"/>
+            <p:cNvCxnSpPr>
+              <a:stCxn id="12" idx="2"/>
+              <a:endCxn id="4" idx="0"/>
+            </p:cNvCxnSpPr>
+            <p:nvPr/>
+          </p:nvCxnSpPr>
+          <p:spPr>
+            <a:xfrm>
+              <a:off x="11606662" y="1989058"/>
+              <a:ext cx="657908" cy="1603913"/>
+            </a:xfrm>
+            <a:prstGeom prst="straightConnector1">
+              <a:avLst/>
+            </a:prstGeom>
+            <a:ln w="76200">
+              <a:solidFill>
+                <a:srgbClr val="FF0000"/>
+              </a:solidFill>
+              <a:tailEnd type="triangle"/>
+            </a:ln>
+          </p:spPr>
+          <p:style>
+            <a:lnRef idx="1">
+              <a:schemeClr val="accent1"/>
+            </a:lnRef>
+            <a:fillRef idx="0">
+              <a:schemeClr val="accent1"/>
+            </a:fillRef>
+            <a:effectRef idx="0">
+              <a:schemeClr val="accent1"/>
+            </a:effectRef>
+            <a:fontRef idx="minor">
+              <a:schemeClr val="tx1"/>
+            </a:fontRef>
+          </p:style>
+        </p:cxnSp>
+        <p:sp>
+          <p:nvSpPr>
+            <p:cNvPr id="12" name="액자 11"/>
+            <p:cNvSpPr/>
+            <p:nvPr/>
+          </p:nvSpPr>
+          <p:spPr>
+            <a:xfrm>
+              <a:off x="10617199" y="916023"/>
+              <a:ext cx="1978926" cy="1073035"/>
+            </a:xfrm>
+            <a:prstGeom prst="frame">
+              <a:avLst/>
+            </a:prstGeom>
+            <a:solidFill>
+              <a:srgbClr val="FF0000"/>
+            </a:solidFill>
+            <a:ln>
+              <a:solidFill>
+                <a:srgbClr val="FF0000"/>
+              </a:solidFill>
+            </a:ln>
+          </p:spPr>
+          <p:style>
+            <a:lnRef idx="2">
+              <a:schemeClr val="accent1">
+                <a:shade val="50000"/>
+              </a:schemeClr>
+            </a:lnRef>
+            <a:fillRef idx="1">
+              <a:schemeClr val="accent1"/>
+            </a:fillRef>
+            <a:effectRef idx="0">
+              <a:schemeClr val="accent1"/>
+            </a:effectRef>
+            <a:fontRef idx="minor">
+              <a:schemeClr val="lt1"/>
+            </a:fontRef>
+          </p:style>
+          <p:txBody>
+            <a:bodyPr rtlCol="0" anchor="ctr"/>
+            <a:lstStyle/>
+            <a:p>
+              <a:pPr algn="ctr"/>
+              <a:endParaRPr lang="ko-KR" altLang="en-US">
+                <a:solidFill>
+                  <a:schemeClr val="tx1"/>
+                </a:solidFill>
+              </a:endParaRPr>
+            </a:p>
+          </p:txBody>
+        </p:sp>
+      </p:grpSp>
+      <p:grpSp>
+        <p:nvGrpSpPr>
+          <p:cNvPr id="16" name="그룹 15"/>
+          <p:cNvGrpSpPr/>
+          <p:nvPr/>
+        </p:nvGrpSpPr>
+        <p:grpSpPr>
+          <a:xfrm>
+            <a:off x="-1181100" y="2823171"/>
+            <a:ext cx="15072000" cy="3749901"/>
+            <a:chOff x="0" y="916023"/>
+            <a:chExt cx="15072000" cy="3749901"/>
+          </a:xfrm>
+        </p:grpSpPr>
+        <p:sp>
+          <p:nvSpPr>
+            <p:cNvPr id="17" name="직사각형 16"/>
+            <p:cNvSpPr/>
+            <p:nvPr/>
+          </p:nvSpPr>
+          <p:spPr>
+            <a:xfrm>
+              <a:off x="0" y="3225924"/>
+              <a:ext cx="5760000" cy="1440000"/>
+            </a:xfrm>
+            <a:prstGeom prst="rect">
+              <a:avLst/>
+            </a:prstGeom>
+            <a:solidFill>
+              <a:schemeClr val="accent5"/>
+            </a:solidFill>
+            <a:ln>
+              <a:solidFill>
+                <a:schemeClr val="tx1"/>
+              </a:solidFill>
+            </a:ln>
+          </p:spPr>
+          <p:style>
+            <a:lnRef idx="2">
+              <a:schemeClr val="accent1">
+                <a:shade val="50000"/>
+              </a:schemeClr>
+            </a:lnRef>
+            <a:fillRef idx="1">
+              <a:schemeClr val="accent1"/>
+            </a:fillRef>
+            <a:effectRef idx="0">
+              <a:schemeClr val="accent1"/>
+            </a:effectRef>
+            <a:fontRef idx="minor">
+              <a:schemeClr val="lt1"/>
+            </a:fontRef>
+          </p:style>
+          <p:txBody>
+            <a:bodyPr rtlCol="0" anchor="ctr"/>
+            <a:lstStyle/>
+            <a:p>
+              <a:pPr algn="ctr"/>
+              <a:r>
+                <a:rPr lang="en-US" altLang="ko-KR" sz="3200" dirty="0" err="1" smtClean="0">
+                  <a:latin typeface="나눔스퀘어 Bold" panose="020B0600000101010101" pitchFamily="50" charset="-127"/>
+                  <a:ea typeface="나눔스퀘어 Bold" panose="020B0600000101010101" pitchFamily="50" charset="-127"/>
+                </a:rPr>
+                <a:t>application.properties</a:t>
+              </a:r>
+              <a:endParaRPr lang="ko-KR" altLang="en-US" sz="3200" dirty="0">
+                <a:latin typeface="나눔스퀘어 Bold" panose="020B0600000101010101" pitchFamily="50" charset="-127"/>
+                <a:ea typeface="나눔스퀘어 Bold" panose="020B0600000101010101" pitchFamily="50" charset="-127"/>
+              </a:endParaRPr>
+            </a:p>
+          </p:txBody>
+        </p:sp>
+        <p:sp>
+          <p:nvSpPr>
+            <p:cNvPr id="18" name="직사각형 17"/>
+            <p:cNvSpPr/>
+            <p:nvPr/>
+          </p:nvSpPr>
+          <p:spPr>
+            <a:xfrm>
+              <a:off x="9312000" y="3225924"/>
+              <a:ext cx="5760000" cy="1440000"/>
+            </a:xfrm>
+            <a:prstGeom prst="rect">
+              <a:avLst/>
+            </a:prstGeom>
+            <a:solidFill>
+              <a:schemeClr val="accent5"/>
+            </a:solidFill>
+            <a:ln>
+              <a:solidFill>
+                <a:schemeClr val="tx1"/>
+              </a:solidFill>
+            </a:ln>
+          </p:spPr>
+          <p:style>
+            <a:lnRef idx="2">
+              <a:schemeClr val="accent1">
+                <a:shade val="50000"/>
+              </a:schemeClr>
+            </a:lnRef>
+            <a:fillRef idx="1">
+              <a:schemeClr val="accent1"/>
+            </a:fillRef>
+            <a:effectRef idx="0">
+              <a:schemeClr val="accent1"/>
+            </a:effectRef>
+            <a:fontRef idx="minor">
+              <a:schemeClr val="lt1"/>
+            </a:fontRef>
+          </p:style>
+          <p:txBody>
+            <a:bodyPr rtlCol="0" anchor="ctr"/>
+            <a:lstStyle/>
+            <a:p>
+              <a:pPr algn="ctr"/>
+              <a:r>
+                <a:rPr lang="en-US" altLang="ko-KR" sz="3200" dirty="0">
+                  <a:latin typeface="나눔스퀘어 Bold" panose="020B0600000101010101" pitchFamily="50" charset="-127"/>
+                  <a:ea typeface="나눔스퀘어 Bold" panose="020B0600000101010101" pitchFamily="50" charset="-127"/>
+                </a:rPr>
+                <a:t>a</a:t>
+              </a:r>
+              <a:r>
+                <a:rPr lang="en-US" altLang="ko-KR" sz="3200" dirty="0" smtClean="0">
+                  <a:latin typeface="나눔스퀘어 Bold" panose="020B0600000101010101" pitchFamily="50" charset="-127"/>
+                  <a:ea typeface="나눔스퀘어 Bold" panose="020B0600000101010101" pitchFamily="50" charset="-127"/>
+                </a:rPr>
+                <a:t>pplication-</a:t>
+              </a:r>
+              <a:r>
+                <a:rPr lang="en-US" altLang="ko-KR" sz="3200" dirty="0" err="1" smtClean="0">
+                  <a:latin typeface="나눔스퀘어 Bold" panose="020B0600000101010101" pitchFamily="50" charset="-127"/>
+                  <a:ea typeface="나눔스퀘어 Bold" panose="020B0600000101010101" pitchFamily="50" charset="-127"/>
+                </a:rPr>
+                <a:t>dev.properties</a:t>
+              </a:r>
+              <a:endParaRPr lang="ko-KR" altLang="en-US" sz="3200" dirty="0">
+                <a:latin typeface="나눔스퀘어 Bold" panose="020B0600000101010101" pitchFamily="50" charset="-127"/>
+                <a:ea typeface="나눔스퀘어 Bold" panose="020B0600000101010101" pitchFamily="50" charset="-127"/>
+              </a:endParaRPr>
+            </a:p>
+          </p:txBody>
+        </p:sp>
+        <p:sp>
+          <p:nvSpPr>
+            <p:cNvPr id="19" name="덧셈 기호 18"/>
+            <p:cNvSpPr/>
+            <p:nvPr/>
+          </p:nvSpPr>
+          <p:spPr>
+            <a:xfrm>
+              <a:off x="6912619" y="3225924"/>
+              <a:ext cx="1440000" cy="1440000"/>
+            </a:xfrm>
+            <a:prstGeom prst="mathPlus">
+              <a:avLst/>
+            </a:prstGeom>
+            <a:solidFill>
+              <a:schemeClr val="tx1"/>
+            </a:solidFill>
+            <a:ln>
+              <a:noFill/>
+            </a:ln>
+          </p:spPr>
+          <p:style>
+            <a:lnRef idx="2">
+              <a:schemeClr val="accent1">
+                <a:shade val="50000"/>
+              </a:schemeClr>
+            </a:lnRef>
+            <a:fillRef idx="1">
+              <a:schemeClr val="accent1"/>
+            </a:fillRef>
+            <a:effectRef idx="0">
+              <a:schemeClr val="accent1"/>
+            </a:effectRef>
+            <a:fontRef idx="minor">
+              <a:schemeClr val="lt1"/>
+            </a:fontRef>
+          </p:style>
+          <p:txBody>
+            <a:bodyPr rtlCol="0" anchor="ctr"/>
+            <a:lstStyle/>
+            <a:p>
+              <a:pPr algn="ctr"/>
+              <a:endParaRPr lang="ko-KR" altLang="en-US"/>
+            </a:p>
+          </p:txBody>
+        </p:sp>
+        <p:sp>
+          <p:nvSpPr>
+            <p:cNvPr id="20" name="TextBox 19"/>
+            <p:cNvSpPr txBox="1"/>
+            <p:nvPr/>
+          </p:nvSpPr>
+          <p:spPr>
+            <a:xfrm>
+              <a:off x="2669112" y="973395"/>
+              <a:ext cx="9564734" cy="1015663"/>
+            </a:xfrm>
+            <a:prstGeom prst="rect">
+              <a:avLst/>
+            </a:prstGeom>
+            <a:noFill/>
+          </p:spPr>
+          <p:txBody>
+            <a:bodyPr wrap="none" rtlCol="0">
+              <a:spAutoFit/>
+            </a:bodyPr>
+            <a:lstStyle/>
+            <a:p>
+              <a:r>
+                <a:rPr lang="en-US" altLang="ko-KR" sz="6000" dirty="0" err="1" smtClean="0">
+                  <a:latin typeface="나눔스퀘어 Bold" panose="020B0600000101010101" pitchFamily="50" charset="-127"/>
+                  <a:ea typeface="나눔스퀘어 Bold" panose="020B0600000101010101" pitchFamily="50" charset="-127"/>
+                </a:rPr>
+                <a:t>spring.profiles.active</a:t>
+              </a:r>
+              <a:r>
+                <a:rPr lang="en-US" altLang="ko-KR" sz="6000" dirty="0" smtClean="0">
+                  <a:latin typeface="나눔스퀘어 Bold" panose="020B0600000101010101" pitchFamily="50" charset="-127"/>
+                  <a:ea typeface="나눔스퀘어 Bold" panose="020B0600000101010101" pitchFamily="50" charset="-127"/>
+                </a:rPr>
+                <a:t>=dev</a:t>
+              </a:r>
+              <a:endParaRPr lang="ko-KR" altLang="en-US" sz="6000" dirty="0">
+                <a:latin typeface="나눔스퀘어 Bold" panose="020B0600000101010101" pitchFamily="50" charset="-127"/>
+                <a:ea typeface="나눔스퀘어 Bold" panose="020B0600000101010101" pitchFamily="50" charset="-127"/>
+              </a:endParaRPr>
+            </a:p>
+          </p:txBody>
+        </p:sp>
+        <p:sp>
+          <p:nvSpPr>
+            <p:cNvPr id="21" name="액자 20"/>
+            <p:cNvSpPr/>
+            <p:nvPr/>
+          </p:nvSpPr>
+          <p:spPr>
+            <a:xfrm>
+              <a:off x="11742058" y="3592971"/>
+              <a:ext cx="1074055" cy="705905"/>
+            </a:xfrm>
+            <a:prstGeom prst="frame">
+              <a:avLst/>
+            </a:prstGeom>
+            <a:solidFill>
+              <a:srgbClr val="FF0000"/>
+            </a:solidFill>
+            <a:ln>
+              <a:solidFill>
+                <a:srgbClr val="FF0000"/>
+              </a:solidFill>
+            </a:ln>
+          </p:spPr>
+          <p:style>
+            <a:lnRef idx="2">
+              <a:schemeClr val="accent1">
+                <a:shade val="50000"/>
+              </a:schemeClr>
+            </a:lnRef>
+            <a:fillRef idx="1">
+              <a:schemeClr val="accent1"/>
+            </a:fillRef>
+            <a:effectRef idx="0">
+              <a:schemeClr val="accent1"/>
+            </a:effectRef>
+            <a:fontRef idx="minor">
+              <a:schemeClr val="lt1"/>
+            </a:fontRef>
+          </p:style>
+          <p:txBody>
+            <a:bodyPr rtlCol="0" anchor="ctr"/>
+            <a:lstStyle/>
+            <a:p>
+              <a:pPr algn="ctr"/>
+              <a:endParaRPr lang="ko-KR" altLang="en-US">
+                <a:solidFill>
+                  <a:schemeClr val="tx1"/>
+                </a:solidFill>
+              </a:endParaRPr>
+            </a:p>
+          </p:txBody>
+        </p:sp>
+        <p:cxnSp>
+          <p:nvCxnSpPr>
+            <p:cNvPr id="22" name="직선 화살표 연결선 21"/>
+            <p:cNvCxnSpPr>
+              <a:stCxn id="23" idx="2"/>
+              <a:endCxn id="21" idx="0"/>
+            </p:cNvCxnSpPr>
+            <p:nvPr/>
+          </p:nvCxnSpPr>
+          <p:spPr>
+            <a:xfrm>
+              <a:off x="11425523" y="1989058"/>
+              <a:ext cx="853563" cy="1603913"/>
+            </a:xfrm>
+            <a:prstGeom prst="straightConnector1">
+              <a:avLst/>
+            </a:prstGeom>
+            <a:ln w="76200">
+              <a:solidFill>
+                <a:srgbClr val="FF0000"/>
+              </a:solidFill>
+              <a:tailEnd type="triangle"/>
+            </a:ln>
+          </p:spPr>
+          <p:style>
+            <a:lnRef idx="1">
+              <a:schemeClr val="accent1"/>
+            </a:lnRef>
+            <a:fillRef idx="0">
+              <a:schemeClr val="accent1"/>
+            </a:fillRef>
+            <a:effectRef idx="0">
+              <a:schemeClr val="accent1"/>
+            </a:effectRef>
+            <a:fontRef idx="minor">
+              <a:schemeClr val="tx1"/>
+            </a:fontRef>
+          </p:style>
+        </p:cxnSp>
+        <p:sp>
+          <p:nvSpPr>
+            <p:cNvPr id="23" name="액자 22"/>
+            <p:cNvSpPr/>
+            <p:nvPr/>
+          </p:nvSpPr>
+          <p:spPr>
+            <a:xfrm>
+              <a:off x="10617199" y="916023"/>
+              <a:ext cx="1616647" cy="1073035"/>
+            </a:xfrm>
+            <a:prstGeom prst="frame">
+              <a:avLst/>
+            </a:prstGeom>
+            <a:solidFill>
+              <a:srgbClr val="FF0000"/>
+            </a:solidFill>
+            <a:ln>
+              <a:solidFill>
+                <a:srgbClr val="FF0000"/>
+              </a:solidFill>
+            </a:ln>
+          </p:spPr>
+          <p:style>
+            <a:lnRef idx="2">
+              <a:schemeClr val="accent1">
+                <a:shade val="50000"/>
+              </a:schemeClr>
+            </a:lnRef>
+            <a:fillRef idx="1">
+              <a:schemeClr val="accent1"/>
+            </a:fillRef>
+            <a:effectRef idx="0">
+              <a:schemeClr val="accent1"/>
+            </a:effectRef>
+            <a:fontRef idx="minor">
+              <a:schemeClr val="lt1"/>
+            </a:fontRef>
+          </p:style>
+          <p:txBody>
+            <a:bodyPr rtlCol="0" anchor="ctr"/>
+            <a:lstStyle/>
+            <a:p>
+              <a:pPr algn="ctr"/>
+              <a:endParaRPr lang="ko-KR" altLang="en-US">
+                <a:solidFill>
+                  <a:schemeClr val="tx1"/>
+                </a:solidFill>
+              </a:endParaRPr>
+            </a:p>
+          </p:txBody>
+        </p:sp>
+      </p:grpSp>
+      <p:grpSp>
+        <p:nvGrpSpPr>
+          <p:cNvPr id="24" name="그룹 23"/>
+          <p:cNvGrpSpPr/>
+          <p:nvPr/>
+        </p:nvGrpSpPr>
+        <p:grpSpPr>
+          <a:xfrm>
+            <a:off x="-1181100" y="6940119"/>
+            <a:ext cx="15077343" cy="3749901"/>
+            <a:chOff x="0" y="916023"/>
+            <a:chExt cx="15077343" cy="3749901"/>
+          </a:xfrm>
+        </p:grpSpPr>
+        <p:sp>
+          <p:nvSpPr>
+            <p:cNvPr id="25" name="직사각형 24"/>
+            <p:cNvSpPr/>
+            <p:nvPr/>
+          </p:nvSpPr>
+          <p:spPr>
+            <a:xfrm>
+              <a:off x="0" y="3225924"/>
+              <a:ext cx="5760000" cy="1440000"/>
+            </a:xfrm>
+            <a:prstGeom prst="rect">
+              <a:avLst/>
+            </a:prstGeom>
+            <a:solidFill>
+              <a:schemeClr val="accent5"/>
+            </a:solidFill>
+            <a:ln>
+              <a:solidFill>
+                <a:schemeClr val="tx1"/>
+              </a:solidFill>
+            </a:ln>
+          </p:spPr>
+          <p:style>
+            <a:lnRef idx="2">
+              <a:schemeClr val="accent1">
+                <a:shade val="50000"/>
+              </a:schemeClr>
+            </a:lnRef>
+            <a:fillRef idx="1">
+              <a:schemeClr val="accent1"/>
+            </a:fillRef>
+            <a:effectRef idx="0">
+              <a:schemeClr val="accent1"/>
+            </a:effectRef>
+            <a:fontRef idx="minor">
+              <a:schemeClr val="lt1"/>
+            </a:fontRef>
+          </p:style>
+          <p:txBody>
+            <a:bodyPr rtlCol="0" anchor="ctr"/>
+            <a:lstStyle/>
+            <a:p>
+              <a:pPr algn="ctr"/>
+              <a:r>
+                <a:rPr lang="en-US" altLang="ko-KR" sz="3200" dirty="0" err="1" smtClean="0">
+                  <a:latin typeface="나눔스퀘어 Bold" panose="020B0600000101010101" pitchFamily="50" charset="-127"/>
+                  <a:ea typeface="나눔스퀘어 Bold" panose="020B0600000101010101" pitchFamily="50" charset="-127"/>
+                </a:rPr>
+                <a:t>application.properties</a:t>
+              </a:r>
+              <a:endParaRPr lang="ko-KR" altLang="en-US" sz="3200" dirty="0">
+                <a:latin typeface="나눔스퀘어 Bold" panose="020B0600000101010101" pitchFamily="50" charset="-127"/>
+                <a:ea typeface="나눔스퀘어 Bold" panose="020B0600000101010101" pitchFamily="50" charset="-127"/>
+              </a:endParaRPr>
+            </a:p>
+          </p:txBody>
+        </p:sp>
+        <p:sp>
+          <p:nvSpPr>
+            <p:cNvPr id="26" name="직사각형 25"/>
+            <p:cNvSpPr/>
+            <p:nvPr/>
+          </p:nvSpPr>
+          <p:spPr>
+            <a:xfrm>
+              <a:off x="9317343" y="3225924"/>
+              <a:ext cx="5760000" cy="1440000"/>
+            </a:xfrm>
+            <a:prstGeom prst="rect">
+              <a:avLst/>
+            </a:prstGeom>
+            <a:solidFill>
+              <a:schemeClr val="accent5"/>
+            </a:solidFill>
+            <a:ln>
+              <a:solidFill>
+                <a:schemeClr val="tx1"/>
+              </a:solidFill>
+            </a:ln>
+          </p:spPr>
+          <p:style>
+            <a:lnRef idx="2">
+              <a:schemeClr val="accent1">
+                <a:shade val="50000"/>
+              </a:schemeClr>
+            </a:lnRef>
+            <a:fillRef idx="1">
+              <a:schemeClr val="accent1"/>
+            </a:fillRef>
+            <a:effectRef idx="0">
+              <a:schemeClr val="accent1"/>
+            </a:effectRef>
+            <a:fontRef idx="minor">
+              <a:schemeClr val="lt1"/>
+            </a:fontRef>
+          </p:style>
+          <p:txBody>
+            <a:bodyPr rtlCol="0" anchor="ctr"/>
+            <a:lstStyle/>
+            <a:p>
+              <a:pPr algn="ctr"/>
+              <a:r>
+                <a:rPr lang="en-US" altLang="ko-KR" sz="3200" dirty="0">
+                  <a:latin typeface="나눔스퀘어 Bold" panose="020B0600000101010101" pitchFamily="50" charset="-127"/>
+                  <a:ea typeface="나눔스퀘어 Bold" panose="020B0600000101010101" pitchFamily="50" charset="-127"/>
+                </a:rPr>
+                <a:t>a</a:t>
+              </a:r>
+              <a:r>
+                <a:rPr lang="en-US" altLang="ko-KR" sz="3200" dirty="0" smtClean="0">
+                  <a:latin typeface="나눔스퀘어 Bold" panose="020B0600000101010101" pitchFamily="50" charset="-127"/>
+                  <a:ea typeface="나눔스퀘어 Bold" panose="020B0600000101010101" pitchFamily="50" charset="-127"/>
+                </a:rPr>
+                <a:t>pplication-</a:t>
+              </a:r>
+              <a:r>
+                <a:rPr lang="en-US" altLang="ko-KR" sz="3200" dirty="0" err="1" smtClean="0">
+                  <a:latin typeface="나눔스퀘어 Bold" panose="020B0600000101010101" pitchFamily="50" charset="-127"/>
+                  <a:ea typeface="나눔스퀘어 Bold" panose="020B0600000101010101" pitchFamily="50" charset="-127"/>
+                </a:rPr>
+                <a:t>prod.properties</a:t>
+              </a:r>
+              <a:endParaRPr lang="ko-KR" altLang="en-US" sz="3200" dirty="0">
+                <a:latin typeface="나눔스퀘어 Bold" panose="020B0600000101010101" pitchFamily="50" charset="-127"/>
+                <a:ea typeface="나눔스퀘어 Bold" panose="020B0600000101010101" pitchFamily="50" charset="-127"/>
+              </a:endParaRPr>
+            </a:p>
+          </p:txBody>
+        </p:sp>
+        <p:sp>
+          <p:nvSpPr>
+            <p:cNvPr id="27" name="덧셈 기호 26"/>
+            <p:cNvSpPr/>
+            <p:nvPr/>
+          </p:nvSpPr>
+          <p:spPr>
+            <a:xfrm>
+              <a:off x="6912619" y="3225924"/>
+              <a:ext cx="1440000" cy="1440000"/>
+            </a:xfrm>
+            <a:prstGeom prst="mathPlus">
+              <a:avLst/>
+            </a:prstGeom>
+            <a:solidFill>
+              <a:schemeClr val="tx1"/>
+            </a:solidFill>
+            <a:ln>
+              <a:noFill/>
+            </a:ln>
+          </p:spPr>
+          <p:style>
+            <a:lnRef idx="2">
+              <a:schemeClr val="accent1">
+                <a:shade val="50000"/>
+              </a:schemeClr>
+            </a:lnRef>
+            <a:fillRef idx="1">
+              <a:schemeClr val="accent1"/>
+            </a:fillRef>
+            <a:effectRef idx="0">
+              <a:schemeClr val="accent1"/>
+            </a:effectRef>
+            <a:fontRef idx="minor">
+              <a:schemeClr val="lt1"/>
+            </a:fontRef>
+          </p:style>
+          <p:txBody>
+            <a:bodyPr rtlCol="0" anchor="ctr"/>
+            <a:lstStyle/>
+            <a:p>
+              <a:pPr algn="ctr"/>
+              <a:endParaRPr lang="ko-KR" altLang="en-US"/>
+            </a:p>
+          </p:txBody>
+        </p:sp>
+        <p:sp>
+          <p:nvSpPr>
+            <p:cNvPr id="28" name="TextBox 27"/>
+            <p:cNvSpPr txBox="1"/>
+            <p:nvPr/>
+          </p:nvSpPr>
+          <p:spPr>
+            <a:xfrm>
+              <a:off x="2669112" y="973395"/>
+              <a:ext cx="9958367" cy="1015663"/>
+            </a:xfrm>
+            <a:prstGeom prst="rect">
+              <a:avLst/>
+            </a:prstGeom>
+            <a:noFill/>
+          </p:spPr>
+          <p:txBody>
+            <a:bodyPr wrap="none" rtlCol="0">
+              <a:spAutoFit/>
+            </a:bodyPr>
+            <a:lstStyle/>
+            <a:p>
+              <a:r>
+                <a:rPr lang="en-US" altLang="ko-KR" sz="6000" dirty="0" err="1" smtClean="0">
+                  <a:latin typeface="나눔스퀘어 Bold" panose="020B0600000101010101" pitchFamily="50" charset="-127"/>
+                  <a:ea typeface="나눔스퀘어 Bold" panose="020B0600000101010101" pitchFamily="50" charset="-127"/>
+                </a:rPr>
+                <a:t>spring.profiles.active</a:t>
+              </a:r>
+              <a:r>
+                <a:rPr lang="en-US" altLang="ko-KR" sz="6000" dirty="0" smtClean="0">
+                  <a:latin typeface="나눔스퀘어 Bold" panose="020B0600000101010101" pitchFamily="50" charset="-127"/>
+                  <a:ea typeface="나눔스퀘어 Bold" panose="020B0600000101010101" pitchFamily="50" charset="-127"/>
+                </a:rPr>
+                <a:t>=prod</a:t>
+              </a:r>
+              <a:endParaRPr lang="ko-KR" altLang="en-US" sz="6000" dirty="0">
+                <a:latin typeface="나눔스퀘어 Bold" panose="020B0600000101010101" pitchFamily="50" charset="-127"/>
+                <a:ea typeface="나눔스퀘어 Bold" panose="020B0600000101010101" pitchFamily="50" charset="-127"/>
+              </a:endParaRPr>
+            </a:p>
+          </p:txBody>
+        </p:sp>
+        <p:sp>
+          <p:nvSpPr>
+            <p:cNvPr id="29" name="액자 28"/>
+            <p:cNvSpPr/>
+            <p:nvPr/>
+          </p:nvSpPr>
+          <p:spPr>
+            <a:xfrm>
+              <a:off x="11683998" y="3592971"/>
+              <a:ext cx="1161144" cy="705905"/>
+            </a:xfrm>
+            <a:prstGeom prst="frame">
+              <a:avLst/>
+            </a:prstGeom>
+            <a:solidFill>
+              <a:srgbClr val="FF0000"/>
+            </a:solidFill>
+            <a:ln>
+              <a:solidFill>
+                <a:srgbClr val="FF0000"/>
+              </a:solidFill>
+            </a:ln>
+          </p:spPr>
+          <p:style>
+            <a:lnRef idx="2">
+              <a:schemeClr val="accent1">
+                <a:shade val="50000"/>
+              </a:schemeClr>
+            </a:lnRef>
+            <a:fillRef idx="1">
+              <a:schemeClr val="accent1"/>
+            </a:fillRef>
+            <a:effectRef idx="0">
+              <a:schemeClr val="accent1"/>
+            </a:effectRef>
+            <a:fontRef idx="minor">
+              <a:schemeClr val="lt1"/>
+            </a:fontRef>
+          </p:style>
+          <p:txBody>
+            <a:bodyPr rtlCol="0" anchor="ctr"/>
+            <a:lstStyle/>
+            <a:p>
+              <a:pPr algn="ctr"/>
+              <a:endParaRPr lang="ko-KR" altLang="en-US">
+                <a:solidFill>
+                  <a:schemeClr val="tx1"/>
+                </a:solidFill>
+              </a:endParaRPr>
+            </a:p>
+          </p:txBody>
+        </p:sp>
+        <p:cxnSp>
+          <p:nvCxnSpPr>
+            <p:cNvPr id="30" name="직선 화살표 연결선 29"/>
+            <p:cNvCxnSpPr>
+              <a:stCxn id="32" idx="2"/>
+              <a:endCxn id="29" idx="0"/>
+            </p:cNvCxnSpPr>
+            <p:nvPr/>
+          </p:nvCxnSpPr>
+          <p:spPr>
+            <a:xfrm>
+              <a:off x="11606662" y="1989058"/>
+              <a:ext cx="657908" cy="1603913"/>
+            </a:xfrm>
+            <a:prstGeom prst="straightConnector1">
+              <a:avLst/>
+            </a:prstGeom>
+            <a:ln w="76200">
+              <a:solidFill>
+                <a:srgbClr val="FF0000"/>
+              </a:solidFill>
+              <a:tailEnd type="triangle"/>
+            </a:ln>
+          </p:spPr>
+          <p:style>
+            <a:lnRef idx="1">
+              <a:schemeClr val="accent1"/>
+            </a:lnRef>
+            <a:fillRef idx="0">
+              <a:schemeClr val="accent1"/>
+            </a:fillRef>
+            <a:effectRef idx="0">
+              <a:schemeClr val="accent1"/>
+            </a:effectRef>
+            <a:fontRef idx="minor">
+              <a:schemeClr val="tx1"/>
+            </a:fontRef>
+          </p:style>
+        </p:cxnSp>
+        <p:sp>
+          <p:nvSpPr>
+            <p:cNvPr id="32" name="액자 31"/>
+            <p:cNvSpPr/>
+            <p:nvPr/>
+          </p:nvSpPr>
+          <p:spPr>
+            <a:xfrm>
+              <a:off x="10617199" y="916023"/>
+              <a:ext cx="1978926" cy="1073035"/>
+            </a:xfrm>
+            <a:prstGeom prst="frame">
+              <a:avLst/>
+            </a:prstGeom>
+            <a:solidFill>
+              <a:srgbClr val="FF0000"/>
+            </a:solidFill>
+            <a:ln>
+              <a:solidFill>
+                <a:srgbClr val="FF0000"/>
+              </a:solidFill>
+            </a:ln>
+          </p:spPr>
+          <p:style>
+            <a:lnRef idx="2">
+              <a:schemeClr val="accent1">
+                <a:shade val="50000"/>
+              </a:schemeClr>
+            </a:lnRef>
+            <a:fillRef idx="1">
+              <a:schemeClr val="accent1"/>
+            </a:fillRef>
+            <a:effectRef idx="0">
+              <a:schemeClr val="accent1"/>
+            </a:effectRef>
+            <a:fontRef idx="minor">
+              <a:schemeClr val="lt1"/>
+            </a:fontRef>
+          </p:style>
+          <p:txBody>
+            <a:bodyPr rtlCol="0" anchor="ctr"/>
+            <a:lstStyle/>
+            <a:p>
+              <a:pPr algn="ctr"/>
+              <a:endParaRPr lang="ko-KR" altLang="en-US">
+                <a:solidFill>
+                  <a:schemeClr val="tx1"/>
+                </a:solidFill>
+              </a:endParaRPr>
+            </a:p>
+          </p:txBody>
+        </p:sp>
+      </p:grpSp>
+    </p:spTree>
+    <p:extLst>
+      <p:ext uri="{BB962C8B-B14F-4D97-AF65-F5344CB8AC3E}">
+        <p14:creationId xmlns:p14="http://schemas.microsoft.com/office/powerpoint/2010/main" val="4224339702"/>
+      </p:ext>
+    </p:extLst>
+  </p:cSld>
+  <p:clrMapOvr>
+    <a:masterClrMapping/>
+  </p:clrMapOvr>
+</p:sld>
+</file>
+
+<file path=ppt/slides/slide2.xml><?xml version="1.0" encoding="utf-8"?>
+<p:sld xmlns:a="http://schemas.openxmlformats.org/drawingml/2006/main" xmlns:r="http://schemas.openxmlformats.org/officeDocument/2006/relationships" xmlns:p="http://schemas.openxmlformats.org/presentationml/2006/main">
+  <p:cSld>
+    <p:spTree>
+      <p:nvGrpSpPr>
+        <p:cNvPr id="1" name=""/>
+        <p:cNvGrpSpPr/>
+        <p:nvPr/>
+      </p:nvGrpSpPr>
+      <p:grpSpPr>
+        <a:xfrm>
+          <a:off x="0" y="0"/>
+          <a:ext cx="0" cy="0"/>
+          <a:chOff x="0" y="0"/>
+          <a:chExt cx="0" cy="0"/>
+        </a:xfrm>
+      </p:grpSpPr>
+      <p:grpSp>
+        <p:nvGrpSpPr>
           <p:cNvPr id="20" name="그룹 19"/>
           <p:cNvGrpSpPr/>
           <p:nvPr/>
@@ -4485,7 +5654,7 @@
     </p:spTree>
     <p:extLst>
       <p:ext uri="{BB962C8B-B14F-4D97-AF65-F5344CB8AC3E}">
-        <p14:creationId xmlns:p14="http://schemas.microsoft.com/office/powerpoint/2010/main" val="3662424553"/>
+        <p14:creationId xmlns:p14="http://schemas.microsoft.com/office/powerpoint/2010/main" val="2166031796"/>
       </p:ext>
     </p:extLst>
   </p:cSld>
@@ -4495,7 +5664,7 @@
 </p:sld>
 </file>
 
-<file path=ppt/slides/slide2.xml><?xml version="1.0" encoding="utf-8"?>
+<file path=ppt/slides/slide3.xml><?xml version="1.0" encoding="utf-8"?>
 <p:sld xmlns:a="http://schemas.openxmlformats.org/drawingml/2006/main" xmlns:r="http://schemas.openxmlformats.org/officeDocument/2006/relationships" xmlns:p="http://schemas.openxmlformats.org/presentationml/2006/main">
   <p:cSld>
     <p:spTree>
@@ -5317,7 +6486,7 @@
 </p:sld>
 </file>
 
-<file path=ppt/slides/slide3.xml><?xml version="1.0" encoding="utf-8"?>
+<file path=ppt/slides/slide4.xml><?xml version="1.0" encoding="utf-8"?>
 <p:sld xmlns:a="http://schemas.openxmlformats.org/drawingml/2006/main" xmlns:r="http://schemas.openxmlformats.org/officeDocument/2006/relationships" xmlns:p="http://schemas.openxmlformats.org/presentationml/2006/main">
   <p:cSld>
     <p:spTree>
@@ -7615,7 +8784,7 @@
 </p:sld>
 </file>
 
-<file path=ppt/slides/slide4.xml><?xml version="1.0" encoding="utf-8"?>
+<file path=ppt/slides/slide5.xml><?xml version="1.0" encoding="utf-8"?>
 <p:sld xmlns:a="http://schemas.openxmlformats.org/drawingml/2006/main" xmlns:r="http://schemas.openxmlformats.org/officeDocument/2006/relationships" xmlns:p="http://schemas.openxmlformats.org/presentationml/2006/main">
   <p:cSld>
     <p:spTree>
@@ -13018,7 +14187,7 @@
 </p:sld>
 </file>
 
-<file path=ppt/slides/slide5.xml><?xml version="1.0" encoding="utf-8"?>
+<file path=ppt/slides/slide6.xml><?xml version="1.0" encoding="utf-8"?>
 <p:sld xmlns:a="http://schemas.openxmlformats.org/drawingml/2006/main" xmlns:r="http://schemas.openxmlformats.org/officeDocument/2006/relationships" xmlns:p="http://schemas.openxmlformats.org/presentationml/2006/main">
   <p:cSld>
     <p:spTree>

</xml_diff>